<commit_message>
ajoute ADR architecture pedagogique dojo signals
</commit_message>
<xml_diff>
--- a/docs/dojo-signals.pptx
+++ b/docs/dojo-signals.pptx
@@ -4462,7 +4462,8 @@
           <a:p>
             <a:r>
               <a:rPr lang="en-US" dirty="0"/>
-              <a:t>Le projet montre volontairement deux patterns Signals.</a:t>
+              <a:t>Les decisions d'architecture pedagogique sont detaillees dans docs/adr/0001-architecture-pedagogique-dojo-signals.md.
+Le projet montre volontairement deux patterns Signals.</a:t>
             </a:r>
             <a:endParaRPr lang="en-US" dirty="0"/>
           </a:p>
@@ -6676,7 +6677,8 @@
           <a:p>
             <a:r>
               <a:rPr lang="en-US" dirty="0"/>
-              <a:t>Le projet contient volontairement du code mixte : certains états sont déjà des signals, d'autres restent des propriétés classiques.
+              <a:t>Voir aussi l'ADR 0001 pour la justification de ce choix.
+Le projet contient volontairement du code mixte : certains états sont déjà des signals, d'autres restent des propriétés classiques.
 Dans les templates, cela donne aussi un mélange visible :
 Ce n'est pas une incohérence. C'est le reflet d'une migration progressive :
 effect(), plusieurs composants, ou quand on veut expliciter ses dépendances.

</xml_diff>

<commit_message>
retire helper focus exercice 4
</commit_message>
<xml_diff>
--- a/docs/dojo-signals.pptx
+++ b/docs/dojo-signals.pptx
@@ -15083,7 +15083,7 @@
         <p:spPr>
           <a:xfrm>
             <a:off x="411480" y="1362456"/>
-            <a:ext cx="11368735" cy="1874520"/>
+            <a:ext cx="11368735" cy="1097280"/>
           </a:xfrm>
           <a:prstGeom prst="rect">
             <a:avLst/>
@@ -15111,7 +15111,7 @@
                 <a:ea typeface="Courier New" pitchFamily="34" charset="-122"/>
                 <a:cs typeface="Courier New" pitchFamily="34" charset="-120"/>
               </a:rPr>
-              <a:t>// Point de départ</a:t>
+              <a:t>// À créer dans le constructeur</a:t>
             </a:r>
             <a:endParaRPr lang="en-US" sz="880" dirty="0"/>
           </a:p>
@@ -15128,7 +15128,7 @@
                 <a:ea typeface="Courier New" pitchFamily="34" charset="-122"/>
                 <a:cs typeface="Courier New" pitchFamily="34" charset="-120"/>
               </a:rPr>
-              <a:t>private focusFirstNameInput(): void {</a:t>
+              <a:t>effect(() =&gt; {</a:t>
             </a:r>
             <a:endParaRPr lang="en-US" sz="880" dirty="0"/>
           </a:p>
@@ -15145,7 +15145,7 @@
                 <a:ea typeface="Courier New" pitchFamily="34" charset="-122"/>
                 <a:cs typeface="Courier New" pitchFamily="34" charset="-120"/>
               </a:rPr>
-              <a:t>  this.firstNameInput()?.nativeElement.focus();</a:t>
+              <a:t>  if (this.adding()) {</a:t>
             </a:r>
             <a:endParaRPr lang="en-US" sz="880" dirty="0"/>
           </a:p>
@@ -15162,7 +15162,7 @@
                 <a:ea typeface="Courier New" pitchFamily="34" charset="-122"/>
                 <a:cs typeface="Courier New" pitchFamily="34" charset="-120"/>
               </a:rPr>
-              <a:t>}</a:t>
+              <a:t>    this.firstNameInput()?.nativeElement.focus();</a:t>
             </a:r>
             <a:endParaRPr lang="en-US" sz="880" dirty="0"/>
           </a:p>
@@ -15170,6 +15170,17 @@
             <a:pPr indent="0" marL="0">
               <a:buNone/>
             </a:pPr>
+            <a:r>
+              <a:rPr lang="en-US" sz="880" dirty="0">
+                <a:solidFill>
+                  <a:srgbClr val="F8FAFC"/>
+                </a:solidFill>
+                <a:latin typeface="Courier New" pitchFamily="34" charset="0"/>
+                <a:ea typeface="Courier New" pitchFamily="34" charset="-122"/>
+                <a:cs typeface="Courier New" pitchFamily="34" charset="-120"/>
+              </a:rPr>
+              <a:t>  }</a:t>
+            </a:r>
             <a:endParaRPr lang="en-US" sz="880" dirty="0"/>
           </a:p>
           <a:p>
@@ -15185,91 +15196,6 @@
                 <a:ea typeface="Courier New" pitchFamily="34" charset="-122"/>
                 <a:cs typeface="Courier New" pitchFamily="34" charset="-120"/>
               </a:rPr>
-              <a:t>// À créer dans le constructeur</a:t>
-            </a:r>
-            <a:endParaRPr lang="en-US" sz="880" dirty="0"/>
-          </a:p>
-          <a:p>
-            <a:pPr indent="0" marL="0">
-              <a:buNone/>
-            </a:pPr>
-            <a:r>
-              <a:rPr lang="en-US" sz="880" dirty="0">
-                <a:solidFill>
-                  <a:srgbClr val="F8FAFC"/>
-                </a:solidFill>
-                <a:latin typeface="Courier New" pitchFamily="34" charset="0"/>
-                <a:ea typeface="Courier New" pitchFamily="34" charset="-122"/>
-                <a:cs typeface="Courier New" pitchFamily="34" charset="-120"/>
-              </a:rPr>
-              <a:t>effect(() =&gt; {</a:t>
-            </a:r>
-            <a:endParaRPr lang="en-US" sz="880" dirty="0"/>
-          </a:p>
-          <a:p>
-            <a:pPr indent="0" marL="0">
-              <a:buNone/>
-            </a:pPr>
-            <a:r>
-              <a:rPr lang="en-US" sz="880" dirty="0">
-                <a:solidFill>
-                  <a:srgbClr val="F8FAFC"/>
-                </a:solidFill>
-                <a:latin typeface="Courier New" pitchFamily="34" charset="0"/>
-                <a:ea typeface="Courier New" pitchFamily="34" charset="-122"/>
-                <a:cs typeface="Courier New" pitchFamily="34" charset="-120"/>
-              </a:rPr>
-              <a:t>  if (this.adding()) {</a:t>
-            </a:r>
-            <a:endParaRPr lang="en-US" sz="880" dirty="0"/>
-          </a:p>
-          <a:p>
-            <a:pPr indent="0" marL="0">
-              <a:buNone/>
-            </a:pPr>
-            <a:r>
-              <a:rPr lang="en-US" sz="880" dirty="0">
-                <a:solidFill>
-                  <a:srgbClr val="F8FAFC"/>
-                </a:solidFill>
-                <a:latin typeface="Courier New" pitchFamily="34" charset="0"/>
-                <a:ea typeface="Courier New" pitchFamily="34" charset="-122"/>
-                <a:cs typeface="Courier New" pitchFamily="34" charset="-120"/>
-              </a:rPr>
-              <a:t>    this.focusFirstNameInput();</a:t>
-            </a:r>
-            <a:endParaRPr lang="en-US" sz="880" dirty="0"/>
-          </a:p>
-          <a:p>
-            <a:pPr indent="0" marL="0">
-              <a:buNone/>
-            </a:pPr>
-            <a:r>
-              <a:rPr lang="en-US" sz="880" dirty="0">
-                <a:solidFill>
-                  <a:srgbClr val="F8FAFC"/>
-                </a:solidFill>
-                <a:latin typeface="Courier New" pitchFamily="34" charset="0"/>
-                <a:ea typeface="Courier New" pitchFamily="34" charset="-122"/>
-                <a:cs typeface="Courier New" pitchFamily="34" charset="-120"/>
-              </a:rPr>
-              <a:t>  }</a:t>
-            </a:r>
-            <a:endParaRPr lang="en-US" sz="880" dirty="0"/>
-          </a:p>
-          <a:p>
-            <a:pPr indent="0" marL="0">
-              <a:buNone/>
-            </a:pPr>
-            <a:r>
-              <a:rPr lang="en-US" sz="880" dirty="0">
-                <a:solidFill>
-                  <a:srgbClr val="F8FAFC"/>
-                </a:solidFill>
-                <a:latin typeface="Courier New" pitchFamily="34" charset="0"/>
-                <a:ea typeface="Courier New" pitchFamily="34" charset="-122"/>
-                <a:cs typeface="Courier New" pitchFamily="34" charset="-120"/>
-              </a:rPr>
               <a:t>});</a:t>
             </a:r>
             <a:endParaRPr lang="en-US" sz="880" dirty="0"/>
@@ -15284,7 +15210,7 @@
         </p:nvSpPr>
         <p:spPr>
           <a:xfrm>
-            <a:off x="411480" y="3383280"/>
+            <a:off x="411480" y="2606040"/>
             <a:ext cx="11368735" cy="502920"/>
           </a:xfrm>
           <a:prstGeom prst="rect">

</xml_diff>

<commit_message>
prepare exercice 4 depuis ViewChild classique
</commit_message>
<xml_diff>
--- a/docs/dojo-signals.pptx
+++ b/docs/dojo-signals.pptx
@@ -14264,7 +14264,7 @@
         <p:spPr>
           <a:xfrm>
             <a:off x="411480" y="932688"/>
-            <a:ext cx="11368735" cy="502920"/>
+            <a:ext cx="11368735" cy="941832"/>
           </a:xfrm>
           <a:prstGeom prst="rect">
             <a:avLst/>
@@ -14279,6 +14279,63 @@
             <a:normAutofit/>
           </a:bodyPr>
           <a:lstStyle/>
+          <a:p>
+            <a:pPr indent="0" marL="0">
+              <a:buNone/>
+            </a:pPr>
+            <a:r>
+              <a:rPr lang="en-US" sz="880" dirty="0">
+                <a:solidFill>
+                  <a:srgbClr val="F8FAFC"/>
+                </a:solidFill>
+                <a:latin typeface="Courier New" pitchFamily="34" charset="0"/>
+                <a:ea typeface="Courier New" pitchFamily="34" charset="-122"/>
+                <a:cs typeface="Courier New" pitchFamily="34" charset="-120"/>
+              </a:rPr>
+              <a:t>// Avant : ViewChild classique</a:t>
+            </a:r>
+            <a:endParaRPr lang="en-US" sz="880" dirty="0"/>
+          </a:p>
+          <a:p>
+            <a:pPr indent="0" marL="0">
+              <a:buNone/>
+            </a:pPr>
+            <a:r>
+              <a:rPr lang="en-US" sz="880" dirty="0">
+                <a:solidFill>
+                  <a:srgbClr val="F8FAFC"/>
+                </a:solidFill>
+                <a:latin typeface="Courier New" pitchFamily="34" charset="0"/>
+                <a:ea typeface="Courier New" pitchFamily="34" charset="-122"/>
+                <a:cs typeface="Courier New" pitchFamily="34" charset="-120"/>
+              </a:rPr>
+              <a:t>@ViewChild('firstNameRef') private firstNameInput?: ElementRef;</a:t>
+            </a:r>
+            <a:endParaRPr lang="en-US" sz="880" dirty="0"/>
+          </a:p>
+          <a:p>
+            <a:pPr indent="0" marL="0">
+              <a:buNone/>
+            </a:pPr>
+            <a:endParaRPr lang="en-US" sz="880" dirty="0"/>
+          </a:p>
+          <a:p>
+            <a:pPr indent="0" marL="0">
+              <a:buNone/>
+            </a:pPr>
+            <a:r>
+              <a:rPr lang="en-US" sz="880" dirty="0">
+                <a:solidFill>
+                  <a:srgbClr val="F8FAFC"/>
+                </a:solidFill>
+                <a:latin typeface="Courier New" pitchFamily="34" charset="0"/>
+                <a:ea typeface="Courier New" pitchFamily="34" charset="-122"/>
+                <a:cs typeface="Courier New" pitchFamily="34" charset="-120"/>
+              </a:rPr>
+              <a:t>// Après : ViewChild signal</a:t>
+            </a:r>
+            <a:endParaRPr lang="en-US" sz="880" dirty="0"/>
+          </a:p>
           <a:p>
             <a:pPr indent="0" marL="0">
               <a:buNone/>
@@ -15045,7 +15102,7 @@
         <p:spPr>
           <a:xfrm>
             <a:off x="411480" y="932688"/>
-            <a:ext cx="11368735" cy="320040"/>
+            <a:ext cx="11368735" cy="429768"/>
           </a:xfrm>
           <a:prstGeom prst="rect">
             <a:avLst/>
@@ -15068,7 +15125,7 @@
                   <a:srgbClr val="333333"/>
                 </a:solidFill>
               </a:rPr>
-              <a:t>Créer un effect() dans le constructeur pour déclencher le focus quand le formulaire d'ajout est ouvert.</a:t>
+              <a:t>Transformer le @ViewChild classique en viewChild() signal, puis créer un effect() dans le constructeur pour déclencher le focus quand le formulaire d'ajout est ouvert.</a:t>
             </a:r>
             <a:endParaRPr lang="en-US" sz="1220" dirty="0"/>
           </a:p>
@@ -15082,8 +15139,8 @@
         </p:nvSpPr>
         <p:spPr>
           <a:xfrm>
-            <a:off x="411480" y="1362456"/>
-            <a:ext cx="11368735" cy="1097280"/>
+            <a:off x="411480" y="1472184"/>
+            <a:ext cx="11368735" cy="2029968"/>
           </a:xfrm>
           <a:prstGeom prst="rect">
             <a:avLst/>
@@ -15111,7 +15168,7 @@
                 <a:ea typeface="Courier New" pitchFamily="34" charset="-122"/>
                 <a:cs typeface="Courier New" pitchFamily="34" charset="-120"/>
               </a:rPr>
-              <a:t>// À créer dans le constructeur</a:t>
+              <a:t>// Avant</a:t>
             </a:r>
             <a:endParaRPr lang="en-US" sz="880" dirty="0"/>
           </a:p>
@@ -15128,7 +15185,7 @@
                 <a:ea typeface="Courier New" pitchFamily="34" charset="-122"/>
                 <a:cs typeface="Courier New" pitchFamily="34" charset="-120"/>
               </a:rPr>
-              <a:t>effect(() =&gt; {</a:t>
+              <a:t>@ViewChild('firstNameRef') private firstNameInput?: ElementRef;</a:t>
             </a:r>
             <a:endParaRPr lang="en-US" sz="880" dirty="0"/>
           </a:p>
@@ -15136,6 +15193,12 @@
             <a:pPr indent="0" marL="0">
               <a:buNone/>
             </a:pPr>
+            <a:endParaRPr lang="en-US" sz="880" dirty="0"/>
+          </a:p>
+          <a:p>
+            <a:pPr indent="0" marL="0">
+              <a:buNone/>
+            </a:pPr>
             <a:r>
               <a:rPr lang="en-US" sz="880" dirty="0">
                 <a:solidFill>
@@ -15145,7 +15208,7 @@
                 <a:ea typeface="Courier New" pitchFamily="34" charset="-122"/>
                 <a:cs typeface="Courier New" pitchFamily="34" charset="-120"/>
               </a:rPr>
-              <a:t>  if (this.adding()) {</a:t>
+              <a:t>// Après</a:t>
             </a:r>
             <a:endParaRPr lang="en-US" sz="880" dirty="0"/>
           </a:p>
@@ -15162,7 +15225,7 @@
                 <a:ea typeface="Courier New" pitchFamily="34" charset="-122"/>
                 <a:cs typeface="Courier New" pitchFamily="34" charset="-120"/>
               </a:rPr>
-              <a:t>    this.firstNameInput()?.nativeElement.focus();</a:t>
+              <a:t>private readonly firstNameInput = viewChild&lt;ElementRef&gt;('firstNameRef');</a:t>
             </a:r>
             <a:endParaRPr lang="en-US" sz="880" dirty="0"/>
           </a:p>
@@ -15170,6 +15233,12 @@
             <a:pPr indent="0" marL="0">
               <a:buNone/>
             </a:pPr>
+            <a:endParaRPr lang="en-US" sz="880" dirty="0"/>
+          </a:p>
+          <a:p>
+            <a:pPr indent="0" marL="0">
+              <a:buNone/>
+            </a:pPr>
             <a:r>
               <a:rPr lang="en-US" sz="880" dirty="0">
                 <a:solidFill>
@@ -15179,7 +15248,7 @@
                 <a:ea typeface="Courier New" pitchFamily="34" charset="-122"/>
                 <a:cs typeface="Courier New" pitchFamily="34" charset="-120"/>
               </a:rPr>
-              <a:t>  }</a:t>
+              <a:t>// À créer dans le constructeur</a:t>
             </a:r>
             <a:endParaRPr lang="en-US" sz="880" dirty="0"/>
           </a:p>
@@ -15196,6 +15265,74 @@
                 <a:ea typeface="Courier New" pitchFamily="34" charset="-122"/>
                 <a:cs typeface="Courier New" pitchFamily="34" charset="-120"/>
               </a:rPr>
+              <a:t>effect(() =&gt; {</a:t>
+            </a:r>
+            <a:endParaRPr lang="en-US" sz="880" dirty="0"/>
+          </a:p>
+          <a:p>
+            <a:pPr indent="0" marL="0">
+              <a:buNone/>
+            </a:pPr>
+            <a:r>
+              <a:rPr lang="en-US" sz="880" dirty="0">
+                <a:solidFill>
+                  <a:srgbClr val="F8FAFC"/>
+                </a:solidFill>
+                <a:latin typeface="Courier New" pitchFamily="34" charset="0"/>
+                <a:ea typeface="Courier New" pitchFamily="34" charset="-122"/>
+                <a:cs typeface="Courier New" pitchFamily="34" charset="-120"/>
+              </a:rPr>
+              <a:t>  if (this.adding()) {</a:t>
+            </a:r>
+            <a:endParaRPr lang="en-US" sz="880" dirty="0"/>
+          </a:p>
+          <a:p>
+            <a:pPr indent="0" marL="0">
+              <a:buNone/>
+            </a:pPr>
+            <a:r>
+              <a:rPr lang="en-US" sz="880" dirty="0">
+                <a:solidFill>
+                  <a:srgbClr val="F8FAFC"/>
+                </a:solidFill>
+                <a:latin typeface="Courier New" pitchFamily="34" charset="0"/>
+                <a:ea typeface="Courier New" pitchFamily="34" charset="-122"/>
+                <a:cs typeface="Courier New" pitchFamily="34" charset="-120"/>
+              </a:rPr>
+              <a:t>    this.firstNameInput()?.nativeElement.focus();</a:t>
+            </a:r>
+            <a:endParaRPr lang="en-US" sz="880" dirty="0"/>
+          </a:p>
+          <a:p>
+            <a:pPr indent="0" marL="0">
+              <a:buNone/>
+            </a:pPr>
+            <a:r>
+              <a:rPr lang="en-US" sz="880" dirty="0">
+                <a:solidFill>
+                  <a:srgbClr val="F8FAFC"/>
+                </a:solidFill>
+                <a:latin typeface="Courier New" pitchFamily="34" charset="0"/>
+                <a:ea typeface="Courier New" pitchFamily="34" charset="-122"/>
+                <a:cs typeface="Courier New" pitchFamily="34" charset="-120"/>
+              </a:rPr>
+              <a:t>  }</a:t>
+            </a:r>
+            <a:endParaRPr lang="en-US" sz="880" dirty="0"/>
+          </a:p>
+          <a:p>
+            <a:pPr indent="0" marL="0">
+              <a:buNone/>
+            </a:pPr>
+            <a:r>
+              <a:rPr lang="en-US" sz="880" dirty="0">
+                <a:solidFill>
+                  <a:srgbClr val="F8FAFC"/>
+                </a:solidFill>
+                <a:latin typeface="Courier New" pitchFamily="34" charset="0"/>
+                <a:ea typeface="Courier New" pitchFamily="34" charset="-122"/>
+                <a:cs typeface="Courier New" pitchFamily="34" charset="-120"/>
+              </a:rPr>
               <a:t>});</a:t>
             </a:r>
             <a:endParaRPr lang="en-US" sz="880" dirty="0"/>
@@ -15210,7 +15347,7 @@
         </p:nvSpPr>
         <p:spPr>
           <a:xfrm>
-            <a:off x="411480" y="2606040"/>
+            <a:off x="411480" y="3648456"/>
             <a:ext cx="11368735" cy="502920"/>
           </a:xfrm>
           <a:prstGeom prst="rect">

</xml_diff>

<commit_message>
ajoute exemple model signals demo
</commit_message>
<xml_diff>
--- a/docs/dojo-signals.pptx
+++ b/docs/dojo-signals.pptx
@@ -19769,7 +19769,7 @@
         </p:nvGraphicFramePr>
         <p:xfrm>
           <a:off x="411480" y="932688"/>
-          <a:ext cx="11368735" cy="1554480"/>
+          <a:ext cx="11368735" cy="1243584"/>
         </p:xfrm>
         <a:graphic>
           <a:graphicData uri="http://schemas.openxmlformats.org/drawingml/2006/table">
@@ -20166,130 +20166,6 @@
                             <a:srgbClr val="333333"/>
                           </a:solidFill>
                         </a:rPr>
-                        <a:t>Flux avec opérateurs temporels</a:t>
-                      </a:r>
-                      <a:endParaRPr lang="en-US" sz="1020" dirty="0"/>
-                    </a:p>
-                  </a:txBody>
-                  <a:tcPr marL="50800" marR="50800" marT="25400" marB="25400" anchor="mid">
-                    <a:lnL w="5715" cap="flat" cmpd="sng" algn="ctr">
-                      <a:solidFill>
-                        <a:srgbClr val="DADCE0"/>
-                      </a:solidFill>
-                      <a:prstDash val="solid"/>
-                      <a:round/>
-                      <a:headEnd type="none" w="med" len="med"/>
-                      <a:tailEnd type="none" w="med" len="med"/>
-                    </a:lnL>
-                    <a:lnR w="5715" cap="flat" cmpd="sng" algn="ctr">
-                      <a:solidFill>
-                        <a:srgbClr val="DADCE0"/>
-                      </a:solidFill>
-                      <a:prstDash val="solid"/>
-                      <a:round/>
-                      <a:headEnd type="none" w="med" len="med"/>
-                      <a:tailEnd type="none" w="med" len="med"/>
-                    </a:lnR>
-                    <a:lnT w="5715" cap="flat" cmpd="sng" algn="ctr">
-                      <a:solidFill>
-                        <a:srgbClr val="DADCE0"/>
-                      </a:solidFill>
-                      <a:prstDash val="solid"/>
-                      <a:round/>
-                      <a:headEnd type="none" w="med" len="med"/>
-                      <a:tailEnd type="none" w="med" len="med"/>
-                    </a:lnT>
-                    <a:lnB w="5715" cap="flat" cmpd="sng" algn="ctr">
-                      <a:solidFill>
-                        <a:srgbClr val="DADCE0"/>
-                      </a:solidFill>
-                      <a:prstDash val="solid"/>
-                      <a:round/>
-                      <a:headEnd type="none" w="med" len="med"/>
-                      <a:tailEnd type="none" w="med" len="med"/>
-                    </a:lnB>
-                    <a:solidFill>
-                      <a:srgbClr val="FFFFFF"/>
-                    </a:solidFill>
-                  </a:tcPr>
-                </a:tc>
-                <a:tc>
-                  <a:txBody>
-                    <a:bodyPr/>
-                    <a:lstStyle/>
-                    <a:p>
-                      <a:pPr indent="0" marL="0">
-                        <a:buNone/>
-                      </a:pPr>
-                      <a:r>
-                        <a:rPr lang="en-US" sz="1020" dirty="0">
-                          <a:solidFill>
-                            <a:srgbClr val="333333"/>
-                          </a:solidFill>
-                        </a:rPr>
-                        <a:t>Flux dédié, pas output()</a:t>
-                      </a:r>
-                      <a:endParaRPr lang="en-US" sz="1020" dirty="0"/>
-                    </a:p>
-                  </a:txBody>
-                  <a:tcPr marL="50800" marR="50800" marT="25400" marB="25400" anchor="mid">
-                    <a:lnL w="5715" cap="flat" cmpd="sng" algn="ctr">
-                      <a:solidFill>
-                        <a:srgbClr val="DADCE0"/>
-                      </a:solidFill>
-                      <a:prstDash val="solid"/>
-                      <a:round/>
-                      <a:headEnd type="none" w="med" len="med"/>
-                      <a:tailEnd type="none" w="med" len="med"/>
-                    </a:lnL>
-                    <a:lnR w="5715" cap="flat" cmpd="sng" algn="ctr">
-                      <a:solidFill>
-                        <a:srgbClr val="DADCE0"/>
-                      </a:solidFill>
-                      <a:prstDash val="solid"/>
-                      <a:round/>
-                      <a:headEnd type="none" w="med" len="med"/>
-                      <a:tailEnd type="none" w="med" len="med"/>
-                    </a:lnR>
-                    <a:lnT w="5715" cap="flat" cmpd="sng" algn="ctr">
-                      <a:solidFill>
-                        <a:srgbClr val="DADCE0"/>
-                      </a:solidFill>
-                      <a:prstDash val="solid"/>
-                      <a:round/>
-                      <a:headEnd type="none" w="med" len="med"/>
-                      <a:tailEnd type="none" w="med" len="med"/>
-                    </a:lnT>
-                    <a:lnB w="5715" cap="flat" cmpd="sng" algn="ctr">
-                      <a:solidFill>
-                        <a:srgbClr val="DADCE0"/>
-                      </a:solidFill>
-                      <a:prstDash val="solid"/>
-                      <a:round/>
-                      <a:headEnd type="none" w="med" len="med"/>
-                      <a:tailEnd type="none" w="med" len="med"/>
-                    </a:lnB>
-                    <a:solidFill>
-                      <a:srgbClr val="FFFFFF"/>
-                    </a:solidFill>
-                  </a:tcPr>
-                </a:tc>
-              </a:tr>
-              <a:tr h="310896">
-                <a:tc>
-                  <a:txBody>
-                    <a:bodyPr/>
-                    <a:lstStyle/>
-                    <a:p>
-                      <a:pPr indent="0" marL="0">
-                        <a:buNone/>
-                      </a:pPr>
-                      <a:r>
-                        <a:rPr lang="en-US" sz="1020" dirty="0">
-                          <a:solidFill>
-                            <a:srgbClr val="333333"/>
-                          </a:solidFill>
-                        </a:rPr>
                         <a:t>Valeur bidirectionnelle entrée + sortie</a:t>
                       </a:r>
                       <a:endParaRPr lang="en-US" sz="1020" dirty="0"/>
@@ -20333,7 +20209,7 @@
                       <a:tailEnd type="none" w="med" len="med"/>
                     </a:lnB>
                     <a:solidFill>
-                      <a:srgbClr val="F6F7F9"/>
+                      <a:srgbClr val="FFFFFF"/>
                     </a:solidFill>
                   </a:tcPr>
                 </a:tc>
@@ -20394,7 +20270,7 @@
                       <a:tailEnd type="none" w="med" len="med"/>
                     </a:lnB>
                     <a:solidFill>
-                      <a:srgbClr val="F6F7F9"/>
+                      <a:srgbClr val="FFFFFF"/>
                     </a:solidFill>
                   </a:tcPr>
                 </a:tc>
@@ -20620,6 +20496,44 @@
       <p:sp>
         <p:nvSpPr>
           <p:cNvPr id="6" name="Text 3"/>
+          <p:cNvSpPr/>
+          <p:nvPr/>
+        </p:nvSpPr>
+        <p:spPr>
+          <a:xfrm>
+            <a:off x="411480" y="1865376"/>
+            <a:ext cx="11368735" cy="320040"/>
+          </a:xfrm>
+          <a:prstGeom prst="rect">
+            <a:avLst/>
+          </a:prstGeom>
+          <a:noFill/>
+          <a:ln/>
+        </p:spPr>
+        <p:txBody>
+          <a:bodyPr wrap="square" lIns="254" tIns="254" rIns="254" bIns="254" rtlCol="0" anchor="t">
+            <a:normAutofit/>
+          </a:bodyPr>
+          <a:lstStyle/>
+          <a:p>
+            <a:pPr indent="0" marL="0">
+              <a:buNone/>
+            </a:pPr>
+            <a:r>
+              <a:rPr lang="en-US" sz="1220" dirty="0">
+                <a:solidFill>
+                  <a:srgbClr val="333333"/>
+                </a:solidFill>
+              </a:rPr>
+              <a:t>Le projet contient aussi un exemple dans src/app/features/signals-demo/model-amount/model-amount.component.ts.</a:t>
+            </a:r>
+            <a:endParaRPr lang="en-US" sz="1220" dirty="0"/>
+          </a:p>
+        </p:txBody>
+      </p:sp>
+      <p:sp>
+        <p:nvSpPr>
+          <p:cNvPr id="7" name="Text 4"/>
           <p:cNvSpPr/>
           <p:nvPr/>
         </p:nvSpPr>

</xml_diff>

<commit_message>
clarifie consignes pptx court
</commit_message>
<xml_diff>
--- a/docs/dojo-signals.pptx
+++ b/docs/dojo-signals.pptx
@@ -3171,19 +3171,18 @@
         </p:nvGraphicFramePr>
         <p:xfrm>
           <a:off x="411480" y="932688"/>
-          <a:ext cx="11368735" cy="2798064"/>
+          <a:ext cx="11368735" cy="4773168"/>
         </p:xfrm>
         <a:graphic>
           <a:graphicData uri="http://schemas.openxmlformats.org/drawingml/2006/table">
             <a:tbl>
               <a:tblPr/>
               <a:tblGrid>
-                <a:gridCol w="2842184"/>
-                <a:gridCol w="2842184"/>
-                <a:gridCol w="2842184"/>
-                <a:gridCol w="2842184"/>
+                <a:gridCol w="1417320"/>
+                <a:gridCol w="2834640"/>
+                <a:gridCol w="7116775"/>
               </a:tblGrid>
-              <a:tr h="310896">
+              <a:tr h="530352">
                 <a:tc>
                   <a:txBody>
                     <a:bodyPr/>
@@ -3193,14 +3192,14 @@
                         <a:buNone/>
                       </a:pPr>
                       <a:r>
-                        <a:rPr lang="en-US" sz="850" b="1" dirty="0">
+                        <a:rPr lang="en-US" sz="740" b="1" dirty="0">
                           <a:solidFill>
                             <a:srgbClr val="FFFFFF"/>
                           </a:solidFill>
                         </a:rPr>
                         <a:t>Ex.</a:t>
                       </a:r>
-                      <a:endParaRPr lang="en-US" sz="850" dirty="0"/>
+                      <a:endParaRPr lang="en-US" sz="740" dirty="0"/>
                     </a:p>
                   </a:txBody>
                   <a:tcPr marL="50800" marR="50800" marT="25400" marB="25400" anchor="mid">
@@ -3254,14 +3253,14 @@
                         <a:buNone/>
                       </a:pPr>
                       <a:r>
-                        <a:rPr lang="en-US" sz="850" b="1" dirty="0">
+                        <a:rPr lang="en-US" sz="740" b="1" dirty="0">
                           <a:solidFill>
                             <a:srgbClr val="FFFFFF"/>
                           </a:solidFill>
                         </a:rPr>
-                        <a:t>API</a:t>
+                        <a:t>Definition courte</a:t>
                       </a:r>
-                      <a:endParaRPr lang="en-US" sz="850" dirty="0"/>
+                      <a:endParaRPr lang="en-US" sz="740" dirty="0"/>
                     </a:p>
                   </a:txBody>
                   <a:tcPr marL="50800" marR="50800" marT="25400" marB="25400" anchor="mid">
@@ -3315,14 +3314,14 @@
                         <a:buNone/>
                       </a:pPr>
                       <a:r>
-                        <a:rPr lang="en-US" sz="850" b="1" dirty="0">
+                        <a:rPr lang="en-US" sz="740" b="1" dirty="0">
                           <a:solidFill>
                             <a:srgbClr val="FFFFFF"/>
                           </a:solidFill>
                         </a:rPr>
-                        <a:t>Definition courte</a:t>
+                        <a:t>Consigne claire</a:t>
                       </a:r>
-                      <a:endParaRPr lang="en-US" sz="850" dirty="0"/>
+                      <a:endParaRPr lang="en-US" sz="740" dirty="0"/>
                     </a:p>
                   </a:txBody>
                   <a:tcPr marL="50800" marR="50800" marT="25400" marB="25400" anchor="mid">
@@ -3367,6 +3366,8 @@
                     </a:solidFill>
                   </a:tcPr>
                 </a:tc>
+              </a:tr>
+              <a:tr h="530352">
                 <a:tc>
                   <a:txBody>
                     <a:bodyPr/>
@@ -3376,77 +3377,14 @@
                         <a:buNone/>
                       </a:pPr>
                       <a:r>
-                        <a:rPr lang="en-US" sz="850" b="1" dirty="0">
-                          <a:solidFill>
-                            <a:srgbClr val="FFFFFF"/>
-                          </a:solidFill>
-                        </a:rPr>
-                        <a:t>Consigne</a:t>
-                      </a:r>
-                      <a:endParaRPr lang="en-US" sz="850" dirty="0"/>
-                    </a:p>
-                  </a:txBody>
-                  <a:tcPr marL="50800" marR="50800" marT="25400" marB="25400" anchor="mid">
-                    <a:lnL w="5715" cap="flat" cmpd="sng" algn="ctr">
-                      <a:solidFill>
-                        <a:srgbClr val="DADCE0"/>
-                      </a:solidFill>
-                      <a:prstDash val="solid"/>
-                      <a:round/>
-                      <a:headEnd type="none" w="med" len="med"/>
-                      <a:tailEnd type="none" w="med" len="med"/>
-                    </a:lnL>
-                    <a:lnR w="5715" cap="flat" cmpd="sng" algn="ctr">
-                      <a:solidFill>
-                        <a:srgbClr val="DADCE0"/>
-                      </a:solidFill>
-                      <a:prstDash val="solid"/>
-                      <a:round/>
-                      <a:headEnd type="none" w="med" len="med"/>
-                      <a:tailEnd type="none" w="med" len="med"/>
-                    </a:lnR>
-                    <a:lnT w="5715" cap="flat" cmpd="sng" algn="ctr">
-                      <a:solidFill>
-                        <a:srgbClr val="DADCE0"/>
-                      </a:solidFill>
-                      <a:prstDash val="solid"/>
-                      <a:round/>
-                      <a:headEnd type="none" w="med" len="med"/>
-                      <a:tailEnd type="none" w="med" len="med"/>
-                    </a:lnT>
-                    <a:lnB w="5715" cap="flat" cmpd="sng" algn="ctr">
-                      <a:solidFill>
-                        <a:srgbClr val="DADCE0"/>
-                      </a:solidFill>
-                      <a:prstDash val="solid"/>
-                      <a:round/>
-                      <a:headEnd type="none" w="med" len="med"/>
-                      <a:tailEnd type="none" w="med" len="med"/>
-                    </a:lnB>
-                    <a:solidFill>
-                      <a:srgbClr val="DD0031"/>
-                    </a:solidFill>
-                  </a:tcPr>
-                </a:tc>
-              </a:tr>
-              <a:tr h="310896">
-                <a:tc>
-                  <a:txBody>
-                    <a:bodyPr/>
-                    <a:lstStyle/>
-                    <a:p>
-                      <a:pPr indent="0" marL="0">
-                        <a:buNone/>
-                      </a:pPr>
-                      <a:r>
-                        <a:rPr lang="en-US" sz="850" dirty="0">
+                        <a:rPr lang="en-US" sz="740" dirty="0">
                           <a:solidFill>
                             <a:srgbClr val="333333"/>
                           </a:solidFill>
                         </a:rPr>
-                        <a:t>1</a:t>
+                        <a:t>1 — signal()</a:t>
                       </a:r>
-                      <a:endParaRPr lang="en-US" sz="850" dirty="0"/>
+                      <a:endParaRPr lang="en-US" sz="740" dirty="0"/>
                     </a:p>
                   </a:txBody>
                   <a:tcPr marL="50800" marR="50800" marT="25400" marB="25400" anchor="mid">
@@ -3500,14 +3438,14 @@
                         <a:buNone/>
                       </a:pPr>
                       <a:r>
-                        <a:rPr lang="en-US" sz="850" dirty="0">
+                        <a:rPr lang="en-US" sz="740" dirty="0">
                           <a:solidFill>
                             <a:srgbClr val="333333"/>
                           </a:solidFill>
                         </a:rPr>
-                        <a:t>signal()</a:t>
+                        <a:t>Valeur reactive mutable lue avec ().</a:t>
                       </a:r>
-                      <a:endParaRPr lang="en-US" sz="850" dirty="0"/>
+                      <a:endParaRPr lang="en-US" sz="740" dirty="0"/>
                     </a:p>
                   </a:txBody>
                   <a:tcPr marL="50800" marR="50800" marT="25400" marB="25400" anchor="mid">
@@ -3561,14 +3499,262 @@
                         <a:buNone/>
                       </a:pPr>
                       <a:r>
-                        <a:rPr lang="en-US" sz="850" dirty="0">
+                        <a:rPr lang="en-US" sz="740" dirty="0">
                           <a:solidFill>
                             <a:srgbClr val="333333"/>
                           </a:solidFill>
                         </a:rPr>
-                        <a:t>Valeur reactive mutable lue avec ().</a:t>
+                        <a:t>Dans la page clients, l'ouverture du formulaire d'ajout ne doit plus etre un booleen classique : elle doit etre portee par un signal et rester lisible depuis le template et les tests.</a:t>
                       </a:r>
-                      <a:endParaRPr lang="en-US" sz="850" dirty="0"/>
+                      <a:endParaRPr lang="en-US" sz="740" dirty="0"/>
+                    </a:p>
+                  </a:txBody>
+                  <a:tcPr marL="50800" marR="50800" marT="25400" marB="25400" anchor="mid">
+                    <a:lnL w="5715" cap="flat" cmpd="sng" algn="ctr">
+                      <a:solidFill>
+                        <a:srgbClr val="DADCE0"/>
+                      </a:solidFill>
+                      <a:prstDash val="solid"/>
+                      <a:round/>
+                      <a:headEnd type="none" w="med" len="med"/>
+                      <a:tailEnd type="none" w="med" len="med"/>
+                    </a:lnL>
+                    <a:lnR w="5715" cap="flat" cmpd="sng" algn="ctr">
+                      <a:solidFill>
+                        <a:srgbClr val="DADCE0"/>
+                      </a:solidFill>
+                      <a:prstDash val="solid"/>
+                      <a:round/>
+                      <a:headEnd type="none" w="med" len="med"/>
+                      <a:tailEnd type="none" w="med" len="med"/>
+                    </a:lnR>
+                    <a:lnT w="5715" cap="flat" cmpd="sng" algn="ctr">
+                      <a:solidFill>
+                        <a:srgbClr val="DADCE0"/>
+                      </a:solidFill>
+                      <a:prstDash val="solid"/>
+                      <a:round/>
+                      <a:headEnd type="none" w="med" len="med"/>
+                      <a:tailEnd type="none" w="med" len="med"/>
+                    </a:lnT>
+                    <a:lnB w="5715" cap="flat" cmpd="sng" algn="ctr">
+                      <a:solidFill>
+                        <a:srgbClr val="DADCE0"/>
+                      </a:solidFill>
+                      <a:prstDash val="solid"/>
+                      <a:round/>
+                      <a:headEnd type="none" w="med" len="med"/>
+                      <a:tailEnd type="none" w="med" len="med"/>
+                    </a:lnB>
+                    <a:solidFill>
+                      <a:srgbClr val="FFFFFF"/>
+                    </a:solidFill>
+                  </a:tcPr>
+                </a:tc>
+              </a:tr>
+              <a:tr h="530352">
+                <a:tc>
+                  <a:txBody>
+                    <a:bodyPr/>
+                    <a:lstStyle/>
+                    <a:p>
+                      <a:pPr indent="0" marL="0">
+                        <a:buNone/>
+                      </a:pPr>
+                      <a:r>
+                        <a:rPr lang="en-US" sz="740" dirty="0">
+                          <a:solidFill>
+                            <a:srgbClr val="333333"/>
+                          </a:solidFill>
+                        </a:rPr>
+                        <a:t>2 — computed()</a:t>
+                      </a:r>
+                      <a:endParaRPr lang="en-US" sz="740" dirty="0"/>
+                    </a:p>
+                  </a:txBody>
+                  <a:tcPr marL="50800" marR="50800" marT="25400" marB="25400" anchor="mid">
+                    <a:lnL w="5715" cap="flat" cmpd="sng" algn="ctr">
+                      <a:solidFill>
+                        <a:srgbClr val="DADCE0"/>
+                      </a:solidFill>
+                      <a:prstDash val="solid"/>
+                      <a:round/>
+                      <a:headEnd type="none" w="med" len="med"/>
+                      <a:tailEnd type="none" w="med" len="med"/>
+                    </a:lnL>
+                    <a:lnR w="5715" cap="flat" cmpd="sng" algn="ctr">
+                      <a:solidFill>
+                        <a:srgbClr val="DADCE0"/>
+                      </a:solidFill>
+                      <a:prstDash val="solid"/>
+                      <a:round/>
+                      <a:headEnd type="none" w="med" len="med"/>
+                      <a:tailEnd type="none" w="med" len="med"/>
+                    </a:lnR>
+                    <a:lnT w="5715" cap="flat" cmpd="sng" algn="ctr">
+                      <a:solidFill>
+                        <a:srgbClr val="DADCE0"/>
+                      </a:solidFill>
+                      <a:prstDash val="solid"/>
+                      <a:round/>
+                      <a:headEnd type="none" w="med" len="med"/>
+                      <a:tailEnd type="none" w="med" len="med"/>
+                    </a:lnT>
+                    <a:lnB w="5715" cap="flat" cmpd="sng" algn="ctr">
+                      <a:solidFill>
+                        <a:srgbClr val="DADCE0"/>
+                      </a:solidFill>
+                      <a:prstDash val="solid"/>
+                      <a:round/>
+                      <a:headEnd type="none" w="med" len="med"/>
+                      <a:tailEnd type="none" w="med" len="med"/>
+                    </a:lnB>
+                    <a:solidFill>
+                      <a:srgbClr val="F6F7F9"/>
+                    </a:solidFill>
+                  </a:tcPr>
+                </a:tc>
+                <a:tc>
+                  <a:txBody>
+                    <a:bodyPr/>
+                    <a:lstStyle/>
+                    <a:p>
+                      <a:pPr indent="0" marL="0">
+                        <a:buNone/>
+                      </a:pPr>
+                      <a:r>
+                        <a:rPr lang="en-US" sz="740" dirty="0">
+                          <a:solidFill>
+                            <a:srgbClr val="333333"/>
+                          </a:solidFill>
+                        </a:rPr>
+                        <a:t>Valeur derivee en lecture seule.</a:t>
+                      </a:r>
+                      <a:endParaRPr lang="en-US" sz="740" dirty="0"/>
+                    </a:p>
+                  </a:txBody>
+                  <a:tcPr marL="50800" marR="50800" marT="25400" marB="25400" anchor="mid">
+                    <a:lnL w="5715" cap="flat" cmpd="sng" algn="ctr">
+                      <a:solidFill>
+                        <a:srgbClr val="DADCE0"/>
+                      </a:solidFill>
+                      <a:prstDash val="solid"/>
+                      <a:round/>
+                      <a:headEnd type="none" w="med" len="med"/>
+                      <a:tailEnd type="none" w="med" len="med"/>
+                    </a:lnL>
+                    <a:lnR w="5715" cap="flat" cmpd="sng" algn="ctr">
+                      <a:solidFill>
+                        <a:srgbClr val="DADCE0"/>
+                      </a:solidFill>
+                      <a:prstDash val="solid"/>
+                      <a:round/>
+                      <a:headEnd type="none" w="med" len="med"/>
+                      <a:tailEnd type="none" w="med" len="med"/>
+                    </a:lnR>
+                    <a:lnT w="5715" cap="flat" cmpd="sng" algn="ctr">
+                      <a:solidFill>
+                        <a:srgbClr val="DADCE0"/>
+                      </a:solidFill>
+                      <a:prstDash val="solid"/>
+                      <a:round/>
+                      <a:headEnd type="none" w="med" len="med"/>
+                      <a:tailEnd type="none" w="med" len="med"/>
+                    </a:lnT>
+                    <a:lnB w="5715" cap="flat" cmpd="sng" algn="ctr">
+                      <a:solidFill>
+                        <a:srgbClr val="DADCE0"/>
+                      </a:solidFill>
+                      <a:prstDash val="solid"/>
+                      <a:round/>
+                      <a:headEnd type="none" w="med" len="med"/>
+                      <a:tailEnd type="none" w="med" len="med"/>
+                    </a:lnB>
+                    <a:solidFill>
+                      <a:srgbClr val="F6F7F9"/>
+                    </a:solidFill>
+                  </a:tcPr>
+                </a:tc>
+                <a:tc>
+                  <a:txBody>
+                    <a:bodyPr/>
+                    <a:lstStyle/>
+                    <a:p>
+                      <a:pPr indent="0" marL="0">
+                        <a:buNone/>
+                      </a:pPr>
+                      <a:r>
+                        <a:rPr lang="en-US" sz="740" dirty="0">
+                          <a:solidFill>
+                            <a:srgbClr val="333333"/>
+                          </a:solidFill>
+                        </a:rPr>
+                        <a:t>Dans la facade accounts, les calculs derives doivent devenir des computed() afin que le composant consomme directement des valeurs reactives pretes a afficher.</a:t>
+                      </a:r>
+                      <a:endParaRPr lang="en-US" sz="740" dirty="0"/>
+                    </a:p>
+                  </a:txBody>
+                  <a:tcPr marL="50800" marR="50800" marT="25400" marB="25400" anchor="mid">
+                    <a:lnL w="5715" cap="flat" cmpd="sng" algn="ctr">
+                      <a:solidFill>
+                        <a:srgbClr val="DADCE0"/>
+                      </a:solidFill>
+                      <a:prstDash val="solid"/>
+                      <a:round/>
+                      <a:headEnd type="none" w="med" len="med"/>
+                      <a:tailEnd type="none" w="med" len="med"/>
+                    </a:lnL>
+                    <a:lnR w="5715" cap="flat" cmpd="sng" algn="ctr">
+                      <a:solidFill>
+                        <a:srgbClr val="DADCE0"/>
+                      </a:solidFill>
+                      <a:prstDash val="solid"/>
+                      <a:round/>
+                      <a:headEnd type="none" w="med" len="med"/>
+                      <a:tailEnd type="none" w="med" len="med"/>
+                    </a:lnR>
+                    <a:lnT w="5715" cap="flat" cmpd="sng" algn="ctr">
+                      <a:solidFill>
+                        <a:srgbClr val="DADCE0"/>
+                      </a:solidFill>
+                      <a:prstDash val="solid"/>
+                      <a:round/>
+                      <a:headEnd type="none" w="med" len="med"/>
+                      <a:tailEnd type="none" w="med" len="med"/>
+                    </a:lnT>
+                    <a:lnB w="5715" cap="flat" cmpd="sng" algn="ctr">
+                      <a:solidFill>
+                        <a:srgbClr val="DADCE0"/>
+                      </a:solidFill>
+                      <a:prstDash val="solid"/>
+                      <a:round/>
+                      <a:headEnd type="none" w="med" len="med"/>
+                      <a:tailEnd type="none" w="med" len="med"/>
+                    </a:lnB>
+                    <a:solidFill>
+                      <a:srgbClr val="F6F7F9"/>
+                    </a:solidFill>
+                  </a:tcPr>
+                </a:tc>
+              </a:tr>
+              <a:tr h="530352">
+                <a:tc>
+                  <a:txBody>
+                    <a:bodyPr/>
+                    <a:lstStyle/>
+                    <a:p>
+                      <a:pPr indent="0" marL="0">
+                        <a:buNone/>
+                      </a:pPr>
+                      <a:r>
+                        <a:rPr lang="en-US" sz="740" dirty="0">
+                          <a:solidFill>
+                            <a:srgbClr val="333333"/>
+                          </a:solidFill>
+                        </a:rPr>
+                        <a:t>3 — effect()</a:t>
+                      </a:r>
+                      <a:endParaRPr lang="en-US" sz="740" dirty="0"/>
                     </a:p>
                   </a:txBody>
                   <a:tcPr marL="50800" marR="50800" marT="25400" marB="25400" anchor="mid">
@@ -3622,14 +3808,14 @@
                         <a:buNone/>
                       </a:pPr>
                       <a:r>
-                        <a:rPr lang="en-US" sz="850" dirty="0">
+                        <a:rPr lang="en-US" sz="740" dirty="0">
                           <a:solidFill>
                             <a:srgbClr val="333333"/>
                           </a:solidFill>
                         </a:rPr>
-                        <a:t>L'etat d'ajout de la page clients doit devenir un signal.</a:t>
+                        <a:t>Effet de bord declenche par les signals lus.</a:t>
                       </a:r>
-                      <a:endParaRPr lang="en-US" sz="850" dirty="0"/>
+                      <a:endParaRPr lang="en-US" sz="740" dirty="0"/>
                     </a:p>
                   </a:txBody>
                   <a:tcPr marL="50800" marR="50800" marT="25400" marB="25400" anchor="mid">
@@ -3674,8 +3860,6 @@
                     </a:solidFill>
                   </a:tcPr>
                 </a:tc>
-              </a:tr>
-              <a:tr h="310896">
                 <a:tc>
                   <a:txBody>
                     <a:bodyPr/>
@@ -3685,14 +3869,77 @@
                         <a:buNone/>
                       </a:pPr>
                       <a:r>
-                        <a:rPr lang="en-US" sz="850" dirty="0">
+                        <a:rPr lang="en-US" sz="740" dirty="0">
                           <a:solidFill>
                             <a:srgbClr val="333333"/>
                           </a:solidFill>
                         </a:rPr>
-                        <a:t>2</a:t>
+                        <a:t>Dans la page clients, l'etat UI doit rester coherent automatiquement quand les donnees ou les filtres changent, sans dupliquer cette logique dans le template.</a:t>
                       </a:r>
-                      <a:endParaRPr lang="en-US" sz="850" dirty="0"/>
+                      <a:endParaRPr lang="en-US" sz="740" dirty="0"/>
+                    </a:p>
+                  </a:txBody>
+                  <a:tcPr marL="50800" marR="50800" marT="25400" marB="25400" anchor="mid">
+                    <a:lnL w="5715" cap="flat" cmpd="sng" algn="ctr">
+                      <a:solidFill>
+                        <a:srgbClr val="DADCE0"/>
+                      </a:solidFill>
+                      <a:prstDash val="solid"/>
+                      <a:round/>
+                      <a:headEnd type="none" w="med" len="med"/>
+                      <a:tailEnd type="none" w="med" len="med"/>
+                    </a:lnL>
+                    <a:lnR w="5715" cap="flat" cmpd="sng" algn="ctr">
+                      <a:solidFill>
+                        <a:srgbClr val="DADCE0"/>
+                      </a:solidFill>
+                      <a:prstDash val="solid"/>
+                      <a:round/>
+                      <a:headEnd type="none" w="med" len="med"/>
+                      <a:tailEnd type="none" w="med" len="med"/>
+                    </a:lnR>
+                    <a:lnT w="5715" cap="flat" cmpd="sng" algn="ctr">
+                      <a:solidFill>
+                        <a:srgbClr val="DADCE0"/>
+                      </a:solidFill>
+                      <a:prstDash val="solid"/>
+                      <a:round/>
+                      <a:headEnd type="none" w="med" len="med"/>
+                      <a:tailEnd type="none" w="med" len="med"/>
+                    </a:lnT>
+                    <a:lnB w="5715" cap="flat" cmpd="sng" algn="ctr">
+                      <a:solidFill>
+                        <a:srgbClr val="DADCE0"/>
+                      </a:solidFill>
+                      <a:prstDash val="solid"/>
+                      <a:round/>
+                      <a:headEnd type="none" w="med" len="med"/>
+                      <a:tailEnd type="none" w="med" len="med"/>
+                    </a:lnB>
+                    <a:solidFill>
+                      <a:srgbClr val="FFFFFF"/>
+                    </a:solidFill>
+                  </a:tcPr>
+                </a:tc>
+              </a:tr>
+              <a:tr h="530352">
+                <a:tc>
+                  <a:txBody>
+                    <a:bodyPr/>
+                    <a:lstStyle/>
+                    <a:p>
+                      <a:pPr indent="0" marL="0">
+                        <a:buNone/>
+                      </a:pPr>
+                      <a:r>
+                        <a:rPr lang="en-US" sz="740" dirty="0">
+                          <a:solidFill>
+                            <a:srgbClr val="333333"/>
+                          </a:solidFill>
+                        </a:rPr>
+                        <a:t>4 — viewChild() + effect()</a:t>
+                      </a:r>
+                      <a:endParaRPr lang="en-US" sz="740" dirty="0"/>
                     </a:p>
                   </a:txBody>
                   <a:tcPr marL="50800" marR="50800" marT="25400" marB="25400" anchor="mid">
@@ -3746,14 +3993,14 @@
                         <a:buNone/>
                       </a:pPr>
                       <a:r>
-                        <a:rPr lang="en-US" sz="850" dirty="0">
+                        <a:rPr lang="en-US" sz="740" dirty="0">
                           <a:solidFill>
                             <a:srgbClr val="333333"/>
                           </a:solidFill>
                         </a:rPr>
-                        <a:t>computed()</a:t>
+                        <a:t>Reference DOM exposee comme signal, puis effet DOM.</a:t>
                       </a:r>
-                      <a:endParaRPr lang="en-US" sz="850" dirty="0"/>
+                      <a:endParaRPr lang="en-US" sz="740" dirty="0"/>
                     </a:p>
                   </a:txBody>
                   <a:tcPr marL="50800" marR="50800" marT="25400" marB="25400" anchor="mid">
@@ -3807,14 +4054,262 @@
                         <a:buNone/>
                       </a:pPr>
                       <a:r>
-                        <a:rPr lang="en-US" sz="850" dirty="0">
+                        <a:rPr lang="en-US" sz="740" dirty="0">
                           <a:solidFill>
                             <a:srgbClr val="333333"/>
                           </a:solidFill>
                         </a:rPr>
-                        <a:t>Valeur derivee en lecture seule.</a:t>
+                        <a:t>Dans la page clients, le champ prenom doit recevoir le focus quand il devient disponible dans le DOM, avec une reference viewChild() signal et un effect() cree par les participants.</a:t>
                       </a:r>
-                      <a:endParaRPr lang="en-US" sz="850" dirty="0"/>
+                      <a:endParaRPr lang="en-US" sz="740" dirty="0"/>
+                    </a:p>
+                  </a:txBody>
+                  <a:tcPr marL="50800" marR="50800" marT="25400" marB="25400" anchor="mid">
+                    <a:lnL w="5715" cap="flat" cmpd="sng" algn="ctr">
+                      <a:solidFill>
+                        <a:srgbClr val="DADCE0"/>
+                      </a:solidFill>
+                      <a:prstDash val="solid"/>
+                      <a:round/>
+                      <a:headEnd type="none" w="med" len="med"/>
+                      <a:tailEnd type="none" w="med" len="med"/>
+                    </a:lnL>
+                    <a:lnR w="5715" cap="flat" cmpd="sng" algn="ctr">
+                      <a:solidFill>
+                        <a:srgbClr val="DADCE0"/>
+                      </a:solidFill>
+                      <a:prstDash val="solid"/>
+                      <a:round/>
+                      <a:headEnd type="none" w="med" len="med"/>
+                      <a:tailEnd type="none" w="med" len="med"/>
+                    </a:lnR>
+                    <a:lnT w="5715" cap="flat" cmpd="sng" algn="ctr">
+                      <a:solidFill>
+                        <a:srgbClr val="DADCE0"/>
+                      </a:solidFill>
+                      <a:prstDash val="solid"/>
+                      <a:round/>
+                      <a:headEnd type="none" w="med" len="med"/>
+                      <a:tailEnd type="none" w="med" len="med"/>
+                    </a:lnT>
+                    <a:lnB w="5715" cap="flat" cmpd="sng" algn="ctr">
+                      <a:solidFill>
+                        <a:srgbClr val="DADCE0"/>
+                      </a:solidFill>
+                      <a:prstDash val="solid"/>
+                      <a:round/>
+                      <a:headEnd type="none" w="med" len="med"/>
+                      <a:tailEnd type="none" w="med" len="med"/>
+                    </a:lnB>
+                    <a:solidFill>
+                      <a:srgbClr val="F6F7F9"/>
+                    </a:solidFill>
+                  </a:tcPr>
+                </a:tc>
+              </a:tr>
+              <a:tr h="530352">
+                <a:tc>
+                  <a:txBody>
+                    <a:bodyPr/>
+                    <a:lstStyle/>
+                    <a:p>
+                      <a:pPr indent="0" marL="0">
+                        <a:buNone/>
+                      </a:pPr>
+                      <a:r>
+                        <a:rPr lang="en-US" sz="740" dirty="0">
+                          <a:solidFill>
+                            <a:srgbClr val="333333"/>
+                          </a:solidFill>
+                        </a:rPr>
+                        <a:t>5 — input()</a:t>
+                      </a:r>
+                      <a:endParaRPr lang="en-US" sz="740" dirty="0"/>
+                    </a:p>
+                  </a:txBody>
+                  <a:tcPr marL="50800" marR="50800" marT="25400" marB="25400" anchor="mid">
+                    <a:lnL w="5715" cap="flat" cmpd="sng" algn="ctr">
+                      <a:solidFill>
+                        <a:srgbClr val="DADCE0"/>
+                      </a:solidFill>
+                      <a:prstDash val="solid"/>
+                      <a:round/>
+                      <a:headEnd type="none" w="med" len="med"/>
+                      <a:tailEnd type="none" w="med" len="med"/>
+                    </a:lnL>
+                    <a:lnR w="5715" cap="flat" cmpd="sng" algn="ctr">
+                      <a:solidFill>
+                        <a:srgbClr val="DADCE0"/>
+                      </a:solidFill>
+                      <a:prstDash val="solid"/>
+                      <a:round/>
+                      <a:headEnd type="none" w="med" len="med"/>
+                      <a:tailEnd type="none" w="med" len="med"/>
+                    </a:lnR>
+                    <a:lnT w="5715" cap="flat" cmpd="sng" algn="ctr">
+                      <a:solidFill>
+                        <a:srgbClr val="DADCE0"/>
+                      </a:solidFill>
+                      <a:prstDash val="solid"/>
+                      <a:round/>
+                      <a:headEnd type="none" w="med" len="med"/>
+                      <a:tailEnd type="none" w="med" len="med"/>
+                    </a:lnT>
+                    <a:lnB w="5715" cap="flat" cmpd="sng" algn="ctr">
+                      <a:solidFill>
+                        <a:srgbClr val="DADCE0"/>
+                      </a:solidFill>
+                      <a:prstDash val="solid"/>
+                      <a:round/>
+                      <a:headEnd type="none" w="med" len="med"/>
+                      <a:tailEnd type="none" w="med" len="med"/>
+                    </a:lnB>
+                    <a:solidFill>
+                      <a:srgbClr val="FFFFFF"/>
+                    </a:solidFill>
+                  </a:tcPr>
+                </a:tc>
+                <a:tc>
+                  <a:txBody>
+                    <a:bodyPr/>
+                    <a:lstStyle/>
+                    <a:p>
+                      <a:pPr indent="0" marL="0">
+                        <a:buNone/>
+                      </a:pPr>
+                      <a:r>
+                        <a:rPr lang="en-US" sz="740" dirty="0">
+                          <a:solidFill>
+                            <a:srgbClr val="333333"/>
+                          </a:solidFill>
+                        </a:rPr>
+                        <a:t>Entree de composant exposee comme signal.</a:t>
+                      </a:r>
+                      <a:endParaRPr lang="en-US" sz="740" dirty="0"/>
+                    </a:p>
+                  </a:txBody>
+                  <a:tcPr marL="50800" marR="50800" marT="25400" marB="25400" anchor="mid">
+                    <a:lnL w="5715" cap="flat" cmpd="sng" algn="ctr">
+                      <a:solidFill>
+                        <a:srgbClr val="DADCE0"/>
+                      </a:solidFill>
+                      <a:prstDash val="solid"/>
+                      <a:round/>
+                      <a:headEnd type="none" w="med" len="med"/>
+                      <a:tailEnd type="none" w="med" len="med"/>
+                    </a:lnL>
+                    <a:lnR w="5715" cap="flat" cmpd="sng" algn="ctr">
+                      <a:solidFill>
+                        <a:srgbClr val="DADCE0"/>
+                      </a:solidFill>
+                      <a:prstDash val="solid"/>
+                      <a:round/>
+                      <a:headEnd type="none" w="med" len="med"/>
+                      <a:tailEnd type="none" w="med" len="med"/>
+                    </a:lnR>
+                    <a:lnT w="5715" cap="flat" cmpd="sng" algn="ctr">
+                      <a:solidFill>
+                        <a:srgbClr val="DADCE0"/>
+                      </a:solidFill>
+                      <a:prstDash val="solid"/>
+                      <a:round/>
+                      <a:headEnd type="none" w="med" len="med"/>
+                      <a:tailEnd type="none" w="med" len="med"/>
+                    </a:lnT>
+                    <a:lnB w="5715" cap="flat" cmpd="sng" algn="ctr">
+                      <a:solidFill>
+                        <a:srgbClr val="DADCE0"/>
+                      </a:solidFill>
+                      <a:prstDash val="solid"/>
+                      <a:round/>
+                      <a:headEnd type="none" w="med" len="med"/>
+                      <a:tailEnd type="none" w="med" len="med"/>
+                    </a:lnB>
+                    <a:solidFill>
+                      <a:srgbClr val="FFFFFF"/>
+                    </a:solidFill>
+                  </a:tcPr>
+                </a:tc>
+                <a:tc>
+                  <a:txBody>
+                    <a:bodyPr/>
+                    <a:lstStyle/>
+                    <a:p>
+                      <a:pPr indent="0" marL="0">
+                        <a:buNone/>
+                      </a:pPr>
+                      <a:r>
+                        <a:rPr lang="en-US" sz="740" dirty="0">
+                          <a:solidFill>
+                            <a:srgbClr val="333333"/>
+                          </a:solidFill>
+                        </a:rPr>
+                        <a:t>Dans la carte compte, l'entree showStatus doit devenir une entree signal pour etre une vraie dependance reactive du calcul d'affichage.</a:t>
+                      </a:r>
+                      <a:endParaRPr lang="en-US" sz="740" dirty="0"/>
+                    </a:p>
+                  </a:txBody>
+                  <a:tcPr marL="50800" marR="50800" marT="25400" marB="25400" anchor="mid">
+                    <a:lnL w="5715" cap="flat" cmpd="sng" algn="ctr">
+                      <a:solidFill>
+                        <a:srgbClr val="DADCE0"/>
+                      </a:solidFill>
+                      <a:prstDash val="solid"/>
+                      <a:round/>
+                      <a:headEnd type="none" w="med" len="med"/>
+                      <a:tailEnd type="none" w="med" len="med"/>
+                    </a:lnL>
+                    <a:lnR w="5715" cap="flat" cmpd="sng" algn="ctr">
+                      <a:solidFill>
+                        <a:srgbClr val="DADCE0"/>
+                      </a:solidFill>
+                      <a:prstDash val="solid"/>
+                      <a:round/>
+                      <a:headEnd type="none" w="med" len="med"/>
+                      <a:tailEnd type="none" w="med" len="med"/>
+                    </a:lnR>
+                    <a:lnT w="5715" cap="flat" cmpd="sng" algn="ctr">
+                      <a:solidFill>
+                        <a:srgbClr val="DADCE0"/>
+                      </a:solidFill>
+                      <a:prstDash val="solid"/>
+                      <a:round/>
+                      <a:headEnd type="none" w="med" len="med"/>
+                      <a:tailEnd type="none" w="med" len="med"/>
+                    </a:lnT>
+                    <a:lnB w="5715" cap="flat" cmpd="sng" algn="ctr">
+                      <a:solidFill>
+                        <a:srgbClr val="DADCE0"/>
+                      </a:solidFill>
+                      <a:prstDash val="solid"/>
+                      <a:round/>
+                      <a:headEnd type="none" w="med" len="med"/>
+                      <a:tailEnd type="none" w="med" len="med"/>
+                    </a:lnB>
+                    <a:solidFill>
+                      <a:srgbClr val="FFFFFF"/>
+                    </a:solidFill>
+                  </a:tcPr>
+                </a:tc>
+              </a:tr>
+              <a:tr h="530352">
+                <a:tc>
+                  <a:txBody>
+                    <a:bodyPr/>
+                    <a:lstStyle/>
+                    <a:p>
+                      <a:pPr indent="0" marL="0">
+                        <a:buNone/>
+                      </a:pPr>
+                      <a:r>
+                        <a:rPr lang="en-US" sz="740" dirty="0">
+                          <a:solidFill>
+                            <a:srgbClr val="333333"/>
+                          </a:solidFill>
+                        </a:rPr>
+                        <a:t>6 — output()</a:t>
+                      </a:r>
+                      <a:endParaRPr lang="en-US" sz="740" dirty="0"/>
                     </a:p>
                   </a:txBody>
                   <a:tcPr marL="50800" marR="50800" marT="25400" marB="25400" anchor="mid">
@@ -3868,14 +4363,14 @@
                         <a:buNone/>
                       </a:pPr>
                       <a:r>
-                        <a:rPr lang="en-US" sz="850" dirty="0">
+                        <a:rPr lang="en-US" sz="740" dirty="0">
                           <a:solidFill>
                             <a:srgbClr val="333333"/>
                           </a:solidFill>
                         </a:rPr>
-                        <a:t>Les valeurs derivees de la facade accounts doivent etre exposees en computed().</a:t>
+                        <a:t>Evenement emis par l'enfant vers le parent.</a:t>
                       </a:r>
-                      <a:endParaRPr lang="en-US" sz="850" dirty="0"/>
+                      <a:endParaRPr lang="en-US" sz="740" dirty="0"/>
                     </a:p>
                   </a:txBody>
                   <a:tcPr marL="50800" marR="50800" marT="25400" marB="25400" anchor="mid">
@@ -3920,8 +4415,6 @@
                     </a:solidFill>
                   </a:tcPr>
                 </a:tc>
-              </a:tr>
-              <a:tr h="310896">
                 <a:tc>
                   <a:txBody>
                     <a:bodyPr/>
@@ -3931,14 +4424,77 @@
                         <a:buNone/>
                       </a:pPr>
                       <a:r>
-                        <a:rPr lang="en-US" sz="850" dirty="0">
+                        <a:rPr lang="en-US" sz="740" dirty="0">
                           <a:solidFill>
                             <a:srgbClr val="333333"/>
                           </a:solidFill>
                         </a:rPr>
-                        <a:t>3</a:t>
+                        <a:t>Dans la liste des comptes, la selection d'un compte doit etre emise avec output() comme une intention vers le parent, en gardant le parent responsable de l'action.</a:t>
                       </a:r>
-                      <a:endParaRPr lang="en-US" sz="850" dirty="0"/>
+                      <a:endParaRPr lang="en-US" sz="740" dirty="0"/>
+                    </a:p>
+                  </a:txBody>
+                  <a:tcPr marL="50800" marR="50800" marT="25400" marB="25400" anchor="mid">
+                    <a:lnL w="5715" cap="flat" cmpd="sng" algn="ctr">
+                      <a:solidFill>
+                        <a:srgbClr val="DADCE0"/>
+                      </a:solidFill>
+                      <a:prstDash val="solid"/>
+                      <a:round/>
+                      <a:headEnd type="none" w="med" len="med"/>
+                      <a:tailEnd type="none" w="med" len="med"/>
+                    </a:lnL>
+                    <a:lnR w="5715" cap="flat" cmpd="sng" algn="ctr">
+                      <a:solidFill>
+                        <a:srgbClr val="DADCE0"/>
+                      </a:solidFill>
+                      <a:prstDash val="solid"/>
+                      <a:round/>
+                      <a:headEnd type="none" w="med" len="med"/>
+                      <a:tailEnd type="none" w="med" len="med"/>
+                    </a:lnR>
+                    <a:lnT w="5715" cap="flat" cmpd="sng" algn="ctr">
+                      <a:solidFill>
+                        <a:srgbClr val="DADCE0"/>
+                      </a:solidFill>
+                      <a:prstDash val="solid"/>
+                      <a:round/>
+                      <a:headEnd type="none" w="med" len="med"/>
+                      <a:tailEnd type="none" w="med" len="med"/>
+                    </a:lnT>
+                    <a:lnB w="5715" cap="flat" cmpd="sng" algn="ctr">
+                      <a:solidFill>
+                        <a:srgbClr val="DADCE0"/>
+                      </a:solidFill>
+                      <a:prstDash val="solid"/>
+                      <a:round/>
+                      <a:headEnd type="none" w="med" len="med"/>
+                      <a:tailEnd type="none" w="med" len="med"/>
+                    </a:lnB>
+                    <a:solidFill>
+                      <a:srgbClr val="F6F7F9"/>
+                    </a:solidFill>
+                  </a:tcPr>
+                </a:tc>
+              </a:tr>
+              <a:tr h="530352">
+                <a:tc>
+                  <a:txBody>
+                    <a:bodyPr/>
+                    <a:lstStyle/>
+                    <a:p>
+                      <a:pPr indent="0" marL="0">
+                        <a:buNone/>
+                      </a:pPr>
+                      <a:r>
+                        <a:rPr lang="en-US" sz="740" dirty="0">
+                          <a:solidFill>
+                            <a:srgbClr val="333333"/>
+                          </a:solidFill>
+                        </a:rPr>
+                        <a:t>7 — toSignal() / toObservable()</a:t>
+                      </a:r>
+                      <a:endParaRPr lang="en-US" sz="740" dirty="0"/>
                     </a:p>
                   </a:txBody>
                   <a:tcPr marL="50800" marR="50800" marT="25400" marB="25400" anchor="mid">
@@ -3992,14 +4548,14 @@
                         <a:buNone/>
                       </a:pPr>
                       <a:r>
-                        <a:rPr lang="en-US" sz="850" dirty="0">
+                        <a:rPr lang="en-US" sz="740" dirty="0">
                           <a:solidFill>
                             <a:srgbClr val="333333"/>
                           </a:solidFill>
                         </a:rPr>
-                        <a:t>effect()</a:t>
+                        <a:t>Frontiere entre Observable RxJS et signal Angular.</a:t>
                       </a:r>
-                      <a:endParaRPr lang="en-US" sz="850" dirty="0"/>
+                      <a:endParaRPr lang="en-US" sz="740" dirty="0"/>
                     </a:p>
                   </a:txBody>
                   <a:tcPr marL="50800" marR="50800" marT="25400" marB="25400" anchor="mid">
@@ -4053,14 +4609,14 @@
                         <a:buNone/>
                       </a:pPr>
                       <a:r>
-                        <a:rPr lang="en-US" sz="850" dirty="0">
+                        <a:rPr lang="en-US" sz="740" dirty="0">
                           <a:solidFill>
                             <a:srgbClr val="333333"/>
                           </a:solidFill>
                         </a:rPr>
-                        <a:t>Effet de bord declenche par les signals lus.</a:t>
+                        <a:t>Les flux de route, de chargement et de recherche doivent etre connectes aux signals sans supprimer RxJS la ou il compose le flux asynchrone.</a:t>
                       </a:r>
-                      <a:endParaRPr lang="en-US" sz="850" dirty="0"/>
+                      <a:endParaRPr lang="en-US" sz="740" dirty="0"/>
                     </a:p>
                   </a:txBody>
                   <a:tcPr marL="50800" marR="50800" marT="25400" marB="25400" anchor="mid">
@@ -4105,6 +4661,8 @@
                     </a:solidFill>
                   </a:tcPr>
                 </a:tc>
+              </a:tr>
+              <a:tr h="530352">
                 <a:tc>
                   <a:txBody>
                     <a:bodyPr/>
@@ -4114,77 +4672,14 @@
                         <a:buNone/>
                       </a:pPr>
                       <a:r>
-                        <a:rPr lang="en-US" sz="850" dirty="0">
+                        <a:rPr lang="en-US" sz="740" dirty="0">
                           <a:solidFill>
                             <a:srgbClr val="333333"/>
                           </a:solidFill>
                         </a:rPr>
-                        <a:t>La coherence de l'etat UI clients doit etre synchronisee par un effect().</a:t>
+                        <a:t>8 — computed() facade</a:t>
                       </a:r>
-                      <a:endParaRPr lang="en-US" sz="850" dirty="0"/>
-                    </a:p>
-                  </a:txBody>
-                  <a:tcPr marL="50800" marR="50800" marT="25400" marB="25400" anchor="mid">
-                    <a:lnL w="5715" cap="flat" cmpd="sng" algn="ctr">
-                      <a:solidFill>
-                        <a:srgbClr val="DADCE0"/>
-                      </a:solidFill>
-                      <a:prstDash val="solid"/>
-                      <a:round/>
-                      <a:headEnd type="none" w="med" len="med"/>
-                      <a:tailEnd type="none" w="med" len="med"/>
-                    </a:lnL>
-                    <a:lnR w="5715" cap="flat" cmpd="sng" algn="ctr">
-                      <a:solidFill>
-                        <a:srgbClr val="DADCE0"/>
-                      </a:solidFill>
-                      <a:prstDash val="solid"/>
-                      <a:round/>
-                      <a:headEnd type="none" w="med" len="med"/>
-                      <a:tailEnd type="none" w="med" len="med"/>
-                    </a:lnR>
-                    <a:lnT w="5715" cap="flat" cmpd="sng" algn="ctr">
-                      <a:solidFill>
-                        <a:srgbClr val="DADCE0"/>
-                      </a:solidFill>
-                      <a:prstDash val="solid"/>
-                      <a:round/>
-                      <a:headEnd type="none" w="med" len="med"/>
-                      <a:tailEnd type="none" w="med" len="med"/>
-                    </a:lnT>
-                    <a:lnB w="5715" cap="flat" cmpd="sng" algn="ctr">
-                      <a:solidFill>
-                        <a:srgbClr val="DADCE0"/>
-                      </a:solidFill>
-                      <a:prstDash val="solid"/>
-                      <a:round/>
-                      <a:headEnd type="none" w="med" len="med"/>
-                      <a:tailEnd type="none" w="med" len="med"/>
-                    </a:lnB>
-                    <a:solidFill>
-                      <a:srgbClr val="FFFFFF"/>
-                    </a:solidFill>
-                  </a:tcPr>
-                </a:tc>
-              </a:tr>
-              <a:tr h="310896">
-                <a:tc>
-                  <a:txBody>
-                    <a:bodyPr/>
-                    <a:lstStyle/>
-                    <a:p>
-                      <a:pPr indent="0" marL="0">
-                        <a:buNone/>
-                      </a:pPr>
-                      <a:r>
-                        <a:rPr lang="en-US" sz="850" dirty="0">
-                          <a:solidFill>
-                            <a:srgbClr val="333333"/>
-                          </a:solidFill>
-                        </a:rPr>
-                        <a:t>4</a:t>
-                      </a:r>
-                      <a:endParaRPr lang="en-US" sz="850" dirty="0"/>
+                      <a:endParaRPr lang="en-US" sz="740" dirty="0"/>
                     </a:p>
                   </a:txBody>
                   <a:tcPr marL="50800" marR="50800" marT="25400" marB="25400" anchor="mid">
@@ -4238,14 +4733,14 @@
                         <a:buNone/>
                       </a:pPr>
                       <a:r>
-                        <a:rPr lang="en-US" sz="850" dirty="0">
+                        <a:rPr lang="en-US" sz="740" dirty="0">
                           <a:solidFill>
                             <a:srgbClr val="333333"/>
                           </a:solidFill>
                         </a:rPr>
-                        <a:t>viewChild() + effect()</a:t>
+                        <a:t>Vue derivee de l'etat metier dans une facade.</a:t>
                       </a:r>
-                      <a:endParaRPr lang="en-US" sz="850" dirty="0"/>
+                      <a:endParaRPr lang="en-US" sz="740" dirty="0"/>
                     </a:p>
                   </a:txBody>
                   <a:tcPr marL="50800" marR="50800" marT="25400" marB="25400" anchor="mid">
@@ -4299,1059 +4794,14 @@
                         <a:buNone/>
                       </a:pPr>
                       <a:r>
-                        <a:rPr lang="en-US" sz="850" dirty="0">
+                        <a:rPr lang="en-US" sz="740" dirty="0">
                           <a:solidFill>
                             <a:srgbClr val="333333"/>
                           </a:solidFill>
                         </a:rPr>
-                        <a:t>Reference DOM exposee comme signal, puis effet DOM.</a:t>
+                        <a:t>La facade accounts doit exposer l'etat derive hasActiveFilter pour retirer ce calcul du composant et centraliser la regle metier.</a:t>
                       </a:r>
-                      <a:endParaRPr lang="en-US" sz="850" dirty="0"/>
-                    </a:p>
-                  </a:txBody>
-                  <a:tcPr marL="50800" marR="50800" marT="25400" marB="25400" anchor="mid">
-                    <a:lnL w="5715" cap="flat" cmpd="sng" algn="ctr">
-                      <a:solidFill>
-                        <a:srgbClr val="DADCE0"/>
-                      </a:solidFill>
-                      <a:prstDash val="solid"/>
-                      <a:round/>
-                      <a:headEnd type="none" w="med" len="med"/>
-                      <a:tailEnd type="none" w="med" len="med"/>
-                    </a:lnL>
-                    <a:lnR w="5715" cap="flat" cmpd="sng" algn="ctr">
-                      <a:solidFill>
-                        <a:srgbClr val="DADCE0"/>
-                      </a:solidFill>
-                      <a:prstDash val="solid"/>
-                      <a:round/>
-                      <a:headEnd type="none" w="med" len="med"/>
-                      <a:tailEnd type="none" w="med" len="med"/>
-                    </a:lnR>
-                    <a:lnT w="5715" cap="flat" cmpd="sng" algn="ctr">
-                      <a:solidFill>
-                        <a:srgbClr val="DADCE0"/>
-                      </a:solidFill>
-                      <a:prstDash val="solid"/>
-                      <a:round/>
-                      <a:headEnd type="none" w="med" len="med"/>
-                      <a:tailEnd type="none" w="med" len="med"/>
-                    </a:lnT>
-                    <a:lnB w="5715" cap="flat" cmpd="sng" algn="ctr">
-                      <a:solidFill>
-                        <a:srgbClr val="DADCE0"/>
-                      </a:solidFill>
-                      <a:prstDash val="solid"/>
-                      <a:round/>
-                      <a:headEnd type="none" w="med" len="med"/>
-                      <a:tailEnd type="none" w="med" len="med"/>
-                    </a:lnB>
-                    <a:solidFill>
-                      <a:srgbClr val="F6F7F9"/>
-                    </a:solidFill>
-                  </a:tcPr>
-                </a:tc>
-                <a:tc>
-                  <a:txBody>
-                    <a:bodyPr/>
-                    <a:lstStyle/>
-                    <a:p>
-                      <a:pPr indent="0" marL="0">
-                        <a:buNone/>
-                      </a:pPr>
-                      <a:r>
-                        <a:rPr lang="en-US" sz="850" dirty="0">
-                          <a:solidFill>
-                            <a:srgbClr val="333333"/>
-                          </a:solidFill>
-                        </a:rPr>
-                        <a:t>Le focus du champ prenom doit etre gere avec viewChild() signal et effect().</a:t>
-                      </a:r>
-                      <a:endParaRPr lang="en-US" sz="850" dirty="0"/>
-                    </a:p>
-                  </a:txBody>
-                  <a:tcPr marL="50800" marR="50800" marT="25400" marB="25400" anchor="mid">
-                    <a:lnL w="5715" cap="flat" cmpd="sng" algn="ctr">
-                      <a:solidFill>
-                        <a:srgbClr val="DADCE0"/>
-                      </a:solidFill>
-                      <a:prstDash val="solid"/>
-                      <a:round/>
-                      <a:headEnd type="none" w="med" len="med"/>
-                      <a:tailEnd type="none" w="med" len="med"/>
-                    </a:lnL>
-                    <a:lnR w="5715" cap="flat" cmpd="sng" algn="ctr">
-                      <a:solidFill>
-                        <a:srgbClr val="DADCE0"/>
-                      </a:solidFill>
-                      <a:prstDash val="solid"/>
-                      <a:round/>
-                      <a:headEnd type="none" w="med" len="med"/>
-                      <a:tailEnd type="none" w="med" len="med"/>
-                    </a:lnR>
-                    <a:lnT w="5715" cap="flat" cmpd="sng" algn="ctr">
-                      <a:solidFill>
-                        <a:srgbClr val="DADCE0"/>
-                      </a:solidFill>
-                      <a:prstDash val="solid"/>
-                      <a:round/>
-                      <a:headEnd type="none" w="med" len="med"/>
-                      <a:tailEnd type="none" w="med" len="med"/>
-                    </a:lnT>
-                    <a:lnB w="5715" cap="flat" cmpd="sng" algn="ctr">
-                      <a:solidFill>
-                        <a:srgbClr val="DADCE0"/>
-                      </a:solidFill>
-                      <a:prstDash val="solid"/>
-                      <a:round/>
-                      <a:headEnd type="none" w="med" len="med"/>
-                      <a:tailEnd type="none" w="med" len="med"/>
-                    </a:lnB>
-                    <a:solidFill>
-                      <a:srgbClr val="F6F7F9"/>
-                    </a:solidFill>
-                  </a:tcPr>
-                </a:tc>
-              </a:tr>
-              <a:tr h="310896">
-                <a:tc>
-                  <a:txBody>
-                    <a:bodyPr/>
-                    <a:lstStyle/>
-                    <a:p>
-                      <a:pPr indent="0" marL="0">
-                        <a:buNone/>
-                      </a:pPr>
-                      <a:r>
-                        <a:rPr lang="en-US" sz="850" dirty="0">
-                          <a:solidFill>
-                            <a:srgbClr val="333333"/>
-                          </a:solidFill>
-                        </a:rPr>
-                        <a:t>5</a:t>
-                      </a:r>
-                      <a:endParaRPr lang="en-US" sz="850" dirty="0"/>
-                    </a:p>
-                  </a:txBody>
-                  <a:tcPr marL="50800" marR="50800" marT="25400" marB="25400" anchor="mid">
-                    <a:lnL w="5715" cap="flat" cmpd="sng" algn="ctr">
-                      <a:solidFill>
-                        <a:srgbClr val="DADCE0"/>
-                      </a:solidFill>
-                      <a:prstDash val="solid"/>
-                      <a:round/>
-                      <a:headEnd type="none" w="med" len="med"/>
-                      <a:tailEnd type="none" w="med" len="med"/>
-                    </a:lnL>
-                    <a:lnR w="5715" cap="flat" cmpd="sng" algn="ctr">
-                      <a:solidFill>
-                        <a:srgbClr val="DADCE0"/>
-                      </a:solidFill>
-                      <a:prstDash val="solid"/>
-                      <a:round/>
-                      <a:headEnd type="none" w="med" len="med"/>
-                      <a:tailEnd type="none" w="med" len="med"/>
-                    </a:lnR>
-                    <a:lnT w="5715" cap="flat" cmpd="sng" algn="ctr">
-                      <a:solidFill>
-                        <a:srgbClr val="DADCE0"/>
-                      </a:solidFill>
-                      <a:prstDash val="solid"/>
-                      <a:round/>
-                      <a:headEnd type="none" w="med" len="med"/>
-                      <a:tailEnd type="none" w="med" len="med"/>
-                    </a:lnT>
-                    <a:lnB w="5715" cap="flat" cmpd="sng" algn="ctr">
-                      <a:solidFill>
-                        <a:srgbClr val="DADCE0"/>
-                      </a:solidFill>
-                      <a:prstDash val="solid"/>
-                      <a:round/>
-                      <a:headEnd type="none" w="med" len="med"/>
-                      <a:tailEnd type="none" w="med" len="med"/>
-                    </a:lnB>
-                    <a:solidFill>
-                      <a:srgbClr val="FFFFFF"/>
-                    </a:solidFill>
-                  </a:tcPr>
-                </a:tc>
-                <a:tc>
-                  <a:txBody>
-                    <a:bodyPr/>
-                    <a:lstStyle/>
-                    <a:p>
-                      <a:pPr indent="0" marL="0">
-                        <a:buNone/>
-                      </a:pPr>
-                      <a:r>
-                        <a:rPr lang="en-US" sz="850" dirty="0">
-                          <a:solidFill>
-                            <a:srgbClr val="333333"/>
-                          </a:solidFill>
-                        </a:rPr>
-                        <a:t>input()</a:t>
-                      </a:r>
-                      <a:endParaRPr lang="en-US" sz="850" dirty="0"/>
-                    </a:p>
-                  </a:txBody>
-                  <a:tcPr marL="50800" marR="50800" marT="25400" marB="25400" anchor="mid">
-                    <a:lnL w="5715" cap="flat" cmpd="sng" algn="ctr">
-                      <a:solidFill>
-                        <a:srgbClr val="DADCE0"/>
-                      </a:solidFill>
-                      <a:prstDash val="solid"/>
-                      <a:round/>
-                      <a:headEnd type="none" w="med" len="med"/>
-                      <a:tailEnd type="none" w="med" len="med"/>
-                    </a:lnL>
-                    <a:lnR w="5715" cap="flat" cmpd="sng" algn="ctr">
-                      <a:solidFill>
-                        <a:srgbClr val="DADCE0"/>
-                      </a:solidFill>
-                      <a:prstDash val="solid"/>
-                      <a:round/>
-                      <a:headEnd type="none" w="med" len="med"/>
-                      <a:tailEnd type="none" w="med" len="med"/>
-                    </a:lnR>
-                    <a:lnT w="5715" cap="flat" cmpd="sng" algn="ctr">
-                      <a:solidFill>
-                        <a:srgbClr val="DADCE0"/>
-                      </a:solidFill>
-                      <a:prstDash val="solid"/>
-                      <a:round/>
-                      <a:headEnd type="none" w="med" len="med"/>
-                      <a:tailEnd type="none" w="med" len="med"/>
-                    </a:lnT>
-                    <a:lnB w="5715" cap="flat" cmpd="sng" algn="ctr">
-                      <a:solidFill>
-                        <a:srgbClr val="DADCE0"/>
-                      </a:solidFill>
-                      <a:prstDash val="solid"/>
-                      <a:round/>
-                      <a:headEnd type="none" w="med" len="med"/>
-                      <a:tailEnd type="none" w="med" len="med"/>
-                    </a:lnB>
-                    <a:solidFill>
-                      <a:srgbClr val="FFFFFF"/>
-                    </a:solidFill>
-                  </a:tcPr>
-                </a:tc>
-                <a:tc>
-                  <a:txBody>
-                    <a:bodyPr/>
-                    <a:lstStyle/>
-                    <a:p>
-                      <a:pPr indent="0" marL="0">
-                        <a:buNone/>
-                      </a:pPr>
-                      <a:r>
-                        <a:rPr lang="en-US" sz="850" dirty="0">
-                          <a:solidFill>
-                            <a:srgbClr val="333333"/>
-                          </a:solidFill>
-                        </a:rPr>
-                        <a:t>Entree de composant exposee comme signal.</a:t>
-                      </a:r>
-                      <a:endParaRPr lang="en-US" sz="850" dirty="0"/>
-                    </a:p>
-                  </a:txBody>
-                  <a:tcPr marL="50800" marR="50800" marT="25400" marB="25400" anchor="mid">
-                    <a:lnL w="5715" cap="flat" cmpd="sng" algn="ctr">
-                      <a:solidFill>
-                        <a:srgbClr val="DADCE0"/>
-                      </a:solidFill>
-                      <a:prstDash val="solid"/>
-                      <a:round/>
-                      <a:headEnd type="none" w="med" len="med"/>
-                      <a:tailEnd type="none" w="med" len="med"/>
-                    </a:lnL>
-                    <a:lnR w="5715" cap="flat" cmpd="sng" algn="ctr">
-                      <a:solidFill>
-                        <a:srgbClr val="DADCE0"/>
-                      </a:solidFill>
-                      <a:prstDash val="solid"/>
-                      <a:round/>
-                      <a:headEnd type="none" w="med" len="med"/>
-                      <a:tailEnd type="none" w="med" len="med"/>
-                    </a:lnR>
-                    <a:lnT w="5715" cap="flat" cmpd="sng" algn="ctr">
-                      <a:solidFill>
-                        <a:srgbClr val="DADCE0"/>
-                      </a:solidFill>
-                      <a:prstDash val="solid"/>
-                      <a:round/>
-                      <a:headEnd type="none" w="med" len="med"/>
-                      <a:tailEnd type="none" w="med" len="med"/>
-                    </a:lnT>
-                    <a:lnB w="5715" cap="flat" cmpd="sng" algn="ctr">
-                      <a:solidFill>
-                        <a:srgbClr val="DADCE0"/>
-                      </a:solidFill>
-                      <a:prstDash val="solid"/>
-                      <a:round/>
-                      <a:headEnd type="none" w="med" len="med"/>
-                      <a:tailEnd type="none" w="med" len="med"/>
-                    </a:lnB>
-                    <a:solidFill>
-                      <a:srgbClr val="FFFFFF"/>
-                    </a:solidFill>
-                  </a:tcPr>
-                </a:tc>
-                <a:tc>
-                  <a:txBody>
-                    <a:bodyPr/>
-                    <a:lstStyle/>
-                    <a:p>
-                      <a:pPr indent="0" marL="0">
-                        <a:buNone/>
-                      </a:pPr>
-                      <a:r>
-                        <a:rPr lang="en-US" sz="850" dirty="0">
-                          <a:solidFill>
-                            <a:srgbClr val="333333"/>
-                          </a:solidFill>
-                        </a:rPr>
-                        <a:t>L'entree du composant carte compte doit etre convertie en input().</a:t>
-                      </a:r>
-                      <a:endParaRPr lang="en-US" sz="850" dirty="0"/>
-                    </a:p>
-                  </a:txBody>
-                  <a:tcPr marL="50800" marR="50800" marT="25400" marB="25400" anchor="mid">
-                    <a:lnL w="5715" cap="flat" cmpd="sng" algn="ctr">
-                      <a:solidFill>
-                        <a:srgbClr val="DADCE0"/>
-                      </a:solidFill>
-                      <a:prstDash val="solid"/>
-                      <a:round/>
-                      <a:headEnd type="none" w="med" len="med"/>
-                      <a:tailEnd type="none" w="med" len="med"/>
-                    </a:lnL>
-                    <a:lnR w="5715" cap="flat" cmpd="sng" algn="ctr">
-                      <a:solidFill>
-                        <a:srgbClr val="DADCE0"/>
-                      </a:solidFill>
-                      <a:prstDash val="solid"/>
-                      <a:round/>
-                      <a:headEnd type="none" w="med" len="med"/>
-                      <a:tailEnd type="none" w="med" len="med"/>
-                    </a:lnR>
-                    <a:lnT w="5715" cap="flat" cmpd="sng" algn="ctr">
-                      <a:solidFill>
-                        <a:srgbClr val="DADCE0"/>
-                      </a:solidFill>
-                      <a:prstDash val="solid"/>
-                      <a:round/>
-                      <a:headEnd type="none" w="med" len="med"/>
-                      <a:tailEnd type="none" w="med" len="med"/>
-                    </a:lnT>
-                    <a:lnB w="5715" cap="flat" cmpd="sng" algn="ctr">
-                      <a:solidFill>
-                        <a:srgbClr val="DADCE0"/>
-                      </a:solidFill>
-                      <a:prstDash val="solid"/>
-                      <a:round/>
-                      <a:headEnd type="none" w="med" len="med"/>
-                      <a:tailEnd type="none" w="med" len="med"/>
-                    </a:lnB>
-                    <a:solidFill>
-                      <a:srgbClr val="FFFFFF"/>
-                    </a:solidFill>
-                  </a:tcPr>
-                </a:tc>
-              </a:tr>
-              <a:tr h="310896">
-                <a:tc>
-                  <a:txBody>
-                    <a:bodyPr/>
-                    <a:lstStyle/>
-                    <a:p>
-                      <a:pPr indent="0" marL="0">
-                        <a:buNone/>
-                      </a:pPr>
-                      <a:r>
-                        <a:rPr lang="en-US" sz="850" dirty="0">
-                          <a:solidFill>
-                            <a:srgbClr val="333333"/>
-                          </a:solidFill>
-                        </a:rPr>
-                        <a:t>6</a:t>
-                      </a:r>
-                      <a:endParaRPr lang="en-US" sz="850" dirty="0"/>
-                    </a:p>
-                  </a:txBody>
-                  <a:tcPr marL="50800" marR="50800" marT="25400" marB="25400" anchor="mid">
-                    <a:lnL w="5715" cap="flat" cmpd="sng" algn="ctr">
-                      <a:solidFill>
-                        <a:srgbClr val="DADCE0"/>
-                      </a:solidFill>
-                      <a:prstDash val="solid"/>
-                      <a:round/>
-                      <a:headEnd type="none" w="med" len="med"/>
-                      <a:tailEnd type="none" w="med" len="med"/>
-                    </a:lnL>
-                    <a:lnR w="5715" cap="flat" cmpd="sng" algn="ctr">
-                      <a:solidFill>
-                        <a:srgbClr val="DADCE0"/>
-                      </a:solidFill>
-                      <a:prstDash val="solid"/>
-                      <a:round/>
-                      <a:headEnd type="none" w="med" len="med"/>
-                      <a:tailEnd type="none" w="med" len="med"/>
-                    </a:lnR>
-                    <a:lnT w="5715" cap="flat" cmpd="sng" algn="ctr">
-                      <a:solidFill>
-                        <a:srgbClr val="DADCE0"/>
-                      </a:solidFill>
-                      <a:prstDash val="solid"/>
-                      <a:round/>
-                      <a:headEnd type="none" w="med" len="med"/>
-                      <a:tailEnd type="none" w="med" len="med"/>
-                    </a:lnT>
-                    <a:lnB w="5715" cap="flat" cmpd="sng" algn="ctr">
-                      <a:solidFill>
-                        <a:srgbClr val="DADCE0"/>
-                      </a:solidFill>
-                      <a:prstDash val="solid"/>
-                      <a:round/>
-                      <a:headEnd type="none" w="med" len="med"/>
-                      <a:tailEnd type="none" w="med" len="med"/>
-                    </a:lnB>
-                    <a:solidFill>
-                      <a:srgbClr val="F6F7F9"/>
-                    </a:solidFill>
-                  </a:tcPr>
-                </a:tc>
-                <a:tc>
-                  <a:txBody>
-                    <a:bodyPr/>
-                    <a:lstStyle/>
-                    <a:p>
-                      <a:pPr indent="0" marL="0">
-                        <a:buNone/>
-                      </a:pPr>
-                      <a:r>
-                        <a:rPr lang="en-US" sz="850" dirty="0">
-                          <a:solidFill>
-                            <a:srgbClr val="333333"/>
-                          </a:solidFill>
-                        </a:rPr>
-                        <a:t>output()</a:t>
-                      </a:r>
-                      <a:endParaRPr lang="en-US" sz="850" dirty="0"/>
-                    </a:p>
-                  </a:txBody>
-                  <a:tcPr marL="50800" marR="50800" marT="25400" marB="25400" anchor="mid">
-                    <a:lnL w="5715" cap="flat" cmpd="sng" algn="ctr">
-                      <a:solidFill>
-                        <a:srgbClr val="DADCE0"/>
-                      </a:solidFill>
-                      <a:prstDash val="solid"/>
-                      <a:round/>
-                      <a:headEnd type="none" w="med" len="med"/>
-                      <a:tailEnd type="none" w="med" len="med"/>
-                    </a:lnL>
-                    <a:lnR w="5715" cap="flat" cmpd="sng" algn="ctr">
-                      <a:solidFill>
-                        <a:srgbClr val="DADCE0"/>
-                      </a:solidFill>
-                      <a:prstDash val="solid"/>
-                      <a:round/>
-                      <a:headEnd type="none" w="med" len="med"/>
-                      <a:tailEnd type="none" w="med" len="med"/>
-                    </a:lnR>
-                    <a:lnT w="5715" cap="flat" cmpd="sng" algn="ctr">
-                      <a:solidFill>
-                        <a:srgbClr val="DADCE0"/>
-                      </a:solidFill>
-                      <a:prstDash val="solid"/>
-                      <a:round/>
-                      <a:headEnd type="none" w="med" len="med"/>
-                      <a:tailEnd type="none" w="med" len="med"/>
-                    </a:lnT>
-                    <a:lnB w="5715" cap="flat" cmpd="sng" algn="ctr">
-                      <a:solidFill>
-                        <a:srgbClr val="DADCE0"/>
-                      </a:solidFill>
-                      <a:prstDash val="solid"/>
-                      <a:round/>
-                      <a:headEnd type="none" w="med" len="med"/>
-                      <a:tailEnd type="none" w="med" len="med"/>
-                    </a:lnB>
-                    <a:solidFill>
-                      <a:srgbClr val="F6F7F9"/>
-                    </a:solidFill>
-                  </a:tcPr>
-                </a:tc>
-                <a:tc>
-                  <a:txBody>
-                    <a:bodyPr/>
-                    <a:lstStyle/>
-                    <a:p>
-                      <a:pPr indent="0" marL="0">
-                        <a:buNone/>
-                      </a:pPr>
-                      <a:r>
-                        <a:rPr lang="en-US" sz="850" dirty="0">
-                          <a:solidFill>
-                            <a:srgbClr val="333333"/>
-                          </a:solidFill>
-                        </a:rPr>
-                        <a:t>Evenement emis par l'enfant vers le parent.</a:t>
-                      </a:r>
-                      <a:endParaRPr lang="en-US" sz="850" dirty="0"/>
-                    </a:p>
-                  </a:txBody>
-                  <a:tcPr marL="50800" marR="50800" marT="25400" marB="25400" anchor="mid">
-                    <a:lnL w="5715" cap="flat" cmpd="sng" algn="ctr">
-                      <a:solidFill>
-                        <a:srgbClr val="DADCE0"/>
-                      </a:solidFill>
-                      <a:prstDash val="solid"/>
-                      <a:round/>
-                      <a:headEnd type="none" w="med" len="med"/>
-                      <a:tailEnd type="none" w="med" len="med"/>
-                    </a:lnL>
-                    <a:lnR w="5715" cap="flat" cmpd="sng" algn="ctr">
-                      <a:solidFill>
-                        <a:srgbClr val="DADCE0"/>
-                      </a:solidFill>
-                      <a:prstDash val="solid"/>
-                      <a:round/>
-                      <a:headEnd type="none" w="med" len="med"/>
-                      <a:tailEnd type="none" w="med" len="med"/>
-                    </a:lnR>
-                    <a:lnT w="5715" cap="flat" cmpd="sng" algn="ctr">
-                      <a:solidFill>
-                        <a:srgbClr val="DADCE0"/>
-                      </a:solidFill>
-                      <a:prstDash val="solid"/>
-                      <a:round/>
-                      <a:headEnd type="none" w="med" len="med"/>
-                      <a:tailEnd type="none" w="med" len="med"/>
-                    </a:lnT>
-                    <a:lnB w="5715" cap="flat" cmpd="sng" algn="ctr">
-                      <a:solidFill>
-                        <a:srgbClr val="DADCE0"/>
-                      </a:solidFill>
-                      <a:prstDash val="solid"/>
-                      <a:round/>
-                      <a:headEnd type="none" w="med" len="med"/>
-                      <a:tailEnd type="none" w="med" len="med"/>
-                    </a:lnB>
-                    <a:solidFill>
-                      <a:srgbClr val="F6F7F9"/>
-                    </a:solidFill>
-                  </a:tcPr>
-                </a:tc>
-                <a:tc>
-                  <a:txBody>
-                    <a:bodyPr/>
-                    <a:lstStyle/>
-                    <a:p>
-                      <a:pPr indent="0" marL="0">
-                        <a:buNone/>
-                      </a:pPr>
-                      <a:r>
-                        <a:rPr lang="en-US" sz="850" dirty="0">
-                          <a:solidFill>
-                            <a:srgbClr val="333333"/>
-                          </a:solidFill>
-                        </a:rPr>
-                        <a:t>L'intention de selection doit etre emise avec output().</a:t>
-                      </a:r>
-                      <a:endParaRPr lang="en-US" sz="850" dirty="0"/>
-                    </a:p>
-                  </a:txBody>
-                  <a:tcPr marL="50800" marR="50800" marT="25400" marB="25400" anchor="mid">
-                    <a:lnL w="5715" cap="flat" cmpd="sng" algn="ctr">
-                      <a:solidFill>
-                        <a:srgbClr val="DADCE0"/>
-                      </a:solidFill>
-                      <a:prstDash val="solid"/>
-                      <a:round/>
-                      <a:headEnd type="none" w="med" len="med"/>
-                      <a:tailEnd type="none" w="med" len="med"/>
-                    </a:lnL>
-                    <a:lnR w="5715" cap="flat" cmpd="sng" algn="ctr">
-                      <a:solidFill>
-                        <a:srgbClr val="DADCE0"/>
-                      </a:solidFill>
-                      <a:prstDash val="solid"/>
-                      <a:round/>
-                      <a:headEnd type="none" w="med" len="med"/>
-                      <a:tailEnd type="none" w="med" len="med"/>
-                    </a:lnR>
-                    <a:lnT w="5715" cap="flat" cmpd="sng" algn="ctr">
-                      <a:solidFill>
-                        <a:srgbClr val="DADCE0"/>
-                      </a:solidFill>
-                      <a:prstDash val="solid"/>
-                      <a:round/>
-                      <a:headEnd type="none" w="med" len="med"/>
-                      <a:tailEnd type="none" w="med" len="med"/>
-                    </a:lnT>
-                    <a:lnB w="5715" cap="flat" cmpd="sng" algn="ctr">
-                      <a:solidFill>
-                        <a:srgbClr val="DADCE0"/>
-                      </a:solidFill>
-                      <a:prstDash val="solid"/>
-                      <a:round/>
-                      <a:headEnd type="none" w="med" len="med"/>
-                      <a:tailEnd type="none" w="med" len="med"/>
-                    </a:lnB>
-                    <a:solidFill>
-                      <a:srgbClr val="F6F7F9"/>
-                    </a:solidFill>
-                  </a:tcPr>
-                </a:tc>
-              </a:tr>
-              <a:tr h="310896">
-                <a:tc>
-                  <a:txBody>
-                    <a:bodyPr/>
-                    <a:lstStyle/>
-                    <a:p>
-                      <a:pPr indent="0" marL="0">
-                        <a:buNone/>
-                      </a:pPr>
-                      <a:r>
-                        <a:rPr lang="en-US" sz="850" dirty="0">
-                          <a:solidFill>
-                            <a:srgbClr val="333333"/>
-                          </a:solidFill>
-                        </a:rPr>
-                        <a:t>7</a:t>
-                      </a:r>
-                      <a:endParaRPr lang="en-US" sz="850" dirty="0"/>
-                    </a:p>
-                  </a:txBody>
-                  <a:tcPr marL="50800" marR="50800" marT="25400" marB="25400" anchor="mid">
-                    <a:lnL w="5715" cap="flat" cmpd="sng" algn="ctr">
-                      <a:solidFill>
-                        <a:srgbClr val="DADCE0"/>
-                      </a:solidFill>
-                      <a:prstDash val="solid"/>
-                      <a:round/>
-                      <a:headEnd type="none" w="med" len="med"/>
-                      <a:tailEnd type="none" w="med" len="med"/>
-                    </a:lnL>
-                    <a:lnR w="5715" cap="flat" cmpd="sng" algn="ctr">
-                      <a:solidFill>
-                        <a:srgbClr val="DADCE0"/>
-                      </a:solidFill>
-                      <a:prstDash val="solid"/>
-                      <a:round/>
-                      <a:headEnd type="none" w="med" len="med"/>
-                      <a:tailEnd type="none" w="med" len="med"/>
-                    </a:lnR>
-                    <a:lnT w="5715" cap="flat" cmpd="sng" algn="ctr">
-                      <a:solidFill>
-                        <a:srgbClr val="DADCE0"/>
-                      </a:solidFill>
-                      <a:prstDash val="solid"/>
-                      <a:round/>
-                      <a:headEnd type="none" w="med" len="med"/>
-                      <a:tailEnd type="none" w="med" len="med"/>
-                    </a:lnT>
-                    <a:lnB w="5715" cap="flat" cmpd="sng" algn="ctr">
-                      <a:solidFill>
-                        <a:srgbClr val="DADCE0"/>
-                      </a:solidFill>
-                      <a:prstDash val="solid"/>
-                      <a:round/>
-                      <a:headEnd type="none" w="med" len="med"/>
-                      <a:tailEnd type="none" w="med" len="med"/>
-                    </a:lnB>
-                    <a:solidFill>
-                      <a:srgbClr val="FFFFFF"/>
-                    </a:solidFill>
-                  </a:tcPr>
-                </a:tc>
-                <a:tc>
-                  <a:txBody>
-                    <a:bodyPr/>
-                    <a:lstStyle/>
-                    <a:p>
-                      <a:pPr indent="0" marL="0">
-                        <a:buNone/>
-                      </a:pPr>
-                      <a:r>
-                        <a:rPr lang="en-US" sz="850" dirty="0">
-                          <a:solidFill>
-                            <a:srgbClr val="333333"/>
-                          </a:solidFill>
-                        </a:rPr>
-                        <a:t>toSignal() / toObservable()</a:t>
-                      </a:r>
-                      <a:endParaRPr lang="en-US" sz="850" dirty="0"/>
-                    </a:p>
-                  </a:txBody>
-                  <a:tcPr marL="50800" marR="50800" marT="25400" marB="25400" anchor="mid">
-                    <a:lnL w="5715" cap="flat" cmpd="sng" algn="ctr">
-                      <a:solidFill>
-                        <a:srgbClr val="DADCE0"/>
-                      </a:solidFill>
-                      <a:prstDash val="solid"/>
-                      <a:round/>
-                      <a:headEnd type="none" w="med" len="med"/>
-                      <a:tailEnd type="none" w="med" len="med"/>
-                    </a:lnL>
-                    <a:lnR w="5715" cap="flat" cmpd="sng" algn="ctr">
-                      <a:solidFill>
-                        <a:srgbClr val="DADCE0"/>
-                      </a:solidFill>
-                      <a:prstDash val="solid"/>
-                      <a:round/>
-                      <a:headEnd type="none" w="med" len="med"/>
-                      <a:tailEnd type="none" w="med" len="med"/>
-                    </a:lnR>
-                    <a:lnT w="5715" cap="flat" cmpd="sng" algn="ctr">
-                      <a:solidFill>
-                        <a:srgbClr val="DADCE0"/>
-                      </a:solidFill>
-                      <a:prstDash val="solid"/>
-                      <a:round/>
-                      <a:headEnd type="none" w="med" len="med"/>
-                      <a:tailEnd type="none" w="med" len="med"/>
-                    </a:lnT>
-                    <a:lnB w="5715" cap="flat" cmpd="sng" algn="ctr">
-                      <a:solidFill>
-                        <a:srgbClr val="DADCE0"/>
-                      </a:solidFill>
-                      <a:prstDash val="solid"/>
-                      <a:round/>
-                      <a:headEnd type="none" w="med" len="med"/>
-                      <a:tailEnd type="none" w="med" len="med"/>
-                    </a:lnB>
-                    <a:solidFill>
-                      <a:srgbClr val="FFFFFF"/>
-                    </a:solidFill>
-                  </a:tcPr>
-                </a:tc>
-                <a:tc>
-                  <a:txBody>
-                    <a:bodyPr/>
-                    <a:lstStyle/>
-                    <a:p>
-                      <a:pPr indent="0" marL="0">
-                        <a:buNone/>
-                      </a:pPr>
-                      <a:r>
-                        <a:rPr lang="en-US" sz="850" dirty="0">
-                          <a:solidFill>
-                            <a:srgbClr val="333333"/>
-                          </a:solidFill>
-                        </a:rPr>
-                        <a:t>Frontiere entre Observable RxJS et signal Angular.</a:t>
-                      </a:r>
-                      <a:endParaRPr lang="en-US" sz="850" dirty="0"/>
-                    </a:p>
-                  </a:txBody>
-                  <a:tcPr marL="50800" marR="50800" marT="25400" marB="25400" anchor="mid">
-                    <a:lnL w="5715" cap="flat" cmpd="sng" algn="ctr">
-                      <a:solidFill>
-                        <a:srgbClr val="DADCE0"/>
-                      </a:solidFill>
-                      <a:prstDash val="solid"/>
-                      <a:round/>
-                      <a:headEnd type="none" w="med" len="med"/>
-                      <a:tailEnd type="none" w="med" len="med"/>
-                    </a:lnL>
-                    <a:lnR w="5715" cap="flat" cmpd="sng" algn="ctr">
-                      <a:solidFill>
-                        <a:srgbClr val="DADCE0"/>
-                      </a:solidFill>
-                      <a:prstDash val="solid"/>
-                      <a:round/>
-                      <a:headEnd type="none" w="med" len="med"/>
-                      <a:tailEnd type="none" w="med" len="med"/>
-                    </a:lnR>
-                    <a:lnT w="5715" cap="flat" cmpd="sng" algn="ctr">
-                      <a:solidFill>
-                        <a:srgbClr val="DADCE0"/>
-                      </a:solidFill>
-                      <a:prstDash val="solid"/>
-                      <a:round/>
-                      <a:headEnd type="none" w="med" len="med"/>
-                      <a:tailEnd type="none" w="med" len="med"/>
-                    </a:lnT>
-                    <a:lnB w="5715" cap="flat" cmpd="sng" algn="ctr">
-                      <a:solidFill>
-                        <a:srgbClr val="DADCE0"/>
-                      </a:solidFill>
-                      <a:prstDash val="solid"/>
-                      <a:round/>
-                      <a:headEnd type="none" w="med" len="med"/>
-                      <a:tailEnd type="none" w="med" len="med"/>
-                    </a:lnB>
-                    <a:solidFill>
-                      <a:srgbClr val="FFFFFF"/>
-                    </a:solidFill>
-                  </a:tcPr>
-                </a:tc>
-                <a:tc>
-                  <a:txBody>
-                    <a:bodyPr/>
-                    <a:lstStyle/>
-                    <a:p>
-                      <a:pPr indent="0" marL="0">
-                        <a:buNone/>
-                      </a:pPr>
-                      <a:r>
-                        <a:rPr lang="en-US" sz="850" dirty="0">
-                          <a:solidFill>
-                            <a:srgbClr val="333333"/>
-                          </a:solidFill>
-                        </a:rPr>
-                        <a:t>Les flux route, chargement et recherche doivent etre connectes aux signals.</a:t>
-                      </a:r>
-                      <a:endParaRPr lang="en-US" sz="850" dirty="0"/>
-                    </a:p>
-                  </a:txBody>
-                  <a:tcPr marL="50800" marR="50800" marT="25400" marB="25400" anchor="mid">
-                    <a:lnL w="5715" cap="flat" cmpd="sng" algn="ctr">
-                      <a:solidFill>
-                        <a:srgbClr val="DADCE0"/>
-                      </a:solidFill>
-                      <a:prstDash val="solid"/>
-                      <a:round/>
-                      <a:headEnd type="none" w="med" len="med"/>
-                      <a:tailEnd type="none" w="med" len="med"/>
-                    </a:lnL>
-                    <a:lnR w="5715" cap="flat" cmpd="sng" algn="ctr">
-                      <a:solidFill>
-                        <a:srgbClr val="DADCE0"/>
-                      </a:solidFill>
-                      <a:prstDash val="solid"/>
-                      <a:round/>
-                      <a:headEnd type="none" w="med" len="med"/>
-                      <a:tailEnd type="none" w="med" len="med"/>
-                    </a:lnR>
-                    <a:lnT w="5715" cap="flat" cmpd="sng" algn="ctr">
-                      <a:solidFill>
-                        <a:srgbClr val="DADCE0"/>
-                      </a:solidFill>
-                      <a:prstDash val="solid"/>
-                      <a:round/>
-                      <a:headEnd type="none" w="med" len="med"/>
-                      <a:tailEnd type="none" w="med" len="med"/>
-                    </a:lnT>
-                    <a:lnB w="5715" cap="flat" cmpd="sng" algn="ctr">
-                      <a:solidFill>
-                        <a:srgbClr val="DADCE0"/>
-                      </a:solidFill>
-                      <a:prstDash val="solid"/>
-                      <a:round/>
-                      <a:headEnd type="none" w="med" len="med"/>
-                      <a:tailEnd type="none" w="med" len="med"/>
-                    </a:lnB>
-                    <a:solidFill>
-                      <a:srgbClr val="FFFFFF"/>
-                    </a:solidFill>
-                  </a:tcPr>
-                </a:tc>
-              </a:tr>
-              <a:tr h="310896">
-                <a:tc>
-                  <a:txBody>
-                    <a:bodyPr/>
-                    <a:lstStyle/>
-                    <a:p>
-                      <a:pPr indent="0" marL="0">
-                        <a:buNone/>
-                      </a:pPr>
-                      <a:r>
-                        <a:rPr lang="en-US" sz="850" dirty="0">
-                          <a:solidFill>
-                            <a:srgbClr val="333333"/>
-                          </a:solidFill>
-                        </a:rPr>
-                        <a:t>8</a:t>
-                      </a:r>
-                      <a:endParaRPr lang="en-US" sz="850" dirty="0"/>
-                    </a:p>
-                  </a:txBody>
-                  <a:tcPr marL="50800" marR="50800" marT="25400" marB="25400" anchor="mid">
-                    <a:lnL w="5715" cap="flat" cmpd="sng" algn="ctr">
-                      <a:solidFill>
-                        <a:srgbClr val="DADCE0"/>
-                      </a:solidFill>
-                      <a:prstDash val="solid"/>
-                      <a:round/>
-                      <a:headEnd type="none" w="med" len="med"/>
-                      <a:tailEnd type="none" w="med" len="med"/>
-                    </a:lnL>
-                    <a:lnR w="5715" cap="flat" cmpd="sng" algn="ctr">
-                      <a:solidFill>
-                        <a:srgbClr val="DADCE0"/>
-                      </a:solidFill>
-                      <a:prstDash val="solid"/>
-                      <a:round/>
-                      <a:headEnd type="none" w="med" len="med"/>
-                      <a:tailEnd type="none" w="med" len="med"/>
-                    </a:lnR>
-                    <a:lnT w="5715" cap="flat" cmpd="sng" algn="ctr">
-                      <a:solidFill>
-                        <a:srgbClr val="DADCE0"/>
-                      </a:solidFill>
-                      <a:prstDash val="solid"/>
-                      <a:round/>
-                      <a:headEnd type="none" w="med" len="med"/>
-                      <a:tailEnd type="none" w="med" len="med"/>
-                    </a:lnT>
-                    <a:lnB w="5715" cap="flat" cmpd="sng" algn="ctr">
-                      <a:solidFill>
-                        <a:srgbClr val="DADCE0"/>
-                      </a:solidFill>
-                      <a:prstDash val="solid"/>
-                      <a:round/>
-                      <a:headEnd type="none" w="med" len="med"/>
-                      <a:tailEnd type="none" w="med" len="med"/>
-                    </a:lnB>
-                    <a:solidFill>
-                      <a:srgbClr val="F6F7F9"/>
-                    </a:solidFill>
-                  </a:tcPr>
-                </a:tc>
-                <a:tc>
-                  <a:txBody>
-                    <a:bodyPr/>
-                    <a:lstStyle/>
-                    <a:p>
-                      <a:pPr indent="0" marL="0">
-                        <a:buNone/>
-                      </a:pPr>
-                      <a:r>
-                        <a:rPr lang="en-US" sz="850" dirty="0">
-                          <a:solidFill>
-                            <a:srgbClr val="333333"/>
-                          </a:solidFill>
-                        </a:rPr>
-                        <a:t>computed() facade</a:t>
-                      </a:r>
-                      <a:endParaRPr lang="en-US" sz="850" dirty="0"/>
-                    </a:p>
-                  </a:txBody>
-                  <a:tcPr marL="50800" marR="50800" marT="25400" marB="25400" anchor="mid">
-                    <a:lnL w="5715" cap="flat" cmpd="sng" algn="ctr">
-                      <a:solidFill>
-                        <a:srgbClr val="DADCE0"/>
-                      </a:solidFill>
-                      <a:prstDash val="solid"/>
-                      <a:round/>
-                      <a:headEnd type="none" w="med" len="med"/>
-                      <a:tailEnd type="none" w="med" len="med"/>
-                    </a:lnL>
-                    <a:lnR w="5715" cap="flat" cmpd="sng" algn="ctr">
-                      <a:solidFill>
-                        <a:srgbClr val="DADCE0"/>
-                      </a:solidFill>
-                      <a:prstDash val="solid"/>
-                      <a:round/>
-                      <a:headEnd type="none" w="med" len="med"/>
-                      <a:tailEnd type="none" w="med" len="med"/>
-                    </a:lnR>
-                    <a:lnT w="5715" cap="flat" cmpd="sng" algn="ctr">
-                      <a:solidFill>
-                        <a:srgbClr val="DADCE0"/>
-                      </a:solidFill>
-                      <a:prstDash val="solid"/>
-                      <a:round/>
-                      <a:headEnd type="none" w="med" len="med"/>
-                      <a:tailEnd type="none" w="med" len="med"/>
-                    </a:lnT>
-                    <a:lnB w="5715" cap="flat" cmpd="sng" algn="ctr">
-                      <a:solidFill>
-                        <a:srgbClr val="DADCE0"/>
-                      </a:solidFill>
-                      <a:prstDash val="solid"/>
-                      <a:round/>
-                      <a:headEnd type="none" w="med" len="med"/>
-                      <a:tailEnd type="none" w="med" len="med"/>
-                    </a:lnB>
-                    <a:solidFill>
-                      <a:srgbClr val="F6F7F9"/>
-                    </a:solidFill>
-                  </a:tcPr>
-                </a:tc>
-                <a:tc>
-                  <a:txBody>
-                    <a:bodyPr/>
-                    <a:lstStyle/>
-                    <a:p>
-                      <a:pPr indent="0" marL="0">
-                        <a:buNone/>
-                      </a:pPr>
-                      <a:r>
-                        <a:rPr lang="en-US" sz="850" dirty="0">
-                          <a:solidFill>
-                            <a:srgbClr val="333333"/>
-                          </a:solidFill>
-                        </a:rPr>
-                        <a:t>Vue derivee de l'etat metier dans une facade.</a:t>
-                      </a:r>
-                      <a:endParaRPr lang="en-US" sz="850" dirty="0"/>
-                    </a:p>
-                  </a:txBody>
-                  <a:tcPr marL="50800" marR="50800" marT="25400" marB="25400" anchor="mid">
-                    <a:lnL w="5715" cap="flat" cmpd="sng" algn="ctr">
-                      <a:solidFill>
-                        <a:srgbClr val="DADCE0"/>
-                      </a:solidFill>
-                      <a:prstDash val="solid"/>
-                      <a:round/>
-                      <a:headEnd type="none" w="med" len="med"/>
-                      <a:tailEnd type="none" w="med" len="med"/>
-                    </a:lnL>
-                    <a:lnR w="5715" cap="flat" cmpd="sng" algn="ctr">
-                      <a:solidFill>
-                        <a:srgbClr val="DADCE0"/>
-                      </a:solidFill>
-                      <a:prstDash val="solid"/>
-                      <a:round/>
-                      <a:headEnd type="none" w="med" len="med"/>
-                      <a:tailEnd type="none" w="med" len="med"/>
-                    </a:lnR>
-                    <a:lnT w="5715" cap="flat" cmpd="sng" algn="ctr">
-                      <a:solidFill>
-                        <a:srgbClr val="DADCE0"/>
-                      </a:solidFill>
-                      <a:prstDash val="solid"/>
-                      <a:round/>
-                      <a:headEnd type="none" w="med" len="med"/>
-                      <a:tailEnd type="none" w="med" len="med"/>
-                    </a:lnT>
-                    <a:lnB w="5715" cap="flat" cmpd="sng" algn="ctr">
-                      <a:solidFill>
-                        <a:srgbClr val="DADCE0"/>
-                      </a:solidFill>
-                      <a:prstDash val="solid"/>
-                      <a:round/>
-                      <a:headEnd type="none" w="med" len="med"/>
-                      <a:tailEnd type="none" w="med" len="med"/>
-                    </a:lnB>
-                    <a:solidFill>
-                      <a:srgbClr val="F6F7F9"/>
-                    </a:solidFill>
-                  </a:tcPr>
-                </a:tc>
-                <a:tc>
-                  <a:txBody>
-                    <a:bodyPr/>
-                    <a:lstStyle/>
-                    <a:p>
-                      <a:pPr indent="0" marL="0">
-                        <a:buNone/>
-                      </a:pPr>
-                      <a:r>
-                        <a:rPr lang="en-US" sz="850" dirty="0">
-                          <a:solidFill>
-                            <a:srgbClr val="333333"/>
-                          </a:solidFill>
-                        </a:rPr>
-                        <a:t>La logique active filter doit etre exposee par un computed() de facade.</a:t>
-                      </a:r>
-                      <a:endParaRPr lang="en-US" sz="850" dirty="0"/>
+                      <a:endParaRPr lang="en-US" sz="740" dirty="0"/>
                     </a:p>
                   </a:txBody>
                   <a:tcPr marL="50800" marR="50800" marT="25400" marB="25400" anchor="mid">

</xml_diff>

<commit_message>
reference fichiers dans consignes pptx
</commit_message>
<xml_diff>
--- a/docs/dojo-signals.pptx
+++ b/docs/dojo-signals.pptx
@@ -3178,9 +3178,10 @@
             <a:tbl>
               <a:tblPr/>
               <a:tblGrid>
-                <a:gridCol w="1417320"/>
-                <a:gridCol w="2834640"/>
-                <a:gridCol w="7116775"/>
+                <a:gridCol w="685800"/>
+                <a:gridCol w="2240280"/>
+                <a:gridCol w="2606040"/>
+                <a:gridCol w="5836615"/>
               </a:tblGrid>
               <a:tr h="530352">
                 <a:tc>
@@ -3192,14 +3193,14 @@
                         <a:buNone/>
                       </a:pPr>
                       <a:r>
-                        <a:rPr lang="en-US" sz="740" b="1" dirty="0">
+                        <a:rPr lang="en-US" sz="780" b="1" dirty="0">
                           <a:solidFill>
                             <a:srgbClr val="FFFFFF"/>
                           </a:solidFill>
                         </a:rPr>
                         <a:t>Ex.</a:t>
                       </a:r>
-                      <a:endParaRPr lang="en-US" sz="740" dirty="0"/>
+                      <a:endParaRPr lang="en-US" sz="780" dirty="0"/>
                     </a:p>
                   </a:txBody>
                   <a:tcPr marL="50800" marR="50800" marT="25400" marB="25400" anchor="mid">
@@ -3253,14 +3254,14 @@
                         <a:buNone/>
                       </a:pPr>
                       <a:r>
-                        <a:rPr lang="en-US" sz="740" b="1" dirty="0">
+                        <a:rPr lang="en-US" sz="780" b="1" dirty="0">
                           <a:solidFill>
                             <a:srgbClr val="FFFFFF"/>
                           </a:solidFill>
                         </a:rPr>
-                        <a:t>Definition courte</a:t>
+                        <a:t>Fichier(s)</a:t>
                       </a:r>
-                      <a:endParaRPr lang="en-US" sz="740" dirty="0"/>
+                      <a:endParaRPr lang="en-US" sz="780" dirty="0"/>
                     </a:p>
                   </a:txBody>
                   <a:tcPr marL="50800" marR="50800" marT="25400" marB="25400" anchor="mid">
@@ -3314,14 +3315,75 @@
                         <a:buNone/>
                       </a:pPr>
                       <a:r>
-                        <a:rPr lang="en-US" sz="740" b="1" dirty="0">
+                        <a:rPr lang="en-US" sz="780" b="1" dirty="0">
+                          <a:solidFill>
+                            <a:srgbClr val="FFFFFF"/>
+                          </a:solidFill>
+                        </a:rPr>
+                        <a:t>Definition courte</a:t>
+                      </a:r>
+                      <a:endParaRPr lang="en-US" sz="780" dirty="0"/>
+                    </a:p>
+                  </a:txBody>
+                  <a:tcPr marL="50800" marR="50800" marT="25400" marB="25400" anchor="mid">
+                    <a:lnL w="5715" cap="flat" cmpd="sng" algn="ctr">
+                      <a:solidFill>
+                        <a:srgbClr val="DADCE0"/>
+                      </a:solidFill>
+                      <a:prstDash val="solid"/>
+                      <a:round/>
+                      <a:headEnd type="none" w="med" len="med"/>
+                      <a:tailEnd type="none" w="med" len="med"/>
+                    </a:lnL>
+                    <a:lnR w="5715" cap="flat" cmpd="sng" algn="ctr">
+                      <a:solidFill>
+                        <a:srgbClr val="DADCE0"/>
+                      </a:solidFill>
+                      <a:prstDash val="solid"/>
+                      <a:round/>
+                      <a:headEnd type="none" w="med" len="med"/>
+                      <a:tailEnd type="none" w="med" len="med"/>
+                    </a:lnR>
+                    <a:lnT w="5715" cap="flat" cmpd="sng" algn="ctr">
+                      <a:solidFill>
+                        <a:srgbClr val="DADCE0"/>
+                      </a:solidFill>
+                      <a:prstDash val="solid"/>
+                      <a:round/>
+                      <a:headEnd type="none" w="med" len="med"/>
+                      <a:tailEnd type="none" w="med" len="med"/>
+                    </a:lnT>
+                    <a:lnB w="5715" cap="flat" cmpd="sng" algn="ctr">
+                      <a:solidFill>
+                        <a:srgbClr val="DADCE0"/>
+                      </a:solidFill>
+                      <a:prstDash val="solid"/>
+                      <a:round/>
+                      <a:headEnd type="none" w="med" len="med"/>
+                      <a:tailEnd type="none" w="med" len="med"/>
+                    </a:lnB>
+                    <a:solidFill>
+                      <a:srgbClr val="DD0031"/>
+                    </a:solidFill>
+                  </a:tcPr>
+                </a:tc>
+                <a:tc>
+                  <a:txBody>
+                    <a:bodyPr/>
+                    <a:lstStyle/>
+                    <a:p>
+                      <a:pPr indent="0" marL="0">
+                        <a:buNone/>
+                      </a:pPr>
+                      <a:r>
+                        <a:rPr lang="en-US" sz="780" b="1" dirty="0">
                           <a:solidFill>
                             <a:srgbClr val="FFFFFF"/>
                           </a:solidFill>
                         </a:rPr>
                         <a:t>Consigne claire</a:t>
                       </a:r>
-                      <a:endParaRPr lang="en-US" sz="740" dirty="0"/>
+                      <a:endParaRPr lang="en-US" sz="780" dirty="0"/>
                     </a:p>
                   </a:txBody>
                   <a:tcPr marL="50800" marR="50800" marT="25400" marB="25400" anchor="mid">
@@ -3377,14 +3439,14 @@
                         <a:buNone/>
                       </a:pPr>
                       <a:r>
-                        <a:rPr lang="en-US" sz="740" dirty="0">
+                        <a:rPr lang="en-US" sz="780" dirty="0">
                           <a:solidFill>
                             <a:srgbClr val="333333"/>
                           </a:solidFill>
                         </a:rPr>
                         <a:t>1 — signal()</a:t>
                       </a:r>
-                      <a:endParaRPr lang="en-US" sz="740" dirty="0"/>
+                      <a:endParaRPr lang="en-US" sz="780" dirty="0"/>
                     </a:p>
                   </a:txBody>
                   <a:tcPr marL="50800" marR="50800" marT="25400" marB="25400" anchor="mid">
@@ -3438,14 +3500,14 @@
                         <a:buNone/>
                       </a:pPr>
                       <a:r>
-                        <a:rPr lang="en-US" sz="740" dirty="0">
+                        <a:rPr lang="en-US" sz="780" dirty="0">
                           <a:solidFill>
                             <a:srgbClr val="333333"/>
                           </a:solidFill>
                         </a:rPr>
-                        <a:t>Valeur reactive mutable lue avec ().</a:t>
+                        <a:t>clients/pages/clients/clients.component.ts</a:t>
                       </a:r>
-                      <a:endParaRPr lang="en-US" sz="740" dirty="0"/>
+                      <a:endParaRPr lang="en-US" sz="780" dirty="0"/>
                     </a:p>
                   </a:txBody>
                   <a:tcPr marL="50800" marR="50800" marT="25400" marB="25400" anchor="mid">
@@ -3499,14 +3561,75 @@
                         <a:buNone/>
                       </a:pPr>
                       <a:r>
-                        <a:rPr lang="en-US" sz="740" dirty="0">
+                        <a:rPr lang="en-US" sz="780" dirty="0">
                           <a:solidFill>
                             <a:srgbClr val="333333"/>
                           </a:solidFill>
                         </a:rPr>
-                        <a:t>Dans la page clients, l'ouverture du formulaire d'ajout ne doit plus etre un booleen classique : elle doit etre portee par un signal et rester lisible depuis le template et les tests.</a:t>
+                        <a:t>Valeur reactive mutable lue avec ().</a:t>
                       </a:r>
-                      <a:endParaRPr lang="en-US" sz="740" dirty="0"/>
+                      <a:endParaRPr lang="en-US" sz="780" dirty="0"/>
+                    </a:p>
+                  </a:txBody>
+                  <a:tcPr marL="50800" marR="50800" marT="25400" marB="25400" anchor="mid">
+                    <a:lnL w="5715" cap="flat" cmpd="sng" algn="ctr">
+                      <a:solidFill>
+                        <a:srgbClr val="DADCE0"/>
+                      </a:solidFill>
+                      <a:prstDash val="solid"/>
+                      <a:round/>
+                      <a:headEnd type="none" w="med" len="med"/>
+                      <a:tailEnd type="none" w="med" len="med"/>
+                    </a:lnL>
+                    <a:lnR w="5715" cap="flat" cmpd="sng" algn="ctr">
+                      <a:solidFill>
+                        <a:srgbClr val="DADCE0"/>
+                      </a:solidFill>
+                      <a:prstDash val="solid"/>
+                      <a:round/>
+                      <a:headEnd type="none" w="med" len="med"/>
+                      <a:tailEnd type="none" w="med" len="med"/>
+                    </a:lnR>
+                    <a:lnT w="5715" cap="flat" cmpd="sng" algn="ctr">
+                      <a:solidFill>
+                        <a:srgbClr val="DADCE0"/>
+                      </a:solidFill>
+                      <a:prstDash val="solid"/>
+                      <a:round/>
+                      <a:headEnd type="none" w="med" len="med"/>
+                      <a:tailEnd type="none" w="med" len="med"/>
+                    </a:lnT>
+                    <a:lnB w="5715" cap="flat" cmpd="sng" algn="ctr">
+                      <a:solidFill>
+                        <a:srgbClr val="DADCE0"/>
+                      </a:solidFill>
+                      <a:prstDash val="solid"/>
+                      <a:round/>
+                      <a:headEnd type="none" w="med" len="med"/>
+                      <a:tailEnd type="none" w="med" len="med"/>
+                    </a:lnB>
+                    <a:solidFill>
+                      <a:srgbClr val="FFFFFF"/>
+                    </a:solidFill>
+                  </a:tcPr>
+                </a:tc>
+                <a:tc>
+                  <a:txBody>
+                    <a:bodyPr/>
+                    <a:lstStyle/>
+                    <a:p>
+                      <a:pPr indent="0" marL="0">
+                        <a:buNone/>
+                      </a:pPr>
+                      <a:r>
+                        <a:rPr lang="en-US" sz="780" dirty="0">
+                          <a:solidFill>
+                            <a:srgbClr val="333333"/>
+                          </a:solidFill>
+                        </a:rPr>
+                        <a:t>Remplacer l'etat d'ouverture du formulaire d'ajout par un signal. Le template et les tests doivent lire cet etat avec la syntaxe signal.</a:t>
+                      </a:r>
+                      <a:endParaRPr lang="en-US" sz="780" dirty="0"/>
                     </a:p>
                   </a:txBody>
                   <a:tcPr marL="50800" marR="50800" marT="25400" marB="25400" anchor="mid">
@@ -3562,14 +3685,14 @@
                         <a:buNone/>
                       </a:pPr>
                       <a:r>
-                        <a:rPr lang="en-US" sz="740" dirty="0">
+                        <a:rPr lang="en-US" sz="780" dirty="0">
                           <a:solidFill>
                             <a:srgbClr val="333333"/>
                           </a:solidFill>
                         </a:rPr>
                         <a:t>2 — computed()</a:t>
                       </a:r>
-                      <a:endParaRPr lang="en-US" sz="740" dirty="0"/>
+                      <a:endParaRPr lang="en-US" sz="780" dirty="0"/>
                     </a:p>
                   </a:txBody>
                   <a:tcPr marL="50800" marR="50800" marT="25400" marB="25400" anchor="mid">
@@ -3623,14 +3746,14 @@
                         <a:buNone/>
                       </a:pPr>
                       <a:r>
-                        <a:rPr lang="en-US" sz="740" dirty="0">
+                        <a:rPr lang="en-US" sz="780" dirty="0">
                           <a:solidFill>
                             <a:srgbClr val="333333"/>
                           </a:solidFill>
                         </a:rPr>
-                        <a:t>Valeur derivee en lecture seule.</a:t>
+                        <a:t>accounts.facade.ts, accounts.component.*</a:t>
                       </a:r>
-                      <a:endParaRPr lang="en-US" sz="740" dirty="0"/>
+                      <a:endParaRPr lang="en-US" sz="780" dirty="0"/>
                     </a:p>
                   </a:txBody>
                   <a:tcPr marL="50800" marR="50800" marT="25400" marB="25400" anchor="mid">
@@ -3684,14 +3807,75 @@
                         <a:buNone/>
                       </a:pPr>
                       <a:r>
-                        <a:rPr lang="en-US" sz="740" dirty="0">
+                        <a:rPr lang="en-US" sz="780" dirty="0">
                           <a:solidFill>
                             <a:srgbClr val="333333"/>
                           </a:solidFill>
                         </a:rPr>
-                        <a:t>Dans la facade accounts, les calculs derives doivent devenir des computed() afin que le composant consomme directement des valeurs reactives pretes a afficher.</a:t>
+                        <a:t>Valeur derivee en lecture seule.</a:t>
                       </a:r>
-                      <a:endParaRPr lang="en-US" sz="740" dirty="0"/>
+                      <a:endParaRPr lang="en-US" sz="780" dirty="0"/>
+                    </a:p>
+                  </a:txBody>
+                  <a:tcPr marL="50800" marR="50800" marT="25400" marB="25400" anchor="mid">
+                    <a:lnL w="5715" cap="flat" cmpd="sng" algn="ctr">
+                      <a:solidFill>
+                        <a:srgbClr val="DADCE0"/>
+                      </a:solidFill>
+                      <a:prstDash val="solid"/>
+                      <a:round/>
+                      <a:headEnd type="none" w="med" len="med"/>
+                      <a:tailEnd type="none" w="med" len="med"/>
+                    </a:lnL>
+                    <a:lnR w="5715" cap="flat" cmpd="sng" algn="ctr">
+                      <a:solidFill>
+                        <a:srgbClr val="DADCE0"/>
+                      </a:solidFill>
+                      <a:prstDash val="solid"/>
+                      <a:round/>
+                      <a:headEnd type="none" w="med" len="med"/>
+                      <a:tailEnd type="none" w="med" len="med"/>
+                    </a:lnR>
+                    <a:lnT w="5715" cap="flat" cmpd="sng" algn="ctr">
+                      <a:solidFill>
+                        <a:srgbClr val="DADCE0"/>
+                      </a:solidFill>
+                      <a:prstDash val="solid"/>
+                      <a:round/>
+                      <a:headEnd type="none" w="med" len="med"/>
+                      <a:tailEnd type="none" w="med" len="med"/>
+                    </a:lnT>
+                    <a:lnB w="5715" cap="flat" cmpd="sng" algn="ctr">
+                      <a:solidFill>
+                        <a:srgbClr val="DADCE0"/>
+                      </a:solidFill>
+                      <a:prstDash val="solid"/>
+                      <a:round/>
+                      <a:headEnd type="none" w="med" len="med"/>
+                      <a:tailEnd type="none" w="med" len="med"/>
+                    </a:lnB>
+                    <a:solidFill>
+                      <a:srgbClr val="F6F7F9"/>
+                    </a:solidFill>
+                  </a:tcPr>
+                </a:tc>
+                <a:tc>
+                  <a:txBody>
+                    <a:bodyPr/>
+                    <a:lstStyle/>
+                    <a:p>
+                      <a:pPr indent="0" marL="0">
+                        <a:buNone/>
+                      </a:pPr>
+                      <a:r>
+                        <a:rPr lang="en-US" sz="780" dirty="0">
+                          <a:solidFill>
+                            <a:srgbClr val="333333"/>
+                          </a:solidFill>
+                        </a:rPr>
+                        <a:t>Deplacer les calculs d'affichage de la page accounts dans des computed() de facade. Le composant doit consommer ces valeurs deja derivees.</a:t>
+                      </a:r>
+                      <a:endParaRPr lang="en-US" sz="780" dirty="0"/>
                     </a:p>
                   </a:txBody>
                   <a:tcPr marL="50800" marR="50800" marT="25400" marB="25400" anchor="mid">
@@ -3747,14 +3931,14 @@
                         <a:buNone/>
                       </a:pPr>
                       <a:r>
-                        <a:rPr lang="en-US" sz="740" dirty="0">
+                        <a:rPr lang="en-US" sz="780" dirty="0">
                           <a:solidFill>
                             <a:srgbClr val="333333"/>
                           </a:solidFill>
                         </a:rPr>
                         <a:t>3 — effect()</a:t>
                       </a:r>
-                      <a:endParaRPr lang="en-US" sz="740" dirty="0"/>
+                      <a:endParaRPr lang="en-US" sz="780" dirty="0"/>
                     </a:p>
                   </a:txBody>
                   <a:tcPr marL="50800" marR="50800" marT="25400" marB="25400" anchor="mid">
@@ -3808,14 +3992,14 @@
                         <a:buNone/>
                       </a:pPr>
                       <a:r>
-                        <a:rPr lang="en-US" sz="740" dirty="0">
+                        <a:rPr lang="en-US" sz="780" dirty="0">
                           <a:solidFill>
                             <a:srgbClr val="333333"/>
                           </a:solidFill>
                         </a:rPr>
-                        <a:t>Effet de bord declenche par les signals lus.</a:t>
+                        <a:t>clients/pages/clients/clients.component.ts</a:t>
                       </a:r>
-                      <a:endParaRPr lang="en-US" sz="740" dirty="0"/>
+                      <a:endParaRPr lang="en-US" sz="780" dirty="0"/>
                     </a:p>
                   </a:txBody>
                   <a:tcPr marL="50800" marR="50800" marT="25400" marB="25400" anchor="mid">
@@ -3869,14 +4053,75 @@
                         <a:buNone/>
                       </a:pPr>
                       <a:r>
-                        <a:rPr lang="en-US" sz="740" dirty="0">
+                        <a:rPr lang="en-US" sz="780" dirty="0">
                           <a:solidFill>
                             <a:srgbClr val="333333"/>
                           </a:solidFill>
                         </a:rPr>
-                        <a:t>Dans la page clients, l'etat UI doit rester coherent automatiquement quand les donnees ou les filtres changent, sans dupliquer cette logique dans le template.</a:t>
+                        <a:t>Effet de bord declenche par les signals lus.</a:t>
                       </a:r>
-                      <a:endParaRPr lang="en-US" sz="740" dirty="0"/>
+                      <a:endParaRPr lang="en-US" sz="780" dirty="0"/>
+                    </a:p>
+                  </a:txBody>
+                  <a:tcPr marL="50800" marR="50800" marT="25400" marB="25400" anchor="mid">
+                    <a:lnL w="5715" cap="flat" cmpd="sng" algn="ctr">
+                      <a:solidFill>
+                        <a:srgbClr val="DADCE0"/>
+                      </a:solidFill>
+                      <a:prstDash val="solid"/>
+                      <a:round/>
+                      <a:headEnd type="none" w="med" len="med"/>
+                      <a:tailEnd type="none" w="med" len="med"/>
+                    </a:lnL>
+                    <a:lnR w="5715" cap="flat" cmpd="sng" algn="ctr">
+                      <a:solidFill>
+                        <a:srgbClr val="DADCE0"/>
+                      </a:solidFill>
+                      <a:prstDash val="solid"/>
+                      <a:round/>
+                      <a:headEnd type="none" w="med" len="med"/>
+                      <a:tailEnd type="none" w="med" len="med"/>
+                    </a:lnR>
+                    <a:lnT w="5715" cap="flat" cmpd="sng" algn="ctr">
+                      <a:solidFill>
+                        <a:srgbClr val="DADCE0"/>
+                      </a:solidFill>
+                      <a:prstDash val="solid"/>
+                      <a:round/>
+                      <a:headEnd type="none" w="med" len="med"/>
+                      <a:tailEnd type="none" w="med" len="med"/>
+                    </a:lnT>
+                    <a:lnB w="5715" cap="flat" cmpd="sng" algn="ctr">
+                      <a:solidFill>
+                        <a:srgbClr val="DADCE0"/>
+                      </a:solidFill>
+                      <a:prstDash val="solid"/>
+                      <a:round/>
+                      <a:headEnd type="none" w="med" len="med"/>
+                      <a:tailEnd type="none" w="med" len="med"/>
+                    </a:lnB>
+                    <a:solidFill>
+                      <a:srgbClr val="FFFFFF"/>
+                    </a:solidFill>
+                  </a:tcPr>
+                </a:tc>
+                <a:tc>
+                  <a:txBody>
+                    <a:bodyPr/>
+                    <a:lstStyle/>
+                    <a:p>
+                      <a:pPr indent="0" marL="0">
+                        <a:buNone/>
+                      </a:pPr>
+                      <a:r>
+                        <a:rPr lang="en-US" sz="780" dirty="0">
+                          <a:solidFill>
+                            <a:srgbClr val="333333"/>
+                          </a:solidFill>
+                        </a:rPr>
+                        <a:t>Ajouter une reaction automatique qui garde l'etat UI coherent quand les donnees clients ou les filtres changent.</a:t>
+                      </a:r>
+                      <a:endParaRPr lang="en-US" sz="780" dirty="0"/>
                     </a:p>
                   </a:txBody>
                   <a:tcPr marL="50800" marR="50800" marT="25400" marB="25400" anchor="mid">
@@ -3932,14 +4177,14 @@
                         <a:buNone/>
                       </a:pPr>
                       <a:r>
-                        <a:rPr lang="en-US" sz="740" dirty="0">
+                        <a:rPr lang="en-US" sz="780" dirty="0">
                           <a:solidFill>
                             <a:srgbClr val="333333"/>
                           </a:solidFill>
                         </a:rPr>
                         <a:t>4 — viewChild() + effect()</a:t>
                       </a:r>
-                      <a:endParaRPr lang="en-US" sz="740" dirty="0"/>
+                      <a:endParaRPr lang="en-US" sz="780" dirty="0"/>
                     </a:p>
                   </a:txBody>
                   <a:tcPr marL="50800" marR="50800" marT="25400" marB="25400" anchor="mid">
@@ -3993,14 +4238,14 @@
                         <a:buNone/>
                       </a:pPr>
                       <a:r>
-                        <a:rPr lang="en-US" sz="740" dirty="0">
+                        <a:rPr lang="en-US" sz="780" dirty="0">
                           <a:solidFill>
                             <a:srgbClr val="333333"/>
                           </a:solidFill>
                         </a:rPr>
-                        <a:t>Reference DOM exposee comme signal, puis effet DOM.</a:t>
+                        <a:t>clients/pages/clients/clients.component.ts</a:t>
                       </a:r>
-                      <a:endParaRPr lang="en-US" sz="740" dirty="0"/>
+                      <a:endParaRPr lang="en-US" sz="780" dirty="0"/>
                     </a:p>
                   </a:txBody>
                   <a:tcPr marL="50800" marR="50800" marT="25400" marB="25400" anchor="mid">
@@ -4054,14 +4299,75 @@
                         <a:buNone/>
                       </a:pPr>
                       <a:r>
-                        <a:rPr lang="en-US" sz="740" dirty="0">
+                        <a:rPr lang="en-US" sz="780" dirty="0">
                           <a:solidFill>
                             <a:srgbClr val="333333"/>
                           </a:solidFill>
                         </a:rPr>
-                        <a:t>Dans la page clients, le champ prenom doit recevoir le focus quand il devient disponible dans le DOM, avec une reference viewChild() signal et un effect() cree par les participants.</a:t>
+                        <a:t>Reference DOM exposee comme signal, puis effet DOM.</a:t>
                       </a:r>
-                      <a:endParaRPr lang="en-US" sz="740" dirty="0"/>
+                      <a:endParaRPr lang="en-US" sz="780" dirty="0"/>
+                    </a:p>
+                  </a:txBody>
+                  <a:tcPr marL="50800" marR="50800" marT="25400" marB="25400" anchor="mid">
+                    <a:lnL w="5715" cap="flat" cmpd="sng" algn="ctr">
+                      <a:solidFill>
+                        <a:srgbClr val="DADCE0"/>
+                      </a:solidFill>
+                      <a:prstDash val="solid"/>
+                      <a:round/>
+                      <a:headEnd type="none" w="med" len="med"/>
+                      <a:tailEnd type="none" w="med" len="med"/>
+                    </a:lnL>
+                    <a:lnR w="5715" cap="flat" cmpd="sng" algn="ctr">
+                      <a:solidFill>
+                        <a:srgbClr val="DADCE0"/>
+                      </a:solidFill>
+                      <a:prstDash val="solid"/>
+                      <a:round/>
+                      <a:headEnd type="none" w="med" len="med"/>
+                      <a:tailEnd type="none" w="med" len="med"/>
+                    </a:lnR>
+                    <a:lnT w="5715" cap="flat" cmpd="sng" algn="ctr">
+                      <a:solidFill>
+                        <a:srgbClr val="DADCE0"/>
+                      </a:solidFill>
+                      <a:prstDash val="solid"/>
+                      <a:round/>
+                      <a:headEnd type="none" w="med" len="med"/>
+                      <a:tailEnd type="none" w="med" len="med"/>
+                    </a:lnT>
+                    <a:lnB w="5715" cap="flat" cmpd="sng" algn="ctr">
+                      <a:solidFill>
+                        <a:srgbClr val="DADCE0"/>
+                      </a:solidFill>
+                      <a:prstDash val="solid"/>
+                      <a:round/>
+                      <a:headEnd type="none" w="med" len="med"/>
+                      <a:tailEnd type="none" w="med" len="med"/>
+                    </a:lnB>
+                    <a:solidFill>
+                      <a:srgbClr val="F6F7F9"/>
+                    </a:solidFill>
+                  </a:tcPr>
+                </a:tc>
+                <a:tc>
+                  <a:txBody>
+                    <a:bodyPr/>
+                    <a:lstStyle/>
+                    <a:p>
+                      <a:pPr indent="0" marL="0">
+                        <a:buNone/>
+                      </a:pPr>
+                      <a:r>
+                        <a:rPr lang="en-US" sz="780" dirty="0">
+                          <a:solidFill>
+                            <a:srgbClr val="333333"/>
+                          </a:solidFill>
+                        </a:rPr>
+                        <a:t>Convertir la reference du champ prenom en viewChild() signal, puis creer l'effect() qui place le focus quand le champ existe.</a:t>
+                      </a:r>
+                      <a:endParaRPr lang="en-US" sz="780" dirty="0"/>
                     </a:p>
                   </a:txBody>
                   <a:tcPr marL="50800" marR="50800" marT="25400" marB="25400" anchor="mid">
@@ -4117,14 +4423,14 @@
                         <a:buNone/>
                       </a:pPr>
                       <a:r>
-                        <a:rPr lang="en-US" sz="740" dirty="0">
+                        <a:rPr lang="en-US" sz="780" dirty="0">
                           <a:solidFill>
                             <a:srgbClr val="333333"/>
                           </a:solidFill>
                         </a:rPr>
                         <a:t>5 — input()</a:t>
                       </a:r>
-                      <a:endParaRPr lang="en-US" sz="740" dirty="0"/>
+                      <a:endParaRPr lang="en-US" sz="780" dirty="0"/>
                     </a:p>
                   </a:txBody>
                   <a:tcPr marL="50800" marR="50800" marT="25400" marB="25400" anchor="mid">
@@ -4178,14 +4484,14 @@
                         <a:buNone/>
                       </a:pPr>
                       <a:r>
-                        <a:rPr lang="en-US" sz="740" dirty="0">
+                        <a:rPr lang="en-US" sz="780" dirty="0">
                           <a:solidFill>
                             <a:srgbClr val="333333"/>
                           </a:solidFill>
                         </a:rPr>
-                        <a:t>Entree de composant exposee comme signal.</a:t>
+                        <a:t>account-card/account-card.component.ts</a:t>
                       </a:r>
-                      <a:endParaRPr lang="en-US" sz="740" dirty="0"/>
+                      <a:endParaRPr lang="en-US" sz="780" dirty="0"/>
                     </a:p>
                   </a:txBody>
                   <a:tcPr marL="50800" marR="50800" marT="25400" marB="25400" anchor="mid">
@@ -4239,14 +4545,75 @@
                         <a:buNone/>
                       </a:pPr>
                       <a:r>
-                        <a:rPr lang="en-US" sz="740" dirty="0">
+                        <a:rPr lang="en-US" sz="780" dirty="0">
                           <a:solidFill>
                             <a:srgbClr val="333333"/>
                           </a:solidFill>
                         </a:rPr>
-                        <a:t>Dans la carte compte, l'entree showStatus doit devenir une entree signal pour etre une vraie dependance reactive du calcul d'affichage.</a:t>
+                        <a:t>Entree de composant exposee comme signal.</a:t>
                       </a:r>
-                      <a:endParaRPr lang="en-US" sz="740" dirty="0"/>
+                      <a:endParaRPr lang="en-US" sz="780" dirty="0"/>
+                    </a:p>
+                  </a:txBody>
+                  <a:tcPr marL="50800" marR="50800" marT="25400" marB="25400" anchor="mid">
+                    <a:lnL w="5715" cap="flat" cmpd="sng" algn="ctr">
+                      <a:solidFill>
+                        <a:srgbClr val="DADCE0"/>
+                      </a:solidFill>
+                      <a:prstDash val="solid"/>
+                      <a:round/>
+                      <a:headEnd type="none" w="med" len="med"/>
+                      <a:tailEnd type="none" w="med" len="med"/>
+                    </a:lnL>
+                    <a:lnR w="5715" cap="flat" cmpd="sng" algn="ctr">
+                      <a:solidFill>
+                        <a:srgbClr val="DADCE0"/>
+                      </a:solidFill>
+                      <a:prstDash val="solid"/>
+                      <a:round/>
+                      <a:headEnd type="none" w="med" len="med"/>
+                      <a:tailEnd type="none" w="med" len="med"/>
+                    </a:lnR>
+                    <a:lnT w="5715" cap="flat" cmpd="sng" algn="ctr">
+                      <a:solidFill>
+                        <a:srgbClr val="DADCE0"/>
+                      </a:solidFill>
+                      <a:prstDash val="solid"/>
+                      <a:round/>
+                      <a:headEnd type="none" w="med" len="med"/>
+                      <a:tailEnd type="none" w="med" len="med"/>
+                    </a:lnT>
+                    <a:lnB w="5715" cap="flat" cmpd="sng" algn="ctr">
+                      <a:solidFill>
+                        <a:srgbClr val="DADCE0"/>
+                      </a:solidFill>
+                      <a:prstDash val="solid"/>
+                      <a:round/>
+                      <a:headEnd type="none" w="med" len="med"/>
+                      <a:tailEnd type="none" w="med" len="med"/>
+                    </a:lnB>
+                    <a:solidFill>
+                      <a:srgbClr val="FFFFFF"/>
+                    </a:solidFill>
+                  </a:tcPr>
+                </a:tc>
+                <a:tc>
+                  <a:txBody>
+                    <a:bodyPr/>
+                    <a:lstStyle/>
+                    <a:p>
+                      <a:pPr indent="0" marL="0">
+                        <a:buNone/>
+                      </a:pPr>
+                      <a:r>
+                        <a:rPr lang="en-US" sz="780" dirty="0">
+                          <a:solidFill>
+                            <a:srgbClr val="333333"/>
+                          </a:solidFill>
+                        </a:rPr>
+                        <a:t>Convertir l'entree showStatus en input(). Le calcul du statut visible doit reagir quand le parent change cette entree.</a:t>
+                      </a:r>
+                      <a:endParaRPr lang="en-US" sz="780" dirty="0"/>
                     </a:p>
                   </a:txBody>
                   <a:tcPr marL="50800" marR="50800" marT="25400" marB="25400" anchor="mid">
@@ -4302,14 +4669,14 @@
                         <a:buNone/>
                       </a:pPr>
                       <a:r>
-                        <a:rPr lang="en-US" sz="740" dirty="0">
+                        <a:rPr lang="en-US" sz="780" dirty="0">
                           <a:solidFill>
                             <a:srgbClr val="333333"/>
                           </a:solidFill>
                         </a:rPr>
                         <a:t>6 — output()</a:t>
                       </a:r>
-                      <a:endParaRPr lang="en-US" sz="740" dirty="0"/>
+                      <a:endParaRPr lang="en-US" sz="780" dirty="0"/>
                     </a:p>
                   </a:txBody>
                   <a:tcPr marL="50800" marR="50800" marT="25400" marB="25400" anchor="mid">
@@ -4363,14 +4730,14 @@
                         <a:buNone/>
                       </a:pPr>
                       <a:r>
-                        <a:rPr lang="en-US" sz="740" dirty="0">
+                        <a:rPr lang="en-US" sz="780" dirty="0">
                           <a:solidFill>
                             <a:srgbClr val="333333"/>
                           </a:solidFill>
                         </a:rPr>
-                        <a:t>Evenement emis par l'enfant vers le parent.</a:t>
+                        <a:t>account-list/account-list.component.ts</a:t>
                       </a:r>
-                      <a:endParaRPr lang="en-US" sz="740" dirty="0"/>
+                      <a:endParaRPr lang="en-US" sz="780" dirty="0"/>
                     </a:p>
                   </a:txBody>
                   <a:tcPr marL="50800" marR="50800" marT="25400" marB="25400" anchor="mid">
@@ -4424,14 +4791,75 @@
                         <a:buNone/>
                       </a:pPr>
                       <a:r>
-                        <a:rPr lang="en-US" sz="740" dirty="0">
+                        <a:rPr lang="en-US" sz="780" dirty="0">
                           <a:solidFill>
                             <a:srgbClr val="333333"/>
                           </a:solidFill>
                         </a:rPr>
-                        <a:t>Dans la liste des comptes, la selection d'un compte doit etre emise avec output() comme une intention vers le parent, en gardant le parent responsable de l'action.</a:t>
+                        <a:t>Evenement emis par l'enfant vers le parent.</a:t>
                       </a:r>
-                      <a:endParaRPr lang="en-US" sz="740" dirty="0"/>
+                      <a:endParaRPr lang="en-US" sz="780" dirty="0"/>
+                    </a:p>
+                  </a:txBody>
+                  <a:tcPr marL="50800" marR="50800" marT="25400" marB="25400" anchor="mid">
+                    <a:lnL w="5715" cap="flat" cmpd="sng" algn="ctr">
+                      <a:solidFill>
+                        <a:srgbClr val="DADCE0"/>
+                      </a:solidFill>
+                      <a:prstDash val="solid"/>
+                      <a:round/>
+                      <a:headEnd type="none" w="med" len="med"/>
+                      <a:tailEnd type="none" w="med" len="med"/>
+                    </a:lnL>
+                    <a:lnR w="5715" cap="flat" cmpd="sng" algn="ctr">
+                      <a:solidFill>
+                        <a:srgbClr val="DADCE0"/>
+                      </a:solidFill>
+                      <a:prstDash val="solid"/>
+                      <a:round/>
+                      <a:headEnd type="none" w="med" len="med"/>
+                      <a:tailEnd type="none" w="med" len="med"/>
+                    </a:lnR>
+                    <a:lnT w="5715" cap="flat" cmpd="sng" algn="ctr">
+                      <a:solidFill>
+                        <a:srgbClr val="DADCE0"/>
+                      </a:solidFill>
+                      <a:prstDash val="solid"/>
+                      <a:round/>
+                      <a:headEnd type="none" w="med" len="med"/>
+                      <a:tailEnd type="none" w="med" len="med"/>
+                    </a:lnT>
+                    <a:lnB w="5715" cap="flat" cmpd="sng" algn="ctr">
+                      <a:solidFill>
+                        <a:srgbClr val="DADCE0"/>
+                      </a:solidFill>
+                      <a:prstDash val="solid"/>
+                      <a:round/>
+                      <a:headEnd type="none" w="med" len="med"/>
+                      <a:tailEnd type="none" w="med" len="med"/>
+                    </a:lnB>
+                    <a:solidFill>
+                      <a:srgbClr val="F6F7F9"/>
+                    </a:solidFill>
+                  </a:tcPr>
+                </a:tc>
+                <a:tc>
+                  <a:txBody>
+                    <a:bodyPr/>
+                    <a:lstStyle/>
+                    <a:p>
+                      <a:pPr indent="0" marL="0">
+                        <a:buNone/>
+                      </a:pPr>
+                      <a:r>
+                        <a:rPr lang="en-US" sz="780" dirty="0">
+                          <a:solidFill>
+                            <a:srgbClr val="333333"/>
+                          </a:solidFill>
+                        </a:rPr>
+                        <a:t>Remplacer la sortie legacy de selection par output(). La liste emet l'intention, le parent garde la decision et l'action.</a:t>
+                      </a:r>
+                      <a:endParaRPr lang="en-US" sz="780" dirty="0"/>
                     </a:p>
                   </a:txBody>
                   <a:tcPr marL="50800" marR="50800" marT="25400" marB="25400" anchor="mid">
@@ -4487,14 +4915,14 @@
                         <a:buNone/>
                       </a:pPr>
                       <a:r>
-                        <a:rPr lang="en-US" sz="740" dirty="0">
+                        <a:rPr lang="en-US" sz="780" dirty="0">
                           <a:solidFill>
                             <a:srgbClr val="333333"/>
                           </a:solidFill>
                         </a:rPr>
                         <a:t>7 — toSignal() / toObservable()</a:t>
                       </a:r>
-                      <a:endParaRPr lang="en-US" sz="740" dirty="0"/>
+                      <a:endParaRPr lang="en-US" sz="780" dirty="0"/>
                     </a:p>
                   </a:txBody>
                   <a:tcPr marL="50800" marR="50800" marT="25400" marB="25400" anchor="mid">
@@ -4548,14 +4976,14 @@
                         <a:buNone/>
                       </a:pPr>
                       <a:r>
-                        <a:rPr lang="en-US" sz="740" dirty="0">
+                        <a:rPr lang="en-US" sz="780" dirty="0">
                           <a:solidFill>
                             <a:srgbClr val="333333"/>
                           </a:solidFill>
                         </a:rPr>
-                        <a:t>Frontiere entre Observable RxJS et signal Angular.</a:t>
+                        <a:t>accounts.component.ts, dashboard.component.ts, clients.component.ts</a:t>
                       </a:r>
-                      <a:endParaRPr lang="en-US" sz="740" dirty="0"/>
+                      <a:endParaRPr lang="en-US" sz="780" dirty="0"/>
                     </a:p>
                   </a:txBody>
                   <a:tcPr marL="50800" marR="50800" marT="25400" marB="25400" anchor="mid">
@@ -4609,14 +5037,75 @@
                         <a:buNone/>
                       </a:pPr>
                       <a:r>
-                        <a:rPr lang="en-US" sz="740" dirty="0">
+                        <a:rPr lang="en-US" sz="780" dirty="0">
                           <a:solidFill>
                             <a:srgbClr val="333333"/>
                           </a:solidFill>
                         </a:rPr>
-                        <a:t>Les flux de route, de chargement et de recherche doivent etre connectes aux signals sans supprimer RxJS la ou il compose le flux asynchrone.</a:t>
+                        <a:t>Pont entre Observable RxJS et signal Angular.</a:t>
                       </a:r>
-                      <a:endParaRPr lang="en-US" sz="740" dirty="0"/>
+                      <a:endParaRPr lang="en-US" sz="780" dirty="0"/>
+                    </a:p>
+                  </a:txBody>
+                  <a:tcPr marL="50800" marR="50800" marT="25400" marB="25400" anchor="mid">
+                    <a:lnL w="5715" cap="flat" cmpd="sng" algn="ctr">
+                      <a:solidFill>
+                        <a:srgbClr val="DADCE0"/>
+                      </a:solidFill>
+                      <a:prstDash val="solid"/>
+                      <a:round/>
+                      <a:headEnd type="none" w="med" len="med"/>
+                      <a:tailEnd type="none" w="med" len="med"/>
+                    </a:lnL>
+                    <a:lnR w="5715" cap="flat" cmpd="sng" algn="ctr">
+                      <a:solidFill>
+                        <a:srgbClr val="DADCE0"/>
+                      </a:solidFill>
+                      <a:prstDash val="solid"/>
+                      <a:round/>
+                      <a:headEnd type="none" w="med" len="med"/>
+                      <a:tailEnd type="none" w="med" len="med"/>
+                    </a:lnR>
+                    <a:lnT w="5715" cap="flat" cmpd="sng" algn="ctr">
+                      <a:solidFill>
+                        <a:srgbClr val="DADCE0"/>
+                      </a:solidFill>
+                      <a:prstDash val="solid"/>
+                      <a:round/>
+                      <a:headEnd type="none" w="med" len="med"/>
+                      <a:tailEnd type="none" w="med" len="med"/>
+                    </a:lnT>
+                    <a:lnB w="5715" cap="flat" cmpd="sng" algn="ctr">
+                      <a:solidFill>
+                        <a:srgbClr val="DADCE0"/>
+                      </a:solidFill>
+                      <a:prstDash val="solid"/>
+                      <a:round/>
+                      <a:headEnd type="none" w="med" len="med"/>
+                      <a:tailEnd type="none" w="med" len="med"/>
+                    </a:lnB>
+                    <a:solidFill>
+                      <a:srgbClr val="FFFFFF"/>
+                    </a:solidFill>
+                  </a:tcPr>
+                </a:tc>
+                <a:tc>
+                  <a:txBody>
+                    <a:bodyPr/>
+                    <a:lstStyle/>
+                    <a:p>
+                      <a:pPr indent="0" marL="0">
+                        <a:buNone/>
+                      </a:pPr>
+                      <a:r>
+                        <a:rPr lang="en-US" sz="780" dirty="0">
+                          <a:solidFill>
+                            <a:srgbClr val="333333"/>
+                          </a:solidFill>
+                        </a:rPr>
+                        <a:t>Connecter les flux route, chargement et recherche aux signals. RxJS reste responsable de composer les flux asynchrones.</a:t>
+                      </a:r>
+                      <a:endParaRPr lang="en-US" sz="780" dirty="0"/>
                     </a:p>
                   </a:txBody>
                   <a:tcPr marL="50800" marR="50800" marT="25400" marB="25400" anchor="mid">
@@ -4672,14 +5161,14 @@
                         <a:buNone/>
                       </a:pPr>
                       <a:r>
-                        <a:rPr lang="en-US" sz="740" dirty="0">
+                        <a:rPr lang="en-US" sz="780" dirty="0">
                           <a:solidFill>
                             <a:srgbClr val="333333"/>
                           </a:solidFill>
                         </a:rPr>
                         <a:t>8 — computed() facade</a:t>
                       </a:r>
-                      <a:endParaRPr lang="en-US" sz="740" dirty="0"/>
+                      <a:endParaRPr lang="en-US" sz="780" dirty="0"/>
                     </a:p>
                   </a:txBody>
                   <a:tcPr marL="50800" marR="50800" marT="25400" marB="25400" anchor="mid">
@@ -4733,14 +5222,14 @@
                         <a:buNone/>
                       </a:pPr>
                       <a:r>
-                        <a:rPr lang="en-US" sz="740" dirty="0">
+                        <a:rPr lang="en-US" sz="780" dirty="0">
                           <a:solidFill>
                             <a:srgbClr val="333333"/>
                           </a:solidFill>
                         </a:rPr>
-                        <a:t>Vue derivee de l'etat metier dans une facade.</a:t>
+                        <a:t>accounts.facade.ts, accounts.component.*</a:t>
                       </a:r>
-                      <a:endParaRPr lang="en-US" sz="740" dirty="0"/>
+                      <a:endParaRPr lang="en-US" sz="780" dirty="0"/>
                     </a:p>
                   </a:txBody>
                   <a:tcPr marL="50800" marR="50800" marT="25400" marB="25400" anchor="mid">
@@ -4794,14 +5283,75 @@
                         <a:buNone/>
                       </a:pPr>
                       <a:r>
-                        <a:rPr lang="en-US" sz="740" dirty="0">
+                        <a:rPr lang="en-US" sz="780" dirty="0">
                           <a:solidFill>
                             <a:srgbClr val="333333"/>
                           </a:solidFill>
                         </a:rPr>
-                        <a:t>La facade accounts doit exposer l'etat derive hasActiveFilter pour retirer ce calcul du composant et centraliser la regle metier.</a:t>
+                        <a:t>Vue derivee de l'etat metier dans une facade.</a:t>
                       </a:r>
-                      <a:endParaRPr lang="en-US" sz="740" dirty="0"/>
+                      <a:endParaRPr lang="en-US" sz="780" dirty="0"/>
+                    </a:p>
+                  </a:txBody>
+                  <a:tcPr marL="50800" marR="50800" marT="25400" marB="25400" anchor="mid">
+                    <a:lnL w="5715" cap="flat" cmpd="sng" algn="ctr">
+                      <a:solidFill>
+                        <a:srgbClr val="DADCE0"/>
+                      </a:solidFill>
+                      <a:prstDash val="solid"/>
+                      <a:round/>
+                      <a:headEnd type="none" w="med" len="med"/>
+                      <a:tailEnd type="none" w="med" len="med"/>
+                    </a:lnL>
+                    <a:lnR w="5715" cap="flat" cmpd="sng" algn="ctr">
+                      <a:solidFill>
+                        <a:srgbClr val="DADCE0"/>
+                      </a:solidFill>
+                      <a:prstDash val="solid"/>
+                      <a:round/>
+                      <a:headEnd type="none" w="med" len="med"/>
+                      <a:tailEnd type="none" w="med" len="med"/>
+                    </a:lnR>
+                    <a:lnT w="5715" cap="flat" cmpd="sng" algn="ctr">
+                      <a:solidFill>
+                        <a:srgbClr val="DADCE0"/>
+                      </a:solidFill>
+                      <a:prstDash val="solid"/>
+                      <a:round/>
+                      <a:headEnd type="none" w="med" len="med"/>
+                      <a:tailEnd type="none" w="med" len="med"/>
+                    </a:lnT>
+                    <a:lnB w="5715" cap="flat" cmpd="sng" algn="ctr">
+                      <a:solidFill>
+                        <a:srgbClr val="DADCE0"/>
+                      </a:solidFill>
+                      <a:prstDash val="solid"/>
+                      <a:round/>
+                      <a:headEnd type="none" w="med" len="med"/>
+                      <a:tailEnd type="none" w="med" len="med"/>
+                    </a:lnB>
+                    <a:solidFill>
+                      <a:srgbClr val="F6F7F9"/>
+                    </a:solidFill>
+                  </a:tcPr>
+                </a:tc>
+                <a:tc>
+                  <a:txBody>
+                    <a:bodyPr/>
+                    <a:lstStyle/>
+                    <a:p>
+                      <a:pPr indent="0" marL="0">
+                        <a:buNone/>
+                      </a:pPr>
+                      <a:r>
+                        <a:rPr lang="en-US" sz="780" dirty="0">
+                          <a:solidFill>
+                            <a:srgbClr val="333333"/>
+                          </a:solidFill>
+                        </a:rPr>
+                        <a:t>Exposer hasActiveFilter depuis la facade avec computed(). Le composant ne doit plus porter ce calcul metier.</a:t>
+                      </a:r>
+                      <a:endParaRPr lang="en-US" sz="780" dirty="0"/>
                     </a:p>
                   </a:txBody>
                   <a:tcPr marL="50800" marR="50800" marT="25400" marB="25400" anchor="mid">

</xml_diff>

<commit_message>
reprend besoins consignes pptx
</commit_message>
<xml_diff>
--- a/docs/dojo-signals.pptx
+++ b/docs/dojo-signals.pptx
@@ -3381,7 +3381,7 @@
                             <a:srgbClr val="FFFFFF"/>
                           </a:solidFill>
                         </a:rPr>
-                        <a:t>Consigne claire</a:t>
+                        <a:t>Besoin a couvrir</a:t>
                       </a:r>
                       <a:endParaRPr lang="en-US" sz="780" dirty="0"/>
                     </a:p>
@@ -3505,7 +3505,7 @@
                             <a:srgbClr val="333333"/>
                           </a:solidFill>
                         </a:rPr>
-                        <a:t>clients/pages/clients/clients.component.ts</a:t>
+                        <a:t>src/app/features/clients/pages/clients/clients.component.ts</a:t>
                       </a:r>
                       <a:endParaRPr lang="en-US" sz="780" dirty="0"/>
                     </a:p>
@@ -3627,7 +3627,7 @@
                             <a:srgbClr val="333333"/>
                           </a:solidFill>
                         </a:rPr>
-                        <a:t>Remplacer l'etat d'ouverture du formulaire d'ajout par un signal. Le template et les tests doivent lire cet etat avec la syntaxe signal.</a:t>
+                        <a:t>Convertir l'etat adding en signal. Le template doit afficher le formulaire a partir du signal et les tests doivent verifier ce nouvel etat reactif.</a:t>
                       </a:r>
                       <a:endParaRPr lang="en-US" sz="780" dirty="0"/>
                     </a:p>
@@ -3751,7 +3751,7 @@
                             <a:srgbClr val="333333"/>
                           </a:solidFill>
                         </a:rPr>
-                        <a:t>accounts.facade.ts, accounts.component.*</a:t>
+                        <a:t>src/app/features/accounts/services/accounts.facade.ts, src/app/features/accounts/pages/accounts/accounts.component.*</a:t>
                       </a:r>
                       <a:endParaRPr lang="en-US" sz="780" dirty="0"/>
                     </a:p>
@@ -3873,7 +3873,7 @@
                             <a:srgbClr val="333333"/>
                           </a:solidFill>
                         </a:rPr>
-                        <a:t>Deplacer les calculs d'affichage de la page accounts dans des computed() de facade. Le composant doit consommer ces valeurs deja derivees.</a:t>
+                        <a:t>Transformer blockedAccountsCount en valeur derivee de la facade. La page accounts doit afficher ce compteur sans recalculer elle-meme la regle.</a:t>
                       </a:r>
                       <a:endParaRPr lang="en-US" sz="780" dirty="0"/>
                     </a:p>
@@ -3997,7 +3997,7 @@
                             <a:srgbClr val="333333"/>
                           </a:solidFill>
                         </a:rPr>
-                        <a:t>clients/pages/clients/clients.component.ts</a:t>
+                        <a:t>src/app/features/clients/pages/clients/clients.component.ts</a:t>
                       </a:r>
                       <a:endParaRPr lang="en-US" sz="780" dirty="0"/>
                     </a:p>
@@ -4119,7 +4119,7 @@
                             <a:srgbClr val="333333"/>
                           </a:solidFill>
                         </a:rPr>
-                        <a:t>Ajouter une reaction automatique qui garde l'etat UI coherent quand les donnees clients ou les filtres changent.</a:t>
+                        <a:t>Remplacer le recalage imperatif de la page courante par une reaction automatique. Quand la liste change, la page selectionnee doit rester valide.</a:t>
                       </a:r>
                       <a:endParaRPr lang="en-US" sz="780" dirty="0"/>
                     </a:p>
@@ -4243,7 +4243,7 @@
                             <a:srgbClr val="333333"/>
                           </a:solidFill>
                         </a:rPr>
-                        <a:t>clients/pages/clients/clients.component.ts</a:t>
+                        <a:t>src/app/features/clients/pages/clients/clients.component.ts</a:t>
                       </a:r>
                       <a:endParaRPr lang="en-US" sz="780" dirty="0"/>
                     </a:p>
@@ -4365,7 +4365,7 @@
                             <a:srgbClr val="333333"/>
                           </a:solidFill>
                         </a:rPr>
-                        <a:t>Convertir la reference du champ prenom en viewChild() signal, puis creer l'effect() qui place le focus quand le champ existe.</a:t>
+                        <a:t>Remplacer la reference DOM classique du champ prenom par une reference signal, puis declencher le focus quand ce champ apparait.</a:t>
                       </a:r>
                       <a:endParaRPr lang="en-US" sz="780" dirty="0"/>
                     </a:p>
@@ -4489,7 +4489,7 @@
                             <a:srgbClr val="333333"/>
                           </a:solidFill>
                         </a:rPr>
-                        <a:t>account-card/account-card.component.ts</a:t>
+                        <a:t>src/app/features/accounts/components/account-card/account-card.component.ts</a:t>
                       </a:r>
                       <a:endParaRPr lang="en-US" sz="780" dirty="0"/>
                     </a:p>
@@ -4611,7 +4611,7 @@
                             <a:srgbClr val="333333"/>
                           </a:solidFill>
                         </a:rPr>
-                        <a:t>Convertir l'entree showStatus en input(). Le calcul du statut visible doit reagir quand le parent change cette entree.</a:t>
+                        <a:t>Convertir showStatus en input signal. Le libelle de statut doit reagir correctement quand le parent choisit d'afficher ou masquer ce statut.</a:t>
                       </a:r>
                       <a:endParaRPr lang="en-US" sz="780" dirty="0"/>
                     </a:p>
@@ -4735,7 +4735,7 @@
                             <a:srgbClr val="333333"/>
                           </a:solidFill>
                         </a:rPr>
-                        <a:t>account-list/account-list.component.ts</a:t>
+                        <a:t>src/app/features/accounts/components/account-list/account-list.component.ts</a:t>
                       </a:r>
                       <a:endParaRPr lang="en-US" sz="780" dirty="0"/>
                     </a:p>
@@ -4857,7 +4857,7 @@
                             <a:srgbClr val="333333"/>
                           </a:solidFill>
                         </a:rPr>
-                        <a:t>Remplacer la sortie legacy de selection par output(). La liste emet l'intention, le parent garde la decision et l'action.</a:t>
+                        <a:t>Remplacer la sortie legacy selectedRequested par output(). La liste doit continuer a emettre la selection vers le parent.</a:t>
                       </a:r>
                       <a:endParaRPr lang="en-US" sz="780" dirty="0"/>
                     </a:p>
@@ -4981,7 +4981,7 @@
                             <a:srgbClr val="333333"/>
                           </a:solidFill>
                         </a:rPr>
-                        <a:t>accounts.component.ts, dashboard.component.ts, clients.component.ts</a:t>
+                        <a:t>src/app/features/accounts/pages/accounts/accounts.component.ts, src/app/features/clients/pages/dashboard/dashboard.component.ts, src/app/features/clients/pages/clients/clients.component.ts</a:t>
                       </a:r>
                       <a:endParaRPr lang="en-US" sz="780" dirty="0"/>
                     </a:p>
@@ -5103,7 +5103,7 @@
                             <a:srgbClr val="333333"/>
                           </a:solidFill>
                         </a:rPr>
-                        <a:t>Connecter les flux route, chargement et recherche aux signals. RxJS reste responsable de composer les flux asynchrones.</a:t>
+                        <a:t>Remplacer la souscription manuelle a la route par toSignal(), exposer le chargement dashboard comme signal, et identifier le pont inverse toObservable() pour la recherche debouncee.</a:t>
                       </a:r>
                       <a:endParaRPr lang="en-US" sz="780" dirty="0"/>
                     </a:p>
@@ -5227,7 +5227,7 @@
                             <a:srgbClr val="333333"/>
                           </a:solidFill>
                         </a:rPr>
-                        <a:t>accounts.facade.ts, accounts.component.*</a:t>
+                        <a:t>src/app/features/accounts/services/accounts.facade.ts, src/app/features/accounts/pages/accounts/accounts.component.*</a:t>
                       </a:r>
                       <a:endParaRPr lang="en-US" sz="780" dirty="0"/>
                     </a:p>
@@ -5349,7 +5349,7 @@
                             <a:srgbClr val="333333"/>
                           </a:solidFill>
                         </a:rPr>
-                        <a:t>Exposer hasActiveFilter depuis la facade avec computed(). Le composant ne doit plus porter ce calcul metier.</a:t>
+                        <a:t>Ajouter hasActiveFilter comme valeur derivee de la facade. Le message vide doit dependre de cette regle exposee par la facade.</a:t>
                       </a:r>
                       <a:endParaRPr lang="en-US" sz="780" dirty="0"/>
                     </a:p>

</xml_diff>

<commit_message>
relativise tests dans pptx court
</commit_message>
<xml_diff>
--- a/docs/dojo-signals.pptx
+++ b/docs/dojo-signals.pptx
@@ -947,7 +947,7 @@
           <a:p>
             <a:r>
               <a:rPr lang="en-US" dirty="0"/>
-              <a:t/>
+              <a:t>Les tests ne sont pas l'objectif principal du dojo. S'ils echouent a cause de la migration demandee, les ajuster pour refleter le nouveau comportement.</a:t>
             </a:r>
             <a:endParaRPr lang="en-US" dirty="0"/>
           </a:p>
@@ -3627,7 +3627,7 @@
                             <a:srgbClr val="333333"/>
                           </a:solidFill>
                         </a:rPr>
-                        <a:t>Convertir l'etat adding en signal. Le template doit afficher le formulaire a partir du signal et les tests doivent verifier ce nouvel etat reactif.</a:t>
+                        <a:t>Convertir l'etat adding en signal. Le template doit afficher le formulaire a partir de ce nouvel etat reactif.</a:t>
                       </a:r>
                       <a:endParaRPr lang="en-US" sz="780" dirty="0"/>
                     </a:p>
@@ -5403,7 +5403,7 @@
       </p:graphicFrame>
       <p:sp>
         <p:nvSpPr>
-          <p:cNvPr id="5" name="Text 2"/>
+          <p:cNvPr id="6" name="Text 2"/>
           <p:cNvSpPr/>
           <p:nvPr/>
         </p:nvSpPr>

</xml_diff>

<commit_message>
retravaille slides rappel pptx
</commit_message>
<xml_diff>
--- a/docs/dojo-signals.pptx
+++ b/docs/dojo-signals.pptx
@@ -595,7 +595,7 @@
           <a:p>
             <a:r>
               <a:rPr lang="en-US" dirty="0"/>
-              <a:t>Un signal est une valeur reactive lue avec (). Quand sa valeur change, Angular sait quelles lectures dependent de cette valeur.</a:t>
+              <a:t/>
             </a:r>
             <a:endParaRPr lang="en-US" dirty="0"/>
           </a:p>
@@ -683,7 +683,7 @@
           <a:p>
             <a:r>
               <a:rPr lang="en-US" dirty="0"/>
-              <a:t>Zone.js intercepte les evenements asynchrones du navigateur et previent Angular qu'un cycle de detection peut etre lance.</a:t>
+              <a:t/>
             </a:r>
             <a:endParaRPr lang="en-US" dirty="0"/>
           </a:p>
@@ -771,7 +771,7 @@
           <a:p>
             <a:r>
               <a:rPr lang="en-US" dirty="0"/>
-              <a:t>RxJS sert a modeliser des flux dans le temps : HTTP, route params, evenements, debounceTime, switchMap, combineLatest.</a:t>
+              <a:t/>
             </a:r>
             <a:endParaRPr lang="en-US" dirty="0"/>
           </a:p>
@@ -1672,14 +1672,66 @@
       </p:sp>
       <p:sp>
         <p:nvSpPr>
-          <p:cNvPr id="6" name="Text 3"/>
-          <p:cNvSpPr/>
-          <p:nvPr/>
-        </p:nvSpPr>
-        <p:spPr>
-          <a:xfrm>
-            <a:off x="576072" y="932688"/>
-            <a:ext cx="11204143" cy="256032"/>
+          <p:cNvPr id="5" name="Shape 3"/>
+          <p:cNvSpPr/>
+          <p:nvPr/>
+        </p:nvSpPr>
+        <p:spPr>
+          <a:xfrm>
+            <a:off x="411480" y="960120"/>
+            <a:ext cx="11368735" cy="1207008"/>
+          </a:xfrm>
+          <a:prstGeom prst="roundRect">
+            <a:avLst>
+              <a:gd name="adj" fmla="val 6061"/>
+            </a:avLst>
+          </a:prstGeom>
+          <a:solidFill>
+            <a:srgbClr val="FFFFFF"/>
+          </a:solidFill>
+          <a:ln w="12700">
+            <a:solidFill>
+              <a:srgbClr val="E4E7EC"/>
+            </a:solidFill>
+            <a:prstDash val="solid"/>
+          </a:ln>
+        </p:spPr>
+      </p:sp>
+      <p:sp>
+        <p:nvSpPr>
+          <p:cNvPr id="6" name="Shape 4"/>
+          <p:cNvSpPr/>
+          <p:nvPr/>
+        </p:nvSpPr>
+        <p:spPr>
+          <a:xfrm>
+            <a:off x="411480" y="960120"/>
+            <a:ext cx="109728" cy="1207008"/>
+          </a:xfrm>
+          <a:prstGeom prst="rect">
+            <a:avLst/>
+          </a:prstGeom>
+          <a:solidFill>
+            <a:srgbClr val="DD0031"/>
+          </a:solidFill>
+          <a:ln w="12700">
+            <a:solidFill>
+              <a:srgbClr val="DD0031"/>
+            </a:solidFill>
+            <a:prstDash val="solid"/>
+          </a:ln>
+        </p:spPr>
+      </p:sp>
+      <p:sp>
+        <p:nvSpPr>
+          <p:cNvPr id="7" name="Text 5"/>
+          <p:cNvSpPr/>
+          <p:nvPr/>
+        </p:nvSpPr>
+        <p:spPr>
+          <a:xfrm>
+            <a:off x="667512" y="1115568"/>
+            <a:ext cx="1143000" cy="228600"/>
           </a:xfrm>
           <a:prstGeom prst="rect">
             <a:avLst/>
@@ -1688,33 +1740,141 @@
           <a:ln/>
         </p:spPr>
         <p:txBody>
-          <a:bodyPr wrap="square" lIns="127" tIns="127" rIns="127" bIns="127" rtlCol="0" anchor="ctr">
+          <a:bodyPr wrap="square" lIns="0" tIns="0" rIns="0" bIns="0" rtlCol="0" anchor="ctr"/>
+          <a:lstStyle/>
+          <a:p>
+            <a:pPr indent="0" marL="0">
+              <a:buNone/>
+            </a:pPr>
+            <a:r>
+              <a:rPr lang="en-US" sz="900" b="1" dirty="0">
+                <a:solidFill>
+                  <a:srgbClr val="DD0031"/>
+                </a:solidFill>
+              </a:rPr>
+              <a:t>Définition</a:t>
+            </a:r>
+            <a:endParaRPr lang="en-US" sz="900" dirty="0"/>
+          </a:p>
+        </p:txBody>
+      </p:sp>
+      <p:sp>
+        <p:nvSpPr>
+          <p:cNvPr id="8" name="Text 6"/>
+          <p:cNvSpPr/>
+          <p:nvPr/>
+        </p:nvSpPr>
+        <p:spPr>
+          <a:xfrm>
+            <a:off x="1892808" y="1078992"/>
+            <a:ext cx="9631375" cy="786384"/>
+          </a:xfrm>
+          <a:prstGeom prst="rect">
+            <a:avLst/>
+          </a:prstGeom>
+          <a:noFill/>
+          <a:ln/>
+        </p:spPr>
+        <p:txBody>
+          <a:bodyPr wrap="square" lIns="254" tIns="254" rIns="254" bIns="254" rtlCol="0" anchor="ctr">
             <a:normAutofit/>
           </a:bodyPr>
           <a:lstStyle/>
           <a:p>
-            <a:r>
-              <a:rPr lang="en-US" sz="1160" dirty="0">
+            <a:pPr indent="0" marL="0">
+              <a:buNone/>
+            </a:pPr>
+            <a:r>
+              <a:rPr lang="en-US" sz="1500" dirty="0">
                 <a:solidFill>
                   <a:srgbClr val="273043"/>
                 </a:solidFill>
               </a:rPr>
-              <a:t>signal() cree une valeur mutable.</a:t>
-            </a:r>
-            <a:endParaRPr lang="en-US" sz="1160" dirty="0"/>
-          </a:p>
-        </p:txBody>
-      </p:sp>
-      <p:sp>
-        <p:nvSpPr>
-          <p:cNvPr id="7" name="Text 4"/>
-          <p:cNvSpPr/>
-          <p:nvPr/>
-        </p:nvSpPr>
-        <p:spPr>
-          <a:xfrm>
-            <a:off x="576072" y="1243584"/>
-            <a:ext cx="11204143" cy="256032"/>
+              <a:t>Un signal est une valeur reactive lue avec (). Quand sa valeur change, Angular sait quelles lectures dependent de cette valeur.</a:t>
+            </a:r>
+            <a:endParaRPr lang="en-US" sz="1500" dirty="0"/>
+          </a:p>
+        </p:txBody>
+      </p:sp>
+      <p:sp>
+        <p:nvSpPr>
+          <p:cNvPr id="9" name="Shape 7"/>
+          <p:cNvSpPr/>
+          <p:nvPr/>
+        </p:nvSpPr>
+        <p:spPr>
+          <a:xfrm>
+            <a:off x="411480" y="2788920"/>
+            <a:ext cx="5547208" cy="1143000"/>
+          </a:xfrm>
+          <a:prstGeom prst="roundRect">
+            <a:avLst>
+              <a:gd name="adj" fmla="val 6400"/>
+            </a:avLst>
+          </a:prstGeom>
+          <a:solidFill>
+            <a:srgbClr val="FFFFFF"/>
+          </a:solidFill>
+          <a:ln w="12700">
+            <a:solidFill>
+              <a:srgbClr val="E4E7EC"/>
+            </a:solidFill>
+            <a:prstDash val="solid"/>
+          </a:ln>
+        </p:spPr>
+      </p:sp>
+      <p:sp>
+        <p:nvSpPr>
+          <p:cNvPr id="10" name="Text 8"/>
+          <p:cNvSpPr/>
+          <p:nvPr/>
+        </p:nvSpPr>
+        <p:spPr>
+          <a:xfrm>
+            <a:off x="557784" y="2935224"/>
+            <a:ext cx="347472" cy="228600"/>
+          </a:xfrm>
+          <a:prstGeom prst="rect">
+            <a:avLst/>
+          </a:prstGeom>
+          <a:solidFill>
+            <a:srgbClr val="FCE7EC"/>
+          </a:solidFill>
+          <a:ln>
+            <a:solidFill>
+              <a:srgbClr val="FCE7EC"/>
+            </a:solidFill>
+          </a:ln>
+        </p:spPr>
+        <p:txBody>
+          <a:bodyPr wrap="square" lIns="0" tIns="0" rIns="0" bIns="0" rtlCol="0" anchor="ctr"/>
+          <a:lstStyle/>
+          <a:p>
+            <a:pPr algn="ctr" indent="0" marL="0">
+              <a:buNone/>
+            </a:pPr>
+            <a:r>
+              <a:rPr lang="en-US" sz="800" b="1" dirty="0">
+                <a:solidFill>
+                  <a:srgbClr val="DD0031"/>
+                </a:solidFill>
+              </a:rPr>
+              <a:t>01</a:t>
+            </a:r>
+            <a:endParaRPr lang="en-US" sz="800" dirty="0"/>
+          </a:p>
+        </p:txBody>
+      </p:sp>
+      <p:sp>
+        <p:nvSpPr>
+          <p:cNvPr id="11" name="Text 9"/>
+          <p:cNvSpPr/>
+          <p:nvPr/>
+        </p:nvSpPr>
+        <p:spPr>
+          <a:xfrm>
+            <a:off x="1033272" y="2953512"/>
+            <a:ext cx="4742536" cy="850392"/>
           </a:xfrm>
           <a:prstGeom prst="rect">
             <a:avLst/>
@@ -1723,33 +1883,105 @@
           <a:ln/>
         </p:spPr>
         <p:txBody>
-          <a:bodyPr wrap="square" lIns="127" tIns="127" rIns="127" bIns="127" rtlCol="0" anchor="ctr">
+          <a:bodyPr wrap="square" lIns="254" tIns="254" rIns="254" bIns="254" rtlCol="0" anchor="ctr">
             <a:normAutofit/>
           </a:bodyPr>
           <a:lstStyle/>
           <a:p>
-            <a:r>
-              <a:rPr lang="en-US" sz="1160" dirty="0">
+            <a:pPr indent="0" marL="0">
+              <a:buNone/>
+            </a:pPr>
+            <a:r>
+              <a:rPr lang="en-US" sz="1200" dirty="0">
                 <a:solidFill>
                   <a:srgbClr val="273043"/>
                 </a:solidFill>
               </a:rPr>
-              <a:t>computed() cree une valeur derivee.</a:t>
-            </a:r>
-            <a:endParaRPr lang="en-US" sz="1160" dirty="0"/>
-          </a:p>
-        </p:txBody>
-      </p:sp>
-      <p:sp>
-        <p:nvSpPr>
-          <p:cNvPr id="8" name="Text 5"/>
-          <p:cNvSpPr/>
-          <p:nvPr/>
-        </p:nvSpPr>
-        <p:spPr>
-          <a:xfrm>
-            <a:off x="576072" y="1554480"/>
-            <a:ext cx="11204143" cy="256032"/>
+              <a:t>signal() cree une valeur mutable.</a:t>
+            </a:r>
+            <a:endParaRPr lang="en-US" sz="1200" dirty="0"/>
+          </a:p>
+        </p:txBody>
+      </p:sp>
+      <p:sp>
+        <p:nvSpPr>
+          <p:cNvPr id="12" name="Shape 10"/>
+          <p:cNvSpPr/>
+          <p:nvPr/>
+        </p:nvSpPr>
+        <p:spPr>
+          <a:xfrm>
+            <a:off x="6233008" y="2788920"/>
+            <a:ext cx="5547208" cy="1143000"/>
+          </a:xfrm>
+          <a:prstGeom prst="roundRect">
+            <a:avLst>
+              <a:gd name="adj" fmla="val 6400"/>
+            </a:avLst>
+          </a:prstGeom>
+          <a:solidFill>
+            <a:srgbClr val="FFFFFF"/>
+          </a:solidFill>
+          <a:ln w="12700">
+            <a:solidFill>
+              <a:srgbClr val="E4E7EC"/>
+            </a:solidFill>
+            <a:prstDash val="solid"/>
+          </a:ln>
+        </p:spPr>
+      </p:sp>
+      <p:sp>
+        <p:nvSpPr>
+          <p:cNvPr id="13" name="Text 11"/>
+          <p:cNvSpPr/>
+          <p:nvPr/>
+        </p:nvSpPr>
+        <p:spPr>
+          <a:xfrm>
+            <a:off x="6379312" y="2935224"/>
+            <a:ext cx="347472" cy="228600"/>
+          </a:xfrm>
+          <a:prstGeom prst="rect">
+            <a:avLst/>
+          </a:prstGeom>
+          <a:solidFill>
+            <a:srgbClr val="E8F1FF"/>
+          </a:solidFill>
+          <a:ln>
+            <a:solidFill>
+              <a:srgbClr val="E8F1FF"/>
+            </a:solidFill>
+          </a:ln>
+        </p:spPr>
+        <p:txBody>
+          <a:bodyPr wrap="square" lIns="0" tIns="0" rIns="0" bIns="0" rtlCol="0" anchor="ctr"/>
+          <a:lstStyle/>
+          <a:p>
+            <a:pPr algn="ctr" indent="0" marL="0">
+              <a:buNone/>
+            </a:pPr>
+            <a:r>
+              <a:rPr lang="en-US" sz="800" b="1" dirty="0">
+                <a:solidFill>
+                  <a:srgbClr val="1976D2"/>
+                </a:solidFill>
+              </a:rPr>
+              <a:t>02</a:t>
+            </a:r>
+            <a:endParaRPr lang="en-US" sz="800" dirty="0"/>
+          </a:p>
+        </p:txBody>
+      </p:sp>
+      <p:sp>
+        <p:nvSpPr>
+          <p:cNvPr id="14" name="Text 12"/>
+          <p:cNvSpPr/>
+          <p:nvPr/>
+        </p:nvSpPr>
+        <p:spPr>
+          <a:xfrm>
+            <a:off x="6854800" y="2953512"/>
+            <a:ext cx="4742536" cy="850392"/>
           </a:xfrm>
           <a:prstGeom prst="rect">
             <a:avLst/>
@@ -1758,33 +1990,105 @@
           <a:ln/>
         </p:spPr>
         <p:txBody>
-          <a:bodyPr wrap="square" lIns="127" tIns="127" rIns="127" bIns="127" rtlCol="0" anchor="ctr">
+          <a:bodyPr wrap="square" lIns="254" tIns="254" rIns="254" bIns="254" rtlCol="0" anchor="ctr">
             <a:normAutofit/>
           </a:bodyPr>
           <a:lstStyle/>
           <a:p>
-            <a:r>
-              <a:rPr lang="en-US" sz="1160" dirty="0">
+            <a:pPr indent="0" marL="0">
+              <a:buNone/>
+            </a:pPr>
+            <a:r>
+              <a:rPr lang="en-US" sz="1200" dirty="0">
                 <a:solidFill>
                   <a:srgbClr val="273043"/>
                 </a:solidFill>
               </a:rPr>
-              <a:t>effect() observe des signals pour declencher un effet de bord.</a:t>
-            </a:r>
-            <a:endParaRPr lang="en-US" sz="1160" dirty="0"/>
-          </a:p>
-        </p:txBody>
-      </p:sp>
-      <p:sp>
-        <p:nvSpPr>
-          <p:cNvPr id="9" name="Text 6"/>
-          <p:cNvSpPr/>
-          <p:nvPr/>
-        </p:nvSpPr>
-        <p:spPr>
-          <a:xfrm>
-            <a:off x="576072" y="1865376"/>
-            <a:ext cx="11204143" cy="256032"/>
+              <a:t>computed() cree une valeur derivee.</a:t>
+            </a:r>
+            <a:endParaRPr lang="en-US" sz="1200" dirty="0"/>
+          </a:p>
+        </p:txBody>
+      </p:sp>
+      <p:sp>
+        <p:nvSpPr>
+          <p:cNvPr id="15" name="Shape 13"/>
+          <p:cNvSpPr/>
+          <p:nvPr/>
+        </p:nvSpPr>
+        <p:spPr>
+          <a:xfrm>
+            <a:off x="411480" y="4142232"/>
+            <a:ext cx="5547208" cy="1143000"/>
+          </a:xfrm>
+          <a:prstGeom prst="roundRect">
+            <a:avLst>
+              <a:gd name="adj" fmla="val 6400"/>
+            </a:avLst>
+          </a:prstGeom>
+          <a:solidFill>
+            <a:srgbClr val="FFFFFF"/>
+          </a:solidFill>
+          <a:ln w="12700">
+            <a:solidFill>
+              <a:srgbClr val="E4E7EC"/>
+            </a:solidFill>
+            <a:prstDash val="solid"/>
+          </a:ln>
+        </p:spPr>
+      </p:sp>
+      <p:sp>
+        <p:nvSpPr>
+          <p:cNvPr id="16" name="Text 14"/>
+          <p:cNvSpPr/>
+          <p:nvPr/>
+        </p:nvSpPr>
+        <p:spPr>
+          <a:xfrm>
+            <a:off x="557784" y="4288536"/>
+            <a:ext cx="347472" cy="228600"/>
+          </a:xfrm>
+          <a:prstGeom prst="rect">
+            <a:avLst/>
+          </a:prstGeom>
+          <a:solidFill>
+            <a:srgbClr val="EAF7F0"/>
+          </a:solidFill>
+          <a:ln>
+            <a:solidFill>
+              <a:srgbClr val="EAF7F0"/>
+            </a:solidFill>
+          </a:ln>
+        </p:spPr>
+        <p:txBody>
+          <a:bodyPr wrap="square" lIns="0" tIns="0" rIns="0" bIns="0" rtlCol="0" anchor="ctr"/>
+          <a:lstStyle/>
+          <a:p>
+            <a:pPr algn="ctr" indent="0" marL="0">
+              <a:buNone/>
+            </a:pPr>
+            <a:r>
+              <a:rPr lang="en-US" sz="800" b="1" dirty="0">
+                <a:solidFill>
+                  <a:srgbClr val="188038"/>
+                </a:solidFill>
+              </a:rPr>
+              <a:t>03</a:t>
+            </a:r>
+            <a:endParaRPr lang="en-US" sz="800" dirty="0"/>
+          </a:p>
+        </p:txBody>
+      </p:sp>
+      <p:sp>
+        <p:nvSpPr>
+          <p:cNvPr id="17" name="Text 15"/>
+          <p:cNvSpPr/>
+          <p:nvPr/>
+        </p:nvSpPr>
+        <p:spPr>
+          <a:xfrm>
+            <a:off x="1033272" y="4306824"/>
+            <a:ext cx="4742536" cy="850392"/>
           </a:xfrm>
           <a:prstGeom prst="rect">
             <a:avLst/>
@@ -1793,26 +2097,136 @@
           <a:ln/>
         </p:spPr>
         <p:txBody>
-          <a:bodyPr wrap="square" lIns="127" tIns="127" rIns="127" bIns="127" rtlCol="0" anchor="ctr">
+          <a:bodyPr wrap="square" lIns="254" tIns="254" rIns="254" bIns="254" rtlCol="0" anchor="ctr">
             <a:normAutofit/>
           </a:bodyPr>
           <a:lstStyle/>
           <a:p>
-            <a:r>
-              <a:rPr lang="en-US" sz="1160" dirty="0">
+            <a:pPr indent="0" marL="0">
+              <a:buNone/>
+            </a:pPr>
+            <a:r>
+              <a:rPr lang="en-US" sz="1200" dirty="0">
                 <a:solidFill>
                   <a:srgbClr val="273043"/>
                 </a:solidFill>
               </a:rPr>
+              <a:t>effect() observe des signals pour declencher un effet de bord.</a:t>
+            </a:r>
+            <a:endParaRPr lang="en-US" sz="1200" dirty="0"/>
+          </a:p>
+        </p:txBody>
+      </p:sp>
+      <p:sp>
+        <p:nvSpPr>
+          <p:cNvPr id="18" name="Shape 16"/>
+          <p:cNvSpPr/>
+          <p:nvPr/>
+        </p:nvSpPr>
+        <p:spPr>
+          <a:xfrm>
+            <a:off x="6233008" y="4142232"/>
+            <a:ext cx="5547208" cy="1143000"/>
+          </a:xfrm>
+          <a:prstGeom prst="roundRect">
+            <a:avLst>
+              <a:gd name="adj" fmla="val 6400"/>
+            </a:avLst>
+          </a:prstGeom>
+          <a:solidFill>
+            <a:srgbClr val="FFFFFF"/>
+          </a:solidFill>
+          <a:ln w="12700">
+            <a:solidFill>
+              <a:srgbClr val="E4E7EC"/>
+            </a:solidFill>
+            <a:prstDash val="solid"/>
+          </a:ln>
+        </p:spPr>
+      </p:sp>
+      <p:sp>
+        <p:nvSpPr>
+          <p:cNvPr id="19" name="Text 17"/>
+          <p:cNvSpPr/>
+          <p:nvPr/>
+        </p:nvSpPr>
+        <p:spPr>
+          <a:xfrm>
+            <a:off x="6379312" y="4288536"/>
+            <a:ext cx="347472" cy="228600"/>
+          </a:xfrm>
+          <a:prstGeom prst="rect">
+            <a:avLst/>
+          </a:prstGeom>
+          <a:solidFill>
+            <a:srgbClr val="F0ECFF"/>
+          </a:solidFill>
+          <a:ln>
+            <a:solidFill>
+              <a:srgbClr val="F0ECFF"/>
+            </a:solidFill>
+          </a:ln>
+        </p:spPr>
+        <p:txBody>
+          <a:bodyPr wrap="square" lIns="0" tIns="0" rIns="0" bIns="0" rtlCol="0" anchor="ctr"/>
+          <a:lstStyle/>
+          <a:p>
+            <a:pPr algn="ctr" indent="0" marL="0">
+              <a:buNone/>
+            </a:pPr>
+            <a:r>
+              <a:rPr lang="en-US" sz="800" b="1" dirty="0">
+                <a:solidFill>
+                  <a:srgbClr val="7B61FF"/>
+                </a:solidFill>
+              </a:rPr>
+              <a:t>04</a:t>
+            </a:r>
+            <a:endParaRPr lang="en-US" sz="800" dirty="0"/>
+          </a:p>
+        </p:txBody>
+      </p:sp>
+      <p:sp>
+        <p:nvSpPr>
+          <p:cNvPr id="20" name="Text 18"/>
+          <p:cNvSpPr/>
+          <p:nvPr/>
+        </p:nvSpPr>
+        <p:spPr>
+          <a:xfrm>
+            <a:off x="6854800" y="4306824"/>
+            <a:ext cx="4742536" cy="850392"/>
+          </a:xfrm>
+          <a:prstGeom prst="rect">
+            <a:avLst/>
+          </a:prstGeom>
+          <a:noFill/>
+          <a:ln/>
+        </p:spPr>
+        <p:txBody>
+          <a:bodyPr wrap="square" lIns="254" tIns="254" rIns="254" bIns="254" rtlCol="0" anchor="ctr">
+            <a:normAutofit/>
+          </a:bodyPr>
+          <a:lstStyle/>
+          <a:p>
+            <a:pPr indent="0" marL="0">
+              <a:buNone/>
+            </a:pPr>
+            <a:r>
+              <a:rPr lang="en-US" sz="1200" dirty="0">
+                <a:solidFill>
+                  <a:srgbClr val="273043"/>
+                </a:solidFill>
+              </a:rPr>
               <a:t>Le template lit un signal avec monSignal().</a:t>
             </a:r>
-            <a:endParaRPr lang="en-US" sz="1160" dirty="0"/>
-          </a:p>
-        </p:txBody>
-      </p:sp>
-      <p:sp>
-        <p:nvSpPr>
-          <p:cNvPr id="10" name="Text 7"/>
+            <a:endParaRPr lang="en-US" sz="1200" dirty="0"/>
+          </a:p>
+        </p:txBody>
+      </p:sp>
+      <p:sp>
+        <p:nvSpPr>
+          <p:cNvPr id="21" name="Text 19"/>
           <p:cNvSpPr/>
           <p:nvPr/>
         </p:nvSpPr>
@@ -1985,14 +2399,66 @@
       </p:sp>
       <p:sp>
         <p:nvSpPr>
-          <p:cNvPr id="6" name="Text 3"/>
-          <p:cNvSpPr/>
-          <p:nvPr/>
-        </p:nvSpPr>
-        <p:spPr>
-          <a:xfrm>
-            <a:off x="576072" y="932688"/>
-            <a:ext cx="11204143" cy="256032"/>
+          <p:cNvPr id="5" name="Shape 3"/>
+          <p:cNvSpPr/>
+          <p:nvPr/>
+        </p:nvSpPr>
+        <p:spPr>
+          <a:xfrm>
+            <a:off x="411480" y="960120"/>
+            <a:ext cx="11368735" cy="1207008"/>
+          </a:xfrm>
+          <a:prstGeom prst="roundRect">
+            <a:avLst>
+              <a:gd name="adj" fmla="val 6061"/>
+            </a:avLst>
+          </a:prstGeom>
+          <a:solidFill>
+            <a:srgbClr val="FFFFFF"/>
+          </a:solidFill>
+          <a:ln w="12700">
+            <a:solidFill>
+              <a:srgbClr val="E4E7EC"/>
+            </a:solidFill>
+            <a:prstDash val="solid"/>
+          </a:ln>
+        </p:spPr>
+      </p:sp>
+      <p:sp>
+        <p:nvSpPr>
+          <p:cNvPr id="6" name="Shape 4"/>
+          <p:cNvSpPr/>
+          <p:nvPr/>
+        </p:nvSpPr>
+        <p:spPr>
+          <a:xfrm>
+            <a:off x="411480" y="960120"/>
+            <a:ext cx="109728" cy="1207008"/>
+          </a:xfrm>
+          <a:prstGeom prst="rect">
+            <a:avLst/>
+          </a:prstGeom>
+          <a:solidFill>
+            <a:srgbClr val="DD0031"/>
+          </a:solidFill>
+          <a:ln w="12700">
+            <a:solidFill>
+              <a:srgbClr val="DD0031"/>
+            </a:solidFill>
+            <a:prstDash val="solid"/>
+          </a:ln>
+        </p:spPr>
+      </p:sp>
+      <p:sp>
+        <p:nvSpPr>
+          <p:cNvPr id="7" name="Text 5"/>
+          <p:cNvSpPr/>
+          <p:nvPr/>
+        </p:nvSpPr>
+        <p:spPr>
+          <a:xfrm>
+            <a:off x="667512" y="1115568"/>
+            <a:ext cx="1143000" cy="228600"/>
           </a:xfrm>
           <a:prstGeom prst="rect">
             <a:avLst/>
@@ -2001,33 +2467,141 @@
           <a:ln/>
         </p:spPr>
         <p:txBody>
-          <a:bodyPr wrap="square" lIns="127" tIns="127" rIns="127" bIns="127" rtlCol="0" anchor="ctr">
+          <a:bodyPr wrap="square" lIns="0" tIns="0" rIns="0" bIns="0" rtlCol="0" anchor="ctr"/>
+          <a:lstStyle/>
+          <a:p>
+            <a:pPr indent="0" marL="0">
+              <a:buNone/>
+            </a:pPr>
+            <a:r>
+              <a:rPr lang="en-US" sz="900" b="1" dirty="0">
+                <a:solidFill>
+                  <a:srgbClr val="DD0031"/>
+                </a:solidFill>
+              </a:rPr>
+              <a:t>Définition</a:t>
+            </a:r>
+            <a:endParaRPr lang="en-US" sz="900" dirty="0"/>
+          </a:p>
+        </p:txBody>
+      </p:sp>
+      <p:sp>
+        <p:nvSpPr>
+          <p:cNvPr id="8" name="Text 6"/>
+          <p:cNvSpPr/>
+          <p:nvPr/>
+        </p:nvSpPr>
+        <p:spPr>
+          <a:xfrm>
+            <a:off x="1892808" y="1078992"/>
+            <a:ext cx="9631375" cy="786384"/>
+          </a:xfrm>
+          <a:prstGeom prst="rect">
+            <a:avLst/>
+          </a:prstGeom>
+          <a:noFill/>
+          <a:ln/>
+        </p:spPr>
+        <p:txBody>
+          <a:bodyPr wrap="square" lIns="254" tIns="254" rIns="254" bIns="254" rtlCol="0" anchor="ctr">
             <a:normAutofit/>
           </a:bodyPr>
           <a:lstStyle/>
           <a:p>
-            <a:r>
-              <a:rPr lang="en-US" sz="1160" dirty="0">
+            <a:pPr indent="0" marL="0">
+              <a:buNone/>
+            </a:pPr>
+            <a:r>
+              <a:rPr lang="en-US" sz="1500" dirty="0">
                 <a:solidFill>
                   <a:srgbClr val="273043"/>
                 </a:solidFill>
               </a:rPr>
-              <a:t>Zone.js declenche la detection apres un evenement async.</a:t>
-            </a:r>
-            <a:endParaRPr lang="en-US" sz="1160" dirty="0"/>
-          </a:p>
-        </p:txBody>
-      </p:sp>
-      <p:sp>
-        <p:nvSpPr>
-          <p:cNvPr id="7" name="Text 4"/>
-          <p:cNvSpPr/>
-          <p:nvPr/>
-        </p:nvSpPr>
-        <p:spPr>
-          <a:xfrm>
-            <a:off x="576072" y="1243584"/>
-            <a:ext cx="11204143" cy="256032"/>
+              <a:t>Zone.js intercepte les evenements asynchrones du navigateur et previent Angular qu'un cycle de detection peut etre lance.</a:t>
+            </a:r>
+            <a:endParaRPr lang="en-US" sz="1500" dirty="0"/>
+          </a:p>
+        </p:txBody>
+      </p:sp>
+      <p:sp>
+        <p:nvSpPr>
+          <p:cNvPr id="9" name="Shape 7"/>
+          <p:cNvSpPr/>
+          <p:nvPr/>
+        </p:nvSpPr>
+        <p:spPr>
+          <a:xfrm>
+            <a:off x="411480" y="2788920"/>
+            <a:ext cx="5547208" cy="1143000"/>
+          </a:xfrm>
+          <a:prstGeom prst="roundRect">
+            <a:avLst>
+              <a:gd name="adj" fmla="val 6400"/>
+            </a:avLst>
+          </a:prstGeom>
+          <a:solidFill>
+            <a:srgbClr val="FFFFFF"/>
+          </a:solidFill>
+          <a:ln w="12700">
+            <a:solidFill>
+              <a:srgbClr val="E4E7EC"/>
+            </a:solidFill>
+            <a:prstDash val="solid"/>
+          </a:ln>
+        </p:spPr>
+      </p:sp>
+      <p:sp>
+        <p:nvSpPr>
+          <p:cNvPr id="10" name="Text 8"/>
+          <p:cNvSpPr/>
+          <p:nvPr/>
+        </p:nvSpPr>
+        <p:spPr>
+          <a:xfrm>
+            <a:off x="557784" y="2935224"/>
+            <a:ext cx="347472" cy="228600"/>
+          </a:xfrm>
+          <a:prstGeom prst="rect">
+            <a:avLst/>
+          </a:prstGeom>
+          <a:solidFill>
+            <a:srgbClr val="FCE7EC"/>
+          </a:solidFill>
+          <a:ln>
+            <a:solidFill>
+              <a:srgbClr val="FCE7EC"/>
+            </a:solidFill>
+          </a:ln>
+        </p:spPr>
+        <p:txBody>
+          <a:bodyPr wrap="square" lIns="0" tIns="0" rIns="0" bIns="0" rtlCol="0" anchor="ctr"/>
+          <a:lstStyle/>
+          <a:p>
+            <a:pPr algn="ctr" indent="0" marL="0">
+              <a:buNone/>
+            </a:pPr>
+            <a:r>
+              <a:rPr lang="en-US" sz="800" b="1" dirty="0">
+                <a:solidFill>
+                  <a:srgbClr val="DD0031"/>
+                </a:solidFill>
+              </a:rPr>
+              <a:t>01</a:t>
+            </a:r>
+            <a:endParaRPr lang="en-US" sz="800" dirty="0"/>
+          </a:p>
+        </p:txBody>
+      </p:sp>
+      <p:sp>
+        <p:nvSpPr>
+          <p:cNvPr id="11" name="Text 9"/>
+          <p:cNvSpPr/>
+          <p:nvPr/>
+        </p:nvSpPr>
+        <p:spPr>
+          <a:xfrm>
+            <a:off x="1033272" y="2953512"/>
+            <a:ext cx="4742536" cy="850392"/>
           </a:xfrm>
           <a:prstGeom prst="rect">
             <a:avLst/>
@@ -2036,33 +2610,105 @@
           <a:ln/>
         </p:spPr>
         <p:txBody>
-          <a:bodyPr wrap="square" lIns="127" tIns="127" rIns="127" bIns="127" rtlCol="0" anchor="ctr">
+          <a:bodyPr wrap="square" lIns="254" tIns="254" rIns="254" bIns="254" rtlCol="0" anchor="ctr">
             <a:normAutofit/>
           </a:bodyPr>
           <a:lstStyle/>
           <a:p>
-            <a:r>
-              <a:rPr lang="en-US" sz="1160" dirty="0">
+            <a:pPr indent="0" marL="0">
+              <a:buNone/>
+            </a:pPr>
+            <a:r>
+              <a:rPr lang="en-US" sz="1200" dirty="0">
                 <a:solidFill>
                   <a:srgbClr val="273043"/>
                 </a:solidFill>
               </a:rPr>
-              <a:t>Zone.js ne dit pas quel etat applicatif a change.</a:t>
-            </a:r>
-            <a:endParaRPr lang="en-US" sz="1160" dirty="0"/>
-          </a:p>
-        </p:txBody>
-      </p:sp>
-      <p:sp>
-        <p:nvSpPr>
-          <p:cNvPr id="8" name="Text 5"/>
-          <p:cNvSpPr/>
-          <p:nvPr/>
-        </p:nvSpPr>
-        <p:spPr>
-          <a:xfrm>
-            <a:off x="576072" y="1554480"/>
-            <a:ext cx="11204143" cy="256032"/>
+              <a:t>Zone.js declenche la detection apres un evenement async.</a:t>
+            </a:r>
+            <a:endParaRPr lang="en-US" sz="1200" dirty="0"/>
+          </a:p>
+        </p:txBody>
+      </p:sp>
+      <p:sp>
+        <p:nvSpPr>
+          <p:cNvPr id="12" name="Shape 10"/>
+          <p:cNvSpPr/>
+          <p:nvPr/>
+        </p:nvSpPr>
+        <p:spPr>
+          <a:xfrm>
+            <a:off x="6233008" y="2788920"/>
+            <a:ext cx="5547208" cy="1143000"/>
+          </a:xfrm>
+          <a:prstGeom prst="roundRect">
+            <a:avLst>
+              <a:gd name="adj" fmla="val 6400"/>
+            </a:avLst>
+          </a:prstGeom>
+          <a:solidFill>
+            <a:srgbClr val="FFFFFF"/>
+          </a:solidFill>
+          <a:ln w="12700">
+            <a:solidFill>
+              <a:srgbClr val="E4E7EC"/>
+            </a:solidFill>
+            <a:prstDash val="solid"/>
+          </a:ln>
+        </p:spPr>
+      </p:sp>
+      <p:sp>
+        <p:nvSpPr>
+          <p:cNvPr id="13" name="Text 11"/>
+          <p:cNvSpPr/>
+          <p:nvPr/>
+        </p:nvSpPr>
+        <p:spPr>
+          <a:xfrm>
+            <a:off x="6379312" y="2935224"/>
+            <a:ext cx="347472" cy="228600"/>
+          </a:xfrm>
+          <a:prstGeom prst="rect">
+            <a:avLst/>
+          </a:prstGeom>
+          <a:solidFill>
+            <a:srgbClr val="E8F1FF"/>
+          </a:solidFill>
+          <a:ln>
+            <a:solidFill>
+              <a:srgbClr val="E8F1FF"/>
+            </a:solidFill>
+          </a:ln>
+        </p:spPr>
+        <p:txBody>
+          <a:bodyPr wrap="square" lIns="0" tIns="0" rIns="0" bIns="0" rtlCol="0" anchor="ctr"/>
+          <a:lstStyle/>
+          <a:p>
+            <a:pPr algn="ctr" indent="0" marL="0">
+              <a:buNone/>
+            </a:pPr>
+            <a:r>
+              <a:rPr lang="en-US" sz="800" b="1" dirty="0">
+                <a:solidFill>
+                  <a:srgbClr val="1976D2"/>
+                </a:solidFill>
+              </a:rPr>
+              <a:t>02</a:t>
+            </a:r>
+            <a:endParaRPr lang="en-US" sz="800" dirty="0"/>
+          </a:p>
+        </p:txBody>
+      </p:sp>
+      <p:sp>
+        <p:nvSpPr>
+          <p:cNvPr id="14" name="Text 12"/>
+          <p:cNvSpPr/>
+          <p:nvPr/>
+        </p:nvSpPr>
+        <p:spPr>
+          <a:xfrm>
+            <a:off x="6854800" y="2953512"/>
+            <a:ext cx="4742536" cy="850392"/>
           </a:xfrm>
           <a:prstGeom prst="rect">
             <a:avLst/>
@@ -2071,33 +2717,105 @@
           <a:ln/>
         </p:spPr>
         <p:txBody>
-          <a:bodyPr wrap="square" lIns="127" tIns="127" rIns="127" bIns="127" rtlCol="0" anchor="ctr">
+          <a:bodyPr wrap="square" lIns="254" tIns="254" rIns="254" bIns="254" rtlCol="0" anchor="ctr">
             <a:normAutofit/>
           </a:bodyPr>
           <a:lstStyle/>
           <a:p>
-            <a:r>
-              <a:rPr lang="en-US" sz="1160" dirty="0">
+            <a:pPr indent="0" marL="0">
+              <a:buNone/>
+            </a:pPr>
+            <a:r>
+              <a:rPr lang="en-US" sz="1200" dirty="0">
                 <a:solidFill>
                   <a:srgbClr val="273043"/>
                 </a:solidFill>
               </a:rPr>
-              <a:t>Le dojo garde Zone.js pour montrer une migration progressive.</a:t>
-            </a:r>
-            <a:endParaRPr lang="en-US" sz="1160" dirty="0"/>
-          </a:p>
-        </p:txBody>
-      </p:sp>
-      <p:sp>
-        <p:nvSpPr>
-          <p:cNvPr id="9" name="Text 6"/>
-          <p:cNvSpPr/>
-          <p:nvPr/>
-        </p:nvSpPr>
-        <p:spPr>
-          <a:xfrm>
-            <a:off x="576072" y="1865376"/>
-            <a:ext cx="11204143" cy="256032"/>
+              <a:t>Zone.js ne dit pas quel etat applicatif a change.</a:t>
+            </a:r>
+            <a:endParaRPr lang="en-US" sz="1200" dirty="0"/>
+          </a:p>
+        </p:txBody>
+      </p:sp>
+      <p:sp>
+        <p:nvSpPr>
+          <p:cNvPr id="15" name="Shape 13"/>
+          <p:cNvSpPr/>
+          <p:nvPr/>
+        </p:nvSpPr>
+        <p:spPr>
+          <a:xfrm>
+            <a:off x="411480" y="4142232"/>
+            <a:ext cx="5547208" cy="1143000"/>
+          </a:xfrm>
+          <a:prstGeom prst="roundRect">
+            <a:avLst>
+              <a:gd name="adj" fmla="val 6400"/>
+            </a:avLst>
+          </a:prstGeom>
+          <a:solidFill>
+            <a:srgbClr val="FFFFFF"/>
+          </a:solidFill>
+          <a:ln w="12700">
+            <a:solidFill>
+              <a:srgbClr val="E4E7EC"/>
+            </a:solidFill>
+            <a:prstDash val="solid"/>
+          </a:ln>
+        </p:spPr>
+      </p:sp>
+      <p:sp>
+        <p:nvSpPr>
+          <p:cNvPr id="16" name="Text 14"/>
+          <p:cNvSpPr/>
+          <p:nvPr/>
+        </p:nvSpPr>
+        <p:spPr>
+          <a:xfrm>
+            <a:off x="557784" y="4288536"/>
+            <a:ext cx="347472" cy="228600"/>
+          </a:xfrm>
+          <a:prstGeom prst="rect">
+            <a:avLst/>
+          </a:prstGeom>
+          <a:solidFill>
+            <a:srgbClr val="EAF7F0"/>
+          </a:solidFill>
+          <a:ln>
+            <a:solidFill>
+              <a:srgbClr val="EAF7F0"/>
+            </a:solidFill>
+          </a:ln>
+        </p:spPr>
+        <p:txBody>
+          <a:bodyPr wrap="square" lIns="0" tIns="0" rIns="0" bIns="0" rtlCol="0" anchor="ctr"/>
+          <a:lstStyle/>
+          <a:p>
+            <a:pPr algn="ctr" indent="0" marL="0">
+              <a:buNone/>
+            </a:pPr>
+            <a:r>
+              <a:rPr lang="en-US" sz="800" b="1" dirty="0">
+                <a:solidFill>
+                  <a:srgbClr val="188038"/>
+                </a:solidFill>
+              </a:rPr>
+              <a:t>03</a:t>
+            </a:r>
+            <a:endParaRPr lang="en-US" sz="800" dirty="0"/>
+          </a:p>
+        </p:txBody>
+      </p:sp>
+      <p:sp>
+        <p:nvSpPr>
+          <p:cNvPr id="17" name="Text 15"/>
+          <p:cNvSpPr/>
+          <p:nvPr/>
+        </p:nvSpPr>
+        <p:spPr>
+          <a:xfrm>
+            <a:off x="1033272" y="4306824"/>
+            <a:ext cx="4742536" cy="850392"/>
           </a:xfrm>
           <a:prstGeom prst="rect">
             <a:avLst/>
@@ -2106,26 +2824,136 @@
           <a:ln/>
         </p:spPr>
         <p:txBody>
-          <a:bodyPr wrap="square" lIns="127" tIns="127" rIns="127" bIns="127" rtlCol="0" anchor="ctr">
+          <a:bodyPr wrap="square" lIns="254" tIns="254" rIns="254" bIns="254" rtlCol="0" anchor="ctr">
             <a:normAutofit/>
           </a:bodyPr>
           <a:lstStyle/>
           <a:p>
-            <a:r>
-              <a:rPr lang="en-US" sz="1160" dirty="0">
+            <a:pPr indent="0" marL="0">
+              <a:buNone/>
+            </a:pPr>
+            <a:r>
+              <a:rPr lang="en-US" sz="1200" dirty="0">
                 <a:solidFill>
                   <a:srgbClr val="273043"/>
                 </a:solidFill>
               </a:rPr>
+              <a:t>Le dojo garde Zone.js pour montrer une migration progressive.</a:t>
+            </a:r>
+            <a:endParaRPr lang="en-US" sz="1200" dirty="0"/>
+          </a:p>
+        </p:txBody>
+      </p:sp>
+      <p:sp>
+        <p:nvSpPr>
+          <p:cNvPr id="18" name="Shape 16"/>
+          <p:cNvSpPr/>
+          <p:nvPr/>
+        </p:nvSpPr>
+        <p:spPr>
+          <a:xfrm>
+            <a:off x="6233008" y="4142232"/>
+            <a:ext cx="5547208" cy="1143000"/>
+          </a:xfrm>
+          <a:prstGeom prst="roundRect">
+            <a:avLst>
+              <a:gd name="adj" fmla="val 6400"/>
+            </a:avLst>
+          </a:prstGeom>
+          <a:solidFill>
+            <a:srgbClr val="FFFFFF"/>
+          </a:solidFill>
+          <a:ln w="12700">
+            <a:solidFill>
+              <a:srgbClr val="E4E7EC"/>
+            </a:solidFill>
+            <a:prstDash val="solid"/>
+          </a:ln>
+        </p:spPr>
+      </p:sp>
+      <p:sp>
+        <p:nvSpPr>
+          <p:cNvPr id="19" name="Text 17"/>
+          <p:cNvSpPr/>
+          <p:nvPr/>
+        </p:nvSpPr>
+        <p:spPr>
+          <a:xfrm>
+            <a:off x="6379312" y="4288536"/>
+            <a:ext cx="347472" cy="228600"/>
+          </a:xfrm>
+          <a:prstGeom prst="rect">
+            <a:avLst/>
+          </a:prstGeom>
+          <a:solidFill>
+            <a:srgbClr val="F0ECFF"/>
+          </a:solidFill>
+          <a:ln>
+            <a:solidFill>
+              <a:srgbClr val="F0ECFF"/>
+            </a:solidFill>
+          </a:ln>
+        </p:spPr>
+        <p:txBody>
+          <a:bodyPr wrap="square" lIns="0" tIns="0" rIns="0" bIns="0" rtlCol="0" anchor="ctr"/>
+          <a:lstStyle/>
+          <a:p>
+            <a:pPr algn="ctr" indent="0" marL="0">
+              <a:buNone/>
+            </a:pPr>
+            <a:r>
+              <a:rPr lang="en-US" sz="800" b="1" dirty="0">
+                <a:solidFill>
+                  <a:srgbClr val="7B61FF"/>
+                </a:solidFill>
+              </a:rPr>
+              <a:t>04</a:t>
+            </a:r>
+            <a:endParaRPr lang="en-US" sz="800" dirty="0"/>
+          </a:p>
+        </p:txBody>
+      </p:sp>
+      <p:sp>
+        <p:nvSpPr>
+          <p:cNvPr id="20" name="Text 18"/>
+          <p:cNvSpPr/>
+          <p:nvPr/>
+        </p:nvSpPr>
+        <p:spPr>
+          <a:xfrm>
+            <a:off x="6854800" y="4306824"/>
+            <a:ext cx="4742536" cy="850392"/>
+          </a:xfrm>
+          <a:prstGeom prst="rect">
+            <a:avLst/>
+          </a:prstGeom>
+          <a:noFill/>
+          <a:ln/>
+        </p:spPr>
+        <p:txBody>
+          <a:bodyPr wrap="square" lIns="254" tIns="254" rIns="254" bIns="254" rtlCol="0" anchor="ctr">
+            <a:normAutofit/>
+          </a:bodyPr>
+          <a:lstStyle/>
+          <a:p>
+            <a:pPr indent="0" marL="0">
+              <a:buNone/>
+            </a:pPr>
+            <a:r>
+              <a:rPr lang="en-US" sz="1200" dirty="0">
+                <a:solidFill>
+                  <a:srgbClr val="273043"/>
+                </a:solidFill>
+              </a:rPr>
               <a:t>Les Signals rendent les dependances d'etat plus explicites.</a:t>
             </a:r>
-            <a:endParaRPr lang="en-US" sz="1160" dirty="0"/>
-          </a:p>
-        </p:txBody>
-      </p:sp>
-      <p:sp>
-        <p:nvSpPr>
-          <p:cNvPr id="10" name="Text 7"/>
+            <a:endParaRPr lang="en-US" sz="1200" dirty="0"/>
+          </a:p>
+        </p:txBody>
+      </p:sp>
+      <p:sp>
+        <p:nvSpPr>
+          <p:cNvPr id="21" name="Text 19"/>
           <p:cNvSpPr/>
           <p:nvPr/>
         </p:nvSpPr>
@@ -2298,14 +3126,66 @@
       </p:sp>
       <p:sp>
         <p:nvSpPr>
-          <p:cNvPr id="6" name="Text 3"/>
-          <p:cNvSpPr/>
-          <p:nvPr/>
-        </p:nvSpPr>
-        <p:spPr>
-          <a:xfrm>
-            <a:off x="576072" y="932688"/>
-            <a:ext cx="11204143" cy="256032"/>
+          <p:cNvPr id="5" name="Shape 3"/>
+          <p:cNvSpPr/>
+          <p:nvPr/>
+        </p:nvSpPr>
+        <p:spPr>
+          <a:xfrm>
+            <a:off x="411480" y="960120"/>
+            <a:ext cx="11368735" cy="1207008"/>
+          </a:xfrm>
+          <a:prstGeom prst="roundRect">
+            <a:avLst>
+              <a:gd name="adj" fmla="val 6061"/>
+            </a:avLst>
+          </a:prstGeom>
+          <a:solidFill>
+            <a:srgbClr val="FFFFFF"/>
+          </a:solidFill>
+          <a:ln w="12700">
+            <a:solidFill>
+              <a:srgbClr val="E4E7EC"/>
+            </a:solidFill>
+            <a:prstDash val="solid"/>
+          </a:ln>
+        </p:spPr>
+      </p:sp>
+      <p:sp>
+        <p:nvSpPr>
+          <p:cNvPr id="6" name="Shape 4"/>
+          <p:cNvSpPr/>
+          <p:nvPr/>
+        </p:nvSpPr>
+        <p:spPr>
+          <a:xfrm>
+            <a:off x="411480" y="960120"/>
+            <a:ext cx="109728" cy="1207008"/>
+          </a:xfrm>
+          <a:prstGeom prst="rect">
+            <a:avLst/>
+          </a:prstGeom>
+          <a:solidFill>
+            <a:srgbClr val="DD0031"/>
+          </a:solidFill>
+          <a:ln w="12700">
+            <a:solidFill>
+              <a:srgbClr val="DD0031"/>
+            </a:solidFill>
+            <a:prstDash val="solid"/>
+          </a:ln>
+        </p:spPr>
+      </p:sp>
+      <p:sp>
+        <p:nvSpPr>
+          <p:cNvPr id="7" name="Text 5"/>
+          <p:cNvSpPr/>
+          <p:nvPr/>
+        </p:nvSpPr>
+        <p:spPr>
+          <a:xfrm>
+            <a:off x="667512" y="1115568"/>
+            <a:ext cx="1143000" cy="228600"/>
           </a:xfrm>
           <a:prstGeom prst="rect">
             <a:avLst/>
@@ -2314,33 +3194,141 @@
           <a:ln/>
         </p:spPr>
         <p:txBody>
-          <a:bodyPr wrap="square" lIns="127" tIns="127" rIns="127" bIns="127" rtlCol="0" anchor="ctr">
+          <a:bodyPr wrap="square" lIns="0" tIns="0" rIns="0" bIns="0" rtlCol="0" anchor="ctr"/>
+          <a:lstStyle/>
+          <a:p>
+            <a:pPr indent="0" marL="0">
+              <a:buNone/>
+            </a:pPr>
+            <a:r>
+              <a:rPr lang="en-US" sz="900" b="1" dirty="0">
+                <a:solidFill>
+                  <a:srgbClr val="DD0031"/>
+                </a:solidFill>
+              </a:rPr>
+              <a:t>Définition</a:t>
+            </a:r>
+            <a:endParaRPr lang="en-US" sz="900" dirty="0"/>
+          </a:p>
+        </p:txBody>
+      </p:sp>
+      <p:sp>
+        <p:nvSpPr>
+          <p:cNvPr id="8" name="Text 6"/>
+          <p:cNvSpPr/>
+          <p:nvPr/>
+        </p:nvSpPr>
+        <p:spPr>
+          <a:xfrm>
+            <a:off x="1892808" y="1078992"/>
+            <a:ext cx="9631375" cy="786384"/>
+          </a:xfrm>
+          <a:prstGeom prst="rect">
+            <a:avLst/>
+          </a:prstGeom>
+          <a:noFill/>
+          <a:ln/>
+        </p:spPr>
+        <p:txBody>
+          <a:bodyPr wrap="square" lIns="254" tIns="254" rIns="254" bIns="254" rtlCol="0" anchor="ctr">
             <a:normAutofit/>
           </a:bodyPr>
           <a:lstStyle/>
           <a:p>
-            <a:r>
-              <a:rPr lang="en-US" sz="1160" dirty="0">
+            <a:pPr indent="0" marL="0">
+              <a:buNone/>
+            </a:pPr>
+            <a:r>
+              <a:rPr lang="en-US" sz="1500" dirty="0">
                 <a:solidFill>
                   <a:srgbClr val="273043"/>
                 </a:solidFill>
               </a:rPr>
-              <a:t>RxJS reste adapte aux flux asynchrones.</a:t>
-            </a:r>
-            <a:endParaRPr lang="en-US" sz="1160" dirty="0"/>
-          </a:p>
-        </p:txBody>
-      </p:sp>
-      <p:sp>
-        <p:nvSpPr>
-          <p:cNvPr id="7" name="Text 4"/>
-          <p:cNvSpPr/>
-          <p:nvPr/>
-        </p:nvSpPr>
-        <p:spPr>
-          <a:xfrm>
-            <a:off x="576072" y="1243584"/>
-            <a:ext cx="11204143" cy="256032"/>
+              <a:t>RxJS sert a modeliser des flux dans le temps : HTTP, route params, evenements, debounceTime, switchMap, combineLatest.</a:t>
+            </a:r>
+            <a:endParaRPr lang="en-US" sz="1500" dirty="0"/>
+          </a:p>
+        </p:txBody>
+      </p:sp>
+      <p:sp>
+        <p:nvSpPr>
+          <p:cNvPr id="9" name="Shape 7"/>
+          <p:cNvSpPr/>
+          <p:nvPr/>
+        </p:nvSpPr>
+        <p:spPr>
+          <a:xfrm>
+            <a:off x="411480" y="2788920"/>
+            <a:ext cx="5547208" cy="1143000"/>
+          </a:xfrm>
+          <a:prstGeom prst="roundRect">
+            <a:avLst>
+              <a:gd name="adj" fmla="val 6400"/>
+            </a:avLst>
+          </a:prstGeom>
+          <a:solidFill>
+            <a:srgbClr val="FFFFFF"/>
+          </a:solidFill>
+          <a:ln w="12700">
+            <a:solidFill>
+              <a:srgbClr val="E4E7EC"/>
+            </a:solidFill>
+            <a:prstDash val="solid"/>
+          </a:ln>
+        </p:spPr>
+      </p:sp>
+      <p:sp>
+        <p:nvSpPr>
+          <p:cNvPr id="10" name="Text 8"/>
+          <p:cNvSpPr/>
+          <p:nvPr/>
+        </p:nvSpPr>
+        <p:spPr>
+          <a:xfrm>
+            <a:off x="557784" y="2935224"/>
+            <a:ext cx="347472" cy="228600"/>
+          </a:xfrm>
+          <a:prstGeom prst="rect">
+            <a:avLst/>
+          </a:prstGeom>
+          <a:solidFill>
+            <a:srgbClr val="FCE7EC"/>
+          </a:solidFill>
+          <a:ln>
+            <a:solidFill>
+              <a:srgbClr val="FCE7EC"/>
+            </a:solidFill>
+          </a:ln>
+        </p:spPr>
+        <p:txBody>
+          <a:bodyPr wrap="square" lIns="0" tIns="0" rIns="0" bIns="0" rtlCol="0" anchor="ctr"/>
+          <a:lstStyle/>
+          <a:p>
+            <a:pPr algn="ctr" indent="0" marL="0">
+              <a:buNone/>
+            </a:pPr>
+            <a:r>
+              <a:rPr lang="en-US" sz="800" b="1" dirty="0">
+                <a:solidFill>
+                  <a:srgbClr val="DD0031"/>
+                </a:solidFill>
+              </a:rPr>
+              <a:t>01</a:t>
+            </a:r>
+            <a:endParaRPr lang="en-US" sz="800" dirty="0"/>
+          </a:p>
+        </p:txBody>
+      </p:sp>
+      <p:sp>
+        <p:nvSpPr>
+          <p:cNvPr id="11" name="Text 9"/>
+          <p:cNvSpPr/>
+          <p:nvPr/>
+        </p:nvSpPr>
+        <p:spPr>
+          <a:xfrm>
+            <a:off x="1033272" y="2953512"/>
+            <a:ext cx="4742536" cy="850392"/>
           </a:xfrm>
           <a:prstGeom prst="rect">
             <a:avLst/>
@@ -2349,33 +3337,105 @@
           <a:ln/>
         </p:spPr>
         <p:txBody>
-          <a:bodyPr wrap="square" lIns="127" tIns="127" rIns="127" bIns="127" rtlCol="0" anchor="ctr">
+          <a:bodyPr wrap="square" lIns="254" tIns="254" rIns="254" bIns="254" rtlCol="0" anchor="ctr">
             <a:normAutofit/>
           </a:bodyPr>
           <a:lstStyle/>
           <a:p>
-            <a:r>
-              <a:rPr lang="en-US" sz="1160" dirty="0">
+            <a:pPr indent="0" marL="0">
+              <a:buNone/>
+            </a:pPr>
+            <a:r>
+              <a:rPr lang="en-US" sz="1200" dirty="0">
                 <a:solidFill>
                   <a:srgbClr val="273043"/>
                 </a:solidFill>
               </a:rPr>
-              <a:t>toSignal() expose la derniere valeur d'un Observable comme signal.</a:t>
-            </a:r>
-            <a:endParaRPr lang="en-US" sz="1160" dirty="0"/>
-          </a:p>
-        </p:txBody>
-      </p:sp>
-      <p:sp>
-        <p:nvSpPr>
-          <p:cNvPr id="8" name="Text 5"/>
-          <p:cNvSpPr/>
-          <p:nvPr/>
-        </p:nvSpPr>
-        <p:spPr>
-          <a:xfrm>
-            <a:off x="576072" y="1554480"/>
-            <a:ext cx="11204143" cy="256032"/>
+              <a:t>RxJS reste adapte aux flux asynchrones.</a:t>
+            </a:r>
+            <a:endParaRPr lang="en-US" sz="1200" dirty="0"/>
+          </a:p>
+        </p:txBody>
+      </p:sp>
+      <p:sp>
+        <p:nvSpPr>
+          <p:cNvPr id="12" name="Shape 10"/>
+          <p:cNvSpPr/>
+          <p:nvPr/>
+        </p:nvSpPr>
+        <p:spPr>
+          <a:xfrm>
+            <a:off x="6233008" y="2788920"/>
+            <a:ext cx="5547208" cy="1143000"/>
+          </a:xfrm>
+          <a:prstGeom prst="roundRect">
+            <a:avLst>
+              <a:gd name="adj" fmla="val 6400"/>
+            </a:avLst>
+          </a:prstGeom>
+          <a:solidFill>
+            <a:srgbClr val="FFFFFF"/>
+          </a:solidFill>
+          <a:ln w="12700">
+            <a:solidFill>
+              <a:srgbClr val="E4E7EC"/>
+            </a:solidFill>
+            <a:prstDash val="solid"/>
+          </a:ln>
+        </p:spPr>
+      </p:sp>
+      <p:sp>
+        <p:nvSpPr>
+          <p:cNvPr id="13" name="Text 11"/>
+          <p:cNvSpPr/>
+          <p:nvPr/>
+        </p:nvSpPr>
+        <p:spPr>
+          <a:xfrm>
+            <a:off x="6379312" y="2935224"/>
+            <a:ext cx="347472" cy="228600"/>
+          </a:xfrm>
+          <a:prstGeom prst="rect">
+            <a:avLst/>
+          </a:prstGeom>
+          <a:solidFill>
+            <a:srgbClr val="E8F1FF"/>
+          </a:solidFill>
+          <a:ln>
+            <a:solidFill>
+              <a:srgbClr val="E8F1FF"/>
+            </a:solidFill>
+          </a:ln>
+        </p:spPr>
+        <p:txBody>
+          <a:bodyPr wrap="square" lIns="0" tIns="0" rIns="0" bIns="0" rtlCol="0" anchor="ctr"/>
+          <a:lstStyle/>
+          <a:p>
+            <a:pPr algn="ctr" indent="0" marL="0">
+              <a:buNone/>
+            </a:pPr>
+            <a:r>
+              <a:rPr lang="en-US" sz="800" b="1" dirty="0">
+                <a:solidFill>
+                  <a:srgbClr val="1976D2"/>
+                </a:solidFill>
+              </a:rPr>
+              <a:t>02</a:t>
+            </a:r>
+            <a:endParaRPr lang="en-US" sz="800" dirty="0"/>
+          </a:p>
+        </p:txBody>
+      </p:sp>
+      <p:sp>
+        <p:nvSpPr>
+          <p:cNvPr id="14" name="Text 12"/>
+          <p:cNvSpPr/>
+          <p:nvPr/>
+        </p:nvSpPr>
+        <p:spPr>
+          <a:xfrm>
+            <a:off x="6854800" y="2953512"/>
+            <a:ext cx="4742536" cy="850392"/>
           </a:xfrm>
           <a:prstGeom prst="rect">
             <a:avLst/>
@@ -2384,33 +3444,105 @@
           <a:ln/>
         </p:spPr>
         <p:txBody>
-          <a:bodyPr wrap="square" lIns="127" tIns="127" rIns="127" bIns="127" rtlCol="0" anchor="ctr">
+          <a:bodyPr wrap="square" lIns="254" tIns="254" rIns="254" bIns="254" rtlCol="0" anchor="ctr">
             <a:normAutofit/>
           </a:bodyPr>
           <a:lstStyle/>
           <a:p>
-            <a:r>
-              <a:rPr lang="en-US" sz="1160" dirty="0">
+            <a:pPr indent="0" marL="0">
+              <a:buNone/>
+            </a:pPr>
+            <a:r>
+              <a:rPr lang="en-US" sz="1200" dirty="0">
                 <a:solidFill>
                   <a:srgbClr val="273043"/>
                 </a:solidFill>
               </a:rPr>
-              <a:t>toObservable() expose un signal comme Observable.</a:t>
-            </a:r>
-            <a:endParaRPr lang="en-US" sz="1160" dirty="0"/>
-          </a:p>
-        </p:txBody>
-      </p:sp>
-      <p:sp>
-        <p:nvSpPr>
-          <p:cNvPr id="9" name="Text 6"/>
-          <p:cNvSpPr/>
-          <p:nvPr/>
-        </p:nvSpPr>
-        <p:spPr>
-          <a:xfrm>
-            <a:off x="576072" y="1865376"/>
-            <a:ext cx="11204143" cy="256032"/>
+              <a:t>toSignal() expose la derniere valeur d'un Observable comme signal.</a:t>
+            </a:r>
+            <a:endParaRPr lang="en-US" sz="1200" dirty="0"/>
+          </a:p>
+        </p:txBody>
+      </p:sp>
+      <p:sp>
+        <p:nvSpPr>
+          <p:cNvPr id="15" name="Shape 13"/>
+          <p:cNvSpPr/>
+          <p:nvPr/>
+        </p:nvSpPr>
+        <p:spPr>
+          <a:xfrm>
+            <a:off x="411480" y="4142232"/>
+            <a:ext cx="5547208" cy="1143000"/>
+          </a:xfrm>
+          <a:prstGeom prst="roundRect">
+            <a:avLst>
+              <a:gd name="adj" fmla="val 6400"/>
+            </a:avLst>
+          </a:prstGeom>
+          <a:solidFill>
+            <a:srgbClr val="FFFFFF"/>
+          </a:solidFill>
+          <a:ln w="12700">
+            <a:solidFill>
+              <a:srgbClr val="E4E7EC"/>
+            </a:solidFill>
+            <a:prstDash val="solid"/>
+          </a:ln>
+        </p:spPr>
+      </p:sp>
+      <p:sp>
+        <p:nvSpPr>
+          <p:cNvPr id="16" name="Text 14"/>
+          <p:cNvSpPr/>
+          <p:nvPr/>
+        </p:nvSpPr>
+        <p:spPr>
+          <a:xfrm>
+            <a:off x="557784" y="4288536"/>
+            <a:ext cx="347472" cy="228600"/>
+          </a:xfrm>
+          <a:prstGeom prst="rect">
+            <a:avLst/>
+          </a:prstGeom>
+          <a:solidFill>
+            <a:srgbClr val="EAF7F0"/>
+          </a:solidFill>
+          <a:ln>
+            <a:solidFill>
+              <a:srgbClr val="EAF7F0"/>
+            </a:solidFill>
+          </a:ln>
+        </p:spPr>
+        <p:txBody>
+          <a:bodyPr wrap="square" lIns="0" tIns="0" rIns="0" bIns="0" rtlCol="0" anchor="ctr"/>
+          <a:lstStyle/>
+          <a:p>
+            <a:pPr algn="ctr" indent="0" marL="0">
+              <a:buNone/>
+            </a:pPr>
+            <a:r>
+              <a:rPr lang="en-US" sz="800" b="1" dirty="0">
+                <a:solidFill>
+                  <a:srgbClr val="188038"/>
+                </a:solidFill>
+              </a:rPr>
+              <a:t>03</a:t>
+            </a:r>
+            <a:endParaRPr lang="en-US" sz="800" dirty="0"/>
+          </a:p>
+        </p:txBody>
+      </p:sp>
+      <p:sp>
+        <p:nvSpPr>
+          <p:cNvPr id="17" name="Text 15"/>
+          <p:cNvSpPr/>
+          <p:nvPr/>
+        </p:nvSpPr>
+        <p:spPr>
+          <a:xfrm>
+            <a:off x="1033272" y="4306824"/>
+            <a:ext cx="4742536" cy="850392"/>
           </a:xfrm>
           <a:prstGeom prst="rect">
             <a:avLst/>
@@ -2419,26 +3551,136 @@
           <a:ln/>
         </p:spPr>
         <p:txBody>
-          <a:bodyPr wrap="square" lIns="127" tIns="127" rIns="127" bIns="127" rtlCol="0" anchor="ctr">
+          <a:bodyPr wrap="square" lIns="254" tIns="254" rIns="254" bIns="254" rtlCol="0" anchor="ctr">
             <a:normAutofit/>
           </a:bodyPr>
           <a:lstStyle/>
           <a:p>
-            <a:r>
-              <a:rPr lang="en-US" sz="1160" dirty="0">
+            <a:pPr indent="0" marL="0">
+              <a:buNone/>
+            </a:pPr>
+            <a:r>
+              <a:rPr lang="en-US" sz="1200" dirty="0">
                 <a:solidFill>
                   <a:srgbClr val="273043"/>
                 </a:solidFill>
               </a:rPr>
+              <a:t>toObservable() expose un signal comme Observable.</a:t>
+            </a:r>
+            <a:endParaRPr lang="en-US" sz="1200" dirty="0"/>
+          </a:p>
+        </p:txBody>
+      </p:sp>
+      <p:sp>
+        <p:nvSpPr>
+          <p:cNvPr id="18" name="Shape 16"/>
+          <p:cNvSpPr/>
+          <p:nvPr/>
+        </p:nvSpPr>
+        <p:spPr>
+          <a:xfrm>
+            <a:off x="6233008" y="4142232"/>
+            <a:ext cx="5547208" cy="1143000"/>
+          </a:xfrm>
+          <a:prstGeom prst="roundRect">
+            <a:avLst>
+              <a:gd name="adj" fmla="val 6400"/>
+            </a:avLst>
+          </a:prstGeom>
+          <a:solidFill>
+            <a:srgbClr val="FFFFFF"/>
+          </a:solidFill>
+          <a:ln w="12700">
+            <a:solidFill>
+              <a:srgbClr val="E4E7EC"/>
+            </a:solidFill>
+            <a:prstDash val="solid"/>
+          </a:ln>
+        </p:spPr>
+      </p:sp>
+      <p:sp>
+        <p:nvSpPr>
+          <p:cNvPr id="19" name="Text 17"/>
+          <p:cNvSpPr/>
+          <p:nvPr/>
+        </p:nvSpPr>
+        <p:spPr>
+          <a:xfrm>
+            <a:off x="6379312" y="4288536"/>
+            <a:ext cx="347472" cy="228600"/>
+          </a:xfrm>
+          <a:prstGeom prst="rect">
+            <a:avLst/>
+          </a:prstGeom>
+          <a:solidFill>
+            <a:srgbClr val="F0ECFF"/>
+          </a:solidFill>
+          <a:ln>
+            <a:solidFill>
+              <a:srgbClr val="F0ECFF"/>
+            </a:solidFill>
+          </a:ln>
+        </p:spPr>
+        <p:txBody>
+          <a:bodyPr wrap="square" lIns="0" tIns="0" rIns="0" bIns="0" rtlCol="0" anchor="ctr"/>
+          <a:lstStyle/>
+          <a:p>
+            <a:pPr algn="ctr" indent="0" marL="0">
+              <a:buNone/>
+            </a:pPr>
+            <a:r>
+              <a:rPr lang="en-US" sz="800" b="1" dirty="0">
+                <a:solidFill>
+                  <a:srgbClr val="7B61FF"/>
+                </a:solidFill>
+              </a:rPr>
+              <a:t>04</a:t>
+            </a:r>
+            <a:endParaRPr lang="en-US" sz="800" dirty="0"/>
+          </a:p>
+        </p:txBody>
+      </p:sp>
+      <p:sp>
+        <p:nvSpPr>
+          <p:cNvPr id="20" name="Text 18"/>
+          <p:cNvSpPr/>
+          <p:nvPr/>
+        </p:nvSpPr>
+        <p:spPr>
+          <a:xfrm>
+            <a:off x="6854800" y="4306824"/>
+            <a:ext cx="4742536" cy="850392"/>
+          </a:xfrm>
+          <a:prstGeom prst="rect">
+            <a:avLst/>
+          </a:prstGeom>
+          <a:noFill/>
+          <a:ln/>
+        </p:spPr>
+        <p:txBody>
+          <a:bodyPr wrap="square" lIns="254" tIns="254" rIns="254" bIns="254" rtlCol="0" anchor="ctr">
+            <a:normAutofit/>
+          </a:bodyPr>
+          <a:lstStyle/>
+          <a:p>
+            <a:pPr indent="0" marL="0">
+              <a:buNone/>
+            </a:pPr>
+            <a:r>
+              <a:rPr lang="en-US" sz="1200" dirty="0">
+                <a:solidFill>
+                  <a:srgbClr val="273043"/>
+                </a:solidFill>
+              </a:rPr>
               <a:t>Le but est de placer clairement la frontiere entre flux RxJS et etat signal.</a:t>
             </a:r>
-            <a:endParaRPr lang="en-US" sz="1160" dirty="0"/>
-          </a:p>
-        </p:txBody>
-      </p:sp>
-      <p:sp>
-        <p:nvSpPr>
-          <p:cNvPr id="10" name="Text 7"/>
+            <a:endParaRPr lang="en-US" sz="1200" dirty="0"/>
+          </a:p>
+        </p:txBody>
+      </p:sp>
+      <p:sp>
+        <p:nvSpPr>
+          <p:cNvPr id="21" name="Text 19"/>
           <p:cNvSpPr/>
           <p:nvPr/>
         </p:nvSpPr>
@@ -5122,14 +6364,41 @@
       </p:sp>
       <p:sp>
         <p:nvSpPr>
-          <p:cNvPr id="53" name="Text 51"/>
-          <p:cNvSpPr/>
-          <p:nvPr/>
-        </p:nvSpPr>
-        <p:spPr>
-          <a:xfrm>
-            <a:off x="411480" y="6144768"/>
-            <a:ext cx="11368735" cy="256032"/>
+          <p:cNvPr id="53" name="Shape 51"/>
+          <p:cNvSpPr/>
+          <p:nvPr/>
+        </p:nvSpPr>
+        <p:spPr>
+          <a:xfrm>
+            <a:off x="411480" y="5989320"/>
+            <a:ext cx="11368735" cy="384048"/>
+          </a:xfrm>
+          <a:prstGeom prst="roundRect">
+            <a:avLst>
+              <a:gd name="adj" fmla="val 14286"/>
+            </a:avLst>
+          </a:prstGeom>
+          <a:solidFill>
+            <a:srgbClr val="EAF7F0"/>
+          </a:solidFill>
+          <a:ln w="12700">
+            <a:solidFill>
+              <a:srgbClr val="B7E4C7"/>
+            </a:solidFill>
+            <a:prstDash val="solid"/>
+          </a:ln>
+        </p:spPr>
+      </p:sp>
+      <p:sp>
+        <p:nvSpPr>
+          <p:cNvPr id="54" name="Text 52"/>
+          <p:cNvSpPr/>
+          <p:nvPr/>
+        </p:nvSpPr>
+        <p:spPr>
+          <a:xfrm>
+            <a:off x="576072" y="6080760"/>
+            <a:ext cx="11039551" cy="173736"/>
           </a:xfrm>
           <a:prstGeom prst="rect">
             <a:avLst/>
@@ -5147,20 +6416,20 @@
               <a:buNone/>
             </a:pPr>
             <a:r>
-              <a:rPr lang="en-US" sz="720" i="1" dirty="0">
-                <a:solidFill>
-                  <a:srgbClr val="667085"/>
-                </a:solidFill>
-              </a:rPr>
-              <a:t>Les tests ne sont pas l'objectif principal du dojo. S'ils echouent a cause de la migration demandee, les ajuster pour refleter le nouveau comportement.</a:t>
-            </a:r>
-            <a:endParaRPr lang="en-US" sz="720" dirty="0"/>
-          </a:p>
-        </p:txBody>
-      </p:sp>
-      <p:sp>
-        <p:nvSpPr>
-          <p:cNvPr id="54" name="Text 52"/>
+              <a:rPr lang="en-US" sz="780" b="1" dirty="0">
+                <a:solidFill>
+                  <a:srgbClr val="273043"/>
+                </a:solidFill>
+              </a:rPr>
+              <a:t>Rappel tests : les tests ne sont pas l'objectif principal du dojo. S'ils echouent a cause de la migration demandee, corriger les erreurs pour refleter le nouveau comportement.</a:t>
+            </a:r>
+            <a:endParaRPr lang="en-US" sz="780" dirty="0"/>
+          </a:p>
+        </p:txBody>
+      </p:sp>
+      <p:sp>
+        <p:nvSpPr>
+          <p:cNvPr id="55" name="Text 53"/>
           <p:cNvSpPr/>
           <p:nvPr/>
         </p:nvSpPr>

</xml_diff>

<commit_message>
restructure rappels et tests pptx
</commit_message>
<xml_diff>
--- a/docs/dojo-signals.pptx
+++ b/docs/dojo-signals.pptx
@@ -11,9 +11,10 @@
     <p:sldId id="259" r:id="rId5"/>
     <p:sldId id="260" r:id="rId6"/>
     <p:sldId id="261" r:id="rId7"/>
+    <p:sldId id="262" r:id="rId8"/>
   </p:sldIdLst>
   <p:notesMasterIdLst>
-    <p:notesMasterId r:id="rId8"/>
+    <p:notesMasterId r:id="rId9"/>
   </p:notesMasterIdLst>
   <p:sldSz cx="12192000" cy="6858000"/>
   <p:notesSz cx="6858000" cy="12192000"/>
@@ -989,6 +990,94 @@
 </p:notes>
 </file>
 
+<file path=ppt/notesSlides/notesSlide7.xml><?xml version="1.0" encoding="utf-8"?>
+<p:notes xmlns:a="http://schemas.openxmlformats.org/drawingml/2006/main" xmlns:r="http://schemas.openxmlformats.org/officeDocument/2006/relationships" xmlns:p="http://schemas.openxmlformats.org/presentationml/2006/main">
+  <p:cSld>
+    <p:spTree>
+      <p:nvGrpSpPr>
+        <p:cNvPr id="1" name=""/>
+        <p:cNvGrpSpPr/>
+        <p:nvPr/>
+      </p:nvGrpSpPr>
+      <p:grpSpPr>
+        <a:xfrm>
+          <a:off x="0" y="0"/>
+          <a:ext cx="0" cy="0"/>
+          <a:chOff x="0" y="0"/>
+          <a:chExt cx="0" cy="0"/>
+        </a:xfrm>
+      </p:grpSpPr>
+      <p:sp>
+        <p:nvSpPr>
+          <p:cNvPr id="2" name="Slide Image Placeholder 1"/>
+          <p:cNvSpPr>
+            <a:spLocks noGrp="1" noRot="1" noChangeAspect="1"/>
+          </p:cNvSpPr>
+          <p:nvPr>
+            <p:ph type="sldImg"/>
+          </p:nvPr>
+        </p:nvSpPr>
+        <p:spPr/>
+      </p:sp>
+      <p:sp>
+        <p:nvSpPr>
+          <p:cNvPr id="3" name="Notes Placeholder 2"/>
+          <p:cNvSpPr>
+            <a:spLocks noGrp="1"/>
+          </p:cNvSpPr>
+          <p:nvPr>
+            <p:ph type="body" idx="1"/>
+          </p:nvPr>
+        </p:nvSpPr>
+        <p:spPr/>
+        <p:txBody>
+          <a:bodyPr/>
+          <a:lstStyle/>
+          <a:p>
+            <a:r>
+              <a:rPr lang="en-US" dirty="0"/>
+              <a:t/>
+            </a:r>
+            <a:endParaRPr lang="en-US" dirty="0"/>
+          </a:p>
+        </p:txBody>
+      </p:sp>
+      <p:sp>
+        <p:nvSpPr>
+          <p:cNvPr id="4" name="Slide Number Placeholder 3"/>
+          <p:cNvSpPr>
+            <a:spLocks noGrp="1"/>
+          </p:cNvSpPr>
+          <p:nvPr>
+            <p:ph type="sldNum" sz="quarter" idx="10"/>
+          </p:nvPr>
+        </p:nvSpPr>
+        <p:spPr/>
+        <p:txBody>
+          <a:bodyPr/>
+          <a:lstStyle/>
+          <a:p>
+            <a:fld id="{F7021451-1387-4CA6-816F-3879F97B5CBC}" type="slidenum">
+              <a:rPr lang="en-US"/>
+              <a:t>7</a:t>
+            </a:fld>
+            <a:endParaRPr lang="en-US"/>
+          </a:p>
+        </p:txBody>
+      </p:sp>
+    </p:spTree>
+    <p:extLst>
+      <p:ext uri="{BB962C8B-B14F-4D97-AF65-F5344CB8AC3E}">
+        <p14:creationId xmlns:p14="http://schemas.microsoft.com/office/powerpoint/2010/main" val="1024086991"/>
+      </p:ext>
+    </p:extLst>
+  </p:cSld>
+  <p:clrMapOvr>
+    <a:masterClrMapping/>
+  </p:clrMapOvr>
+</p:notes>
+</file>
+
 <file path=ppt/slideLayouts/slideLayout1.xml><?xml version="1.0" encoding="utf-8"?>
 <p:sldLayout xmlns:a="http://schemas.openxmlformats.org/drawingml/2006/main" xmlns:r="http://schemas.openxmlformats.org/officeDocument/2006/relationships" xmlns:p="http://schemas.openxmlformats.org/presentationml/2006/main" preserve="1">
   <p:cSld name="DEFAULT">
@@ -1527,7 +1616,7 @@
                   <a:srgbClr val="667085"/>
                 </a:solidFill>
               </a:rPr>
-              <a:t>1/6</a:t>
+              <a:t>1/7</a:t>
             </a:r>
             <a:endParaRPr lang="en-US" sz="700" dirty="0"/>
           </a:p>
@@ -1679,11 +1768,188 @@
         <p:spPr>
           <a:xfrm>
             <a:off x="411480" y="960120"/>
-            <a:ext cx="11368735" cy="1207008"/>
+            <a:ext cx="3794760" cy="5212080"/>
           </a:xfrm>
           <a:prstGeom prst="roundRect">
             <a:avLst>
-              <a:gd name="adj" fmla="val 6061"/>
+              <a:gd name="adj" fmla="val 1928"/>
+            </a:avLst>
+          </a:prstGeom>
+          <a:solidFill>
+            <a:srgbClr val="FCE7EC"/>
+          </a:solidFill>
+          <a:ln w="12700">
+            <a:solidFill>
+              <a:srgbClr val="FCE7EC"/>
+            </a:solidFill>
+            <a:prstDash val="solid"/>
+          </a:ln>
+        </p:spPr>
+      </p:sp>
+      <p:sp>
+        <p:nvSpPr>
+          <p:cNvPr id="6" name="Text 4"/>
+          <p:cNvSpPr/>
+          <p:nvPr/>
+        </p:nvSpPr>
+        <p:spPr>
+          <a:xfrm>
+            <a:off x="704088" y="1234440"/>
+            <a:ext cx="3154680" cy="457200"/>
+          </a:xfrm>
+          <a:prstGeom prst="rect">
+            <a:avLst/>
+          </a:prstGeom>
+          <a:noFill/>
+          <a:ln/>
+        </p:spPr>
+        <p:txBody>
+          <a:bodyPr wrap="square" lIns="0" tIns="0" rIns="0" bIns="0" rtlCol="0" anchor="ctr">
+            <a:normAutofit/>
+          </a:bodyPr>
+          <a:lstStyle/>
+          <a:p>
+            <a:pPr indent="0" marL="0">
+              <a:buNone/>
+            </a:pPr>
+            <a:r>
+              <a:rPr lang="en-US" sz="2600" b="1" dirty="0">
+                <a:solidFill>
+                  <a:srgbClr val="DD0031"/>
+                </a:solidFill>
+              </a:rPr>
+              <a:t>Signal</a:t>
+            </a:r>
+            <a:endParaRPr lang="en-US" sz="2600" dirty="0"/>
+          </a:p>
+        </p:txBody>
+      </p:sp>
+      <p:sp>
+        <p:nvSpPr>
+          <p:cNvPr id="7" name="Text 5"/>
+          <p:cNvSpPr/>
+          <p:nvPr/>
+        </p:nvSpPr>
+        <p:spPr>
+          <a:xfrm>
+            <a:off x="704088" y="1993392"/>
+            <a:ext cx="3127248" cy="2148840"/>
+          </a:xfrm>
+          <a:prstGeom prst="rect">
+            <a:avLst/>
+          </a:prstGeom>
+          <a:noFill/>
+          <a:ln/>
+        </p:spPr>
+        <p:txBody>
+          <a:bodyPr wrap="square" lIns="381" tIns="381" rIns="381" bIns="381" rtlCol="0" anchor="ctr">
+            <a:normAutofit/>
+          </a:bodyPr>
+          <a:lstStyle/>
+          <a:p>
+            <a:pPr indent="0" marL="0">
+              <a:buNone/>
+            </a:pPr>
+            <a:r>
+              <a:rPr lang="en-US" sz="1700" b="1" dirty="0">
+                <a:solidFill>
+                  <a:srgbClr val="202124"/>
+                </a:solidFill>
+              </a:rPr>
+              <a:t>Un signal est une valeur reactive lue avec (). Quand sa valeur change, Angular sait quelles lectures dependent de cette valeur.</a:t>
+            </a:r>
+            <a:endParaRPr lang="en-US" sz="1700" dirty="0"/>
+          </a:p>
+        </p:txBody>
+      </p:sp>
+      <p:sp>
+        <p:nvSpPr>
+          <p:cNvPr id="8" name="Text 6"/>
+          <p:cNvSpPr/>
+          <p:nvPr/>
+        </p:nvSpPr>
+        <p:spPr>
+          <a:xfrm>
+            <a:off x="704088" y="4800600"/>
+            <a:ext cx="1188720" cy="182880"/>
+          </a:xfrm>
+          <a:prstGeom prst="rect">
+            <a:avLst/>
+          </a:prstGeom>
+          <a:noFill/>
+          <a:ln/>
+        </p:spPr>
+        <p:txBody>
+          <a:bodyPr wrap="square" lIns="0" tIns="0" rIns="0" bIns="0" rtlCol="0" anchor="ctr"/>
+          <a:lstStyle/>
+          <a:p>
+            <a:pPr indent="0" marL="0">
+              <a:buNone/>
+            </a:pPr>
+            <a:r>
+              <a:rPr lang="en-US" sz="800" b="1" dirty="0">
+                <a:solidFill>
+                  <a:srgbClr val="DD0031"/>
+                </a:solidFill>
+              </a:rPr>
+              <a:t>Question cle</a:t>
+            </a:r>
+            <a:endParaRPr lang="en-US" sz="800" dirty="0"/>
+          </a:p>
+        </p:txBody>
+      </p:sp>
+      <p:sp>
+        <p:nvSpPr>
+          <p:cNvPr id="9" name="Text 7"/>
+          <p:cNvSpPr/>
+          <p:nvPr/>
+        </p:nvSpPr>
+        <p:spPr>
+          <a:xfrm>
+            <a:off x="704088" y="5074920"/>
+            <a:ext cx="3108960" cy="384048"/>
+          </a:xfrm>
+          <a:prstGeom prst="rect">
+            <a:avLst/>
+          </a:prstGeom>
+          <a:noFill/>
+          <a:ln/>
+        </p:spPr>
+        <p:txBody>
+          <a:bodyPr wrap="square" lIns="0" tIns="0" rIns="0" bIns="0" rtlCol="0" anchor="ctr">
+            <a:normAutofit/>
+          </a:bodyPr>
+          <a:lstStyle/>
+          <a:p>
+            <a:pPr indent="0" marL="0">
+              <a:buNone/>
+            </a:pPr>
+            <a:r>
+              <a:rPr lang="en-US" sz="1200" dirty="0">
+                <a:solidFill>
+                  <a:srgbClr val="273043"/>
+                </a:solidFill>
+              </a:rPr>
+              <a:t>Qui depend de cette valeur ?</a:t>
+            </a:r>
+            <a:endParaRPr lang="en-US" sz="1200" dirty="0"/>
+          </a:p>
+        </p:txBody>
+      </p:sp>
+      <p:sp>
+        <p:nvSpPr>
+          <p:cNvPr id="10" name="Shape 8"/>
+          <p:cNvSpPr/>
+          <p:nvPr/>
+        </p:nvSpPr>
+        <p:spPr>
+          <a:xfrm>
+            <a:off x="4572000" y="960120"/>
+            <a:ext cx="7208215" cy="2331720"/>
+          </a:xfrm>
+          <a:prstGeom prst="roundRect">
+            <a:avLst>
+              <a:gd name="adj" fmla="val 3137"/>
             </a:avLst>
           </a:prstGeom>
           <a:solidFill>
@@ -1699,16 +1965,52 @@
       </p:sp>
       <p:sp>
         <p:nvSpPr>
-          <p:cNvPr id="6" name="Shape 4"/>
-          <p:cNvSpPr/>
-          <p:nvPr/>
-        </p:nvSpPr>
-        <p:spPr>
-          <a:xfrm>
-            <a:off x="411480" y="960120"/>
-            <a:ext cx="109728" cy="1207008"/>
-          </a:xfrm>
-          <a:prstGeom prst="rect">
+          <p:cNvPr id="11" name="Text 9"/>
+          <p:cNvSpPr/>
+          <p:nvPr/>
+        </p:nvSpPr>
+        <p:spPr>
+          <a:xfrm>
+            <a:off x="4846320" y="1161288"/>
+            <a:ext cx="2926080" cy="256032"/>
+          </a:xfrm>
+          <a:prstGeom prst="rect">
+            <a:avLst/>
+          </a:prstGeom>
+          <a:noFill/>
+          <a:ln/>
+        </p:spPr>
+        <p:txBody>
+          <a:bodyPr wrap="square" lIns="0" tIns="0" rIns="0" bIns="0" rtlCol="0" anchor="ctr"/>
+          <a:lstStyle/>
+          <a:p>
+            <a:pPr indent="0" marL="0">
+              <a:buNone/>
+            </a:pPr>
+            <a:r>
+              <a:rPr lang="en-US" sz="1300" b="1" dirty="0">
+                <a:solidFill>
+                  <a:srgbClr val="DD0031"/>
+                </a:solidFill>
+              </a:rPr>
+              <a:t>Rôle dans le dojo</a:t>
+            </a:r>
+            <a:endParaRPr lang="en-US" sz="1300" dirty="0"/>
+          </a:p>
+        </p:txBody>
+      </p:sp>
+      <p:sp>
+        <p:nvSpPr>
+          <p:cNvPr id="12" name="Shape 10"/>
+          <p:cNvSpPr/>
+          <p:nvPr/>
+        </p:nvSpPr>
+        <p:spPr>
+          <a:xfrm>
+            <a:off x="4873752" y="1664208"/>
+            <a:ext cx="109728" cy="109728"/>
+          </a:xfrm>
+          <a:prstGeom prst="ellipse">
             <a:avLst/>
           </a:prstGeom>
           <a:solidFill>
@@ -1724,59 +2026,23 @@
       </p:sp>
       <p:sp>
         <p:nvSpPr>
-          <p:cNvPr id="7" name="Text 5"/>
-          <p:cNvSpPr/>
-          <p:nvPr/>
-        </p:nvSpPr>
-        <p:spPr>
-          <a:xfrm>
-            <a:off x="667512" y="1115568"/>
-            <a:ext cx="1143000" cy="228600"/>
-          </a:xfrm>
-          <a:prstGeom prst="rect">
-            <a:avLst/>
-          </a:prstGeom>
-          <a:noFill/>
-          <a:ln/>
-        </p:spPr>
-        <p:txBody>
-          <a:bodyPr wrap="square" lIns="0" tIns="0" rIns="0" bIns="0" rtlCol="0" anchor="ctr"/>
-          <a:lstStyle/>
-          <a:p>
-            <a:pPr indent="0" marL="0">
-              <a:buNone/>
-            </a:pPr>
-            <a:r>
-              <a:rPr lang="en-US" sz="900" b="1" dirty="0">
-                <a:solidFill>
-                  <a:srgbClr val="DD0031"/>
-                </a:solidFill>
-              </a:rPr>
-              <a:t>Définition</a:t>
-            </a:r>
-            <a:endParaRPr lang="en-US" sz="900" dirty="0"/>
-          </a:p>
-        </p:txBody>
-      </p:sp>
-      <p:sp>
-        <p:nvSpPr>
-          <p:cNvPr id="8" name="Text 6"/>
-          <p:cNvSpPr/>
-          <p:nvPr/>
-        </p:nvSpPr>
-        <p:spPr>
-          <a:xfrm>
-            <a:off x="1892808" y="1078992"/>
-            <a:ext cx="9631375" cy="786384"/>
-          </a:xfrm>
-          <a:prstGeom prst="rect">
-            <a:avLst/>
-          </a:prstGeom>
-          <a:noFill/>
-          <a:ln/>
-        </p:spPr>
-        <p:txBody>
-          <a:bodyPr wrap="square" lIns="254" tIns="254" rIns="254" bIns="254" rtlCol="0" anchor="ctr">
+          <p:cNvPr id="13" name="Text 11"/>
+          <p:cNvSpPr/>
+          <p:nvPr/>
+        </p:nvSpPr>
+        <p:spPr>
+          <a:xfrm>
+            <a:off x="5120640" y="1563624"/>
+            <a:ext cx="6385255" cy="438912"/>
+          </a:xfrm>
+          <a:prstGeom prst="rect">
+            <a:avLst/>
+          </a:prstGeom>
+          <a:noFill/>
+          <a:ln/>
+        </p:spPr>
+        <p:txBody>
+          <a:bodyPr wrap="square" lIns="0" tIns="0" rIns="0" bIns="0" rtlCol="0" anchor="ctr">
             <a:normAutofit/>
           </a:bodyPr>
           <a:lstStyle/>
@@ -1785,31 +2051,94 @@
               <a:buNone/>
             </a:pPr>
             <a:r>
-              <a:rPr lang="en-US" sz="1500" dirty="0">
+              <a:rPr lang="en-US" sz="1250" dirty="0">
                 <a:solidFill>
                   <a:srgbClr val="273043"/>
                 </a:solidFill>
               </a:rPr>
-              <a:t>Un signal est une valeur reactive lue avec (). Quand sa valeur change, Angular sait quelles lectures dependent de cette valeur.</a:t>
-            </a:r>
-            <a:endParaRPr lang="en-US" sz="1500" dirty="0"/>
-          </a:p>
-        </p:txBody>
-      </p:sp>
-      <p:sp>
-        <p:nvSpPr>
-          <p:cNvPr id="9" name="Shape 7"/>
-          <p:cNvSpPr/>
-          <p:nvPr/>
-        </p:nvSpPr>
-        <p:spPr>
-          <a:xfrm>
-            <a:off x="411480" y="2788920"/>
-            <a:ext cx="5547208" cy="1143000"/>
+              <a:t>signal() cree une valeur mutable.</a:t>
+            </a:r>
+            <a:endParaRPr lang="en-US" sz="1250" dirty="0"/>
+          </a:p>
+        </p:txBody>
+      </p:sp>
+      <p:sp>
+        <p:nvSpPr>
+          <p:cNvPr id="14" name="Shape 12"/>
+          <p:cNvSpPr/>
+          <p:nvPr/>
+        </p:nvSpPr>
+        <p:spPr>
+          <a:xfrm>
+            <a:off x="4873752" y="2322576"/>
+            <a:ext cx="109728" cy="109728"/>
+          </a:xfrm>
+          <a:prstGeom prst="ellipse">
+            <a:avLst/>
+          </a:prstGeom>
+          <a:solidFill>
+            <a:srgbClr val="DD0031"/>
+          </a:solidFill>
+          <a:ln w="12700">
+            <a:solidFill>
+              <a:srgbClr val="DD0031"/>
+            </a:solidFill>
+            <a:prstDash val="solid"/>
+          </a:ln>
+        </p:spPr>
+      </p:sp>
+      <p:sp>
+        <p:nvSpPr>
+          <p:cNvPr id="15" name="Text 13"/>
+          <p:cNvSpPr/>
+          <p:nvPr/>
+        </p:nvSpPr>
+        <p:spPr>
+          <a:xfrm>
+            <a:off x="5120640" y="2221992"/>
+            <a:ext cx="6385255" cy="438912"/>
+          </a:xfrm>
+          <a:prstGeom prst="rect">
+            <a:avLst/>
+          </a:prstGeom>
+          <a:noFill/>
+          <a:ln/>
+        </p:spPr>
+        <p:txBody>
+          <a:bodyPr wrap="square" lIns="0" tIns="0" rIns="0" bIns="0" rtlCol="0" anchor="ctr">
+            <a:normAutofit/>
+          </a:bodyPr>
+          <a:lstStyle/>
+          <a:p>
+            <a:pPr indent="0" marL="0">
+              <a:buNone/>
+            </a:pPr>
+            <a:r>
+              <a:rPr lang="en-US" sz="1250" dirty="0">
+                <a:solidFill>
+                  <a:srgbClr val="273043"/>
+                </a:solidFill>
+              </a:rPr>
+              <a:t>computed() cree une valeur derivee.</a:t>
+            </a:r>
+            <a:endParaRPr lang="en-US" sz="1250" dirty="0"/>
+          </a:p>
+        </p:txBody>
+      </p:sp>
+      <p:sp>
+        <p:nvSpPr>
+          <p:cNvPr id="16" name="Shape 14"/>
+          <p:cNvSpPr/>
+          <p:nvPr/>
+        </p:nvSpPr>
+        <p:spPr>
+          <a:xfrm>
+            <a:off x="4572000" y="3584448"/>
+            <a:ext cx="7208215" cy="2331720"/>
           </a:xfrm>
           <a:prstGeom prst="roundRect">
             <a:avLst>
-              <a:gd name="adj" fmla="val 6400"/>
+              <a:gd name="adj" fmla="val 3137"/>
             </a:avLst>
           </a:prstGeom>
           <a:solidFill>
@@ -1825,106 +2154,60 @@
       </p:sp>
       <p:sp>
         <p:nvSpPr>
-          <p:cNvPr id="10" name="Text 8"/>
-          <p:cNvSpPr/>
-          <p:nvPr/>
-        </p:nvSpPr>
-        <p:spPr>
-          <a:xfrm>
-            <a:off x="557784" y="2935224"/>
-            <a:ext cx="347472" cy="228600"/>
-          </a:xfrm>
-          <a:prstGeom prst="rect">
-            <a:avLst/>
-          </a:prstGeom>
-          <a:solidFill>
-            <a:srgbClr val="FCE7EC"/>
-          </a:solidFill>
-          <a:ln>
-            <a:solidFill>
-              <a:srgbClr val="FCE7EC"/>
-            </a:solidFill>
-          </a:ln>
+          <p:cNvPr id="17" name="Text 15"/>
+          <p:cNvSpPr/>
+          <p:nvPr/>
+        </p:nvSpPr>
+        <p:spPr>
+          <a:xfrm>
+            <a:off x="4846320" y="3785616"/>
+            <a:ext cx="2926080" cy="256032"/>
+          </a:xfrm>
+          <a:prstGeom prst="rect">
+            <a:avLst/>
+          </a:prstGeom>
+          <a:noFill/>
+          <a:ln/>
         </p:spPr>
         <p:txBody>
           <a:bodyPr wrap="square" lIns="0" tIns="0" rIns="0" bIns="0" rtlCol="0" anchor="ctr"/>
           <a:lstStyle/>
           <a:p>
-            <a:pPr algn="ctr" indent="0" marL="0">
-              <a:buNone/>
-            </a:pPr>
-            <a:r>
-              <a:rPr lang="en-US" sz="800" b="1" dirty="0">
+            <a:pPr indent="0" marL="0">
+              <a:buNone/>
+            </a:pPr>
+            <a:r>
+              <a:rPr lang="en-US" sz="1300" b="1" dirty="0">
                 <a:solidFill>
                   <a:srgbClr val="DD0031"/>
                 </a:solidFill>
               </a:rPr>
-              <a:t>01</a:t>
-            </a:r>
-            <a:endParaRPr lang="en-US" sz="800" dirty="0"/>
-          </a:p>
-        </p:txBody>
-      </p:sp>
-      <p:sp>
-        <p:nvSpPr>
-          <p:cNvPr id="11" name="Text 9"/>
-          <p:cNvSpPr/>
-          <p:nvPr/>
-        </p:nvSpPr>
-        <p:spPr>
-          <a:xfrm>
-            <a:off x="1033272" y="2953512"/>
-            <a:ext cx="4742536" cy="850392"/>
-          </a:xfrm>
-          <a:prstGeom prst="rect">
-            <a:avLst/>
-          </a:prstGeom>
-          <a:noFill/>
-          <a:ln/>
-        </p:spPr>
-        <p:txBody>
-          <a:bodyPr wrap="square" lIns="254" tIns="254" rIns="254" bIns="254" rtlCol="0" anchor="ctr">
-            <a:normAutofit/>
-          </a:bodyPr>
-          <a:lstStyle/>
-          <a:p>
-            <a:pPr indent="0" marL="0">
-              <a:buNone/>
-            </a:pPr>
-            <a:r>
-              <a:rPr lang="en-US" sz="1200" dirty="0">
-                <a:solidFill>
-                  <a:srgbClr val="273043"/>
-                </a:solidFill>
-              </a:rPr>
-              <a:t>signal() cree une valeur mutable.</a:t>
-            </a:r>
-            <a:endParaRPr lang="en-US" sz="1200" dirty="0"/>
-          </a:p>
-        </p:txBody>
-      </p:sp>
-      <p:sp>
-        <p:nvSpPr>
-          <p:cNvPr id="12" name="Shape 10"/>
-          <p:cNvSpPr/>
-          <p:nvPr/>
-        </p:nvSpPr>
-        <p:spPr>
-          <a:xfrm>
-            <a:off x="6233008" y="2788920"/>
-            <a:ext cx="5547208" cy="1143000"/>
-          </a:xfrm>
-          <a:prstGeom prst="roundRect">
-            <a:avLst>
-              <a:gd name="adj" fmla="val 6400"/>
-            </a:avLst>
-          </a:prstGeom>
-          <a:solidFill>
-            <a:srgbClr val="FFFFFF"/>
+              <a:t>À retenir</a:t>
+            </a:r>
+            <a:endParaRPr lang="en-US" sz="1300" dirty="0"/>
+          </a:p>
+        </p:txBody>
+      </p:sp>
+      <p:sp>
+        <p:nvSpPr>
+          <p:cNvPr id="18" name="Shape 16"/>
+          <p:cNvSpPr/>
+          <p:nvPr/>
+        </p:nvSpPr>
+        <p:spPr>
+          <a:xfrm>
+            <a:off x="4873752" y="4288536"/>
+            <a:ext cx="109728" cy="109728"/>
+          </a:xfrm>
+          <a:prstGeom prst="ellipse">
+            <a:avLst/>
+          </a:prstGeom>
+          <a:solidFill>
+            <a:srgbClr val="DD0031"/>
           </a:solidFill>
           <a:ln w="12700">
             <a:solidFill>
-              <a:srgbClr val="E4E7EC"/>
+              <a:srgbClr val="DD0031"/>
             </a:solidFill>
             <a:prstDash val="solid"/>
           </a:ln>
@@ -1932,65 +2215,23 @@
       </p:sp>
       <p:sp>
         <p:nvSpPr>
-          <p:cNvPr id="13" name="Text 11"/>
-          <p:cNvSpPr/>
-          <p:nvPr/>
-        </p:nvSpPr>
-        <p:spPr>
-          <a:xfrm>
-            <a:off x="6379312" y="2935224"/>
-            <a:ext cx="347472" cy="228600"/>
-          </a:xfrm>
-          <a:prstGeom prst="rect">
-            <a:avLst/>
-          </a:prstGeom>
-          <a:solidFill>
-            <a:srgbClr val="E8F1FF"/>
-          </a:solidFill>
-          <a:ln>
-            <a:solidFill>
-              <a:srgbClr val="E8F1FF"/>
-            </a:solidFill>
-          </a:ln>
-        </p:spPr>
-        <p:txBody>
-          <a:bodyPr wrap="square" lIns="0" tIns="0" rIns="0" bIns="0" rtlCol="0" anchor="ctr"/>
-          <a:lstStyle/>
-          <a:p>
-            <a:pPr algn="ctr" indent="0" marL="0">
-              <a:buNone/>
-            </a:pPr>
-            <a:r>
-              <a:rPr lang="en-US" sz="800" b="1" dirty="0">
-                <a:solidFill>
-                  <a:srgbClr val="1976D2"/>
-                </a:solidFill>
-              </a:rPr>
-              <a:t>02</a:t>
-            </a:r>
-            <a:endParaRPr lang="en-US" sz="800" dirty="0"/>
-          </a:p>
-        </p:txBody>
-      </p:sp>
-      <p:sp>
-        <p:nvSpPr>
-          <p:cNvPr id="14" name="Text 12"/>
-          <p:cNvSpPr/>
-          <p:nvPr/>
-        </p:nvSpPr>
-        <p:spPr>
-          <a:xfrm>
-            <a:off x="6854800" y="2953512"/>
-            <a:ext cx="4742536" cy="850392"/>
-          </a:xfrm>
-          <a:prstGeom prst="rect">
-            <a:avLst/>
-          </a:prstGeom>
-          <a:noFill/>
-          <a:ln/>
-        </p:spPr>
-        <p:txBody>
-          <a:bodyPr wrap="square" lIns="254" tIns="254" rIns="254" bIns="254" rtlCol="0" anchor="ctr">
+          <p:cNvPr id="19" name="Text 17"/>
+          <p:cNvSpPr/>
+          <p:nvPr/>
+        </p:nvSpPr>
+        <p:spPr>
+          <a:xfrm>
+            <a:off x="5120640" y="4187952"/>
+            <a:ext cx="6385255" cy="438912"/>
+          </a:xfrm>
+          <a:prstGeom prst="rect">
+            <a:avLst/>
+          </a:prstGeom>
+          <a:noFill/>
+          <a:ln/>
+        </p:spPr>
+        <p:txBody>
+          <a:bodyPr wrap="square" lIns="0" tIns="0" rIns="0" bIns="0" rtlCol="0" anchor="ctr">
             <a:normAutofit/>
           </a:bodyPr>
           <a:lstStyle/>
@@ -1999,39 +2240,37 @@
               <a:buNone/>
             </a:pPr>
             <a:r>
-              <a:rPr lang="en-US" sz="1200" dirty="0">
+              <a:rPr lang="en-US" sz="1250" dirty="0">
                 <a:solidFill>
                   <a:srgbClr val="273043"/>
                 </a:solidFill>
               </a:rPr>
-              <a:t>computed() cree une valeur derivee.</a:t>
-            </a:r>
-            <a:endParaRPr lang="en-US" sz="1200" dirty="0"/>
-          </a:p>
-        </p:txBody>
-      </p:sp>
-      <p:sp>
-        <p:nvSpPr>
-          <p:cNvPr id="15" name="Shape 13"/>
-          <p:cNvSpPr/>
-          <p:nvPr/>
-        </p:nvSpPr>
-        <p:spPr>
-          <a:xfrm>
-            <a:off x="411480" y="4142232"/>
-            <a:ext cx="5547208" cy="1143000"/>
-          </a:xfrm>
-          <a:prstGeom prst="roundRect">
-            <a:avLst>
-              <a:gd name="adj" fmla="val 6400"/>
-            </a:avLst>
-          </a:prstGeom>
-          <a:solidFill>
-            <a:srgbClr val="FFFFFF"/>
+              <a:t>effect() observe des signals pour declencher un effet de bord.</a:t>
+            </a:r>
+            <a:endParaRPr lang="en-US" sz="1250" dirty="0"/>
+          </a:p>
+        </p:txBody>
+      </p:sp>
+      <p:sp>
+        <p:nvSpPr>
+          <p:cNvPr id="20" name="Shape 18"/>
+          <p:cNvSpPr/>
+          <p:nvPr/>
+        </p:nvSpPr>
+        <p:spPr>
+          <a:xfrm>
+            <a:off x="4873752" y="4946904"/>
+            <a:ext cx="109728" cy="109728"/>
+          </a:xfrm>
+          <a:prstGeom prst="ellipse">
+            <a:avLst/>
+          </a:prstGeom>
+          <a:solidFill>
+            <a:srgbClr val="DD0031"/>
           </a:solidFill>
           <a:ln w="12700">
             <a:solidFill>
-              <a:srgbClr val="E4E7EC"/>
+              <a:srgbClr val="DD0031"/>
             </a:solidFill>
             <a:prstDash val="solid"/>
           </a:ln>
@@ -2039,65 +2278,23 @@
       </p:sp>
       <p:sp>
         <p:nvSpPr>
-          <p:cNvPr id="16" name="Text 14"/>
-          <p:cNvSpPr/>
-          <p:nvPr/>
-        </p:nvSpPr>
-        <p:spPr>
-          <a:xfrm>
-            <a:off x="557784" y="4288536"/>
-            <a:ext cx="347472" cy="228600"/>
-          </a:xfrm>
-          <a:prstGeom prst="rect">
-            <a:avLst/>
-          </a:prstGeom>
-          <a:solidFill>
-            <a:srgbClr val="EAF7F0"/>
-          </a:solidFill>
-          <a:ln>
-            <a:solidFill>
-              <a:srgbClr val="EAF7F0"/>
-            </a:solidFill>
-          </a:ln>
-        </p:spPr>
-        <p:txBody>
-          <a:bodyPr wrap="square" lIns="0" tIns="0" rIns="0" bIns="0" rtlCol="0" anchor="ctr"/>
-          <a:lstStyle/>
-          <a:p>
-            <a:pPr algn="ctr" indent="0" marL="0">
-              <a:buNone/>
-            </a:pPr>
-            <a:r>
-              <a:rPr lang="en-US" sz="800" b="1" dirty="0">
-                <a:solidFill>
-                  <a:srgbClr val="188038"/>
-                </a:solidFill>
-              </a:rPr>
-              <a:t>03</a:t>
-            </a:r>
-            <a:endParaRPr lang="en-US" sz="800" dirty="0"/>
-          </a:p>
-        </p:txBody>
-      </p:sp>
-      <p:sp>
-        <p:nvSpPr>
-          <p:cNvPr id="17" name="Text 15"/>
-          <p:cNvSpPr/>
-          <p:nvPr/>
-        </p:nvSpPr>
-        <p:spPr>
-          <a:xfrm>
-            <a:off x="1033272" y="4306824"/>
-            <a:ext cx="4742536" cy="850392"/>
-          </a:xfrm>
-          <a:prstGeom prst="rect">
-            <a:avLst/>
-          </a:prstGeom>
-          <a:noFill/>
-          <a:ln/>
-        </p:spPr>
-        <p:txBody>
-          <a:bodyPr wrap="square" lIns="254" tIns="254" rIns="254" bIns="254" rtlCol="0" anchor="ctr">
+          <p:cNvPr id="21" name="Text 19"/>
+          <p:cNvSpPr/>
+          <p:nvPr/>
+        </p:nvSpPr>
+        <p:spPr>
+          <a:xfrm>
+            <a:off x="5120640" y="4846320"/>
+            <a:ext cx="6385255" cy="438912"/>
+          </a:xfrm>
+          <a:prstGeom prst="rect">
+            <a:avLst/>
+          </a:prstGeom>
+          <a:noFill/>
+          <a:ln/>
+        </p:spPr>
+        <p:txBody>
+          <a:bodyPr wrap="square" lIns="0" tIns="0" rIns="0" bIns="0" rtlCol="0" anchor="ctr">
             <a:normAutofit/>
           </a:bodyPr>
           <a:lstStyle/>
@@ -2106,127 +2303,20 @@
               <a:buNone/>
             </a:pPr>
             <a:r>
-              <a:rPr lang="en-US" sz="1200" dirty="0">
+              <a:rPr lang="en-US" sz="1250" dirty="0">
                 <a:solidFill>
                   <a:srgbClr val="273043"/>
                 </a:solidFill>
               </a:rPr>
-              <a:t>effect() observe des signals pour declencher un effet de bord.</a:t>
-            </a:r>
-            <a:endParaRPr lang="en-US" sz="1200" dirty="0"/>
-          </a:p>
-        </p:txBody>
-      </p:sp>
-      <p:sp>
-        <p:nvSpPr>
-          <p:cNvPr id="18" name="Shape 16"/>
-          <p:cNvSpPr/>
-          <p:nvPr/>
-        </p:nvSpPr>
-        <p:spPr>
-          <a:xfrm>
-            <a:off x="6233008" y="4142232"/>
-            <a:ext cx="5547208" cy="1143000"/>
-          </a:xfrm>
-          <a:prstGeom prst="roundRect">
-            <a:avLst>
-              <a:gd name="adj" fmla="val 6400"/>
-            </a:avLst>
-          </a:prstGeom>
-          <a:solidFill>
-            <a:srgbClr val="FFFFFF"/>
-          </a:solidFill>
-          <a:ln w="12700">
-            <a:solidFill>
-              <a:srgbClr val="E4E7EC"/>
-            </a:solidFill>
-            <a:prstDash val="solid"/>
-          </a:ln>
-        </p:spPr>
-      </p:sp>
-      <p:sp>
-        <p:nvSpPr>
-          <p:cNvPr id="19" name="Text 17"/>
-          <p:cNvSpPr/>
-          <p:nvPr/>
-        </p:nvSpPr>
-        <p:spPr>
-          <a:xfrm>
-            <a:off x="6379312" y="4288536"/>
-            <a:ext cx="347472" cy="228600"/>
-          </a:xfrm>
-          <a:prstGeom prst="rect">
-            <a:avLst/>
-          </a:prstGeom>
-          <a:solidFill>
-            <a:srgbClr val="F0ECFF"/>
-          </a:solidFill>
-          <a:ln>
-            <a:solidFill>
-              <a:srgbClr val="F0ECFF"/>
-            </a:solidFill>
-          </a:ln>
-        </p:spPr>
-        <p:txBody>
-          <a:bodyPr wrap="square" lIns="0" tIns="0" rIns="0" bIns="0" rtlCol="0" anchor="ctr"/>
-          <a:lstStyle/>
-          <a:p>
-            <a:pPr algn="ctr" indent="0" marL="0">
-              <a:buNone/>
-            </a:pPr>
-            <a:r>
-              <a:rPr lang="en-US" sz="800" b="1" dirty="0">
-                <a:solidFill>
-                  <a:srgbClr val="7B61FF"/>
-                </a:solidFill>
-              </a:rPr>
-              <a:t>04</a:t>
-            </a:r>
-            <a:endParaRPr lang="en-US" sz="800" dirty="0"/>
-          </a:p>
-        </p:txBody>
-      </p:sp>
-      <p:sp>
-        <p:nvSpPr>
-          <p:cNvPr id="20" name="Text 18"/>
-          <p:cNvSpPr/>
-          <p:nvPr/>
-        </p:nvSpPr>
-        <p:spPr>
-          <a:xfrm>
-            <a:off x="6854800" y="4306824"/>
-            <a:ext cx="4742536" cy="850392"/>
-          </a:xfrm>
-          <a:prstGeom prst="rect">
-            <a:avLst/>
-          </a:prstGeom>
-          <a:noFill/>
-          <a:ln/>
-        </p:spPr>
-        <p:txBody>
-          <a:bodyPr wrap="square" lIns="254" tIns="254" rIns="254" bIns="254" rtlCol="0" anchor="ctr">
-            <a:normAutofit/>
-          </a:bodyPr>
-          <a:lstStyle/>
-          <a:p>
-            <a:pPr indent="0" marL="0">
-              <a:buNone/>
-            </a:pPr>
-            <a:r>
-              <a:rPr lang="en-US" sz="1200" dirty="0">
-                <a:solidFill>
-                  <a:srgbClr val="273043"/>
-                </a:solidFill>
-              </a:rPr>
               <a:t>Le template lit un signal avec monSignal().</a:t>
             </a:r>
-            <a:endParaRPr lang="en-US" sz="1200" dirty="0"/>
-          </a:p>
-        </p:txBody>
-      </p:sp>
-      <p:sp>
-        <p:nvSpPr>
-          <p:cNvPr id="21" name="Text 19"/>
+            <a:endParaRPr lang="en-US" sz="1250" dirty="0"/>
+          </a:p>
+        </p:txBody>
+      </p:sp>
+      <p:sp>
+        <p:nvSpPr>
+          <p:cNvPr id="22" name="Text 20"/>
           <p:cNvSpPr/>
           <p:nvPr/>
         </p:nvSpPr>
@@ -2254,7 +2344,7 @@
                   <a:srgbClr val="667085"/>
                 </a:solidFill>
               </a:rPr>
-              <a:t>2/6</a:t>
+              <a:t>2/7</a:t>
             </a:r>
             <a:endParaRPr lang="en-US" sz="700" dirty="0"/>
           </a:p>
@@ -2406,11 +2496,188 @@
         <p:spPr>
           <a:xfrm>
             <a:off x="411480" y="960120"/>
-            <a:ext cx="11368735" cy="1207008"/>
+            <a:ext cx="3794760" cy="5212080"/>
           </a:xfrm>
           <a:prstGeom prst="roundRect">
             <a:avLst>
-              <a:gd name="adj" fmla="val 6061"/>
+              <a:gd name="adj" fmla="val 1928"/>
+            </a:avLst>
+          </a:prstGeom>
+          <a:solidFill>
+            <a:srgbClr val="E8F1FF"/>
+          </a:solidFill>
+          <a:ln w="12700">
+            <a:solidFill>
+              <a:srgbClr val="E8F1FF"/>
+            </a:solidFill>
+            <a:prstDash val="solid"/>
+          </a:ln>
+        </p:spPr>
+      </p:sp>
+      <p:sp>
+        <p:nvSpPr>
+          <p:cNvPr id="6" name="Text 4"/>
+          <p:cNvSpPr/>
+          <p:nvPr/>
+        </p:nvSpPr>
+        <p:spPr>
+          <a:xfrm>
+            <a:off x="704088" y="1234440"/>
+            <a:ext cx="3154680" cy="457200"/>
+          </a:xfrm>
+          <a:prstGeom prst="rect">
+            <a:avLst/>
+          </a:prstGeom>
+          <a:noFill/>
+          <a:ln/>
+        </p:spPr>
+        <p:txBody>
+          <a:bodyPr wrap="square" lIns="0" tIns="0" rIns="0" bIns="0" rtlCol="0" anchor="ctr">
+            <a:normAutofit/>
+          </a:bodyPr>
+          <a:lstStyle/>
+          <a:p>
+            <a:pPr indent="0" marL="0">
+              <a:buNone/>
+            </a:pPr>
+            <a:r>
+              <a:rPr lang="en-US" sz="2600" b="1" dirty="0">
+                <a:solidFill>
+                  <a:srgbClr val="1976D2"/>
+                </a:solidFill>
+              </a:rPr>
+              <a:t>Zone.js</a:t>
+            </a:r>
+            <a:endParaRPr lang="en-US" sz="2600" dirty="0"/>
+          </a:p>
+        </p:txBody>
+      </p:sp>
+      <p:sp>
+        <p:nvSpPr>
+          <p:cNvPr id="7" name="Text 5"/>
+          <p:cNvSpPr/>
+          <p:nvPr/>
+        </p:nvSpPr>
+        <p:spPr>
+          <a:xfrm>
+            <a:off x="704088" y="1993392"/>
+            <a:ext cx="3127248" cy="2148840"/>
+          </a:xfrm>
+          <a:prstGeom prst="rect">
+            <a:avLst/>
+          </a:prstGeom>
+          <a:noFill/>
+          <a:ln/>
+        </p:spPr>
+        <p:txBody>
+          <a:bodyPr wrap="square" lIns="381" tIns="381" rIns="381" bIns="381" rtlCol="0" anchor="ctr">
+            <a:normAutofit/>
+          </a:bodyPr>
+          <a:lstStyle/>
+          <a:p>
+            <a:pPr indent="0" marL="0">
+              <a:buNone/>
+            </a:pPr>
+            <a:r>
+              <a:rPr lang="en-US" sz="1700" b="1" dirty="0">
+                <a:solidFill>
+                  <a:srgbClr val="202124"/>
+                </a:solidFill>
+              </a:rPr>
+              <a:t>Zone.js intercepte les evenements asynchrones du navigateur et previent Angular qu'un cycle de detection peut etre lance.</a:t>
+            </a:r>
+            <a:endParaRPr lang="en-US" sz="1700" dirty="0"/>
+          </a:p>
+        </p:txBody>
+      </p:sp>
+      <p:sp>
+        <p:nvSpPr>
+          <p:cNvPr id="8" name="Text 6"/>
+          <p:cNvSpPr/>
+          <p:nvPr/>
+        </p:nvSpPr>
+        <p:spPr>
+          <a:xfrm>
+            <a:off x="704088" y="4800600"/>
+            <a:ext cx="1188720" cy="182880"/>
+          </a:xfrm>
+          <a:prstGeom prst="rect">
+            <a:avLst/>
+          </a:prstGeom>
+          <a:noFill/>
+          <a:ln/>
+        </p:spPr>
+        <p:txBody>
+          <a:bodyPr wrap="square" lIns="0" tIns="0" rIns="0" bIns="0" rtlCol="0" anchor="ctr"/>
+          <a:lstStyle/>
+          <a:p>
+            <a:pPr indent="0" marL="0">
+              <a:buNone/>
+            </a:pPr>
+            <a:r>
+              <a:rPr lang="en-US" sz="800" b="1" dirty="0">
+                <a:solidFill>
+                  <a:srgbClr val="1976D2"/>
+                </a:solidFill>
+              </a:rPr>
+              <a:t>Question cle</a:t>
+            </a:r>
+            <a:endParaRPr lang="en-US" sz="800" dirty="0"/>
+          </a:p>
+        </p:txBody>
+      </p:sp>
+      <p:sp>
+        <p:nvSpPr>
+          <p:cNvPr id="9" name="Text 7"/>
+          <p:cNvSpPr/>
+          <p:nvPr/>
+        </p:nvSpPr>
+        <p:spPr>
+          <a:xfrm>
+            <a:off x="704088" y="5074920"/>
+            <a:ext cx="3108960" cy="384048"/>
+          </a:xfrm>
+          <a:prstGeom prst="rect">
+            <a:avLst/>
+          </a:prstGeom>
+          <a:noFill/>
+          <a:ln/>
+        </p:spPr>
+        <p:txBody>
+          <a:bodyPr wrap="square" lIns="0" tIns="0" rIns="0" bIns="0" rtlCol="0" anchor="ctr">
+            <a:normAutofit/>
+          </a:bodyPr>
+          <a:lstStyle/>
+          <a:p>
+            <a:pPr indent="0" marL="0">
+              <a:buNone/>
+            </a:pPr>
+            <a:r>
+              <a:rPr lang="en-US" sz="1200" dirty="0">
+                <a:solidFill>
+                  <a:srgbClr val="273043"/>
+                </a:solidFill>
+              </a:rPr>
+              <a:t>Qui declenche la detection ?</a:t>
+            </a:r>
+            <a:endParaRPr lang="en-US" sz="1200" dirty="0"/>
+          </a:p>
+        </p:txBody>
+      </p:sp>
+      <p:sp>
+        <p:nvSpPr>
+          <p:cNvPr id="10" name="Shape 8"/>
+          <p:cNvSpPr/>
+          <p:nvPr/>
+        </p:nvSpPr>
+        <p:spPr>
+          <a:xfrm>
+            <a:off x="4572000" y="960120"/>
+            <a:ext cx="7208215" cy="2331720"/>
+          </a:xfrm>
+          <a:prstGeom prst="roundRect">
+            <a:avLst>
+              <a:gd name="adj" fmla="val 3137"/>
             </a:avLst>
           </a:prstGeom>
           <a:solidFill>
@@ -2426,24 +2693,60 @@
       </p:sp>
       <p:sp>
         <p:nvSpPr>
-          <p:cNvPr id="6" name="Shape 4"/>
-          <p:cNvSpPr/>
-          <p:nvPr/>
-        </p:nvSpPr>
-        <p:spPr>
-          <a:xfrm>
-            <a:off x="411480" y="960120"/>
-            <a:ext cx="109728" cy="1207008"/>
-          </a:xfrm>
-          <a:prstGeom prst="rect">
-            <a:avLst/>
-          </a:prstGeom>
-          <a:solidFill>
-            <a:srgbClr val="DD0031"/>
+          <p:cNvPr id="11" name="Text 9"/>
+          <p:cNvSpPr/>
+          <p:nvPr/>
+        </p:nvSpPr>
+        <p:spPr>
+          <a:xfrm>
+            <a:off x="4846320" y="1161288"/>
+            <a:ext cx="2926080" cy="256032"/>
+          </a:xfrm>
+          <a:prstGeom prst="rect">
+            <a:avLst/>
+          </a:prstGeom>
+          <a:noFill/>
+          <a:ln/>
+        </p:spPr>
+        <p:txBody>
+          <a:bodyPr wrap="square" lIns="0" tIns="0" rIns="0" bIns="0" rtlCol="0" anchor="ctr"/>
+          <a:lstStyle/>
+          <a:p>
+            <a:pPr indent="0" marL="0">
+              <a:buNone/>
+            </a:pPr>
+            <a:r>
+              <a:rPr lang="en-US" sz="1300" b="1" dirty="0">
+                <a:solidFill>
+                  <a:srgbClr val="1976D2"/>
+                </a:solidFill>
+              </a:rPr>
+              <a:t>Rôle dans le dojo</a:t>
+            </a:r>
+            <a:endParaRPr lang="en-US" sz="1300" dirty="0"/>
+          </a:p>
+        </p:txBody>
+      </p:sp>
+      <p:sp>
+        <p:nvSpPr>
+          <p:cNvPr id="12" name="Shape 10"/>
+          <p:cNvSpPr/>
+          <p:nvPr/>
+        </p:nvSpPr>
+        <p:spPr>
+          <a:xfrm>
+            <a:off x="4873752" y="1664208"/>
+            <a:ext cx="109728" cy="109728"/>
+          </a:xfrm>
+          <a:prstGeom prst="ellipse">
+            <a:avLst/>
+          </a:prstGeom>
+          <a:solidFill>
+            <a:srgbClr val="1976D2"/>
           </a:solidFill>
           <a:ln w="12700">
             <a:solidFill>
-              <a:srgbClr val="DD0031"/>
+              <a:srgbClr val="1976D2"/>
             </a:solidFill>
             <a:prstDash val="solid"/>
           </a:ln>
@@ -2451,59 +2754,23 @@
       </p:sp>
       <p:sp>
         <p:nvSpPr>
-          <p:cNvPr id="7" name="Text 5"/>
-          <p:cNvSpPr/>
-          <p:nvPr/>
-        </p:nvSpPr>
-        <p:spPr>
-          <a:xfrm>
-            <a:off x="667512" y="1115568"/>
-            <a:ext cx="1143000" cy="228600"/>
-          </a:xfrm>
-          <a:prstGeom prst="rect">
-            <a:avLst/>
-          </a:prstGeom>
-          <a:noFill/>
-          <a:ln/>
-        </p:spPr>
-        <p:txBody>
-          <a:bodyPr wrap="square" lIns="0" tIns="0" rIns="0" bIns="0" rtlCol="0" anchor="ctr"/>
-          <a:lstStyle/>
-          <a:p>
-            <a:pPr indent="0" marL="0">
-              <a:buNone/>
-            </a:pPr>
-            <a:r>
-              <a:rPr lang="en-US" sz="900" b="1" dirty="0">
-                <a:solidFill>
-                  <a:srgbClr val="DD0031"/>
-                </a:solidFill>
-              </a:rPr>
-              <a:t>Définition</a:t>
-            </a:r>
-            <a:endParaRPr lang="en-US" sz="900" dirty="0"/>
-          </a:p>
-        </p:txBody>
-      </p:sp>
-      <p:sp>
-        <p:nvSpPr>
-          <p:cNvPr id="8" name="Text 6"/>
-          <p:cNvSpPr/>
-          <p:nvPr/>
-        </p:nvSpPr>
-        <p:spPr>
-          <a:xfrm>
-            <a:off x="1892808" y="1078992"/>
-            <a:ext cx="9631375" cy="786384"/>
-          </a:xfrm>
-          <a:prstGeom prst="rect">
-            <a:avLst/>
-          </a:prstGeom>
-          <a:noFill/>
-          <a:ln/>
-        </p:spPr>
-        <p:txBody>
-          <a:bodyPr wrap="square" lIns="254" tIns="254" rIns="254" bIns="254" rtlCol="0" anchor="ctr">
+          <p:cNvPr id="13" name="Text 11"/>
+          <p:cNvSpPr/>
+          <p:nvPr/>
+        </p:nvSpPr>
+        <p:spPr>
+          <a:xfrm>
+            <a:off x="5120640" y="1563624"/>
+            <a:ext cx="6385255" cy="438912"/>
+          </a:xfrm>
+          <a:prstGeom prst="rect">
+            <a:avLst/>
+          </a:prstGeom>
+          <a:noFill/>
+          <a:ln/>
+        </p:spPr>
+        <p:txBody>
+          <a:bodyPr wrap="square" lIns="0" tIns="0" rIns="0" bIns="0" rtlCol="0" anchor="ctr">
             <a:normAutofit/>
           </a:bodyPr>
           <a:lstStyle/>
@@ -2512,31 +2779,94 @@
               <a:buNone/>
             </a:pPr>
             <a:r>
-              <a:rPr lang="en-US" sz="1500" dirty="0">
+              <a:rPr lang="en-US" sz="1250" dirty="0">
                 <a:solidFill>
                   <a:srgbClr val="273043"/>
                 </a:solidFill>
               </a:rPr>
-              <a:t>Zone.js intercepte les evenements asynchrones du navigateur et previent Angular qu'un cycle de detection peut etre lance.</a:t>
-            </a:r>
-            <a:endParaRPr lang="en-US" sz="1500" dirty="0"/>
-          </a:p>
-        </p:txBody>
-      </p:sp>
-      <p:sp>
-        <p:nvSpPr>
-          <p:cNvPr id="9" name="Shape 7"/>
-          <p:cNvSpPr/>
-          <p:nvPr/>
-        </p:nvSpPr>
-        <p:spPr>
-          <a:xfrm>
-            <a:off x="411480" y="2788920"/>
-            <a:ext cx="5547208" cy="1143000"/>
+              <a:t>Zone.js declenche la detection apres un evenement async.</a:t>
+            </a:r>
+            <a:endParaRPr lang="en-US" sz="1250" dirty="0"/>
+          </a:p>
+        </p:txBody>
+      </p:sp>
+      <p:sp>
+        <p:nvSpPr>
+          <p:cNvPr id="14" name="Shape 12"/>
+          <p:cNvSpPr/>
+          <p:nvPr/>
+        </p:nvSpPr>
+        <p:spPr>
+          <a:xfrm>
+            <a:off x="4873752" y="2322576"/>
+            <a:ext cx="109728" cy="109728"/>
+          </a:xfrm>
+          <a:prstGeom prst="ellipse">
+            <a:avLst/>
+          </a:prstGeom>
+          <a:solidFill>
+            <a:srgbClr val="1976D2"/>
+          </a:solidFill>
+          <a:ln w="12700">
+            <a:solidFill>
+              <a:srgbClr val="1976D2"/>
+            </a:solidFill>
+            <a:prstDash val="solid"/>
+          </a:ln>
+        </p:spPr>
+      </p:sp>
+      <p:sp>
+        <p:nvSpPr>
+          <p:cNvPr id="15" name="Text 13"/>
+          <p:cNvSpPr/>
+          <p:nvPr/>
+        </p:nvSpPr>
+        <p:spPr>
+          <a:xfrm>
+            <a:off x="5120640" y="2221992"/>
+            <a:ext cx="6385255" cy="438912"/>
+          </a:xfrm>
+          <a:prstGeom prst="rect">
+            <a:avLst/>
+          </a:prstGeom>
+          <a:noFill/>
+          <a:ln/>
+        </p:spPr>
+        <p:txBody>
+          <a:bodyPr wrap="square" lIns="0" tIns="0" rIns="0" bIns="0" rtlCol="0" anchor="ctr">
+            <a:normAutofit/>
+          </a:bodyPr>
+          <a:lstStyle/>
+          <a:p>
+            <a:pPr indent="0" marL="0">
+              <a:buNone/>
+            </a:pPr>
+            <a:r>
+              <a:rPr lang="en-US" sz="1250" dirty="0">
+                <a:solidFill>
+                  <a:srgbClr val="273043"/>
+                </a:solidFill>
+              </a:rPr>
+              <a:t>Zone.js ne dit pas quel etat applicatif a change.</a:t>
+            </a:r>
+            <a:endParaRPr lang="en-US" sz="1250" dirty="0"/>
+          </a:p>
+        </p:txBody>
+      </p:sp>
+      <p:sp>
+        <p:nvSpPr>
+          <p:cNvPr id="16" name="Shape 14"/>
+          <p:cNvSpPr/>
+          <p:nvPr/>
+        </p:nvSpPr>
+        <p:spPr>
+          <a:xfrm>
+            <a:off x="4572000" y="3584448"/>
+            <a:ext cx="7208215" cy="2331720"/>
           </a:xfrm>
           <a:prstGeom prst="roundRect">
             <a:avLst>
-              <a:gd name="adj" fmla="val 6400"/>
+              <a:gd name="adj" fmla="val 3137"/>
             </a:avLst>
           </a:prstGeom>
           <a:solidFill>
@@ -2552,106 +2882,60 @@
       </p:sp>
       <p:sp>
         <p:nvSpPr>
-          <p:cNvPr id="10" name="Text 8"/>
-          <p:cNvSpPr/>
-          <p:nvPr/>
-        </p:nvSpPr>
-        <p:spPr>
-          <a:xfrm>
-            <a:off x="557784" y="2935224"/>
-            <a:ext cx="347472" cy="228600"/>
-          </a:xfrm>
-          <a:prstGeom prst="rect">
-            <a:avLst/>
-          </a:prstGeom>
-          <a:solidFill>
-            <a:srgbClr val="FCE7EC"/>
-          </a:solidFill>
-          <a:ln>
-            <a:solidFill>
-              <a:srgbClr val="FCE7EC"/>
-            </a:solidFill>
-          </a:ln>
+          <p:cNvPr id="17" name="Text 15"/>
+          <p:cNvSpPr/>
+          <p:nvPr/>
+        </p:nvSpPr>
+        <p:spPr>
+          <a:xfrm>
+            <a:off x="4846320" y="3785616"/>
+            <a:ext cx="2926080" cy="256032"/>
+          </a:xfrm>
+          <a:prstGeom prst="rect">
+            <a:avLst/>
+          </a:prstGeom>
+          <a:noFill/>
+          <a:ln/>
         </p:spPr>
         <p:txBody>
           <a:bodyPr wrap="square" lIns="0" tIns="0" rIns="0" bIns="0" rtlCol="0" anchor="ctr"/>
           <a:lstStyle/>
           <a:p>
-            <a:pPr algn="ctr" indent="0" marL="0">
-              <a:buNone/>
-            </a:pPr>
-            <a:r>
-              <a:rPr lang="en-US" sz="800" b="1" dirty="0">
-                <a:solidFill>
-                  <a:srgbClr val="DD0031"/>
-                </a:solidFill>
-              </a:rPr>
-              <a:t>01</a:t>
-            </a:r>
-            <a:endParaRPr lang="en-US" sz="800" dirty="0"/>
-          </a:p>
-        </p:txBody>
-      </p:sp>
-      <p:sp>
-        <p:nvSpPr>
-          <p:cNvPr id="11" name="Text 9"/>
-          <p:cNvSpPr/>
-          <p:nvPr/>
-        </p:nvSpPr>
-        <p:spPr>
-          <a:xfrm>
-            <a:off x="1033272" y="2953512"/>
-            <a:ext cx="4742536" cy="850392"/>
-          </a:xfrm>
-          <a:prstGeom prst="rect">
-            <a:avLst/>
-          </a:prstGeom>
-          <a:noFill/>
-          <a:ln/>
-        </p:spPr>
-        <p:txBody>
-          <a:bodyPr wrap="square" lIns="254" tIns="254" rIns="254" bIns="254" rtlCol="0" anchor="ctr">
-            <a:normAutofit/>
-          </a:bodyPr>
-          <a:lstStyle/>
-          <a:p>
-            <a:pPr indent="0" marL="0">
-              <a:buNone/>
-            </a:pPr>
-            <a:r>
-              <a:rPr lang="en-US" sz="1200" dirty="0">
-                <a:solidFill>
-                  <a:srgbClr val="273043"/>
-                </a:solidFill>
-              </a:rPr>
-              <a:t>Zone.js declenche la detection apres un evenement async.</a:t>
-            </a:r>
-            <a:endParaRPr lang="en-US" sz="1200" dirty="0"/>
-          </a:p>
-        </p:txBody>
-      </p:sp>
-      <p:sp>
-        <p:nvSpPr>
-          <p:cNvPr id="12" name="Shape 10"/>
-          <p:cNvSpPr/>
-          <p:nvPr/>
-        </p:nvSpPr>
-        <p:spPr>
-          <a:xfrm>
-            <a:off x="6233008" y="2788920"/>
-            <a:ext cx="5547208" cy="1143000"/>
-          </a:xfrm>
-          <a:prstGeom prst="roundRect">
-            <a:avLst>
-              <a:gd name="adj" fmla="val 6400"/>
-            </a:avLst>
-          </a:prstGeom>
-          <a:solidFill>
-            <a:srgbClr val="FFFFFF"/>
+            <a:pPr indent="0" marL="0">
+              <a:buNone/>
+            </a:pPr>
+            <a:r>
+              <a:rPr lang="en-US" sz="1300" b="1" dirty="0">
+                <a:solidFill>
+                  <a:srgbClr val="1976D2"/>
+                </a:solidFill>
+              </a:rPr>
+              <a:t>À retenir</a:t>
+            </a:r>
+            <a:endParaRPr lang="en-US" sz="1300" dirty="0"/>
+          </a:p>
+        </p:txBody>
+      </p:sp>
+      <p:sp>
+        <p:nvSpPr>
+          <p:cNvPr id="18" name="Shape 16"/>
+          <p:cNvSpPr/>
+          <p:nvPr/>
+        </p:nvSpPr>
+        <p:spPr>
+          <a:xfrm>
+            <a:off x="4873752" y="4288536"/>
+            <a:ext cx="109728" cy="109728"/>
+          </a:xfrm>
+          <a:prstGeom prst="ellipse">
+            <a:avLst/>
+          </a:prstGeom>
+          <a:solidFill>
+            <a:srgbClr val="1976D2"/>
           </a:solidFill>
           <a:ln w="12700">
             <a:solidFill>
-              <a:srgbClr val="E4E7EC"/>
+              <a:srgbClr val="1976D2"/>
             </a:solidFill>
             <a:prstDash val="solid"/>
           </a:ln>
@@ -2659,65 +2943,23 @@
       </p:sp>
       <p:sp>
         <p:nvSpPr>
-          <p:cNvPr id="13" name="Text 11"/>
-          <p:cNvSpPr/>
-          <p:nvPr/>
-        </p:nvSpPr>
-        <p:spPr>
-          <a:xfrm>
-            <a:off x="6379312" y="2935224"/>
-            <a:ext cx="347472" cy="228600"/>
-          </a:xfrm>
-          <a:prstGeom prst="rect">
-            <a:avLst/>
-          </a:prstGeom>
-          <a:solidFill>
-            <a:srgbClr val="E8F1FF"/>
-          </a:solidFill>
-          <a:ln>
-            <a:solidFill>
-              <a:srgbClr val="E8F1FF"/>
-            </a:solidFill>
-          </a:ln>
-        </p:spPr>
-        <p:txBody>
-          <a:bodyPr wrap="square" lIns="0" tIns="0" rIns="0" bIns="0" rtlCol="0" anchor="ctr"/>
-          <a:lstStyle/>
-          <a:p>
-            <a:pPr algn="ctr" indent="0" marL="0">
-              <a:buNone/>
-            </a:pPr>
-            <a:r>
-              <a:rPr lang="en-US" sz="800" b="1" dirty="0">
-                <a:solidFill>
-                  <a:srgbClr val="1976D2"/>
-                </a:solidFill>
-              </a:rPr>
-              <a:t>02</a:t>
-            </a:r>
-            <a:endParaRPr lang="en-US" sz="800" dirty="0"/>
-          </a:p>
-        </p:txBody>
-      </p:sp>
-      <p:sp>
-        <p:nvSpPr>
-          <p:cNvPr id="14" name="Text 12"/>
-          <p:cNvSpPr/>
-          <p:nvPr/>
-        </p:nvSpPr>
-        <p:spPr>
-          <a:xfrm>
-            <a:off x="6854800" y="2953512"/>
-            <a:ext cx="4742536" cy="850392"/>
-          </a:xfrm>
-          <a:prstGeom prst="rect">
-            <a:avLst/>
-          </a:prstGeom>
-          <a:noFill/>
-          <a:ln/>
-        </p:spPr>
-        <p:txBody>
-          <a:bodyPr wrap="square" lIns="254" tIns="254" rIns="254" bIns="254" rtlCol="0" anchor="ctr">
+          <p:cNvPr id="19" name="Text 17"/>
+          <p:cNvSpPr/>
+          <p:nvPr/>
+        </p:nvSpPr>
+        <p:spPr>
+          <a:xfrm>
+            <a:off x="5120640" y="4187952"/>
+            <a:ext cx="6385255" cy="438912"/>
+          </a:xfrm>
+          <a:prstGeom prst="rect">
+            <a:avLst/>
+          </a:prstGeom>
+          <a:noFill/>
+          <a:ln/>
+        </p:spPr>
+        <p:txBody>
+          <a:bodyPr wrap="square" lIns="0" tIns="0" rIns="0" bIns="0" rtlCol="0" anchor="ctr">
             <a:normAutofit/>
           </a:bodyPr>
           <a:lstStyle/>
@@ -2726,39 +2968,37 @@
               <a:buNone/>
             </a:pPr>
             <a:r>
-              <a:rPr lang="en-US" sz="1200" dirty="0">
+              <a:rPr lang="en-US" sz="1250" dirty="0">
                 <a:solidFill>
                   <a:srgbClr val="273043"/>
                 </a:solidFill>
               </a:rPr>
-              <a:t>Zone.js ne dit pas quel etat applicatif a change.</a:t>
-            </a:r>
-            <a:endParaRPr lang="en-US" sz="1200" dirty="0"/>
-          </a:p>
-        </p:txBody>
-      </p:sp>
-      <p:sp>
-        <p:nvSpPr>
-          <p:cNvPr id="15" name="Shape 13"/>
-          <p:cNvSpPr/>
-          <p:nvPr/>
-        </p:nvSpPr>
-        <p:spPr>
-          <a:xfrm>
-            <a:off x="411480" y="4142232"/>
-            <a:ext cx="5547208" cy="1143000"/>
-          </a:xfrm>
-          <a:prstGeom prst="roundRect">
-            <a:avLst>
-              <a:gd name="adj" fmla="val 6400"/>
-            </a:avLst>
-          </a:prstGeom>
-          <a:solidFill>
-            <a:srgbClr val="FFFFFF"/>
+              <a:t>Le dojo garde Zone.js pour montrer une migration progressive.</a:t>
+            </a:r>
+            <a:endParaRPr lang="en-US" sz="1250" dirty="0"/>
+          </a:p>
+        </p:txBody>
+      </p:sp>
+      <p:sp>
+        <p:nvSpPr>
+          <p:cNvPr id="20" name="Shape 18"/>
+          <p:cNvSpPr/>
+          <p:nvPr/>
+        </p:nvSpPr>
+        <p:spPr>
+          <a:xfrm>
+            <a:off x="4873752" y="4946904"/>
+            <a:ext cx="109728" cy="109728"/>
+          </a:xfrm>
+          <a:prstGeom prst="ellipse">
+            <a:avLst/>
+          </a:prstGeom>
+          <a:solidFill>
+            <a:srgbClr val="1976D2"/>
           </a:solidFill>
           <a:ln w="12700">
             <a:solidFill>
-              <a:srgbClr val="E4E7EC"/>
+              <a:srgbClr val="1976D2"/>
             </a:solidFill>
             <a:prstDash val="solid"/>
           </a:ln>
@@ -2766,65 +3006,23 @@
       </p:sp>
       <p:sp>
         <p:nvSpPr>
-          <p:cNvPr id="16" name="Text 14"/>
-          <p:cNvSpPr/>
-          <p:nvPr/>
-        </p:nvSpPr>
-        <p:spPr>
-          <a:xfrm>
-            <a:off x="557784" y="4288536"/>
-            <a:ext cx="347472" cy="228600"/>
-          </a:xfrm>
-          <a:prstGeom prst="rect">
-            <a:avLst/>
-          </a:prstGeom>
-          <a:solidFill>
-            <a:srgbClr val="EAF7F0"/>
-          </a:solidFill>
-          <a:ln>
-            <a:solidFill>
-              <a:srgbClr val="EAF7F0"/>
-            </a:solidFill>
-          </a:ln>
-        </p:spPr>
-        <p:txBody>
-          <a:bodyPr wrap="square" lIns="0" tIns="0" rIns="0" bIns="0" rtlCol="0" anchor="ctr"/>
-          <a:lstStyle/>
-          <a:p>
-            <a:pPr algn="ctr" indent="0" marL="0">
-              <a:buNone/>
-            </a:pPr>
-            <a:r>
-              <a:rPr lang="en-US" sz="800" b="1" dirty="0">
-                <a:solidFill>
-                  <a:srgbClr val="188038"/>
-                </a:solidFill>
-              </a:rPr>
-              <a:t>03</a:t>
-            </a:r>
-            <a:endParaRPr lang="en-US" sz="800" dirty="0"/>
-          </a:p>
-        </p:txBody>
-      </p:sp>
-      <p:sp>
-        <p:nvSpPr>
-          <p:cNvPr id="17" name="Text 15"/>
-          <p:cNvSpPr/>
-          <p:nvPr/>
-        </p:nvSpPr>
-        <p:spPr>
-          <a:xfrm>
-            <a:off x="1033272" y="4306824"/>
-            <a:ext cx="4742536" cy="850392"/>
-          </a:xfrm>
-          <a:prstGeom prst="rect">
-            <a:avLst/>
-          </a:prstGeom>
-          <a:noFill/>
-          <a:ln/>
-        </p:spPr>
-        <p:txBody>
-          <a:bodyPr wrap="square" lIns="254" tIns="254" rIns="254" bIns="254" rtlCol="0" anchor="ctr">
+          <p:cNvPr id="21" name="Text 19"/>
+          <p:cNvSpPr/>
+          <p:nvPr/>
+        </p:nvSpPr>
+        <p:spPr>
+          <a:xfrm>
+            <a:off x="5120640" y="4846320"/>
+            <a:ext cx="6385255" cy="438912"/>
+          </a:xfrm>
+          <a:prstGeom prst="rect">
+            <a:avLst/>
+          </a:prstGeom>
+          <a:noFill/>
+          <a:ln/>
+        </p:spPr>
+        <p:txBody>
+          <a:bodyPr wrap="square" lIns="0" tIns="0" rIns="0" bIns="0" rtlCol="0" anchor="ctr">
             <a:normAutofit/>
           </a:bodyPr>
           <a:lstStyle/>
@@ -2833,127 +3031,20 @@
               <a:buNone/>
             </a:pPr>
             <a:r>
-              <a:rPr lang="en-US" sz="1200" dirty="0">
+              <a:rPr lang="en-US" sz="1250" dirty="0">
                 <a:solidFill>
                   <a:srgbClr val="273043"/>
                 </a:solidFill>
               </a:rPr>
-              <a:t>Le dojo garde Zone.js pour montrer une migration progressive.</a:t>
-            </a:r>
-            <a:endParaRPr lang="en-US" sz="1200" dirty="0"/>
-          </a:p>
-        </p:txBody>
-      </p:sp>
-      <p:sp>
-        <p:nvSpPr>
-          <p:cNvPr id="18" name="Shape 16"/>
-          <p:cNvSpPr/>
-          <p:nvPr/>
-        </p:nvSpPr>
-        <p:spPr>
-          <a:xfrm>
-            <a:off x="6233008" y="4142232"/>
-            <a:ext cx="5547208" cy="1143000"/>
-          </a:xfrm>
-          <a:prstGeom prst="roundRect">
-            <a:avLst>
-              <a:gd name="adj" fmla="val 6400"/>
-            </a:avLst>
-          </a:prstGeom>
-          <a:solidFill>
-            <a:srgbClr val="FFFFFF"/>
-          </a:solidFill>
-          <a:ln w="12700">
-            <a:solidFill>
-              <a:srgbClr val="E4E7EC"/>
-            </a:solidFill>
-            <a:prstDash val="solid"/>
-          </a:ln>
-        </p:spPr>
-      </p:sp>
-      <p:sp>
-        <p:nvSpPr>
-          <p:cNvPr id="19" name="Text 17"/>
-          <p:cNvSpPr/>
-          <p:nvPr/>
-        </p:nvSpPr>
-        <p:spPr>
-          <a:xfrm>
-            <a:off x="6379312" y="4288536"/>
-            <a:ext cx="347472" cy="228600"/>
-          </a:xfrm>
-          <a:prstGeom prst="rect">
-            <a:avLst/>
-          </a:prstGeom>
-          <a:solidFill>
-            <a:srgbClr val="F0ECFF"/>
-          </a:solidFill>
-          <a:ln>
-            <a:solidFill>
-              <a:srgbClr val="F0ECFF"/>
-            </a:solidFill>
-          </a:ln>
-        </p:spPr>
-        <p:txBody>
-          <a:bodyPr wrap="square" lIns="0" tIns="0" rIns="0" bIns="0" rtlCol="0" anchor="ctr"/>
-          <a:lstStyle/>
-          <a:p>
-            <a:pPr algn="ctr" indent="0" marL="0">
-              <a:buNone/>
-            </a:pPr>
-            <a:r>
-              <a:rPr lang="en-US" sz="800" b="1" dirty="0">
-                <a:solidFill>
-                  <a:srgbClr val="7B61FF"/>
-                </a:solidFill>
-              </a:rPr>
-              <a:t>04</a:t>
-            </a:r>
-            <a:endParaRPr lang="en-US" sz="800" dirty="0"/>
-          </a:p>
-        </p:txBody>
-      </p:sp>
-      <p:sp>
-        <p:nvSpPr>
-          <p:cNvPr id="20" name="Text 18"/>
-          <p:cNvSpPr/>
-          <p:nvPr/>
-        </p:nvSpPr>
-        <p:spPr>
-          <a:xfrm>
-            <a:off x="6854800" y="4306824"/>
-            <a:ext cx="4742536" cy="850392"/>
-          </a:xfrm>
-          <a:prstGeom prst="rect">
-            <a:avLst/>
-          </a:prstGeom>
-          <a:noFill/>
-          <a:ln/>
-        </p:spPr>
-        <p:txBody>
-          <a:bodyPr wrap="square" lIns="254" tIns="254" rIns="254" bIns="254" rtlCol="0" anchor="ctr">
-            <a:normAutofit/>
-          </a:bodyPr>
-          <a:lstStyle/>
-          <a:p>
-            <a:pPr indent="0" marL="0">
-              <a:buNone/>
-            </a:pPr>
-            <a:r>
-              <a:rPr lang="en-US" sz="1200" dirty="0">
-                <a:solidFill>
-                  <a:srgbClr val="273043"/>
-                </a:solidFill>
-              </a:rPr>
               <a:t>Les Signals rendent les dependances d'etat plus explicites.</a:t>
             </a:r>
-            <a:endParaRPr lang="en-US" sz="1200" dirty="0"/>
-          </a:p>
-        </p:txBody>
-      </p:sp>
-      <p:sp>
-        <p:nvSpPr>
-          <p:cNvPr id="21" name="Text 19"/>
+            <a:endParaRPr lang="en-US" sz="1250" dirty="0"/>
+          </a:p>
+        </p:txBody>
+      </p:sp>
+      <p:sp>
+        <p:nvSpPr>
+          <p:cNvPr id="22" name="Text 20"/>
           <p:cNvSpPr/>
           <p:nvPr/>
         </p:nvSpPr>
@@ -2981,7 +3072,7 @@
                   <a:srgbClr val="667085"/>
                 </a:solidFill>
               </a:rPr>
-              <a:t>3/6</a:t>
+              <a:t>3/7</a:t>
             </a:r>
             <a:endParaRPr lang="en-US" sz="700" dirty="0"/>
           </a:p>
@@ -3133,11 +3224,188 @@
         <p:spPr>
           <a:xfrm>
             <a:off x="411480" y="960120"/>
-            <a:ext cx="11368735" cy="1207008"/>
+            <a:ext cx="3794760" cy="5212080"/>
           </a:xfrm>
           <a:prstGeom prst="roundRect">
             <a:avLst>
-              <a:gd name="adj" fmla="val 6061"/>
+              <a:gd name="adj" fmla="val 1928"/>
+            </a:avLst>
+          </a:prstGeom>
+          <a:solidFill>
+            <a:srgbClr val="EAF7F0"/>
+          </a:solidFill>
+          <a:ln w="12700">
+            <a:solidFill>
+              <a:srgbClr val="EAF7F0"/>
+            </a:solidFill>
+            <a:prstDash val="solid"/>
+          </a:ln>
+        </p:spPr>
+      </p:sp>
+      <p:sp>
+        <p:nvSpPr>
+          <p:cNvPr id="6" name="Text 4"/>
+          <p:cNvSpPr/>
+          <p:nvPr/>
+        </p:nvSpPr>
+        <p:spPr>
+          <a:xfrm>
+            <a:off x="704088" y="1234440"/>
+            <a:ext cx="3154680" cy="457200"/>
+          </a:xfrm>
+          <a:prstGeom prst="rect">
+            <a:avLst/>
+          </a:prstGeom>
+          <a:noFill/>
+          <a:ln/>
+        </p:spPr>
+        <p:txBody>
+          <a:bodyPr wrap="square" lIns="0" tIns="0" rIns="0" bIns="0" rtlCol="0" anchor="ctr">
+            <a:normAutofit/>
+          </a:bodyPr>
+          <a:lstStyle/>
+          <a:p>
+            <a:pPr indent="0" marL="0">
+              <a:buNone/>
+            </a:pPr>
+            <a:r>
+              <a:rPr lang="en-US" sz="2600" b="1" dirty="0">
+                <a:solidFill>
+                  <a:srgbClr val="188038"/>
+                </a:solidFill>
+              </a:rPr>
+              <a:t>RxJS</a:t>
+            </a:r>
+            <a:endParaRPr lang="en-US" sz="2600" dirty="0"/>
+          </a:p>
+        </p:txBody>
+      </p:sp>
+      <p:sp>
+        <p:nvSpPr>
+          <p:cNvPr id="7" name="Text 5"/>
+          <p:cNvSpPr/>
+          <p:nvPr/>
+        </p:nvSpPr>
+        <p:spPr>
+          <a:xfrm>
+            <a:off x="704088" y="1993392"/>
+            <a:ext cx="3127248" cy="2148840"/>
+          </a:xfrm>
+          <a:prstGeom prst="rect">
+            <a:avLst/>
+          </a:prstGeom>
+          <a:noFill/>
+          <a:ln/>
+        </p:spPr>
+        <p:txBody>
+          <a:bodyPr wrap="square" lIns="381" tIns="381" rIns="381" bIns="381" rtlCol="0" anchor="ctr">
+            <a:normAutofit/>
+          </a:bodyPr>
+          <a:lstStyle/>
+          <a:p>
+            <a:pPr indent="0" marL="0">
+              <a:buNone/>
+            </a:pPr>
+            <a:r>
+              <a:rPr lang="en-US" sz="1700" b="1" dirty="0">
+                <a:solidFill>
+                  <a:srgbClr val="202124"/>
+                </a:solidFill>
+              </a:rPr>
+              <a:t>RxJS sert a modeliser des flux dans le temps : HTTP, route params, evenements, debounceTime, switchMap, combineLatest.</a:t>
+            </a:r>
+            <a:endParaRPr lang="en-US" sz="1700" dirty="0"/>
+          </a:p>
+        </p:txBody>
+      </p:sp>
+      <p:sp>
+        <p:nvSpPr>
+          <p:cNvPr id="8" name="Text 6"/>
+          <p:cNvSpPr/>
+          <p:nvPr/>
+        </p:nvSpPr>
+        <p:spPr>
+          <a:xfrm>
+            <a:off x="704088" y="4800600"/>
+            <a:ext cx="1188720" cy="182880"/>
+          </a:xfrm>
+          <a:prstGeom prst="rect">
+            <a:avLst/>
+          </a:prstGeom>
+          <a:noFill/>
+          <a:ln/>
+        </p:spPr>
+        <p:txBody>
+          <a:bodyPr wrap="square" lIns="0" tIns="0" rIns="0" bIns="0" rtlCol="0" anchor="ctr"/>
+          <a:lstStyle/>
+          <a:p>
+            <a:pPr indent="0" marL="0">
+              <a:buNone/>
+            </a:pPr>
+            <a:r>
+              <a:rPr lang="en-US" sz="800" b="1" dirty="0">
+                <a:solidFill>
+                  <a:srgbClr val="188038"/>
+                </a:solidFill>
+              </a:rPr>
+              <a:t>Question cle</a:t>
+            </a:r>
+            <a:endParaRPr lang="en-US" sz="800" dirty="0"/>
+          </a:p>
+        </p:txBody>
+      </p:sp>
+      <p:sp>
+        <p:nvSpPr>
+          <p:cNvPr id="9" name="Text 7"/>
+          <p:cNvSpPr/>
+          <p:nvPr/>
+        </p:nvSpPr>
+        <p:spPr>
+          <a:xfrm>
+            <a:off x="704088" y="5074920"/>
+            <a:ext cx="3108960" cy="384048"/>
+          </a:xfrm>
+          <a:prstGeom prst="rect">
+            <a:avLst/>
+          </a:prstGeom>
+          <a:noFill/>
+          <a:ln/>
+        </p:spPr>
+        <p:txBody>
+          <a:bodyPr wrap="square" lIns="0" tIns="0" rIns="0" bIns="0" rtlCol="0" anchor="ctr">
+            <a:normAutofit/>
+          </a:bodyPr>
+          <a:lstStyle/>
+          <a:p>
+            <a:pPr indent="0" marL="0">
+              <a:buNone/>
+            </a:pPr>
+            <a:r>
+              <a:rPr lang="en-US" sz="1200" dirty="0">
+                <a:solidFill>
+                  <a:srgbClr val="273043"/>
+                </a:solidFill>
+              </a:rPr>
+              <a:t>Ou placer la frontiere avec Signals ?</a:t>
+            </a:r>
+            <a:endParaRPr lang="en-US" sz="1200" dirty="0"/>
+          </a:p>
+        </p:txBody>
+      </p:sp>
+      <p:sp>
+        <p:nvSpPr>
+          <p:cNvPr id="10" name="Shape 8"/>
+          <p:cNvSpPr/>
+          <p:nvPr/>
+        </p:nvSpPr>
+        <p:spPr>
+          <a:xfrm>
+            <a:off x="4572000" y="960120"/>
+            <a:ext cx="7208215" cy="2331720"/>
+          </a:xfrm>
+          <a:prstGeom prst="roundRect">
+            <a:avLst>
+              <a:gd name="adj" fmla="val 3137"/>
             </a:avLst>
           </a:prstGeom>
           <a:solidFill>
@@ -3153,24 +3421,60 @@
       </p:sp>
       <p:sp>
         <p:nvSpPr>
-          <p:cNvPr id="6" name="Shape 4"/>
-          <p:cNvSpPr/>
-          <p:nvPr/>
-        </p:nvSpPr>
-        <p:spPr>
-          <a:xfrm>
-            <a:off x="411480" y="960120"/>
-            <a:ext cx="109728" cy="1207008"/>
-          </a:xfrm>
-          <a:prstGeom prst="rect">
-            <a:avLst/>
-          </a:prstGeom>
-          <a:solidFill>
-            <a:srgbClr val="DD0031"/>
+          <p:cNvPr id="11" name="Text 9"/>
+          <p:cNvSpPr/>
+          <p:nvPr/>
+        </p:nvSpPr>
+        <p:spPr>
+          <a:xfrm>
+            <a:off x="4846320" y="1161288"/>
+            <a:ext cx="2926080" cy="256032"/>
+          </a:xfrm>
+          <a:prstGeom prst="rect">
+            <a:avLst/>
+          </a:prstGeom>
+          <a:noFill/>
+          <a:ln/>
+        </p:spPr>
+        <p:txBody>
+          <a:bodyPr wrap="square" lIns="0" tIns="0" rIns="0" bIns="0" rtlCol="0" anchor="ctr"/>
+          <a:lstStyle/>
+          <a:p>
+            <a:pPr indent="0" marL="0">
+              <a:buNone/>
+            </a:pPr>
+            <a:r>
+              <a:rPr lang="en-US" sz="1300" b="1" dirty="0">
+                <a:solidFill>
+                  <a:srgbClr val="188038"/>
+                </a:solidFill>
+              </a:rPr>
+              <a:t>Rôle dans le dojo</a:t>
+            </a:r>
+            <a:endParaRPr lang="en-US" sz="1300" dirty="0"/>
+          </a:p>
+        </p:txBody>
+      </p:sp>
+      <p:sp>
+        <p:nvSpPr>
+          <p:cNvPr id="12" name="Shape 10"/>
+          <p:cNvSpPr/>
+          <p:nvPr/>
+        </p:nvSpPr>
+        <p:spPr>
+          <a:xfrm>
+            <a:off x="4873752" y="1664208"/>
+            <a:ext cx="109728" cy="109728"/>
+          </a:xfrm>
+          <a:prstGeom prst="ellipse">
+            <a:avLst/>
+          </a:prstGeom>
+          <a:solidFill>
+            <a:srgbClr val="188038"/>
           </a:solidFill>
           <a:ln w="12700">
             <a:solidFill>
-              <a:srgbClr val="DD0031"/>
+              <a:srgbClr val="188038"/>
             </a:solidFill>
             <a:prstDash val="solid"/>
           </a:ln>
@@ -3178,59 +3482,23 @@
       </p:sp>
       <p:sp>
         <p:nvSpPr>
-          <p:cNvPr id="7" name="Text 5"/>
-          <p:cNvSpPr/>
-          <p:nvPr/>
-        </p:nvSpPr>
-        <p:spPr>
-          <a:xfrm>
-            <a:off x="667512" y="1115568"/>
-            <a:ext cx="1143000" cy="228600"/>
-          </a:xfrm>
-          <a:prstGeom prst="rect">
-            <a:avLst/>
-          </a:prstGeom>
-          <a:noFill/>
-          <a:ln/>
-        </p:spPr>
-        <p:txBody>
-          <a:bodyPr wrap="square" lIns="0" tIns="0" rIns="0" bIns="0" rtlCol="0" anchor="ctr"/>
-          <a:lstStyle/>
-          <a:p>
-            <a:pPr indent="0" marL="0">
-              <a:buNone/>
-            </a:pPr>
-            <a:r>
-              <a:rPr lang="en-US" sz="900" b="1" dirty="0">
-                <a:solidFill>
-                  <a:srgbClr val="DD0031"/>
-                </a:solidFill>
-              </a:rPr>
-              <a:t>Définition</a:t>
-            </a:r>
-            <a:endParaRPr lang="en-US" sz="900" dirty="0"/>
-          </a:p>
-        </p:txBody>
-      </p:sp>
-      <p:sp>
-        <p:nvSpPr>
-          <p:cNvPr id="8" name="Text 6"/>
-          <p:cNvSpPr/>
-          <p:nvPr/>
-        </p:nvSpPr>
-        <p:spPr>
-          <a:xfrm>
-            <a:off x="1892808" y="1078992"/>
-            <a:ext cx="9631375" cy="786384"/>
-          </a:xfrm>
-          <a:prstGeom prst="rect">
-            <a:avLst/>
-          </a:prstGeom>
-          <a:noFill/>
-          <a:ln/>
-        </p:spPr>
-        <p:txBody>
-          <a:bodyPr wrap="square" lIns="254" tIns="254" rIns="254" bIns="254" rtlCol="0" anchor="ctr">
+          <p:cNvPr id="13" name="Text 11"/>
+          <p:cNvSpPr/>
+          <p:nvPr/>
+        </p:nvSpPr>
+        <p:spPr>
+          <a:xfrm>
+            <a:off x="5120640" y="1563624"/>
+            <a:ext cx="6385255" cy="438912"/>
+          </a:xfrm>
+          <a:prstGeom prst="rect">
+            <a:avLst/>
+          </a:prstGeom>
+          <a:noFill/>
+          <a:ln/>
+        </p:spPr>
+        <p:txBody>
+          <a:bodyPr wrap="square" lIns="0" tIns="0" rIns="0" bIns="0" rtlCol="0" anchor="ctr">
             <a:normAutofit/>
           </a:bodyPr>
           <a:lstStyle/>
@@ -3239,31 +3507,94 @@
               <a:buNone/>
             </a:pPr>
             <a:r>
-              <a:rPr lang="en-US" sz="1500" dirty="0">
+              <a:rPr lang="en-US" sz="1250" dirty="0">
                 <a:solidFill>
                   <a:srgbClr val="273043"/>
                 </a:solidFill>
               </a:rPr>
-              <a:t>RxJS sert a modeliser des flux dans le temps : HTTP, route params, evenements, debounceTime, switchMap, combineLatest.</a:t>
-            </a:r>
-            <a:endParaRPr lang="en-US" sz="1500" dirty="0"/>
-          </a:p>
-        </p:txBody>
-      </p:sp>
-      <p:sp>
-        <p:nvSpPr>
-          <p:cNvPr id="9" name="Shape 7"/>
-          <p:cNvSpPr/>
-          <p:nvPr/>
-        </p:nvSpPr>
-        <p:spPr>
-          <a:xfrm>
-            <a:off x="411480" y="2788920"/>
-            <a:ext cx="5547208" cy="1143000"/>
+              <a:t>RxJS reste adapte aux flux asynchrones.</a:t>
+            </a:r>
+            <a:endParaRPr lang="en-US" sz="1250" dirty="0"/>
+          </a:p>
+        </p:txBody>
+      </p:sp>
+      <p:sp>
+        <p:nvSpPr>
+          <p:cNvPr id="14" name="Shape 12"/>
+          <p:cNvSpPr/>
+          <p:nvPr/>
+        </p:nvSpPr>
+        <p:spPr>
+          <a:xfrm>
+            <a:off x="4873752" y="2322576"/>
+            <a:ext cx="109728" cy="109728"/>
+          </a:xfrm>
+          <a:prstGeom prst="ellipse">
+            <a:avLst/>
+          </a:prstGeom>
+          <a:solidFill>
+            <a:srgbClr val="188038"/>
+          </a:solidFill>
+          <a:ln w="12700">
+            <a:solidFill>
+              <a:srgbClr val="188038"/>
+            </a:solidFill>
+            <a:prstDash val="solid"/>
+          </a:ln>
+        </p:spPr>
+      </p:sp>
+      <p:sp>
+        <p:nvSpPr>
+          <p:cNvPr id="15" name="Text 13"/>
+          <p:cNvSpPr/>
+          <p:nvPr/>
+        </p:nvSpPr>
+        <p:spPr>
+          <a:xfrm>
+            <a:off x="5120640" y="2221992"/>
+            <a:ext cx="6385255" cy="438912"/>
+          </a:xfrm>
+          <a:prstGeom prst="rect">
+            <a:avLst/>
+          </a:prstGeom>
+          <a:noFill/>
+          <a:ln/>
+        </p:spPr>
+        <p:txBody>
+          <a:bodyPr wrap="square" lIns="0" tIns="0" rIns="0" bIns="0" rtlCol="0" anchor="ctr">
+            <a:normAutofit/>
+          </a:bodyPr>
+          <a:lstStyle/>
+          <a:p>
+            <a:pPr indent="0" marL="0">
+              <a:buNone/>
+            </a:pPr>
+            <a:r>
+              <a:rPr lang="en-US" sz="1250" dirty="0">
+                <a:solidFill>
+                  <a:srgbClr val="273043"/>
+                </a:solidFill>
+              </a:rPr>
+              <a:t>toSignal() expose la derniere valeur d'un Observable comme signal.</a:t>
+            </a:r>
+            <a:endParaRPr lang="en-US" sz="1250" dirty="0"/>
+          </a:p>
+        </p:txBody>
+      </p:sp>
+      <p:sp>
+        <p:nvSpPr>
+          <p:cNvPr id="16" name="Shape 14"/>
+          <p:cNvSpPr/>
+          <p:nvPr/>
+        </p:nvSpPr>
+        <p:spPr>
+          <a:xfrm>
+            <a:off x="4572000" y="3584448"/>
+            <a:ext cx="7208215" cy="2331720"/>
           </a:xfrm>
           <a:prstGeom prst="roundRect">
             <a:avLst>
-              <a:gd name="adj" fmla="val 6400"/>
+              <a:gd name="adj" fmla="val 3137"/>
             </a:avLst>
           </a:prstGeom>
           <a:solidFill>
@@ -3279,106 +3610,60 @@
       </p:sp>
       <p:sp>
         <p:nvSpPr>
-          <p:cNvPr id="10" name="Text 8"/>
-          <p:cNvSpPr/>
-          <p:nvPr/>
-        </p:nvSpPr>
-        <p:spPr>
-          <a:xfrm>
-            <a:off x="557784" y="2935224"/>
-            <a:ext cx="347472" cy="228600"/>
-          </a:xfrm>
-          <a:prstGeom prst="rect">
-            <a:avLst/>
-          </a:prstGeom>
-          <a:solidFill>
-            <a:srgbClr val="FCE7EC"/>
-          </a:solidFill>
-          <a:ln>
-            <a:solidFill>
-              <a:srgbClr val="FCE7EC"/>
-            </a:solidFill>
-          </a:ln>
+          <p:cNvPr id="17" name="Text 15"/>
+          <p:cNvSpPr/>
+          <p:nvPr/>
+        </p:nvSpPr>
+        <p:spPr>
+          <a:xfrm>
+            <a:off x="4846320" y="3785616"/>
+            <a:ext cx="2926080" cy="256032"/>
+          </a:xfrm>
+          <a:prstGeom prst="rect">
+            <a:avLst/>
+          </a:prstGeom>
+          <a:noFill/>
+          <a:ln/>
         </p:spPr>
         <p:txBody>
           <a:bodyPr wrap="square" lIns="0" tIns="0" rIns="0" bIns="0" rtlCol="0" anchor="ctr"/>
           <a:lstStyle/>
           <a:p>
-            <a:pPr algn="ctr" indent="0" marL="0">
-              <a:buNone/>
-            </a:pPr>
-            <a:r>
-              <a:rPr lang="en-US" sz="800" b="1" dirty="0">
-                <a:solidFill>
-                  <a:srgbClr val="DD0031"/>
-                </a:solidFill>
-              </a:rPr>
-              <a:t>01</a:t>
-            </a:r>
-            <a:endParaRPr lang="en-US" sz="800" dirty="0"/>
-          </a:p>
-        </p:txBody>
-      </p:sp>
-      <p:sp>
-        <p:nvSpPr>
-          <p:cNvPr id="11" name="Text 9"/>
-          <p:cNvSpPr/>
-          <p:nvPr/>
-        </p:nvSpPr>
-        <p:spPr>
-          <a:xfrm>
-            <a:off x="1033272" y="2953512"/>
-            <a:ext cx="4742536" cy="850392"/>
-          </a:xfrm>
-          <a:prstGeom prst="rect">
-            <a:avLst/>
-          </a:prstGeom>
-          <a:noFill/>
-          <a:ln/>
-        </p:spPr>
-        <p:txBody>
-          <a:bodyPr wrap="square" lIns="254" tIns="254" rIns="254" bIns="254" rtlCol="0" anchor="ctr">
-            <a:normAutofit/>
-          </a:bodyPr>
-          <a:lstStyle/>
-          <a:p>
-            <a:pPr indent="0" marL="0">
-              <a:buNone/>
-            </a:pPr>
-            <a:r>
-              <a:rPr lang="en-US" sz="1200" dirty="0">
-                <a:solidFill>
-                  <a:srgbClr val="273043"/>
-                </a:solidFill>
-              </a:rPr>
-              <a:t>RxJS reste adapte aux flux asynchrones.</a:t>
-            </a:r>
-            <a:endParaRPr lang="en-US" sz="1200" dirty="0"/>
-          </a:p>
-        </p:txBody>
-      </p:sp>
-      <p:sp>
-        <p:nvSpPr>
-          <p:cNvPr id="12" name="Shape 10"/>
-          <p:cNvSpPr/>
-          <p:nvPr/>
-        </p:nvSpPr>
-        <p:spPr>
-          <a:xfrm>
-            <a:off x="6233008" y="2788920"/>
-            <a:ext cx="5547208" cy="1143000"/>
-          </a:xfrm>
-          <a:prstGeom prst="roundRect">
-            <a:avLst>
-              <a:gd name="adj" fmla="val 6400"/>
-            </a:avLst>
-          </a:prstGeom>
-          <a:solidFill>
-            <a:srgbClr val="FFFFFF"/>
+            <a:pPr indent="0" marL="0">
+              <a:buNone/>
+            </a:pPr>
+            <a:r>
+              <a:rPr lang="en-US" sz="1300" b="1" dirty="0">
+                <a:solidFill>
+                  <a:srgbClr val="188038"/>
+                </a:solidFill>
+              </a:rPr>
+              <a:t>À retenir</a:t>
+            </a:r>
+            <a:endParaRPr lang="en-US" sz="1300" dirty="0"/>
+          </a:p>
+        </p:txBody>
+      </p:sp>
+      <p:sp>
+        <p:nvSpPr>
+          <p:cNvPr id="18" name="Shape 16"/>
+          <p:cNvSpPr/>
+          <p:nvPr/>
+        </p:nvSpPr>
+        <p:spPr>
+          <a:xfrm>
+            <a:off x="4873752" y="4288536"/>
+            <a:ext cx="109728" cy="109728"/>
+          </a:xfrm>
+          <a:prstGeom prst="ellipse">
+            <a:avLst/>
+          </a:prstGeom>
+          <a:solidFill>
+            <a:srgbClr val="188038"/>
           </a:solidFill>
           <a:ln w="12700">
             <a:solidFill>
-              <a:srgbClr val="E4E7EC"/>
+              <a:srgbClr val="188038"/>
             </a:solidFill>
             <a:prstDash val="solid"/>
           </a:ln>
@@ -3386,65 +3671,23 @@
       </p:sp>
       <p:sp>
         <p:nvSpPr>
-          <p:cNvPr id="13" name="Text 11"/>
-          <p:cNvSpPr/>
-          <p:nvPr/>
-        </p:nvSpPr>
-        <p:spPr>
-          <a:xfrm>
-            <a:off x="6379312" y="2935224"/>
-            <a:ext cx="347472" cy="228600"/>
-          </a:xfrm>
-          <a:prstGeom prst="rect">
-            <a:avLst/>
-          </a:prstGeom>
-          <a:solidFill>
-            <a:srgbClr val="E8F1FF"/>
-          </a:solidFill>
-          <a:ln>
-            <a:solidFill>
-              <a:srgbClr val="E8F1FF"/>
-            </a:solidFill>
-          </a:ln>
-        </p:spPr>
-        <p:txBody>
-          <a:bodyPr wrap="square" lIns="0" tIns="0" rIns="0" bIns="0" rtlCol="0" anchor="ctr"/>
-          <a:lstStyle/>
-          <a:p>
-            <a:pPr algn="ctr" indent="0" marL="0">
-              <a:buNone/>
-            </a:pPr>
-            <a:r>
-              <a:rPr lang="en-US" sz="800" b="1" dirty="0">
-                <a:solidFill>
-                  <a:srgbClr val="1976D2"/>
-                </a:solidFill>
-              </a:rPr>
-              <a:t>02</a:t>
-            </a:r>
-            <a:endParaRPr lang="en-US" sz="800" dirty="0"/>
-          </a:p>
-        </p:txBody>
-      </p:sp>
-      <p:sp>
-        <p:nvSpPr>
-          <p:cNvPr id="14" name="Text 12"/>
-          <p:cNvSpPr/>
-          <p:nvPr/>
-        </p:nvSpPr>
-        <p:spPr>
-          <a:xfrm>
-            <a:off x="6854800" y="2953512"/>
-            <a:ext cx="4742536" cy="850392"/>
-          </a:xfrm>
-          <a:prstGeom prst="rect">
-            <a:avLst/>
-          </a:prstGeom>
-          <a:noFill/>
-          <a:ln/>
-        </p:spPr>
-        <p:txBody>
-          <a:bodyPr wrap="square" lIns="254" tIns="254" rIns="254" bIns="254" rtlCol="0" anchor="ctr">
+          <p:cNvPr id="19" name="Text 17"/>
+          <p:cNvSpPr/>
+          <p:nvPr/>
+        </p:nvSpPr>
+        <p:spPr>
+          <a:xfrm>
+            <a:off x="5120640" y="4187952"/>
+            <a:ext cx="6385255" cy="438912"/>
+          </a:xfrm>
+          <a:prstGeom prst="rect">
+            <a:avLst/>
+          </a:prstGeom>
+          <a:noFill/>
+          <a:ln/>
+        </p:spPr>
+        <p:txBody>
+          <a:bodyPr wrap="square" lIns="0" tIns="0" rIns="0" bIns="0" rtlCol="0" anchor="ctr">
             <a:normAutofit/>
           </a:bodyPr>
           <a:lstStyle/>
@@ -3453,39 +3696,37 @@
               <a:buNone/>
             </a:pPr>
             <a:r>
-              <a:rPr lang="en-US" sz="1200" dirty="0">
+              <a:rPr lang="en-US" sz="1250" dirty="0">
                 <a:solidFill>
                   <a:srgbClr val="273043"/>
                 </a:solidFill>
               </a:rPr>
-              <a:t>toSignal() expose la derniere valeur d'un Observable comme signal.</a:t>
-            </a:r>
-            <a:endParaRPr lang="en-US" sz="1200" dirty="0"/>
-          </a:p>
-        </p:txBody>
-      </p:sp>
-      <p:sp>
-        <p:nvSpPr>
-          <p:cNvPr id="15" name="Shape 13"/>
-          <p:cNvSpPr/>
-          <p:nvPr/>
-        </p:nvSpPr>
-        <p:spPr>
-          <a:xfrm>
-            <a:off x="411480" y="4142232"/>
-            <a:ext cx="5547208" cy="1143000"/>
-          </a:xfrm>
-          <a:prstGeom prst="roundRect">
-            <a:avLst>
-              <a:gd name="adj" fmla="val 6400"/>
-            </a:avLst>
-          </a:prstGeom>
-          <a:solidFill>
-            <a:srgbClr val="FFFFFF"/>
+              <a:t>toObservable() expose un signal comme Observable.</a:t>
+            </a:r>
+            <a:endParaRPr lang="en-US" sz="1250" dirty="0"/>
+          </a:p>
+        </p:txBody>
+      </p:sp>
+      <p:sp>
+        <p:nvSpPr>
+          <p:cNvPr id="20" name="Shape 18"/>
+          <p:cNvSpPr/>
+          <p:nvPr/>
+        </p:nvSpPr>
+        <p:spPr>
+          <a:xfrm>
+            <a:off x="4873752" y="4946904"/>
+            <a:ext cx="109728" cy="109728"/>
+          </a:xfrm>
+          <a:prstGeom prst="ellipse">
+            <a:avLst/>
+          </a:prstGeom>
+          <a:solidFill>
+            <a:srgbClr val="188038"/>
           </a:solidFill>
           <a:ln w="12700">
             <a:solidFill>
-              <a:srgbClr val="E4E7EC"/>
+              <a:srgbClr val="188038"/>
             </a:solidFill>
             <a:prstDash val="solid"/>
           </a:ln>
@@ -3493,65 +3734,23 @@
       </p:sp>
       <p:sp>
         <p:nvSpPr>
-          <p:cNvPr id="16" name="Text 14"/>
-          <p:cNvSpPr/>
-          <p:nvPr/>
-        </p:nvSpPr>
-        <p:spPr>
-          <a:xfrm>
-            <a:off x="557784" y="4288536"/>
-            <a:ext cx="347472" cy="228600"/>
-          </a:xfrm>
-          <a:prstGeom prst="rect">
-            <a:avLst/>
-          </a:prstGeom>
-          <a:solidFill>
-            <a:srgbClr val="EAF7F0"/>
-          </a:solidFill>
-          <a:ln>
-            <a:solidFill>
-              <a:srgbClr val="EAF7F0"/>
-            </a:solidFill>
-          </a:ln>
-        </p:spPr>
-        <p:txBody>
-          <a:bodyPr wrap="square" lIns="0" tIns="0" rIns="0" bIns="0" rtlCol="0" anchor="ctr"/>
-          <a:lstStyle/>
-          <a:p>
-            <a:pPr algn="ctr" indent="0" marL="0">
-              <a:buNone/>
-            </a:pPr>
-            <a:r>
-              <a:rPr lang="en-US" sz="800" b="1" dirty="0">
-                <a:solidFill>
-                  <a:srgbClr val="188038"/>
-                </a:solidFill>
-              </a:rPr>
-              <a:t>03</a:t>
-            </a:r>
-            <a:endParaRPr lang="en-US" sz="800" dirty="0"/>
-          </a:p>
-        </p:txBody>
-      </p:sp>
-      <p:sp>
-        <p:nvSpPr>
-          <p:cNvPr id="17" name="Text 15"/>
-          <p:cNvSpPr/>
-          <p:nvPr/>
-        </p:nvSpPr>
-        <p:spPr>
-          <a:xfrm>
-            <a:off x="1033272" y="4306824"/>
-            <a:ext cx="4742536" cy="850392"/>
-          </a:xfrm>
-          <a:prstGeom prst="rect">
-            <a:avLst/>
-          </a:prstGeom>
-          <a:noFill/>
-          <a:ln/>
-        </p:spPr>
-        <p:txBody>
-          <a:bodyPr wrap="square" lIns="254" tIns="254" rIns="254" bIns="254" rtlCol="0" anchor="ctr">
+          <p:cNvPr id="21" name="Text 19"/>
+          <p:cNvSpPr/>
+          <p:nvPr/>
+        </p:nvSpPr>
+        <p:spPr>
+          <a:xfrm>
+            <a:off x="5120640" y="4846320"/>
+            <a:ext cx="6385255" cy="438912"/>
+          </a:xfrm>
+          <a:prstGeom prst="rect">
+            <a:avLst/>
+          </a:prstGeom>
+          <a:noFill/>
+          <a:ln/>
+        </p:spPr>
+        <p:txBody>
+          <a:bodyPr wrap="square" lIns="0" tIns="0" rIns="0" bIns="0" rtlCol="0" anchor="ctr">
             <a:normAutofit/>
           </a:bodyPr>
           <a:lstStyle/>
@@ -3560,127 +3759,20 @@
               <a:buNone/>
             </a:pPr>
             <a:r>
-              <a:rPr lang="en-US" sz="1200" dirty="0">
+              <a:rPr lang="en-US" sz="1250" dirty="0">
                 <a:solidFill>
                   <a:srgbClr val="273043"/>
                 </a:solidFill>
               </a:rPr>
-              <a:t>toObservable() expose un signal comme Observable.</a:t>
-            </a:r>
-            <a:endParaRPr lang="en-US" sz="1200" dirty="0"/>
-          </a:p>
-        </p:txBody>
-      </p:sp>
-      <p:sp>
-        <p:nvSpPr>
-          <p:cNvPr id="18" name="Shape 16"/>
-          <p:cNvSpPr/>
-          <p:nvPr/>
-        </p:nvSpPr>
-        <p:spPr>
-          <a:xfrm>
-            <a:off x="6233008" y="4142232"/>
-            <a:ext cx="5547208" cy="1143000"/>
-          </a:xfrm>
-          <a:prstGeom prst="roundRect">
-            <a:avLst>
-              <a:gd name="adj" fmla="val 6400"/>
-            </a:avLst>
-          </a:prstGeom>
-          <a:solidFill>
-            <a:srgbClr val="FFFFFF"/>
-          </a:solidFill>
-          <a:ln w="12700">
-            <a:solidFill>
-              <a:srgbClr val="E4E7EC"/>
-            </a:solidFill>
-            <a:prstDash val="solid"/>
-          </a:ln>
-        </p:spPr>
-      </p:sp>
-      <p:sp>
-        <p:nvSpPr>
-          <p:cNvPr id="19" name="Text 17"/>
-          <p:cNvSpPr/>
-          <p:nvPr/>
-        </p:nvSpPr>
-        <p:spPr>
-          <a:xfrm>
-            <a:off x="6379312" y="4288536"/>
-            <a:ext cx="347472" cy="228600"/>
-          </a:xfrm>
-          <a:prstGeom prst="rect">
-            <a:avLst/>
-          </a:prstGeom>
-          <a:solidFill>
-            <a:srgbClr val="F0ECFF"/>
-          </a:solidFill>
-          <a:ln>
-            <a:solidFill>
-              <a:srgbClr val="F0ECFF"/>
-            </a:solidFill>
-          </a:ln>
-        </p:spPr>
-        <p:txBody>
-          <a:bodyPr wrap="square" lIns="0" tIns="0" rIns="0" bIns="0" rtlCol="0" anchor="ctr"/>
-          <a:lstStyle/>
-          <a:p>
-            <a:pPr algn="ctr" indent="0" marL="0">
-              <a:buNone/>
-            </a:pPr>
-            <a:r>
-              <a:rPr lang="en-US" sz="800" b="1" dirty="0">
-                <a:solidFill>
-                  <a:srgbClr val="7B61FF"/>
-                </a:solidFill>
-              </a:rPr>
-              <a:t>04</a:t>
-            </a:r>
-            <a:endParaRPr lang="en-US" sz="800" dirty="0"/>
-          </a:p>
-        </p:txBody>
-      </p:sp>
-      <p:sp>
-        <p:nvSpPr>
-          <p:cNvPr id="20" name="Text 18"/>
-          <p:cNvSpPr/>
-          <p:nvPr/>
-        </p:nvSpPr>
-        <p:spPr>
-          <a:xfrm>
-            <a:off x="6854800" y="4306824"/>
-            <a:ext cx="4742536" cy="850392"/>
-          </a:xfrm>
-          <a:prstGeom prst="rect">
-            <a:avLst/>
-          </a:prstGeom>
-          <a:noFill/>
-          <a:ln/>
-        </p:spPr>
-        <p:txBody>
-          <a:bodyPr wrap="square" lIns="254" tIns="254" rIns="254" bIns="254" rtlCol="0" anchor="ctr">
-            <a:normAutofit/>
-          </a:bodyPr>
-          <a:lstStyle/>
-          <a:p>
-            <a:pPr indent="0" marL="0">
-              <a:buNone/>
-            </a:pPr>
-            <a:r>
-              <a:rPr lang="en-US" sz="1200" dirty="0">
-                <a:solidFill>
-                  <a:srgbClr val="273043"/>
-                </a:solidFill>
-              </a:rPr>
               <a:t>Le but est de placer clairement la frontiere entre flux RxJS et etat signal.</a:t>
             </a:r>
-            <a:endParaRPr lang="en-US" sz="1200" dirty="0"/>
-          </a:p>
-        </p:txBody>
-      </p:sp>
-      <p:sp>
-        <p:nvSpPr>
-          <p:cNvPr id="21" name="Text 19"/>
+            <a:endParaRPr lang="en-US" sz="1250" dirty="0"/>
+          </a:p>
+        </p:txBody>
+      </p:sp>
+      <p:sp>
+        <p:nvSpPr>
+          <p:cNvPr id="22" name="Text 20"/>
           <p:cNvSpPr/>
           <p:nvPr/>
         </p:nvSpPr>
@@ -3708,7 +3800,7 @@
                   <a:srgbClr val="667085"/>
                 </a:solidFill>
               </a:rPr>
-              <a:t>4/6</a:t>
+              <a:t>4/7</a:t>
             </a:r>
             <a:endParaRPr lang="en-US" sz="700" dirty="0"/>
           </a:p>
@@ -4531,7 +4623,7 @@
                   <a:srgbClr val="667085"/>
                 </a:solidFill>
               </a:rPr>
-              <a:t>5/6</a:t>
+              <a:t>5/7</a:t>
             </a:r>
             <a:endParaRPr lang="en-US" sz="700" dirty="0"/>
           </a:p>
@@ -6364,18 +6456,191 @@
       </p:sp>
       <p:sp>
         <p:nvSpPr>
-          <p:cNvPr id="53" name="Shape 51"/>
-          <p:cNvSpPr/>
-          <p:nvPr/>
-        </p:nvSpPr>
-        <p:spPr>
-          <a:xfrm>
-            <a:off x="411480" y="5989320"/>
-            <a:ext cx="11368735" cy="384048"/>
+          <p:cNvPr id="53" name="Text 51"/>
+          <p:cNvSpPr/>
+          <p:nvPr/>
+        </p:nvSpPr>
+        <p:spPr>
+          <a:xfrm>
+            <a:off x="11277295" y="6537960"/>
+            <a:ext cx="502920" cy="182880"/>
+          </a:xfrm>
+          <a:prstGeom prst="rect">
+            <a:avLst/>
+          </a:prstGeom>
+          <a:noFill/>
+          <a:ln/>
+        </p:spPr>
+        <p:txBody>
+          <a:bodyPr wrap="square" rtlCol="0" anchor="ctr"/>
+          <a:lstStyle/>
+          <a:p>
+            <a:pPr algn="r" indent="0" marL="0">
+              <a:buNone/>
+            </a:pPr>
+            <a:r>
+              <a:rPr lang="en-US" sz="700" dirty="0">
+                <a:solidFill>
+                  <a:srgbClr val="667085"/>
+                </a:solidFill>
+              </a:rPr>
+              <a:t>6/7</a:t>
+            </a:r>
+            <a:endParaRPr lang="en-US" sz="700" dirty="0"/>
+          </a:p>
+        </p:txBody>
+      </p:sp>
+    </p:spTree>
+  </p:cSld>
+  <p:clrMapOvr>
+    <a:masterClrMapping/>
+  </p:clrMapOvr>
+</p:sld>
+</file>
+
+<file path=ppt/slides/slide7.xml><?xml version="1.0" encoding="utf-8"?>
+<p:sld xmlns:a="http://schemas.openxmlformats.org/drawingml/2006/main" xmlns:r="http://schemas.openxmlformats.org/officeDocument/2006/relationships" xmlns:p="http://schemas.openxmlformats.org/presentationml/2006/main">
+  <p:cSld name="Slide 7">
+    <p:bg>
+      <p:bgPr>
+        <a:solidFill>
+          <a:srgbClr val="F7F9FC"/>
+        </a:solidFill>
+      </p:bgPr>
+    </p:bg>
+    <p:spTree>
+      <p:nvGrpSpPr>
+        <p:cNvPr id="1" name=""/>
+        <p:cNvGrpSpPr/>
+        <p:nvPr/>
+      </p:nvGrpSpPr>
+      <p:grpSpPr>
+        <a:xfrm>
+          <a:off x="0" y="0"/>
+          <a:ext cx="0" cy="0"/>
+          <a:chOff x="0" y="0"/>
+          <a:chExt cx="0" cy="0"/>
+        </a:xfrm>
+      </p:grpSpPr>
+      <p:sp>
+        <p:nvSpPr>
+          <p:cNvPr id="2" name="Shape 0"/>
+          <p:cNvSpPr/>
+          <p:nvPr/>
+        </p:nvSpPr>
+        <p:spPr>
+          <a:xfrm>
+            <a:off x="0" y="0"/>
+            <a:ext cx="12191695" cy="91440"/>
+          </a:xfrm>
+          <a:prstGeom prst="rect">
+            <a:avLst/>
+          </a:prstGeom>
+          <a:solidFill>
+            <a:srgbClr val="188038"/>
+          </a:solidFill>
+          <a:ln w="12700">
+            <a:solidFill>
+              <a:srgbClr val="188038"/>
+            </a:solidFill>
+            <a:prstDash val="solid"/>
+          </a:ln>
+        </p:spPr>
+      </p:sp>
+      <p:sp>
+        <p:nvSpPr>
+          <p:cNvPr id="3" name="Text 1"/>
+          <p:cNvSpPr/>
+          <p:nvPr/>
+        </p:nvSpPr>
+        <p:spPr>
+          <a:xfrm>
+            <a:off x="411480" y="219456"/>
+            <a:ext cx="9357055" cy="347472"/>
+          </a:xfrm>
+          <a:prstGeom prst="rect">
+            <a:avLst/>
+          </a:prstGeom>
+          <a:noFill/>
+          <a:ln/>
+        </p:spPr>
+        <p:txBody>
+          <a:bodyPr wrap="square" lIns="0" tIns="0" rIns="0" bIns="0" rtlCol="0" anchor="ctr">
+            <a:normAutofit/>
+          </a:bodyPr>
+          <a:lstStyle/>
+          <a:p>
+            <a:pPr indent="0" marL="0">
+              <a:buNone/>
+            </a:pPr>
+            <a:r>
+              <a:rPr lang="en-US" sz="2000" b="1" dirty="0">
+                <a:solidFill>
+                  <a:srgbClr val="202124"/>
+                </a:solidFill>
+              </a:rPr>
+              <a:t>Rappel tests</a:t>
+            </a:r>
+            <a:endParaRPr lang="en-US" sz="2000" dirty="0"/>
+          </a:p>
+        </p:txBody>
+      </p:sp>
+      <p:sp>
+        <p:nvSpPr>
+          <p:cNvPr id="4" name="Text 2"/>
+          <p:cNvSpPr/>
+          <p:nvPr/>
+        </p:nvSpPr>
+        <p:spPr>
+          <a:xfrm>
+            <a:off x="10317175" y="246888"/>
+            <a:ext cx="1463040" cy="219456"/>
+          </a:xfrm>
+          <a:prstGeom prst="rect">
+            <a:avLst/>
+          </a:prstGeom>
+          <a:solidFill>
+            <a:srgbClr val="FCE7EC"/>
+          </a:solidFill>
+          <a:ln>
+            <a:solidFill>
+              <a:srgbClr val="FCE7EC"/>
+            </a:solidFill>
+          </a:ln>
+        </p:spPr>
+        <p:txBody>
+          <a:bodyPr wrap="square" lIns="254" tIns="254" rIns="254" bIns="254" rtlCol="0" anchor="ctr"/>
+          <a:lstStyle/>
+          <a:p>
+            <a:pPr algn="ctr" indent="0" marL="0">
+              <a:buNone/>
+            </a:pPr>
+            <a:r>
+              <a:rPr lang="en-US" sz="800" b="1" dirty="0">
+                <a:solidFill>
+                  <a:srgbClr val="188038"/>
+                </a:solidFill>
+              </a:rPr>
+              <a:t>Angular Signals</a:t>
+            </a:r>
+            <a:endParaRPr lang="en-US" sz="800" dirty="0"/>
+          </a:p>
+        </p:txBody>
+      </p:sp>
+      <p:sp>
+        <p:nvSpPr>
+          <p:cNvPr id="5" name="Shape 3"/>
+          <p:cNvSpPr/>
+          <p:nvPr/>
+        </p:nvSpPr>
+        <p:spPr>
+          <a:xfrm>
+            <a:off x="411480" y="987552"/>
+            <a:ext cx="3977640" cy="5074920"/>
           </a:xfrm>
           <a:prstGeom prst="roundRect">
             <a:avLst>
-              <a:gd name="adj" fmla="val 14286"/>
+              <a:gd name="adj" fmla="val 1839"/>
             </a:avLst>
           </a:prstGeom>
           <a:solidFill>
@@ -6391,14 +6656,93 @@
       </p:sp>
       <p:sp>
         <p:nvSpPr>
-          <p:cNvPr id="54" name="Text 52"/>
-          <p:cNvSpPr/>
-          <p:nvPr/>
-        </p:nvSpPr>
-        <p:spPr>
-          <a:xfrm>
-            <a:off x="576072" y="6080760"/>
-            <a:ext cx="11039551" cy="173736"/>
+          <p:cNvPr id="6" name="Text 4"/>
+          <p:cNvSpPr/>
+          <p:nvPr/>
+        </p:nvSpPr>
+        <p:spPr>
+          <a:xfrm>
+            <a:off x="731520" y="1298448"/>
+            <a:ext cx="1097280" cy="228600"/>
+          </a:xfrm>
+          <a:prstGeom prst="rect">
+            <a:avLst/>
+          </a:prstGeom>
+          <a:noFill/>
+          <a:ln/>
+        </p:spPr>
+        <p:txBody>
+          <a:bodyPr wrap="square" lIns="0" tIns="0" rIns="0" bIns="0" rtlCol="0" anchor="ctr"/>
+          <a:lstStyle/>
+          <a:p>
+            <a:pPr indent="0" marL="0">
+              <a:buNone/>
+            </a:pPr>
+            <a:r>
+              <a:rPr lang="en-US" sz="1000" b="1" dirty="0">
+                <a:solidFill>
+                  <a:srgbClr val="188038"/>
+                </a:solidFill>
+              </a:rPr>
+              <a:t>À lancer</a:t>
+            </a:r>
+            <a:endParaRPr lang="en-US" sz="1000" dirty="0"/>
+          </a:p>
+        </p:txBody>
+      </p:sp>
+      <p:sp>
+        <p:nvSpPr>
+          <p:cNvPr id="7" name="Text 5"/>
+          <p:cNvSpPr/>
+          <p:nvPr/>
+        </p:nvSpPr>
+        <p:spPr>
+          <a:xfrm>
+            <a:off x="731520" y="1847088"/>
+            <a:ext cx="3246120" cy="658368"/>
+          </a:xfrm>
+          <a:prstGeom prst="rect">
+            <a:avLst/>
+          </a:prstGeom>
+          <a:solidFill>
+            <a:srgbClr val="1F2937"/>
+          </a:solidFill>
+          <a:ln/>
+        </p:spPr>
+        <p:txBody>
+          <a:bodyPr wrap="square" lIns="1270" tIns="1270" rIns="1270" bIns="1270" rtlCol="0" anchor="ctr">
+            <a:normAutofit/>
+          </a:bodyPr>
+          <a:lstStyle/>
+          <a:p>
+            <a:pPr indent="0" marL="0">
+              <a:buNone/>
+            </a:pPr>
+            <a:r>
+              <a:rPr lang="en-US" sz="2000" b="1" dirty="0">
+                <a:solidFill>
+                  <a:srgbClr val="F8FAFC"/>
+                </a:solidFill>
+                <a:latin typeface="Courier New" pitchFamily="34" charset="0"/>
+                <a:ea typeface="Courier New" pitchFamily="34" charset="-122"/>
+                <a:cs typeface="Courier New" pitchFamily="34" charset="-120"/>
+              </a:rPr>
+              <a:t>npm test</a:t>
+            </a:r>
+            <a:endParaRPr lang="en-US" sz="2000" dirty="0"/>
+          </a:p>
+        </p:txBody>
+      </p:sp>
+      <p:sp>
+        <p:nvSpPr>
+          <p:cNvPr id="8" name="Text 6"/>
+          <p:cNvSpPr/>
+          <p:nvPr/>
+        </p:nvSpPr>
+        <p:spPr>
+          <a:xfrm>
+            <a:off x="731520" y="3063240"/>
+            <a:ext cx="3246120" cy="1143000"/>
           </a:xfrm>
           <a:prstGeom prst="rect">
             <a:avLst/>
@@ -6412,24 +6756,452 @@
           </a:bodyPr>
           <a:lstStyle/>
           <a:p>
+            <a:pPr indent="0" marL="0">
+              <a:buNone/>
+            </a:pPr>
+            <a:r>
+              <a:rPr lang="en-US" sz="1600" b="1" dirty="0">
+                <a:solidFill>
+                  <a:srgbClr val="202124"/>
+                </a:solidFill>
+              </a:rPr>
+              <a:t>But : verifier que la migration ne casse pas le comportement existant.</a:t>
+            </a:r>
+            <a:endParaRPr lang="en-US" sz="1600" dirty="0"/>
+          </a:p>
+        </p:txBody>
+      </p:sp>
+      <p:sp>
+        <p:nvSpPr>
+          <p:cNvPr id="9" name="Shape 7"/>
+          <p:cNvSpPr/>
+          <p:nvPr/>
+        </p:nvSpPr>
+        <p:spPr>
+          <a:xfrm>
+            <a:off x="4754880" y="987552"/>
+            <a:ext cx="7025335" cy="1024128"/>
+          </a:xfrm>
+          <a:prstGeom prst="roundRect">
+            <a:avLst>
+              <a:gd name="adj" fmla="val 7143"/>
+            </a:avLst>
+          </a:prstGeom>
+          <a:solidFill>
+            <a:srgbClr val="FFFFFF"/>
+          </a:solidFill>
+          <a:ln w="12700">
+            <a:solidFill>
+              <a:srgbClr val="E4E7EC"/>
+            </a:solidFill>
+            <a:prstDash val="solid"/>
+          </a:ln>
+        </p:spPr>
+      </p:sp>
+      <p:sp>
+        <p:nvSpPr>
+          <p:cNvPr id="10" name="Text 8"/>
+          <p:cNvSpPr/>
+          <p:nvPr/>
+        </p:nvSpPr>
+        <p:spPr>
+          <a:xfrm>
+            <a:off x="5001768" y="1243584"/>
+            <a:ext cx="274320" cy="274320"/>
+          </a:xfrm>
+          <a:prstGeom prst="rect">
+            <a:avLst/>
+          </a:prstGeom>
+          <a:solidFill>
+            <a:srgbClr val="EAF7F0"/>
+          </a:solidFill>
+          <a:ln>
+            <a:solidFill>
+              <a:srgbClr val="EAF7F0"/>
+            </a:solidFill>
+          </a:ln>
+        </p:spPr>
+        <p:txBody>
+          <a:bodyPr wrap="square" lIns="0" tIns="0" rIns="0" bIns="0" rtlCol="0" anchor="ctr"/>
+          <a:lstStyle/>
+          <a:p>
             <a:pPr algn="ctr" indent="0" marL="0">
               <a:buNone/>
             </a:pPr>
             <a:r>
-              <a:rPr lang="en-US" sz="780" b="1" dirty="0">
+              <a:rPr lang="en-US" sz="1000" b="1" dirty="0">
+                <a:solidFill>
+                  <a:srgbClr val="188038"/>
+                </a:solidFill>
+              </a:rPr>
+              <a:t>1</a:t>
+            </a:r>
+            <a:endParaRPr lang="en-US" sz="1000" dirty="0"/>
+          </a:p>
+        </p:txBody>
+      </p:sp>
+      <p:sp>
+        <p:nvSpPr>
+          <p:cNvPr id="11" name="Text 9"/>
+          <p:cNvSpPr/>
+          <p:nvPr/>
+        </p:nvSpPr>
+        <p:spPr>
+          <a:xfrm>
+            <a:off x="5458968" y="1188720"/>
+            <a:ext cx="6019495" cy="530352"/>
+          </a:xfrm>
+          <a:prstGeom prst="rect">
+            <a:avLst/>
+          </a:prstGeom>
+          <a:noFill/>
+          <a:ln/>
+        </p:spPr>
+        <p:txBody>
+          <a:bodyPr wrap="square" lIns="0" tIns="0" rIns="0" bIns="0" rtlCol="0" anchor="ctr">
+            <a:normAutofit/>
+          </a:bodyPr>
+          <a:lstStyle/>
+          <a:p>
+            <a:pPr indent="0" marL="0">
+              <a:buNone/>
+            </a:pPr>
+            <a:r>
+              <a:rPr lang="en-US" sz="1200" dirty="0">
                 <a:solidFill>
                   <a:srgbClr val="273043"/>
                 </a:solidFill>
               </a:rPr>
-              <a:t>Rappel tests : les tests ne sont pas l'objectif principal du dojo. S'ils echouent a cause de la migration demandee, corriger les erreurs pour refleter le nouveau comportement.</a:t>
-            </a:r>
-            <a:endParaRPr lang="en-US" sz="780" dirty="0"/>
-          </a:p>
-        </p:txBody>
-      </p:sp>
-      <p:sp>
-        <p:nvSpPr>
-          <p:cNvPr id="55" name="Text 53"/>
+              <a:t>Les tests ne sont pas l'objectif principal du dojo.</a:t>
+            </a:r>
+            <a:endParaRPr lang="en-US" sz="1200" dirty="0"/>
+          </a:p>
+        </p:txBody>
+      </p:sp>
+      <p:sp>
+        <p:nvSpPr>
+          <p:cNvPr id="12" name="Shape 10"/>
+          <p:cNvSpPr/>
+          <p:nvPr/>
+        </p:nvSpPr>
+        <p:spPr>
+          <a:xfrm>
+            <a:off x="4754880" y="2231136"/>
+            <a:ext cx="7025335" cy="1024128"/>
+          </a:xfrm>
+          <a:prstGeom prst="roundRect">
+            <a:avLst>
+              <a:gd name="adj" fmla="val 7143"/>
+            </a:avLst>
+          </a:prstGeom>
+          <a:solidFill>
+            <a:srgbClr val="FFFFFF"/>
+          </a:solidFill>
+          <a:ln w="12700">
+            <a:solidFill>
+              <a:srgbClr val="E4E7EC"/>
+            </a:solidFill>
+            <a:prstDash val="solid"/>
+          </a:ln>
+        </p:spPr>
+      </p:sp>
+      <p:sp>
+        <p:nvSpPr>
+          <p:cNvPr id="13" name="Text 11"/>
+          <p:cNvSpPr/>
+          <p:nvPr/>
+        </p:nvSpPr>
+        <p:spPr>
+          <a:xfrm>
+            <a:off x="5001768" y="2487168"/>
+            <a:ext cx="274320" cy="274320"/>
+          </a:xfrm>
+          <a:prstGeom prst="rect">
+            <a:avLst/>
+          </a:prstGeom>
+          <a:solidFill>
+            <a:srgbClr val="EAF7F0"/>
+          </a:solidFill>
+          <a:ln>
+            <a:solidFill>
+              <a:srgbClr val="EAF7F0"/>
+            </a:solidFill>
+          </a:ln>
+        </p:spPr>
+        <p:txBody>
+          <a:bodyPr wrap="square" lIns="0" tIns="0" rIns="0" bIns="0" rtlCol="0" anchor="ctr"/>
+          <a:lstStyle/>
+          <a:p>
+            <a:pPr algn="ctr" indent="0" marL="0">
+              <a:buNone/>
+            </a:pPr>
+            <a:r>
+              <a:rPr lang="en-US" sz="1000" b="1" dirty="0">
+                <a:solidFill>
+                  <a:srgbClr val="188038"/>
+                </a:solidFill>
+              </a:rPr>
+              <a:t>2</a:t>
+            </a:r>
+            <a:endParaRPr lang="en-US" sz="1000" dirty="0"/>
+          </a:p>
+        </p:txBody>
+      </p:sp>
+      <p:sp>
+        <p:nvSpPr>
+          <p:cNvPr id="14" name="Text 12"/>
+          <p:cNvSpPr/>
+          <p:nvPr/>
+        </p:nvSpPr>
+        <p:spPr>
+          <a:xfrm>
+            <a:off x="5458968" y="2432304"/>
+            <a:ext cx="6019495" cy="530352"/>
+          </a:xfrm>
+          <a:prstGeom prst="rect">
+            <a:avLst/>
+          </a:prstGeom>
+          <a:noFill/>
+          <a:ln/>
+        </p:spPr>
+        <p:txBody>
+          <a:bodyPr wrap="square" lIns="0" tIns="0" rIns="0" bIns="0" rtlCol="0" anchor="ctr">
+            <a:normAutofit/>
+          </a:bodyPr>
+          <a:lstStyle/>
+          <a:p>
+            <a:pPr indent="0" marL="0">
+              <a:buNone/>
+            </a:pPr>
+            <a:r>
+              <a:rPr lang="en-US" sz="1200" dirty="0">
+                <a:solidFill>
+                  <a:srgbClr val="273043"/>
+                </a:solidFill>
+              </a:rPr>
+              <a:t>Lancer les tests pour verifier que la migration n'a pas casse le comportement existant.</a:t>
+            </a:r>
+            <a:endParaRPr lang="en-US" sz="1200" dirty="0"/>
+          </a:p>
+        </p:txBody>
+      </p:sp>
+      <p:sp>
+        <p:nvSpPr>
+          <p:cNvPr id="15" name="Shape 13"/>
+          <p:cNvSpPr/>
+          <p:nvPr/>
+        </p:nvSpPr>
+        <p:spPr>
+          <a:xfrm>
+            <a:off x="4754880" y="3474720"/>
+            <a:ext cx="7025335" cy="1024128"/>
+          </a:xfrm>
+          <a:prstGeom prst="roundRect">
+            <a:avLst>
+              <a:gd name="adj" fmla="val 7143"/>
+            </a:avLst>
+          </a:prstGeom>
+          <a:solidFill>
+            <a:srgbClr val="FFFFFF"/>
+          </a:solidFill>
+          <a:ln w="12700">
+            <a:solidFill>
+              <a:srgbClr val="E4E7EC"/>
+            </a:solidFill>
+            <a:prstDash val="solid"/>
+          </a:ln>
+        </p:spPr>
+      </p:sp>
+      <p:sp>
+        <p:nvSpPr>
+          <p:cNvPr id="16" name="Text 14"/>
+          <p:cNvSpPr/>
+          <p:nvPr/>
+        </p:nvSpPr>
+        <p:spPr>
+          <a:xfrm>
+            <a:off x="5001768" y="3730752"/>
+            <a:ext cx="274320" cy="274320"/>
+          </a:xfrm>
+          <a:prstGeom prst="rect">
+            <a:avLst/>
+          </a:prstGeom>
+          <a:solidFill>
+            <a:srgbClr val="EAF7F0"/>
+          </a:solidFill>
+          <a:ln>
+            <a:solidFill>
+              <a:srgbClr val="EAF7F0"/>
+            </a:solidFill>
+          </a:ln>
+        </p:spPr>
+        <p:txBody>
+          <a:bodyPr wrap="square" lIns="0" tIns="0" rIns="0" bIns="0" rtlCol="0" anchor="ctr"/>
+          <a:lstStyle/>
+          <a:p>
+            <a:pPr algn="ctr" indent="0" marL="0">
+              <a:buNone/>
+            </a:pPr>
+            <a:r>
+              <a:rPr lang="en-US" sz="1000" b="1" dirty="0">
+                <a:solidFill>
+                  <a:srgbClr val="188038"/>
+                </a:solidFill>
+              </a:rPr>
+              <a:t>3</a:t>
+            </a:r>
+            <a:endParaRPr lang="en-US" sz="1000" dirty="0"/>
+          </a:p>
+        </p:txBody>
+      </p:sp>
+      <p:sp>
+        <p:nvSpPr>
+          <p:cNvPr id="17" name="Text 15"/>
+          <p:cNvSpPr/>
+          <p:nvPr/>
+        </p:nvSpPr>
+        <p:spPr>
+          <a:xfrm>
+            <a:off x="5458968" y="3675888"/>
+            <a:ext cx="6019495" cy="530352"/>
+          </a:xfrm>
+          <a:prstGeom prst="rect">
+            <a:avLst/>
+          </a:prstGeom>
+          <a:noFill/>
+          <a:ln/>
+        </p:spPr>
+        <p:txBody>
+          <a:bodyPr wrap="square" lIns="0" tIns="0" rIns="0" bIns="0" rtlCol="0" anchor="ctr">
+            <a:normAutofit/>
+          </a:bodyPr>
+          <a:lstStyle/>
+          <a:p>
+            <a:pPr indent="0" marL="0">
+              <a:buNone/>
+            </a:pPr>
+            <a:r>
+              <a:rPr lang="en-US" sz="1200" dirty="0">
+                <a:solidFill>
+                  <a:srgbClr val="273043"/>
+                </a:solidFill>
+              </a:rPr>
+              <a:t>Si une erreur apparait a cause de la migration demandee, corriger le code ou le test pour refleter le nouveau comportement attendu.</a:t>
+            </a:r>
+            <a:endParaRPr lang="en-US" sz="1200" dirty="0"/>
+          </a:p>
+        </p:txBody>
+      </p:sp>
+      <p:sp>
+        <p:nvSpPr>
+          <p:cNvPr id="18" name="Shape 16"/>
+          <p:cNvSpPr/>
+          <p:nvPr/>
+        </p:nvSpPr>
+        <p:spPr>
+          <a:xfrm>
+            <a:off x="4754880" y="4718304"/>
+            <a:ext cx="7025335" cy="1024128"/>
+          </a:xfrm>
+          <a:prstGeom prst="roundRect">
+            <a:avLst>
+              <a:gd name="adj" fmla="val 7143"/>
+            </a:avLst>
+          </a:prstGeom>
+          <a:solidFill>
+            <a:srgbClr val="FFFFFF"/>
+          </a:solidFill>
+          <a:ln w="12700">
+            <a:solidFill>
+              <a:srgbClr val="E4E7EC"/>
+            </a:solidFill>
+            <a:prstDash val="solid"/>
+          </a:ln>
+        </p:spPr>
+      </p:sp>
+      <p:sp>
+        <p:nvSpPr>
+          <p:cNvPr id="19" name="Text 17"/>
+          <p:cNvSpPr/>
+          <p:nvPr/>
+        </p:nvSpPr>
+        <p:spPr>
+          <a:xfrm>
+            <a:off x="5001768" y="4974336"/>
+            <a:ext cx="274320" cy="274320"/>
+          </a:xfrm>
+          <a:prstGeom prst="rect">
+            <a:avLst/>
+          </a:prstGeom>
+          <a:solidFill>
+            <a:srgbClr val="EAF7F0"/>
+          </a:solidFill>
+          <a:ln>
+            <a:solidFill>
+              <a:srgbClr val="EAF7F0"/>
+            </a:solidFill>
+          </a:ln>
+        </p:spPr>
+        <p:txBody>
+          <a:bodyPr wrap="square" lIns="0" tIns="0" rIns="0" bIns="0" rtlCol="0" anchor="ctr"/>
+          <a:lstStyle/>
+          <a:p>
+            <a:pPr algn="ctr" indent="0" marL="0">
+              <a:buNone/>
+            </a:pPr>
+            <a:r>
+              <a:rPr lang="en-US" sz="1000" b="1" dirty="0">
+                <a:solidFill>
+                  <a:srgbClr val="188038"/>
+                </a:solidFill>
+              </a:rPr>
+              <a:t>4</a:t>
+            </a:r>
+            <a:endParaRPr lang="en-US" sz="1000" dirty="0"/>
+          </a:p>
+        </p:txBody>
+      </p:sp>
+      <p:sp>
+        <p:nvSpPr>
+          <p:cNvPr id="20" name="Text 18"/>
+          <p:cNvSpPr/>
+          <p:nvPr/>
+        </p:nvSpPr>
+        <p:spPr>
+          <a:xfrm>
+            <a:off x="5458968" y="4919472"/>
+            <a:ext cx="6019495" cy="530352"/>
+          </a:xfrm>
+          <a:prstGeom prst="rect">
+            <a:avLst/>
+          </a:prstGeom>
+          <a:noFill/>
+          <a:ln/>
+        </p:spPr>
+        <p:txBody>
+          <a:bodyPr wrap="square" lIns="0" tIns="0" rIns="0" bIns="0" rtlCol="0" anchor="ctr">
+            <a:normAutofit/>
+          </a:bodyPr>
+          <a:lstStyle/>
+          <a:p>
+            <a:pPr indent="0" marL="0">
+              <a:buNone/>
+            </a:pPr>
+            <a:r>
+              <a:rPr lang="en-US" sz="1200" dirty="0">
+                <a:solidFill>
+                  <a:srgbClr val="273043"/>
+                </a:solidFill>
+              </a:rPr>
+              <a:t>Ne pas perdre de temps sur les tests hors perimetre de l'exercice.</a:t>
+            </a:r>
+            <a:endParaRPr lang="en-US" sz="1200" dirty="0"/>
+          </a:p>
+        </p:txBody>
+      </p:sp>
+      <p:sp>
+        <p:nvSpPr>
+          <p:cNvPr id="21" name="Text 19"/>
           <p:cNvSpPr/>
           <p:nvPr/>
         </p:nvSpPr>
@@ -6457,7 +7229,7 @@
                   <a:srgbClr val="667085"/>
                 </a:solidFill>
               </a:rPr>
-              <a:t>6/6</a:t>
+              <a:t>7/7</a:t>
             </a:r>
             <a:endParaRPr lang="en-US" sz="700" dirty="0"/>
           </a:p>

</xml_diff>

<commit_message>
ajuste rappel tests pptx
</commit_message>
<xml_diff>
--- a/docs/dojo-signals.pptx
+++ b/docs/dojo-signals.pptx
@@ -6872,7 +6872,7 @@
                   <a:srgbClr val="273043"/>
                 </a:solidFill>
               </a:rPr>
-              <a:t>Les tests ne sont pas l'objectif principal du dojo.</a:t>
+              <a:t>Avant de commencer un exercice, lancer les tests pour connaitre l'etat de depart.</a:t>
             </a:r>
             <a:endParaRPr lang="en-US" sz="1200" dirty="0"/>
           </a:p>
@@ -6979,7 +6979,7 @@
                   <a:srgbClr val="273043"/>
                 </a:solidFill>
               </a:rPr>
-              <a:t>Lancer les tests pour verifier que la migration n'a pas casse le comportement existant.</a:t>
+              <a:t>A la fin de l'exercice, relancer les tests pour verifier la migration.</a:t>
             </a:r>
             <a:endParaRPr lang="en-US" sz="1200" dirty="0"/>
           </a:p>
@@ -7086,7 +7086,7 @@
                   <a:srgbClr val="273043"/>
                 </a:solidFill>
               </a:rPr>
-              <a:t>Si une erreur apparait a cause de la migration demandee, corriger le code ou le test pour refleter le nouveau comportement attendu.</a:t>
+              <a:t>Si une erreur apparait, identifier si elle vient du changement realise.</a:t>
             </a:r>
             <a:endParaRPr lang="en-US" sz="1200" dirty="0"/>
           </a:p>
@@ -7193,7 +7193,7 @@
                   <a:srgbClr val="273043"/>
                 </a:solidFill>
               </a:rPr>
-              <a:t>Ne pas perdre de temps sur les tests hors perimetre de l'exercice.</a:t>
+              <a:t>Si besoin, corriger le code ou le test pour refleter le comportement attendu.</a:t>
             </a:r>
             <a:endParaRPr lang="en-US" sz="1200" dirty="0"/>
           </a:p>

</xml_diff>

<commit_message>
clarifie definition et role rappels pptx
</commit_message>
<xml_diff>
--- a/docs/dojo-signals.pptx
+++ b/docs/dojo-signals.pptx
@@ -1832,8 +1832,44 @@
         </p:nvSpPr>
         <p:spPr>
           <a:xfrm>
-            <a:off x="704088" y="1993392"/>
-            <a:ext cx="3127248" cy="2148840"/>
+            <a:off x="704088" y="1810512"/>
+            <a:ext cx="1234440" cy="182880"/>
+          </a:xfrm>
+          <a:prstGeom prst="rect">
+            <a:avLst/>
+          </a:prstGeom>
+          <a:noFill/>
+          <a:ln/>
+        </p:spPr>
+        <p:txBody>
+          <a:bodyPr wrap="square" lIns="0" tIns="0" rIns="0" bIns="0" rtlCol="0" anchor="ctr"/>
+          <a:lstStyle/>
+          <a:p>
+            <a:pPr indent="0" marL="0">
+              <a:buNone/>
+            </a:pPr>
+            <a:r>
+              <a:rPr lang="en-US" sz="800" b="1" dirty="0">
+                <a:solidFill>
+                  <a:srgbClr val="DD0031"/>
+                </a:solidFill>
+              </a:rPr>
+              <a:t>Définition</a:t>
+            </a:r>
+            <a:endParaRPr lang="en-US" sz="800" dirty="0"/>
+          </a:p>
+        </p:txBody>
+      </p:sp>
+      <p:sp>
+        <p:nvSpPr>
+          <p:cNvPr id="8" name="Text 6"/>
+          <p:cNvSpPr/>
+          <p:nvPr/>
+        </p:nvSpPr>
+        <p:spPr>
+          <a:xfrm>
+            <a:off x="704088" y="2103120"/>
+            <a:ext cx="3127248" cy="1965960"/>
           </a:xfrm>
           <a:prstGeom prst="rect">
             <a:avLst/>
@@ -1851,20 +1887,20 @@
               <a:buNone/>
             </a:pPr>
             <a:r>
-              <a:rPr lang="en-US" sz="1700" b="1" dirty="0">
+              <a:rPr lang="en-US" sz="1600" b="1" dirty="0">
                 <a:solidFill>
                   <a:srgbClr val="202124"/>
                 </a:solidFill>
               </a:rPr>
               <a:t>Un signal est une valeur reactive lue avec (). Quand sa valeur change, Angular sait quelles lectures dependent de cette valeur.</a:t>
             </a:r>
-            <a:endParaRPr lang="en-US" sz="1700" dirty="0"/>
-          </a:p>
-        </p:txBody>
-      </p:sp>
-      <p:sp>
-        <p:nvSpPr>
-          <p:cNvPr id="8" name="Text 6"/>
+            <a:endParaRPr lang="en-US" sz="1600" dirty="0"/>
+          </a:p>
+        </p:txBody>
+      </p:sp>
+      <p:sp>
+        <p:nvSpPr>
+          <p:cNvPr id="9" name="Text 7"/>
           <p:cNvSpPr/>
           <p:nvPr/>
         </p:nvSpPr>
@@ -1900,7 +1936,7 @@
       </p:sp>
       <p:sp>
         <p:nvSpPr>
-          <p:cNvPr id="9" name="Text 7"/>
+          <p:cNvPr id="10" name="Text 8"/>
           <p:cNvSpPr/>
           <p:nvPr/>
         </p:nvSpPr>
@@ -1938,7 +1974,7 @@
       </p:sp>
       <p:sp>
         <p:nvSpPr>
-          <p:cNvPr id="10" name="Shape 8"/>
+          <p:cNvPr id="11" name="Shape 9"/>
           <p:cNvSpPr/>
           <p:nvPr/>
         </p:nvSpPr>
@@ -1965,7 +2001,7 @@
       </p:sp>
       <p:sp>
         <p:nvSpPr>
-          <p:cNvPr id="11" name="Text 9"/>
+          <p:cNvPr id="12" name="Text 10"/>
           <p:cNvSpPr/>
           <p:nvPr/>
         </p:nvSpPr>
@@ -1993,7 +2029,7 @@
                   <a:srgbClr val="DD0031"/>
                 </a:solidFill>
               </a:rPr>
-              <a:t>Rôle dans le dojo</a:t>
+              <a:t>Rôle</a:t>
             </a:r>
             <a:endParaRPr lang="en-US" sz="1300" dirty="0"/>
           </a:p>
@@ -2001,7 +2037,7 @@
       </p:sp>
       <p:sp>
         <p:nvSpPr>
-          <p:cNvPr id="12" name="Shape 10"/>
+          <p:cNvPr id="13" name="Shape 11"/>
           <p:cNvSpPr/>
           <p:nvPr/>
         </p:nvSpPr>
@@ -2026,7 +2062,7 @@
       </p:sp>
       <p:sp>
         <p:nvSpPr>
-          <p:cNvPr id="13" name="Text 11"/>
+          <p:cNvPr id="14" name="Text 12"/>
           <p:cNvSpPr/>
           <p:nvPr/>
         </p:nvSpPr>
@@ -2056,7 +2092,7 @@
                   <a:srgbClr val="273043"/>
                 </a:solidFill>
               </a:rPr>
-              <a:t>signal() cree une valeur mutable.</a:t>
+              <a:t>Representer explicitement un etat reactive dans l'application.</a:t>
             </a:r>
             <a:endParaRPr lang="en-US" sz="1250" dirty="0"/>
           </a:p>
@@ -2064,7 +2100,7 @@
       </p:sp>
       <p:sp>
         <p:nvSpPr>
-          <p:cNvPr id="14" name="Shape 12"/>
+          <p:cNvPr id="15" name="Shape 13"/>
           <p:cNvSpPr/>
           <p:nvPr/>
         </p:nvSpPr>
@@ -2089,7 +2125,7 @@
       </p:sp>
       <p:sp>
         <p:nvSpPr>
-          <p:cNvPr id="15" name="Text 13"/>
+          <p:cNvPr id="16" name="Text 14"/>
           <p:cNvSpPr/>
           <p:nvPr/>
         </p:nvSpPr>
@@ -2119,7 +2155,7 @@
                   <a:srgbClr val="273043"/>
                 </a:solidFill>
               </a:rPr>
-              <a:t>computed() cree une valeur derivee.</a:t>
+              <a:t>Notifier Angular des lectures dependantes quand la valeur change.</a:t>
             </a:r>
             <a:endParaRPr lang="en-US" sz="1250" dirty="0"/>
           </a:p>
@@ -2127,7 +2163,7 @@
       </p:sp>
       <p:sp>
         <p:nvSpPr>
-          <p:cNvPr id="16" name="Shape 14"/>
+          <p:cNvPr id="17" name="Shape 15"/>
           <p:cNvSpPr/>
           <p:nvPr/>
         </p:nvSpPr>
@@ -2154,7 +2190,7 @@
       </p:sp>
       <p:sp>
         <p:nvSpPr>
-          <p:cNvPr id="17" name="Text 15"/>
+          <p:cNvPr id="18" name="Text 16"/>
           <p:cNvSpPr/>
           <p:nvPr/>
         </p:nvSpPr>
@@ -2190,7 +2226,7 @@
       </p:sp>
       <p:sp>
         <p:nvSpPr>
-          <p:cNvPr id="18" name="Shape 16"/>
+          <p:cNvPr id="19" name="Shape 17"/>
           <p:cNvSpPr/>
           <p:nvPr/>
         </p:nvSpPr>
@@ -2215,7 +2251,7 @@
       </p:sp>
       <p:sp>
         <p:nvSpPr>
-          <p:cNvPr id="19" name="Text 17"/>
+          <p:cNvPr id="20" name="Text 18"/>
           <p:cNvSpPr/>
           <p:nvPr/>
         </p:nvSpPr>
@@ -2245,7 +2281,7 @@
                   <a:srgbClr val="273043"/>
                 </a:solidFill>
               </a:rPr>
-              <a:t>effect() observe des signals pour declencher un effet de bord.</a:t>
+              <a:t>Un signal se lit avec () et se modifie avec .set() ou .update().</a:t>
             </a:r>
             <a:endParaRPr lang="en-US" sz="1250" dirty="0"/>
           </a:p>
@@ -2253,7 +2289,7 @@
       </p:sp>
       <p:sp>
         <p:nvSpPr>
-          <p:cNvPr id="20" name="Shape 18"/>
+          <p:cNvPr id="21" name="Shape 19"/>
           <p:cNvSpPr/>
           <p:nvPr/>
         </p:nvSpPr>
@@ -2278,7 +2314,7 @@
       </p:sp>
       <p:sp>
         <p:nvSpPr>
-          <p:cNvPr id="21" name="Text 19"/>
+          <p:cNvPr id="22" name="Text 20"/>
           <p:cNvSpPr/>
           <p:nvPr/>
         </p:nvSpPr>
@@ -2308,7 +2344,7 @@
                   <a:srgbClr val="273043"/>
                 </a:solidFill>
               </a:rPr>
-              <a:t>Le template lit un signal avec monSignal().</a:t>
+              <a:t>computed() derive une valeur ; effect() declenche un effet de bord.</a:t>
             </a:r>
             <a:endParaRPr lang="en-US" sz="1250" dirty="0"/>
           </a:p>
@@ -2316,7 +2352,7 @@
       </p:sp>
       <p:sp>
         <p:nvSpPr>
-          <p:cNvPr id="22" name="Text 20"/>
+          <p:cNvPr id="23" name="Text 21"/>
           <p:cNvSpPr/>
           <p:nvPr/>
         </p:nvSpPr>
@@ -2560,8 +2596,44 @@
         </p:nvSpPr>
         <p:spPr>
           <a:xfrm>
-            <a:off x="704088" y="1993392"/>
-            <a:ext cx="3127248" cy="2148840"/>
+            <a:off x="704088" y="1810512"/>
+            <a:ext cx="1234440" cy="182880"/>
+          </a:xfrm>
+          <a:prstGeom prst="rect">
+            <a:avLst/>
+          </a:prstGeom>
+          <a:noFill/>
+          <a:ln/>
+        </p:spPr>
+        <p:txBody>
+          <a:bodyPr wrap="square" lIns="0" tIns="0" rIns="0" bIns="0" rtlCol="0" anchor="ctr"/>
+          <a:lstStyle/>
+          <a:p>
+            <a:pPr indent="0" marL="0">
+              <a:buNone/>
+            </a:pPr>
+            <a:r>
+              <a:rPr lang="en-US" sz="800" b="1" dirty="0">
+                <a:solidFill>
+                  <a:srgbClr val="1976D2"/>
+                </a:solidFill>
+              </a:rPr>
+              <a:t>Définition</a:t>
+            </a:r>
+            <a:endParaRPr lang="en-US" sz="800" dirty="0"/>
+          </a:p>
+        </p:txBody>
+      </p:sp>
+      <p:sp>
+        <p:nvSpPr>
+          <p:cNvPr id="8" name="Text 6"/>
+          <p:cNvSpPr/>
+          <p:nvPr/>
+        </p:nvSpPr>
+        <p:spPr>
+          <a:xfrm>
+            <a:off x="704088" y="2103120"/>
+            <a:ext cx="3127248" cy="1965960"/>
           </a:xfrm>
           <a:prstGeom prst="rect">
             <a:avLst/>
@@ -2579,20 +2651,20 @@
               <a:buNone/>
             </a:pPr>
             <a:r>
-              <a:rPr lang="en-US" sz="1700" b="1" dirty="0">
+              <a:rPr lang="en-US" sz="1600" b="1" dirty="0">
                 <a:solidFill>
                   <a:srgbClr val="202124"/>
                 </a:solidFill>
               </a:rPr>
               <a:t>Zone.js intercepte les evenements asynchrones du navigateur et previent Angular qu'un cycle de detection peut etre lance.</a:t>
             </a:r>
-            <a:endParaRPr lang="en-US" sz="1700" dirty="0"/>
-          </a:p>
-        </p:txBody>
-      </p:sp>
-      <p:sp>
-        <p:nvSpPr>
-          <p:cNvPr id="8" name="Text 6"/>
+            <a:endParaRPr lang="en-US" sz="1600" dirty="0"/>
+          </a:p>
+        </p:txBody>
+      </p:sp>
+      <p:sp>
+        <p:nvSpPr>
+          <p:cNvPr id="9" name="Text 7"/>
           <p:cNvSpPr/>
           <p:nvPr/>
         </p:nvSpPr>
@@ -2628,7 +2700,7 @@
       </p:sp>
       <p:sp>
         <p:nvSpPr>
-          <p:cNvPr id="9" name="Text 7"/>
+          <p:cNvPr id="10" name="Text 8"/>
           <p:cNvSpPr/>
           <p:nvPr/>
         </p:nvSpPr>
@@ -2666,7 +2738,7 @@
       </p:sp>
       <p:sp>
         <p:nvSpPr>
-          <p:cNvPr id="10" name="Shape 8"/>
+          <p:cNvPr id="11" name="Shape 9"/>
           <p:cNvSpPr/>
           <p:nvPr/>
         </p:nvSpPr>
@@ -2693,7 +2765,7 @@
       </p:sp>
       <p:sp>
         <p:nvSpPr>
-          <p:cNvPr id="11" name="Text 9"/>
+          <p:cNvPr id="12" name="Text 10"/>
           <p:cNvSpPr/>
           <p:nvPr/>
         </p:nvSpPr>
@@ -2721,7 +2793,7 @@
                   <a:srgbClr val="1976D2"/>
                 </a:solidFill>
               </a:rPr>
-              <a:t>Rôle dans le dojo</a:t>
+              <a:t>Rôle</a:t>
             </a:r>
             <a:endParaRPr lang="en-US" sz="1300" dirty="0"/>
           </a:p>
@@ -2729,7 +2801,7 @@
       </p:sp>
       <p:sp>
         <p:nvSpPr>
-          <p:cNvPr id="12" name="Shape 10"/>
+          <p:cNvPr id="13" name="Shape 11"/>
           <p:cNvSpPr/>
           <p:nvPr/>
         </p:nvSpPr>
@@ -2754,7 +2826,7 @@
       </p:sp>
       <p:sp>
         <p:nvSpPr>
-          <p:cNvPr id="13" name="Text 11"/>
+          <p:cNvPr id="14" name="Text 12"/>
           <p:cNvSpPr/>
           <p:nvPr/>
         </p:nvSpPr>
@@ -2784,7 +2856,7 @@
                   <a:srgbClr val="273043"/>
                 </a:solidFill>
               </a:rPr>
-              <a:t>Zone.js declenche la detection apres un evenement async.</a:t>
+              <a:t>Declencher la detection de changement apres une tache asynchrone.</a:t>
             </a:r>
             <a:endParaRPr lang="en-US" sz="1250" dirty="0"/>
           </a:p>
@@ -2792,7 +2864,7 @@
       </p:sp>
       <p:sp>
         <p:nvSpPr>
-          <p:cNvPr id="14" name="Shape 12"/>
+          <p:cNvPr id="15" name="Shape 13"/>
           <p:cNvSpPr/>
           <p:nvPr/>
         </p:nvSpPr>
@@ -2817,7 +2889,7 @@
       </p:sp>
       <p:sp>
         <p:nvSpPr>
-          <p:cNvPr id="15" name="Text 13"/>
+          <p:cNvPr id="16" name="Text 14"/>
           <p:cNvSpPr/>
           <p:nvPr/>
         </p:nvSpPr>
@@ -2847,7 +2919,7 @@
                   <a:srgbClr val="273043"/>
                 </a:solidFill>
               </a:rPr>
-              <a:t>Zone.js ne dit pas quel etat applicatif a change.</a:t>
+              <a:t>Fournir le comportement historique d'Angular sans appels manuels de detection.</a:t>
             </a:r>
             <a:endParaRPr lang="en-US" sz="1250" dirty="0"/>
           </a:p>
@@ -2855,7 +2927,7 @@
       </p:sp>
       <p:sp>
         <p:nvSpPr>
-          <p:cNvPr id="16" name="Shape 14"/>
+          <p:cNvPr id="17" name="Shape 15"/>
           <p:cNvSpPr/>
           <p:nvPr/>
         </p:nvSpPr>
@@ -2882,7 +2954,7 @@
       </p:sp>
       <p:sp>
         <p:nvSpPr>
-          <p:cNvPr id="17" name="Text 15"/>
+          <p:cNvPr id="18" name="Text 16"/>
           <p:cNvSpPr/>
           <p:nvPr/>
         </p:nvSpPr>
@@ -2918,7 +2990,7 @@
       </p:sp>
       <p:sp>
         <p:nvSpPr>
-          <p:cNvPr id="18" name="Shape 16"/>
+          <p:cNvPr id="19" name="Shape 17"/>
           <p:cNvSpPr/>
           <p:nvPr/>
         </p:nvSpPr>
@@ -2943,7 +3015,7 @@
       </p:sp>
       <p:sp>
         <p:nvSpPr>
-          <p:cNvPr id="19" name="Text 17"/>
+          <p:cNvPr id="20" name="Text 18"/>
           <p:cNvSpPr/>
           <p:nvPr/>
         </p:nvSpPr>
@@ -2973,7 +3045,7 @@
                   <a:srgbClr val="273043"/>
                 </a:solidFill>
               </a:rPr>
-              <a:t>Le dojo garde Zone.js pour montrer une migration progressive.</a:t>
+              <a:t>Zone.js ne modelise pas l'etat applicatif et ne sait pas quelle valeur a change.</a:t>
             </a:r>
             <a:endParaRPr lang="en-US" sz="1250" dirty="0"/>
           </a:p>
@@ -2981,7 +3053,7 @@
       </p:sp>
       <p:sp>
         <p:nvSpPr>
-          <p:cNvPr id="20" name="Shape 18"/>
+          <p:cNvPr id="21" name="Shape 19"/>
           <p:cNvSpPr/>
           <p:nvPr/>
         </p:nvSpPr>
@@ -3006,7 +3078,7 @@
       </p:sp>
       <p:sp>
         <p:nvSpPr>
-          <p:cNvPr id="21" name="Text 19"/>
+          <p:cNvPr id="22" name="Text 20"/>
           <p:cNvSpPr/>
           <p:nvPr/>
         </p:nvSpPr>
@@ -3036,7 +3108,7 @@
                   <a:srgbClr val="273043"/>
                 </a:solidFill>
               </a:rPr>
-              <a:t>Les Signals rendent les dependances d'etat plus explicites.</a:t>
+              <a:t>Les Signals completent ce mecanisme en rendant les dependances d'etat explicites.</a:t>
             </a:r>
             <a:endParaRPr lang="en-US" sz="1250" dirty="0"/>
           </a:p>
@@ -3044,7 +3116,7 @@
       </p:sp>
       <p:sp>
         <p:nvSpPr>
-          <p:cNvPr id="22" name="Text 20"/>
+          <p:cNvPr id="23" name="Text 21"/>
           <p:cNvSpPr/>
           <p:nvPr/>
         </p:nvSpPr>
@@ -3288,8 +3360,44 @@
         </p:nvSpPr>
         <p:spPr>
           <a:xfrm>
-            <a:off x="704088" y="1993392"/>
-            <a:ext cx="3127248" cy="2148840"/>
+            <a:off x="704088" y="1810512"/>
+            <a:ext cx="1234440" cy="182880"/>
+          </a:xfrm>
+          <a:prstGeom prst="rect">
+            <a:avLst/>
+          </a:prstGeom>
+          <a:noFill/>
+          <a:ln/>
+        </p:spPr>
+        <p:txBody>
+          <a:bodyPr wrap="square" lIns="0" tIns="0" rIns="0" bIns="0" rtlCol="0" anchor="ctr"/>
+          <a:lstStyle/>
+          <a:p>
+            <a:pPr indent="0" marL="0">
+              <a:buNone/>
+            </a:pPr>
+            <a:r>
+              <a:rPr lang="en-US" sz="800" b="1" dirty="0">
+                <a:solidFill>
+                  <a:srgbClr val="188038"/>
+                </a:solidFill>
+              </a:rPr>
+              <a:t>Définition</a:t>
+            </a:r>
+            <a:endParaRPr lang="en-US" sz="800" dirty="0"/>
+          </a:p>
+        </p:txBody>
+      </p:sp>
+      <p:sp>
+        <p:nvSpPr>
+          <p:cNvPr id="8" name="Text 6"/>
+          <p:cNvSpPr/>
+          <p:nvPr/>
+        </p:nvSpPr>
+        <p:spPr>
+          <a:xfrm>
+            <a:off x="704088" y="2103120"/>
+            <a:ext cx="3127248" cy="1965960"/>
           </a:xfrm>
           <a:prstGeom prst="rect">
             <a:avLst/>
@@ -3307,20 +3415,20 @@
               <a:buNone/>
             </a:pPr>
             <a:r>
-              <a:rPr lang="en-US" sz="1700" b="1" dirty="0">
+              <a:rPr lang="en-US" sz="1600" b="1" dirty="0">
                 <a:solidFill>
                   <a:srgbClr val="202124"/>
                 </a:solidFill>
               </a:rPr>
               <a:t>RxJS sert a modeliser des flux dans le temps : HTTP, route params, evenements, debounceTime, switchMap, combineLatest.</a:t>
             </a:r>
-            <a:endParaRPr lang="en-US" sz="1700" dirty="0"/>
-          </a:p>
-        </p:txBody>
-      </p:sp>
-      <p:sp>
-        <p:nvSpPr>
-          <p:cNvPr id="8" name="Text 6"/>
+            <a:endParaRPr lang="en-US" sz="1600" dirty="0"/>
+          </a:p>
+        </p:txBody>
+      </p:sp>
+      <p:sp>
+        <p:nvSpPr>
+          <p:cNvPr id="9" name="Text 7"/>
           <p:cNvSpPr/>
           <p:nvPr/>
         </p:nvSpPr>
@@ -3356,7 +3464,7 @@
       </p:sp>
       <p:sp>
         <p:nvSpPr>
-          <p:cNvPr id="9" name="Text 7"/>
+          <p:cNvPr id="10" name="Text 8"/>
           <p:cNvSpPr/>
           <p:nvPr/>
         </p:nvSpPr>
@@ -3394,7 +3502,7 @@
       </p:sp>
       <p:sp>
         <p:nvSpPr>
-          <p:cNvPr id="10" name="Shape 8"/>
+          <p:cNvPr id="11" name="Shape 9"/>
           <p:cNvSpPr/>
           <p:nvPr/>
         </p:nvSpPr>
@@ -3421,7 +3529,7 @@
       </p:sp>
       <p:sp>
         <p:nvSpPr>
-          <p:cNvPr id="11" name="Text 9"/>
+          <p:cNvPr id="12" name="Text 10"/>
           <p:cNvSpPr/>
           <p:nvPr/>
         </p:nvSpPr>
@@ -3449,7 +3557,7 @@
                   <a:srgbClr val="188038"/>
                 </a:solidFill>
               </a:rPr>
-              <a:t>Rôle dans le dojo</a:t>
+              <a:t>Rôle</a:t>
             </a:r>
             <a:endParaRPr lang="en-US" sz="1300" dirty="0"/>
           </a:p>
@@ -3457,7 +3565,7 @@
       </p:sp>
       <p:sp>
         <p:nvSpPr>
-          <p:cNvPr id="12" name="Shape 10"/>
+          <p:cNvPr id="13" name="Shape 11"/>
           <p:cNvSpPr/>
           <p:nvPr/>
         </p:nvSpPr>
@@ -3482,7 +3590,7 @@
       </p:sp>
       <p:sp>
         <p:nvSpPr>
-          <p:cNvPr id="13" name="Text 11"/>
+          <p:cNvPr id="14" name="Text 12"/>
           <p:cNvSpPr/>
           <p:nvPr/>
         </p:nvSpPr>
@@ -3512,7 +3620,7 @@
                   <a:srgbClr val="273043"/>
                 </a:solidFill>
               </a:rPr>
-              <a:t>RxJS reste adapte aux flux asynchrones.</a:t>
+              <a:t>Modeliser et composer des donnees qui arrivent dans le temps.</a:t>
             </a:r>
             <a:endParaRPr lang="en-US" sz="1250" dirty="0"/>
           </a:p>
@@ -3520,7 +3628,7 @@
       </p:sp>
       <p:sp>
         <p:nvSpPr>
-          <p:cNvPr id="14" name="Shape 12"/>
+          <p:cNvPr id="15" name="Shape 13"/>
           <p:cNvSpPr/>
           <p:nvPr/>
         </p:nvSpPr>
@@ -3545,7 +3653,7 @@
       </p:sp>
       <p:sp>
         <p:nvSpPr>
-          <p:cNvPr id="15" name="Text 13"/>
+          <p:cNvPr id="16" name="Text 14"/>
           <p:cNvSpPr/>
           <p:nvPr/>
         </p:nvSpPr>
@@ -3575,7 +3683,7 @@
                   <a:srgbClr val="273043"/>
                 </a:solidFill>
               </a:rPr>
-              <a:t>toSignal() expose la derniere valeur d'un Observable comme signal.</a:t>
+              <a:t>Gerer les transformations asynchrones avec des operateurs comme switchMap ou debounceTime.</a:t>
             </a:r>
             <a:endParaRPr lang="en-US" sz="1250" dirty="0"/>
           </a:p>
@@ -3583,7 +3691,7 @@
       </p:sp>
       <p:sp>
         <p:nvSpPr>
-          <p:cNvPr id="16" name="Shape 14"/>
+          <p:cNvPr id="17" name="Shape 15"/>
           <p:cNvSpPr/>
           <p:nvPr/>
         </p:nvSpPr>
@@ -3610,7 +3718,7 @@
       </p:sp>
       <p:sp>
         <p:nvSpPr>
-          <p:cNvPr id="17" name="Text 15"/>
+          <p:cNvPr id="18" name="Text 16"/>
           <p:cNvSpPr/>
           <p:nvPr/>
         </p:nvSpPr>
@@ -3646,7 +3754,7 @@
       </p:sp>
       <p:sp>
         <p:nvSpPr>
-          <p:cNvPr id="18" name="Shape 16"/>
+          <p:cNvPr id="19" name="Shape 17"/>
           <p:cNvSpPr/>
           <p:nvPr/>
         </p:nvSpPr>
@@ -3671,7 +3779,7 @@
       </p:sp>
       <p:sp>
         <p:nvSpPr>
-          <p:cNvPr id="19" name="Text 17"/>
+          <p:cNvPr id="20" name="Text 18"/>
           <p:cNvSpPr/>
           <p:nvPr/>
         </p:nvSpPr>
@@ -3701,7 +3809,7 @@
                   <a:srgbClr val="273043"/>
                 </a:solidFill>
               </a:rPr>
-              <a:t>toObservable() expose un signal comme Observable.</a:t>
+              <a:t>toSignal() expose la derniere valeur d'un Observable comme signal.</a:t>
             </a:r>
             <a:endParaRPr lang="en-US" sz="1250" dirty="0"/>
           </a:p>
@@ -3709,7 +3817,7 @@
       </p:sp>
       <p:sp>
         <p:nvSpPr>
-          <p:cNvPr id="20" name="Shape 18"/>
+          <p:cNvPr id="21" name="Shape 19"/>
           <p:cNvSpPr/>
           <p:nvPr/>
         </p:nvSpPr>
@@ -3734,7 +3842,7 @@
       </p:sp>
       <p:sp>
         <p:nvSpPr>
-          <p:cNvPr id="21" name="Text 19"/>
+          <p:cNvPr id="22" name="Text 20"/>
           <p:cNvSpPr/>
           <p:nvPr/>
         </p:nvSpPr>
@@ -3764,7 +3872,7 @@
                   <a:srgbClr val="273043"/>
                 </a:solidFill>
               </a:rPr>
-              <a:t>Le but est de placer clairement la frontiere entre flux RxJS et etat signal.</a:t>
+              <a:t>toObservable() permet de repasser d'un signal vers un flux Observable.</a:t>
             </a:r>
             <a:endParaRPr lang="en-US" sz="1250" dirty="0"/>
           </a:p>
@@ -3772,7 +3880,7 @@
       </p:sp>
       <p:sp>
         <p:nvSpPr>
-          <p:cNvPr id="22" name="Text 20"/>
+          <p:cNvPr id="23" name="Text 21"/>
           <p:cNvSpPr/>
           <p:nvPr/>
         </p:nvSpPr>

</xml_diff>

<commit_message>
applique theme bnp paribas pptx
</commit_message>
<xml_diff>
--- a/docs/dojo-signals.pptx
+++ b/docs/dojo-signals.pptx
@@ -1658,7 +1658,7 @@
     <p:bg>
       <p:bgPr>
         <a:solidFill>
-          <a:srgbClr val="F7F9FC"/>
+          <a:srgbClr val="F3F8F6"/>
         </a:solidFill>
       </p:bgPr>
     </p:bg>
@@ -1691,11 +1691,11 @@
             <a:avLst/>
           </a:prstGeom>
           <a:solidFill>
-            <a:srgbClr val="DD0031"/>
+            <a:srgbClr val="008A5B"/>
           </a:solidFill>
           <a:ln w="12700">
             <a:solidFill>
-              <a:srgbClr val="DD0031"/>
+              <a:srgbClr val="008A5B"/>
             </a:solidFill>
             <a:prstDash val="solid"/>
           </a:ln>
@@ -1703,14 +1703,39 @@
       </p:sp>
       <p:sp>
         <p:nvSpPr>
-          <p:cNvPr id="3" name="Text 1"/>
+          <p:cNvPr id="3" name="Shape 1"/>
+          <p:cNvSpPr/>
+          <p:nvPr/>
+        </p:nvSpPr>
+        <p:spPr>
+          <a:xfrm>
+            <a:off x="164592" y="164592"/>
+            <a:ext cx="109728" cy="6528816"/>
+          </a:xfrm>
+          <a:prstGeom prst="rect">
+            <a:avLst/>
+          </a:prstGeom>
+          <a:solidFill>
+            <a:srgbClr val="00A86B"/>
+          </a:solidFill>
+          <a:ln w="12700">
+            <a:solidFill>
+              <a:srgbClr val="00A86B"/>
+            </a:solidFill>
+            <a:prstDash val="solid"/>
+          </a:ln>
+        </p:spPr>
+      </p:sp>
+      <p:sp>
+        <p:nvSpPr>
+          <p:cNvPr id="4" name="Text 2"/>
           <p:cNvSpPr/>
           <p:nvPr/>
         </p:nvSpPr>
         <p:spPr>
           <a:xfrm>
             <a:off x="502920" y="502920"/>
-            <a:ext cx="1920240" cy="411480"/>
+            <a:ext cx="2011680" cy="411480"/>
           </a:xfrm>
           <a:prstGeom prst="rect">
             <a:avLst/>
@@ -1726,20 +1751,56 @@
               <a:buNone/>
             </a:pPr>
             <a:r>
-              <a:rPr lang="en-US" sz="2200" b="1" dirty="0">
+              <a:rPr lang="en-US" sz="1800" b="1" dirty="0">
                 <a:solidFill>
                   <a:srgbClr val="FFFFFF"/>
                 </a:solidFill>
               </a:rPr>
-              <a:t>Dojo</a:t>
-            </a:r>
-            <a:endParaRPr lang="en-US" sz="2200" dirty="0"/>
-          </a:p>
-        </p:txBody>
-      </p:sp>
-      <p:sp>
-        <p:nvSpPr>
-          <p:cNvPr id="4" name="Text 2"/>
+              <a:t>BNP Paribas</a:t>
+            </a:r>
+            <a:endParaRPr lang="en-US" sz="1800" dirty="0"/>
+          </a:p>
+        </p:txBody>
+      </p:sp>
+      <p:sp>
+        <p:nvSpPr>
+          <p:cNvPr id="5" name="Text 3"/>
+          <p:cNvSpPr/>
+          <p:nvPr/>
+        </p:nvSpPr>
+        <p:spPr>
+          <a:xfrm>
+            <a:off x="502920" y="1024128"/>
+            <a:ext cx="2011680" cy="292608"/>
+          </a:xfrm>
+          <a:prstGeom prst="rect">
+            <a:avLst/>
+          </a:prstGeom>
+          <a:noFill/>
+          <a:ln/>
+        </p:spPr>
+        <p:txBody>
+          <a:bodyPr wrap="square" lIns="0" tIns="0" rIns="0" bIns="0" rtlCol="0" anchor="ctr"/>
+          <a:lstStyle/>
+          <a:p>
+            <a:pPr indent="0" marL="0">
+              <a:buNone/>
+            </a:pPr>
+            <a:r>
+              <a:rPr lang="en-US" sz="1200" dirty="0">
+                <a:solidFill>
+                  <a:srgbClr val="DFF2EA"/>
+                </a:solidFill>
+              </a:rPr>
+              <a:t>Angular Dojo</a:t>
+            </a:r>
+            <a:endParaRPr lang="en-US" sz="1200" dirty="0"/>
+          </a:p>
+        </p:txBody>
+      </p:sp>
+      <p:sp>
+        <p:nvSpPr>
+          <p:cNvPr id="6" name="Text 4"/>
           <p:cNvSpPr/>
           <p:nvPr/>
         </p:nvSpPr>
@@ -1766,7 +1827,7 @@
             <a:r>
               <a:rPr lang="en-US" sz="3800" b="1" dirty="0">
                 <a:solidFill>
-                  <a:srgbClr val="202124"/>
+                  <a:srgbClr val="1B2B2A"/>
                 </a:solidFill>
               </a:rPr>
               <a:t>Angular 21 Signals — Dojo court</a:t>
@@ -1777,7 +1838,7 @@
       </p:sp>
       <p:sp>
         <p:nvSpPr>
-          <p:cNvPr id="5" name="Text 3"/>
+          <p:cNvPr id="7" name="Text 5"/>
           <p:cNvSpPr/>
           <p:nvPr/>
         </p:nvSpPr>
@@ -1802,7 +1863,7 @@
             <a:r>
               <a:rPr lang="en-US" sz="1800" dirty="0">
                 <a:solidFill>
-                  <a:srgbClr val="667085"/>
+                  <a:srgbClr val="61716F"/>
                 </a:solidFill>
               </a:rPr>
               <a:t>Support de présentation dojo</a:t>
@@ -1813,7 +1874,7 @@
       </p:sp>
       <p:sp>
         <p:nvSpPr>
-          <p:cNvPr id="6" name="Text 4"/>
+          <p:cNvPr id="8" name="Text 6"/>
           <p:cNvSpPr/>
           <p:nvPr/>
         </p:nvSpPr>
@@ -1826,11 +1887,11 @@
             <a:avLst/>
           </a:prstGeom>
           <a:solidFill>
-            <a:srgbClr val="FCE7EC"/>
+            <a:srgbClr val="CFEDE2"/>
           </a:solidFill>
           <a:ln>
             <a:solidFill>
-              <a:srgbClr val="FCE7EC"/>
+              <a:srgbClr val="CFEDE2"/>
             </a:solidFill>
           </a:ln>
         </p:spPr>
@@ -1844,7 +1905,7 @@
             <a:r>
               <a:rPr lang="en-US" sz="1100" b="1" dirty="0">
                 <a:solidFill>
-                  <a:srgbClr val="DD0031"/>
+                  <a:srgbClr val="008A5B"/>
                 </a:solidFill>
               </a:rPr>
               <a:t>Angular 21 · Signals · Zone.js · RxJS interop</a:t>
@@ -1855,7 +1916,7 @@
       </p:sp>
       <p:sp>
         <p:nvSpPr>
-          <p:cNvPr id="7" name="Text 5"/>
+          <p:cNvPr id="9" name="Text 7"/>
           <p:cNvSpPr/>
           <p:nvPr/>
         </p:nvSpPr>
@@ -1880,7 +1941,7 @@
             <a:r>
               <a:rPr lang="en-US" sz="700" dirty="0">
                 <a:solidFill>
-                  <a:srgbClr val="667085"/>
+                  <a:srgbClr val="61716F"/>
                 </a:solidFill>
               </a:rPr>
               <a:t>1/10</a:t>
@@ -1903,7 +1964,7 @@
     <p:bg>
       <p:bgPr>
         <a:solidFill>
-          <a:srgbClr val="F7F9FC"/>
+          <a:srgbClr val="F3F8F6"/>
         </a:solidFill>
       </p:bgPr>
     </p:bg>
@@ -1936,11 +1997,11 @@
             <a:avLst/>
           </a:prstGeom>
           <a:solidFill>
-            <a:srgbClr val="188038"/>
+            <a:srgbClr val="00A86B"/>
           </a:solidFill>
           <a:ln w="12700">
             <a:solidFill>
-              <a:srgbClr val="188038"/>
+              <a:srgbClr val="00A86B"/>
             </a:solidFill>
             <a:prstDash val="solid"/>
           </a:ln>
@@ -1975,7 +2036,7 @@
             <a:r>
               <a:rPr lang="en-US" sz="2000" b="1" dirty="0">
                 <a:solidFill>
-                  <a:srgbClr val="202124"/>
+                  <a:srgbClr val="1B2B2A"/>
                 </a:solidFill>
               </a:rPr>
               <a:t>Rappel tests</a:t>
@@ -1999,11 +2060,11 @@
             <a:avLst/>
           </a:prstGeom>
           <a:solidFill>
-            <a:srgbClr val="FCE7EC"/>
+            <a:srgbClr val="CFEDE2"/>
           </a:solidFill>
           <a:ln>
             <a:solidFill>
-              <a:srgbClr val="FCE7EC"/>
+              <a:srgbClr val="CFEDE2"/>
             </a:solidFill>
           </a:ln>
         </p:spPr>
@@ -2017,10 +2078,10 @@
             <a:r>
               <a:rPr lang="en-US" sz="800" b="1" dirty="0">
                 <a:solidFill>
-                  <a:srgbClr val="188038"/>
-                </a:solidFill>
-              </a:rPr>
-              <a:t>Angular Signals</a:t>
+                  <a:srgbClr val="00A86B"/>
+                </a:solidFill>
+              </a:rPr>
+              <a:t>BNP Paribas</a:t>
             </a:r>
             <a:endParaRPr lang="en-US" sz="800" dirty="0"/>
           </a:p>
@@ -2043,7 +2104,7 @@
             </a:avLst>
           </a:prstGeom>
           <a:solidFill>
-            <a:srgbClr val="EAF7F0"/>
+            <a:srgbClr val="DFF2EA"/>
           </a:solidFill>
           <a:ln w="12700">
             <a:solidFill>
@@ -2080,7 +2141,7 @@
             <a:r>
               <a:rPr lang="en-US" sz="1000" b="1" dirty="0">
                 <a:solidFill>
-                  <a:srgbClr val="188038"/>
+                  <a:srgbClr val="00A86B"/>
                 </a:solidFill>
               </a:rPr>
               <a:t>À lancer</a:t>
@@ -2104,7 +2165,7 @@
             <a:avLst/>
           </a:prstGeom>
           <a:solidFill>
-            <a:srgbClr val="1F2937"/>
+            <a:srgbClr val="15332F"/>
           </a:solidFill>
           <a:ln/>
         </p:spPr>
@@ -2161,7 +2222,7 @@
             <a:r>
               <a:rPr lang="en-US" sz="1600" b="1" dirty="0">
                 <a:solidFill>
-                  <a:srgbClr val="202124"/>
+                  <a:srgbClr val="1B2B2A"/>
                 </a:solidFill>
               </a:rPr>
               <a:t>But : verifier que la migration ne casse pas le comportement existant.</a:t>
@@ -2191,7 +2252,7 @@
           </a:solidFill>
           <a:ln w="12700">
             <a:solidFill>
-              <a:srgbClr val="E4E7EC"/>
+              <a:srgbClr val="D6E5E0"/>
             </a:solidFill>
             <a:prstDash val="solid"/>
           </a:ln>
@@ -2212,11 +2273,11 @@
             <a:avLst/>
           </a:prstGeom>
           <a:solidFill>
-            <a:srgbClr val="EAF7F0"/>
+            <a:srgbClr val="DFF2EA"/>
           </a:solidFill>
           <a:ln>
             <a:solidFill>
-              <a:srgbClr val="EAF7F0"/>
+              <a:srgbClr val="DFF2EA"/>
             </a:solidFill>
           </a:ln>
         </p:spPr>
@@ -2230,7 +2291,7 @@
             <a:r>
               <a:rPr lang="en-US" sz="1000" b="1" dirty="0">
                 <a:solidFill>
-                  <a:srgbClr val="188038"/>
+                  <a:srgbClr val="00A86B"/>
                 </a:solidFill>
               </a:rPr>
               <a:t>1</a:t>
@@ -2268,7 +2329,7 @@
             <a:r>
               <a:rPr lang="en-US" sz="1200" dirty="0">
                 <a:solidFill>
-                  <a:srgbClr val="273043"/>
+                  <a:srgbClr val="263B38"/>
                 </a:solidFill>
               </a:rPr>
               <a:t>Avant de commencer un exercice, lancer les tests pour connaitre l'etat de depart.</a:t>
@@ -2298,7 +2359,7 @@
           </a:solidFill>
           <a:ln w="12700">
             <a:solidFill>
-              <a:srgbClr val="E4E7EC"/>
+              <a:srgbClr val="D6E5E0"/>
             </a:solidFill>
             <a:prstDash val="solid"/>
           </a:ln>
@@ -2319,11 +2380,11 @@
             <a:avLst/>
           </a:prstGeom>
           <a:solidFill>
-            <a:srgbClr val="EAF7F0"/>
+            <a:srgbClr val="DFF2EA"/>
           </a:solidFill>
           <a:ln>
             <a:solidFill>
-              <a:srgbClr val="EAF7F0"/>
+              <a:srgbClr val="DFF2EA"/>
             </a:solidFill>
           </a:ln>
         </p:spPr>
@@ -2337,7 +2398,7 @@
             <a:r>
               <a:rPr lang="en-US" sz="1000" b="1" dirty="0">
                 <a:solidFill>
-                  <a:srgbClr val="188038"/>
+                  <a:srgbClr val="00A86B"/>
                 </a:solidFill>
               </a:rPr>
               <a:t>2</a:t>
@@ -2375,7 +2436,7 @@
             <a:r>
               <a:rPr lang="en-US" sz="1200" dirty="0">
                 <a:solidFill>
-                  <a:srgbClr val="273043"/>
+                  <a:srgbClr val="263B38"/>
                 </a:solidFill>
               </a:rPr>
               <a:t>A la fin de l'exercice, relancer les tests pour verifier la migration.</a:t>
@@ -2405,7 +2466,7 @@
           </a:solidFill>
           <a:ln w="12700">
             <a:solidFill>
-              <a:srgbClr val="E4E7EC"/>
+              <a:srgbClr val="D6E5E0"/>
             </a:solidFill>
             <a:prstDash val="solid"/>
           </a:ln>
@@ -2426,11 +2487,11 @@
             <a:avLst/>
           </a:prstGeom>
           <a:solidFill>
-            <a:srgbClr val="EAF7F0"/>
+            <a:srgbClr val="DFF2EA"/>
           </a:solidFill>
           <a:ln>
             <a:solidFill>
-              <a:srgbClr val="EAF7F0"/>
+              <a:srgbClr val="DFF2EA"/>
             </a:solidFill>
           </a:ln>
         </p:spPr>
@@ -2444,7 +2505,7 @@
             <a:r>
               <a:rPr lang="en-US" sz="1000" b="1" dirty="0">
                 <a:solidFill>
-                  <a:srgbClr val="188038"/>
+                  <a:srgbClr val="00A86B"/>
                 </a:solidFill>
               </a:rPr>
               <a:t>3</a:t>
@@ -2482,7 +2543,7 @@
             <a:r>
               <a:rPr lang="en-US" sz="1200" dirty="0">
                 <a:solidFill>
-                  <a:srgbClr val="273043"/>
+                  <a:srgbClr val="263B38"/>
                 </a:solidFill>
               </a:rPr>
               <a:t>Si une erreur apparait, identifier si elle vient du changement realise.</a:t>
@@ -2512,7 +2573,7 @@
           </a:solidFill>
           <a:ln w="12700">
             <a:solidFill>
-              <a:srgbClr val="E4E7EC"/>
+              <a:srgbClr val="D6E5E0"/>
             </a:solidFill>
             <a:prstDash val="solid"/>
           </a:ln>
@@ -2533,11 +2594,11 @@
             <a:avLst/>
           </a:prstGeom>
           <a:solidFill>
-            <a:srgbClr val="EAF7F0"/>
+            <a:srgbClr val="DFF2EA"/>
           </a:solidFill>
           <a:ln>
             <a:solidFill>
-              <a:srgbClr val="EAF7F0"/>
+              <a:srgbClr val="DFF2EA"/>
             </a:solidFill>
           </a:ln>
         </p:spPr>
@@ -2551,7 +2612,7 @@
             <a:r>
               <a:rPr lang="en-US" sz="1000" b="1" dirty="0">
                 <a:solidFill>
-                  <a:srgbClr val="188038"/>
+                  <a:srgbClr val="00A86B"/>
                 </a:solidFill>
               </a:rPr>
               <a:t>4</a:t>
@@ -2589,7 +2650,7 @@
             <a:r>
               <a:rPr lang="en-US" sz="1200" dirty="0">
                 <a:solidFill>
-                  <a:srgbClr val="273043"/>
+                  <a:srgbClr val="263B38"/>
                 </a:solidFill>
               </a:rPr>
               <a:t>Si besoin, corriger le code ou le test pour refleter le comportement attendu.</a:t>
@@ -2625,7 +2686,7 @@
             <a:r>
               <a:rPr lang="en-US" sz="700" dirty="0">
                 <a:solidFill>
-                  <a:srgbClr val="667085"/>
+                  <a:srgbClr val="61716F"/>
                 </a:solidFill>
               </a:rPr>
               <a:t>10/10</a:t>
@@ -2648,7 +2709,7 @@
     <p:bg>
       <p:bgPr>
         <a:solidFill>
-          <a:srgbClr val="F7F9FC"/>
+          <a:srgbClr val="F3F8F6"/>
         </a:solidFill>
       </p:bgPr>
     </p:bg>
@@ -2681,11 +2742,11 @@
             <a:avLst/>
           </a:prstGeom>
           <a:solidFill>
-            <a:srgbClr val="DD0031"/>
+            <a:srgbClr val="008A5B"/>
           </a:solidFill>
           <a:ln w="12700">
             <a:solidFill>
-              <a:srgbClr val="DD0031"/>
+              <a:srgbClr val="008A5B"/>
             </a:solidFill>
             <a:prstDash val="solid"/>
           </a:ln>
@@ -2720,7 +2781,7 @@
             <a:r>
               <a:rPr lang="en-US" sz="2000" b="1" dirty="0">
                 <a:solidFill>
-                  <a:srgbClr val="202124"/>
+                  <a:srgbClr val="1B2B2A"/>
                 </a:solidFill>
               </a:rPr>
               <a:t>Rappels — Signal — Définition et rôle</a:t>
@@ -2744,11 +2805,11 @@
             <a:avLst/>
           </a:prstGeom>
           <a:solidFill>
-            <a:srgbClr val="FCE7EC"/>
+            <a:srgbClr val="CFEDE2"/>
           </a:solidFill>
           <a:ln>
             <a:solidFill>
-              <a:srgbClr val="FCE7EC"/>
+              <a:srgbClr val="CFEDE2"/>
             </a:solidFill>
           </a:ln>
         </p:spPr>
@@ -2762,10 +2823,10 @@
             <a:r>
               <a:rPr lang="en-US" sz="800" b="1" dirty="0">
                 <a:solidFill>
-                  <a:srgbClr val="DD0031"/>
-                </a:solidFill>
-              </a:rPr>
-              <a:t>Angular Signals</a:t>
+                  <a:srgbClr val="008A5B"/>
+                </a:solidFill>
+              </a:rPr>
+              <a:t>BNP Paribas</a:t>
             </a:r>
             <a:endParaRPr lang="en-US" sz="800" dirty="0"/>
           </a:p>
@@ -2788,11 +2849,11 @@
             </a:avLst>
           </a:prstGeom>
           <a:solidFill>
-            <a:srgbClr val="FCE7EC"/>
+            <a:srgbClr val="CFEDE2"/>
           </a:solidFill>
           <a:ln w="12700">
             <a:solidFill>
-              <a:srgbClr val="FCE7EC"/>
+              <a:srgbClr val="CFEDE2"/>
             </a:solidFill>
             <a:prstDash val="solid"/>
           </a:ln>
@@ -2827,7 +2888,7 @@
             <a:r>
               <a:rPr lang="en-US" sz="3000" b="1" dirty="0">
                 <a:solidFill>
-                  <a:srgbClr val="DD0031"/>
+                  <a:srgbClr val="008A5B"/>
                 </a:solidFill>
               </a:rPr>
               <a:t>Signal</a:t>
@@ -2863,7 +2924,7 @@
             <a:r>
               <a:rPr lang="en-US" sz="900" b="1" dirty="0">
                 <a:solidFill>
-                  <a:srgbClr val="DD0031"/>
+                  <a:srgbClr val="008A5B"/>
                 </a:solidFill>
               </a:rPr>
               <a:t>Définition</a:t>
@@ -2901,7 +2962,7 @@
             <a:r>
               <a:rPr lang="en-US" sz="1800" b="1" dirty="0">
                 <a:solidFill>
-                  <a:srgbClr val="202124"/>
+                  <a:srgbClr val="1B2B2A"/>
                 </a:solidFill>
               </a:rPr>
               <a:t>Un signal est une valeur reactive lue avec (). Quand sa valeur change, Angular sait quelles lectures dependent de cette valeur.</a:t>
@@ -2937,7 +2998,7 @@
             <a:r>
               <a:rPr lang="en-US" sz="800" b="1" dirty="0">
                 <a:solidFill>
-                  <a:srgbClr val="DD0031"/>
+                  <a:srgbClr val="008A5B"/>
                 </a:solidFill>
               </a:rPr>
               <a:t>Question clé</a:t>
@@ -2975,7 +3036,7 @@
             <a:r>
               <a:rPr lang="en-US" sz="1300" dirty="0">
                 <a:solidFill>
-                  <a:srgbClr val="273043"/>
+                  <a:srgbClr val="263B38"/>
                 </a:solidFill>
               </a:rPr>
               <a:t>Qui dépend de cette valeur ?</a:t>
@@ -3005,7 +3066,7 @@
           </a:solidFill>
           <a:ln w="12700">
             <a:solidFill>
-              <a:srgbClr val="E4E7EC"/>
+              <a:srgbClr val="D6E5E0"/>
             </a:solidFill>
             <a:prstDash val="solid"/>
           </a:ln>
@@ -3038,7 +3099,7 @@
             <a:r>
               <a:rPr lang="en-US" sz="1700" b="1" dirty="0">
                 <a:solidFill>
-                  <a:srgbClr val="DD0031"/>
+                  <a:srgbClr val="008A5B"/>
                 </a:solidFill>
               </a:rPr>
               <a:t>Rôle</a:t>
@@ -3062,11 +3123,11 @@
             <a:avLst/>
           </a:prstGeom>
           <a:solidFill>
-            <a:srgbClr val="DD0031"/>
+            <a:srgbClr val="008A5B"/>
           </a:solidFill>
           <a:ln w="12700">
             <a:solidFill>
-              <a:srgbClr val="DD0031"/>
+              <a:srgbClr val="008A5B"/>
             </a:solidFill>
             <a:prstDash val="solid"/>
           </a:ln>
@@ -3101,7 +3162,7 @@
             <a:r>
               <a:rPr lang="en-US" sz="1500" dirty="0">
                 <a:solidFill>
-                  <a:srgbClr val="273043"/>
+                  <a:srgbClr val="263B38"/>
                 </a:solidFill>
               </a:rPr>
               <a:t>Representer explicitement un etat reactive dans l'application.</a:t>
@@ -3125,11 +3186,11 @@
             <a:avLst/>
           </a:prstGeom>
           <a:solidFill>
-            <a:srgbClr val="DD0031"/>
+            <a:srgbClr val="008A5B"/>
           </a:solidFill>
           <a:ln w="12700">
             <a:solidFill>
-              <a:srgbClr val="DD0031"/>
+              <a:srgbClr val="008A5B"/>
             </a:solidFill>
             <a:prstDash val="solid"/>
           </a:ln>
@@ -3164,7 +3225,7 @@
             <a:r>
               <a:rPr lang="en-US" sz="1500" dirty="0">
                 <a:solidFill>
-                  <a:srgbClr val="273043"/>
+                  <a:srgbClr val="263B38"/>
                 </a:solidFill>
               </a:rPr>
               <a:t>Notifier Angular des lectures dependantes quand la valeur change.</a:t>
@@ -3200,7 +3261,7 @@
             <a:r>
               <a:rPr lang="en-US" sz="700" dirty="0">
                 <a:solidFill>
-                  <a:srgbClr val="667085"/>
+                  <a:srgbClr val="61716F"/>
                 </a:solidFill>
               </a:rPr>
               <a:t>2/10</a:t>
@@ -3223,7 +3284,7 @@
     <p:bg>
       <p:bgPr>
         <a:solidFill>
-          <a:srgbClr val="F7F9FC"/>
+          <a:srgbClr val="F3F8F6"/>
         </a:solidFill>
       </p:bgPr>
     </p:bg>
@@ -3256,11 +3317,11 @@
             <a:avLst/>
           </a:prstGeom>
           <a:solidFill>
-            <a:srgbClr val="DD0031"/>
+            <a:srgbClr val="008A5B"/>
           </a:solidFill>
           <a:ln w="12700">
             <a:solidFill>
-              <a:srgbClr val="DD0031"/>
+              <a:srgbClr val="008A5B"/>
             </a:solidFill>
             <a:prstDash val="solid"/>
           </a:ln>
@@ -3295,7 +3356,7 @@
             <a:r>
               <a:rPr lang="en-US" sz="2000" b="1" dirty="0">
                 <a:solidFill>
-                  <a:srgbClr val="202124"/>
+                  <a:srgbClr val="1B2B2A"/>
                 </a:solidFill>
               </a:rPr>
               <a:t>Rappels — Signal — À retenir</a:t>
@@ -3319,11 +3380,11 @@
             <a:avLst/>
           </a:prstGeom>
           <a:solidFill>
-            <a:srgbClr val="FCE7EC"/>
+            <a:srgbClr val="CFEDE2"/>
           </a:solidFill>
           <a:ln>
             <a:solidFill>
-              <a:srgbClr val="FCE7EC"/>
+              <a:srgbClr val="CFEDE2"/>
             </a:solidFill>
           </a:ln>
         </p:spPr>
@@ -3337,10 +3398,10 @@
             <a:r>
               <a:rPr lang="en-US" sz="800" b="1" dirty="0">
                 <a:solidFill>
-                  <a:srgbClr val="DD0031"/>
-                </a:solidFill>
-              </a:rPr>
-              <a:t>Angular Signals</a:t>
+                  <a:srgbClr val="008A5B"/>
+                </a:solidFill>
+              </a:rPr>
+              <a:t>BNP Paribas</a:t>
             </a:r>
             <a:endParaRPr lang="en-US" sz="800" dirty="0"/>
           </a:p>
@@ -3373,7 +3434,7 @@
             <a:r>
               <a:rPr lang="en-US" sz="1500" b="1" dirty="0">
                 <a:solidFill>
-                  <a:srgbClr val="DD0031"/>
+                  <a:srgbClr val="008A5B"/>
                 </a:solidFill>
               </a:rPr>
               <a:t>Signal</a:t>
@@ -3403,7 +3464,7 @@
           </a:solidFill>
           <a:ln w="12700">
             <a:solidFill>
-              <a:srgbClr val="E4E7EC"/>
+              <a:srgbClr val="D6E5E0"/>
             </a:solidFill>
             <a:prstDash val="solid"/>
           </a:ln>
@@ -3424,11 +3485,11 @@
             <a:avLst/>
           </a:prstGeom>
           <a:solidFill>
-            <a:srgbClr val="FCE7EC"/>
+            <a:srgbClr val="CFEDE2"/>
           </a:solidFill>
           <a:ln>
             <a:solidFill>
-              <a:srgbClr val="FCE7EC"/>
+              <a:srgbClr val="CFEDE2"/>
             </a:solidFill>
           </a:ln>
         </p:spPr>
@@ -3442,7 +3503,7 @@
             <a:r>
               <a:rPr lang="en-US" sz="1100" b="1" dirty="0">
                 <a:solidFill>
-                  <a:srgbClr val="DD0031"/>
+                  <a:srgbClr val="008A5B"/>
                 </a:solidFill>
               </a:rPr>
               <a:t>01</a:t>
@@ -3480,7 +3541,7 @@
             <a:r>
               <a:rPr lang="en-US" sz="1800" b="1" dirty="0">
                 <a:solidFill>
-                  <a:srgbClr val="273043"/>
+                  <a:srgbClr val="263B38"/>
                 </a:solidFill>
               </a:rPr>
               <a:t>Un signal se lit avec () et se modifie avec .set() ou .update().</a:t>
@@ -3510,7 +3571,7 @@
           </a:solidFill>
           <a:ln w="12700">
             <a:solidFill>
-              <a:srgbClr val="E4E7EC"/>
+              <a:srgbClr val="D6E5E0"/>
             </a:solidFill>
             <a:prstDash val="solid"/>
           </a:ln>
@@ -3531,11 +3592,11 @@
             <a:avLst/>
           </a:prstGeom>
           <a:solidFill>
-            <a:srgbClr val="FCE7EC"/>
+            <a:srgbClr val="CFEDE2"/>
           </a:solidFill>
           <a:ln>
             <a:solidFill>
-              <a:srgbClr val="FCE7EC"/>
+              <a:srgbClr val="CFEDE2"/>
             </a:solidFill>
           </a:ln>
         </p:spPr>
@@ -3549,7 +3610,7 @@
             <a:r>
               <a:rPr lang="en-US" sz="1100" b="1" dirty="0">
                 <a:solidFill>
-                  <a:srgbClr val="DD0031"/>
+                  <a:srgbClr val="008A5B"/>
                 </a:solidFill>
               </a:rPr>
               <a:t>02</a:t>
@@ -3587,7 +3648,7 @@
             <a:r>
               <a:rPr lang="en-US" sz="1800" b="1" dirty="0">
                 <a:solidFill>
-                  <a:srgbClr val="273043"/>
+                  <a:srgbClr val="263B38"/>
                 </a:solidFill>
               </a:rPr>
               <a:t>computed() derive une valeur ; effect() declenche un effet de bord.</a:t>
@@ -3623,7 +3684,7 @@
             <a:r>
               <a:rPr lang="en-US" sz="700" dirty="0">
                 <a:solidFill>
-                  <a:srgbClr val="667085"/>
+                  <a:srgbClr val="61716F"/>
                 </a:solidFill>
               </a:rPr>
               <a:t>3/10</a:t>
@@ -3646,7 +3707,7 @@
     <p:bg>
       <p:bgPr>
         <a:solidFill>
-          <a:srgbClr val="F7F9FC"/>
+          <a:srgbClr val="F3F8F6"/>
         </a:solidFill>
       </p:bgPr>
     </p:bg>
@@ -3679,11 +3740,11 @@
             <a:avLst/>
           </a:prstGeom>
           <a:solidFill>
-            <a:srgbClr val="DD0031"/>
+            <a:srgbClr val="008A5B"/>
           </a:solidFill>
           <a:ln w="12700">
             <a:solidFill>
-              <a:srgbClr val="DD0031"/>
+              <a:srgbClr val="008A5B"/>
             </a:solidFill>
             <a:prstDash val="solid"/>
           </a:ln>
@@ -3718,7 +3779,7 @@
             <a:r>
               <a:rPr lang="en-US" sz="2000" b="1" dirty="0">
                 <a:solidFill>
-                  <a:srgbClr val="202124"/>
+                  <a:srgbClr val="1B2B2A"/>
                 </a:solidFill>
               </a:rPr>
               <a:t>Rappels — Zone.js — Définition et rôle</a:t>
@@ -3742,11 +3803,11 @@
             <a:avLst/>
           </a:prstGeom>
           <a:solidFill>
-            <a:srgbClr val="FCE7EC"/>
+            <a:srgbClr val="CFEDE2"/>
           </a:solidFill>
           <a:ln>
             <a:solidFill>
-              <a:srgbClr val="FCE7EC"/>
+              <a:srgbClr val="CFEDE2"/>
             </a:solidFill>
           </a:ln>
         </p:spPr>
@@ -3760,10 +3821,10 @@
             <a:r>
               <a:rPr lang="en-US" sz="800" b="1" dirty="0">
                 <a:solidFill>
-                  <a:srgbClr val="DD0031"/>
-                </a:solidFill>
-              </a:rPr>
-              <a:t>Angular Signals</a:t>
+                  <a:srgbClr val="008A5B"/>
+                </a:solidFill>
+              </a:rPr>
+              <a:t>BNP Paribas</a:t>
             </a:r>
             <a:endParaRPr lang="en-US" sz="800" dirty="0"/>
           </a:p>
@@ -3786,11 +3847,11 @@
             </a:avLst>
           </a:prstGeom>
           <a:solidFill>
-            <a:srgbClr val="E8F1FF"/>
+            <a:srgbClr val="E8F2EF"/>
           </a:solidFill>
           <a:ln w="12700">
             <a:solidFill>
-              <a:srgbClr val="E8F1FF"/>
+              <a:srgbClr val="E8F2EF"/>
             </a:solidFill>
             <a:prstDash val="solid"/>
           </a:ln>
@@ -3825,7 +3886,7 @@
             <a:r>
               <a:rPr lang="en-US" sz="3000" b="1" dirty="0">
                 <a:solidFill>
-                  <a:srgbClr val="1976D2"/>
+                  <a:srgbClr val="006B4F"/>
                 </a:solidFill>
               </a:rPr>
               <a:t>Zone.js</a:t>
@@ -3861,7 +3922,7 @@
             <a:r>
               <a:rPr lang="en-US" sz="900" b="1" dirty="0">
                 <a:solidFill>
-                  <a:srgbClr val="1976D2"/>
+                  <a:srgbClr val="006B4F"/>
                 </a:solidFill>
               </a:rPr>
               <a:t>Définition</a:t>
@@ -3899,7 +3960,7 @@
             <a:r>
               <a:rPr lang="en-US" sz="1800" b="1" dirty="0">
                 <a:solidFill>
-                  <a:srgbClr val="202124"/>
+                  <a:srgbClr val="1B2B2A"/>
                 </a:solidFill>
               </a:rPr>
               <a:t>Zone.js intercepte les evenements asynchrones du navigateur et previent Angular qu'un cycle de detection peut etre lance.</a:t>
@@ -3935,7 +3996,7 @@
             <a:r>
               <a:rPr lang="en-US" sz="800" b="1" dirty="0">
                 <a:solidFill>
-                  <a:srgbClr val="1976D2"/>
+                  <a:srgbClr val="006B4F"/>
                 </a:solidFill>
               </a:rPr>
               <a:t>Question clé</a:t>
@@ -3973,7 +4034,7 @@
             <a:r>
               <a:rPr lang="en-US" sz="1300" dirty="0">
                 <a:solidFill>
-                  <a:srgbClr val="273043"/>
+                  <a:srgbClr val="263B38"/>
                 </a:solidFill>
               </a:rPr>
               <a:t>Qui déclenche la détection ?</a:t>
@@ -4003,7 +4064,7 @@
           </a:solidFill>
           <a:ln w="12700">
             <a:solidFill>
-              <a:srgbClr val="E4E7EC"/>
+              <a:srgbClr val="D6E5E0"/>
             </a:solidFill>
             <a:prstDash val="solid"/>
           </a:ln>
@@ -4036,7 +4097,7 @@
             <a:r>
               <a:rPr lang="en-US" sz="1700" b="1" dirty="0">
                 <a:solidFill>
-                  <a:srgbClr val="1976D2"/>
+                  <a:srgbClr val="006B4F"/>
                 </a:solidFill>
               </a:rPr>
               <a:t>Rôle</a:t>
@@ -4060,11 +4121,11 @@
             <a:avLst/>
           </a:prstGeom>
           <a:solidFill>
-            <a:srgbClr val="1976D2"/>
+            <a:srgbClr val="006B4F"/>
           </a:solidFill>
           <a:ln w="12700">
             <a:solidFill>
-              <a:srgbClr val="1976D2"/>
+              <a:srgbClr val="006B4F"/>
             </a:solidFill>
             <a:prstDash val="solid"/>
           </a:ln>
@@ -4099,7 +4160,7 @@
             <a:r>
               <a:rPr lang="en-US" sz="1500" dirty="0">
                 <a:solidFill>
-                  <a:srgbClr val="273043"/>
+                  <a:srgbClr val="263B38"/>
                 </a:solidFill>
               </a:rPr>
               <a:t>Declencher la detection de changement apres une tache asynchrone.</a:t>
@@ -4123,11 +4184,11 @@
             <a:avLst/>
           </a:prstGeom>
           <a:solidFill>
-            <a:srgbClr val="1976D2"/>
+            <a:srgbClr val="006B4F"/>
           </a:solidFill>
           <a:ln w="12700">
             <a:solidFill>
-              <a:srgbClr val="1976D2"/>
+              <a:srgbClr val="006B4F"/>
             </a:solidFill>
             <a:prstDash val="solid"/>
           </a:ln>
@@ -4162,7 +4223,7 @@
             <a:r>
               <a:rPr lang="en-US" sz="1500" dirty="0">
                 <a:solidFill>
-                  <a:srgbClr val="273043"/>
+                  <a:srgbClr val="263B38"/>
                 </a:solidFill>
               </a:rPr>
               <a:t>Fournir le comportement historique d'Angular sans appels manuels de detection.</a:t>
@@ -4198,7 +4259,7 @@
             <a:r>
               <a:rPr lang="en-US" sz="700" dirty="0">
                 <a:solidFill>
-                  <a:srgbClr val="667085"/>
+                  <a:srgbClr val="61716F"/>
                 </a:solidFill>
               </a:rPr>
               <a:t>4/10</a:t>
@@ -4221,7 +4282,7 @@
     <p:bg>
       <p:bgPr>
         <a:solidFill>
-          <a:srgbClr val="F7F9FC"/>
+          <a:srgbClr val="F3F8F6"/>
         </a:solidFill>
       </p:bgPr>
     </p:bg>
@@ -4254,11 +4315,11 @@
             <a:avLst/>
           </a:prstGeom>
           <a:solidFill>
-            <a:srgbClr val="DD0031"/>
+            <a:srgbClr val="008A5B"/>
           </a:solidFill>
           <a:ln w="12700">
             <a:solidFill>
-              <a:srgbClr val="DD0031"/>
+              <a:srgbClr val="008A5B"/>
             </a:solidFill>
             <a:prstDash val="solid"/>
           </a:ln>
@@ -4293,7 +4354,7 @@
             <a:r>
               <a:rPr lang="en-US" sz="2000" b="1" dirty="0">
                 <a:solidFill>
-                  <a:srgbClr val="202124"/>
+                  <a:srgbClr val="1B2B2A"/>
                 </a:solidFill>
               </a:rPr>
               <a:t>Rappels — Zone.js — À retenir</a:t>
@@ -4317,11 +4378,11 @@
             <a:avLst/>
           </a:prstGeom>
           <a:solidFill>
-            <a:srgbClr val="FCE7EC"/>
+            <a:srgbClr val="CFEDE2"/>
           </a:solidFill>
           <a:ln>
             <a:solidFill>
-              <a:srgbClr val="FCE7EC"/>
+              <a:srgbClr val="CFEDE2"/>
             </a:solidFill>
           </a:ln>
         </p:spPr>
@@ -4335,10 +4396,10 @@
             <a:r>
               <a:rPr lang="en-US" sz="800" b="1" dirty="0">
                 <a:solidFill>
-                  <a:srgbClr val="DD0031"/>
-                </a:solidFill>
-              </a:rPr>
-              <a:t>Angular Signals</a:t>
+                  <a:srgbClr val="008A5B"/>
+                </a:solidFill>
+              </a:rPr>
+              <a:t>BNP Paribas</a:t>
             </a:r>
             <a:endParaRPr lang="en-US" sz="800" dirty="0"/>
           </a:p>
@@ -4371,7 +4432,7 @@
             <a:r>
               <a:rPr lang="en-US" sz="1500" b="1" dirty="0">
                 <a:solidFill>
-                  <a:srgbClr val="1976D2"/>
+                  <a:srgbClr val="006B4F"/>
                 </a:solidFill>
               </a:rPr>
               <a:t>Zone.js</a:t>
@@ -4401,7 +4462,7 @@
           </a:solidFill>
           <a:ln w="12700">
             <a:solidFill>
-              <a:srgbClr val="E4E7EC"/>
+              <a:srgbClr val="D6E5E0"/>
             </a:solidFill>
             <a:prstDash val="solid"/>
           </a:ln>
@@ -4422,11 +4483,11 @@
             <a:avLst/>
           </a:prstGeom>
           <a:solidFill>
-            <a:srgbClr val="E8F1FF"/>
+            <a:srgbClr val="E8F2EF"/>
           </a:solidFill>
           <a:ln>
             <a:solidFill>
-              <a:srgbClr val="E8F1FF"/>
+              <a:srgbClr val="E8F2EF"/>
             </a:solidFill>
           </a:ln>
         </p:spPr>
@@ -4440,7 +4501,7 @@
             <a:r>
               <a:rPr lang="en-US" sz="1100" b="1" dirty="0">
                 <a:solidFill>
-                  <a:srgbClr val="1976D2"/>
+                  <a:srgbClr val="006B4F"/>
                 </a:solidFill>
               </a:rPr>
               <a:t>01</a:t>
@@ -4478,7 +4539,7 @@
             <a:r>
               <a:rPr lang="en-US" sz="1800" b="1" dirty="0">
                 <a:solidFill>
-                  <a:srgbClr val="273043"/>
+                  <a:srgbClr val="263B38"/>
                 </a:solidFill>
               </a:rPr>
               <a:t>Zone.js ne modelise pas l'etat applicatif et ne sait pas quelle valeur a change.</a:t>
@@ -4508,7 +4569,7 @@
           </a:solidFill>
           <a:ln w="12700">
             <a:solidFill>
-              <a:srgbClr val="E4E7EC"/>
+              <a:srgbClr val="D6E5E0"/>
             </a:solidFill>
             <a:prstDash val="solid"/>
           </a:ln>
@@ -4529,11 +4590,11 @@
             <a:avLst/>
           </a:prstGeom>
           <a:solidFill>
-            <a:srgbClr val="E8F1FF"/>
+            <a:srgbClr val="E8F2EF"/>
           </a:solidFill>
           <a:ln>
             <a:solidFill>
-              <a:srgbClr val="E8F1FF"/>
+              <a:srgbClr val="E8F2EF"/>
             </a:solidFill>
           </a:ln>
         </p:spPr>
@@ -4547,7 +4608,7 @@
             <a:r>
               <a:rPr lang="en-US" sz="1100" b="1" dirty="0">
                 <a:solidFill>
-                  <a:srgbClr val="1976D2"/>
+                  <a:srgbClr val="006B4F"/>
                 </a:solidFill>
               </a:rPr>
               <a:t>02</a:t>
@@ -4585,7 +4646,7 @@
             <a:r>
               <a:rPr lang="en-US" sz="1800" b="1" dirty="0">
                 <a:solidFill>
-                  <a:srgbClr val="273043"/>
+                  <a:srgbClr val="263B38"/>
                 </a:solidFill>
               </a:rPr>
               <a:t>Les Signals completent ce mecanisme en rendant les dependances d'etat explicites.</a:t>
@@ -4621,7 +4682,7 @@
             <a:r>
               <a:rPr lang="en-US" sz="700" dirty="0">
                 <a:solidFill>
-                  <a:srgbClr val="667085"/>
+                  <a:srgbClr val="61716F"/>
                 </a:solidFill>
               </a:rPr>
               <a:t>5/10</a:t>
@@ -4644,7 +4705,7 @@
     <p:bg>
       <p:bgPr>
         <a:solidFill>
-          <a:srgbClr val="F7F9FC"/>
+          <a:srgbClr val="F3F8F6"/>
         </a:solidFill>
       </p:bgPr>
     </p:bg>
@@ -4677,11 +4738,11 @@
             <a:avLst/>
           </a:prstGeom>
           <a:solidFill>
-            <a:srgbClr val="DD0031"/>
+            <a:srgbClr val="008A5B"/>
           </a:solidFill>
           <a:ln w="12700">
             <a:solidFill>
-              <a:srgbClr val="DD0031"/>
+              <a:srgbClr val="008A5B"/>
             </a:solidFill>
             <a:prstDash val="solid"/>
           </a:ln>
@@ -4716,7 +4777,7 @@
             <a:r>
               <a:rPr lang="en-US" sz="2000" b="1" dirty="0">
                 <a:solidFill>
-                  <a:srgbClr val="202124"/>
+                  <a:srgbClr val="1B2B2A"/>
                 </a:solidFill>
               </a:rPr>
               <a:t>Rappels — RxJS — Définition et rôle</a:t>
@@ -4740,11 +4801,11 @@
             <a:avLst/>
           </a:prstGeom>
           <a:solidFill>
-            <a:srgbClr val="FCE7EC"/>
+            <a:srgbClr val="CFEDE2"/>
           </a:solidFill>
           <a:ln>
             <a:solidFill>
-              <a:srgbClr val="FCE7EC"/>
+              <a:srgbClr val="CFEDE2"/>
             </a:solidFill>
           </a:ln>
         </p:spPr>
@@ -4758,10 +4819,10 @@
             <a:r>
               <a:rPr lang="en-US" sz="800" b="1" dirty="0">
                 <a:solidFill>
-                  <a:srgbClr val="DD0031"/>
-                </a:solidFill>
-              </a:rPr>
-              <a:t>Angular Signals</a:t>
+                  <a:srgbClr val="008A5B"/>
+                </a:solidFill>
+              </a:rPr>
+              <a:t>BNP Paribas</a:t>
             </a:r>
             <a:endParaRPr lang="en-US" sz="800" dirty="0"/>
           </a:p>
@@ -4784,11 +4845,11 @@
             </a:avLst>
           </a:prstGeom>
           <a:solidFill>
-            <a:srgbClr val="EAF7F0"/>
+            <a:srgbClr val="DFF2EA"/>
           </a:solidFill>
           <a:ln w="12700">
             <a:solidFill>
-              <a:srgbClr val="EAF7F0"/>
+              <a:srgbClr val="DFF2EA"/>
             </a:solidFill>
             <a:prstDash val="solid"/>
           </a:ln>
@@ -4823,7 +4884,7 @@
             <a:r>
               <a:rPr lang="en-US" sz="3000" b="1" dirty="0">
                 <a:solidFill>
-                  <a:srgbClr val="188038"/>
+                  <a:srgbClr val="00A86B"/>
                 </a:solidFill>
               </a:rPr>
               <a:t>RxJS</a:t>
@@ -4859,7 +4920,7 @@
             <a:r>
               <a:rPr lang="en-US" sz="900" b="1" dirty="0">
                 <a:solidFill>
-                  <a:srgbClr val="188038"/>
+                  <a:srgbClr val="00A86B"/>
                 </a:solidFill>
               </a:rPr>
               <a:t>Définition</a:t>
@@ -4897,7 +4958,7 @@
             <a:r>
               <a:rPr lang="en-US" sz="1800" b="1" dirty="0">
                 <a:solidFill>
-                  <a:srgbClr val="202124"/>
+                  <a:srgbClr val="1B2B2A"/>
                 </a:solidFill>
               </a:rPr>
               <a:t>RxJS sert a modeliser des flux dans le temps : HTTP, route params, evenements, debounceTime, switchMap, combineLatest.</a:t>
@@ -4933,7 +4994,7 @@
             <a:r>
               <a:rPr lang="en-US" sz="800" b="1" dirty="0">
                 <a:solidFill>
-                  <a:srgbClr val="188038"/>
+                  <a:srgbClr val="00A86B"/>
                 </a:solidFill>
               </a:rPr>
               <a:t>Question clé</a:t>
@@ -4971,7 +5032,7 @@
             <a:r>
               <a:rPr lang="en-US" sz="1300" dirty="0">
                 <a:solidFill>
-                  <a:srgbClr val="273043"/>
+                  <a:srgbClr val="263B38"/>
                 </a:solidFill>
               </a:rPr>
               <a:t>Où placer la frontière avec Signals ?</a:t>
@@ -5001,7 +5062,7 @@
           </a:solidFill>
           <a:ln w="12700">
             <a:solidFill>
-              <a:srgbClr val="E4E7EC"/>
+              <a:srgbClr val="D6E5E0"/>
             </a:solidFill>
             <a:prstDash val="solid"/>
           </a:ln>
@@ -5034,7 +5095,7 @@
             <a:r>
               <a:rPr lang="en-US" sz="1700" b="1" dirty="0">
                 <a:solidFill>
-                  <a:srgbClr val="188038"/>
+                  <a:srgbClr val="00A86B"/>
                 </a:solidFill>
               </a:rPr>
               <a:t>Rôle</a:t>
@@ -5058,11 +5119,11 @@
             <a:avLst/>
           </a:prstGeom>
           <a:solidFill>
-            <a:srgbClr val="188038"/>
+            <a:srgbClr val="00A86B"/>
           </a:solidFill>
           <a:ln w="12700">
             <a:solidFill>
-              <a:srgbClr val="188038"/>
+              <a:srgbClr val="00A86B"/>
             </a:solidFill>
             <a:prstDash val="solid"/>
           </a:ln>
@@ -5097,7 +5158,7 @@
             <a:r>
               <a:rPr lang="en-US" sz="1500" dirty="0">
                 <a:solidFill>
-                  <a:srgbClr val="273043"/>
+                  <a:srgbClr val="263B38"/>
                 </a:solidFill>
               </a:rPr>
               <a:t>Modeliser et composer des donnees qui arrivent dans le temps.</a:t>
@@ -5121,11 +5182,11 @@
             <a:avLst/>
           </a:prstGeom>
           <a:solidFill>
-            <a:srgbClr val="188038"/>
+            <a:srgbClr val="00A86B"/>
           </a:solidFill>
           <a:ln w="12700">
             <a:solidFill>
-              <a:srgbClr val="188038"/>
+              <a:srgbClr val="00A86B"/>
             </a:solidFill>
             <a:prstDash val="solid"/>
           </a:ln>
@@ -5160,7 +5221,7 @@
             <a:r>
               <a:rPr lang="en-US" sz="1500" dirty="0">
                 <a:solidFill>
-                  <a:srgbClr val="273043"/>
+                  <a:srgbClr val="263B38"/>
                 </a:solidFill>
               </a:rPr>
               <a:t>Gerer les transformations asynchrones avec des operateurs comme switchMap ou debounceTime.</a:t>
@@ -5196,7 +5257,7 @@
             <a:r>
               <a:rPr lang="en-US" sz="700" dirty="0">
                 <a:solidFill>
-                  <a:srgbClr val="667085"/>
+                  <a:srgbClr val="61716F"/>
                 </a:solidFill>
               </a:rPr>
               <a:t>6/10</a:t>
@@ -5219,7 +5280,7 @@
     <p:bg>
       <p:bgPr>
         <a:solidFill>
-          <a:srgbClr val="F7F9FC"/>
+          <a:srgbClr val="F3F8F6"/>
         </a:solidFill>
       </p:bgPr>
     </p:bg>
@@ -5252,11 +5313,11 @@
             <a:avLst/>
           </a:prstGeom>
           <a:solidFill>
-            <a:srgbClr val="DD0031"/>
+            <a:srgbClr val="008A5B"/>
           </a:solidFill>
           <a:ln w="12700">
             <a:solidFill>
-              <a:srgbClr val="DD0031"/>
+              <a:srgbClr val="008A5B"/>
             </a:solidFill>
             <a:prstDash val="solid"/>
           </a:ln>
@@ -5291,7 +5352,7 @@
             <a:r>
               <a:rPr lang="en-US" sz="2000" b="1" dirty="0">
                 <a:solidFill>
-                  <a:srgbClr val="202124"/>
+                  <a:srgbClr val="1B2B2A"/>
                 </a:solidFill>
               </a:rPr>
               <a:t>Rappels — RxJS — À retenir</a:t>
@@ -5315,11 +5376,11 @@
             <a:avLst/>
           </a:prstGeom>
           <a:solidFill>
-            <a:srgbClr val="FCE7EC"/>
+            <a:srgbClr val="CFEDE2"/>
           </a:solidFill>
           <a:ln>
             <a:solidFill>
-              <a:srgbClr val="FCE7EC"/>
+              <a:srgbClr val="CFEDE2"/>
             </a:solidFill>
           </a:ln>
         </p:spPr>
@@ -5333,10 +5394,10 @@
             <a:r>
               <a:rPr lang="en-US" sz="800" b="1" dirty="0">
                 <a:solidFill>
-                  <a:srgbClr val="DD0031"/>
-                </a:solidFill>
-              </a:rPr>
-              <a:t>Angular Signals</a:t>
+                  <a:srgbClr val="008A5B"/>
+                </a:solidFill>
+              </a:rPr>
+              <a:t>BNP Paribas</a:t>
             </a:r>
             <a:endParaRPr lang="en-US" sz="800" dirty="0"/>
           </a:p>
@@ -5369,7 +5430,7 @@
             <a:r>
               <a:rPr lang="en-US" sz="1500" b="1" dirty="0">
                 <a:solidFill>
-                  <a:srgbClr val="188038"/>
+                  <a:srgbClr val="00A86B"/>
                 </a:solidFill>
               </a:rPr>
               <a:t>RxJS</a:t>
@@ -5399,7 +5460,7 @@
           </a:solidFill>
           <a:ln w="12700">
             <a:solidFill>
-              <a:srgbClr val="E4E7EC"/>
+              <a:srgbClr val="D6E5E0"/>
             </a:solidFill>
             <a:prstDash val="solid"/>
           </a:ln>
@@ -5420,11 +5481,11 @@
             <a:avLst/>
           </a:prstGeom>
           <a:solidFill>
-            <a:srgbClr val="EAF7F0"/>
+            <a:srgbClr val="DFF2EA"/>
           </a:solidFill>
           <a:ln>
             <a:solidFill>
-              <a:srgbClr val="EAF7F0"/>
+              <a:srgbClr val="DFF2EA"/>
             </a:solidFill>
           </a:ln>
         </p:spPr>
@@ -5438,7 +5499,7 @@
             <a:r>
               <a:rPr lang="en-US" sz="1100" b="1" dirty="0">
                 <a:solidFill>
-                  <a:srgbClr val="188038"/>
+                  <a:srgbClr val="00A86B"/>
                 </a:solidFill>
               </a:rPr>
               <a:t>01</a:t>
@@ -5476,7 +5537,7 @@
             <a:r>
               <a:rPr lang="en-US" sz="1800" b="1" dirty="0">
                 <a:solidFill>
-                  <a:srgbClr val="273043"/>
+                  <a:srgbClr val="263B38"/>
                 </a:solidFill>
               </a:rPr>
               <a:t>toSignal() expose la derniere valeur d'un Observable comme signal.</a:t>
@@ -5506,7 +5567,7 @@
           </a:solidFill>
           <a:ln w="12700">
             <a:solidFill>
-              <a:srgbClr val="E4E7EC"/>
+              <a:srgbClr val="D6E5E0"/>
             </a:solidFill>
             <a:prstDash val="solid"/>
           </a:ln>
@@ -5527,11 +5588,11 @@
             <a:avLst/>
           </a:prstGeom>
           <a:solidFill>
-            <a:srgbClr val="EAF7F0"/>
+            <a:srgbClr val="DFF2EA"/>
           </a:solidFill>
           <a:ln>
             <a:solidFill>
-              <a:srgbClr val="EAF7F0"/>
+              <a:srgbClr val="DFF2EA"/>
             </a:solidFill>
           </a:ln>
         </p:spPr>
@@ -5545,7 +5606,7 @@
             <a:r>
               <a:rPr lang="en-US" sz="1100" b="1" dirty="0">
                 <a:solidFill>
-                  <a:srgbClr val="188038"/>
+                  <a:srgbClr val="00A86B"/>
                 </a:solidFill>
               </a:rPr>
               <a:t>02</a:t>
@@ -5583,7 +5644,7 @@
             <a:r>
               <a:rPr lang="en-US" sz="1800" b="1" dirty="0">
                 <a:solidFill>
-                  <a:srgbClr val="273043"/>
+                  <a:srgbClr val="263B38"/>
                 </a:solidFill>
               </a:rPr>
               <a:t>toObservable() permet de repasser d'un signal vers un flux Observable.</a:t>
@@ -5619,7 +5680,7 @@
             <a:r>
               <a:rPr lang="en-US" sz="700" dirty="0">
                 <a:solidFill>
-                  <a:srgbClr val="667085"/>
+                  <a:srgbClr val="61716F"/>
                 </a:solidFill>
               </a:rPr>
               <a:t>7/10</a:t>
@@ -5642,7 +5703,7 @@
     <p:bg>
       <p:bgPr>
         <a:solidFill>
-          <a:srgbClr val="F7F9FC"/>
+          <a:srgbClr val="F3F8F6"/>
         </a:solidFill>
       </p:bgPr>
     </p:bg>
@@ -5675,11 +5736,11 @@
             <a:avLst/>
           </a:prstGeom>
           <a:solidFill>
-            <a:srgbClr val="DD0031"/>
+            <a:srgbClr val="008A5B"/>
           </a:solidFill>
           <a:ln w="12700">
             <a:solidFill>
-              <a:srgbClr val="DD0031"/>
+              <a:srgbClr val="008A5B"/>
             </a:solidFill>
             <a:prstDash val="solid"/>
           </a:ln>
@@ -5714,7 +5775,7 @@
             <a:r>
               <a:rPr lang="en-US" sz="2000" b="1" dirty="0">
                 <a:solidFill>
-                  <a:srgbClr val="202124"/>
+                  <a:srgbClr val="1B2B2A"/>
                 </a:solidFill>
               </a:rPr>
               <a:t>Structure des branches</a:t>
@@ -5738,11 +5799,11 @@
             <a:avLst/>
           </a:prstGeom>
           <a:solidFill>
-            <a:srgbClr val="FCE7EC"/>
+            <a:srgbClr val="CFEDE2"/>
           </a:solidFill>
           <a:ln>
             <a:solidFill>
-              <a:srgbClr val="FCE7EC"/>
+              <a:srgbClr val="CFEDE2"/>
             </a:solidFill>
           </a:ln>
         </p:spPr>
@@ -5756,10 +5817,10 @@
             <a:r>
               <a:rPr lang="en-US" sz="800" b="1" dirty="0">
                 <a:solidFill>
-                  <a:srgbClr val="DD0031"/>
-                </a:solidFill>
-              </a:rPr>
-              <a:t>Angular Signals</a:t>
+                  <a:srgbClr val="008A5B"/>
+                </a:solidFill>
+              </a:rPr>
+              <a:t>BNP Paribas</a:t>
             </a:r>
             <a:endParaRPr lang="en-US" sz="800" dirty="0"/>
           </a:p>
@@ -5814,7 +5875,7 @@
                   <a:tcPr marL="50800" marR="50800" marT="25400" marB="25400" anchor="mid">
                     <a:lnL w="5715" cap="flat" cmpd="sng" algn="ctr">
                       <a:solidFill>
-                        <a:srgbClr val="E4E7EC"/>
+                        <a:srgbClr val="D6E5E0"/>
                       </a:solidFill>
                       <a:prstDash val="solid"/>
                       <a:round/>
@@ -5823,7 +5884,7 @@
                     </a:lnL>
                     <a:lnR w="5715" cap="flat" cmpd="sng" algn="ctr">
                       <a:solidFill>
-                        <a:srgbClr val="E4E7EC"/>
+                        <a:srgbClr val="D6E5E0"/>
                       </a:solidFill>
                       <a:prstDash val="solid"/>
                       <a:round/>
@@ -5832,7 +5893,7 @@
                     </a:lnR>
                     <a:lnT w="5715" cap="flat" cmpd="sng" algn="ctr">
                       <a:solidFill>
-                        <a:srgbClr val="E4E7EC"/>
+                        <a:srgbClr val="D6E5E0"/>
                       </a:solidFill>
                       <a:prstDash val="solid"/>
                       <a:round/>
@@ -5841,7 +5902,7 @@
                     </a:lnT>
                     <a:lnB w="5715" cap="flat" cmpd="sng" algn="ctr">
                       <a:solidFill>
-                        <a:srgbClr val="E4E7EC"/>
+                        <a:srgbClr val="D6E5E0"/>
                       </a:solidFill>
                       <a:prstDash val="solid"/>
                       <a:round/>
@@ -5849,7 +5910,7 @@
                       <a:tailEnd type="none" w="med" len="med"/>
                     </a:lnB>
                     <a:solidFill>
-                      <a:srgbClr val="DD0031"/>
+                      <a:srgbClr val="008A5B"/>
                     </a:solidFill>
                   </a:tcPr>
                 </a:tc>
@@ -5875,7 +5936,7 @@
                   <a:tcPr marL="50800" marR="50800" marT="25400" marB="25400" anchor="mid">
                     <a:lnL w="5715" cap="flat" cmpd="sng" algn="ctr">
                       <a:solidFill>
-                        <a:srgbClr val="E4E7EC"/>
+                        <a:srgbClr val="D6E5E0"/>
                       </a:solidFill>
                       <a:prstDash val="solid"/>
                       <a:round/>
@@ -5884,7 +5945,7 @@
                     </a:lnL>
                     <a:lnR w="5715" cap="flat" cmpd="sng" algn="ctr">
                       <a:solidFill>
-                        <a:srgbClr val="E4E7EC"/>
+                        <a:srgbClr val="D6E5E0"/>
                       </a:solidFill>
                       <a:prstDash val="solid"/>
                       <a:round/>
@@ -5893,7 +5954,7 @@
                     </a:lnR>
                     <a:lnT w="5715" cap="flat" cmpd="sng" algn="ctr">
                       <a:solidFill>
-                        <a:srgbClr val="E4E7EC"/>
+                        <a:srgbClr val="D6E5E0"/>
                       </a:solidFill>
                       <a:prstDash val="solid"/>
                       <a:round/>
@@ -5902,7 +5963,7 @@
                     </a:lnT>
                     <a:lnB w="5715" cap="flat" cmpd="sng" algn="ctr">
                       <a:solidFill>
-                        <a:srgbClr val="E4E7EC"/>
+                        <a:srgbClr val="D6E5E0"/>
                       </a:solidFill>
                       <a:prstDash val="solid"/>
                       <a:round/>
@@ -5910,7 +5971,7 @@
                       <a:tailEnd type="none" w="med" len="med"/>
                     </a:lnB>
                     <a:solidFill>
-                      <a:srgbClr val="DD0031"/>
+                      <a:srgbClr val="008A5B"/>
                     </a:solidFill>
                   </a:tcPr>
                 </a:tc>
@@ -5927,7 +5988,7 @@
                       <a:r>
                         <a:rPr lang="en-US" sz="1020" dirty="0">
                           <a:solidFill>
-                            <a:srgbClr val="273043"/>
+                            <a:srgbClr val="263B38"/>
                           </a:solidFill>
                         </a:rPr>
                         <a:t>main / init</a:t>
@@ -5938,7 +5999,7 @@
                   <a:tcPr marL="50800" marR="50800" marT="25400" marB="25400" anchor="mid">
                     <a:lnL w="5715" cap="flat" cmpd="sng" algn="ctr">
                       <a:solidFill>
-                        <a:srgbClr val="E4E7EC"/>
+                        <a:srgbClr val="D6E5E0"/>
                       </a:solidFill>
                       <a:prstDash val="solid"/>
                       <a:round/>
@@ -5947,7 +6008,7 @@
                     </a:lnL>
                     <a:lnR w="5715" cap="flat" cmpd="sng" algn="ctr">
                       <a:solidFill>
-                        <a:srgbClr val="E4E7EC"/>
+                        <a:srgbClr val="D6E5E0"/>
                       </a:solidFill>
                       <a:prstDash val="solid"/>
                       <a:round/>
@@ -5956,7 +6017,7 @@
                     </a:lnR>
                     <a:lnT w="5715" cap="flat" cmpd="sng" algn="ctr">
                       <a:solidFill>
-                        <a:srgbClr val="E4E7EC"/>
+                        <a:srgbClr val="D6E5E0"/>
                       </a:solidFill>
                       <a:prstDash val="solid"/>
                       <a:round/>
@@ -5965,7 +6026,7 @@
                     </a:lnT>
                     <a:lnB w="5715" cap="flat" cmpd="sng" algn="ctr">
                       <a:solidFill>
-                        <a:srgbClr val="E4E7EC"/>
+                        <a:srgbClr val="D6E5E0"/>
                       </a:solidFill>
                       <a:prstDash val="solid"/>
                       <a:round/>
@@ -5988,7 +6049,7 @@
                       <a:r>
                         <a:rPr lang="en-US" sz="1020" dirty="0">
                           <a:solidFill>
-                            <a:srgbClr val="273043"/>
+                            <a:srgbClr val="263B38"/>
                           </a:solidFill>
                         </a:rPr>
                         <a:t>base sans correction</a:t>
@@ -5999,7 +6060,7 @@
                   <a:tcPr marL="50800" marR="50800" marT="25400" marB="25400" anchor="mid">
                     <a:lnL w="5715" cap="flat" cmpd="sng" algn="ctr">
                       <a:solidFill>
-                        <a:srgbClr val="E4E7EC"/>
+                        <a:srgbClr val="D6E5E0"/>
                       </a:solidFill>
                       <a:prstDash val="solid"/>
                       <a:round/>
@@ -6008,7 +6069,7 @@
                     </a:lnL>
                     <a:lnR w="5715" cap="flat" cmpd="sng" algn="ctr">
                       <a:solidFill>
-                        <a:srgbClr val="E4E7EC"/>
+                        <a:srgbClr val="D6E5E0"/>
                       </a:solidFill>
                       <a:prstDash val="solid"/>
                       <a:round/>
@@ -6017,7 +6078,7 @@
                     </a:lnR>
                     <a:lnT w="5715" cap="flat" cmpd="sng" algn="ctr">
                       <a:solidFill>
-                        <a:srgbClr val="E4E7EC"/>
+                        <a:srgbClr val="D6E5E0"/>
                       </a:solidFill>
                       <a:prstDash val="solid"/>
                       <a:round/>
@@ -6026,7 +6087,7 @@
                     </a:lnT>
                     <a:lnB w="5715" cap="flat" cmpd="sng" algn="ctr">
                       <a:solidFill>
-                        <a:srgbClr val="E4E7EC"/>
+                        <a:srgbClr val="D6E5E0"/>
                       </a:solidFill>
                       <a:prstDash val="solid"/>
                       <a:round/>
@@ -6051,7 +6112,7 @@
                       <a:r>
                         <a:rPr lang="en-US" sz="1020" dirty="0">
                           <a:solidFill>
-                            <a:srgbClr val="273043"/>
+                            <a:srgbClr val="263B38"/>
                           </a:solidFill>
                         </a:rPr>
                         <a:t>exercice-1</a:t>
@@ -6062,7 +6123,7 @@
                   <a:tcPr marL="50800" marR="50800" marT="25400" marB="25400" anchor="mid">
                     <a:lnL w="5715" cap="flat" cmpd="sng" algn="ctr">
                       <a:solidFill>
-                        <a:srgbClr val="E4E7EC"/>
+                        <a:srgbClr val="D6E5E0"/>
                       </a:solidFill>
                       <a:prstDash val="solid"/>
                       <a:round/>
@@ -6071,7 +6132,7 @@
                     </a:lnL>
                     <a:lnR w="5715" cap="flat" cmpd="sng" algn="ctr">
                       <a:solidFill>
-                        <a:srgbClr val="E4E7EC"/>
+                        <a:srgbClr val="D6E5E0"/>
                       </a:solidFill>
                       <a:prstDash val="solid"/>
                       <a:round/>
@@ -6080,7 +6141,7 @@
                     </a:lnR>
                     <a:lnT w="5715" cap="flat" cmpd="sng" algn="ctr">
                       <a:solidFill>
-                        <a:srgbClr val="E4E7EC"/>
+                        <a:srgbClr val="D6E5E0"/>
                       </a:solidFill>
                       <a:prstDash val="solid"/>
                       <a:round/>
@@ -6089,7 +6150,7 @@
                     </a:lnT>
                     <a:lnB w="5715" cap="flat" cmpd="sng" algn="ctr">
                       <a:solidFill>
-                        <a:srgbClr val="E4E7EC"/>
+                        <a:srgbClr val="D6E5E0"/>
                       </a:solidFill>
                       <a:prstDash val="solid"/>
                       <a:round/>
@@ -6097,7 +6158,7 @@
                       <a:tailEnd type="none" w="med" len="med"/>
                     </a:lnB>
                     <a:solidFill>
-                      <a:srgbClr val="F7F9FC"/>
+                      <a:srgbClr val="F3F8F6"/>
                     </a:solidFill>
                   </a:tcPr>
                 </a:tc>
@@ -6112,7 +6173,7 @@
                       <a:r>
                         <a:rPr lang="en-US" sz="1020" dirty="0">
                           <a:solidFill>
-                            <a:srgbClr val="273043"/>
+                            <a:srgbClr val="263B38"/>
                           </a:solidFill>
                         </a:rPr>
                         <a:t>correction exercice 1</a:t>
@@ -6123,7 +6184,7 @@
                   <a:tcPr marL="50800" marR="50800" marT="25400" marB="25400" anchor="mid">
                     <a:lnL w="5715" cap="flat" cmpd="sng" algn="ctr">
                       <a:solidFill>
-                        <a:srgbClr val="E4E7EC"/>
+                        <a:srgbClr val="D6E5E0"/>
                       </a:solidFill>
                       <a:prstDash val="solid"/>
                       <a:round/>
@@ -6132,7 +6193,7 @@
                     </a:lnL>
                     <a:lnR w="5715" cap="flat" cmpd="sng" algn="ctr">
                       <a:solidFill>
-                        <a:srgbClr val="E4E7EC"/>
+                        <a:srgbClr val="D6E5E0"/>
                       </a:solidFill>
                       <a:prstDash val="solid"/>
                       <a:round/>
@@ -6141,7 +6202,7 @@
                     </a:lnR>
                     <a:lnT w="5715" cap="flat" cmpd="sng" algn="ctr">
                       <a:solidFill>
-                        <a:srgbClr val="E4E7EC"/>
+                        <a:srgbClr val="D6E5E0"/>
                       </a:solidFill>
                       <a:prstDash val="solid"/>
                       <a:round/>
@@ -6150,7 +6211,7 @@
                     </a:lnT>
                     <a:lnB w="5715" cap="flat" cmpd="sng" algn="ctr">
                       <a:solidFill>
-                        <a:srgbClr val="E4E7EC"/>
+                        <a:srgbClr val="D6E5E0"/>
                       </a:solidFill>
                       <a:prstDash val="solid"/>
                       <a:round/>
@@ -6158,7 +6219,7 @@
                       <a:tailEnd type="none" w="med" len="med"/>
                     </a:lnB>
                     <a:solidFill>
-                      <a:srgbClr val="F7F9FC"/>
+                      <a:srgbClr val="F3F8F6"/>
                     </a:solidFill>
                   </a:tcPr>
                 </a:tc>
@@ -6175,7 +6236,7 @@
                       <a:r>
                         <a:rPr lang="en-US" sz="1020" dirty="0">
                           <a:solidFill>
-                            <a:srgbClr val="273043"/>
+                            <a:srgbClr val="263B38"/>
                           </a:solidFill>
                         </a:rPr>
                         <a:t>exercice-2</a:t>
@@ -6186,7 +6247,7 @@
                   <a:tcPr marL="50800" marR="50800" marT="25400" marB="25400" anchor="mid">
                     <a:lnL w="5715" cap="flat" cmpd="sng" algn="ctr">
                       <a:solidFill>
-                        <a:srgbClr val="E4E7EC"/>
+                        <a:srgbClr val="D6E5E0"/>
                       </a:solidFill>
                       <a:prstDash val="solid"/>
                       <a:round/>
@@ -6195,7 +6256,7 @@
                     </a:lnL>
                     <a:lnR w="5715" cap="flat" cmpd="sng" algn="ctr">
                       <a:solidFill>
-                        <a:srgbClr val="E4E7EC"/>
+                        <a:srgbClr val="D6E5E0"/>
                       </a:solidFill>
                       <a:prstDash val="solid"/>
                       <a:round/>
@@ -6204,7 +6265,7 @@
                     </a:lnR>
                     <a:lnT w="5715" cap="flat" cmpd="sng" algn="ctr">
                       <a:solidFill>
-                        <a:srgbClr val="E4E7EC"/>
+                        <a:srgbClr val="D6E5E0"/>
                       </a:solidFill>
                       <a:prstDash val="solid"/>
                       <a:round/>
@@ -6213,7 +6274,7 @@
                     </a:lnT>
                     <a:lnB w="5715" cap="flat" cmpd="sng" algn="ctr">
                       <a:solidFill>
-                        <a:srgbClr val="E4E7EC"/>
+                        <a:srgbClr val="D6E5E0"/>
                       </a:solidFill>
                       <a:prstDash val="solid"/>
                       <a:round/>
@@ -6236,7 +6297,7 @@
                       <a:r>
                         <a:rPr lang="en-US" sz="1020" dirty="0">
                           <a:solidFill>
-                            <a:srgbClr val="273043"/>
+                            <a:srgbClr val="263B38"/>
                           </a:solidFill>
                         </a:rPr>
                         <a:t>corrections exercices 1 + 2</a:t>
@@ -6247,7 +6308,7 @@
                   <a:tcPr marL="50800" marR="50800" marT="25400" marB="25400" anchor="mid">
                     <a:lnL w="5715" cap="flat" cmpd="sng" algn="ctr">
                       <a:solidFill>
-                        <a:srgbClr val="E4E7EC"/>
+                        <a:srgbClr val="D6E5E0"/>
                       </a:solidFill>
                       <a:prstDash val="solid"/>
                       <a:round/>
@@ -6256,7 +6317,7 @@
                     </a:lnL>
                     <a:lnR w="5715" cap="flat" cmpd="sng" algn="ctr">
                       <a:solidFill>
-                        <a:srgbClr val="E4E7EC"/>
+                        <a:srgbClr val="D6E5E0"/>
                       </a:solidFill>
                       <a:prstDash val="solid"/>
                       <a:round/>
@@ -6265,7 +6326,7 @@
                     </a:lnR>
                     <a:lnT w="5715" cap="flat" cmpd="sng" algn="ctr">
                       <a:solidFill>
-                        <a:srgbClr val="E4E7EC"/>
+                        <a:srgbClr val="D6E5E0"/>
                       </a:solidFill>
                       <a:prstDash val="solid"/>
                       <a:round/>
@@ -6274,7 +6335,7 @@
                     </a:lnT>
                     <a:lnB w="5715" cap="flat" cmpd="sng" algn="ctr">
                       <a:solidFill>
-                        <a:srgbClr val="E4E7EC"/>
+                        <a:srgbClr val="D6E5E0"/>
                       </a:solidFill>
                       <a:prstDash val="solid"/>
                       <a:round/>
@@ -6299,7 +6360,7 @@
                       <a:r>
                         <a:rPr lang="en-US" sz="1020" dirty="0">
                           <a:solidFill>
-                            <a:srgbClr val="273043"/>
+                            <a:srgbClr val="263B38"/>
                           </a:solidFill>
                         </a:rPr>
                         <a:t>exercice-N</a:t>
@@ -6310,7 +6371,7 @@
                   <a:tcPr marL="50800" marR="50800" marT="25400" marB="25400" anchor="mid">
                     <a:lnL w="5715" cap="flat" cmpd="sng" algn="ctr">
                       <a:solidFill>
-                        <a:srgbClr val="E4E7EC"/>
+                        <a:srgbClr val="D6E5E0"/>
                       </a:solidFill>
                       <a:prstDash val="solid"/>
                       <a:round/>
@@ -6319,7 +6380,7 @@
                     </a:lnL>
                     <a:lnR w="5715" cap="flat" cmpd="sng" algn="ctr">
                       <a:solidFill>
-                        <a:srgbClr val="E4E7EC"/>
+                        <a:srgbClr val="D6E5E0"/>
                       </a:solidFill>
                       <a:prstDash val="solid"/>
                       <a:round/>
@@ -6328,7 +6389,7 @@
                     </a:lnR>
                     <a:lnT w="5715" cap="flat" cmpd="sng" algn="ctr">
                       <a:solidFill>
-                        <a:srgbClr val="E4E7EC"/>
+                        <a:srgbClr val="D6E5E0"/>
                       </a:solidFill>
                       <a:prstDash val="solid"/>
                       <a:round/>
@@ -6337,7 +6398,7 @@
                     </a:lnT>
                     <a:lnB w="5715" cap="flat" cmpd="sng" algn="ctr">
                       <a:solidFill>
-                        <a:srgbClr val="E4E7EC"/>
+                        <a:srgbClr val="D6E5E0"/>
                       </a:solidFill>
                       <a:prstDash val="solid"/>
                       <a:round/>
@@ -6345,7 +6406,7 @@
                       <a:tailEnd type="none" w="med" len="med"/>
                     </a:lnB>
                     <a:solidFill>
-                      <a:srgbClr val="F7F9FC"/>
+                      <a:srgbClr val="F3F8F6"/>
                     </a:solidFill>
                   </a:tcPr>
                 </a:tc>
@@ -6360,7 +6421,7 @@
                       <a:r>
                         <a:rPr lang="en-US" sz="1020" dirty="0">
                           <a:solidFill>
-                            <a:srgbClr val="273043"/>
+                            <a:srgbClr val="263B38"/>
                           </a:solidFill>
                         </a:rPr>
                         <a:t>corrections cumulees jusqu'a N</a:t>
@@ -6371,7 +6432,7 @@
                   <a:tcPr marL="50800" marR="50800" marT="25400" marB="25400" anchor="mid">
                     <a:lnL w="5715" cap="flat" cmpd="sng" algn="ctr">
                       <a:solidFill>
-                        <a:srgbClr val="E4E7EC"/>
+                        <a:srgbClr val="D6E5E0"/>
                       </a:solidFill>
                       <a:prstDash val="solid"/>
                       <a:round/>
@@ -6380,7 +6441,7 @@
                     </a:lnL>
                     <a:lnR w="5715" cap="flat" cmpd="sng" algn="ctr">
                       <a:solidFill>
-                        <a:srgbClr val="E4E7EC"/>
+                        <a:srgbClr val="D6E5E0"/>
                       </a:solidFill>
                       <a:prstDash val="solid"/>
                       <a:round/>
@@ -6389,7 +6450,7 @@
                     </a:lnR>
                     <a:lnT w="5715" cap="flat" cmpd="sng" algn="ctr">
                       <a:solidFill>
-                        <a:srgbClr val="E4E7EC"/>
+                        <a:srgbClr val="D6E5E0"/>
                       </a:solidFill>
                       <a:prstDash val="solid"/>
                       <a:round/>
@@ -6398,7 +6459,7 @@
                     </a:lnT>
                     <a:lnB w="5715" cap="flat" cmpd="sng" algn="ctr">
                       <a:solidFill>
-                        <a:srgbClr val="E4E7EC"/>
+                        <a:srgbClr val="D6E5E0"/>
                       </a:solidFill>
                       <a:prstDash val="solid"/>
                       <a:round/>
@@ -6406,7 +6467,7 @@
                       <a:tailEnd type="none" w="med" len="med"/>
                     </a:lnB>
                     <a:solidFill>
-                      <a:srgbClr val="F7F9FC"/>
+                      <a:srgbClr val="F3F8F6"/>
                     </a:solidFill>
                   </a:tcPr>
                 </a:tc>
@@ -6442,7 +6503,7 @@
             <a:r>
               <a:rPr lang="en-US" sz="700" dirty="0">
                 <a:solidFill>
-                  <a:srgbClr val="667085"/>
+                  <a:srgbClr val="61716F"/>
                 </a:solidFill>
               </a:rPr>
               <a:t>8/10</a:t>
@@ -6465,7 +6526,7 @@
     <p:bg>
       <p:bgPr>
         <a:solidFill>
-          <a:srgbClr val="F7F9FC"/>
+          <a:srgbClr val="F3F8F6"/>
         </a:solidFill>
       </p:bgPr>
     </p:bg>
@@ -6498,11 +6559,11 @@
             <a:avLst/>
           </a:prstGeom>
           <a:solidFill>
-            <a:srgbClr val="DD0031"/>
+            <a:srgbClr val="008A5B"/>
           </a:solidFill>
           <a:ln w="12700">
             <a:solidFill>
-              <a:srgbClr val="DD0031"/>
+              <a:srgbClr val="008A5B"/>
             </a:solidFill>
             <a:prstDash val="solid"/>
           </a:ln>
@@ -6537,7 +6598,7 @@
             <a:r>
               <a:rPr lang="en-US" sz="2000" b="1" dirty="0">
                 <a:solidFill>
-                  <a:srgbClr val="202124"/>
+                  <a:srgbClr val="1B2B2A"/>
                 </a:solidFill>
               </a:rPr>
               <a:t>Exercices</a:t>
@@ -6561,11 +6622,11 @@
             <a:avLst/>
           </a:prstGeom>
           <a:solidFill>
-            <a:srgbClr val="FCE7EC"/>
+            <a:srgbClr val="CFEDE2"/>
           </a:solidFill>
           <a:ln>
             <a:solidFill>
-              <a:srgbClr val="FCE7EC"/>
+              <a:srgbClr val="CFEDE2"/>
             </a:solidFill>
           </a:ln>
         </p:spPr>
@@ -6579,10 +6640,10 @@
             <a:r>
               <a:rPr lang="en-US" sz="800" b="1" dirty="0">
                 <a:solidFill>
-                  <a:srgbClr val="DD0031"/>
-                </a:solidFill>
-              </a:rPr>
-              <a:t>Angular Signals</a:t>
+                  <a:srgbClr val="008A5B"/>
+                </a:solidFill>
+              </a:rPr>
+              <a:t>BNP Paribas</a:t>
             </a:r>
             <a:endParaRPr lang="en-US" sz="800" dirty="0"/>
           </a:p>
@@ -6609,7 +6670,7 @@
           </a:solidFill>
           <a:ln w="12700">
             <a:solidFill>
-              <a:srgbClr val="E4E7EC"/>
+              <a:srgbClr val="D6E5E0"/>
             </a:solidFill>
             <a:prstDash val="solid"/>
           </a:ln>
@@ -6630,11 +6691,11 @@
             <a:avLst/>
           </a:prstGeom>
           <a:solidFill>
-            <a:srgbClr val="DD0031"/>
+            <a:srgbClr val="008A5B"/>
           </a:solidFill>
           <a:ln w="12700">
             <a:solidFill>
-              <a:srgbClr val="DD0031"/>
+              <a:srgbClr val="008A5B"/>
             </a:solidFill>
             <a:prstDash val="solid"/>
           </a:ln>
@@ -6669,7 +6730,7 @@
             <a:r>
               <a:rPr lang="en-US" sz="820" b="1" dirty="0">
                 <a:solidFill>
-                  <a:srgbClr val="DD0031"/>
+                  <a:srgbClr val="008A5B"/>
                 </a:solidFill>
               </a:rPr>
               <a:t>1 — signal()</a:t>
@@ -6707,7 +6768,7 @@
             <a:r>
               <a:rPr lang="en-US" sz="680" dirty="0">
                 <a:solidFill>
-                  <a:srgbClr val="667085"/>
+                  <a:srgbClr val="61716F"/>
                 </a:solidFill>
               </a:rPr>
               <a:t>Valeur reactive mutable lue avec ().</a:t>
@@ -6745,7 +6806,7 @@
             <a:r>
               <a:rPr lang="en-US" sz="580" dirty="0">
                 <a:solidFill>
-                  <a:srgbClr val="1976D2"/>
+                  <a:srgbClr val="006B4F"/>
                 </a:solidFill>
               </a:rPr>
               <a:t>clients/pages/clients/clients.component.ts</a:t>
@@ -6783,7 +6844,7 @@
             <a:r>
               <a:rPr lang="en-US" sz="680" dirty="0">
                 <a:solidFill>
-                  <a:srgbClr val="273043"/>
+                  <a:srgbClr val="263B38"/>
                 </a:solidFill>
               </a:rPr>
               <a:t>Convertir l'etat adding en signal. Le template doit afficher le formulaire a partir de ce nouvel etat reactif.</a:t>
@@ -6813,7 +6874,7 @@
           </a:solidFill>
           <a:ln w="12700">
             <a:solidFill>
-              <a:srgbClr val="E4E7EC"/>
+              <a:srgbClr val="D6E5E0"/>
             </a:solidFill>
             <a:prstDash val="solid"/>
           </a:ln>
@@ -6834,11 +6895,11 @@
             <a:avLst/>
           </a:prstGeom>
           <a:solidFill>
-            <a:srgbClr val="1976D2"/>
+            <a:srgbClr val="006B4F"/>
           </a:solidFill>
           <a:ln w="12700">
             <a:solidFill>
-              <a:srgbClr val="1976D2"/>
+              <a:srgbClr val="006B4F"/>
             </a:solidFill>
             <a:prstDash val="solid"/>
           </a:ln>
@@ -6873,7 +6934,7 @@
             <a:r>
               <a:rPr lang="en-US" sz="820" b="1" dirty="0">
                 <a:solidFill>
-                  <a:srgbClr val="1976D2"/>
+                  <a:srgbClr val="006B4F"/>
                 </a:solidFill>
               </a:rPr>
               <a:t>2 — computed()</a:t>
@@ -6911,7 +6972,7 @@
             <a:r>
               <a:rPr lang="en-US" sz="680" dirty="0">
                 <a:solidFill>
-                  <a:srgbClr val="667085"/>
+                  <a:srgbClr val="61716F"/>
                 </a:solidFill>
               </a:rPr>
               <a:t>Valeur derivee en lecture seule.</a:t>
@@ -6949,7 +7010,7 @@
             <a:r>
               <a:rPr lang="en-US" sz="580" dirty="0">
                 <a:solidFill>
-                  <a:srgbClr val="1976D2"/>
+                  <a:srgbClr val="006B4F"/>
                 </a:solidFill>
               </a:rPr>
               <a:t>accounts/services/accounts.facade.ts</a:t>
@@ -6963,7 +7024,7 @@
             <a:r>
               <a:rPr lang="en-US" sz="580" dirty="0">
                 <a:solidFill>
-                  <a:srgbClr val="1976D2"/>
+                  <a:srgbClr val="006B4F"/>
                 </a:solidFill>
               </a:rPr>
               <a:t>accounts/pages/accounts/accounts.component.*</a:t>
@@ -7001,7 +7062,7 @@
             <a:r>
               <a:rPr lang="en-US" sz="680" dirty="0">
                 <a:solidFill>
-                  <a:srgbClr val="273043"/>
+                  <a:srgbClr val="263B38"/>
                 </a:solidFill>
               </a:rPr>
               <a:t>Transformer blockedAccountsCount en valeur derivee de la facade. La page accounts doit afficher ce compteur sans recalculer elle-meme la regle.</a:t>
@@ -7031,7 +7092,7 @@
           </a:solidFill>
           <a:ln w="12700">
             <a:solidFill>
-              <a:srgbClr val="E4E7EC"/>
+              <a:srgbClr val="D6E5E0"/>
             </a:solidFill>
             <a:prstDash val="solid"/>
           </a:ln>
@@ -7052,11 +7113,11 @@
             <a:avLst/>
           </a:prstGeom>
           <a:solidFill>
-            <a:srgbClr val="DD0031"/>
+            <a:srgbClr val="008A5B"/>
           </a:solidFill>
           <a:ln w="12700">
             <a:solidFill>
-              <a:srgbClr val="DD0031"/>
+              <a:srgbClr val="008A5B"/>
             </a:solidFill>
             <a:prstDash val="solid"/>
           </a:ln>
@@ -7091,7 +7152,7 @@
             <a:r>
               <a:rPr lang="en-US" sz="820" b="1" dirty="0">
                 <a:solidFill>
-                  <a:srgbClr val="DD0031"/>
+                  <a:srgbClr val="008A5B"/>
                 </a:solidFill>
               </a:rPr>
               <a:t>3 — effect()</a:t>
@@ -7129,7 +7190,7 @@
             <a:r>
               <a:rPr lang="en-US" sz="680" dirty="0">
                 <a:solidFill>
-                  <a:srgbClr val="667085"/>
+                  <a:srgbClr val="61716F"/>
                 </a:solidFill>
               </a:rPr>
               <a:t>Effet de bord declenche par les signals lus.</a:t>
@@ -7167,7 +7228,7 @@
             <a:r>
               <a:rPr lang="en-US" sz="580" dirty="0">
                 <a:solidFill>
-                  <a:srgbClr val="1976D2"/>
+                  <a:srgbClr val="006B4F"/>
                 </a:solidFill>
               </a:rPr>
               <a:t>clients/pages/clients/clients.component.ts</a:t>
@@ -7205,7 +7266,7 @@
             <a:r>
               <a:rPr lang="en-US" sz="680" dirty="0">
                 <a:solidFill>
-                  <a:srgbClr val="273043"/>
+                  <a:srgbClr val="263B38"/>
                 </a:solidFill>
               </a:rPr>
               <a:t>Remplacer le recalage imperatif de la page courante par une reaction automatique. Quand la liste change, la page selectionnee doit rester valide.</a:t>
@@ -7235,7 +7296,7 @@
           </a:solidFill>
           <a:ln w="12700">
             <a:solidFill>
-              <a:srgbClr val="E4E7EC"/>
+              <a:srgbClr val="D6E5E0"/>
             </a:solidFill>
             <a:prstDash val="solid"/>
           </a:ln>
@@ -7256,11 +7317,11 @@
             <a:avLst/>
           </a:prstGeom>
           <a:solidFill>
-            <a:srgbClr val="1976D2"/>
+            <a:srgbClr val="006B4F"/>
           </a:solidFill>
           <a:ln w="12700">
             <a:solidFill>
-              <a:srgbClr val="1976D2"/>
+              <a:srgbClr val="006B4F"/>
             </a:solidFill>
             <a:prstDash val="solid"/>
           </a:ln>
@@ -7295,7 +7356,7 @@
             <a:r>
               <a:rPr lang="en-US" sz="820" b="1" dirty="0">
                 <a:solidFill>
-                  <a:srgbClr val="1976D2"/>
+                  <a:srgbClr val="006B4F"/>
                 </a:solidFill>
               </a:rPr>
               <a:t>4 — viewChild() + effect()</a:t>
@@ -7333,7 +7394,7 @@
             <a:r>
               <a:rPr lang="en-US" sz="680" dirty="0">
                 <a:solidFill>
-                  <a:srgbClr val="667085"/>
+                  <a:srgbClr val="61716F"/>
                 </a:solidFill>
               </a:rPr>
               <a:t>Reference DOM exposee comme signal, puis effet DOM.</a:t>
@@ -7371,7 +7432,7 @@
             <a:r>
               <a:rPr lang="en-US" sz="580" dirty="0">
                 <a:solidFill>
-                  <a:srgbClr val="1976D2"/>
+                  <a:srgbClr val="006B4F"/>
                 </a:solidFill>
               </a:rPr>
               <a:t>clients/pages/clients/clients.component.ts</a:t>
@@ -7409,7 +7470,7 @@
             <a:r>
               <a:rPr lang="en-US" sz="680" dirty="0">
                 <a:solidFill>
-                  <a:srgbClr val="273043"/>
+                  <a:srgbClr val="263B38"/>
                 </a:solidFill>
               </a:rPr>
               <a:t>Remplacer la reference DOM classique du champ prenom par une reference signal, puis declencher le focus quand ce champ apparait.</a:t>
@@ -7439,7 +7500,7 @@
           </a:solidFill>
           <a:ln w="12700">
             <a:solidFill>
-              <a:srgbClr val="E4E7EC"/>
+              <a:srgbClr val="D6E5E0"/>
             </a:solidFill>
             <a:prstDash val="solid"/>
           </a:ln>
@@ -7460,11 +7521,11 @@
             <a:avLst/>
           </a:prstGeom>
           <a:solidFill>
-            <a:srgbClr val="DD0031"/>
+            <a:srgbClr val="008A5B"/>
           </a:solidFill>
           <a:ln w="12700">
             <a:solidFill>
-              <a:srgbClr val="DD0031"/>
+              <a:srgbClr val="008A5B"/>
             </a:solidFill>
             <a:prstDash val="solid"/>
           </a:ln>
@@ -7499,7 +7560,7 @@
             <a:r>
               <a:rPr lang="en-US" sz="820" b="1" dirty="0">
                 <a:solidFill>
-                  <a:srgbClr val="DD0031"/>
+                  <a:srgbClr val="008A5B"/>
                 </a:solidFill>
               </a:rPr>
               <a:t>5 — input()</a:t>
@@ -7537,7 +7598,7 @@
             <a:r>
               <a:rPr lang="en-US" sz="680" dirty="0">
                 <a:solidFill>
-                  <a:srgbClr val="667085"/>
+                  <a:srgbClr val="61716F"/>
                 </a:solidFill>
               </a:rPr>
               <a:t>Entree de composant exposee comme signal.</a:t>
@@ -7575,7 +7636,7 @@
             <a:r>
               <a:rPr lang="en-US" sz="580" dirty="0">
                 <a:solidFill>
-                  <a:srgbClr val="1976D2"/>
+                  <a:srgbClr val="006B4F"/>
                 </a:solidFill>
               </a:rPr>
               <a:t>accounts/components/account-card/account-card.component.ts</a:t>
@@ -7613,7 +7674,7 @@
             <a:r>
               <a:rPr lang="en-US" sz="680" dirty="0">
                 <a:solidFill>
-                  <a:srgbClr val="273043"/>
+                  <a:srgbClr val="263B38"/>
                 </a:solidFill>
               </a:rPr>
               <a:t>Convertir showStatus en input signal. Le libelle de statut doit reagir correctement quand le parent choisit d'afficher ou masquer ce statut.</a:t>
@@ -7643,7 +7704,7 @@
           </a:solidFill>
           <a:ln w="12700">
             <a:solidFill>
-              <a:srgbClr val="E4E7EC"/>
+              <a:srgbClr val="D6E5E0"/>
             </a:solidFill>
             <a:prstDash val="solid"/>
           </a:ln>
@@ -7664,11 +7725,11 @@
             <a:avLst/>
           </a:prstGeom>
           <a:solidFill>
-            <a:srgbClr val="1976D2"/>
+            <a:srgbClr val="006B4F"/>
           </a:solidFill>
           <a:ln w="12700">
             <a:solidFill>
-              <a:srgbClr val="1976D2"/>
+              <a:srgbClr val="006B4F"/>
             </a:solidFill>
             <a:prstDash val="solid"/>
           </a:ln>
@@ -7703,7 +7764,7 @@
             <a:r>
               <a:rPr lang="en-US" sz="820" b="1" dirty="0">
                 <a:solidFill>
-                  <a:srgbClr val="1976D2"/>
+                  <a:srgbClr val="006B4F"/>
                 </a:solidFill>
               </a:rPr>
               <a:t>6 — output()</a:t>
@@ -7741,7 +7802,7 @@
             <a:r>
               <a:rPr lang="en-US" sz="680" dirty="0">
                 <a:solidFill>
-                  <a:srgbClr val="667085"/>
+                  <a:srgbClr val="61716F"/>
                 </a:solidFill>
               </a:rPr>
               <a:t>Evenement emis par l'enfant vers le parent.</a:t>
@@ -7779,7 +7840,7 @@
             <a:r>
               <a:rPr lang="en-US" sz="580" dirty="0">
                 <a:solidFill>
-                  <a:srgbClr val="1976D2"/>
+                  <a:srgbClr val="006B4F"/>
                 </a:solidFill>
               </a:rPr>
               <a:t>accounts/components/account-list/account-list.component.ts</a:t>
@@ -7817,7 +7878,7 @@
             <a:r>
               <a:rPr lang="en-US" sz="680" dirty="0">
                 <a:solidFill>
-                  <a:srgbClr val="273043"/>
+                  <a:srgbClr val="263B38"/>
                 </a:solidFill>
               </a:rPr>
               <a:t>Remplacer la sortie legacy selectedRequested par output(). La liste doit continuer a emettre la selection vers le parent.</a:t>
@@ -7847,7 +7908,7 @@
           </a:solidFill>
           <a:ln w="12700">
             <a:solidFill>
-              <a:srgbClr val="E4E7EC"/>
+              <a:srgbClr val="D6E5E0"/>
             </a:solidFill>
             <a:prstDash val="solid"/>
           </a:ln>
@@ -7868,11 +7929,11 @@
             <a:avLst/>
           </a:prstGeom>
           <a:solidFill>
-            <a:srgbClr val="DD0031"/>
+            <a:srgbClr val="008A5B"/>
           </a:solidFill>
           <a:ln w="12700">
             <a:solidFill>
-              <a:srgbClr val="DD0031"/>
+              <a:srgbClr val="008A5B"/>
             </a:solidFill>
             <a:prstDash val="solid"/>
           </a:ln>
@@ -7907,7 +7968,7 @@
             <a:r>
               <a:rPr lang="en-US" sz="820" b="1" dirty="0">
                 <a:solidFill>
-                  <a:srgbClr val="DD0031"/>
+                  <a:srgbClr val="008A5B"/>
                 </a:solidFill>
               </a:rPr>
               <a:t>7 — toSignal() / toObservable()</a:t>
@@ -7945,7 +8006,7 @@
             <a:r>
               <a:rPr lang="en-US" sz="680" dirty="0">
                 <a:solidFill>
-                  <a:srgbClr val="667085"/>
+                  <a:srgbClr val="61716F"/>
                 </a:solidFill>
               </a:rPr>
               <a:t>Pont entre Observable RxJS et signal Angular.</a:t>
@@ -7983,7 +8044,7 @@
             <a:r>
               <a:rPr lang="en-US" sz="580" dirty="0">
                 <a:solidFill>
-                  <a:srgbClr val="1976D2"/>
+                  <a:srgbClr val="006B4F"/>
                 </a:solidFill>
               </a:rPr>
               <a:t>accounts/pages/accounts/accounts.component.ts</a:t>
@@ -7997,7 +8058,7 @@
             <a:r>
               <a:rPr lang="en-US" sz="580" dirty="0">
                 <a:solidFill>
-                  <a:srgbClr val="1976D2"/>
+                  <a:srgbClr val="006B4F"/>
                 </a:solidFill>
               </a:rPr>
               <a:t>clients/pages/dashboard/dashboard.component.ts</a:t>
@@ -8011,7 +8072,7 @@
             <a:r>
               <a:rPr lang="en-US" sz="580" dirty="0">
                 <a:solidFill>
-                  <a:srgbClr val="1976D2"/>
+                  <a:srgbClr val="006B4F"/>
                 </a:solidFill>
               </a:rPr>
               <a:t>clients/pages/clients/clients.component.ts</a:t>
@@ -8049,7 +8110,7 @@
             <a:r>
               <a:rPr lang="en-US" sz="680" dirty="0">
                 <a:solidFill>
-                  <a:srgbClr val="273043"/>
+                  <a:srgbClr val="263B38"/>
                 </a:solidFill>
               </a:rPr>
               <a:t>Remplacer la souscription manuelle a la route par toSignal(), exposer le chargement dashboard comme signal, et identifier le pont inverse toObservable() pour la recherche debouncee.</a:t>
@@ -8079,7 +8140,7 @@
           </a:solidFill>
           <a:ln w="12700">
             <a:solidFill>
-              <a:srgbClr val="E4E7EC"/>
+              <a:srgbClr val="D6E5E0"/>
             </a:solidFill>
             <a:prstDash val="solid"/>
           </a:ln>
@@ -8100,11 +8161,11 @@
             <a:avLst/>
           </a:prstGeom>
           <a:solidFill>
-            <a:srgbClr val="1976D2"/>
+            <a:srgbClr val="006B4F"/>
           </a:solidFill>
           <a:ln w="12700">
             <a:solidFill>
-              <a:srgbClr val="1976D2"/>
+              <a:srgbClr val="006B4F"/>
             </a:solidFill>
             <a:prstDash val="solid"/>
           </a:ln>
@@ -8139,7 +8200,7 @@
             <a:r>
               <a:rPr lang="en-US" sz="820" b="1" dirty="0">
                 <a:solidFill>
-                  <a:srgbClr val="1976D2"/>
+                  <a:srgbClr val="006B4F"/>
                 </a:solidFill>
               </a:rPr>
               <a:t>8 — computed() facade</a:t>
@@ -8177,7 +8238,7 @@
             <a:r>
               <a:rPr lang="en-US" sz="680" dirty="0">
                 <a:solidFill>
-                  <a:srgbClr val="667085"/>
+                  <a:srgbClr val="61716F"/>
                 </a:solidFill>
               </a:rPr>
               <a:t>Vue derivee de l'etat metier dans une facade.</a:t>
@@ -8215,7 +8276,7 @@
             <a:r>
               <a:rPr lang="en-US" sz="580" dirty="0">
                 <a:solidFill>
-                  <a:srgbClr val="1976D2"/>
+                  <a:srgbClr val="006B4F"/>
                 </a:solidFill>
               </a:rPr>
               <a:t>accounts/services/accounts.facade.ts</a:t>
@@ -8229,7 +8290,7 @@
             <a:r>
               <a:rPr lang="en-US" sz="580" dirty="0">
                 <a:solidFill>
-                  <a:srgbClr val="1976D2"/>
+                  <a:srgbClr val="006B4F"/>
                 </a:solidFill>
               </a:rPr>
               <a:t>accounts/pages/accounts/accounts.component.*</a:t>
@@ -8267,7 +8328,7 @@
             <a:r>
               <a:rPr lang="en-US" sz="680" dirty="0">
                 <a:solidFill>
-                  <a:srgbClr val="273043"/>
+                  <a:srgbClr val="263B38"/>
                 </a:solidFill>
               </a:rPr>
               <a:t>Ajouter hasActiveFilter comme valeur derivee de la facade. Le message vide doit dependre de cette regle exposee par la facade.</a:t>
@@ -8303,7 +8364,7 @@
             <a:r>
               <a:rPr lang="en-US" sz="700" dirty="0">
                 <a:solidFill>
-                  <a:srgbClr val="667085"/>
+                  <a:srgbClr val="61716F"/>
                 </a:solidFill>
               </a:rPr>
               <a:t>9/10</a:t>

</xml_diff>

<commit_message>
ajoute arbre branches au pptx
</commit_message>
<xml_diff>
--- a/docs/dojo-signals.pptx
+++ b/docs/dojo-signals.pptx
@@ -1215,7 +1215,8 @@
           <a:p>
             <a:r>
               <a:rPr lang="en-US" dirty="0"/>
-              <a:t>Chaque branche d'exercice ajoute uniquement la correction de son exercice par rapport a la branche precedente.</a:t>
+              <a:t>main contient les docs. init reprend la base fonctionnelle sans docs.
+Chaque branche d'exercice ajoute uniquement la correction de son exercice par rapport a la branche precedente.</a:t>
             </a:r>
             <a:endParaRPr lang="en-US" dirty="0"/>
           </a:p>
@@ -5826,659 +5827,188 @@
           </a:p>
         </p:txBody>
       </p:sp>
-      <p:graphicFrame>
-        <p:nvGraphicFramePr>
-          <p:cNvPr id="9" name="Table 0"/>
-          <p:cNvGraphicFramePr>
-            <a:graphicFrameLocks noGrp="1"/>
-          </p:cNvGraphicFramePr>
-          <p:nvPr>
-            <p:extLst>
-              <p:ext uri="{D42A27DB-BD31-4B8C-83A1-F6EECF244321}">
-                <p14:modId xmlns:p14="http://schemas.microsoft.com/office/powerpoint/2010/main" val="1579011935"/>
-              </p:ext>
-            </p:extLst>
-          </p:nvPr>
-        </p:nvGraphicFramePr>
-        <p:xfrm>
-          <a:off x="411480" y="932688"/>
-          <a:ext cx="11368735" cy="1554480"/>
-        </p:xfrm>
-        <a:graphic>
-          <a:graphicData uri="http://schemas.openxmlformats.org/drawingml/2006/table">
-            <a:tbl>
-              <a:tblPr/>
-              <a:tblGrid>
-                <a:gridCol w="5684368"/>
-                <a:gridCol w="5684368"/>
-              </a:tblGrid>
-              <a:tr h="310896">
-                <a:tc>
-                  <a:txBody>
-                    <a:bodyPr/>
-                    <a:lstStyle/>
-                    <a:p>
-                      <a:pPr indent="0" marL="0">
-                        <a:buNone/>
-                      </a:pPr>
-                      <a:r>
-                        <a:rPr lang="en-US" sz="1020" b="1" dirty="0">
-                          <a:solidFill>
-                            <a:srgbClr val="FFFFFF"/>
-                          </a:solidFill>
-                        </a:rPr>
-                        <a:t>Branche</a:t>
-                      </a:r>
-                      <a:endParaRPr lang="en-US" sz="1020" dirty="0"/>
-                    </a:p>
-                  </a:txBody>
-                  <a:tcPr marL="50800" marR="50800" marT="25400" marB="25400" anchor="mid">
-                    <a:lnL w="5715" cap="flat" cmpd="sng" algn="ctr">
-                      <a:solidFill>
-                        <a:srgbClr val="D6E5E0"/>
-                      </a:solidFill>
-                      <a:prstDash val="solid"/>
-                      <a:round/>
-                      <a:headEnd type="none" w="med" len="med"/>
-                      <a:tailEnd type="none" w="med" len="med"/>
-                    </a:lnL>
-                    <a:lnR w="5715" cap="flat" cmpd="sng" algn="ctr">
-                      <a:solidFill>
-                        <a:srgbClr val="D6E5E0"/>
-                      </a:solidFill>
-                      <a:prstDash val="solid"/>
-                      <a:round/>
-                      <a:headEnd type="none" w="med" len="med"/>
-                      <a:tailEnd type="none" w="med" len="med"/>
-                    </a:lnR>
-                    <a:lnT w="5715" cap="flat" cmpd="sng" algn="ctr">
-                      <a:solidFill>
-                        <a:srgbClr val="D6E5E0"/>
-                      </a:solidFill>
-                      <a:prstDash val="solid"/>
-                      <a:round/>
-                      <a:headEnd type="none" w="med" len="med"/>
-                      <a:tailEnd type="none" w="med" len="med"/>
-                    </a:lnT>
-                    <a:lnB w="5715" cap="flat" cmpd="sng" algn="ctr">
-                      <a:solidFill>
-                        <a:srgbClr val="D6E5E0"/>
-                      </a:solidFill>
-                      <a:prstDash val="solid"/>
-                      <a:round/>
-                      <a:headEnd type="none" w="med" len="med"/>
-                      <a:tailEnd type="none" w="med" len="med"/>
-                    </a:lnB>
-                    <a:solidFill>
-                      <a:srgbClr val="008A5B"/>
-                    </a:solidFill>
-                  </a:tcPr>
-                </a:tc>
-                <a:tc>
-                  <a:txBody>
-                    <a:bodyPr/>
-                    <a:lstStyle/>
-                    <a:p>
-                      <a:pPr indent="0" marL="0">
-                        <a:buNone/>
-                      </a:pPr>
-                      <a:r>
-                        <a:rPr lang="en-US" sz="1020" b="1" dirty="0">
-                          <a:solidFill>
-                            <a:srgbClr val="FFFFFF"/>
-                          </a:solidFill>
-                        </a:rPr>
-                        <a:t>Role</a:t>
-                      </a:r>
-                      <a:endParaRPr lang="en-US" sz="1020" dirty="0"/>
-                    </a:p>
-                  </a:txBody>
-                  <a:tcPr marL="50800" marR="50800" marT="25400" marB="25400" anchor="mid">
-                    <a:lnL w="5715" cap="flat" cmpd="sng" algn="ctr">
-                      <a:solidFill>
-                        <a:srgbClr val="D6E5E0"/>
-                      </a:solidFill>
-                      <a:prstDash val="solid"/>
-                      <a:round/>
-                      <a:headEnd type="none" w="med" len="med"/>
-                      <a:tailEnd type="none" w="med" len="med"/>
-                    </a:lnL>
-                    <a:lnR w="5715" cap="flat" cmpd="sng" algn="ctr">
-                      <a:solidFill>
-                        <a:srgbClr val="D6E5E0"/>
-                      </a:solidFill>
-                      <a:prstDash val="solid"/>
-                      <a:round/>
-                      <a:headEnd type="none" w="med" len="med"/>
-                      <a:tailEnd type="none" w="med" len="med"/>
-                    </a:lnR>
-                    <a:lnT w="5715" cap="flat" cmpd="sng" algn="ctr">
-                      <a:solidFill>
-                        <a:srgbClr val="D6E5E0"/>
-                      </a:solidFill>
-                      <a:prstDash val="solid"/>
-                      <a:round/>
-                      <a:headEnd type="none" w="med" len="med"/>
-                      <a:tailEnd type="none" w="med" len="med"/>
-                    </a:lnT>
-                    <a:lnB w="5715" cap="flat" cmpd="sng" algn="ctr">
-                      <a:solidFill>
-                        <a:srgbClr val="D6E5E0"/>
-                      </a:solidFill>
-                      <a:prstDash val="solid"/>
-                      <a:round/>
-                      <a:headEnd type="none" w="med" len="med"/>
-                      <a:tailEnd type="none" w="med" len="med"/>
-                    </a:lnB>
-                    <a:solidFill>
-                      <a:srgbClr val="008A5B"/>
-                    </a:solidFill>
-                  </a:tcPr>
-                </a:tc>
-              </a:tr>
-              <a:tr h="310896">
-                <a:tc>
-                  <a:txBody>
-                    <a:bodyPr/>
-                    <a:lstStyle/>
-                    <a:p>
-                      <a:pPr indent="0" marL="0">
-                        <a:buNone/>
-                      </a:pPr>
-                      <a:r>
-                        <a:rPr lang="en-US" sz="1020" dirty="0">
-                          <a:solidFill>
-                            <a:srgbClr val="263B38"/>
-                          </a:solidFill>
-                        </a:rPr>
-                        <a:t>main / init</a:t>
-                      </a:r>
-                      <a:endParaRPr lang="en-US" sz="1020" dirty="0"/>
-                    </a:p>
-                  </a:txBody>
-                  <a:tcPr marL="50800" marR="50800" marT="25400" marB="25400" anchor="mid">
-                    <a:lnL w="5715" cap="flat" cmpd="sng" algn="ctr">
-                      <a:solidFill>
-                        <a:srgbClr val="D6E5E0"/>
-                      </a:solidFill>
-                      <a:prstDash val="solid"/>
-                      <a:round/>
-                      <a:headEnd type="none" w="med" len="med"/>
-                      <a:tailEnd type="none" w="med" len="med"/>
-                    </a:lnL>
-                    <a:lnR w="5715" cap="flat" cmpd="sng" algn="ctr">
-                      <a:solidFill>
-                        <a:srgbClr val="D6E5E0"/>
-                      </a:solidFill>
-                      <a:prstDash val="solid"/>
-                      <a:round/>
-                      <a:headEnd type="none" w="med" len="med"/>
-                      <a:tailEnd type="none" w="med" len="med"/>
-                    </a:lnR>
-                    <a:lnT w="5715" cap="flat" cmpd="sng" algn="ctr">
-                      <a:solidFill>
-                        <a:srgbClr val="D6E5E0"/>
-                      </a:solidFill>
-                      <a:prstDash val="solid"/>
-                      <a:round/>
-                      <a:headEnd type="none" w="med" len="med"/>
-                      <a:tailEnd type="none" w="med" len="med"/>
-                    </a:lnT>
-                    <a:lnB w="5715" cap="flat" cmpd="sng" algn="ctr">
-                      <a:solidFill>
-                        <a:srgbClr val="D6E5E0"/>
-                      </a:solidFill>
-                      <a:prstDash val="solid"/>
-                      <a:round/>
-                      <a:headEnd type="none" w="med" len="med"/>
-                      <a:tailEnd type="none" w="med" len="med"/>
-                    </a:lnB>
-                    <a:solidFill>
-                      <a:srgbClr val="FFFFFF"/>
-                    </a:solidFill>
-                  </a:tcPr>
-                </a:tc>
-                <a:tc>
-                  <a:txBody>
-                    <a:bodyPr/>
-                    <a:lstStyle/>
-                    <a:p>
-                      <a:pPr indent="0" marL="0">
-                        <a:buNone/>
-                      </a:pPr>
-                      <a:r>
-                        <a:rPr lang="en-US" sz="1020" dirty="0">
-                          <a:solidFill>
-                            <a:srgbClr val="263B38"/>
-                          </a:solidFill>
-                        </a:rPr>
-                        <a:t>base sans correction</a:t>
-                      </a:r>
-                      <a:endParaRPr lang="en-US" sz="1020" dirty="0"/>
-                    </a:p>
-                  </a:txBody>
-                  <a:tcPr marL="50800" marR="50800" marT="25400" marB="25400" anchor="mid">
-                    <a:lnL w="5715" cap="flat" cmpd="sng" algn="ctr">
-                      <a:solidFill>
-                        <a:srgbClr val="D6E5E0"/>
-                      </a:solidFill>
-                      <a:prstDash val="solid"/>
-                      <a:round/>
-                      <a:headEnd type="none" w="med" len="med"/>
-                      <a:tailEnd type="none" w="med" len="med"/>
-                    </a:lnL>
-                    <a:lnR w="5715" cap="flat" cmpd="sng" algn="ctr">
-                      <a:solidFill>
-                        <a:srgbClr val="D6E5E0"/>
-                      </a:solidFill>
-                      <a:prstDash val="solid"/>
-                      <a:round/>
-                      <a:headEnd type="none" w="med" len="med"/>
-                      <a:tailEnd type="none" w="med" len="med"/>
-                    </a:lnR>
-                    <a:lnT w="5715" cap="flat" cmpd="sng" algn="ctr">
-                      <a:solidFill>
-                        <a:srgbClr val="D6E5E0"/>
-                      </a:solidFill>
-                      <a:prstDash val="solid"/>
-                      <a:round/>
-                      <a:headEnd type="none" w="med" len="med"/>
-                      <a:tailEnd type="none" w="med" len="med"/>
-                    </a:lnT>
-                    <a:lnB w="5715" cap="flat" cmpd="sng" algn="ctr">
-                      <a:solidFill>
-                        <a:srgbClr val="D6E5E0"/>
-                      </a:solidFill>
-                      <a:prstDash val="solid"/>
-                      <a:round/>
-                      <a:headEnd type="none" w="med" len="med"/>
-                      <a:tailEnd type="none" w="med" len="med"/>
-                    </a:lnB>
-                    <a:solidFill>
-                      <a:srgbClr val="FFFFFF"/>
-                    </a:solidFill>
-                  </a:tcPr>
-                </a:tc>
-              </a:tr>
-              <a:tr h="310896">
-                <a:tc>
-                  <a:txBody>
-                    <a:bodyPr/>
-                    <a:lstStyle/>
-                    <a:p>
-                      <a:pPr indent="0" marL="0">
-                        <a:buNone/>
-                      </a:pPr>
-                      <a:r>
-                        <a:rPr lang="en-US" sz="1020" dirty="0">
-                          <a:solidFill>
-                            <a:srgbClr val="263B38"/>
-                          </a:solidFill>
-                        </a:rPr>
-                        <a:t>exercice-1</a:t>
-                      </a:r>
-                      <a:endParaRPr lang="en-US" sz="1020" dirty="0"/>
-                    </a:p>
-                  </a:txBody>
-                  <a:tcPr marL="50800" marR="50800" marT="25400" marB="25400" anchor="mid">
-                    <a:lnL w="5715" cap="flat" cmpd="sng" algn="ctr">
-                      <a:solidFill>
-                        <a:srgbClr val="D6E5E0"/>
-                      </a:solidFill>
-                      <a:prstDash val="solid"/>
-                      <a:round/>
-                      <a:headEnd type="none" w="med" len="med"/>
-                      <a:tailEnd type="none" w="med" len="med"/>
-                    </a:lnL>
-                    <a:lnR w="5715" cap="flat" cmpd="sng" algn="ctr">
-                      <a:solidFill>
-                        <a:srgbClr val="D6E5E0"/>
-                      </a:solidFill>
-                      <a:prstDash val="solid"/>
-                      <a:round/>
-                      <a:headEnd type="none" w="med" len="med"/>
-                      <a:tailEnd type="none" w="med" len="med"/>
-                    </a:lnR>
-                    <a:lnT w="5715" cap="flat" cmpd="sng" algn="ctr">
-                      <a:solidFill>
-                        <a:srgbClr val="D6E5E0"/>
-                      </a:solidFill>
-                      <a:prstDash val="solid"/>
-                      <a:round/>
-                      <a:headEnd type="none" w="med" len="med"/>
-                      <a:tailEnd type="none" w="med" len="med"/>
-                    </a:lnT>
-                    <a:lnB w="5715" cap="flat" cmpd="sng" algn="ctr">
-                      <a:solidFill>
-                        <a:srgbClr val="D6E5E0"/>
-                      </a:solidFill>
-                      <a:prstDash val="solid"/>
-                      <a:round/>
-                      <a:headEnd type="none" w="med" len="med"/>
-                      <a:tailEnd type="none" w="med" len="med"/>
-                    </a:lnB>
-                    <a:solidFill>
-                      <a:srgbClr val="F3F8F6"/>
-                    </a:solidFill>
-                  </a:tcPr>
-                </a:tc>
-                <a:tc>
-                  <a:txBody>
-                    <a:bodyPr/>
-                    <a:lstStyle/>
-                    <a:p>
-                      <a:pPr indent="0" marL="0">
-                        <a:buNone/>
-                      </a:pPr>
-                      <a:r>
-                        <a:rPr lang="en-US" sz="1020" dirty="0">
-                          <a:solidFill>
-                            <a:srgbClr val="263B38"/>
-                          </a:solidFill>
-                        </a:rPr>
-                        <a:t>correction exercice 1</a:t>
-                      </a:r>
-                      <a:endParaRPr lang="en-US" sz="1020" dirty="0"/>
-                    </a:p>
-                  </a:txBody>
-                  <a:tcPr marL="50800" marR="50800" marT="25400" marB="25400" anchor="mid">
-                    <a:lnL w="5715" cap="flat" cmpd="sng" algn="ctr">
-                      <a:solidFill>
-                        <a:srgbClr val="D6E5E0"/>
-                      </a:solidFill>
-                      <a:prstDash val="solid"/>
-                      <a:round/>
-                      <a:headEnd type="none" w="med" len="med"/>
-                      <a:tailEnd type="none" w="med" len="med"/>
-                    </a:lnL>
-                    <a:lnR w="5715" cap="flat" cmpd="sng" algn="ctr">
-                      <a:solidFill>
-                        <a:srgbClr val="D6E5E0"/>
-                      </a:solidFill>
-                      <a:prstDash val="solid"/>
-                      <a:round/>
-                      <a:headEnd type="none" w="med" len="med"/>
-                      <a:tailEnd type="none" w="med" len="med"/>
-                    </a:lnR>
-                    <a:lnT w="5715" cap="flat" cmpd="sng" algn="ctr">
-                      <a:solidFill>
-                        <a:srgbClr val="D6E5E0"/>
-                      </a:solidFill>
-                      <a:prstDash val="solid"/>
-                      <a:round/>
-                      <a:headEnd type="none" w="med" len="med"/>
-                      <a:tailEnd type="none" w="med" len="med"/>
-                    </a:lnT>
-                    <a:lnB w="5715" cap="flat" cmpd="sng" algn="ctr">
-                      <a:solidFill>
-                        <a:srgbClr val="D6E5E0"/>
-                      </a:solidFill>
-                      <a:prstDash val="solid"/>
-                      <a:round/>
-                      <a:headEnd type="none" w="med" len="med"/>
-                      <a:tailEnd type="none" w="med" len="med"/>
-                    </a:lnB>
-                    <a:solidFill>
-                      <a:srgbClr val="F3F8F6"/>
-                    </a:solidFill>
-                  </a:tcPr>
-                </a:tc>
-              </a:tr>
-              <a:tr h="310896">
-                <a:tc>
-                  <a:txBody>
-                    <a:bodyPr/>
-                    <a:lstStyle/>
-                    <a:p>
-                      <a:pPr indent="0" marL="0">
-                        <a:buNone/>
-                      </a:pPr>
-                      <a:r>
-                        <a:rPr lang="en-US" sz="1020" dirty="0">
-                          <a:solidFill>
-                            <a:srgbClr val="263B38"/>
-                          </a:solidFill>
-                        </a:rPr>
-                        <a:t>exercice-2</a:t>
-                      </a:r>
-                      <a:endParaRPr lang="en-US" sz="1020" dirty="0"/>
-                    </a:p>
-                  </a:txBody>
-                  <a:tcPr marL="50800" marR="50800" marT="25400" marB="25400" anchor="mid">
-                    <a:lnL w="5715" cap="flat" cmpd="sng" algn="ctr">
-                      <a:solidFill>
-                        <a:srgbClr val="D6E5E0"/>
-                      </a:solidFill>
-                      <a:prstDash val="solid"/>
-                      <a:round/>
-                      <a:headEnd type="none" w="med" len="med"/>
-                      <a:tailEnd type="none" w="med" len="med"/>
-                    </a:lnL>
-                    <a:lnR w="5715" cap="flat" cmpd="sng" algn="ctr">
-                      <a:solidFill>
-                        <a:srgbClr val="D6E5E0"/>
-                      </a:solidFill>
-                      <a:prstDash val="solid"/>
-                      <a:round/>
-                      <a:headEnd type="none" w="med" len="med"/>
-                      <a:tailEnd type="none" w="med" len="med"/>
-                    </a:lnR>
-                    <a:lnT w="5715" cap="flat" cmpd="sng" algn="ctr">
-                      <a:solidFill>
-                        <a:srgbClr val="D6E5E0"/>
-                      </a:solidFill>
-                      <a:prstDash val="solid"/>
-                      <a:round/>
-                      <a:headEnd type="none" w="med" len="med"/>
-                      <a:tailEnd type="none" w="med" len="med"/>
-                    </a:lnT>
-                    <a:lnB w="5715" cap="flat" cmpd="sng" algn="ctr">
-                      <a:solidFill>
-                        <a:srgbClr val="D6E5E0"/>
-                      </a:solidFill>
-                      <a:prstDash val="solid"/>
-                      <a:round/>
-                      <a:headEnd type="none" w="med" len="med"/>
-                      <a:tailEnd type="none" w="med" len="med"/>
-                    </a:lnB>
-                    <a:solidFill>
-                      <a:srgbClr val="FFFFFF"/>
-                    </a:solidFill>
-                  </a:tcPr>
-                </a:tc>
-                <a:tc>
-                  <a:txBody>
-                    <a:bodyPr/>
-                    <a:lstStyle/>
-                    <a:p>
-                      <a:pPr indent="0" marL="0">
-                        <a:buNone/>
-                      </a:pPr>
-                      <a:r>
-                        <a:rPr lang="en-US" sz="1020" dirty="0">
-                          <a:solidFill>
-                            <a:srgbClr val="263B38"/>
-                          </a:solidFill>
-                        </a:rPr>
-                        <a:t>corrections exercices 1 + 2</a:t>
-                      </a:r>
-                      <a:endParaRPr lang="en-US" sz="1020" dirty="0"/>
-                    </a:p>
-                  </a:txBody>
-                  <a:tcPr marL="50800" marR="50800" marT="25400" marB="25400" anchor="mid">
-                    <a:lnL w="5715" cap="flat" cmpd="sng" algn="ctr">
-                      <a:solidFill>
-                        <a:srgbClr val="D6E5E0"/>
-                      </a:solidFill>
-                      <a:prstDash val="solid"/>
-                      <a:round/>
-                      <a:headEnd type="none" w="med" len="med"/>
-                      <a:tailEnd type="none" w="med" len="med"/>
-                    </a:lnL>
-                    <a:lnR w="5715" cap="flat" cmpd="sng" algn="ctr">
-                      <a:solidFill>
-                        <a:srgbClr val="D6E5E0"/>
-                      </a:solidFill>
-                      <a:prstDash val="solid"/>
-                      <a:round/>
-                      <a:headEnd type="none" w="med" len="med"/>
-                      <a:tailEnd type="none" w="med" len="med"/>
-                    </a:lnR>
-                    <a:lnT w="5715" cap="flat" cmpd="sng" algn="ctr">
-                      <a:solidFill>
-                        <a:srgbClr val="D6E5E0"/>
-                      </a:solidFill>
-                      <a:prstDash val="solid"/>
-                      <a:round/>
-                      <a:headEnd type="none" w="med" len="med"/>
-                      <a:tailEnd type="none" w="med" len="med"/>
-                    </a:lnT>
-                    <a:lnB w="5715" cap="flat" cmpd="sng" algn="ctr">
-                      <a:solidFill>
-                        <a:srgbClr val="D6E5E0"/>
-                      </a:solidFill>
-                      <a:prstDash val="solid"/>
-                      <a:round/>
-                      <a:headEnd type="none" w="med" len="med"/>
-                      <a:tailEnd type="none" w="med" len="med"/>
-                    </a:lnB>
-                    <a:solidFill>
-                      <a:srgbClr val="FFFFFF"/>
-                    </a:solidFill>
-                  </a:tcPr>
-                </a:tc>
-              </a:tr>
-              <a:tr h="310896">
-                <a:tc>
-                  <a:txBody>
-                    <a:bodyPr/>
-                    <a:lstStyle/>
-                    <a:p>
-                      <a:pPr indent="0" marL="0">
-                        <a:buNone/>
-                      </a:pPr>
-                      <a:r>
-                        <a:rPr lang="en-US" sz="1020" dirty="0">
-                          <a:solidFill>
-                            <a:srgbClr val="263B38"/>
-                          </a:solidFill>
-                        </a:rPr>
-                        <a:t>exercice-N</a:t>
-                      </a:r>
-                      <a:endParaRPr lang="en-US" sz="1020" dirty="0"/>
-                    </a:p>
-                  </a:txBody>
-                  <a:tcPr marL="50800" marR="50800" marT="25400" marB="25400" anchor="mid">
-                    <a:lnL w="5715" cap="flat" cmpd="sng" algn="ctr">
-                      <a:solidFill>
-                        <a:srgbClr val="D6E5E0"/>
-                      </a:solidFill>
-                      <a:prstDash val="solid"/>
-                      <a:round/>
-                      <a:headEnd type="none" w="med" len="med"/>
-                      <a:tailEnd type="none" w="med" len="med"/>
-                    </a:lnL>
-                    <a:lnR w="5715" cap="flat" cmpd="sng" algn="ctr">
-                      <a:solidFill>
-                        <a:srgbClr val="D6E5E0"/>
-                      </a:solidFill>
-                      <a:prstDash val="solid"/>
-                      <a:round/>
-                      <a:headEnd type="none" w="med" len="med"/>
-                      <a:tailEnd type="none" w="med" len="med"/>
-                    </a:lnR>
-                    <a:lnT w="5715" cap="flat" cmpd="sng" algn="ctr">
-                      <a:solidFill>
-                        <a:srgbClr val="D6E5E0"/>
-                      </a:solidFill>
-                      <a:prstDash val="solid"/>
-                      <a:round/>
-                      <a:headEnd type="none" w="med" len="med"/>
-                      <a:tailEnd type="none" w="med" len="med"/>
-                    </a:lnT>
-                    <a:lnB w="5715" cap="flat" cmpd="sng" algn="ctr">
-                      <a:solidFill>
-                        <a:srgbClr val="D6E5E0"/>
-                      </a:solidFill>
-                      <a:prstDash val="solid"/>
-                      <a:round/>
-                      <a:headEnd type="none" w="med" len="med"/>
-                      <a:tailEnd type="none" w="med" len="med"/>
-                    </a:lnB>
-                    <a:solidFill>
-                      <a:srgbClr val="F3F8F6"/>
-                    </a:solidFill>
-                  </a:tcPr>
-                </a:tc>
-                <a:tc>
-                  <a:txBody>
-                    <a:bodyPr/>
-                    <a:lstStyle/>
-                    <a:p>
-                      <a:pPr indent="0" marL="0">
-                        <a:buNone/>
-                      </a:pPr>
-                      <a:r>
-                        <a:rPr lang="en-US" sz="1020" dirty="0">
-                          <a:solidFill>
-                            <a:srgbClr val="263B38"/>
-                          </a:solidFill>
-                        </a:rPr>
-                        <a:t>corrections cumulees jusqu'a N</a:t>
-                      </a:r>
-                      <a:endParaRPr lang="en-US" sz="1020" dirty="0"/>
-                    </a:p>
-                  </a:txBody>
-                  <a:tcPr marL="50800" marR="50800" marT="25400" marB="25400" anchor="mid">
-                    <a:lnL w="5715" cap="flat" cmpd="sng" algn="ctr">
-                      <a:solidFill>
-                        <a:srgbClr val="D6E5E0"/>
-                      </a:solidFill>
-                      <a:prstDash val="solid"/>
-                      <a:round/>
-                      <a:headEnd type="none" w="med" len="med"/>
-                      <a:tailEnd type="none" w="med" len="med"/>
-                    </a:lnL>
-                    <a:lnR w="5715" cap="flat" cmpd="sng" algn="ctr">
-                      <a:solidFill>
-                        <a:srgbClr val="D6E5E0"/>
-                      </a:solidFill>
-                      <a:prstDash val="solid"/>
-                      <a:round/>
-                      <a:headEnd type="none" w="med" len="med"/>
-                      <a:tailEnd type="none" w="med" len="med"/>
-                    </a:lnR>
-                    <a:lnT w="5715" cap="flat" cmpd="sng" algn="ctr">
-                      <a:solidFill>
-                        <a:srgbClr val="D6E5E0"/>
-                      </a:solidFill>
-                      <a:prstDash val="solid"/>
-                      <a:round/>
-                      <a:headEnd type="none" w="med" len="med"/>
-                      <a:tailEnd type="none" w="med" len="med"/>
-                    </a:lnT>
-                    <a:lnB w="5715" cap="flat" cmpd="sng" algn="ctr">
-                      <a:solidFill>
-                        <a:srgbClr val="D6E5E0"/>
-                      </a:solidFill>
-                      <a:prstDash val="solid"/>
-                      <a:round/>
-                      <a:headEnd type="none" w="med" len="med"/>
-                      <a:tailEnd type="none" w="med" len="med"/>
-                    </a:lnB>
-                    <a:solidFill>
-                      <a:srgbClr val="F3F8F6"/>
-                    </a:solidFill>
-                  </a:tcPr>
-                </a:tc>
-              </a:tr>
-            </a:tbl>
-          </a:graphicData>
-        </a:graphic>
-      </p:graphicFrame>
-      <p:sp>
-        <p:nvSpPr>
-          <p:cNvPr id="7" name="Text 3"/>
+      <p:sp>
+        <p:nvSpPr>
+          <p:cNvPr id="6" name="Text 3"/>
+          <p:cNvSpPr/>
+          <p:nvPr/>
+        </p:nvSpPr>
+        <p:spPr>
+          <a:xfrm>
+            <a:off x="411480" y="932688"/>
+            <a:ext cx="11368735" cy="1563624"/>
+          </a:xfrm>
+          <a:prstGeom prst="rect">
+            <a:avLst/>
+          </a:prstGeom>
+          <a:solidFill>
+            <a:srgbClr val="15332F"/>
+          </a:solidFill>
+          <a:ln/>
+        </p:spPr>
+        <p:txBody>
+          <a:bodyPr wrap="square" lIns="1016" tIns="1016" rIns="1016" bIns="1016" rtlCol="0" anchor="t">
+            <a:normAutofit/>
+          </a:bodyPr>
+          <a:lstStyle/>
+          <a:p>
+            <a:pPr indent="0" marL="0">
+              <a:buNone/>
+            </a:pPr>
+            <a:r>
+              <a:rPr lang="en-US" sz="880" dirty="0">
+                <a:solidFill>
+                  <a:srgbClr val="F8FAFC"/>
+                </a:solidFill>
+                <a:latin typeface="Courier New" pitchFamily="34" charset="0"/>
+                <a:ea typeface="Courier New" pitchFamily="34" charset="-122"/>
+                <a:cs typeface="Courier New" pitchFamily="34" charset="-120"/>
+              </a:rPr>
+              <a:t>init</a:t>
+            </a:r>
+            <a:endParaRPr lang="en-US" sz="880" dirty="0"/>
+          </a:p>
+          <a:p>
+            <a:pPr indent="0" marL="0">
+              <a:buNone/>
+            </a:pPr>
+            <a:r>
+              <a:rPr lang="en-US" sz="880" dirty="0">
+                <a:solidFill>
+                  <a:srgbClr val="F8FAFC"/>
+                </a:solidFill>
+                <a:latin typeface="Courier New" pitchFamily="34" charset="0"/>
+                <a:ea typeface="Courier New" pitchFamily="34" charset="-122"/>
+                <a:cs typeface="Courier New" pitchFamily="34" charset="-120"/>
+              </a:rPr>
+              <a:t>`-- exercice-1</a:t>
+            </a:r>
+            <a:endParaRPr lang="en-US" sz="880" dirty="0"/>
+          </a:p>
+          <a:p>
+            <a:pPr indent="0" marL="0">
+              <a:buNone/>
+            </a:pPr>
+            <a:r>
+              <a:rPr lang="en-US" sz="880" dirty="0">
+                <a:solidFill>
+                  <a:srgbClr val="F8FAFC"/>
+                </a:solidFill>
+                <a:latin typeface="Courier New" pitchFamily="34" charset="0"/>
+                <a:ea typeface="Courier New" pitchFamily="34" charset="-122"/>
+                <a:cs typeface="Courier New" pitchFamily="34" charset="-120"/>
+              </a:rPr>
+              <a:t>    `-- exercice-2</a:t>
+            </a:r>
+            <a:endParaRPr lang="en-US" sz="880" dirty="0"/>
+          </a:p>
+          <a:p>
+            <a:pPr indent="0" marL="0">
+              <a:buNone/>
+            </a:pPr>
+            <a:r>
+              <a:rPr lang="en-US" sz="880" dirty="0">
+                <a:solidFill>
+                  <a:srgbClr val="F8FAFC"/>
+                </a:solidFill>
+                <a:latin typeface="Courier New" pitchFamily="34" charset="0"/>
+                <a:ea typeface="Courier New" pitchFamily="34" charset="-122"/>
+                <a:cs typeface="Courier New" pitchFamily="34" charset="-120"/>
+              </a:rPr>
+              <a:t>        `-- exercice-3</a:t>
+            </a:r>
+            <a:endParaRPr lang="en-US" sz="880" dirty="0"/>
+          </a:p>
+          <a:p>
+            <a:pPr indent="0" marL="0">
+              <a:buNone/>
+            </a:pPr>
+            <a:r>
+              <a:rPr lang="en-US" sz="880" dirty="0">
+                <a:solidFill>
+                  <a:srgbClr val="F8FAFC"/>
+                </a:solidFill>
+                <a:latin typeface="Courier New" pitchFamily="34" charset="0"/>
+                <a:ea typeface="Courier New" pitchFamily="34" charset="-122"/>
+                <a:cs typeface="Courier New" pitchFamily="34" charset="-120"/>
+              </a:rPr>
+              <a:t>            `-- exercice-4</a:t>
+            </a:r>
+            <a:endParaRPr lang="en-US" sz="880" dirty="0"/>
+          </a:p>
+          <a:p>
+            <a:pPr indent="0" marL="0">
+              <a:buNone/>
+            </a:pPr>
+            <a:r>
+              <a:rPr lang="en-US" sz="880" dirty="0">
+                <a:solidFill>
+                  <a:srgbClr val="F8FAFC"/>
+                </a:solidFill>
+                <a:latin typeface="Courier New" pitchFamily="34" charset="0"/>
+                <a:ea typeface="Courier New" pitchFamily="34" charset="-122"/>
+                <a:cs typeface="Courier New" pitchFamily="34" charset="-120"/>
+              </a:rPr>
+              <a:t>                `-- exercice-5</a:t>
+            </a:r>
+            <a:endParaRPr lang="en-US" sz="880" dirty="0"/>
+          </a:p>
+          <a:p>
+            <a:pPr indent="0" marL="0">
+              <a:buNone/>
+            </a:pPr>
+            <a:r>
+              <a:rPr lang="en-US" sz="880" dirty="0">
+                <a:solidFill>
+                  <a:srgbClr val="F8FAFC"/>
+                </a:solidFill>
+                <a:latin typeface="Courier New" pitchFamily="34" charset="0"/>
+                <a:ea typeface="Courier New" pitchFamily="34" charset="-122"/>
+                <a:cs typeface="Courier New" pitchFamily="34" charset="-120"/>
+              </a:rPr>
+              <a:t>                    `-- exercice-6</a:t>
+            </a:r>
+            <a:endParaRPr lang="en-US" sz="880" dirty="0"/>
+          </a:p>
+          <a:p>
+            <a:pPr indent="0" marL="0">
+              <a:buNone/>
+            </a:pPr>
+            <a:r>
+              <a:rPr lang="en-US" sz="880" dirty="0">
+                <a:solidFill>
+                  <a:srgbClr val="F8FAFC"/>
+                </a:solidFill>
+                <a:latin typeface="Courier New" pitchFamily="34" charset="0"/>
+                <a:ea typeface="Courier New" pitchFamily="34" charset="-122"/>
+                <a:cs typeface="Courier New" pitchFamily="34" charset="-120"/>
+              </a:rPr>
+              <a:t>                        `-- exercice-7</a:t>
+            </a:r>
+            <a:endParaRPr lang="en-US" sz="880" dirty="0"/>
+          </a:p>
+          <a:p>
+            <a:pPr indent="0" marL="0">
+              <a:buNone/>
+            </a:pPr>
+            <a:r>
+              <a:rPr lang="en-US" sz="880" dirty="0">
+                <a:solidFill>
+                  <a:srgbClr val="F8FAFC"/>
+                </a:solidFill>
+                <a:latin typeface="Courier New" pitchFamily="34" charset="0"/>
+                <a:ea typeface="Courier New" pitchFamily="34" charset="-122"/>
+                <a:cs typeface="Courier New" pitchFamily="34" charset="-120"/>
+              </a:rPr>
+              <a:t>                            `-- exercice-8</a:t>
+            </a:r>
+            <a:endParaRPr lang="en-US" sz="880" dirty="0"/>
+          </a:p>
+        </p:txBody>
+      </p:sp>
+      <p:sp>
+        <p:nvSpPr>
+          <p:cNvPr id="7" name="Text 4"/>
           <p:cNvSpPr/>
           <p:nvPr/>
         </p:nvSpPr>

</xml_diff>

<commit_message>
agrandit slide arbre branches
</commit_message>
<xml_diff>
--- a/docs/dojo-signals.pptx
+++ b/docs/dojo-signals.pptx
@@ -1215,8 +1215,7 @@
           <a:p>
             <a:r>
               <a:rPr lang="en-US" dirty="0"/>
-              <a:t>Les branches d'exercices sont cumulatives.
-Chaque branche d'exercice ajoute uniquement la correction de son exercice par rapport a la branche precedente.</a:t>
+              <a:t/>
             </a:r>
             <a:endParaRPr lang="en-US" dirty="0"/>
           </a:p>
@@ -5829,25 +5828,23 @@
       </p:sp>
       <p:sp>
         <p:nvSpPr>
-          <p:cNvPr id="6" name="Text 3"/>
-          <p:cNvSpPr/>
-          <p:nvPr/>
-        </p:nvSpPr>
-        <p:spPr>
-          <a:xfrm>
-            <a:off x="411480" y="932688"/>
-            <a:ext cx="11368735" cy="1563624"/>
-          </a:xfrm>
-          <a:prstGeom prst="rect">
-            <a:avLst/>
-          </a:prstGeom>
-          <a:solidFill>
-            <a:srgbClr val="15332F"/>
-          </a:solidFill>
-          <a:ln/>
-        </p:spPr>
-        <p:txBody>
-          <a:bodyPr wrap="square" lIns="1016" tIns="1016" rIns="1016" bIns="1016" rtlCol="0" anchor="t">
+          <p:cNvPr id="5" name="Text 3"/>
+          <p:cNvSpPr/>
+          <p:nvPr/>
+        </p:nvSpPr>
+        <p:spPr>
+          <a:xfrm>
+            <a:off x="411480" y="987552"/>
+            <a:ext cx="11368735" cy="347472"/>
+          </a:xfrm>
+          <a:prstGeom prst="rect">
+            <a:avLst/>
+          </a:prstGeom>
+          <a:noFill/>
+          <a:ln/>
+        </p:spPr>
+        <p:txBody>
+          <a:bodyPr wrap="square" lIns="0" tIns="0" rIns="0" bIns="0" rtlCol="0" anchor="ctr">
             <a:normAutofit/>
           </a:bodyPr>
           <a:lstStyle/>
@@ -5856,7 +5853,72 @@
               <a:buNone/>
             </a:pPr>
             <a:r>
-              <a:rPr lang="en-US" sz="880" dirty="0">
+              <a:rPr lang="en-US" sz="1700" b="1" dirty="0">
+                <a:solidFill>
+                  <a:srgbClr val="1B2B2A"/>
+                </a:solidFill>
+              </a:rPr>
+              <a:t>Les branches d'exercices sont cumulatives.</a:t>
+            </a:r>
+            <a:endParaRPr lang="en-US" sz="1700" dirty="0"/>
+          </a:p>
+        </p:txBody>
+      </p:sp>
+      <p:sp>
+        <p:nvSpPr>
+          <p:cNvPr id="6" name="Shape 4"/>
+          <p:cNvSpPr/>
+          <p:nvPr/>
+        </p:nvSpPr>
+        <p:spPr>
+          <a:xfrm>
+            <a:off x="1828800" y="1572768"/>
+            <a:ext cx="8534095" cy="4160520"/>
+          </a:xfrm>
+          <a:prstGeom prst="roundRect">
+            <a:avLst>
+              <a:gd name="adj" fmla="val 1758"/>
+            </a:avLst>
+          </a:prstGeom>
+          <a:solidFill>
+            <a:srgbClr val="15332F"/>
+          </a:solidFill>
+          <a:ln w="12700">
+            <a:solidFill>
+              <a:srgbClr val="004B3A"/>
+            </a:solidFill>
+            <a:prstDash val="solid"/>
+          </a:ln>
+        </p:spPr>
+      </p:sp>
+      <p:sp>
+        <p:nvSpPr>
+          <p:cNvPr id="7" name="Text 5"/>
+          <p:cNvSpPr/>
+          <p:nvPr/>
+        </p:nvSpPr>
+        <p:spPr>
+          <a:xfrm>
+            <a:off x="2423160" y="1847088"/>
+            <a:ext cx="7345375" cy="3566160"/>
+          </a:xfrm>
+          <a:prstGeom prst="rect">
+            <a:avLst/>
+          </a:prstGeom>
+          <a:noFill/>
+          <a:ln/>
+        </p:spPr>
+        <p:txBody>
+          <a:bodyPr wrap="square" lIns="635" tIns="635" rIns="635" bIns="635" rtlCol="0" anchor="ctr">
+            <a:normAutofit/>
+          </a:bodyPr>
+          <a:lstStyle/>
+          <a:p>
+            <a:pPr indent="0" marL="0">
+              <a:buNone/>
+            </a:pPr>
+            <a:r>
+              <a:rPr lang="en-US" sz="1900" b="1" dirty="0">
                 <a:solidFill>
                   <a:srgbClr val="F8FAFC"/>
                 </a:solidFill>
@@ -5866,14 +5928,14 @@
               </a:rPr>
               <a:t>init</a:t>
             </a:r>
-            <a:endParaRPr lang="en-US" sz="880" dirty="0"/>
-          </a:p>
-          <a:p>
-            <a:pPr indent="0" marL="0">
-              <a:buNone/>
-            </a:pPr>
-            <a:r>
-              <a:rPr lang="en-US" sz="880" dirty="0">
+            <a:endParaRPr lang="en-US" sz="1900" dirty="0"/>
+          </a:p>
+          <a:p>
+            <a:pPr indent="0" marL="0">
+              <a:buNone/>
+            </a:pPr>
+            <a:r>
+              <a:rPr lang="en-US" sz="1900" b="1" dirty="0">
                 <a:solidFill>
                   <a:srgbClr val="F8FAFC"/>
                 </a:solidFill>
@@ -5883,14 +5945,14 @@
               </a:rPr>
               <a:t>`-- exercice-1</a:t>
             </a:r>
-            <a:endParaRPr lang="en-US" sz="880" dirty="0"/>
-          </a:p>
-          <a:p>
-            <a:pPr indent="0" marL="0">
-              <a:buNone/>
-            </a:pPr>
-            <a:r>
-              <a:rPr lang="en-US" sz="880" dirty="0">
+            <a:endParaRPr lang="en-US" sz="1900" dirty="0"/>
+          </a:p>
+          <a:p>
+            <a:pPr indent="0" marL="0">
+              <a:buNone/>
+            </a:pPr>
+            <a:r>
+              <a:rPr lang="en-US" sz="1900" b="1" dirty="0">
                 <a:solidFill>
                   <a:srgbClr val="F8FAFC"/>
                 </a:solidFill>
@@ -5900,14 +5962,14 @@
               </a:rPr>
               <a:t>    `-- exercice-2</a:t>
             </a:r>
-            <a:endParaRPr lang="en-US" sz="880" dirty="0"/>
-          </a:p>
-          <a:p>
-            <a:pPr indent="0" marL="0">
-              <a:buNone/>
-            </a:pPr>
-            <a:r>
-              <a:rPr lang="en-US" sz="880" dirty="0">
+            <a:endParaRPr lang="en-US" sz="1900" dirty="0"/>
+          </a:p>
+          <a:p>
+            <a:pPr indent="0" marL="0">
+              <a:buNone/>
+            </a:pPr>
+            <a:r>
+              <a:rPr lang="en-US" sz="1900" b="1" dirty="0">
                 <a:solidFill>
                   <a:srgbClr val="F8FAFC"/>
                 </a:solidFill>
@@ -5917,14 +5979,14 @@
               </a:rPr>
               <a:t>        `-- exercice-3</a:t>
             </a:r>
-            <a:endParaRPr lang="en-US" sz="880" dirty="0"/>
-          </a:p>
-          <a:p>
-            <a:pPr indent="0" marL="0">
-              <a:buNone/>
-            </a:pPr>
-            <a:r>
-              <a:rPr lang="en-US" sz="880" dirty="0">
+            <a:endParaRPr lang="en-US" sz="1900" dirty="0"/>
+          </a:p>
+          <a:p>
+            <a:pPr indent="0" marL="0">
+              <a:buNone/>
+            </a:pPr>
+            <a:r>
+              <a:rPr lang="en-US" sz="1900" b="1" dirty="0">
                 <a:solidFill>
                   <a:srgbClr val="F8FAFC"/>
                 </a:solidFill>
@@ -5934,14 +5996,14 @@
               </a:rPr>
               <a:t>            `-- exercice-4</a:t>
             </a:r>
-            <a:endParaRPr lang="en-US" sz="880" dirty="0"/>
-          </a:p>
-          <a:p>
-            <a:pPr indent="0" marL="0">
-              <a:buNone/>
-            </a:pPr>
-            <a:r>
-              <a:rPr lang="en-US" sz="880" dirty="0">
+            <a:endParaRPr lang="en-US" sz="1900" dirty="0"/>
+          </a:p>
+          <a:p>
+            <a:pPr indent="0" marL="0">
+              <a:buNone/>
+            </a:pPr>
+            <a:r>
+              <a:rPr lang="en-US" sz="1900" b="1" dirty="0">
                 <a:solidFill>
                   <a:srgbClr val="F8FAFC"/>
                 </a:solidFill>
@@ -5951,14 +6013,14 @@
               </a:rPr>
               <a:t>                `-- exercice-5</a:t>
             </a:r>
-            <a:endParaRPr lang="en-US" sz="880" dirty="0"/>
-          </a:p>
-          <a:p>
-            <a:pPr indent="0" marL="0">
-              <a:buNone/>
-            </a:pPr>
-            <a:r>
-              <a:rPr lang="en-US" sz="880" dirty="0">
+            <a:endParaRPr lang="en-US" sz="1900" dirty="0"/>
+          </a:p>
+          <a:p>
+            <a:pPr indent="0" marL="0">
+              <a:buNone/>
+            </a:pPr>
+            <a:r>
+              <a:rPr lang="en-US" sz="1900" b="1" dirty="0">
                 <a:solidFill>
                   <a:srgbClr val="F8FAFC"/>
                 </a:solidFill>
@@ -5968,14 +6030,14 @@
               </a:rPr>
               <a:t>                    `-- exercice-6</a:t>
             </a:r>
-            <a:endParaRPr lang="en-US" sz="880" dirty="0"/>
-          </a:p>
-          <a:p>
-            <a:pPr indent="0" marL="0">
-              <a:buNone/>
-            </a:pPr>
-            <a:r>
-              <a:rPr lang="en-US" sz="880" dirty="0">
+            <a:endParaRPr lang="en-US" sz="1900" dirty="0"/>
+          </a:p>
+          <a:p>
+            <a:pPr indent="0" marL="0">
+              <a:buNone/>
+            </a:pPr>
+            <a:r>
+              <a:rPr lang="en-US" sz="1900" b="1" dirty="0">
                 <a:solidFill>
                   <a:srgbClr val="F8FAFC"/>
                 </a:solidFill>
@@ -5985,14 +6047,14 @@
               </a:rPr>
               <a:t>                        `-- exercice-7</a:t>
             </a:r>
-            <a:endParaRPr lang="en-US" sz="880" dirty="0"/>
-          </a:p>
-          <a:p>
-            <a:pPr indent="0" marL="0">
-              <a:buNone/>
-            </a:pPr>
-            <a:r>
-              <a:rPr lang="en-US" sz="880" dirty="0">
+            <a:endParaRPr lang="en-US" sz="1900" dirty="0"/>
+          </a:p>
+          <a:p>
+            <a:pPr indent="0" marL="0">
+              <a:buNone/>
+            </a:pPr>
+            <a:r>
+              <a:rPr lang="en-US" sz="1900" b="1" dirty="0">
                 <a:solidFill>
                   <a:srgbClr val="F8FAFC"/>
                 </a:solidFill>
@@ -6002,13 +6064,51 @@
               </a:rPr>
               <a:t>                            `-- exercice-8</a:t>
             </a:r>
-            <a:endParaRPr lang="en-US" sz="880" dirty="0"/>
-          </a:p>
-        </p:txBody>
-      </p:sp>
-      <p:sp>
-        <p:nvSpPr>
-          <p:cNvPr id="7" name="Text 4"/>
+            <a:endParaRPr lang="en-US" sz="1900" dirty="0"/>
+          </a:p>
+        </p:txBody>
+      </p:sp>
+      <p:sp>
+        <p:nvSpPr>
+          <p:cNvPr id="8" name="Text 6"/>
+          <p:cNvSpPr/>
+          <p:nvPr/>
+        </p:nvSpPr>
+        <p:spPr>
+          <a:xfrm>
+            <a:off x="411480" y="5989320"/>
+            <a:ext cx="11368735" cy="256032"/>
+          </a:xfrm>
+          <a:prstGeom prst="rect">
+            <a:avLst/>
+          </a:prstGeom>
+          <a:noFill/>
+          <a:ln/>
+        </p:spPr>
+        <p:txBody>
+          <a:bodyPr wrap="square" lIns="0" tIns="0" rIns="0" bIns="0" rtlCol="0" anchor="ctr">
+            <a:normAutofit/>
+          </a:bodyPr>
+          <a:lstStyle/>
+          <a:p>
+            <a:pPr algn="ctr" indent="0" marL="0">
+              <a:buNone/>
+            </a:pPr>
+            <a:r>
+              <a:rPr lang="en-US" sz="950" i="1" dirty="0">
+                <a:solidFill>
+                  <a:srgbClr val="61716F"/>
+                </a:solidFill>
+              </a:rPr>
+              <a:t>Chaque branche d'exercice ajoute uniquement la correction de son exercice par rapport a la branche precedente.</a:t>
+            </a:r>
+            <a:endParaRPr lang="en-US" sz="950" dirty="0"/>
+          </a:p>
+        </p:txBody>
+      </p:sp>
+      <p:sp>
+        <p:nvSpPr>
+          <p:cNvPr id="9" name="Text 7"/>
           <p:cNvSpPr/>
           <p:nvPr/>
         </p:nvSpPr>

</xml_diff>

<commit_message>
documente untracked exercice 3
</commit_message>
<xml_diff>
--- a/docs/dojo-signals.pptx
+++ b/docs/dojo-signals.pptx
@@ -21,9 +21,10 @@
     <p:sldId id="269" r:id="rId15"/>
     <p:sldId id="270" r:id="rId16"/>
     <p:sldId id="271" r:id="rId17"/>
+    <p:sldId id="272" r:id="rId18"/>
   </p:sldIdLst>
   <p:notesMasterIdLst>
-    <p:notesMasterId r:id="rId18"/>
+    <p:notesMasterId r:id="rId19"/>
   </p:notesMasterIdLst>
   <p:sldSz cx="12192000" cy="6858000"/>
   <p:notesSz cx="6858000" cy="12192000"/>
@@ -1045,7 +1046,7 @@
           <a:p>
             <a:r>
               <a:rPr lang="en-US" dirty="0"/>
-              <a:t>En Zoneless, afterRender() ne se declenche que quand un signal change — beaucoup plus previsible qu'en Zone.js.</a:t>
+              <a:t/>
             </a:r>
             <a:endParaRPr lang="en-US" dirty="0"/>
           </a:p>
@@ -1133,7 +1134,7 @@
           <a:p>
             <a:r>
               <a:rPr lang="en-US" dirty="0"/>
-              <a:t/>
+              <a:t>En Zoneless, afterRender() ne se declenche que quand un signal change — beaucoup plus previsible qu'en Zone.js.</a:t>
             </a:r>
             <a:endParaRPr lang="en-US" dirty="0"/>
           </a:p>
@@ -1157,6 +1158,94 @@
             <a:fld id="{F7021451-1387-4CA6-816F-3879F97B5CBC}" type="slidenum">
               <a:rPr lang="en-US"/>
               <a:t>16</a:t>
+            </a:fld>
+            <a:endParaRPr lang="en-US"/>
+          </a:p>
+        </p:txBody>
+      </p:sp>
+    </p:spTree>
+    <p:extLst>
+      <p:ext uri="{BB962C8B-B14F-4D97-AF65-F5344CB8AC3E}">
+        <p14:creationId xmlns:p14="http://schemas.microsoft.com/office/powerpoint/2010/main" val="1024086991"/>
+      </p:ext>
+    </p:extLst>
+  </p:cSld>
+  <p:clrMapOvr>
+    <a:masterClrMapping/>
+  </p:clrMapOvr>
+</p:notes>
+</file>
+
+<file path=ppt/notesSlides/notesSlide17.xml><?xml version="1.0" encoding="utf-8"?>
+<p:notes xmlns:a="http://schemas.openxmlformats.org/drawingml/2006/main" xmlns:r="http://schemas.openxmlformats.org/officeDocument/2006/relationships" xmlns:p="http://schemas.openxmlformats.org/presentationml/2006/main">
+  <p:cSld>
+    <p:spTree>
+      <p:nvGrpSpPr>
+        <p:cNvPr id="1" name=""/>
+        <p:cNvGrpSpPr/>
+        <p:nvPr/>
+      </p:nvGrpSpPr>
+      <p:grpSpPr>
+        <a:xfrm>
+          <a:off x="0" y="0"/>
+          <a:ext cx="0" cy="0"/>
+          <a:chOff x="0" y="0"/>
+          <a:chExt cx="0" cy="0"/>
+        </a:xfrm>
+      </p:grpSpPr>
+      <p:sp>
+        <p:nvSpPr>
+          <p:cNvPr id="2" name="Slide Image Placeholder 1"/>
+          <p:cNvSpPr>
+            <a:spLocks noGrp="1" noRot="1" noChangeAspect="1"/>
+          </p:cNvSpPr>
+          <p:nvPr>
+            <p:ph type="sldImg"/>
+          </p:nvPr>
+        </p:nvSpPr>
+        <p:spPr/>
+      </p:sp>
+      <p:sp>
+        <p:nvSpPr>
+          <p:cNvPr id="3" name="Notes Placeholder 2"/>
+          <p:cNvSpPr>
+            <a:spLocks noGrp="1"/>
+          </p:cNvSpPr>
+          <p:nvPr>
+            <p:ph type="body" idx="1"/>
+          </p:nvPr>
+        </p:nvSpPr>
+        <p:spPr/>
+        <p:txBody>
+          <a:bodyPr/>
+          <a:lstStyle/>
+          <a:p>
+            <a:r>
+              <a:rPr lang="en-US" dirty="0"/>
+              <a:t/>
+            </a:r>
+            <a:endParaRPr lang="en-US" dirty="0"/>
+          </a:p>
+        </p:txBody>
+      </p:sp>
+      <p:sp>
+        <p:nvSpPr>
+          <p:cNvPr id="4" name="Slide Number Placeholder 3"/>
+          <p:cNvSpPr>
+            <a:spLocks noGrp="1"/>
+          </p:cNvSpPr>
+          <p:nvPr>
+            <p:ph type="sldNum" sz="quarter" idx="10"/>
+          </p:nvPr>
+        </p:nvSpPr>
+        <p:spPr/>
+        <p:txBody>
+          <a:bodyPr/>
+          <a:lstStyle/>
+          <a:p>
+            <a:fld id="{F7021451-1387-4CA6-816F-3879F97B5CBC}" type="slidenum">
+              <a:rPr lang="en-US"/>
+              <a:t>17</a:t>
             </a:fld>
             <a:endParaRPr lang="en-US"/>
           </a:p>
@@ -2478,7 +2567,7 @@
                   <a:srgbClr val="61716F"/>
                 </a:solidFill>
               </a:rPr>
-              <a:t>1/16</a:t>
+              <a:t>1/17</a:t>
             </a:r>
             <a:endParaRPr lang="en-US" sz="700" dirty="0"/>
           </a:p>
@@ -2644,10 +2733,11 @@
             <a:tbl>
               <a:tblPr/>
               <a:tblGrid>
-                <a:gridCol w="5684368"/>
-                <a:gridCol w="5684368"/>
+                <a:gridCol w="1417320"/>
+                <a:gridCol w="2834640"/>
+                <a:gridCol w="7116775"/>
               </a:tblGrid>
-              <a:tr h="324343">
+              <a:tr h="306324">
                 <a:tc>
                   <a:txBody>
                     <a:bodyPr/>
@@ -2770,8 +2860,69 @@
                     </a:solidFill>
                   </a:tcPr>
                 </a:tc>
+                <a:tc>
+                  <a:txBody>
+                    <a:bodyPr/>
+                    <a:lstStyle/>
+                    <a:p>
+                      <a:pPr indent="0" marL="0">
+                        <a:buNone/>
+                      </a:pPr>
+                      <a:r>
+                        <a:rPr lang="en-US" sz="740" b="1" dirty="0">
+                          <a:solidFill>
+                            <a:srgbClr val="FFFFFF"/>
+                          </a:solidFill>
+                        </a:rPr>
+                        <a:t>Exemple fichier</a:t>
+                      </a:r>
+                      <a:endParaRPr lang="en-US" sz="740" dirty="0"/>
+                    </a:p>
+                  </a:txBody>
+                  <a:tcPr marL="50800" marR="50800" marT="25400" marB="25400" anchor="mid">
+                    <a:lnL w="5715" cap="flat" cmpd="sng" algn="ctr">
+                      <a:solidFill>
+                        <a:srgbClr val="D6E5E0"/>
+                      </a:solidFill>
+                      <a:prstDash val="solid"/>
+                      <a:round/>
+                      <a:headEnd type="none" w="med" len="med"/>
+                      <a:tailEnd type="none" w="med" len="med"/>
+                    </a:lnL>
+                    <a:lnR w="5715" cap="flat" cmpd="sng" algn="ctr">
+                      <a:solidFill>
+                        <a:srgbClr val="D6E5E0"/>
+                      </a:solidFill>
+                      <a:prstDash val="solid"/>
+                      <a:round/>
+                      <a:headEnd type="none" w="med" len="med"/>
+                      <a:tailEnd type="none" w="med" len="med"/>
+                    </a:lnR>
+                    <a:lnT w="5715" cap="flat" cmpd="sng" algn="ctr">
+                      <a:solidFill>
+                        <a:srgbClr val="D6E5E0"/>
+                      </a:solidFill>
+                      <a:prstDash val="solid"/>
+                      <a:round/>
+                      <a:headEnd type="none" w="med" len="med"/>
+                      <a:tailEnd type="none" w="med" len="med"/>
+                    </a:lnT>
+                    <a:lnB w="5715" cap="flat" cmpd="sng" algn="ctr">
+                      <a:solidFill>
+                        <a:srgbClr val="D6E5E0"/>
+                      </a:solidFill>
+                      <a:prstDash val="solid"/>
+                      <a:round/>
+                      <a:headEnd type="none" w="med" len="med"/>
+                      <a:tailEnd type="none" w="med" len="med"/>
+                    </a:lnB>
+                    <a:solidFill>
+                      <a:srgbClr val="008A5B"/>
+                    </a:solidFill>
+                  </a:tcPr>
+                </a:tc>
               </a:tr>
-              <a:tr h="324343">
+              <a:tr h="306324">
                 <a:tc>
                   <a:txBody>
                     <a:bodyPr/>
@@ -2847,7 +2998,68 @@
                             <a:srgbClr val="263B38"/>
                           </a:solidFill>
                         </a:rPr>
-                        <a:t>Valeur reactive mutable. Source de verite de l'etat local.</a:t>
+                        <a:t>Valeur reactive mutable. Source de verite locale.</a:t>
+                      </a:r>
+                      <a:endParaRPr lang="en-US" sz="740" dirty="0"/>
+                    </a:p>
+                  </a:txBody>
+                  <a:tcPr marL="50800" marR="50800" marT="25400" marB="25400" anchor="mid">
+                    <a:lnL w="5715" cap="flat" cmpd="sng" algn="ctr">
+                      <a:solidFill>
+                        <a:srgbClr val="D6E5E0"/>
+                      </a:solidFill>
+                      <a:prstDash val="solid"/>
+                      <a:round/>
+                      <a:headEnd type="none" w="med" len="med"/>
+                      <a:tailEnd type="none" w="med" len="med"/>
+                    </a:lnL>
+                    <a:lnR w="5715" cap="flat" cmpd="sng" algn="ctr">
+                      <a:solidFill>
+                        <a:srgbClr val="D6E5E0"/>
+                      </a:solidFill>
+                      <a:prstDash val="solid"/>
+                      <a:round/>
+                      <a:headEnd type="none" w="med" len="med"/>
+                      <a:tailEnd type="none" w="med" len="med"/>
+                    </a:lnR>
+                    <a:lnT w="5715" cap="flat" cmpd="sng" algn="ctr">
+                      <a:solidFill>
+                        <a:srgbClr val="D6E5E0"/>
+                      </a:solidFill>
+                      <a:prstDash val="solid"/>
+                      <a:round/>
+                      <a:headEnd type="none" w="med" len="med"/>
+                      <a:tailEnd type="none" w="med" len="med"/>
+                    </a:lnT>
+                    <a:lnB w="5715" cap="flat" cmpd="sng" algn="ctr">
+                      <a:solidFill>
+                        <a:srgbClr val="D6E5E0"/>
+                      </a:solidFill>
+                      <a:prstDash val="solid"/>
+                      <a:round/>
+                      <a:headEnd type="none" w="med" len="med"/>
+                      <a:tailEnd type="none" w="med" len="med"/>
+                    </a:lnB>
+                    <a:solidFill>
+                      <a:srgbClr val="FFFFFF"/>
+                    </a:solidFill>
+                  </a:tcPr>
+                </a:tc>
+                <a:tc>
+                  <a:txBody>
+                    <a:bodyPr/>
+                    <a:lstStyle/>
+                    <a:p>
+                      <a:pPr indent="0" marL="0">
+                        <a:buNone/>
+                      </a:pPr>
+                      <a:r>
+                        <a:rPr lang="en-US" sz="740" dirty="0">
+                          <a:solidFill>
+                            <a:srgbClr val="263B38"/>
+                          </a:solidFill>
+                        </a:rPr>
+                        <a:t>clients.component.ts</a:t>
                       </a:r>
                       <a:endParaRPr lang="en-US" sz="740" dirty="0"/>
                     </a:p>
@@ -2895,7 +3107,7 @@
                   </a:tcPr>
                 </a:tc>
               </a:tr>
-              <a:tr h="324343">
+              <a:tr h="306324">
                 <a:tc>
                   <a:txBody>
                     <a:bodyPr/>
@@ -2971,7 +3183,68 @@
                             <a:srgbClr val="263B38"/>
                           </a:solidFill>
                         </a:rPr>
-                        <a:t>Valeur derivee en lecture seule, mise en cache automatiquement.</a:t>
+                        <a:t>Valeur derivee en lecture seule.</a:t>
+                      </a:r>
+                      <a:endParaRPr lang="en-US" sz="740" dirty="0"/>
+                    </a:p>
+                  </a:txBody>
+                  <a:tcPr marL="50800" marR="50800" marT="25400" marB="25400" anchor="mid">
+                    <a:lnL w="5715" cap="flat" cmpd="sng" algn="ctr">
+                      <a:solidFill>
+                        <a:srgbClr val="D6E5E0"/>
+                      </a:solidFill>
+                      <a:prstDash val="solid"/>
+                      <a:round/>
+                      <a:headEnd type="none" w="med" len="med"/>
+                      <a:tailEnd type="none" w="med" len="med"/>
+                    </a:lnL>
+                    <a:lnR w="5715" cap="flat" cmpd="sng" algn="ctr">
+                      <a:solidFill>
+                        <a:srgbClr val="D6E5E0"/>
+                      </a:solidFill>
+                      <a:prstDash val="solid"/>
+                      <a:round/>
+                      <a:headEnd type="none" w="med" len="med"/>
+                      <a:tailEnd type="none" w="med" len="med"/>
+                    </a:lnR>
+                    <a:lnT w="5715" cap="flat" cmpd="sng" algn="ctr">
+                      <a:solidFill>
+                        <a:srgbClr val="D6E5E0"/>
+                      </a:solidFill>
+                      <a:prstDash val="solid"/>
+                      <a:round/>
+                      <a:headEnd type="none" w="med" len="med"/>
+                      <a:tailEnd type="none" w="med" len="med"/>
+                    </a:lnT>
+                    <a:lnB w="5715" cap="flat" cmpd="sng" algn="ctr">
+                      <a:solidFill>
+                        <a:srgbClr val="D6E5E0"/>
+                      </a:solidFill>
+                      <a:prstDash val="solid"/>
+                      <a:round/>
+                      <a:headEnd type="none" w="med" len="med"/>
+                      <a:tailEnd type="none" w="med" len="med"/>
+                    </a:lnB>
+                    <a:solidFill>
+                      <a:srgbClr val="F3F8F6"/>
+                    </a:solidFill>
+                  </a:tcPr>
+                </a:tc>
+                <a:tc>
+                  <a:txBody>
+                    <a:bodyPr/>
+                    <a:lstStyle/>
+                    <a:p>
+                      <a:pPr indent="0" marL="0">
+                        <a:buNone/>
+                      </a:pPr>
+                      <a:r>
+                        <a:rPr lang="en-US" sz="740" dirty="0">
+                          <a:solidFill>
+                            <a:srgbClr val="263B38"/>
+                          </a:solidFill>
+                        </a:rPr>
+                        <a:t>accounts.facade.ts</a:t>
                       </a:r>
                       <a:endParaRPr lang="en-US" sz="740" dirty="0"/>
                     </a:p>
@@ -3019,7 +3292,7 @@
                   </a:tcPr>
                 </a:tc>
               </a:tr>
-              <a:tr h="324343">
+              <a:tr h="306324">
                 <a:tc>
                   <a:txBody>
                     <a:bodyPr/>
@@ -3095,7 +3368,68 @@
                             <a:srgbClr val="263B38"/>
                           </a:solidFill>
                         </a:rPr>
-                        <a:t>Effet de bord execute a chaque changement de dependance.</a:t>
+                        <a:t>Effet de bord sur dependances signal.</a:t>
+                      </a:r>
+                      <a:endParaRPr lang="en-US" sz="740" dirty="0"/>
+                    </a:p>
+                  </a:txBody>
+                  <a:tcPr marL="50800" marR="50800" marT="25400" marB="25400" anchor="mid">
+                    <a:lnL w="5715" cap="flat" cmpd="sng" algn="ctr">
+                      <a:solidFill>
+                        <a:srgbClr val="D6E5E0"/>
+                      </a:solidFill>
+                      <a:prstDash val="solid"/>
+                      <a:round/>
+                      <a:headEnd type="none" w="med" len="med"/>
+                      <a:tailEnd type="none" w="med" len="med"/>
+                    </a:lnL>
+                    <a:lnR w="5715" cap="flat" cmpd="sng" algn="ctr">
+                      <a:solidFill>
+                        <a:srgbClr val="D6E5E0"/>
+                      </a:solidFill>
+                      <a:prstDash val="solid"/>
+                      <a:round/>
+                      <a:headEnd type="none" w="med" len="med"/>
+                      <a:tailEnd type="none" w="med" len="med"/>
+                    </a:lnR>
+                    <a:lnT w="5715" cap="flat" cmpd="sng" algn="ctr">
+                      <a:solidFill>
+                        <a:srgbClr val="D6E5E0"/>
+                      </a:solidFill>
+                      <a:prstDash val="solid"/>
+                      <a:round/>
+                      <a:headEnd type="none" w="med" len="med"/>
+                      <a:tailEnd type="none" w="med" len="med"/>
+                    </a:lnT>
+                    <a:lnB w="5715" cap="flat" cmpd="sng" algn="ctr">
+                      <a:solidFill>
+                        <a:srgbClr val="D6E5E0"/>
+                      </a:solidFill>
+                      <a:prstDash val="solid"/>
+                      <a:round/>
+                      <a:headEnd type="none" w="med" len="med"/>
+                      <a:tailEnd type="none" w="med" len="med"/>
+                    </a:lnB>
+                    <a:solidFill>
+                      <a:srgbClr val="FFFFFF"/>
+                    </a:solidFill>
+                  </a:tcPr>
+                </a:tc>
+                <a:tc>
+                  <a:txBody>
+                    <a:bodyPr/>
+                    <a:lstStyle/>
+                    <a:p>
+                      <a:pPr indent="0" marL="0">
+                        <a:buNone/>
+                      </a:pPr>
+                      <a:r>
+                        <a:rPr lang="en-US" sz="740" dirty="0">
+                          <a:solidFill>
+                            <a:srgbClr val="263B38"/>
+                          </a:solidFill>
+                        </a:rPr>
+                        <a:t>clients.component.ts</a:t>
                       </a:r>
                       <a:endParaRPr lang="en-US" sz="740" dirty="0"/>
                     </a:p>
@@ -3143,7 +3477,7 @@
                   </a:tcPr>
                 </a:tc>
               </a:tr>
-              <a:tr h="324343">
+              <a:tr h="306324">
                 <a:tc>
                   <a:txBody>
                     <a:bodyPr/>
@@ -3219,7 +3553,68 @@
                             <a:srgbClr val="263B38"/>
                           </a:solidFill>
                         </a:rPr>
-                        <a:t>Libere une ressource avant la prochaine execution de l'effet.</a:t>
+                        <a:t>Libere timer, listener ou subscription.</a:t>
+                      </a:r>
+                      <a:endParaRPr lang="en-US" sz="740" dirty="0"/>
+                    </a:p>
+                  </a:txBody>
+                  <a:tcPr marL="50800" marR="50800" marT="25400" marB="25400" anchor="mid">
+                    <a:lnL w="5715" cap="flat" cmpd="sng" algn="ctr">
+                      <a:solidFill>
+                        <a:srgbClr val="D6E5E0"/>
+                      </a:solidFill>
+                      <a:prstDash val="solid"/>
+                      <a:round/>
+                      <a:headEnd type="none" w="med" len="med"/>
+                      <a:tailEnd type="none" w="med" len="med"/>
+                    </a:lnL>
+                    <a:lnR w="5715" cap="flat" cmpd="sng" algn="ctr">
+                      <a:solidFill>
+                        <a:srgbClr val="D6E5E0"/>
+                      </a:solidFill>
+                      <a:prstDash val="solid"/>
+                      <a:round/>
+                      <a:headEnd type="none" w="med" len="med"/>
+                      <a:tailEnd type="none" w="med" len="med"/>
+                    </a:lnR>
+                    <a:lnT w="5715" cap="flat" cmpd="sng" algn="ctr">
+                      <a:solidFill>
+                        <a:srgbClr val="D6E5E0"/>
+                      </a:solidFill>
+                      <a:prstDash val="solid"/>
+                      <a:round/>
+                      <a:headEnd type="none" w="med" len="med"/>
+                      <a:tailEnd type="none" w="med" len="med"/>
+                    </a:lnT>
+                    <a:lnB w="5715" cap="flat" cmpd="sng" algn="ctr">
+                      <a:solidFill>
+                        <a:srgbClr val="D6E5E0"/>
+                      </a:solidFill>
+                      <a:prstDash val="solid"/>
+                      <a:round/>
+                      <a:headEnd type="none" w="med" len="med"/>
+                      <a:tailEnd type="none" w="med" len="med"/>
+                    </a:lnB>
+                    <a:solidFill>
+                      <a:srgbClr val="F3F8F6"/>
+                    </a:solidFill>
+                  </a:tcPr>
+                </a:tc>
+                <a:tc>
+                  <a:txBody>
+                    <a:bodyPr/>
+                    <a:lstStyle/>
+                    <a:p>
+                      <a:pPr indent="0" marL="0">
+                        <a:buNone/>
+                      </a:pPr>
+                      <a:r>
+                        <a:rPr lang="en-US" sz="740" dirty="0">
+                          <a:solidFill>
+                            <a:srgbClr val="263B38"/>
+                          </a:solidFill>
+                        </a:rPr>
+                        <a:t>signals-demo.component.ts</a:t>
                       </a:r>
                       <a:endParaRPr lang="en-US" sz="740" dirty="0"/>
                     </a:p>
@@ -3267,7 +3662,7 @@
                   </a:tcPr>
                 </a:tc>
               </a:tr>
-              <a:tr h="324343">
+              <a:tr h="306324">
                 <a:tc>
                   <a:txBody>
                     <a:bodyPr/>
@@ -3343,7 +3738,68 @@
                             <a:srgbClr val="263B38"/>
                           </a:solidFill>
                         </a:rPr>
-                        <a:t>Reference reactive a un element DOM ou composant enfant.</a:t>
+                        <a:t>Reference reactive a un element DOM.</a:t>
+                      </a:r>
+                      <a:endParaRPr lang="en-US" sz="740" dirty="0"/>
+                    </a:p>
+                  </a:txBody>
+                  <a:tcPr marL="50800" marR="50800" marT="25400" marB="25400" anchor="mid">
+                    <a:lnL w="5715" cap="flat" cmpd="sng" algn="ctr">
+                      <a:solidFill>
+                        <a:srgbClr val="D6E5E0"/>
+                      </a:solidFill>
+                      <a:prstDash val="solid"/>
+                      <a:round/>
+                      <a:headEnd type="none" w="med" len="med"/>
+                      <a:tailEnd type="none" w="med" len="med"/>
+                    </a:lnL>
+                    <a:lnR w="5715" cap="flat" cmpd="sng" algn="ctr">
+                      <a:solidFill>
+                        <a:srgbClr val="D6E5E0"/>
+                      </a:solidFill>
+                      <a:prstDash val="solid"/>
+                      <a:round/>
+                      <a:headEnd type="none" w="med" len="med"/>
+                      <a:tailEnd type="none" w="med" len="med"/>
+                    </a:lnR>
+                    <a:lnT w="5715" cap="flat" cmpd="sng" algn="ctr">
+                      <a:solidFill>
+                        <a:srgbClr val="D6E5E0"/>
+                      </a:solidFill>
+                      <a:prstDash val="solid"/>
+                      <a:round/>
+                      <a:headEnd type="none" w="med" len="med"/>
+                      <a:tailEnd type="none" w="med" len="med"/>
+                    </a:lnT>
+                    <a:lnB w="5715" cap="flat" cmpd="sng" algn="ctr">
+                      <a:solidFill>
+                        <a:srgbClr val="D6E5E0"/>
+                      </a:solidFill>
+                      <a:prstDash val="solid"/>
+                      <a:round/>
+                      <a:headEnd type="none" w="med" len="med"/>
+                      <a:tailEnd type="none" w="med" len="med"/>
+                    </a:lnB>
+                    <a:solidFill>
+                      <a:srgbClr val="FFFFFF"/>
+                    </a:solidFill>
+                  </a:tcPr>
+                </a:tc>
+                <a:tc>
+                  <a:txBody>
+                    <a:bodyPr/>
+                    <a:lstStyle/>
+                    <a:p>
+                      <a:pPr indent="0" marL="0">
+                        <a:buNone/>
+                      </a:pPr>
+                      <a:r>
+                        <a:rPr lang="en-US" sz="740" dirty="0">
+                          <a:solidFill>
+                            <a:srgbClr val="263B38"/>
+                          </a:solidFill>
+                        </a:rPr>
+                        <a:t>clients.component.ts</a:t>
                       </a:r>
                       <a:endParaRPr lang="en-US" sz="740" dirty="0"/>
                     </a:p>
@@ -3391,7 +3847,192 @@
                   </a:tcPr>
                 </a:tc>
               </a:tr>
-              <a:tr h="324343">
+              <a:tr h="306324">
+                <a:tc>
+                  <a:txBody>
+                    <a:bodyPr/>
+                    <a:lstStyle/>
+                    <a:p>
+                      <a:pPr indent="0" marL="0">
+                        <a:buNone/>
+                      </a:pPr>
+                      <a:r>
+                        <a:rPr lang="en-US" sz="740" dirty="0">
+                          <a:solidFill>
+                            <a:srgbClr val="263B38"/>
+                          </a:solidFill>
+                        </a:rPr>
+                        <a:t>viewChildren()</a:t>
+                      </a:r>
+                      <a:endParaRPr lang="en-US" sz="740" dirty="0"/>
+                    </a:p>
+                  </a:txBody>
+                  <a:tcPr marL="50800" marR="50800" marT="25400" marB="25400" anchor="mid">
+                    <a:lnL w="5715" cap="flat" cmpd="sng" algn="ctr">
+                      <a:solidFill>
+                        <a:srgbClr val="D6E5E0"/>
+                      </a:solidFill>
+                      <a:prstDash val="solid"/>
+                      <a:round/>
+                      <a:headEnd type="none" w="med" len="med"/>
+                      <a:tailEnd type="none" w="med" len="med"/>
+                    </a:lnL>
+                    <a:lnR w="5715" cap="flat" cmpd="sng" algn="ctr">
+                      <a:solidFill>
+                        <a:srgbClr val="D6E5E0"/>
+                      </a:solidFill>
+                      <a:prstDash val="solid"/>
+                      <a:round/>
+                      <a:headEnd type="none" w="med" len="med"/>
+                      <a:tailEnd type="none" w="med" len="med"/>
+                    </a:lnR>
+                    <a:lnT w="5715" cap="flat" cmpd="sng" algn="ctr">
+                      <a:solidFill>
+                        <a:srgbClr val="D6E5E0"/>
+                      </a:solidFill>
+                      <a:prstDash val="solid"/>
+                      <a:round/>
+                      <a:headEnd type="none" w="med" len="med"/>
+                      <a:tailEnd type="none" w="med" len="med"/>
+                    </a:lnT>
+                    <a:lnB w="5715" cap="flat" cmpd="sng" algn="ctr">
+                      <a:solidFill>
+                        <a:srgbClr val="D6E5E0"/>
+                      </a:solidFill>
+                      <a:prstDash val="solid"/>
+                      <a:round/>
+                      <a:headEnd type="none" w="med" len="med"/>
+                      <a:tailEnd type="none" w="med" len="med"/>
+                    </a:lnB>
+                    <a:solidFill>
+                      <a:srgbClr val="F3F8F6"/>
+                    </a:solidFill>
+                  </a:tcPr>
+                </a:tc>
+                <a:tc>
+                  <a:txBody>
+                    <a:bodyPr/>
+                    <a:lstStyle/>
+                    <a:p>
+                      <a:pPr indent="0" marL="0">
+                        <a:buNone/>
+                      </a:pPr>
+                      <a:r>
+                        <a:rPr lang="en-US" sz="740" dirty="0">
+                          <a:solidFill>
+                            <a:srgbClr val="263B38"/>
+                          </a:solidFill>
+                        </a:rPr>
+                        <a:t>Liste reactive de references rendues.</a:t>
+                      </a:r>
+                      <a:endParaRPr lang="en-US" sz="740" dirty="0"/>
+                    </a:p>
+                  </a:txBody>
+                  <a:tcPr marL="50800" marR="50800" marT="25400" marB="25400" anchor="mid">
+                    <a:lnL w="5715" cap="flat" cmpd="sng" algn="ctr">
+                      <a:solidFill>
+                        <a:srgbClr val="D6E5E0"/>
+                      </a:solidFill>
+                      <a:prstDash val="solid"/>
+                      <a:round/>
+                      <a:headEnd type="none" w="med" len="med"/>
+                      <a:tailEnd type="none" w="med" len="med"/>
+                    </a:lnL>
+                    <a:lnR w="5715" cap="flat" cmpd="sng" algn="ctr">
+                      <a:solidFill>
+                        <a:srgbClr val="D6E5E0"/>
+                      </a:solidFill>
+                      <a:prstDash val="solid"/>
+                      <a:round/>
+                      <a:headEnd type="none" w="med" len="med"/>
+                      <a:tailEnd type="none" w="med" len="med"/>
+                    </a:lnR>
+                    <a:lnT w="5715" cap="flat" cmpd="sng" algn="ctr">
+                      <a:solidFill>
+                        <a:srgbClr val="D6E5E0"/>
+                      </a:solidFill>
+                      <a:prstDash val="solid"/>
+                      <a:round/>
+                      <a:headEnd type="none" w="med" len="med"/>
+                      <a:tailEnd type="none" w="med" len="med"/>
+                    </a:lnT>
+                    <a:lnB w="5715" cap="flat" cmpd="sng" algn="ctr">
+                      <a:solidFill>
+                        <a:srgbClr val="D6E5E0"/>
+                      </a:solidFill>
+                      <a:prstDash val="solid"/>
+                      <a:round/>
+                      <a:headEnd type="none" w="med" len="med"/>
+                      <a:tailEnd type="none" w="med" len="med"/>
+                    </a:lnB>
+                    <a:solidFill>
+                      <a:srgbClr val="F3F8F6"/>
+                    </a:solidFill>
+                  </a:tcPr>
+                </a:tc>
+                <a:tc>
+                  <a:txBody>
+                    <a:bodyPr/>
+                    <a:lstStyle/>
+                    <a:p>
+                      <a:pPr indent="0" marL="0">
+                        <a:buNone/>
+                      </a:pPr>
+                      <a:r>
+                        <a:rPr lang="en-US" sz="740" dirty="0">
+                          <a:solidFill>
+                            <a:srgbClr val="263B38"/>
+                          </a:solidFill>
+                        </a:rPr>
+                        <a:t>signals-demo.component.ts</a:t>
+                      </a:r>
+                      <a:endParaRPr lang="en-US" sz="740" dirty="0"/>
+                    </a:p>
+                  </a:txBody>
+                  <a:tcPr marL="50800" marR="50800" marT="25400" marB="25400" anchor="mid">
+                    <a:lnL w="5715" cap="flat" cmpd="sng" algn="ctr">
+                      <a:solidFill>
+                        <a:srgbClr val="D6E5E0"/>
+                      </a:solidFill>
+                      <a:prstDash val="solid"/>
+                      <a:round/>
+                      <a:headEnd type="none" w="med" len="med"/>
+                      <a:tailEnd type="none" w="med" len="med"/>
+                    </a:lnL>
+                    <a:lnR w="5715" cap="flat" cmpd="sng" algn="ctr">
+                      <a:solidFill>
+                        <a:srgbClr val="D6E5E0"/>
+                      </a:solidFill>
+                      <a:prstDash val="solid"/>
+                      <a:round/>
+                      <a:headEnd type="none" w="med" len="med"/>
+                      <a:tailEnd type="none" w="med" len="med"/>
+                    </a:lnR>
+                    <a:lnT w="5715" cap="flat" cmpd="sng" algn="ctr">
+                      <a:solidFill>
+                        <a:srgbClr val="D6E5E0"/>
+                      </a:solidFill>
+                      <a:prstDash val="solid"/>
+                      <a:round/>
+                      <a:headEnd type="none" w="med" len="med"/>
+                      <a:tailEnd type="none" w="med" len="med"/>
+                    </a:lnT>
+                    <a:lnB w="5715" cap="flat" cmpd="sng" algn="ctr">
+                      <a:solidFill>
+                        <a:srgbClr val="D6E5E0"/>
+                      </a:solidFill>
+                      <a:prstDash val="solid"/>
+                      <a:round/>
+                      <a:headEnd type="none" w="med" len="med"/>
+                      <a:tailEnd type="none" w="med" len="med"/>
+                    </a:lnB>
+                    <a:solidFill>
+                      <a:srgbClr val="F3F8F6"/>
+                    </a:solidFill>
+                  </a:tcPr>
+                </a:tc>
+              </a:tr>
+              <a:tr h="306324">
                 <a:tc>
                   <a:txBody>
                     <a:bodyPr/>
@@ -3449,7 +4090,7 @@
                       <a:tailEnd type="none" w="med" len="med"/>
                     </a:lnB>
                     <a:solidFill>
-                      <a:srgbClr val="F3F8F6"/>
+                      <a:srgbClr val="FFFFFF"/>
                     </a:solidFill>
                   </a:tcPr>
                 </a:tc>
@@ -3510,12 +4151,73 @@
                       <a:tailEnd type="none" w="med" len="med"/>
                     </a:lnB>
                     <a:solidFill>
-                      <a:srgbClr val="F3F8F6"/>
+                      <a:srgbClr val="FFFFFF"/>
+                    </a:solidFill>
+                  </a:tcPr>
+                </a:tc>
+                <a:tc>
+                  <a:txBody>
+                    <a:bodyPr/>
+                    <a:lstStyle/>
+                    <a:p>
+                      <a:pPr indent="0" marL="0">
+                        <a:buNone/>
+                      </a:pPr>
+                      <a:r>
+                        <a:rPr lang="en-US" sz="740" dirty="0">
+                          <a:solidFill>
+                            <a:srgbClr val="263B38"/>
+                          </a:solidFill>
+                        </a:rPr>
+                        <a:t>account-card.component.ts</a:t>
+                      </a:r>
+                      <a:endParaRPr lang="en-US" sz="740" dirty="0"/>
+                    </a:p>
+                  </a:txBody>
+                  <a:tcPr marL="50800" marR="50800" marT="25400" marB="25400" anchor="mid">
+                    <a:lnL w="5715" cap="flat" cmpd="sng" algn="ctr">
+                      <a:solidFill>
+                        <a:srgbClr val="D6E5E0"/>
+                      </a:solidFill>
+                      <a:prstDash val="solid"/>
+                      <a:round/>
+                      <a:headEnd type="none" w="med" len="med"/>
+                      <a:tailEnd type="none" w="med" len="med"/>
+                    </a:lnL>
+                    <a:lnR w="5715" cap="flat" cmpd="sng" algn="ctr">
+                      <a:solidFill>
+                        <a:srgbClr val="D6E5E0"/>
+                      </a:solidFill>
+                      <a:prstDash val="solid"/>
+                      <a:round/>
+                      <a:headEnd type="none" w="med" len="med"/>
+                      <a:tailEnd type="none" w="med" len="med"/>
+                    </a:lnR>
+                    <a:lnT w="5715" cap="flat" cmpd="sng" algn="ctr">
+                      <a:solidFill>
+                        <a:srgbClr val="D6E5E0"/>
+                      </a:solidFill>
+                      <a:prstDash val="solid"/>
+                      <a:round/>
+                      <a:headEnd type="none" w="med" len="med"/>
+                      <a:tailEnd type="none" w="med" len="med"/>
+                    </a:lnT>
+                    <a:lnB w="5715" cap="flat" cmpd="sng" algn="ctr">
+                      <a:solidFill>
+                        <a:srgbClr val="D6E5E0"/>
+                      </a:solidFill>
+                      <a:prstDash val="solid"/>
+                      <a:round/>
+                      <a:headEnd type="none" w="med" len="med"/>
+                      <a:tailEnd type="none" w="med" len="med"/>
+                    </a:lnB>
+                    <a:solidFill>
+                      <a:srgbClr val="FFFFFF"/>
                     </a:solidFill>
                   </a:tcPr>
                 </a:tc>
               </a:tr>
-              <a:tr h="324343">
+              <a:tr h="306324">
                 <a:tc>
                   <a:txBody>
                     <a:bodyPr/>
@@ -3573,7 +4275,7 @@
                       <a:tailEnd type="none" w="med" len="med"/>
                     </a:lnB>
                     <a:solidFill>
-                      <a:srgbClr val="FFFFFF"/>
+                      <a:srgbClr val="F3F8F6"/>
                     </a:solidFill>
                   </a:tcPr>
                 </a:tc>
@@ -3591,7 +4293,7 @@
                             <a:srgbClr val="263B38"/>
                           </a:solidFill>
                         </a:rPr>
-                        <a:t>Evenement sortant vers le parent. Pas un Observable.</a:t>
+                        <a:t>Evenement sortant vers le parent.</a:t>
                       </a:r>
                       <a:endParaRPr lang="en-US" sz="740" dirty="0"/>
                     </a:p>
@@ -3634,12 +4336,73 @@
                       <a:tailEnd type="none" w="med" len="med"/>
                     </a:lnB>
                     <a:solidFill>
-                      <a:srgbClr val="FFFFFF"/>
+                      <a:srgbClr val="F3F8F6"/>
+                    </a:solidFill>
+                  </a:tcPr>
+                </a:tc>
+                <a:tc>
+                  <a:txBody>
+                    <a:bodyPr/>
+                    <a:lstStyle/>
+                    <a:p>
+                      <a:pPr indent="0" marL="0">
+                        <a:buNone/>
+                      </a:pPr>
+                      <a:r>
+                        <a:rPr lang="en-US" sz="740" dirty="0">
+                          <a:solidFill>
+                            <a:srgbClr val="263B38"/>
+                          </a:solidFill>
+                        </a:rPr>
+                        <a:t>account-list.component.ts</a:t>
+                      </a:r>
+                      <a:endParaRPr lang="en-US" sz="740" dirty="0"/>
+                    </a:p>
+                  </a:txBody>
+                  <a:tcPr marL="50800" marR="50800" marT="25400" marB="25400" anchor="mid">
+                    <a:lnL w="5715" cap="flat" cmpd="sng" algn="ctr">
+                      <a:solidFill>
+                        <a:srgbClr val="D6E5E0"/>
+                      </a:solidFill>
+                      <a:prstDash val="solid"/>
+                      <a:round/>
+                      <a:headEnd type="none" w="med" len="med"/>
+                      <a:tailEnd type="none" w="med" len="med"/>
+                    </a:lnL>
+                    <a:lnR w="5715" cap="flat" cmpd="sng" algn="ctr">
+                      <a:solidFill>
+                        <a:srgbClr val="D6E5E0"/>
+                      </a:solidFill>
+                      <a:prstDash val="solid"/>
+                      <a:round/>
+                      <a:headEnd type="none" w="med" len="med"/>
+                      <a:tailEnd type="none" w="med" len="med"/>
+                    </a:lnR>
+                    <a:lnT w="5715" cap="flat" cmpd="sng" algn="ctr">
+                      <a:solidFill>
+                        <a:srgbClr val="D6E5E0"/>
+                      </a:solidFill>
+                      <a:prstDash val="solid"/>
+                      <a:round/>
+                      <a:headEnd type="none" w="med" len="med"/>
+                      <a:tailEnd type="none" w="med" len="med"/>
+                    </a:lnT>
+                    <a:lnB w="5715" cap="flat" cmpd="sng" algn="ctr">
+                      <a:solidFill>
+                        <a:srgbClr val="D6E5E0"/>
+                      </a:solidFill>
+                      <a:prstDash val="solid"/>
+                      <a:round/>
+                      <a:headEnd type="none" w="med" len="med"/>
+                      <a:tailEnd type="none" w="med" len="med"/>
+                    </a:lnB>
+                    <a:solidFill>
+                      <a:srgbClr val="F3F8F6"/>
                     </a:solidFill>
                   </a:tcPr>
                 </a:tc>
               </a:tr>
-              <a:tr h="324343">
+              <a:tr h="306324">
                 <a:tc>
                   <a:txBody>
                     <a:bodyPr/>
@@ -3697,7 +4460,7 @@
                       <a:tailEnd type="none" w="med" len="med"/>
                     </a:lnB>
                     <a:solidFill>
-                      <a:srgbClr val="F3F8F6"/>
+                      <a:srgbClr val="FFFFFF"/>
                     </a:solidFill>
                   </a:tcPr>
                 </a:tc>
@@ -3715,7 +4478,7 @@
                             <a:srgbClr val="263B38"/>
                           </a:solidFill>
                         </a:rPr>
-                        <a:t>Valeur bidirectionnelle input + output. Two-way binding signal.</a:t>
+                        <a:t>Valeur bidirectionnelle input + output.</a:t>
                       </a:r>
                       <a:endParaRPr lang="en-US" sz="740" dirty="0"/>
                     </a:p>
@@ -3758,12 +4521,73 @@
                       <a:tailEnd type="none" w="med" len="med"/>
                     </a:lnB>
                     <a:solidFill>
-                      <a:srgbClr val="F3F8F6"/>
+                      <a:srgbClr val="FFFFFF"/>
+                    </a:solidFill>
+                  </a:tcPr>
+                </a:tc>
+                <a:tc>
+                  <a:txBody>
+                    <a:bodyPr/>
+                    <a:lstStyle/>
+                    <a:p>
+                      <a:pPr indent="0" marL="0">
+                        <a:buNone/>
+                      </a:pPr>
+                      <a:r>
+                        <a:rPr lang="en-US" sz="740" dirty="0">
+                          <a:solidFill>
+                            <a:srgbClr val="263B38"/>
+                          </a:solidFill>
+                        </a:rPr>
+                        <a:t>account-list.component.ts</a:t>
+                      </a:r>
+                      <a:endParaRPr lang="en-US" sz="740" dirty="0"/>
+                    </a:p>
+                  </a:txBody>
+                  <a:tcPr marL="50800" marR="50800" marT="25400" marB="25400" anchor="mid">
+                    <a:lnL w="5715" cap="flat" cmpd="sng" algn="ctr">
+                      <a:solidFill>
+                        <a:srgbClr val="D6E5E0"/>
+                      </a:solidFill>
+                      <a:prstDash val="solid"/>
+                      <a:round/>
+                      <a:headEnd type="none" w="med" len="med"/>
+                      <a:tailEnd type="none" w="med" len="med"/>
+                    </a:lnL>
+                    <a:lnR w="5715" cap="flat" cmpd="sng" algn="ctr">
+                      <a:solidFill>
+                        <a:srgbClr val="D6E5E0"/>
+                      </a:solidFill>
+                      <a:prstDash val="solid"/>
+                      <a:round/>
+                      <a:headEnd type="none" w="med" len="med"/>
+                      <a:tailEnd type="none" w="med" len="med"/>
+                    </a:lnR>
+                    <a:lnT w="5715" cap="flat" cmpd="sng" algn="ctr">
+                      <a:solidFill>
+                        <a:srgbClr val="D6E5E0"/>
+                      </a:solidFill>
+                      <a:prstDash val="solid"/>
+                      <a:round/>
+                      <a:headEnd type="none" w="med" len="med"/>
+                      <a:tailEnd type="none" w="med" len="med"/>
+                    </a:lnT>
+                    <a:lnB w="5715" cap="flat" cmpd="sng" algn="ctr">
+                      <a:solidFill>
+                        <a:srgbClr val="D6E5E0"/>
+                      </a:solidFill>
+                      <a:prstDash val="solid"/>
+                      <a:round/>
+                      <a:headEnd type="none" w="med" len="med"/>
+                      <a:tailEnd type="none" w="med" len="med"/>
+                    </a:lnB>
+                    <a:solidFill>
+                      <a:srgbClr val="FFFFFF"/>
                     </a:solidFill>
                   </a:tcPr>
                 </a:tc>
               </a:tr>
-              <a:tr h="324343">
+              <a:tr h="306324">
                 <a:tc>
                   <a:txBody>
                     <a:bodyPr/>
@@ -3821,7 +4645,7 @@
                       <a:tailEnd type="none" w="med" len="med"/>
                     </a:lnB>
                     <a:solidFill>
-                      <a:srgbClr val="FFFFFF"/>
+                      <a:srgbClr val="F3F8F6"/>
                     </a:solidFill>
                   </a:tcPr>
                 </a:tc>
@@ -3839,7 +4663,7 @@
                             <a:srgbClr val="263B38"/>
                           </a:solidFill>
                         </a:rPr>
-                        <a:t>Signal mutable derive d'un autre. Se reinitialise quand la source change.</a:t>
+                        <a:t>Signal mutable derive d'une source.</a:t>
                       </a:r>
                       <a:endParaRPr lang="en-US" sz="740" dirty="0"/>
                     </a:p>
@@ -3882,12 +4706,73 @@
                       <a:tailEnd type="none" w="med" len="med"/>
                     </a:lnB>
                     <a:solidFill>
-                      <a:srgbClr val="FFFFFF"/>
+                      <a:srgbClr val="F3F8F6"/>
+                    </a:solidFill>
+                  </a:tcPr>
+                </a:tc>
+                <a:tc>
+                  <a:txBody>
+                    <a:bodyPr/>
+                    <a:lstStyle/>
+                    <a:p>
+                      <a:pPr indent="0" marL="0">
+                        <a:buNone/>
+                      </a:pPr>
+                      <a:r>
+                        <a:rPr lang="en-US" sz="740" dirty="0">
+                          <a:solidFill>
+                            <a:srgbClr val="263B38"/>
+                          </a:solidFill>
+                        </a:rPr>
+                        <a:t>accounts.component.ts</a:t>
+                      </a:r>
+                      <a:endParaRPr lang="en-US" sz="740" dirty="0"/>
+                    </a:p>
+                  </a:txBody>
+                  <a:tcPr marL="50800" marR="50800" marT="25400" marB="25400" anchor="mid">
+                    <a:lnL w="5715" cap="flat" cmpd="sng" algn="ctr">
+                      <a:solidFill>
+                        <a:srgbClr val="D6E5E0"/>
+                      </a:solidFill>
+                      <a:prstDash val="solid"/>
+                      <a:round/>
+                      <a:headEnd type="none" w="med" len="med"/>
+                      <a:tailEnd type="none" w="med" len="med"/>
+                    </a:lnL>
+                    <a:lnR w="5715" cap="flat" cmpd="sng" algn="ctr">
+                      <a:solidFill>
+                        <a:srgbClr val="D6E5E0"/>
+                      </a:solidFill>
+                      <a:prstDash val="solid"/>
+                      <a:round/>
+                      <a:headEnd type="none" w="med" len="med"/>
+                      <a:tailEnd type="none" w="med" len="med"/>
+                    </a:lnR>
+                    <a:lnT w="5715" cap="flat" cmpd="sng" algn="ctr">
+                      <a:solidFill>
+                        <a:srgbClr val="D6E5E0"/>
+                      </a:solidFill>
+                      <a:prstDash val="solid"/>
+                      <a:round/>
+                      <a:headEnd type="none" w="med" len="med"/>
+                      <a:tailEnd type="none" w="med" len="med"/>
+                    </a:lnT>
+                    <a:lnB w="5715" cap="flat" cmpd="sng" algn="ctr">
+                      <a:solidFill>
+                        <a:srgbClr val="D6E5E0"/>
+                      </a:solidFill>
+                      <a:prstDash val="solid"/>
+                      <a:round/>
+                      <a:headEnd type="none" w="med" len="med"/>
+                      <a:tailEnd type="none" w="med" len="med"/>
+                    </a:lnB>
+                    <a:solidFill>
+                      <a:srgbClr val="F3F8F6"/>
                     </a:solidFill>
                   </a:tcPr>
                 </a:tc>
               </a:tr>
-              <a:tr h="324343">
+              <a:tr h="306324">
                 <a:tc>
                   <a:txBody>
                     <a:bodyPr/>
@@ -3945,7 +4830,7 @@
                       <a:tailEnd type="none" w="med" len="med"/>
                     </a:lnB>
                     <a:solidFill>
-                      <a:srgbClr val="F3F8F6"/>
+                      <a:srgbClr val="FFFFFF"/>
                     </a:solidFill>
                   </a:tcPr>
                 </a:tc>
@@ -3963,7 +4848,7 @@
                             <a:srgbClr val="263B38"/>
                           </a:solidFill>
                         </a:rPr>
-                        <a:t>Convertit un Observable en signal. Abonnement gere automatiquement.</a:t>
+                        <a:t>Observable vers signal.</a:t>
                       </a:r>
                       <a:endParaRPr lang="en-US" sz="740" dirty="0"/>
                     </a:p>
@@ -4006,12 +4891,73 @@
                       <a:tailEnd type="none" w="med" len="med"/>
                     </a:lnB>
                     <a:solidFill>
-                      <a:srgbClr val="F3F8F6"/>
+                      <a:srgbClr val="FFFFFF"/>
+                    </a:solidFill>
+                  </a:tcPr>
+                </a:tc>
+                <a:tc>
+                  <a:txBody>
+                    <a:bodyPr/>
+                    <a:lstStyle/>
+                    <a:p>
+                      <a:pPr indent="0" marL="0">
+                        <a:buNone/>
+                      </a:pPr>
+                      <a:r>
+                        <a:rPr lang="en-US" sz="740" dirty="0">
+                          <a:solidFill>
+                            <a:srgbClr val="263B38"/>
+                          </a:solidFill>
+                        </a:rPr>
+                        <a:t>accounts.component.ts</a:t>
+                      </a:r>
+                      <a:endParaRPr lang="en-US" sz="740" dirty="0"/>
+                    </a:p>
+                  </a:txBody>
+                  <a:tcPr marL="50800" marR="50800" marT="25400" marB="25400" anchor="mid">
+                    <a:lnL w="5715" cap="flat" cmpd="sng" algn="ctr">
+                      <a:solidFill>
+                        <a:srgbClr val="D6E5E0"/>
+                      </a:solidFill>
+                      <a:prstDash val="solid"/>
+                      <a:round/>
+                      <a:headEnd type="none" w="med" len="med"/>
+                      <a:tailEnd type="none" w="med" len="med"/>
+                    </a:lnL>
+                    <a:lnR w="5715" cap="flat" cmpd="sng" algn="ctr">
+                      <a:solidFill>
+                        <a:srgbClr val="D6E5E0"/>
+                      </a:solidFill>
+                      <a:prstDash val="solid"/>
+                      <a:round/>
+                      <a:headEnd type="none" w="med" len="med"/>
+                      <a:tailEnd type="none" w="med" len="med"/>
+                    </a:lnR>
+                    <a:lnT w="5715" cap="flat" cmpd="sng" algn="ctr">
+                      <a:solidFill>
+                        <a:srgbClr val="D6E5E0"/>
+                      </a:solidFill>
+                      <a:prstDash val="solid"/>
+                      <a:round/>
+                      <a:headEnd type="none" w="med" len="med"/>
+                      <a:tailEnd type="none" w="med" len="med"/>
+                    </a:lnT>
+                    <a:lnB w="5715" cap="flat" cmpd="sng" algn="ctr">
+                      <a:solidFill>
+                        <a:srgbClr val="D6E5E0"/>
+                      </a:solidFill>
+                      <a:prstDash val="solid"/>
+                      <a:round/>
+                      <a:headEnd type="none" w="med" len="med"/>
+                      <a:tailEnd type="none" w="med" len="med"/>
+                    </a:lnB>
+                    <a:solidFill>
+                      <a:srgbClr val="FFFFFF"/>
                     </a:solidFill>
                   </a:tcPr>
                 </a:tc>
               </a:tr>
-              <a:tr h="324343">
+              <a:tr h="306324">
                 <a:tc>
                   <a:txBody>
                     <a:bodyPr/>
@@ -4069,7 +5015,7 @@
                       <a:tailEnd type="none" w="med" len="med"/>
                     </a:lnB>
                     <a:solidFill>
-                      <a:srgbClr val="FFFFFF"/>
+                      <a:srgbClr val="F3F8F6"/>
                     </a:solidFill>
                   </a:tcPr>
                 </a:tc>
@@ -4087,7 +5033,7 @@
                             <a:srgbClr val="263B38"/>
                           </a:solidFill>
                         </a:rPr>
-                        <a:t>Expose un signal comme Observable pour les operateurs RxJS.</a:t>
+                        <a:t>Signal vers Observable RxJS.</a:t>
                       </a:r>
                       <a:endParaRPr lang="en-US" sz="740" dirty="0"/>
                     </a:p>
@@ -4130,12 +5076,73 @@
                       <a:tailEnd type="none" w="med" len="med"/>
                     </a:lnB>
                     <a:solidFill>
-                      <a:srgbClr val="FFFFFF"/>
+                      <a:srgbClr val="F3F8F6"/>
+                    </a:solidFill>
+                  </a:tcPr>
+                </a:tc>
+                <a:tc>
+                  <a:txBody>
+                    <a:bodyPr/>
+                    <a:lstStyle/>
+                    <a:p>
+                      <a:pPr indent="0" marL="0">
+                        <a:buNone/>
+                      </a:pPr>
+                      <a:r>
+                        <a:rPr lang="en-US" sz="740" dirty="0">
+                          <a:solidFill>
+                            <a:srgbClr val="263B38"/>
+                          </a:solidFill>
+                        </a:rPr>
+                        <a:t>clients.component.ts</a:t>
+                      </a:r>
+                      <a:endParaRPr lang="en-US" sz="740" dirty="0"/>
+                    </a:p>
+                  </a:txBody>
+                  <a:tcPr marL="50800" marR="50800" marT="25400" marB="25400" anchor="mid">
+                    <a:lnL w="5715" cap="flat" cmpd="sng" algn="ctr">
+                      <a:solidFill>
+                        <a:srgbClr val="D6E5E0"/>
+                      </a:solidFill>
+                      <a:prstDash val="solid"/>
+                      <a:round/>
+                      <a:headEnd type="none" w="med" len="med"/>
+                      <a:tailEnd type="none" w="med" len="med"/>
+                    </a:lnL>
+                    <a:lnR w="5715" cap="flat" cmpd="sng" algn="ctr">
+                      <a:solidFill>
+                        <a:srgbClr val="D6E5E0"/>
+                      </a:solidFill>
+                      <a:prstDash val="solid"/>
+                      <a:round/>
+                      <a:headEnd type="none" w="med" len="med"/>
+                      <a:tailEnd type="none" w="med" len="med"/>
+                    </a:lnR>
+                    <a:lnT w="5715" cap="flat" cmpd="sng" algn="ctr">
+                      <a:solidFill>
+                        <a:srgbClr val="D6E5E0"/>
+                      </a:solidFill>
+                      <a:prstDash val="solid"/>
+                      <a:round/>
+                      <a:headEnd type="none" w="med" len="med"/>
+                      <a:tailEnd type="none" w="med" len="med"/>
+                    </a:lnT>
+                    <a:lnB w="5715" cap="flat" cmpd="sng" algn="ctr">
+                      <a:solidFill>
+                        <a:srgbClr val="D6E5E0"/>
+                      </a:solidFill>
+                      <a:prstDash val="solid"/>
+                      <a:round/>
+                      <a:headEnd type="none" w="med" len="med"/>
+                      <a:tailEnd type="none" w="med" len="med"/>
+                    </a:lnB>
+                    <a:solidFill>
+                      <a:srgbClr val="F3F8F6"/>
                     </a:solidFill>
                   </a:tcPr>
                 </a:tc>
               </a:tr>
-              <a:tr h="324343">
+              <a:tr h="306324">
                 <a:tc>
                   <a:txBody>
                     <a:bodyPr/>
@@ -4193,7 +5200,7 @@
                       <a:tailEnd type="none" w="med" len="med"/>
                     </a:lnB>
                     <a:solidFill>
-                      <a:srgbClr val="F3F8F6"/>
+                      <a:srgbClr val="FFFFFF"/>
                     </a:solidFill>
                   </a:tcPr>
                 </a:tc>
@@ -4211,7 +5218,7 @@
                             <a:srgbClr val="263B38"/>
                           </a:solidFill>
                         </a:rPr>
-                        <a:t>Chargement async reactif avec value(), isLoading et error().</a:t>
+                        <a:t>Chargement async avec loading/error/value.</a:t>
                       </a:r>
                       <a:endParaRPr lang="en-US" sz="740" dirty="0"/>
                     </a:p>
@@ -4254,12 +5261,73 @@
                       <a:tailEnd type="none" w="med" len="med"/>
                     </a:lnB>
                     <a:solidFill>
-                      <a:srgbClr val="F3F8F6"/>
+                      <a:srgbClr val="FFFFFF"/>
+                    </a:solidFill>
+                  </a:tcPr>
+                </a:tc>
+                <a:tc>
+                  <a:txBody>
+                    <a:bodyPr/>
+                    <a:lstStyle/>
+                    <a:p>
+                      <a:pPr indent="0" marL="0">
+                        <a:buNone/>
+                      </a:pPr>
+                      <a:r>
+                        <a:rPr lang="en-US" sz="740" dirty="0">
+                          <a:solidFill>
+                            <a:srgbClr val="263B38"/>
+                          </a:solidFill>
+                        </a:rPr>
+                        <a:t>dashboard.component.ts</a:t>
+                      </a:r>
+                      <a:endParaRPr lang="en-US" sz="740" dirty="0"/>
+                    </a:p>
+                  </a:txBody>
+                  <a:tcPr marL="50800" marR="50800" marT="25400" marB="25400" anchor="mid">
+                    <a:lnL w="5715" cap="flat" cmpd="sng" algn="ctr">
+                      <a:solidFill>
+                        <a:srgbClr val="D6E5E0"/>
+                      </a:solidFill>
+                      <a:prstDash val="solid"/>
+                      <a:round/>
+                      <a:headEnd type="none" w="med" len="med"/>
+                      <a:tailEnd type="none" w="med" len="med"/>
+                    </a:lnL>
+                    <a:lnR w="5715" cap="flat" cmpd="sng" algn="ctr">
+                      <a:solidFill>
+                        <a:srgbClr val="D6E5E0"/>
+                      </a:solidFill>
+                      <a:prstDash val="solid"/>
+                      <a:round/>
+                      <a:headEnd type="none" w="med" len="med"/>
+                      <a:tailEnd type="none" w="med" len="med"/>
+                    </a:lnR>
+                    <a:lnT w="5715" cap="flat" cmpd="sng" algn="ctr">
+                      <a:solidFill>
+                        <a:srgbClr val="D6E5E0"/>
+                      </a:solidFill>
+                      <a:prstDash val="solid"/>
+                      <a:round/>
+                      <a:headEnd type="none" w="med" len="med"/>
+                      <a:tailEnd type="none" w="med" len="med"/>
+                    </a:lnT>
+                    <a:lnB w="5715" cap="flat" cmpd="sng" algn="ctr">
+                      <a:solidFill>
+                        <a:srgbClr val="D6E5E0"/>
+                      </a:solidFill>
+                      <a:prstDash val="solid"/>
+                      <a:round/>
+                      <a:headEnd type="none" w="med" len="med"/>
+                      <a:tailEnd type="none" w="med" len="med"/>
+                    </a:lnB>
+                    <a:solidFill>
+                      <a:srgbClr val="FFFFFF"/>
                     </a:solidFill>
                   </a:tcPr>
                 </a:tc>
               </a:tr>
-              <a:tr h="324343">
+              <a:tr h="306324">
                 <a:tc>
                   <a:txBody>
                     <a:bodyPr/>
@@ -4317,7 +5385,7 @@
                       <a:tailEnd type="none" w="med" len="med"/>
                     </a:lnB>
                     <a:solidFill>
-                      <a:srgbClr val="FFFFFF"/>
+                      <a:srgbClr val="F3F8F6"/>
                     </a:solidFill>
                   </a:tcPr>
                 </a:tc>
@@ -4335,7 +5403,7 @@
                             <a:srgbClr val="263B38"/>
                           </a:solidFill>
                         </a:rPr>
-                        <a:t>Callback execute une seule fois apres le prochain rendu DOM.</a:t>
+                        <a:t>Callback one-shot apres prochain rendu.</a:t>
                       </a:r>
                       <a:endParaRPr lang="en-US" sz="740" dirty="0"/>
                     </a:p>
@@ -4378,12 +5446,73 @@
                       <a:tailEnd type="none" w="med" len="med"/>
                     </a:lnB>
                     <a:solidFill>
-                      <a:srgbClr val="FFFFFF"/>
+                      <a:srgbClr val="F3F8F6"/>
+                    </a:solidFill>
+                  </a:tcPr>
+                </a:tc>
+                <a:tc>
+                  <a:txBody>
+                    <a:bodyPr/>
+                    <a:lstStyle/>
+                    <a:p>
+                      <a:pPr indent="0" marL="0">
+                        <a:buNone/>
+                      </a:pPr>
+                      <a:r>
+                        <a:rPr lang="en-US" sz="740" dirty="0">
+                          <a:solidFill>
+                            <a:srgbClr val="263B38"/>
+                          </a:solidFill>
+                        </a:rPr>
+                        <a:t>clients.component.ts</a:t>
+                      </a:r>
+                      <a:endParaRPr lang="en-US" sz="740" dirty="0"/>
+                    </a:p>
+                  </a:txBody>
+                  <a:tcPr marL="50800" marR="50800" marT="25400" marB="25400" anchor="mid">
+                    <a:lnL w="5715" cap="flat" cmpd="sng" algn="ctr">
+                      <a:solidFill>
+                        <a:srgbClr val="D6E5E0"/>
+                      </a:solidFill>
+                      <a:prstDash val="solid"/>
+                      <a:round/>
+                      <a:headEnd type="none" w="med" len="med"/>
+                      <a:tailEnd type="none" w="med" len="med"/>
+                    </a:lnL>
+                    <a:lnR w="5715" cap="flat" cmpd="sng" algn="ctr">
+                      <a:solidFill>
+                        <a:srgbClr val="D6E5E0"/>
+                      </a:solidFill>
+                      <a:prstDash val="solid"/>
+                      <a:round/>
+                      <a:headEnd type="none" w="med" len="med"/>
+                      <a:tailEnd type="none" w="med" len="med"/>
+                    </a:lnR>
+                    <a:lnT w="5715" cap="flat" cmpd="sng" algn="ctr">
+                      <a:solidFill>
+                        <a:srgbClr val="D6E5E0"/>
+                      </a:solidFill>
+                      <a:prstDash val="solid"/>
+                      <a:round/>
+                      <a:headEnd type="none" w="med" len="med"/>
+                      <a:tailEnd type="none" w="med" len="med"/>
+                    </a:lnT>
+                    <a:lnB w="5715" cap="flat" cmpd="sng" algn="ctr">
+                      <a:solidFill>
+                        <a:srgbClr val="D6E5E0"/>
+                      </a:solidFill>
+                      <a:prstDash val="solid"/>
+                      <a:round/>
+                      <a:headEnd type="none" w="med" len="med"/>
+                      <a:tailEnd type="none" w="med" len="med"/>
+                    </a:lnB>
+                    <a:solidFill>
+                      <a:srgbClr val="F3F8F6"/>
                     </a:solidFill>
                   </a:tcPr>
                 </a:tc>
               </a:tr>
-              <a:tr h="324343">
+              <a:tr h="306324">
                 <a:tc>
                   <a:txBody>
                     <a:bodyPr/>
@@ -4441,7 +5570,7 @@
                       <a:tailEnd type="none" w="med" len="med"/>
                     </a:lnB>
                     <a:solidFill>
-                      <a:srgbClr val="F3F8F6"/>
+                      <a:srgbClr val="FFFFFF"/>
                     </a:solidFill>
                   </a:tcPr>
                 </a:tc>
@@ -4459,7 +5588,7 @@
                             <a:srgbClr val="263B38"/>
                           </a:solidFill>
                         </a:rPr>
-                        <a:t>Callback execute apres chaque cycle de rendu DOM.</a:t>
+                        <a:t>Callback apres chaque rendu Angular.</a:t>
                       </a:r>
                       <a:endParaRPr lang="en-US" sz="740" dirty="0"/>
                     </a:p>
@@ -4502,12 +5631,73 @@
                       <a:tailEnd type="none" w="med" len="med"/>
                     </a:lnB>
                     <a:solidFill>
-                      <a:srgbClr val="F3F8F6"/>
+                      <a:srgbClr val="FFFFFF"/>
+                    </a:solidFill>
+                  </a:tcPr>
+                </a:tc>
+                <a:tc>
+                  <a:txBody>
+                    <a:bodyPr/>
+                    <a:lstStyle/>
+                    <a:p>
+                      <a:pPr indent="0" marL="0">
+                        <a:buNone/>
+                      </a:pPr>
+                      <a:r>
+                        <a:rPr lang="en-US" sz="740" dirty="0">
+                          <a:solidFill>
+                            <a:srgbClr val="263B38"/>
+                          </a:solidFill>
+                        </a:rPr>
+                        <a:t>signals-demo.component.ts</a:t>
+                      </a:r>
+                      <a:endParaRPr lang="en-US" sz="740" dirty="0"/>
+                    </a:p>
+                  </a:txBody>
+                  <a:tcPr marL="50800" marR="50800" marT="25400" marB="25400" anchor="mid">
+                    <a:lnL w="5715" cap="flat" cmpd="sng" algn="ctr">
+                      <a:solidFill>
+                        <a:srgbClr val="D6E5E0"/>
+                      </a:solidFill>
+                      <a:prstDash val="solid"/>
+                      <a:round/>
+                      <a:headEnd type="none" w="med" len="med"/>
+                      <a:tailEnd type="none" w="med" len="med"/>
+                    </a:lnL>
+                    <a:lnR w="5715" cap="flat" cmpd="sng" algn="ctr">
+                      <a:solidFill>
+                        <a:srgbClr val="D6E5E0"/>
+                      </a:solidFill>
+                      <a:prstDash val="solid"/>
+                      <a:round/>
+                      <a:headEnd type="none" w="med" len="med"/>
+                      <a:tailEnd type="none" w="med" len="med"/>
+                    </a:lnR>
+                    <a:lnT w="5715" cap="flat" cmpd="sng" algn="ctr">
+                      <a:solidFill>
+                        <a:srgbClr val="D6E5E0"/>
+                      </a:solidFill>
+                      <a:prstDash val="solid"/>
+                      <a:round/>
+                      <a:headEnd type="none" w="med" len="med"/>
+                      <a:tailEnd type="none" w="med" len="med"/>
+                    </a:lnT>
+                    <a:lnB w="5715" cap="flat" cmpd="sng" algn="ctr">
+                      <a:solidFill>
+                        <a:srgbClr val="D6E5E0"/>
+                      </a:solidFill>
+                      <a:prstDash val="solid"/>
+                      <a:round/>
+                      <a:headEnd type="none" w="med" len="med"/>
+                      <a:tailEnd type="none" w="med" len="med"/>
+                    </a:lnB>
+                    <a:solidFill>
+                      <a:srgbClr val="FFFFFF"/>
                     </a:solidFill>
                   </a:tcPr>
                 </a:tc>
               </a:tr>
-              <a:tr h="324343">
+              <a:tr h="306324">
                 <a:tc>
                   <a:txBody>
                     <a:bodyPr/>
@@ -4565,7 +5755,7 @@
                       <a:tailEnd type="none" w="med" len="med"/>
                     </a:lnB>
                     <a:solidFill>
-                      <a:srgbClr val="FFFFFF"/>
+                      <a:srgbClr val="F3F8F6"/>
                     </a:solidFill>
                   </a:tcPr>
                 </a:tc>
@@ -4583,7 +5773,7 @@
                             <a:srgbClr val="263B38"/>
                           </a:solidFill>
                         </a:rPr>
-                        <a:t>Lit un signal sans creer de dependance dans un effet ou computed.</a:t>
+                        <a:t>Lecture sans dependance reactive.</a:t>
                       </a:r>
                       <a:endParaRPr lang="en-US" sz="740" dirty="0"/>
                     </a:p>
@@ -4626,12 +5816,73 @@
                       <a:tailEnd type="none" w="med" len="med"/>
                     </a:lnB>
                     <a:solidFill>
-                      <a:srgbClr val="FFFFFF"/>
+                      <a:srgbClr val="F3F8F6"/>
+                    </a:solidFill>
+                  </a:tcPr>
+                </a:tc>
+                <a:tc>
+                  <a:txBody>
+                    <a:bodyPr/>
+                    <a:lstStyle/>
+                    <a:p>
+                      <a:pPr indent="0" marL="0">
+                        <a:buNone/>
+                      </a:pPr>
+                      <a:r>
+                        <a:rPr lang="en-US" sz="740" dirty="0">
+                          <a:solidFill>
+                            <a:srgbClr val="263B38"/>
+                          </a:solidFill>
+                        </a:rPr>
+                        <a:t>signals-demo.component.ts</a:t>
+                      </a:r>
+                      <a:endParaRPr lang="en-US" sz="740" dirty="0"/>
+                    </a:p>
+                  </a:txBody>
+                  <a:tcPr marL="50800" marR="50800" marT="25400" marB="25400" anchor="mid">
+                    <a:lnL w="5715" cap="flat" cmpd="sng" algn="ctr">
+                      <a:solidFill>
+                        <a:srgbClr val="D6E5E0"/>
+                      </a:solidFill>
+                      <a:prstDash val="solid"/>
+                      <a:round/>
+                      <a:headEnd type="none" w="med" len="med"/>
+                      <a:tailEnd type="none" w="med" len="med"/>
+                    </a:lnL>
+                    <a:lnR w="5715" cap="flat" cmpd="sng" algn="ctr">
+                      <a:solidFill>
+                        <a:srgbClr val="D6E5E0"/>
+                      </a:solidFill>
+                      <a:prstDash val="solid"/>
+                      <a:round/>
+                      <a:headEnd type="none" w="med" len="med"/>
+                      <a:tailEnd type="none" w="med" len="med"/>
+                    </a:lnR>
+                    <a:lnT w="5715" cap="flat" cmpd="sng" algn="ctr">
+                      <a:solidFill>
+                        <a:srgbClr val="D6E5E0"/>
+                      </a:solidFill>
+                      <a:prstDash val="solid"/>
+                      <a:round/>
+                      <a:headEnd type="none" w="med" len="med"/>
+                      <a:tailEnd type="none" w="med" len="med"/>
+                    </a:lnT>
+                    <a:lnB w="5715" cap="flat" cmpd="sng" algn="ctr">
+                      <a:solidFill>
+                        <a:srgbClr val="D6E5E0"/>
+                      </a:solidFill>
+                      <a:prstDash val="solid"/>
+                      <a:round/>
+                      <a:headEnd type="none" w="med" len="med"/>
+                      <a:tailEnd type="none" w="med" len="med"/>
+                    </a:lnB>
+                    <a:solidFill>
+                      <a:srgbClr val="F3F8F6"/>
                     </a:solidFill>
                   </a:tcPr>
                 </a:tc>
               </a:tr>
-              <a:tr h="324343">
+              <a:tr h="306324">
                 <a:tc>
                   <a:txBody>
                     <a:bodyPr/>
@@ -4689,7 +5940,7 @@
                       <a:tailEnd type="none" w="med" len="med"/>
                     </a:lnB>
                     <a:solidFill>
-                      <a:srgbClr val="F3F8F6"/>
+                      <a:srgbClr val="FFFFFF"/>
                     </a:solidFill>
                   </a:tcPr>
                 </a:tc>
@@ -4707,7 +5958,7 @@
                             <a:srgbClr val="263B38"/>
                           </a:solidFill>
                         </a:rPr>
-                        <a:t>Expose un signal interne sans son setter.</a:t>
+                        <a:t>Etat interne expose sans setter.</a:t>
                       </a:r>
                       <a:endParaRPr lang="en-US" sz="740" dirty="0"/>
                     </a:p>
@@ -4750,7 +6001,68 @@
                       <a:tailEnd type="none" w="med" len="med"/>
                     </a:lnB>
                     <a:solidFill>
-                      <a:srgbClr val="F3F8F6"/>
+                      <a:srgbClr val="FFFFFF"/>
+                    </a:solidFill>
+                  </a:tcPr>
+                </a:tc>
+                <a:tc>
+                  <a:txBody>
+                    <a:bodyPr/>
+                    <a:lstStyle/>
+                    <a:p>
+                      <a:pPr indent="0" marL="0">
+                        <a:buNone/>
+                      </a:pPr>
+                      <a:r>
+                        <a:rPr lang="en-US" sz="740" dirty="0">
+                          <a:solidFill>
+                            <a:srgbClr val="263B38"/>
+                          </a:solidFill>
+                        </a:rPr>
+                        <a:t>accounts.facade.ts</a:t>
+                      </a:r>
+                      <a:endParaRPr lang="en-US" sz="740" dirty="0"/>
+                    </a:p>
+                  </a:txBody>
+                  <a:tcPr marL="50800" marR="50800" marT="25400" marB="25400" anchor="mid">
+                    <a:lnL w="5715" cap="flat" cmpd="sng" algn="ctr">
+                      <a:solidFill>
+                        <a:srgbClr val="D6E5E0"/>
+                      </a:solidFill>
+                      <a:prstDash val="solid"/>
+                      <a:round/>
+                      <a:headEnd type="none" w="med" len="med"/>
+                      <a:tailEnd type="none" w="med" len="med"/>
+                    </a:lnL>
+                    <a:lnR w="5715" cap="flat" cmpd="sng" algn="ctr">
+                      <a:solidFill>
+                        <a:srgbClr val="D6E5E0"/>
+                      </a:solidFill>
+                      <a:prstDash val="solid"/>
+                      <a:round/>
+                      <a:headEnd type="none" w="med" len="med"/>
+                      <a:tailEnd type="none" w="med" len="med"/>
+                    </a:lnR>
+                    <a:lnT w="5715" cap="flat" cmpd="sng" algn="ctr">
+                      <a:solidFill>
+                        <a:srgbClr val="D6E5E0"/>
+                      </a:solidFill>
+                      <a:prstDash val="solid"/>
+                      <a:round/>
+                      <a:headEnd type="none" w="med" len="med"/>
+                      <a:tailEnd type="none" w="med" len="med"/>
+                    </a:lnT>
+                    <a:lnB w="5715" cap="flat" cmpd="sng" algn="ctr">
+                      <a:solidFill>
+                        <a:srgbClr val="D6E5E0"/>
+                      </a:solidFill>
+                      <a:prstDash val="solid"/>
+                      <a:round/>
+                      <a:headEnd type="none" w="med" len="med"/>
+                      <a:tailEnd type="none" w="med" len="med"/>
+                    </a:lnB>
+                    <a:solidFill>
+                      <a:srgbClr val="FFFFFF"/>
                     </a:solidFill>
                   </a:tcPr>
                 </a:tc>
@@ -4789,7 +6101,7 @@
                   <a:srgbClr val="61716F"/>
                 </a:solidFill>
               </a:rPr>
-              <a:t>10/16</a:t>
+              <a:t>10/17</a:t>
             </a:r>
             <a:endParaRPr lang="en-US" sz="700" dirty="0"/>
           </a:p>
@@ -5438,7 +6750,7 @@
                   <a:srgbClr val="008A5B"/>
                 </a:solidFill>
               </a:rPr>
-              <a:t>3 — effect()</a:t>
+              <a:t>3 — effect() + untracked()</a:t>
             </a:r>
             <a:endParaRPr lang="en-US" sz="820" dirty="0"/>
           </a:p>
@@ -5476,7 +6788,7 @@
                   <a:srgbClr val="61716F"/>
                 </a:solidFill>
               </a:rPr>
-              <a:t>Effet de bord declenche par les signals lus.</a:t>
+              <a:t>Effet de bord declenche par les signals lus, avec lecture non suivie.</a:t>
             </a:r>
             <a:endParaRPr lang="en-US" sz="680" dirty="0"/>
           </a:p>
@@ -5552,7 +6864,7 @@
                   <a:srgbClr val="263B38"/>
                 </a:solidFill>
               </a:rPr>
-              <a:t>Remplacer le recalage imperatif de la page courante par une reaction automatique. Quand la liste change, la page selectionnee doit rester valide.</a:t>
+              <a:t>Remplacer le recalage imperatif de la page courante par une reaction automatique. Lire la page courante avec untracked() pour ne pas l'ajouter aux dependances de l'effet.</a:t>
             </a:r>
             <a:endParaRPr lang="en-US" sz="680" dirty="0"/>
           </a:p>
@@ -6622,7 +7934,7 @@
                   <a:srgbClr val="61716F"/>
                 </a:solidFill>
               </a:rPr>
-              <a:t>11/16</a:t>
+              <a:t>11/17</a:t>
             </a:r>
             <a:endParaRPr lang="en-US" sz="700" dirty="0"/>
           </a:p>
@@ -7653,7 +8965,7 @@
                   <a:srgbClr val="61716F"/>
                 </a:solidFill>
               </a:rPr>
-              <a:t>12/16</a:t>
+              <a:t>12/17</a:t>
             </a:r>
             <a:endParaRPr lang="en-US" sz="700" dirty="0"/>
           </a:p>
@@ -7795,7 +9107,7 @@
                   <a:srgbClr val="61716F"/>
                 </a:solidFill>
               </a:rPr>
-              <a:t>13/16</a:t>
+              <a:t>13/17</a:t>
             </a:r>
             <a:endParaRPr lang="en-US" sz="700" dirty="0"/>
           </a:p>
@@ -7890,7 +9202,7 @@
                   <a:srgbClr val="1B2B2A"/>
                 </a:solidFill>
               </a:rPr>
-              <a:t>effect() — onCleanup</a:t>
+              <a:t>Références code — primitives avancées</a:t>
             </a:r>
             <a:endParaRPr lang="en-US" sz="2000" dirty="0"/>
           </a:p>
@@ -7938,9 +9250,395 @@
           </a:p>
         </p:txBody>
       </p:sp>
+      <p:sp>
+        <p:nvSpPr>
+          <p:cNvPr id="5" name="Text 3"/>
+          <p:cNvSpPr/>
+          <p:nvPr/>
+        </p:nvSpPr>
+        <p:spPr>
+          <a:xfrm>
+            <a:off x="411480" y="932688"/>
+            <a:ext cx="11368735" cy="429768"/>
+          </a:xfrm>
+          <a:prstGeom prst="rect">
+            <a:avLst/>
+          </a:prstGeom>
+          <a:noFill/>
+          <a:ln/>
+        </p:spPr>
+        <p:txBody>
+          <a:bodyPr wrap="square" lIns="254" tIns="254" rIns="254" bIns="254" rtlCol="0" anchor="t">
+            <a:normAutofit/>
+          </a:bodyPr>
+          <a:lstStyle/>
+          <a:p>
+            <a:pPr indent="0" marL="0">
+              <a:buNone/>
+            </a:pPr>
+            <a:r>
+              <a:rPr lang="en-US" sz="1220" dirty="0">
+                <a:solidFill>
+                  <a:srgbClr val="263B38"/>
+                </a:solidFill>
+              </a:rPr>
+              <a:t>src/app/features/signals-demo/signals-demo.component.ts contient des références rapides pour les primitives citées mais non exercées directement :</a:t>
+            </a:r>
+            <a:endParaRPr lang="en-US" sz="1220" dirty="0"/>
+          </a:p>
+        </p:txBody>
+      </p:sp>
+      <p:sp>
+        <p:nvSpPr>
+          <p:cNvPr id="6" name="Text 4"/>
+          <p:cNvSpPr/>
+          <p:nvPr/>
+        </p:nvSpPr>
+        <p:spPr>
+          <a:xfrm>
+            <a:off x="576072" y="1472184"/>
+            <a:ext cx="11204143" cy="256032"/>
+          </a:xfrm>
+          <a:prstGeom prst="rect">
+            <a:avLst/>
+          </a:prstGeom>
+          <a:noFill/>
+          <a:ln/>
+        </p:spPr>
+        <p:txBody>
+          <a:bodyPr wrap="square" lIns="127" tIns="127" rIns="127" bIns="127" rtlCol="0" anchor="ctr">
+            <a:normAutofit/>
+          </a:bodyPr>
+          <a:lstStyle/>
+          <a:p>
+            <a:r>
+              <a:rPr lang="en-US" sz="1160" dirty="0">
+                <a:solidFill>
+                  <a:srgbClr val="263B38"/>
+                </a:solidFill>
+              </a:rPr>
+              <a:t>untracked() : lire un signal sans créer de dépendance réactive.</a:t>
+            </a:r>
+            <a:endParaRPr lang="en-US" sz="1160" dirty="0"/>
+          </a:p>
+        </p:txBody>
+      </p:sp>
+      <p:sp>
+        <p:nvSpPr>
+          <p:cNvPr id="7" name="Text 5"/>
+          <p:cNvSpPr/>
+          <p:nvPr/>
+        </p:nvSpPr>
+        <p:spPr>
+          <a:xfrm>
+            <a:off x="576072" y="1783080"/>
+            <a:ext cx="11204143" cy="256032"/>
+          </a:xfrm>
+          <a:prstGeom prst="rect">
+            <a:avLst/>
+          </a:prstGeom>
+          <a:noFill/>
+          <a:ln/>
+        </p:spPr>
+        <p:txBody>
+          <a:bodyPr wrap="square" lIns="127" tIns="127" rIns="127" bIns="127" rtlCol="0" anchor="ctr">
+            <a:normAutofit/>
+          </a:bodyPr>
+          <a:lstStyle/>
+          <a:p>
+            <a:r>
+              <a:rPr lang="en-US" sz="1160" dirty="0">
+                <a:solidFill>
+                  <a:srgbClr val="263B38"/>
+                </a:solidFill>
+              </a:rPr>
+              <a:t>signal.asReadonly() : exposer un signal interne sans setter public.</a:t>
+            </a:r>
+            <a:endParaRPr lang="en-US" sz="1160" dirty="0"/>
+          </a:p>
+        </p:txBody>
+      </p:sp>
+      <p:sp>
+        <p:nvSpPr>
+          <p:cNvPr id="8" name="Text 6"/>
+          <p:cNvSpPr/>
+          <p:nvPr/>
+        </p:nvSpPr>
+        <p:spPr>
+          <a:xfrm>
+            <a:off x="576072" y="2093976"/>
+            <a:ext cx="11204143" cy="256032"/>
+          </a:xfrm>
+          <a:prstGeom prst="rect">
+            <a:avLst/>
+          </a:prstGeom>
+          <a:noFill/>
+          <a:ln/>
+        </p:spPr>
+        <p:txBody>
+          <a:bodyPr wrap="square" lIns="127" tIns="127" rIns="127" bIns="127" rtlCol="0" anchor="ctr">
+            <a:normAutofit/>
+          </a:bodyPr>
+          <a:lstStyle/>
+          <a:p>
+            <a:r>
+              <a:rPr lang="en-US" sz="1160" dirty="0">
+                <a:solidFill>
+                  <a:srgbClr val="263B38"/>
+                </a:solidFill>
+              </a:rPr>
+              <a:t>viewChildren() : récupérer toutes les instances rendues sous forme de signal.</a:t>
+            </a:r>
+            <a:endParaRPr lang="en-US" sz="1160" dirty="0"/>
+          </a:p>
+        </p:txBody>
+      </p:sp>
+      <p:sp>
+        <p:nvSpPr>
+          <p:cNvPr id="9" name="Text 7"/>
+          <p:cNvSpPr/>
+          <p:nvPr/>
+        </p:nvSpPr>
+        <p:spPr>
+          <a:xfrm>
+            <a:off x="576072" y="2404872"/>
+            <a:ext cx="11204143" cy="256032"/>
+          </a:xfrm>
+          <a:prstGeom prst="rect">
+            <a:avLst/>
+          </a:prstGeom>
+          <a:noFill/>
+          <a:ln/>
+        </p:spPr>
+        <p:txBody>
+          <a:bodyPr wrap="square" lIns="127" tIns="127" rIns="127" bIns="127" rtlCol="0" anchor="ctr">
+            <a:normAutofit/>
+          </a:bodyPr>
+          <a:lstStyle/>
+          <a:p>
+            <a:r>
+              <a:rPr lang="en-US" sz="1160" dirty="0">
+                <a:solidFill>
+                  <a:srgbClr val="263B38"/>
+                </a:solidFill>
+              </a:rPr>
+              <a:t>effect(onCleanup) : libérer timer, listener ou subscription.</a:t>
+            </a:r>
+            <a:endParaRPr lang="en-US" sz="1160" dirty="0"/>
+          </a:p>
+        </p:txBody>
+      </p:sp>
+      <p:sp>
+        <p:nvSpPr>
+          <p:cNvPr id="10" name="Text 8"/>
+          <p:cNvSpPr/>
+          <p:nvPr/>
+        </p:nvSpPr>
+        <p:spPr>
+          <a:xfrm>
+            <a:off x="576072" y="2715768"/>
+            <a:ext cx="11204143" cy="256032"/>
+          </a:xfrm>
+          <a:prstGeom prst="rect">
+            <a:avLst/>
+          </a:prstGeom>
+          <a:noFill/>
+          <a:ln/>
+        </p:spPr>
+        <p:txBody>
+          <a:bodyPr wrap="square" lIns="127" tIns="127" rIns="127" bIns="127" rtlCol="0" anchor="ctr">
+            <a:normAutofit/>
+          </a:bodyPr>
+          <a:lstStyle/>
+          <a:p>
+            <a:r>
+              <a:rPr lang="en-US" sz="1160" dirty="0">
+                <a:solidFill>
+                  <a:srgbClr val="263B38"/>
+                </a:solidFill>
+              </a:rPr>
+              <a:t>afterRender() : exécuter une mesure DOM après chaque rendu Angular.</a:t>
+            </a:r>
+            <a:endParaRPr lang="en-US" sz="1160" dirty="0"/>
+          </a:p>
+        </p:txBody>
+      </p:sp>
+      <p:sp>
+        <p:nvSpPr>
+          <p:cNvPr id="11" name="Text 9"/>
+          <p:cNvSpPr/>
+          <p:nvPr/>
+        </p:nvSpPr>
+        <p:spPr>
+          <a:xfrm>
+            <a:off x="11277295" y="6537960"/>
+            <a:ext cx="502920" cy="182880"/>
+          </a:xfrm>
+          <a:prstGeom prst="rect">
+            <a:avLst/>
+          </a:prstGeom>
+          <a:noFill/>
+          <a:ln/>
+        </p:spPr>
+        <p:txBody>
+          <a:bodyPr wrap="square" rtlCol="0" anchor="ctr"/>
+          <a:lstStyle/>
+          <a:p>
+            <a:pPr algn="r" indent="0" marL="0">
+              <a:buNone/>
+            </a:pPr>
+            <a:r>
+              <a:rPr lang="en-US" sz="700" dirty="0">
+                <a:solidFill>
+                  <a:srgbClr val="61716F"/>
+                </a:solidFill>
+              </a:rPr>
+              <a:t>14/17</a:t>
+            </a:r>
+            <a:endParaRPr lang="en-US" sz="700" dirty="0"/>
+          </a:p>
+        </p:txBody>
+      </p:sp>
+    </p:spTree>
+  </p:cSld>
+  <p:clrMapOvr>
+    <a:masterClrMapping/>
+  </p:clrMapOvr>
+</p:sld>
+</file>
+
+<file path=ppt/slides/slide15.xml><?xml version="1.0" encoding="utf-8"?>
+<p:sld xmlns:a="http://schemas.openxmlformats.org/drawingml/2006/main" xmlns:r="http://schemas.openxmlformats.org/officeDocument/2006/relationships" xmlns:p="http://schemas.openxmlformats.org/presentationml/2006/main">
+  <p:cSld name="Slide 15">
+    <p:bg>
+      <p:bgPr>
+        <a:solidFill>
+          <a:srgbClr val="F3F8F6"/>
+        </a:solidFill>
+      </p:bgPr>
+    </p:bg>
+    <p:spTree>
+      <p:nvGrpSpPr>
+        <p:cNvPr id="1" name=""/>
+        <p:cNvGrpSpPr/>
+        <p:nvPr/>
+      </p:nvGrpSpPr>
+      <p:grpSpPr>
+        <a:xfrm>
+          <a:off x="0" y="0"/>
+          <a:ext cx="0" cy="0"/>
+          <a:chOff x="0" y="0"/>
+          <a:chExt cx="0" cy="0"/>
+        </a:xfrm>
+      </p:grpSpPr>
+      <p:sp>
+        <p:nvSpPr>
+          <p:cNvPr id="2" name="Shape 0"/>
+          <p:cNvSpPr/>
+          <p:nvPr/>
+        </p:nvSpPr>
+        <p:spPr>
+          <a:xfrm>
+            <a:off x="0" y="0"/>
+            <a:ext cx="12191695" cy="91440"/>
+          </a:xfrm>
+          <a:prstGeom prst="rect">
+            <a:avLst/>
+          </a:prstGeom>
+          <a:solidFill>
+            <a:srgbClr val="008A5B"/>
+          </a:solidFill>
+          <a:ln w="12700">
+            <a:solidFill>
+              <a:srgbClr val="008A5B"/>
+            </a:solidFill>
+            <a:prstDash val="solid"/>
+          </a:ln>
+        </p:spPr>
+      </p:sp>
+      <p:sp>
+        <p:nvSpPr>
+          <p:cNvPr id="3" name="Text 1"/>
+          <p:cNvSpPr/>
+          <p:nvPr/>
+        </p:nvSpPr>
+        <p:spPr>
+          <a:xfrm>
+            <a:off x="411480" y="219456"/>
+            <a:ext cx="9357055" cy="347472"/>
+          </a:xfrm>
+          <a:prstGeom prst="rect">
+            <a:avLst/>
+          </a:prstGeom>
+          <a:noFill/>
+          <a:ln/>
+        </p:spPr>
+        <p:txBody>
+          <a:bodyPr wrap="square" lIns="0" tIns="0" rIns="0" bIns="0" rtlCol="0" anchor="ctr">
+            <a:normAutofit/>
+          </a:bodyPr>
+          <a:lstStyle/>
+          <a:p>
+            <a:pPr indent="0" marL="0">
+              <a:buNone/>
+            </a:pPr>
+            <a:r>
+              <a:rPr lang="en-US" sz="2000" b="1" dirty="0">
+                <a:solidFill>
+                  <a:srgbClr val="1B2B2A"/>
+                </a:solidFill>
+              </a:rPr>
+              <a:t>effect() — onCleanup</a:t>
+            </a:r>
+            <a:endParaRPr lang="en-US" sz="2000" dirty="0"/>
+          </a:p>
+        </p:txBody>
+      </p:sp>
+      <p:sp>
+        <p:nvSpPr>
+          <p:cNvPr id="4" name="Text 2"/>
+          <p:cNvSpPr/>
+          <p:nvPr/>
+        </p:nvSpPr>
+        <p:spPr>
+          <a:xfrm>
+            <a:off x="10317175" y="246888"/>
+            <a:ext cx="1463040" cy="219456"/>
+          </a:xfrm>
+          <a:prstGeom prst="rect">
+            <a:avLst/>
+          </a:prstGeom>
+          <a:solidFill>
+            <a:srgbClr val="CFEDE2"/>
+          </a:solidFill>
+          <a:ln>
+            <a:solidFill>
+              <a:srgbClr val="CFEDE2"/>
+            </a:solidFill>
+          </a:ln>
+        </p:spPr>
+        <p:txBody>
+          <a:bodyPr wrap="square" lIns="254" tIns="254" rIns="254" bIns="254" rtlCol="0" anchor="ctr"/>
+          <a:lstStyle/>
+          <a:p>
+            <a:pPr algn="ctr" indent="0" marL="0">
+              <a:buNone/>
+            </a:pPr>
+            <a:r>
+              <a:rPr lang="en-US" sz="800" b="1" dirty="0">
+                <a:solidFill>
+                  <a:srgbClr val="008A5B"/>
+                </a:solidFill>
+              </a:rPr>
+              <a:t>BNP Paribas</a:t>
+            </a:r>
+            <a:endParaRPr lang="en-US" sz="800" dirty="0"/>
+          </a:p>
+        </p:txBody>
+      </p:sp>
       <p:graphicFrame>
         <p:nvGraphicFramePr>
-          <p:cNvPr id="15" name="Table 0"/>
+          <p:cNvPr id="16" name="Table 0"/>
           <p:cNvGraphicFramePr>
             <a:graphicFrameLocks noGrp="1"/>
           </p:cNvGraphicFramePr>
@@ -8340,7 +10038,7 @@
                   <a:srgbClr val="61716F"/>
                 </a:solidFill>
               </a:rPr>
-              <a:t>14/16</a:t>
+              <a:t>15/17</a:t>
             </a:r>
             <a:endParaRPr lang="en-US" sz="700" dirty="0"/>
           </a:p>
@@ -8354,9 +10052,9 @@
 </p:sld>
 </file>
 
-<file path=ppt/slides/slide15.xml><?xml version="1.0" encoding="utf-8"?>
+<file path=ppt/slides/slide16.xml><?xml version="1.0" encoding="utf-8"?>
 <p:sld xmlns:a="http://schemas.openxmlformats.org/drawingml/2006/main" xmlns:r="http://schemas.openxmlformats.org/officeDocument/2006/relationships" xmlns:p="http://schemas.openxmlformats.org/presentationml/2006/main">
-  <p:cSld name="Slide 15">
+  <p:cSld name="Slide 16">
     <p:bg>
       <p:bgPr>
         <a:solidFill>
@@ -8485,7 +10183,7 @@
       </p:sp>
       <p:graphicFrame>
         <p:nvGraphicFramePr>
-          <p:cNvPr id="16" name="Table 0"/>
+          <p:cNvPr id="17" name="Table 0"/>
           <p:cNvGraphicFramePr>
             <a:graphicFrameLocks noGrp="1"/>
           </p:cNvGraphicFramePr>
@@ -9376,7 +11074,7 @@
                   <a:srgbClr val="61716F"/>
                 </a:solidFill>
               </a:rPr>
-              <a:t>15/16</a:t>
+              <a:t>16/17</a:t>
             </a:r>
             <a:endParaRPr lang="en-US" sz="700" dirty="0"/>
           </a:p>
@@ -9390,9 +11088,9 @@
 </p:sld>
 </file>
 
-<file path=ppt/slides/slide16.xml><?xml version="1.0" encoding="utf-8"?>
+<file path=ppt/slides/slide17.xml><?xml version="1.0" encoding="utf-8"?>
 <p:sld xmlns:a="http://schemas.openxmlformats.org/drawingml/2006/main" xmlns:r="http://schemas.openxmlformats.org/officeDocument/2006/relationships" xmlns:p="http://schemas.openxmlformats.org/presentationml/2006/main">
-  <p:cSld name="Slide 16">
+  <p:cSld name="Slide 17">
     <p:bg>
       <p:bgPr>
         <a:solidFill>
@@ -10121,7 +11819,7 @@
                   <a:srgbClr val="61716F"/>
                 </a:solidFill>
               </a:rPr>
-              <a:t>16/16</a:t>
+              <a:t>17/17</a:t>
             </a:r>
             <a:endParaRPr lang="en-US" sz="700" dirty="0"/>
           </a:p>
@@ -10696,7 +12394,7 @@
                   <a:srgbClr val="61716F"/>
                 </a:solidFill>
               </a:rPr>
-              <a:t>2/16</a:t>
+              <a:t>2/17</a:t>
             </a:r>
             <a:endParaRPr lang="en-US" sz="700" dirty="0"/>
           </a:p>
@@ -11119,7 +12817,7 @@
                   <a:srgbClr val="61716F"/>
                 </a:solidFill>
               </a:rPr>
-              <a:t>3/16</a:t>
+              <a:t>3/17</a:t>
             </a:r>
             <a:endParaRPr lang="en-US" sz="700" dirty="0"/>
           </a:p>
@@ -11694,7 +13392,7 @@
                   <a:srgbClr val="61716F"/>
                 </a:solidFill>
               </a:rPr>
-              <a:t>4/16</a:t>
+              <a:t>4/17</a:t>
             </a:r>
             <a:endParaRPr lang="en-US" sz="700" dirty="0"/>
           </a:p>
@@ -12117,7 +13815,7 @@
                   <a:srgbClr val="61716F"/>
                 </a:solidFill>
               </a:rPr>
-              <a:t>5/16</a:t>
+              <a:t>5/17</a:t>
             </a:r>
             <a:endParaRPr lang="en-US" sz="700" dirty="0"/>
           </a:p>
@@ -12692,7 +14390,7 @@
                   <a:srgbClr val="61716F"/>
                 </a:solidFill>
               </a:rPr>
-              <a:t>6/16</a:t>
+              <a:t>6/17</a:t>
             </a:r>
             <a:endParaRPr lang="en-US" sz="700" dirty="0"/>
           </a:p>
@@ -13115,7 +14813,7 @@
                   <a:srgbClr val="61716F"/>
                 </a:solidFill>
               </a:rPr>
-              <a:t>7/16</a:t>
+              <a:t>7/17</a:t>
             </a:r>
             <a:endParaRPr lang="en-US" sz="700" dirty="0"/>
           </a:p>
@@ -14644,7 +16342,7 @@
                   <a:srgbClr val="61716F"/>
                 </a:solidFill>
               </a:rPr>
-              <a:t>8/16</a:t>
+              <a:t>8/17</a:t>
             </a:r>
             <a:endParaRPr lang="en-US" sz="700" dirty="0"/>
           </a:p>
@@ -14887,8 +16585,14 @@
                 <a:ea typeface="Courier New" pitchFamily="34" charset="-122"/>
                 <a:cs typeface="Courier New" pitchFamily="34" charset="-120"/>
               </a:rPr>
-              <a:t>init</a:t>
-            </a:r>
+              <a:t>main : support de présentation et documentation</a:t>
+            </a:r>
+            <a:endParaRPr lang="en-US" sz="1900" dirty="0"/>
+          </a:p>
+          <a:p>
+            <a:pPr indent="0" marL="0">
+              <a:buNone/>
+            </a:pPr>
             <a:endParaRPr lang="en-US" sz="1900" dirty="0"/>
           </a:p>
           <a:p>
@@ -14904,7 +16608,7 @@
                 <a:ea typeface="Courier New" pitchFamily="34" charset="-122"/>
                 <a:cs typeface="Courier New" pitchFamily="34" charset="-120"/>
               </a:rPr>
-              <a:t>`-- exercice-1</a:t>
+              <a:t>init -&gt; ex1 -&gt; ex2 -&gt; ex3 -&gt; ex4 -&gt; ex5 -&gt; ex6</a:t>
             </a:r>
             <a:endParaRPr lang="en-US" sz="1900" dirty="0"/>
           </a:p>
@@ -14921,160 +16625,7 @@
                 <a:ea typeface="Courier New" pitchFamily="34" charset="-122"/>
                 <a:cs typeface="Courier New" pitchFamily="34" charset="-120"/>
               </a:rPr>
-              <a:t>    `-- exercice-2</a:t>
-            </a:r>
-            <a:endParaRPr lang="en-US" sz="1900" dirty="0"/>
-          </a:p>
-          <a:p>
-            <a:pPr indent="0" marL="0">
-              <a:buNone/>
-            </a:pPr>
-            <a:r>
-              <a:rPr lang="en-US" sz="1900" b="1" dirty="0">
-                <a:solidFill>
-                  <a:srgbClr val="F8FAFC"/>
-                </a:solidFill>
-                <a:latin typeface="Courier New" pitchFamily="34" charset="0"/>
-                <a:ea typeface="Courier New" pitchFamily="34" charset="-122"/>
-                <a:cs typeface="Courier New" pitchFamily="34" charset="-120"/>
-              </a:rPr>
-              <a:t>        `-- exercice-3</a:t>
-            </a:r>
-            <a:endParaRPr lang="en-US" sz="1900" dirty="0"/>
-          </a:p>
-          <a:p>
-            <a:pPr indent="0" marL="0">
-              <a:buNone/>
-            </a:pPr>
-            <a:r>
-              <a:rPr lang="en-US" sz="1900" b="1" dirty="0">
-                <a:solidFill>
-                  <a:srgbClr val="F8FAFC"/>
-                </a:solidFill>
-                <a:latin typeface="Courier New" pitchFamily="34" charset="0"/>
-                <a:ea typeface="Courier New" pitchFamily="34" charset="-122"/>
-                <a:cs typeface="Courier New" pitchFamily="34" charset="-120"/>
-              </a:rPr>
-              <a:t>            `-- exercice-4</a:t>
-            </a:r>
-            <a:endParaRPr lang="en-US" sz="1900" dirty="0"/>
-          </a:p>
-          <a:p>
-            <a:pPr indent="0" marL="0">
-              <a:buNone/>
-            </a:pPr>
-            <a:r>
-              <a:rPr lang="en-US" sz="1900" b="1" dirty="0">
-                <a:solidFill>
-                  <a:srgbClr val="F8FAFC"/>
-                </a:solidFill>
-                <a:latin typeface="Courier New" pitchFamily="34" charset="0"/>
-                <a:ea typeface="Courier New" pitchFamily="34" charset="-122"/>
-                <a:cs typeface="Courier New" pitchFamily="34" charset="-120"/>
-              </a:rPr>
-              <a:t>                `-- exercice-5</a:t>
-            </a:r>
-            <a:endParaRPr lang="en-US" sz="1900" dirty="0"/>
-          </a:p>
-          <a:p>
-            <a:pPr indent="0" marL="0">
-              <a:buNone/>
-            </a:pPr>
-            <a:r>
-              <a:rPr lang="en-US" sz="1900" b="1" dirty="0">
-                <a:solidFill>
-                  <a:srgbClr val="F8FAFC"/>
-                </a:solidFill>
-                <a:latin typeface="Courier New" pitchFamily="34" charset="0"/>
-                <a:ea typeface="Courier New" pitchFamily="34" charset="-122"/>
-                <a:cs typeface="Courier New" pitchFamily="34" charset="-120"/>
-              </a:rPr>
-              <a:t>                    `-- exercice-6</a:t>
-            </a:r>
-            <a:endParaRPr lang="en-US" sz="1900" dirty="0"/>
-          </a:p>
-          <a:p>
-            <a:pPr indent="0" marL="0">
-              <a:buNone/>
-            </a:pPr>
-            <a:r>
-              <a:rPr lang="en-US" sz="1900" b="1" dirty="0">
-                <a:solidFill>
-                  <a:srgbClr val="F8FAFC"/>
-                </a:solidFill>
-                <a:latin typeface="Courier New" pitchFamily="34" charset="0"/>
-                <a:ea typeface="Courier New" pitchFamily="34" charset="-122"/>
-                <a:cs typeface="Courier New" pitchFamily="34" charset="-120"/>
-              </a:rPr>
-              <a:t>                        `-- exercice-7</a:t>
-            </a:r>
-            <a:endParaRPr lang="en-US" sz="1900" dirty="0"/>
-          </a:p>
-          <a:p>
-            <a:pPr indent="0" marL="0">
-              <a:buNone/>
-            </a:pPr>
-            <a:r>
-              <a:rPr lang="en-US" sz="1900" b="1" dirty="0">
-                <a:solidFill>
-                  <a:srgbClr val="F8FAFC"/>
-                </a:solidFill>
-                <a:latin typeface="Courier New" pitchFamily="34" charset="0"/>
-                <a:ea typeface="Courier New" pitchFamily="34" charset="-122"/>
-                <a:cs typeface="Courier New" pitchFamily="34" charset="-120"/>
-              </a:rPr>
-              <a:t>                            `-- exercice-8</a:t>
-            </a:r>
-            <a:endParaRPr lang="en-US" sz="1900" dirty="0"/>
-          </a:p>
-          <a:p>
-            <a:pPr indent="0" marL="0">
-              <a:buNone/>
-            </a:pPr>
-            <a:r>
-              <a:rPr lang="en-US" sz="1900" b="1" dirty="0">
-                <a:solidFill>
-                  <a:srgbClr val="F8FAFC"/>
-                </a:solidFill>
-                <a:latin typeface="Courier New" pitchFamily="34" charset="0"/>
-                <a:ea typeface="Courier New" pitchFamily="34" charset="-122"/>
-                <a:cs typeface="Courier New" pitchFamily="34" charset="-120"/>
-              </a:rPr>
-              <a:t>                                `-- exercice-9</a:t>
-            </a:r>
-            <a:endParaRPr lang="en-US" sz="1900" dirty="0"/>
-          </a:p>
-          <a:p>
-            <a:pPr indent="0" marL="0">
-              <a:buNone/>
-            </a:pPr>
-            <a:r>
-              <a:rPr lang="en-US" sz="1900" b="1" dirty="0">
-                <a:solidFill>
-                  <a:srgbClr val="F8FAFC"/>
-                </a:solidFill>
-                <a:latin typeface="Courier New" pitchFamily="34" charset="0"/>
-                <a:ea typeface="Courier New" pitchFamily="34" charset="-122"/>
-                <a:cs typeface="Courier New" pitchFamily="34" charset="-120"/>
-              </a:rPr>
-              <a:t>                                    `-- exercice-10</a:t>
-            </a:r>
-            <a:endParaRPr lang="en-US" sz="1900" dirty="0"/>
-          </a:p>
-          <a:p>
-            <a:pPr indent="0" marL="0">
-              <a:buNone/>
-            </a:pPr>
-            <a:r>
-              <a:rPr lang="en-US" sz="1900" b="1" dirty="0">
-                <a:solidFill>
-                  <a:srgbClr val="F8FAFC"/>
-                </a:solidFill>
-                <a:latin typeface="Courier New" pitchFamily="34" charset="0"/>
-                <a:ea typeface="Courier New" pitchFamily="34" charset="-122"/>
-                <a:cs typeface="Courier New" pitchFamily="34" charset="-120"/>
-              </a:rPr>
-              <a:t>                                        `-- exercice-11</a:t>
+              <a:t>     -&gt; ex6-model -&gt; ex7 -&gt; ex8 -&gt; ex9 -&gt; ex10 -&gt; ex11</a:t>
             </a:r>
             <a:endParaRPr lang="en-US" sz="1900" dirty="0"/>
           </a:p>
@@ -15148,7 +16699,7 @@
                   <a:srgbClr val="61716F"/>
                 </a:solidFill>
               </a:rPr>
-              <a:t>9/16</a:t>
+              <a:t>9/17</a:t>
             </a:r>
             <a:endParaRPr lang="en-US" sz="700" dirty="0"/>
           </a:p>

</xml_diff>

<commit_message>
mets a jour les slides du dojo
</commit_message>
<xml_diff>
--- a/docs/dojo-signals.pptx
+++ b/docs/dojo-signals.pptx
@@ -21,10 +21,9 @@
     <p:sldId id="269" r:id="rId15"/>
     <p:sldId id="270" r:id="rId16"/>
     <p:sldId id="271" r:id="rId17"/>
-    <p:sldId id="272" r:id="rId18"/>
   </p:sldIdLst>
   <p:notesMasterIdLst>
-    <p:notesMasterId r:id="rId19"/>
+    <p:notesMasterId r:id="rId18"/>
   </p:notesMasterIdLst>
   <p:sldSz cx="12192000" cy="6858000"/>
   <p:notesSz cx="6858000" cy="12192000"/>
@@ -1046,7 +1045,7 @@
           <a:p>
             <a:r>
               <a:rPr lang="en-US" dirty="0"/>
-              <a:t/>
+              <a:t>En Zoneless, afterRender() ne se declenche que quand un signal change — beaucoup plus previsible qu'en Zone.js.</a:t>
             </a:r>
             <a:endParaRPr lang="en-US" dirty="0"/>
           </a:p>
@@ -1134,7 +1133,7 @@
           <a:p>
             <a:r>
               <a:rPr lang="en-US" dirty="0"/>
-              <a:t>En Zoneless, afterRender() ne se declenche que quand un signal change — beaucoup plus previsible qu'en Zone.js.</a:t>
+              <a:t/>
             </a:r>
             <a:endParaRPr lang="en-US" dirty="0"/>
           </a:p>
@@ -1158,94 +1157,6 @@
             <a:fld id="{F7021451-1387-4CA6-816F-3879F97B5CBC}" type="slidenum">
               <a:rPr lang="en-US"/>
               <a:t>16</a:t>
-            </a:fld>
-            <a:endParaRPr lang="en-US"/>
-          </a:p>
-        </p:txBody>
-      </p:sp>
-    </p:spTree>
-    <p:extLst>
-      <p:ext uri="{BB962C8B-B14F-4D97-AF65-F5344CB8AC3E}">
-        <p14:creationId xmlns:p14="http://schemas.microsoft.com/office/powerpoint/2010/main" val="1024086991"/>
-      </p:ext>
-    </p:extLst>
-  </p:cSld>
-  <p:clrMapOvr>
-    <a:masterClrMapping/>
-  </p:clrMapOvr>
-</p:notes>
-</file>
-
-<file path=ppt/notesSlides/notesSlide17.xml><?xml version="1.0" encoding="utf-8"?>
-<p:notes xmlns:a="http://schemas.openxmlformats.org/drawingml/2006/main" xmlns:r="http://schemas.openxmlformats.org/officeDocument/2006/relationships" xmlns:p="http://schemas.openxmlformats.org/presentationml/2006/main">
-  <p:cSld>
-    <p:spTree>
-      <p:nvGrpSpPr>
-        <p:cNvPr id="1" name=""/>
-        <p:cNvGrpSpPr/>
-        <p:nvPr/>
-      </p:nvGrpSpPr>
-      <p:grpSpPr>
-        <a:xfrm>
-          <a:off x="0" y="0"/>
-          <a:ext cx="0" cy="0"/>
-          <a:chOff x="0" y="0"/>
-          <a:chExt cx="0" cy="0"/>
-        </a:xfrm>
-      </p:grpSpPr>
-      <p:sp>
-        <p:nvSpPr>
-          <p:cNvPr id="2" name="Slide Image Placeholder 1"/>
-          <p:cNvSpPr>
-            <a:spLocks noGrp="1" noRot="1" noChangeAspect="1"/>
-          </p:cNvSpPr>
-          <p:nvPr>
-            <p:ph type="sldImg"/>
-          </p:nvPr>
-        </p:nvSpPr>
-        <p:spPr/>
-      </p:sp>
-      <p:sp>
-        <p:nvSpPr>
-          <p:cNvPr id="3" name="Notes Placeholder 2"/>
-          <p:cNvSpPr>
-            <a:spLocks noGrp="1"/>
-          </p:cNvSpPr>
-          <p:nvPr>
-            <p:ph type="body" idx="1"/>
-          </p:nvPr>
-        </p:nvSpPr>
-        <p:spPr/>
-        <p:txBody>
-          <a:bodyPr/>
-          <a:lstStyle/>
-          <a:p>
-            <a:r>
-              <a:rPr lang="en-US" dirty="0"/>
-              <a:t/>
-            </a:r>
-            <a:endParaRPr lang="en-US" dirty="0"/>
-          </a:p>
-        </p:txBody>
-      </p:sp>
-      <p:sp>
-        <p:nvSpPr>
-          <p:cNvPr id="4" name="Slide Number Placeholder 3"/>
-          <p:cNvSpPr>
-            <a:spLocks noGrp="1"/>
-          </p:cNvSpPr>
-          <p:nvPr>
-            <p:ph type="sldNum" sz="quarter" idx="10"/>
-          </p:nvPr>
-        </p:nvSpPr>
-        <p:spPr/>
-        <p:txBody>
-          <a:bodyPr/>
-          <a:lstStyle/>
-          <a:p>
-            <a:fld id="{F7021451-1387-4CA6-816F-3879F97B5CBC}" type="slidenum">
-              <a:rPr lang="en-US"/>
-              <a:t>17</a:t>
             </a:fld>
             <a:endParaRPr lang="en-US"/>
           </a:p>
@@ -2567,7 +2478,7 @@
                   <a:srgbClr val="61716F"/>
                 </a:solidFill>
               </a:rPr>
-              <a:t>1/17</a:t>
+              <a:t>1/16</a:t>
             </a:r>
             <a:endParaRPr lang="en-US" sz="700" dirty="0"/>
           </a:p>
@@ -2998,7 +2909,7 @@
                             <a:srgbClr val="263B38"/>
                           </a:solidFill>
                         </a:rPr>
-                        <a:t>Valeur reactive mutable. Source de verite locale.</a:t>
+                        <a:t>Etat mutable local. Se lit avec () et se modifie avec .set() ou .update().</a:t>
                       </a:r>
                       <a:endParaRPr lang="en-US" sz="740" dirty="0"/>
                     </a:p>
@@ -3183,7 +3094,7 @@
                             <a:srgbClr val="263B38"/>
                           </a:solidFill>
                         </a:rPr>
-                        <a:t>Valeur derivee en lecture seule.</a:t>
+                        <a:t>Valeur derivee pure, mise en cache, recalculee quand ses signaux lus changent.</a:t>
                       </a:r>
                       <a:endParaRPr lang="en-US" sz="740" dirty="0"/>
                     </a:p>
@@ -3368,7 +3279,7 @@
                             <a:srgbClr val="263B38"/>
                           </a:solidFill>
                         </a:rPr>
-                        <a:t>Effet de bord sur dependances signal.</a:t>
+                        <a:t>Effet de bord reactif. Sert a synchroniser DOM, titre, page courante, etc.</a:t>
                       </a:r>
                       <a:endParaRPr lang="en-US" sz="740" dirty="0"/>
                     </a:p>
@@ -3553,7 +3464,7 @@
                             <a:srgbClr val="263B38"/>
                           </a:solidFill>
                         </a:rPr>
-                        <a:t>Libere timer, listener ou subscription.</a:t>
+                        <a:t>Variante d'effet qui libere une ressource avant reexecution ou destruction.</a:t>
                       </a:r>
                       <a:endParaRPr lang="en-US" sz="740" dirty="0"/>
                     </a:p>
@@ -3738,7 +3649,7 @@
                             <a:srgbClr val="263B38"/>
                           </a:solidFill>
                         </a:rPr>
-                        <a:t>Reference reactive a un element DOM.</a:t>
+                        <a:t>Reference DOM ou composant enfant exposee comme signal nullable.</a:t>
                       </a:r>
                       <a:endParaRPr lang="en-US" sz="740" dirty="0"/>
                     </a:p>
@@ -3923,7 +3834,7 @@
                             <a:srgbClr val="263B38"/>
                           </a:solidFill>
                         </a:rPr>
-                        <a:t>Liste reactive de references rendues.</a:t>
+                        <a:t>Liste reactive de references rendues, mise a jour avec le template.</a:t>
                       </a:r>
                       <a:endParaRPr lang="en-US" sz="740" dirty="0"/>
                     </a:p>
@@ -4108,7 +4019,7 @@
                             <a:srgbClr val="263B38"/>
                           </a:solidFill>
                         </a:rPr>
-                        <a:t>Prop en lecture seule exposee comme signal.</a:t>
+                        <a:t>Entree de composant en lecture seule, utilisable dans computed().</a:t>
                       </a:r>
                       <a:endParaRPr lang="en-US" sz="740" dirty="0"/>
                     </a:p>
@@ -4293,7 +4204,7 @@
                             <a:srgbClr val="263B38"/>
                           </a:solidFill>
                         </a:rPr>
-                        <a:t>Evenement sortant vers le parent.</a:t>
+                        <a:t>Evenement sortant vers le parent. Exprime une intention, pas un etat.</a:t>
                       </a:r>
                       <a:endParaRPr lang="en-US" sz="740" dirty="0"/>
                     </a:p>
@@ -4478,7 +4389,7 @@
                             <a:srgbClr val="263B38"/>
                           </a:solidFill>
                         </a:rPr>
-                        <a:t>Valeur bidirectionnelle input + output.</a:t>
+                        <a:t>Valeur bidirectionnelle explicite : input + output pour selection, toggle, formulaire.</a:t>
                       </a:r>
                       <a:endParaRPr lang="en-US" sz="740" dirty="0"/>
                     </a:p>
@@ -4663,7 +4574,7 @@
                             <a:srgbClr val="263B38"/>
                           </a:solidFill>
                         </a:rPr>
-                        <a:t>Signal mutable derive d'une source.</a:t>
+                        <a:t>Signal writable initialise depuis une source et modifiable localement.</a:t>
                       </a:r>
                       <a:endParaRPr lang="en-US" sz="740" dirty="0"/>
                     </a:p>
@@ -4848,7 +4759,7 @@
                             <a:srgbClr val="263B38"/>
                           </a:solidFill>
                         </a:rPr>
-                        <a:t>Observable vers signal.</a:t>
+                        <a:t>Consomme la derniere valeur d'un Observable sous forme de signal.</a:t>
                       </a:r>
                       <a:endParaRPr lang="en-US" sz="740" dirty="0"/>
                     </a:p>
@@ -5033,7 +4944,7 @@
                             <a:srgbClr val="263B38"/>
                           </a:solidFill>
                         </a:rPr>
-                        <a:t>Signal vers Observable RxJS.</a:t>
+                        <a:t>Expose un signal en Observable pour utiliser les operateurs RxJS.</a:t>
                       </a:r>
                       <a:endParaRPr lang="en-US" sz="740" dirty="0"/>
                     </a:p>
@@ -5218,7 +5129,7 @@
                             <a:srgbClr val="263B38"/>
                           </a:solidFill>
                         </a:rPr>
-                        <a:t>Chargement async avec loading/error/value.</a:t>
+                        <a:t>Ressource async basee Observable, avec value, isLoading et error.</a:t>
                       </a:r>
                       <a:endParaRPr lang="en-US" sz="740" dirty="0"/>
                     </a:p>
@@ -5403,7 +5314,7 @@
                             <a:srgbClr val="263B38"/>
                           </a:solidFill>
                         </a:rPr>
-                        <a:t>Callback one-shot apres prochain rendu.</a:t>
+                        <a:t>Callback one-shot apres le prochain rendu DOM. Utile pour scroll ou focus post-action.</a:t>
                       </a:r>
                       <a:endParaRPr lang="en-US" sz="740" dirty="0"/>
                     </a:p>
@@ -5588,7 +5499,7 @@
                             <a:srgbClr val="263B38"/>
                           </a:solidFill>
                         </a:rPr>
-                        <a:t>Callback apres chaque rendu Angular.</a:t>
+                        <a:t>Callback recurrent apres chaque rendu Angular. Utile pour mesures DOM continues.</a:t>
                       </a:r>
                       <a:endParaRPr lang="en-US" sz="740" dirty="0"/>
                     </a:p>
@@ -5773,7 +5684,7 @@
                             <a:srgbClr val="263B38"/>
                           </a:solidFill>
                         </a:rPr>
-                        <a:t>Lecture sans dependance reactive.</a:t>
+                        <a:t>Lit un signal sans l'ajouter aux dependances d'un effect() ou computed().</a:t>
                       </a:r>
                       <a:endParaRPr lang="en-US" sz="740" dirty="0"/>
                     </a:p>
@@ -5834,7 +5745,7 @@
                             <a:srgbClr val="263B38"/>
                           </a:solidFill>
                         </a:rPr>
-                        <a:t>signals-demo.component.ts</a:t>
+                        <a:t>clients.component.ts</a:t>
                       </a:r>
                       <a:endParaRPr lang="en-US" sz="740" dirty="0"/>
                     </a:p>
@@ -5958,7 +5869,7 @@
                             <a:srgbClr val="263B38"/>
                           </a:solidFill>
                         </a:rPr>
-                        <a:t>Etat interne expose sans setter.</a:t>
+                        <a:t>Expose un etat interne sans donner acces au setter public.</a:t>
                       </a:r>
                       <a:endParaRPr lang="en-US" sz="740" dirty="0"/>
                     </a:p>
@@ -6101,7 +6012,7 @@
                   <a:srgbClr val="61716F"/>
                 </a:solidFill>
               </a:rPr>
-              <a:t>10/17</a:t>
+              <a:t>10/16</a:t>
             </a:r>
             <a:endParaRPr lang="en-US" sz="700" dirty="0"/>
           </a:p>
@@ -7934,7 +7845,7 @@
                   <a:srgbClr val="61716F"/>
                 </a:solidFill>
               </a:rPr>
-              <a:t>11/17</a:t>
+              <a:t>11/16</a:t>
             </a:r>
             <a:endParaRPr lang="en-US" sz="700" dirty="0"/>
           </a:p>
@@ -8965,7 +8876,7 @@
                   <a:srgbClr val="61716F"/>
                 </a:solidFill>
               </a:rPr>
-              <a:t>12/17</a:t>
+              <a:t>12/16</a:t>
             </a:r>
             <a:endParaRPr lang="en-US" sz="700" dirty="0"/>
           </a:p>
@@ -9107,7 +9018,7 @@
                   <a:srgbClr val="61716F"/>
                 </a:solidFill>
               </a:rPr>
-              <a:t>13/17</a:t>
+              <a:t>13/16</a:t>
             </a:r>
             <a:endParaRPr lang="en-US" sz="700" dirty="0"/>
           </a:p>
@@ -9202,7 +9113,7 @@
                   <a:srgbClr val="1B2B2A"/>
                 </a:solidFill>
               </a:rPr>
-              <a:t>Références code — primitives avancées</a:t>
+              <a:t>effect() — onCleanup</a:t>
             </a:r>
             <a:endParaRPr lang="en-US" sz="2000" dirty="0"/>
           </a:p>
@@ -9250,395 +9161,9 @@
           </a:p>
         </p:txBody>
       </p:sp>
-      <p:sp>
-        <p:nvSpPr>
-          <p:cNvPr id="5" name="Text 3"/>
-          <p:cNvSpPr/>
-          <p:nvPr/>
-        </p:nvSpPr>
-        <p:spPr>
-          <a:xfrm>
-            <a:off x="411480" y="932688"/>
-            <a:ext cx="11368735" cy="429768"/>
-          </a:xfrm>
-          <a:prstGeom prst="rect">
-            <a:avLst/>
-          </a:prstGeom>
-          <a:noFill/>
-          <a:ln/>
-        </p:spPr>
-        <p:txBody>
-          <a:bodyPr wrap="square" lIns="254" tIns="254" rIns="254" bIns="254" rtlCol="0" anchor="t">
-            <a:normAutofit/>
-          </a:bodyPr>
-          <a:lstStyle/>
-          <a:p>
-            <a:pPr indent="0" marL="0">
-              <a:buNone/>
-            </a:pPr>
-            <a:r>
-              <a:rPr lang="en-US" sz="1220" dirty="0">
-                <a:solidFill>
-                  <a:srgbClr val="263B38"/>
-                </a:solidFill>
-              </a:rPr>
-              <a:t>src/app/features/signals-demo/signals-demo.component.ts contient des références rapides pour les primitives citées mais non exercées directement :</a:t>
-            </a:r>
-            <a:endParaRPr lang="en-US" sz="1220" dirty="0"/>
-          </a:p>
-        </p:txBody>
-      </p:sp>
-      <p:sp>
-        <p:nvSpPr>
-          <p:cNvPr id="6" name="Text 4"/>
-          <p:cNvSpPr/>
-          <p:nvPr/>
-        </p:nvSpPr>
-        <p:spPr>
-          <a:xfrm>
-            <a:off x="576072" y="1472184"/>
-            <a:ext cx="11204143" cy="256032"/>
-          </a:xfrm>
-          <a:prstGeom prst="rect">
-            <a:avLst/>
-          </a:prstGeom>
-          <a:noFill/>
-          <a:ln/>
-        </p:spPr>
-        <p:txBody>
-          <a:bodyPr wrap="square" lIns="127" tIns="127" rIns="127" bIns="127" rtlCol="0" anchor="ctr">
-            <a:normAutofit/>
-          </a:bodyPr>
-          <a:lstStyle/>
-          <a:p>
-            <a:r>
-              <a:rPr lang="en-US" sz="1160" dirty="0">
-                <a:solidFill>
-                  <a:srgbClr val="263B38"/>
-                </a:solidFill>
-              </a:rPr>
-              <a:t>untracked() : lire un signal sans créer de dépendance réactive.</a:t>
-            </a:r>
-            <a:endParaRPr lang="en-US" sz="1160" dirty="0"/>
-          </a:p>
-        </p:txBody>
-      </p:sp>
-      <p:sp>
-        <p:nvSpPr>
-          <p:cNvPr id="7" name="Text 5"/>
-          <p:cNvSpPr/>
-          <p:nvPr/>
-        </p:nvSpPr>
-        <p:spPr>
-          <a:xfrm>
-            <a:off x="576072" y="1783080"/>
-            <a:ext cx="11204143" cy="256032"/>
-          </a:xfrm>
-          <a:prstGeom prst="rect">
-            <a:avLst/>
-          </a:prstGeom>
-          <a:noFill/>
-          <a:ln/>
-        </p:spPr>
-        <p:txBody>
-          <a:bodyPr wrap="square" lIns="127" tIns="127" rIns="127" bIns="127" rtlCol="0" anchor="ctr">
-            <a:normAutofit/>
-          </a:bodyPr>
-          <a:lstStyle/>
-          <a:p>
-            <a:r>
-              <a:rPr lang="en-US" sz="1160" dirty="0">
-                <a:solidFill>
-                  <a:srgbClr val="263B38"/>
-                </a:solidFill>
-              </a:rPr>
-              <a:t>signal.asReadonly() : exposer un signal interne sans setter public.</a:t>
-            </a:r>
-            <a:endParaRPr lang="en-US" sz="1160" dirty="0"/>
-          </a:p>
-        </p:txBody>
-      </p:sp>
-      <p:sp>
-        <p:nvSpPr>
-          <p:cNvPr id="8" name="Text 6"/>
-          <p:cNvSpPr/>
-          <p:nvPr/>
-        </p:nvSpPr>
-        <p:spPr>
-          <a:xfrm>
-            <a:off x="576072" y="2093976"/>
-            <a:ext cx="11204143" cy="256032"/>
-          </a:xfrm>
-          <a:prstGeom prst="rect">
-            <a:avLst/>
-          </a:prstGeom>
-          <a:noFill/>
-          <a:ln/>
-        </p:spPr>
-        <p:txBody>
-          <a:bodyPr wrap="square" lIns="127" tIns="127" rIns="127" bIns="127" rtlCol="0" anchor="ctr">
-            <a:normAutofit/>
-          </a:bodyPr>
-          <a:lstStyle/>
-          <a:p>
-            <a:r>
-              <a:rPr lang="en-US" sz="1160" dirty="0">
-                <a:solidFill>
-                  <a:srgbClr val="263B38"/>
-                </a:solidFill>
-              </a:rPr>
-              <a:t>viewChildren() : récupérer toutes les instances rendues sous forme de signal.</a:t>
-            </a:r>
-            <a:endParaRPr lang="en-US" sz="1160" dirty="0"/>
-          </a:p>
-        </p:txBody>
-      </p:sp>
-      <p:sp>
-        <p:nvSpPr>
-          <p:cNvPr id="9" name="Text 7"/>
-          <p:cNvSpPr/>
-          <p:nvPr/>
-        </p:nvSpPr>
-        <p:spPr>
-          <a:xfrm>
-            <a:off x="576072" y="2404872"/>
-            <a:ext cx="11204143" cy="256032"/>
-          </a:xfrm>
-          <a:prstGeom prst="rect">
-            <a:avLst/>
-          </a:prstGeom>
-          <a:noFill/>
-          <a:ln/>
-        </p:spPr>
-        <p:txBody>
-          <a:bodyPr wrap="square" lIns="127" tIns="127" rIns="127" bIns="127" rtlCol="0" anchor="ctr">
-            <a:normAutofit/>
-          </a:bodyPr>
-          <a:lstStyle/>
-          <a:p>
-            <a:r>
-              <a:rPr lang="en-US" sz="1160" dirty="0">
-                <a:solidFill>
-                  <a:srgbClr val="263B38"/>
-                </a:solidFill>
-              </a:rPr>
-              <a:t>effect(onCleanup) : libérer timer, listener ou subscription.</a:t>
-            </a:r>
-            <a:endParaRPr lang="en-US" sz="1160" dirty="0"/>
-          </a:p>
-        </p:txBody>
-      </p:sp>
-      <p:sp>
-        <p:nvSpPr>
-          <p:cNvPr id="10" name="Text 8"/>
-          <p:cNvSpPr/>
-          <p:nvPr/>
-        </p:nvSpPr>
-        <p:spPr>
-          <a:xfrm>
-            <a:off x="576072" y="2715768"/>
-            <a:ext cx="11204143" cy="256032"/>
-          </a:xfrm>
-          <a:prstGeom prst="rect">
-            <a:avLst/>
-          </a:prstGeom>
-          <a:noFill/>
-          <a:ln/>
-        </p:spPr>
-        <p:txBody>
-          <a:bodyPr wrap="square" lIns="127" tIns="127" rIns="127" bIns="127" rtlCol="0" anchor="ctr">
-            <a:normAutofit/>
-          </a:bodyPr>
-          <a:lstStyle/>
-          <a:p>
-            <a:r>
-              <a:rPr lang="en-US" sz="1160" dirty="0">
-                <a:solidFill>
-                  <a:srgbClr val="263B38"/>
-                </a:solidFill>
-              </a:rPr>
-              <a:t>afterRender() : exécuter une mesure DOM après chaque rendu Angular.</a:t>
-            </a:r>
-            <a:endParaRPr lang="en-US" sz="1160" dirty="0"/>
-          </a:p>
-        </p:txBody>
-      </p:sp>
-      <p:sp>
-        <p:nvSpPr>
-          <p:cNvPr id="11" name="Text 9"/>
-          <p:cNvSpPr/>
-          <p:nvPr/>
-        </p:nvSpPr>
-        <p:spPr>
-          <a:xfrm>
-            <a:off x="11277295" y="6537960"/>
-            <a:ext cx="502920" cy="182880"/>
-          </a:xfrm>
-          <a:prstGeom prst="rect">
-            <a:avLst/>
-          </a:prstGeom>
-          <a:noFill/>
-          <a:ln/>
-        </p:spPr>
-        <p:txBody>
-          <a:bodyPr wrap="square" rtlCol="0" anchor="ctr"/>
-          <a:lstStyle/>
-          <a:p>
-            <a:pPr algn="r" indent="0" marL="0">
-              <a:buNone/>
-            </a:pPr>
-            <a:r>
-              <a:rPr lang="en-US" sz="700" dirty="0">
-                <a:solidFill>
-                  <a:srgbClr val="61716F"/>
-                </a:solidFill>
-              </a:rPr>
-              <a:t>14/17</a:t>
-            </a:r>
-            <a:endParaRPr lang="en-US" sz="700" dirty="0"/>
-          </a:p>
-        </p:txBody>
-      </p:sp>
-    </p:spTree>
-  </p:cSld>
-  <p:clrMapOvr>
-    <a:masterClrMapping/>
-  </p:clrMapOvr>
-</p:sld>
-</file>
-
-<file path=ppt/slides/slide15.xml><?xml version="1.0" encoding="utf-8"?>
-<p:sld xmlns:a="http://schemas.openxmlformats.org/drawingml/2006/main" xmlns:r="http://schemas.openxmlformats.org/officeDocument/2006/relationships" xmlns:p="http://schemas.openxmlformats.org/presentationml/2006/main">
-  <p:cSld name="Slide 15">
-    <p:bg>
-      <p:bgPr>
-        <a:solidFill>
-          <a:srgbClr val="F3F8F6"/>
-        </a:solidFill>
-      </p:bgPr>
-    </p:bg>
-    <p:spTree>
-      <p:nvGrpSpPr>
-        <p:cNvPr id="1" name=""/>
-        <p:cNvGrpSpPr/>
-        <p:nvPr/>
-      </p:nvGrpSpPr>
-      <p:grpSpPr>
-        <a:xfrm>
-          <a:off x="0" y="0"/>
-          <a:ext cx="0" cy="0"/>
-          <a:chOff x="0" y="0"/>
-          <a:chExt cx="0" cy="0"/>
-        </a:xfrm>
-      </p:grpSpPr>
-      <p:sp>
-        <p:nvSpPr>
-          <p:cNvPr id="2" name="Shape 0"/>
-          <p:cNvSpPr/>
-          <p:nvPr/>
-        </p:nvSpPr>
-        <p:spPr>
-          <a:xfrm>
-            <a:off x="0" y="0"/>
-            <a:ext cx="12191695" cy="91440"/>
-          </a:xfrm>
-          <a:prstGeom prst="rect">
-            <a:avLst/>
-          </a:prstGeom>
-          <a:solidFill>
-            <a:srgbClr val="008A5B"/>
-          </a:solidFill>
-          <a:ln w="12700">
-            <a:solidFill>
-              <a:srgbClr val="008A5B"/>
-            </a:solidFill>
-            <a:prstDash val="solid"/>
-          </a:ln>
-        </p:spPr>
-      </p:sp>
-      <p:sp>
-        <p:nvSpPr>
-          <p:cNvPr id="3" name="Text 1"/>
-          <p:cNvSpPr/>
-          <p:nvPr/>
-        </p:nvSpPr>
-        <p:spPr>
-          <a:xfrm>
-            <a:off x="411480" y="219456"/>
-            <a:ext cx="9357055" cy="347472"/>
-          </a:xfrm>
-          <a:prstGeom prst="rect">
-            <a:avLst/>
-          </a:prstGeom>
-          <a:noFill/>
-          <a:ln/>
-        </p:spPr>
-        <p:txBody>
-          <a:bodyPr wrap="square" lIns="0" tIns="0" rIns="0" bIns="0" rtlCol="0" anchor="ctr">
-            <a:normAutofit/>
-          </a:bodyPr>
-          <a:lstStyle/>
-          <a:p>
-            <a:pPr indent="0" marL="0">
-              <a:buNone/>
-            </a:pPr>
-            <a:r>
-              <a:rPr lang="en-US" sz="2000" b="1" dirty="0">
-                <a:solidFill>
-                  <a:srgbClr val="1B2B2A"/>
-                </a:solidFill>
-              </a:rPr>
-              <a:t>effect() — onCleanup</a:t>
-            </a:r>
-            <a:endParaRPr lang="en-US" sz="2000" dirty="0"/>
-          </a:p>
-        </p:txBody>
-      </p:sp>
-      <p:sp>
-        <p:nvSpPr>
-          <p:cNvPr id="4" name="Text 2"/>
-          <p:cNvSpPr/>
-          <p:nvPr/>
-        </p:nvSpPr>
-        <p:spPr>
-          <a:xfrm>
-            <a:off x="10317175" y="246888"/>
-            <a:ext cx="1463040" cy="219456"/>
-          </a:xfrm>
-          <a:prstGeom prst="rect">
-            <a:avLst/>
-          </a:prstGeom>
-          <a:solidFill>
-            <a:srgbClr val="CFEDE2"/>
-          </a:solidFill>
-          <a:ln>
-            <a:solidFill>
-              <a:srgbClr val="CFEDE2"/>
-            </a:solidFill>
-          </a:ln>
-        </p:spPr>
-        <p:txBody>
-          <a:bodyPr wrap="square" lIns="254" tIns="254" rIns="254" bIns="254" rtlCol="0" anchor="ctr"/>
-          <a:lstStyle/>
-          <a:p>
-            <a:pPr algn="ctr" indent="0" marL="0">
-              <a:buNone/>
-            </a:pPr>
-            <a:r>
-              <a:rPr lang="en-US" sz="800" b="1" dirty="0">
-                <a:solidFill>
-                  <a:srgbClr val="008A5B"/>
-                </a:solidFill>
-              </a:rPr>
-              <a:t>BNP Paribas</a:t>
-            </a:r>
-            <a:endParaRPr lang="en-US" sz="800" dirty="0"/>
-          </a:p>
-        </p:txBody>
-      </p:sp>
       <p:graphicFrame>
         <p:nvGraphicFramePr>
-          <p:cNvPr id="16" name="Table 0"/>
+          <p:cNvPr id="15" name="Table 0"/>
           <p:cNvGraphicFramePr>
             <a:graphicFrameLocks noGrp="1"/>
           </p:cNvGraphicFramePr>
@@ -10038,7 +9563,7 @@
                   <a:srgbClr val="61716F"/>
                 </a:solidFill>
               </a:rPr>
-              <a:t>15/17</a:t>
+              <a:t>14/16</a:t>
             </a:r>
             <a:endParaRPr lang="en-US" sz="700" dirty="0"/>
           </a:p>
@@ -10052,9 +9577,9 @@
 </p:sld>
 </file>
 
-<file path=ppt/slides/slide16.xml><?xml version="1.0" encoding="utf-8"?>
+<file path=ppt/slides/slide15.xml><?xml version="1.0" encoding="utf-8"?>
 <p:sld xmlns:a="http://schemas.openxmlformats.org/drawingml/2006/main" xmlns:r="http://schemas.openxmlformats.org/officeDocument/2006/relationships" xmlns:p="http://schemas.openxmlformats.org/presentationml/2006/main">
-  <p:cSld name="Slide 16">
+  <p:cSld name="Slide 15">
     <p:bg>
       <p:bgPr>
         <a:solidFill>
@@ -10183,7 +9708,7 @@
       </p:sp>
       <p:graphicFrame>
         <p:nvGraphicFramePr>
-          <p:cNvPr id="17" name="Table 0"/>
+          <p:cNvPr id="16" name="Table 0"/>
           <p:cNvGraphicFramePr>
             <a:graphicFrameLocks noGrp="1"/>
           </p:cNvGraphicFramePr>
@@ -11074,7 +10599,7 @@
                   <a:srgbClr val="61716F"/>
                 </a:solidFill>
               </a:rPr>
-              <a:t>16/17</a:t>
+              <a:t>15/16</a:t>
             </a:r>
             <a:endParaRPr lang="en-US" sz="700" dirty="0"/>
           </a:p>
@@ -11088,9 +10613,9 @@
 </p:sld>
 </file>
 
-<file path=ppt/slides/slide17.xml><?xml version="1.0" encoding="utf-8"?>
+<file path=ppt/slides/slide16.xml><?xml version="1.0" encoding="utf-8"?>
 <p:sld xmlns:a="http://schemas.openxmlformats.org/drawingml/2006/main" xmlns:r="http://schemas.openxmlformats.org/officeDocument/2006/relationships" xmlns:p="http://schemas.openxmlformats.org/presentationml/2006/main">
-  <p:cSld name="Slide 17">
+  <p:cSld name="Slide 16">
     <p:bg>
       <p:bgPr>
         <a:solidFill>
@@ -11819,7 +11344,7 @@
                   <a:srgbClr val="61716F"/>
                 </a:solidFill>
               </a:rPr>
-              <a:t>17/17</a:t>
+              <a:t>16/16</a:t>
             </a:r>
             <a:endParaRPr lang="en-US" sz="700" dirty="0"/>
           </a:p>
@@ -12394,7 +11919,7 @@
                   <a:srgbClr val="61716F"/>
                 </a:solidFill>
               </a:rPr>
-              <a:t>2/17</a:t>
+              <a:t>2/16</a:t>
             </a:r>
             <a:endParaRPr lang="en-US" sz="700" dirty="0"/>
           </a:p>
@@ -12817,7 +12342,7 @@
                   <a:srgbClr val="61716F"/>
                 </a:solidFill>
               </a:rPr>
-              <a:t>3/17</a:t>
+              <a:t>3/16</a:t>
             </a:r>
             <a:endParaRPr lang="en-US" sz="700" dirty="0"/>
           </a:p>
@@ -13392,7 +12917,7 @@
                   <a:srgbClr val="61716F"/>
                 </a:solidFill>
               </a:rPr>
-              <a:t>4/17</a:t>
+              <a:t>4/16</a:t>
             </a:r>
             <a:endParaRPr lang="en-US" sz="700" dirty="0"/>
           </a:p>
@@ -13815,7 +13340,7 @@
                   <a:srgbClr val="61716F"/>
                 </a:solidFill>
               </a:rPr>
-              <a:t>5/17</a:t>
+              <a:t>5/16</a:t>
             </a:r>
             <a:endParaRPr lang="en-US" sz="700" dirty="0"/>
           </a:p>
@@ -14390,7 +13915,7 @@
                   <a:srgbClr val="61716F"/>
                 </a:solidFill>
               </a:rPr>
-              <a:t>6/17</a:t>
+              <a:t>6/16</a:t>
             </a:r>
             <a:endParaRPr lang="en-US" sz="700" dirty="0"/>
           </a:p>
@@ -14813,7 +14338,7 @@
                   <a:srgbClr val="61716F"/>
                 </a:solidFill>
               </a:rPr>
-              <a:t>7/17</a:t>
+              <a:t>7/16</a:t>
             </a:r>
             <a:endParaRPr lang="en-US" sz="700" dirty="0"/>
           </a:p>
@@ -16342,7 +15867,7 @@
                   <a:srgbClr val="61716F"/>
                 </a:solidFill>
               </a:rPr>
-              <a:t>8/17</a:t>
+              <a:t>8/16</a:t>
             </a:r>
             <a:endParaRPr lang="en-US" sz="700" dirty="0"/>
           </a:p>
@@ -16699,7 +16224,7 @@
                   <a:srgbClr val="61716F"/>
                 </a:solidFill>
               </a:rPr>
-              <a:t>9/17</a:t>
+              <a:t>9/16</a:t>
             </a:r>
             <a:endParaRPr lang="en-US" sz="700" dirty="0"/>
           </a:p>

</xml_diff>

<commit_message>
retire rxResource du dojo
</commit_message>
<xml_diff>
--- a/docs/dojo-signals.pptx
+++ b/docs/dojo-signals.pptx
@@ -2648,7 +2648,7 @@
                 <a:gridCol w="2834640"/>
                 <a:gridCol w="7116775"/>
               </a:tblGrid>
-              <a:tr h="306324">
+              <a:tr h="324343">
                 <a:tc>
                   <a:txBody>
                     <a:bodyPr/>
@@ -2833,7 +2833,7 @@
                   </a:tcPr>
                 </a:tc>
               </a:tr>
-              <a:tr h="306324">
+              <a:tr h="324343">
                 <a:tc>
                   <a:txBody>
                     <a:bodyPr/>
@@ -3018,7 +3018,7 @@
                   </a:tcPr>
                 </a:tc>
               </a:tr>
-              <a:tr h="306324">
+              <a:tr h="324343">
                 <a:tc>
                   <a:txBody>
                     <a:bodyPr/>
@@ -3203,7 +3203,7 @@
                   </a:tcPr>
                 </a:tc>
               </a:tr>
-              <a:tr h="306324">
+              <a:tr h="324343">
                 <a:tc>
                   <a:txBody>
                     <a:bodyPr/>
@@ -3388,7 +3388,7 @@
                   </a:tcPr>
                 </a:tc>
               </a:tr>
-              <a:tr h="306324">
+              <a:tr h="324343">
                 <a:tc>
                   <a:txBody>
                     <a:bodyPr/>
@@ -3573,7 +3573,7 @@
                   </a:tcPr>
                 </a:tc>
               </a:tr>
-              <a:tr h="306324">
+              <a:tr h="324343">
                 <a:tc>
                   <a:txBody>
                     <a:bodyPr/>
@@ -3758,7 +3758,7 @@
                   </a:tcPr>
                 </a:tc>
               </a:tr>
-              <a:tr h="306324">
+              <a:tr h="324343">
                 <a:tc>
                   <a:txBody>
                     <a:bodyPr/>
@@ -3943,7 +3943,7 @@
                   </a:tcPr>
                 </a:tc>
               </a:tr>
-              <a:tr h="306324">
+              <a:tr h="324343">
                 <a:tc>
                   <a:txBody>
                     <a:bodyPr/>
@@ -4128,7 +4128,7 @@
                   </a:tcPr>
                 </a:tc>
               </a:tr>
-              <a:tr h="306324">
+              <a:tr h="324343">
                 <a:tc>
                   <a:txBody>
                     <a:bodyPr/>
@@ -4313,7 +4313,7 @@
                   </a:tcPr>
                 </a:tc>
               </a:tr>
-              <a:tr h="306324">
+              <a:tr h="324343">
                 <a:tc>
                   <a:txBody>
                     <a:bodyPr/>
@@ -4498,7 +4498,7 @@
                   </a:tcPr>
                 </a:tc>
               </a:tr>
-              <a:tr h="306324">
+              <a:tr h="324343">
                 <a:tc>
                   <a:txBody>
                     <a:bodyPr/>
@@ -4683,7 +4683,7 @@
                   </a:tcPr>
                 </a:tc>
               </a:tr>
-              <a:tr h="306324">
+              <a:tr h="324343">
                 <a:tc>
                   <a:txBody>
                     <a:bodyPr/>
@@ -4868,7 +4868,7 @@
                   </a:tcPr>
                 </a:tc>
               </a:tr>
-              <a:tr h="306324">
+              <a:tr h="324343">
                 <a:tc>
                   <a:txBody>
                     <a:bodyPr/>
@@ -5053,192 +5053,7 @@
                   </a:tcPr>
                 </a:tc>
               </a:tr>
-              <a:tr h="306324">
-                <a:tc>
-                  <a:txBody>
-                    <a:bodyPr/>
-                    <a:lstStyle/>
-                    <a:p>
-                      <a:pPr indent="0" marL="0">
-                        <a:buNone/>
-                      </a:pPr>
-                      <a:r>
-                        <a:rPr lang="en-US" sz="740" dirty="0">
-                          <a:solidFill>
-                            <a:srgbClr val="263B38"/>
-                          </a:solidFill>
-                        </a:rPr>
-                        <a:t>rxResource()</a:t>
-                      </a:r>
-                      <a:endParaRPr lang="en-US" sz="740" dirty="0"/>
-                    </a:p>
-                  </a:txBody>
-                  <a:tcPr marL="50800" marR="50800" marT="25400" marB="25400" anchor="mid">
-                    <a:lnL w="5715" cap="flat" cmpd="sng" algn="ctr">
-                      <a:solidFill>
-                        <a:srgbClr val="D6E5E0"/>
-                      </a:solidFill>
-                      <a:prstDash val="solid"/>
-                      <a:round/>
-                      <a:headEnd type="none" w="med" len="med"/>
-                      <a:tailEnd type="none" w="med" len="med"/>
-                    </a:lnL>
-                    <a:lnR w="5715" cap="flat" cmpd="sng" algn="ctr">
-                      <a:solidFill>
-                        <a:srgbClr val="D6E5E0"/>
-                      </a:solidFill>
-                      <a:prstDash val="solid"/>
-                      <a:round/>
-                      <a:headEnd type="none" w="med" len="med"/>
-                      <a:tailEnd type="none" w="med" len="med"/>
-                    </a:lnR>
-                    <a:lnT w="5715" cap="flat" cmpd="sng" algn="ctr">
-                      <a:solidFill>
-                        <a:srgbClr val="D6E5E0"/>
-                      </a:solidFill>
-                      <a:prstDash val="solid"/>
-                      <a:round/>
-                      <a:headEnd type="none" w="med" len="med"/>
-                      <a:tailEnd type="none" w="med" len="med"/>
-                    </a:lnT>
-                    <a:lnB w="5715" cap="flat" cmpd="sng" algn="ctr">
-                      <a:solidFill>
-                        <a:srgbClr val="D6E5E0"/>
-                      </a:solidFill>
-                      <a:prstDash val="solid"/>
-                      <a:round/>
-                      <a:headEnd type="none" w="med" len="med"/>
-                      <a:tailEnd type="none" w="med" len="med"/>
-                    </a:lnB>
-                    <a:solidFill>
-                      <a:srgbClr val="FFFFFF"/>
-                    </a:solidFill>
-                  </a:tcPr>
-                </a:tc>
-                <a:tc>
-                  <a:txBody>
-                    <a:bodyPr/>
-                    <a:lstStyle/>
-                    <a:p>
-                      <a:pPr indent="0" marL="0">
-                        <a:buNone/>
-                      </a:pPr>
-                      <a:r>
-                        <a:rPr lang="en-US" sz="740" dirty="0">
-                          <a:solidFill>
-                            <a:srgbClr val="263B38"/>
-                          </a:solidFill>
-                        </a:rPr>
-                        <a:t>Ressource async basee Observable, avec value, isLoading et error.</a:t>
-                      </a:r>
-                      <a:endParaRPr lang="en-US" sz="740" dirty="0"/>
-                    </a:p>
-                  </a:txBody>
-                  <a:tcPr marL="50800" marR="50800" marT="25400" marB="25400" anchor="mid">
-                    <a:lnL w="5715" cap="flat" cmpd="sng" algn="ctr">
-                      <a:solidFill>
-                        <a:srgbClr val="D6E5E0"/>
-                      </a:solidFill>
-                      <a:prstDash val="solid"/>
-                      <a:round/>
-                      <a:headEnd type="none" w="med" len="med"/>
-                      <a:tailEnd type="none" w="med" len="med"/>
-                    </a:lnL>
-                    <a:lnR w="5715" cap="flat" cmpd="sng" algn="ctr">
-                      <a:solidFill>
-                        <a:srgbClr val="D6E5E0"/>
-                      </a:solidFill>
-                      <a:prstDash val="solid"/>
-                      <a:round/>
-                      <a:headEnd type="none" w="med" len="med"/>
-                      <a:tailEnd type="none" w="med" len="med"/>
-                    </a:lnR>
-                    <a:lnT w="5715" cap="flat" cmpd="sng" algn="ctr">
-                      <a:solidFill>
-                        <a:srgbClr val="D6E5E0"/>
-                      </a:solidFill>
-                      <a:prstDash val="solid"/>
-                      <a:round/>
-                      <a:headEnd type="none" w="med" len="med"/>
-                      <a:tailEnd type="none" w="med" len="med"/>
-                    </a:lnT>
-                    <a:lnB w="5715" cap="flat" cmpd="sng" algn="ctr">
-                      <a:solidFill>
-                        <a:srgbClr val="D6E5E0"/>
-                      </a:solidFill>
-                      <a:prstDash val="solid"/>
-                      <a:round/>
-                      <a:headEnd type="none" w="med" len="med"/>
-                      <a:tailEnd type="none" w="med" len="med"/>
-                    </a:lnB>
-                    <a:solidFill>
-                      <a:srgbClr val="FFFFFF"/>
-                    </a:solidFill>
-                  </a:tcPr>
-                </a:tc>
-                <a:tc>
-                  <a:txBody>
-                    <a:bodyPr/>
-                    <a:lstStyle/>
-                    <a:p>
-                      <a:pPr indent="0" marL="0">
-                        <a:buNone/>
-                      </a:pPr>
-                      <a:r>
-                        <a:rPr lang="en-US" sz="740" dirty="0">
-                          <a:solidFill>
-                            <a:srgbClr val="263B38"/>
-                          </a:solidFill>
-                        </a:rPr>
-                        <a:t>dashboard.component.ts</a:t>
-                      </a:r>
-                      <a:endParaRPr lang="en-US" sz="740" dirty="0"/>
-                    </a:p>
-                  </a:txBody>
-                  <a:tcPr marL="50800" marR="50800" marT="25400" marB="25400" anchor="mid">
-                    <a:lnL w="5715" cap="flat" cmpd="sng" algn="ctr">
-                      <a:solidFill>
-                        <a:srgbClr val="D6E5E0"/>
-                      </a:solidFill>
-                      <a:prstDash val="solid"/>
-                      <a:round/>
-                      <a:headEnd type="none" w="med" len="med"/>
-                      <a:tailEnd type="none" w="med" len="med"/>
-                    </a:lnL>
-                    <a:lnR w="5715" cap="flat" cmpd="sng" algn="ctr">
-                      <a:solidFill>
-                        <a:srgbClr val="D6E5E0"/>
-                      </a:solidFill>
-                      <a:prstDash val="solid"/>
-                      <a:round/>
-                      <a:headEnd type="none" w="med" len="med"/>
-                      <a:tailEnd type="none" w="med" len="med"/>
-                    </a:lnR>
-                    <a:lnT w="5715" cap="flat" cmpd="sng" algn="ctr">
-                      <a:solidFill>
-                        <a:srgbClr val="D6E5E0"/>
-                      </a:solidFill>
-                      <a:prstDash val="solid"/>
-                      <a:round/>
-                      <a:headEnd type="none" w="med" len="med"/>
-                      <a:tailEnd type="none" w="med" len="med"/>
-                    </a:lnT>
-                    <a:lnB w="5715" cap="flat" cmpd="sng" algn="ctr">
-                      <a:solidFill>
-                        <a:srgbClr val="D6E5E0"/>
-                      </a:solidFill>
-                      <a:prstDash val="solid"/>
-                      <a:round/>
-                      <a:headEnd type="none" w="med" len="med"/>
-                      <a:tailEnd type="none" w="med" len="med"/>
-                    </a:lnB>
-                    <a:solidFill>
-                      <a:srgbClr val="FFFFFF"/>
-                    </a:solidFill>
-                  </a:tcPr>
-                </a:tc>
-              </a:tr>
-              <a:tr h="306324">
+              <a:tr h="324343">
                 <a:tc>
                   <a:txBody>
                     <a:bodyPr/>
@@ -5296,7 +5111,7 @@
                       <a:tailEnd type="none" w="med" len="med"/>
                     </a:lnB>
                     <a:solidFill>
-                      <a:srgbClr val="F3F8F6"/>
+                      <a:srgbClr val="FFFFFF"/>
                     </a:solidFill>
                   </a:tcPr>
                 </a:tc>
@@ -5357,7 +5172,7 @@
                       <a:tailEnd type="none" w="med" len="med"/>
                     </a:lnB>
                     <a:solidFill>
-                      <a:srgbClr val="F3F8F6"/>
+                      <a:srgbClr val="FFFFFF"/>
                     </a:solidFill>
                   </a:tcPr>
                 </a:tc>
@@ -5418,12 +5233,12 @@
                       <a:tailEnd type="none" w="med" len="med"/>
                     </a:lnB>
                     <a:solidFill>
-                      <a:srgbClr val="F3F8F6"/>
+                      <a:srgbClr val="FFFFFF"/>
                     </a:solidFill>
                   </a:tcPr>
                 </a:tc>
               </a:tr>
-              <a:tr h="306324">
+              <a:tr h="324343">
                 <a:tc>
                   <a:txBody>
                     <a:bodyPr/>
@@ -5481,7 +5296,7 @@
                       <a:tailEnd type="none" w="med" len="med"/>
                     </a:lnB>
                     <a:solidFill>
-                      <a:srgbClr val="FFFFFF"/>
+                      <a:srgbClr val="F3F8F6"/>
                     </a:solidFill>
                   </a:tcPr>
                 </a:tc>
@@ -5542,7 +5357,7 @@
                       <a:tailEnd type="none" w="med" len="med"/>
                     </a:lnB>
                     <a:solidFill>
-                      <a:srgbClr val="FFFFFF"/>
+                      <a:srgbClr val="F3F8F6"/>
                     </a:solidFill>
                   </a:tcPr>
                 </a:tc>
@@ -5603,12 +5418,12 @@
                       <a:tailEnd type="none" w="med" len="med"/>
                     </a:lnB>
                     <a:solidFill>
-                      <a:srgbClr val="FFFFFF"/>
+                      <a:srgbClr val="F3F8F6"/>
                     </a:solidFill>
                   </a:tcPr>
                 </a:tc>
               </a:tr>
-              <a:tr h="306324">
+              <a:tr h="324343">
                 <a:tc>
                   <a:txBody>
                     <a:bodyPr/>
@@ -5666,7 +5481,7 @@
                       <a:tailEnd type="none" w="med" len="med"/>
                     </a:lnB>
                     <a:solidFill>
-                      <a:srgbClr val="F3F8F6"/>
+                      <a:srgbClr val="FFFFFF"/>
                     </a:solidFill>
                   </a:tcPr>
                 </a:tc>
@@ -5727,7 +5542,7 @@
                       <a:tailEnd type="none" w="med" len="med"/>
                     </a:lnB>
                     <a:solidFill>
-                      <a:srgbClr val="F3F8F6"/>
+                      <a:srgbClr val="FFFFFF"/>
                     </a:solidFill>
                   </a:tcPr>
                 </a:tc>
@@ -5788,12 +5603,12 @@
                       <a:tailEnd type="none" w="med" len="med"/>
                     </a:lnB>
                     <a:solidFill>
-                      <a:srgbClr val="F3F8F6"/>
+                      <a:srgbClr val="FFFFFF"/>
                     </a:solidFill>
                   </a:tcPr>
                 </a:tc>
               </a:tr>
-              <a:tr h="306324">
+              <a:tr h="324343">
                 <a:tc>
                   <a:txBody>
                     <a:bodyPr/>
@@ -5851,7 +5666,7 @@
                       <a:tailEnd type="none" w="med" len="med"/>
                     </a:lnB>
                     <a:solidFill>
-                      <a:srgbClr val="FFFFFF"/>
+                      <a:srgbClr val="F3F8F6"/>
                     </a:solidFill>
                   </a:tcPr>
                 </a:tc>
@@ -5912,7 +5727,7 @@
                       <a:tailEnd type="none" w="med" len="med"/>
                     </a:lnB>
                     <a:solidFill>
-                      <a:srgbClr val="FFFFFF"/>
+                      <a:srgbClr val="F3F8F6"/>
                     </a:solidFill>
                   </a:tcPr>
                 </a:tc>
@@ -5973,7 +5788,7 @@
                       <a:tailEnd type="none" w="med" len="med"/>
                     </a:lnB>
                     <a:solidFill>
-                      <a:srgbClr val="FFFFFF"/>
+                      <a:srgbClr val="F3F8F6"/>
                     </a:solidFill>
                   </a:tcPr>
                 </a:tc>
@@ -8304,7 +8119,7 @@
                   <a:srgbClr val="006B4F"/>
                 </a:solidFill>
               </a:rPr>
-              <a:t>9 — rxResource()</a:t>
+              <a:t>9 — afterNextRender() / afterRender()</a:t>
             </a:r>
             <a:endParaRPr lang="en-US" sz="820" dirty="0"/>
           </a:p>
@@ -8342,7 +8157,7 @@
                   <a:srgbClr val="61716F"/>
                 </a:solidFill>
               </a:rPr>
-              <a:t>Chargement asynchrone reactif avec etat loading/error/value.</a:t>
+              <a:t>Hook post-rendu DOM one-shot ou recurrent.</a:t>
             </a:r>
             <a:endParaRPr lang="en-US" sz="680" dirty="0"/>
           </a:p>
@@ -8380,7 +8195,7 @@
                   <a:srgbClr val="006B4F"/>
                 </a:solidFill>
               </a:rPr>
-              <a:t>clients/pages/dashboard/dashboard.component.ts</a:t>
+              <a:t>clients/pages/clients/clients.component.ts</a:t>
             </a:r>
             <a:endParaRPr lang="en-US" sz="580" dirty="0"/>
           </a:p>
@@ -8418,7 +8233,7 @@
                   <a:srgbClr val="263B38"/>
                 </a:solidFill>
               </a:rPr>
-              <a:t>Remplacer le chargement imperatif du dashboard par rxResource(). Le composant doit exposer les signaux loading, error et value derives de la ressource.</a:t>
+              <a:t>Ajouter la reference au viewport, puis scroller en haut de liste avec afterNextRender() apres l'ajout d'un client.</a:t>
             </a:r>
             <a:endParaRPr lang="en-US" sz="680" dirty="0"/>
           </a:p>
@@ -8508,7 +8323,7 @@
                   <a:srgbClr val="008A5B"/>
                 </a:solidFill>
               </a:rPr>
-              <a:t>10 — afterNextRender() / afterRender()</a:t>
+              <a:t>10 — computed() facade</a:t>
             </a:r>
             <a:endParaRPr lang="en-US" sz="820" dirty="0"/>
           </a:p>
@@ -8546,7 +8361,7 @@
                   <a:srgbClr val="61716F"/>
                 </a:solidFill>
               </a:rPr>
-              <a:t>Hook post-rendu DOM one-shot ou recurrent.</a:t>
+              <a:t>Vue derivee de l'etat metier dans une facade.</a:t>
             </a:r>
             <a:endParaRPr lang="en-US" sz="680" dirty="0"/>
           </a:p>
@@ -8584,7 +8399,21 @@
                   <a:srgbClr val="006B4F"/>
                 </a:solidFill>
               </a:rPr>
-              <a:t>clients/pages/clients/clients.component.ts</a:t>
+              <a:t>accounts/services/accounts.facade.ts</a:t>
+            </a:r>
+            <a:endParaRPr lang="en-US" sz="580" dirty="0"/>
+          </a:p>
+          <a:p>
+            <a:pPr indent="0" marL="0">
+              <a:buNone/>
+            </a:pPr>
+            <a:r>
+              <a:rPr lang="en-US" sz="580" dirty="0">
+                <a:solidFill>
+                  <a:srgbClr val="006B4F"/>
+                </a:solidFill>
+              </a:rPr>
+              <a:t>accounts/pages/accounts/accounts.component.*</a:t>
             </a:r>
             <a:endParaRPr lang="en-US" sz="580" dirty="0"/>
           </a:p>
@@ -8622,7 +8451,7 @@
                   <a:srgbClr val="263B38"/>
                 </a:solidFill>
               </a:rPr>
-              <a:t>Ajouter la reference au viewport, puis scroller en haut de liste avec afterNextRender() apres l'ajout d'un client.</a:t>
+              <a:t>Ajouter hasActiveFilter comme valeur derivee de la facade. Le message vide doit dependre de cette regle exposee par la facade.</a:t>
             </a:r>
             <a:endParaRPr lang="en-US" sz="680" dirty="0"/>
           </a:p>
@@ -8630,225 +8459,7 @@
       </p:sp>
       <p:sp>
         <p:nvSpPr>
-          <p:cNvPr id="23" name="Shape 21"/>
-          <p:cNvSpPr/>
-          <p:nvPr/>
-        </p:nvSpPr>
-        <p:spPr>
-          <a:xfrm>
-            <a:off x="411480" y="4745736"/>
-            <a:ext cx="5574640" cy="1170432"/>
-          </a:xfrm>
-          <a:prstGeom prst="roundRect">
-            <a:avLst>
-              <a:gd name="adj" fmla="val 4688"/>
-            </a:avLst>
-          </a:prstGeom>
-          <a:solidFill>
-            <a:srgbClr val="FFFFFF"/>
-          </a:solidFill>
-          <a:ln w="12700">
-            <a:solidFill>
-              <a:srgbClr val="D6E5E0"/>
-            </a:solidFill>
-            <a:prstDash val="solid"/>
-          </a:ln>
-        </p:spPr>
-      </p:sp>
-      <p:sp>
-        <p:nvSpPr>
-          <p:cNvPr id="24" name="Shape 22"/>
-          <p:cNvSpPr/>
-          <p:nvPr/>
-        </p:nvSpPr>
-        <p:spPr>
-          <a:xfrm>
-            <a:off x="411480" y="4745736"/>
-            <a:ext cx="73152" cy="1170432"/>
-          </a:xfrm>
-          <a:prstGeom prst="rect">
-            <a:avLst/>
-          </a:prstGeom>
-          <a:solidFill>
-            <a:srgbClr val="006B4F"/>
-          </a:solidFill>
-          <a:ln w="12700">
-            <a:solidFill>
-              <a:srgbClr val="006B4F"/>
-            </a:solidFill>
-            <a:prstDash val="solid"/>
-          </a:ln>
-        </p:spPr>
-      </p:sp>
-      <p:sp>
-        <p:nvSpPr>
-          <p:cNvPr id="25" name="Text 23"/>
-          <p:cNvSpPr/>
-          <p:nvPr/>
-        </p:nvSpPr>
-        <p:spPr>
-          <a:xfrm>
-            <a:off x="576072" y="4855464"/>
-            <a:ext cx="1417320" cy="182880"/>
-          </a:xfrm>
-          <a:prstGeom prst="rect">
-            <a:avLst/>
-          </a:prstGeom>
-          <a:noFill/>
-          <a:ln/>
-        </p:spPr>
-        <p:txBody>
-          <a:bodyPr wrap="square" lIns="0" tIns="0" rIns="0" bIns="0" rtlCol="0" anchor="ctr">
-            <a:normAutofit/>
-          </a:bodyPr>
-          <a:lstStyle/>
-          <a:p>
-            <a:pPr indent="0" marL="0">
-              <a:buNone/>
-            </a:pPr>
-            <a:r>
-              <a:rPr lang="en-US" sz="820" b="1" dirty="0">
-                <a:solidFill>
-                  <a:srgbClr val="006B4F"/>
-                </a:solidFill>
-              </a:rPr>
-              <a:t>11 — computed() facade</a:t>
-            </a:r>
-            <a:endParaRPr lang="en-US" sz="820" dirty="0"/>
-          </a:p>
-        </p:txBody>
-      </p:sp>
-      <p:sp>
-        <p:nvSpPr>
-          <p:cNvPr id="26" name="Text 24"/>
-          <p:cNvSpPr/>
-          <p:nvPr/>
-        </p:nvSpPr>
-        <p:spPr>
-          <a:xfrm>
-            <a:off x="2039112" y="4855464"/>
-            <a:ext cx="3791560" cy="182880"/>
-          </a:xfrm>
-          <a:prstGeom prst="rect">
-            <a:avLst/>
-          </a:prstGeom>
-          <a:noFill/>
-          <a:ln/>
-        </p:spPr>
-        <p:txBody>
-          <a:bodyPr wrap="square" lIns="0" tIns="0" rIns="0" bIns="0" rtlCol="0" anchor="ctr">
-            <a:normAutofit/>
-          </a:bodyPr>
-          <a:lstStyle/>
-          <a:p>
-            <a:pPr indent="0" marL="0">
-              <a:buNone/>
-            </a:pPr>
-            <a:r>
-              <a:rPr lang="en-US" sz="680" dirty="0">
-                <a:solidFill>
-                  <a:srgbClr val="61716F"/>
-                </a:solidFill>
-              </a:rPr>
-              <a:t>Vue derivee de l'etat metier dans une facade.</a:t>
-            </a:r>
-            <a:endParaRPr lang="en-US" sz="680" dirty="0"/>
-          </a:p>
-        </p:txBody>
-      </p:sp>
-      <p:sp>
-        <p:nvSpPr>
-          <p:cNvPr id="27" name="Text 25"/>
-          <p:cNvSpPr/>
-          <p:nvPr/>
-        </p:nvSpPr>
-        <p:spPr>
-          <a:xfrm>
-            <a:off x="576072" y="5111496"/>
-            <a:ext cx="1874520" cy="512064"/>
-          </a:xfrm>
-          <a:prstGeom prst="rect">
-            <a:avLst/>
-          </a:prstGeom>
-          <a:noFill/>
-          <a:ln/>
-        </p:spPr>
-        <p:txBody>
-          <a:bodyPr wrap="square" lIns="0" tIns="0" rIns="0" bIns="0" rtlCol="0" anchor="t">
-            <a:normAutofit/>
-          </a:bodyPr>
-          <a:lstStyle/>
-          <a:p>
-            <a:pPr indent="0" marL="0">
-              <a:buNone/>
-            </a:pPr>
-            <a:r>
-              <a:rPr lang="en-US" sz="580" dirty="0">
-                <a:solidFill>
-                  <a:srgbClr val="006B4F"/>
-                </a:solidFill>
-              </a:rPr>
-              <a:t>accounts/services/accounts.facade.ts</a:t>
-            </a:r>
-            <a:endParaRPr lang="en-US" sz="580" dirty="0"/>
-          </a:p>
-          <a:p>
-            <a:pPr indent="0" marL="0">
-              <a:buNone/>
-            </a:pPr>
-            <a:r>
-              <a:rPr lang="en-US" sz="580" dirty="0">
-                <a:solidFill>
-                  <a:srgbClr val="006B4F"/>
-                </a:solidFill>
-              </a:rPr>
-              <a:t>accounts/pages/accounts/accounts.component.*</a:t>
-            </a:r>
-            <a:endParaRPr lang="en-US" sz="580" dirty="0"/>
-          </a:p>
-        </p:txBody>
-      </p:sp>
-      <p:sp>
-        <p:nvSpPr>
-          <p:cNvPr id="28" name="Text 26"/>
-          <p:cNvSpPr/>
-          <p:nvPr/>
-        </p:nvSpPr>
-        <p:spPr>
-          <a:xfrm>
-            <a:off x="2551176" y="5102352"/>
-            <a:ext cx="3270352" cy="658368"/>
-          </a:xfrm>
-          <a:prstGeom prst="rect">
-            <a:avLst/>
-          </a:prstGeom>
-          <a:noFill/>
-          <a:ln/>
-        </p:spPr>
-        <p:txBody>
-          <a:bodyPr wrap="square" lIns="254" tIns="254" rIns="254" bIns="254" rtlCol="0" anchor="t">
-            <a:normAutofit/>
-          </a:bodyPr>
-          <a:lstStyle/>
-          <a:p>
-            <a:pPr indent="0" marL="0">
-              <a:buNone/>
-            </a:pPr>
-            <a:r>
-              <a:rPr lang="en-US" sz="680" dirty="0">
-                <a:solidFill>
-                  <a:srgbClr val="263B38"/>
-                </a:solidFill>
-              </a:rPr>
-              <a:t>Ajouter hasActiveFilter comme valeur derivee de la facade. Le message vide doit dependre de cette regle exposee par la facade.</a:t>
-            </a:r>
-            <a:endParaRPr lang="en-US" sz="680" dirty="0"/>
-          </a:p>
-        </p:txBody>
-      </p:sp>
-      <p:sp>
-        <p:nvSpPr>
-          <p:cNvPr id="29" name="Text 27"/>
+          <p:cNvPr id="23" name="Text 21"/>
           <p:cNvSpPr/>
           <p:nvPr/>
         </p:nvSpPr>
@@ -8922,43 +8533,7 @@
         </p:nvSpPr>
         <p:spPr>
           <a:xfrm>
-            <a:off x="594360" y="1600200"/>
-            <a:ext cx="11002975" cy="411480"/>
-          </a:xfrm>
-          <a:prstGeom prst="rect">
-            <a:avLst/>
-          </a:prstGeom>
-          <a:noFill/>
-          <a:ln/>
-        </p:spPr>
-        <p:txBody>
-          <a:bodyPr wrap="square" lIns="0" tIns="0" rIns="0" bIns="0" rtlCol="0" anchor="ctr"/>
-          <a:lstStyle/>
-          <a:p>
-            <a:pPr algn="ctr" indent="0" marL="0">
-              <a:buNone/>
-            </a:pPr>
-            <a:r>
-              <a:rPr lang="en-US" sz="1800" dirty="0">
-                <a:solidFill>
-                  <a:srgbClr val="CFEDE2"/>
-                </a:solidFill>
-              </a:rPr>
-              <a:t>Extension avancée</a:t>
-            </a:r>
-            <a:endParaRPr lang="en-US" sz="1800" dirty="0"/>
-          </a:p>
-        </p:txBody>
-      </p:sp>
-      <p:sp>
-        <p:nvSpPr>
-          <p:cNvPr id="3" name="Text 1"/>
-          <p:cNvSpPr/>
-          <p:nvPr/>
-        </p:nvSpPr>
-        <p:spPr>
-          <a:xfrm>
-            <a:off x="594360" y="2148840"/>
+            <a:off x="594360" y="2011680"/>
             <a:ext cx="11002975" cy="1097280"/>
           </a:xfrm>
           <a:prstGeom prst="rect">
@@ -8982,7 +8557,7 @@
                   <a:srgbClr val="FFFFFF"/>
                 </a:solidFill>
               </a:rPr>
-              <a:t>Exercices 8 à 11</a:t>
+              <a:t>Extension avancée</a:t>
             </a:r>
             <a:endParaRPr lang="en-US" sz="3800" dirty="0"/>
           </a:p>
@@ -8990,7 +8565,7 @@
       </p:sp>
       <p:sp>
         <p:nvSpPr>
-          <p:cNvPr id="5" name="Text 2"/>
+          <p:cNvPr id="4" name="Text 1"/>
           <p:cNvSpPr/>
           <p:nvPr/>
         </p:nvSpPr>

</xml_diff>

<commit_message>
ajoute primitive-lab et support de presentation reduit
- primitive-lab : 8 cartes avec cas de defaillance concrets (signal, computed, effect, viewChild, input, linkedSignal, afterNextRender, zone-computed)
- dojo-signals.md : corrections de coherence (ex6A, ex6B, ex7)
- dojo-signals-core.md : nouveau support parcours essentiel (6 exercices : signal, computed, effect, input, output, linkedSignal)
- supprime les anciens slides courts et longs

Co-Authored-By: Claude Sonnet 4.6 <noreply@anthropic.com>
</commit_message>
<xml_diff>
--- a/docs/dojo-signals.pptx
+++ b/docs/dojo-signals.pptx
@@ -21,10 +21,9 @@
     <p:sldId id="269" r:id="rId15"/>
     <p:sldId id="270" r:id="rId16"/>
     <p:sldId id="271" r:id="rId17"/>
-    <p:sldId id="272" r:id="rId18"/>
   </p:sldIdLst>
   <p:notesMasterIdLst>
-    <p:notesMasterId r:id="rId19"/>
+    <p:notesMasterId r:id="rId18"/>
   </p:notesMasterIdLst>
   <p:sldSz cx="12192000" cy="6858000"/>
   <p:notesSz cx="6858000" cy="12192000"/>
@@ -958,7 +957,7 @@
           <a:p>
             <a:r>
               <a:rPr lang="en-US" dirty="0"/>
-              <a:t>rxResource() applique le modèle resource à un Observable RxJS et expose value(), isLoading() et error().</a:t>
+              <a:t/>
             </a:r>
             <a:endParaRPr lang="en-US" dirty="0"/>
           </a:p>
@@ -1046,7 +1045,7 @@
           <a:p>
             <a:r>
               <a:rPr lang="en-US" dirty="0"/>
-              <a:t/>
+              <a:t>En Zoneless, afterEveryRender() ne se declenche que quand Angular a un rendu a effectuer — beaucoup plus previsible qu'en Zone.js.</a:t>
             </a:r>
             <a:endParaRPr lang="en-US" dirty="0"/>
           </a:p>
@@ -1134,7 +1133,7 @@
           <a:p>
             <a:r>
               <a:rPr lang="en-US" dirty="0"/>
-              <a:t>En Zoneless, afterEveryRender() ne se declenche que quand Angular a un rendu a effectuer — beaucoup plus previsible qu'en Zone.js.</a:t>
+              <a:t/>
             </a:r>
             <a:endParaRPr lang="en-US" dirty="0"/>
           </a:p>
@@ -1158,94 +1157,6 @@
             <a:fld id="{F7021451-1387-4CA6-816F-3879F97B5CBC}" type="slidenum">
               <a:rPr lang="en-US"/>
               <a:t>16</a:t>
-            </a:fld>
-            <a:endParaRPr lang="en-US"/>
-          </a:p>
-        </p:txBody>
-      </p:sp>
-    </p:spTree>
-    <p:extLst>
-      <p:ext uri="{BB962C8B-B14F-4D97-AF65-F5344CB8AC3E}">
-        <p14:creationId xmlns:p14="http://schemas.microsoft.com/office/powerpoint/2010/main" val="1024086991"/>
-      </p:ext>
-    </p:extLst>
-  </p:cSld>
-  <p:clrMapOvr>
-    <a:masterClrMapping/>
-  </p:clrMapOvr>
-</p:notes>
-</file>
-
-<file path=ppt/notesSlides/notesSlide17.xml><?xml version="1.0" encoding="utf-8"?>
-<p:notes xmlns:a="http://schemas.openxmlformats.org/drawingml/2006/main" xmlns:r="http://schemas.openxmlformats.org/officeDocument/2006/relationships" xmlns:p="http://schemas.openxmlformats.org/presentationml/2006/main">
-  <p:cSld>
-    <p:spTree>
-      <p:nvGrpSpPr>
-        <p:cNvPr id="1" name=""/>
-        <p:cNvGrpSpPr/>
-        <p:nvPr/>
-      </p:nvGrpSpPr>
-      <p:grpSpPr>
-        <a:xfrm>
-          <a:off x="0" y="0"/>
-          <a:ext cx="0" cy="0"/>
-          <a:chOff x="0" y="0"/>
-          <a:chExt cx="0" cy="0"/>
-        </a:xfrm>
-      </p:grpSpPr>
-      <p:sp>
-        <p:nvSpPr>
-          <p:cNvPr id="2" name="Slide Image Placeholder 1"/>
-          <p:cNvSpPr>
-            <a:spLocks noGrp="1" noRot="1" noChangeAspect="1"/>
-          </p:cNvSpPr>
-          <p:nvPr>
-            <p:ph type="sldImg"/>
-          </p:nvPr>
-        </p:nvSpPr>
-        <p:spPr/>
-      </p:sp>
-      <p:sp>
-        <p:nvSpPr>
-          <p:cNvPr id="3" name="Notes Placeholder 2"/>
-          <p:cNvSpPr>
-            <a:spLocks noGrp="1"/>
-          </p:cNvSpPr>
-          <p:nvPr>
-            <p:ph type="body" idx="1"/>
-          </p:nvPr>
-        </p:nvSpPr>
-        <p:spPr/>
-        <p:txBody>
-          <a:bodyPr/>
-          <a:lstStyle/>
-          <a:p>
-            <a:r>
-              <a:rPr lang="en-US" dirty="0"/>
-              <a:t/>
-            </a:r>
-            <a:endParaRPr lang="en-US" dirty="0"/>
-          </a:p>
-        </p:txBody>
-      </p:sp>
-      <p:sp>
-        <p:nvSpPr>
-          <p:cNvPr id="4" name="Slide Number Placeholder 3"/>
-          <p:cNvSpPr>
-            <a:spLocks noGrp="1"/>
-          </p:cNvSpPr>
-          <p:nvPr>
-            <p:ph type="sldNum" sz="quarter" idx="10"/>
-          </p:nvPr>
-        </p:nvSpPr>
-        <p:spPr/>
-        <p:txBody>
-          <a:bodyPr/>
-          <a:lstStyle/>
-          <a:p>
-            <a:fld id="{F7021451-1387-4CA6-816F-3879F97B5CBC}" type="slidenum">
-              <a:rPr lang="en-US"/>
-              <a:t>17</a:t>
             </a:fld>
             <a:endParaRPr lang="en-US"/>
           </a:p>
@@ -2567,7 +2478,7 @@
                   <a:srgbClr val="61716F"/>
                 </a:solidFill>
               </a:rPr>
-              <a:t>1/17</a:t>
+              <a:t>1/16</a:t>
             </a:r>
             <a:endParaRPr lang="en-US" sz="700" dirty="0"/>
           </a:p>
@@ -5953,7 +5864,7 @@
                   <a:srgbClr val="61716F"/>
                 </a:solidFill>
               </a:rPr>
-              <a:t>10/17</a:t>
+              <a:t>10/16</a:t>
             </a:r>
             <a:endParaRPr lang="en-US" sz="700" dirty="0"/>
           </a:p>
@@ -7786,7 +7697,7 @@
                   <a:srgbClr val="61716F"/>
                 </a:solidFill>
               </a:rPr>
-              <a:t>11/17</a:t>
+              <a:t>11/16</a:t>
             </a:r>
             <a:endParaRPr lang="en-US" sz="700" dirty="0"/>
           </a:p>
@@ -8245,7 +8156,7 @@
                   <a:srgbClr val="006B4F"/>
                 </a:solidFill>
               </a:rPr>
-              <a:t>9 — afterNextRender() / afterEveryRender()</a:t>
+              <a:t>9 — afterNextRender() / afterRender()</a:t>
             </a:r>
             <a:endParaRPr lang="en-US" sz="820" dirty="0"/>
           </a:p>
@@ -8613,7 +8524,7 @@
                   <a:srgbClr val="61716F"/>
                 </a:solidFill>
               </a:rPr>
-              <a:t>12/17</a:t>
+              <a:t>12/16</a:t>
             </a:r>
             <a:endParaRPr lang="en-US" sz="700" dirty="0"/>
           </a:p>
@@ -8719,7 +8630,7 @@
                   <a:srgbClr val="61716F"/>
                 </a:solidFill>
               </a:rPr>
-              <a:t>13/17</a:t>
+              <a:t>13/16</a:t>
             </a:r>
             <a:endParaRPr lang="en-US" sz="700" dirty="0"/>
           </a:p>
@@ -8814,7 +8725,7 @@
                   <a:srgbClr val="1B2B2A"/>
                 </a:solidFill>
               </a:rPr>
-              <a:t>API hors exercice — rxResource()</a:t>
+              <a:t>effect() — onCleanup</a:t>
             </a:r>
             <a:endParaRPr lang="en-US" sz="2000" dirty="0"/>
           </a:p>
@@ -8864,14 +8775,39 @@
       </p:sp>
       <p:sp>
         <p:nvSpPr>
-          <p:cNvPr id="6" name="Text 3"/>
-          <p:cNvSpPr/>
-          <p:nvPr/>
-        </p:nvSpPr>
-        <p:spPr>
-          <a:xfrm>
-            <a:off x="576072" y="932688"/>
-            <a:ext cx="11204143" cy="256032"/>
+          <p:cNvPr id="5" name="Shape 3"/>
+          <p:cNvSpPr/>
+          <p:nvPr/>
+        </p:nvSpPr>
+        <p:spPr>
+          <a:xfrm>
+            <a:off x="411480" y="932688"/>
+            <a:ext cx="5684368" cy="310896"/>
+          </a:xfrm>
+          <a:prstGeom prst="rect">
+            <a:avLst/>
+          </a:prstGeom>
+          <a:solidFill>
+            <a:srgbClr val="008A5B"/>
+          </a:solidFill>
+          <a:ln w="12700">
+            <a:solidFill>
+              <a:srgbClr val="D6E5E0"/>
+            </a:solidFill>
+            <a:prstDash val="solid"/>
+          </a:ln>
+        </p:spPr>
+      </p:sp>
+      <p:sp>
+        <p:nvSpPr>
+          <p:cNvPr id="6" name="Text 4"/>
+          <p:cNvSpPr/>
+          <p:nvPr/>
+        </p:nvSpPr>
+        <p:spPr>
+          <a:xfrm>
+            <a:off x="448056" y="960120"/>
+            <a:ext cx="5611216" cy="256032"/>
           </a:xfrm>
           <a:prstGeom prst="rect">
             <a:avLst/>
@@ -8885,28 +8821,182 @@
           </a:bodyPr>
           <a:lstStyle/>
           <a:p>
-            <a:r>
-              <a:rPr lang="en-US" sz="1160" dirty="0">
+            <a:pPr indent="0" marL="0">
+              <a:buNone/>
+            </a:pPr>
+            <a:r>
+              <a:rPr lang="en-US" sz="1020" b="1" dirty="0">
+                <a:solidFill>
+                  <a:srgbClr val="FFFFFF"/>
+                </a:solidFill>
+              </a:rPr>
+              <a:t>Sans onCleanup</a:t>
+            </a:r>
+            <a:endParaRPr lang="en-US" sz="1020" dirty="0"/>
+          </a:p>
+        </p:txBody>
+      </p:sp>
+      <p:sp>
+        <p:nvSpPr>
+          <p:cNvPr id="7" name="Shape 5"/>
+          <p:cNvSpPr/>
+          <p:nvPr/>
+        </p:nvSpPr>
+        <p:spPr>
+          <a:xfrm>
+            <a:off x="6095848" y="932688"/>
+            <a:ext cx="5684368" cy="310896"/>
+          </a:xfrm>
+          <a:prstGeom prst="rect">
+            <a:avLst/>
+          </a:prstGeom>
+          <a:solidFill>
+            <a:srgbClr val="008A5B"/>
+          </a:solidFill>
+          <a:ln w="12700">
+            <a:solidFill>
+              <a:srgbClr val="D6E5E0"/>
+            </a:solidFill>
+            <a:prstDash val="solid"/>
+          </a:ln>
+        </p:spPr>
+      </p:sp>
+      <p:sp>
+        <p:nvSpPr>
+          <p:cNvPr id="8" name="Text 6"/>
+          <p:cNvSpPr/>
+          <p:nvPr/>
+        </p:nvSpPr>
+        <p:spPr>
+          <a:xfrm>
+            <a:off x="6132424" y="960120"/>
+            <a:ext cx="5611216" cy="256032"/>
+          </a:xfrm>
+          <a:prstGeom prst="rect">
+            <a:avLst/>
+          </a:prstGeom>
+          <a:noFill/>
+          <a:ln/>
+        </p:spPr>
+        <p:txBody>
+          <a:bodyPr wrap="square" lIns="127" tIns="127" rIns="127" bIns="127" rtlCol="0" anchor="ctr">
+            <a:normAutofit/>
+          </a:bodyPr>
+          <a:lstStyle/>
+          <a:p>
+            <a:pPr indent="0" marL="0">
+              <a:buNone/>
+            </a:pPr>
+            <a:r>
+              <a:rPr lang="en-US" sz="1020" b="1" dirty="0">
+                <a:solidFill>
+                  <a:srgbClr val="FFFFFF"/>
+                </a:solidFill>
+              </a:rPr>
+              <a:t>Avec onCleanup</a:t>
+            </a:r>
+            <a:endParaRPr lang="en-US" sz="1020" dirty="0"/>
+          </a:p>
+        </p:txBody>
+      </p:sp>
+      <p:sp>
+        <p:nvSpPr>
+          <p:cNvPr id="9" name="Shape 7"/>
+          <p:cNvSpPr/>
+          <p:nvPr/>
+        </p:nvSpPr>
+        <p:spPr>
+          <a:xfrm>
+            <a:off x="411480" y="1243584"/>
+            <a:ext cx="5684368" cy="310896"/>
+          </a:xfrm>
+          <a:prstGeom prst="rect">
+            <a:avLst/>
+          </a:prstGeom>
+          <a:solidFill>
+            <a:srgbClr val="FFFFFF"/>
+          </a:solidFill>
+          <a:ln w="12700">
+            <a:solidFill>
+              <a:srgbClr val="D6E5E0"/>
+            </a:solidFill>
+            <a:prstDash val="solid"/>
+          </a:ln>
+        </p:spPr>
+      </p:sp>
+      <p:sp>
+        <p:nvSpPr>
+          <p:cNvPr id="10" name="Text 8"/>
+          <p:cNvSpPr/>
+          <p:nvPr/>
+        </p:nvSpPr>
+        <p:spPr>
+          <a:xfrm>
+            <a:off x="448056" y="1271016"/>
+            <a:ext cx="5611216" cy="256032"/>
+          </a:xfrm>
+          <a:prstGeom prst="rect">
+            <a:avLst/>
+          </a:prstGeom>
+          <a:noFill/>
+          <a:ln/>
+        </p:spPr>
+        <p:txBody>
+          <a:bodyPr wrap="square" lIns="127" tIns="127" rIns="127" bIns="127" rtlCol="0" anchor="ctr">
+            <a:normAutofit/>
+          </a:bodyPr>
+          <a:lstStyle/>
+          <a:p>
+            <a:pPr indent="0" marL="0">
+              <a:buNone/>
+            </a:pPr>
+            <a:r>
+              <a:rPr lang="en-US" sz="1020" dirty="0">
                 <a:solidFill>
                   <a:srgbClr val="263B38"/>
                 </a:solidFill>
               </a:rPr>
-              <a:t>En Angular 21.2, l'API est encore marquée experimental.</a:t>
-            </a:r>
-            <a:endParaRPr lang="en-US" sz="1160" dirty="0"/>
-          </a:p>
-        </p:txBody>
-      </p:sp>
-      <p:sp>
-        <p:nvSpPr>
-          <p:cNvPr id="7" name="Text 4"/>
-          <p:cNvSpPr/>
-          <p:nvPr/>
-        </p:nvSpPr>
-        <p:spPr>
-          <a:xfrm>
-            <a:off x="576072" y="1243584"/>
-            <a:ext cx="11204143" cy="256032"/>
+              <a:t>Chaque re-exécution crée une ressource sans supprimer la précédente</a:t>
+            </a:r>
+            <a:endParaRPr lang="en-US" sz="1020" dirty="0"/>
+          </a:p>
+        </p:txBody>
+      </p:sp>
+      <p:sp>
+        <p:nvSpPr>
+          <p:cNvPr id="11" name="Shape 9"/>
+          <p:cNvSpPr/>
+          <p:nvPr/>
+        </p:nvSpPr>
+        <p:spPr>
+          <a:xfrm>
+            <a:off x="6095848" y="1243584"/>
+            <a:ext cx="5684368" cy="310896"/>
+          </a:xfrm>
+          <a:prstGeom prst="rect">
+            <a:avLst/>
+          </a:prstGeom>
+          <a:solidFill>
+            <a:srgbClr val="FFFFFF"/>
+          </a:solidFill>
+          <a:ln w="12700">
+            <a:solidFill>
+              <a:srgbClr val="D6E5E0"/>
+            </a:solidFill>
+            <a:prstDash val="solid"/>
+          </a:ln>
+        </p:spPr>
+      </p:sp>
+      <p:sp>
+        <p:nvSpPr>
+          <p:cNvPr id="12" name="Text 10"/>
+          <p:cNvSpPr/>
+          <p:nvPr/>
+        </p:nvSpPr>
+        <p:spPr>
+          <a:xfrm>
+            <a:off x="6132424" y="1271016"/>
+            <a:ext cx="5611216" cy="256032"/>
           </a:xfrm>
           <a:prstGeom prst="rect">
             <a:avLst/>
@@ -8920,56 +9010,118 @@
           </a:bodyPr>
           <a:lstStyle/>
           <a:p>
-            <a:r>
-              <a:rPr lang="en-US" sz="1160" dirty="0">
+            <a:pPr indent="0" marL="0">
+              <a:buNone/>
+            </a:pPr>
+            <a:r>
+              <a:rPr lang="en-US" sz="1020" dirty="0">
                 <a:solidFill>
                   <a:srgbClr val="263B38"/>
                 </a:solidFill>
               </a:rPr>
-              <a:t>Elle reste hors exercices et hors convention de production pour ce dojo.</a:t>
-            </a:r>
-            <a:endParaRPr lang="en-US" sz="1160" dirty="0"/>
-          </a:p>
-        </p:txBody>
-      </p:sp>
-      <p:sp>
-        <p:nvSpPr>
-          <p:cNvPr id="8" name="Text 5"/>
-          <p:cNvSpPr/>
-          <p:nvPr/>
-        </p:nvSpPr>
-        <p:spPr>
-          <a:xfrm>
-            <a:off x="576072" y="1554480"/>
-            <a:ext cx="11204143" cy="256032"/>
-          </a:xfrm>
-          <a:prstGeom prst="rect">
-            <a:avLst/>
-          </a:prstGeom>
-          <a:noFill/>
-          <a:ln/>
-        </p:spPr>
-        <p:txBody>
-          <a:bodyPr wrap="square" lIns="127" tIns="127" rIns="127" bIns="127" rtlCol="0" anchor="ctr">
-            <a:normAutofit/>
-          </a:bodyPr>
-          <a:lstStyle/>
-          <a:p>
-            <a:r>
-              <a:rPr lang="en-US" sz="1160" dirty="0">
-                <a:solidFill>
-                  <a:srgbClr val="263B38"/>
-                </a:solidFill>
-              </a:rPr>
-              <a:t>Dans ce support, on garde toSignal() + RxJS pour les chargements HTTP.</a:t>
-            </a:r>
-            <a:endParaRPr lang="en-US" sz="1160" dirty="0"/>
-          </a:p>
-        </p:txBody>
-      </p:sp>
-      <p:sp>
-        <p:nvSpPr>
-          <p:cNvPr id="9" name="Text 6"/>
+              <a:t>La ressource est libérée avant la prochaine exécution</a:t>
+            </a:r>
+            <a:endParaRPr lang="en-US" sz="1020" dirty="0"/>
+          </a:p>
+        </p:txBody>
+      </p:sp>
+      <p:sp>
+        <p:nvSpPr>
+          <p:cNvPr id="13" name="Text 11"/>
+          <p:cNvSpPr/>
+          <p:nvPr/>
+        </p:nvSpPr>
+        <p:spPr>
+          <a:xfrm>
+            <a:off x="411480" y="1719072"/>
+            <a:ext cx="11368735" cy="786384"/>
+          </a:xfrm>
+          <a:prstGeom prst="rect">
+            <a:avLst/>
+          </a:prstGeom>
+          <a:solidFill>
+            <a:srgbClr val="15332F"/>
+          </a:solidFill>
+          <a:ln/>
+        </p:spPr>
+        <p:txBody>
+          <a:bodyPr wrap="square" lIns="1016" tIns="1016" rIns="1016" bIns="1016" rtlCol="0" anchor="t">
+            <a:normAutofit/>
+          </a:bodyPr>
+          <a:lstStyle/>
+          <a:p>
+            <a:pPr indent="0" marL="0">
+              <a:buNone/>
+            </a:pPr>
+            <a:r>
+              <a:rPr lang="en-US" sz="880" dirty="0">
+                <a:solidFill>
+                  <a:srgbClr val="F8FAFC"/>
+                </a:solidFill>
+                <a:latin typeface="Courier New" pitchFamily="34" charset="0"/>
+                <a:ea typeface="Courier New" pitchFamily="34" charset="-122"/>
+                <a:cs typeface="Courier New" pitchFamily="34" charset="-120"/>
+              </a:rPr>
+              <a:t>effect((onCleanup) =&gt; {</a:t>
+            </a:r>
+            <a:endParaRPr lang="en-US" sz="880" dirty="0"/>
+          </a:p>
+          <a:p>
+            <a:pPr indent="0" marL="0">
+              <a:buNone/>
+            </a:pPr>
+            <a:r>
+              <a:rPr lang="en-US" sz="880" dirty="0">
+                <a:solidFill>
+                  <a:srgbClr val="F8FAFC"/>
+                </a:solidFill>
+                <a:latin typeface="Courier New" pitchFamily="34" charset="0"/>
+                <a:ea typeface="Courier New" pitchFamily="34" charset="-122"/>
+                <a:cs typeface="Courier New" pitchFamily="34" charset="-120"/>
+              </a:rPr>
+              <a:t>  const id = setInterval(() =&gt; console.log(this.search()), 1000);</a:t>
+            </a:r>
+            <a:endParaRPr lang="en-US" sz="880" dirty="0"/>
+          </a:p>
+          <a:p>
+            <a:pPr indent="0" marL="0">
+              <a:buNone/>
+            </a:pPr>
+            <a:r>
+              <a:rPr lang="en-US" sz="880" dirty="0">
+                <a:solidFill>
+                  <a:srgbClr val="F8FAFC"/>
+                </a:solidFill>
+                <a:latin typeface="Courier New" pitchFamily="34" charset="0"/>
+                <a:ea typeface="Courier New" pitchFamily="34" charset="-122"/>
+                <a:cs typeface="Courier New" pitchFamily="34" charset="-120"/>
+              </a:rPr>
+              <a:t>  onCleanup(() =&gt; clearInterval(id));</a:t>
+            </a:r>
+            <a:endParaRPr lang="en-US" sz="880" dirty="0"/>
+          </a:p>
+          <a:p>
+            <a:pPr indent="0" marL="0">
+              <a:buNone/>
+            </a:pPr>
+            <a:r>
+              <a:rPr lang="en-US" sz="880" dirty="0">
+                <a:solidFill>
+                  <a:srgbClr val="F8FAFC"/>
+                </a:solidFill>
+                <a:latin typeface="Courier New" pitchFamily="34" charset="0"/>
+                <a:ea typeface="Courier New" pitchFamily="34" charset="-122"/>
+                <a:cs typeface="Courier New" pitchFamily="34" charset="-120"/>
+              </a:rPr>
+              <a:t>});</a:t>
+            </a:r>
+            <a:endParaRPr lang="en-US" sz="880" dirty="0"/>
+          </a:p>
+        </p:txBody>
+      </p:sp>
+      <p:sp>
+        <p:nvSpPr>
+          <p:cNvPr id="14" name="Text 12"/>
           <p:cNvSpPr/>
           <p:nvPr/>
         </p:nvSpPr>
@@ -8997,7 +9149,7 @@
                   <a:srgbClr val="61716F"/>
                 </a:solidFill>
               </a:rPr>
-              <a:t>14/17</a:t>
+              <a:t>14/16</a:t>
             </a:r>
             <a:endParaRPr lang="en-US" sz="700" dirty="0"/>
           </a:p>
@@ -9092,7 +9244,7 @@
                   <a:srgbClr val="1B2B2A"/>
                 </a:solidFill>
               </a:rPr>
-              <a:t>effect() — onCleanup</a:t>
+              <a:t>afterNextRender() vs afterEveryRender()</a:t>
             </a:r>
             <a:endParaRPr lang="en-US" sz="2000" dirty="0"/>
           </a:p>
@@ -9142,14 +9294,14 @@
       </p:sp>
       <p:sp>
         <p:nvSpPr>
-          <p:cNvPr id="5" name="Shape 3"/>
+          <p:cNvPr id="6" name="Shape 3"/>
           <p:cNvSpPr/>
           <p:nvPr/>
         </p:nvSpPr>
         <p:spPr>
           <a:xfrm>
             <a:off x="411480" y="932688"/>
-            <a:ext cx="5684368" cy="310896"/>
+            <a:ext cx="1417320" cy="310896"/>
           </a:xfrm>
           <a:prstGeom prst="rect">
             <a:avLst/>
@@ -9167,14 +9319,14 @@
       </p:sp>
       <p:sp>
         <p:nvSpPr>
-          <p:cNvPr id="6" name="Text 4"/>
+          <p:cNvPr id="7" name="Text 4"/>
           <p:cNvSpPr/>
           <p:nvPr/>
         </p:nvSpPr>
         <p:spPr>
           <a:xfrm>
             <a:off x="448056" y="960120"/>
-            <a:ext cx="5611216" cy="256032"/>
+            <a:ext cx="1344168" cy="256032"/>
           </a:xfrm>
           <a:prstGeom prst="rect">
             <a:avLst/>
@@ -9191,13 +9343,68 @@
             <a:pPr indent="0" marL="0">
               <a:buNone/>
             </a:pPr>
+            <a:endParaRPr lang="en-US" sz="1020" dirty="0"/>
+          </a:p>
+        </p:txBody>
+      </p:sp>
+      <p:sp>
+        <p:nvSpPr>
+          <p:cNvPr id="8" name="Shape 5"/>
+          <p:cNvSpPr/>
+          <p:nvPr/>
+        </p:nvSpPr>
+        <p:spPr>
+          <a:xfrm>
+            <a:off x="1828800" y="932688"/>
+            <a:ext cx="2834640" cy="310896"/>
+          </a:xfrm>
+          <a:prstGeom prst="rect">
+            <a:avLst/>
+          </a:prstGeom>
+          <a:solidFill>
+            <a:srgbClr val="008A5B"/>
+          </a:solidFill>
+          <a:ln w="12700">
+            <a:solidFill>
+              <a:srgbClr val="D6E5E0"/>
+            </a:solidFill>
+            <a:prstDash val="solid"/>
+          </a:ln>
+        </p:spPr>
+      </p:sp>
+      <p:sp>
+        <p:nvSpPr>
+          <p:cNvPr id="9" name="Text 6"/>
+          <p:cNvSpPr/>
+          <p:nvPr/>
+        </p:nvSpPr>
+        <p:spPr>
+          <a:xfrm>
+            <a:off x="1865376" y="960120"/>
+            <a:ext cx="2761488" cy="256032"/>
+          </a:xfrm>
+          <a:prstGeom prst="rect">
+            <a:avLst/>
+          </a:prstGeom>
+          <a:noFill/>
+          <a:ln/>
+        </p:spPr>
+        <p:txBody>
+          <a:bodyPr wrap="square" lIns="127" tIns="127" rIns="127" bIns="127" rtlCol="0" anchor="ctr">
+            <a:normAutofit/>
+          </a:bodyPr>
+          <a:lstStyle/>
+          <a:p>
+            <a:pPr indent="0" marL="0">
+              <a:buNone/>
+            </a:pPr>
             <a:r>
               <a:rPr lang="en-US" sz="1020" b="1" dirty="0">
                 <a:solidFill>
                   <a:srgbClr val="FFFFFF"/>
                 </a:solidFill>
               </a:rPr>
-              <a:t>Sans onCleanup</a:t>
+              <a:t>afterNextRender()</a:t>
             </a:r>
             <a:endParaRPr lang="en-US" sz="1020" dirty="0"/>
           </a:p>
@@ -9205,14 +9412,14 @@
       </p:sp>
       <p:sp>
         <p:nvSpPr>
-          <p:cNvPr id="7" name="Shape 5"/>
-          <p:cNvSpPr/>
-          <p:nvPr/>
-        </p:nvSpPr>
-        <p:spPr>
-          <a:xfrm>
-            <a:off x="6095848" y="932688"/>
-            <a:ext cx="5684368" cy="310896"/>
+          <p:cNvPr id="10" name="Shape 7"/>
+          <p:cNvSpPr/>
+          <p:nvPr/>
+        </p:nvSpPr>
+        <p:spPr>
+          <a:xfrm>
+            <a:off x="4663440" y="932688"/>
+            <a:ext cx="7116775" cy="310896"/>
           </a:xfrm>
           <a:prstGeom prst="rect">
             <a:avLst/>
@@ -9230,14 +9437,14 @@
       </p:sp>
       <p:sp>
         <p:nvSpPr>
-          <p:cNvPr id="8" name="Text 6"/>
-          <p:cNvSpPr/>
-          <p:nvPr/>
-        </p:nvSpPr>
-        <p:spPr>
-          <a:xfrm>
-            <a:off x="6132424" y="960120"/>
-            <a:ext cx="5611216" cy="256032"/>
+          <p:cNvPr id="11" name="Text 8"/>
+          <p:cNvSpPr/>
+          <p:nvPr/>
+        </p:nvSpPr>
+        <p:spPr>
+          <a:xfrm>
+            <a:off x="4700016" y="960120"/>
+            <a:ext cx="7043623" cy="256032"/>
           </a:xfrm>
           <a:prstGeom prst="rect">
             <a:avLst/>
@@ -9260,7 +9467,7 @@
                   <a:srgbClr val="FFFFFF"/>
                 </a:solidFill>
               </a:rPr>
-              <a:t>Avec onCleanup</a:t>
+              <a:t>afterEveryRender()</a:t>
             </a:r>
             <a:endParaRPr lang="en-US" sz="1020" dirty="0"/>
           </a:p>
@@ -9268,14 +9475,14 @@
       </p:sp>
       <p:sp>
         <p:nvSpPr>
-          <p:cNvPr id="9" name="Shape 7"/>
+          <p:cNvPr id="12" name="Shape 9"/>
           <p:cNvSpPr/>
           <p:nvPr/>
         </p:nvSpPr>
         <p:spPr>
           <a:xfrm>
             <a:off x="411480" y="1243584"/>
-            <a:ext cx="5684368" cy="310896"/>
+            <a:ext cx="1417320" cy="310896"/>
           </a:xfrm>
           <a:prstGeom prst="rect">
             <a:avLst/>
@@ -9293,14 +9500,14 @@
       </p:sp>
       <p:sp>
         <p:nvSpPr>
-          <p:cNvPr id="10" name="Text 8"/>
+          <p:cNvPr id="13" name="Text 10"/>
           <p:cNvSpPr/>
           <p:nvPr/>
         </p:nvSpPr>
         <p:spPr>
           <a:xfrm>
             <a:off x="448056" y="1271016"/>
-            <a:ext cx="5611216" cy="256032"/>
+            <a:ext cx="1344168" cy="256032"/>
           </a:xfrm>
           <a:prstGeom prst="rect">
             <a:avLst/>
@@ -9323,7 +9530,7 @@
                   <a:srgbClr val="263B38"/>
                 </a:solidFill>
               </a:rPr>
-              <a:t>Chaque re-exécution crée une ressource sans supprimer la précédente</a:t>
+              <a:t>Frequence</a:t>
             </a:r>
             <a:endParaRPr lang="en-US" sz="1020" dirty="0"/>
           </a:p>
@@ -9331,14 +9538,14 @@
       </p:sp>
       <p:sp>
         <p:nvSpPr>
-          <p:cNvPr id="11" name="Shape 9"/>
-          <p:cNvSpPr/>
-          <p:nvPr/>
-        </p:nvSpPr>
-        <p:spPr>
-          <a:xfrm>
-            <a:off x="6095848" y="1243584"/>
-            <a:ext cx="5684368" cy="310896"/>
+          <p:cNvPr id="14" name="Shape 11"/>
+          <p:cNvSpPr/>
+          <p:nvPr/>
+        </p:nvSpPr>
+        <p:spPr>
+          <a:xfrm>
+            <a:off x="1828800" y="1243584"/>
+            <a:ext cx="2834640" cy="310896"/>
           </a:xfrm>
           <a:prstGeom prst="rect">
             <a:avLst/>
@@ -9356,14 +9563,14 @@
       </p:sp>
       <p:sp>
         <p:nvSpPr>
-          <p:cNvPr id="12" name="Text 10"/>
-          <p:cNvSpPr/>
-          <p:nvPr/>
-        </p:nvSpPr>
-        <p:spPr>
-          <a:xfrm>
-            <a:off x="6132424" y="1271016"/>
-            <a:ext cx="5611216" cy="256032"/>
+          <p:cNvPr id="15" name="Text 12"/>
+          <p:cNvSpPr/>
+          <p:nvPr/>
+        </p:nvSpPr>
+        <p:spPr>
+          <a:xfrm>
+            <a:off x="1865376" y="1271016"/>
+            <a:ext cx="2761488" cy="256032"/>
           </a:xfrm>
           <a:prstGeom prst="rect">
             <a:avLst/>
@@ -9386,7 +9593,7 @@
                   <a:srgbClr val="263B38"/>
                 </a:solidFill>
               </a:rPr>
-              <a:t>La ressource est libérée avant la prochaine exécution</a:t>
+              <a:t>Une seule fois apres le prochain rendu</a:t>
             </a:r>
             <a:endParaRPr lang="en-US" sz="1020" dirty="0"/>
           </a:p>
@@ -9394,14 +9601,455 @@
       </p:sp>
       <p:sp>
         <p:nvSpPr>
-          <p:cNvPr id="13" name="Text 11"/>
-          <p:cNvSpPr/>
-          <p:nvPr/>
-        </p:nvSpPr>
-        <p:spPr>
-          <a:xfrm>
-            <a:off x="411480" y="1719072"/>
-            <a:ext cx="11368735" cy="786384"/>
+          <p:cNvPr id="16" name="Shape 13"/>
+          <p:cNvSpPr/>
+          <p:nvPr/>
+        </p:nvSpPr>
+        <p:spPr>
+          <a:xfrm>
+            <a:off x="4663440" y="1243584"/>
+            <a:ext cx="7116775" cy="310896"/>
+          </a:xfrm>
+          <a:prstGeom prst="rect">
+            <a:avLst/>
+          </a:prstGeom>
+          <a:solidFill>
+            <a:srgbClr val="FFFFFF"/>
+          </a:solidFill>
+          <a:ln w="12700">
+            <a:solidFill>
+              <a:srgbClr val="D6E5E0"/>
+            </a:solidFill>
+            <a:prstDash val="solid"/>
+          </a:ln>
+        </p:spPr>
+      </p:sp>
+      <p:sp>
+        <p:nvSpPr>
+          <p:cNvPr id="17" name="Text 14"/>
+          <p:cNvSpPr/>
+          <p:nvPr/>
+        </p:nvSpPr>
+        <p:spPr>
+          <a:xfrm>
+            <a:off x="4700016" y="1271016"/>
+            <a:ext cx="7043623" cy="256032"/>
+          </a:xfrm>
+          <a:prstGeom prst="rect">
+            <a:avLst/>
+          </a:prstGeom>
+          <a:noFill/>
+          <a:ln/>
+        </p:spPr>
+        <p:txBody>
+          <a:bodyPr wrap="square" lIns="127" tIns="127" rIns="127" bIns="127" rtlCol="0" anchor="ctr">
+            <a:normAutofit/>
+          </a:bodyPr>
+          <a:lstStyle/>
+          <a:p>
+            <a:pPr indent="0" marL="0">
+              <a:buNone/>
+            </a:pPr>
+            <a:r>
+              <a:rPr lang="en-US" sz="1020" dirty="0">
+                <a:solidFill>
+                  <a:srgbClr val="263B38"/>
+                </a:solidFill>
+              </a:rPr>
+              <a:t>Apres chaque cycle de rendu</a:t>
+            </a:r>
+            <a:endParaRPr lang="en-US" sz="1020" dirty="0"/>
+          </a:p>
+        </p:txBody>
+      </p:sp>
+      <p:sp>
+        <p:nvSpPr>
+          <p:cNvPr id="18" name="Shape 15"/>
+          <p:cNvSpPr/>
+          <p:nvPr/>
+        </p:nvSpPr>
+        <p:spPr>
+          <a:xfrm>
+            <a:off x="411480" y="1554480"/>
+            <a:ext cx="1417320" cy="310896"/>
+          </a:xfrm>
+          <a:prstGeom prst="rect">
+            <a:avLst/>
+          </a:prstGeom>
+          <a:solidFill>
+            <a:srgbClr val="F3F8F6"/>
+          </a:solidFill>
+          <a:ln w="12700">
+            <a:solidFill>
+              <a:srgbClr val="D6E5E0"/>
+            </a:solidFill>
+            <a:prstDash val="solid"/>
+          </a:ln>
+        </p:spPr>
+      </p:sp>
+      <p:sp>
+        <p:nvSpPr>
+          <p:cNvPr id="19" name="Text 16"/>
+          <p:cNvSpPr/>
+          <p:nvPr/>
+        </p:nvSpPr>
+        <p:spPr>
+          <a:xfrm>
+            <a:off x="448056" y="1581912"/>
+            <a:ext cx="1344168" cy="256032"/>
+          </a:xfrm>
+          <a:prstGeom prst="rect">
+            <a:avLst/>
+          </a:prstGeom>
+          <a:noFill/>
+          <a:ln/>
+        </p:spPr>
+        <p:txBody>
+          <a:bodyPr wrap="square" lIns="127" tIns="127" rIns="127" bIns="127" rtlCol="0" anchor="ctr">
+            <a:normAutofit/>
+          </a:bodyPr>
+          <a:lstStyle/>
+          <a:p>
+            <a:pPr indent="0" marL="0">
+              <a:buNone/>
+            </a:pPr>
+            <a:r>
+              <a:rPr lang="en-US" sz="1020" dirty="0">
+                <a:solidFill>
+                  <a:srgbClr val="263B38"/>
+                </a:solidFill>
+              </a:rPr>
+              <a:t>Usage typique</a:t>
+            </a:r>
+            <a:endParaRPr lang="en-US" sz="1020" dirty="0"/>
+          </a:p>
+        </p:txBody>
+      </p:sp>
+      <p:sp>
+        <p:nvSpPr>
+          <p:cNvPr id="20" name="Shape 17"/>
+          <p:cNvSpPr/>
+          <p:nvPr/>
+        </p:nvSpPr>
+        <p:spPr>
+          <a:xfrm>
+            <a:off x="1828800" y="1554480"/>
+            <a:ext cx="2834640" cy="310896"/>
+          </a:xfrm>
+          <a:prstGeom prst="rect">
+            <a:avLst/>
+          </a:prstGeom>
+          <a:solidFill>
+            <a:srgbClr val="F3F8F6"/>
+          </a:solidFill>
+          <a:ln w="12700">
+            <a:solidFill>
+              <a:srgbClr val="D6E5E0"/>
+            </a:solidFill>
+            <a:prstDash val="solid"/>
+          </a:ln>
+        </p:spPr>
+      </p:sp>
+      <p:sp>
+        <p:nvSpPr>
+          <p:cNvPr id="21" name="Text 18"/>
+          <p:cNvSpPr/>
+          <p:nvPr/>
+        </p:nvSpPr>
+        <p:spPr>
+          <a:xfrm>
+            <a:off x="1865376" y="1581912"/>
+            <a:ext cx="2761488" cy="256032"/>
+          </a:xfrm>
+          <a:prstGeom prst="rect">
+            <a:avLst/>
+          </a:prstGeom>
+          <a:noFill/>
+          <a:ln/>
+        </p:spPr>
+        <p:txBody>
+          <a:bodyPr wrap="square" lIns="127" tIns="127" rIns="127" bIns="127" rtlCol="0" anchor="ctr">
+            <a:normAutofit/>
+          </a:bodyPr>
+          <a:lstStyle/>
+          <a:p>
+            <a:pPr indent="0" marL="0">
+              <a:buNone/>
+            </a:pPr>
+            <a:r>
+              <a:rPr lang="en-US" sz="1020" dirty="0">
+                <a:solidFill>
+                  <a:srgbClr val="263B38"/>
+                </a:solidFill>
+              </a:rPr>
+              <a:t>Scroll one-shot, init librairie tierce</a:t>
+            </a:r>
+            <a:endParaRPr lang="en-US" sz="1020" dirty="0"/>
+          </a:p>
+        </p:txBody>
+      </p:sp>
+      <p:sp>
+        <p:nvSpPr>
+          <p:cNvPr id="22" name="Shape 19"/>
+          <p:cNvSpPr/>
+          <p:nvPr/>
+        </p:nvSpPr>
+        <p:spPr>
+          <a:xfrm>
+            <a:off x="4663440" y="1554480"/>
+            <a:ext cx="7116775" cy="310896"/>
+          </a:xfrm>
+          <a:prstGeom prst="rect">
+            <a:avLst/>
+          </a:prstGeom>
+          <a:solidFill>
+            <a:srgbClr val="F3F8F6"/>
+          </a:solidFill>
+          <a:ln w="12700">
+            <a:solidFill>
+              <a:srgbClr val="D6E5E0"/>
+            </a:solidFill>
+            <a:prstDash val="solid"/>
+          </a:ln>
+        </p:spPr>
+      </p:sp>
+      <p:sp>
+        <p:nvSpPr>
+          <p:cNvPr id="23" name="Text 20"/>
+          <p:cNvSpPr/>
+          <p:nvPr/>
+        </p:nvSpPr>
+        <p:spPr>
+          <a:xfrm>
+            <a:off x="4700016" y="1581912"/>
+            <a:ext cx="7043623" cy="256032"/>
+          </a:xfrm>
+          <a:prstGeom prst="rect">
+            <a:avLst/>
+          </a:prstGeom>
+          <a:noFill/>
+          <a:ln/>
+        </p:spPr>
+        <p:txBody>
+          <a:bodyPr wrap="square" lIns="127" tIns="127" rIns="127" bIns="127" rtlCol="0" anchor="ctr">
+            <a:normAutofit/>
+          </a:bodyPr>
+          <a:lstStyle/>
+          <a:p>
+            <a:pPr indent="0" marL="0">
+              <a:buNone/>
+            </a:pPr>
+            <a:r>
+              <a:rPr lang="en-US" sz="1020" dirty="0">
+                <a:solidFill>
+                  <a:srgbClr val="263B38"/>
+                </a:solidFill>
+              </a:rPr>
+              <a:t>Mesures DOM continues, animations</a:t>
+            </a:r>
+            <a:endParaRPr lang="en-US" sz="1020" dirty="0"/>
+          </a:p>
+        </p:txBody>
+      </p:sp>
+      <p:sp>
+        <p:nvSpPr>
+          <p:cNvPr id="24" name="Shape 21"/>
+          <p:cNvSpPr/>
+          <p:nvPr/>
+        </p:nvSpPr>
+        <p:spPr>
+          <a:xfrm>
+            <a:off x="411480" y="1865376"/>
+            <a:ext cx="1417320" cy="310896"/>
+          </a:xfrm>
+          <a:prstGeom prst="rect">
+            <a:avLst/>
+          </a:prstGeom>
+          <a:solidFill>
+            <a:srgbClr val="FFFFFF"/>
+          </a:solidFill>
+          <a:ln w="12700">
+            <a:solidFill>
+              <a:srgbClr val="D6E5E0"/>
+            </a:solidFill>
+            <a:prstDash val="solid"/>
+          </a:ln>
+        </p:spPr>
+      </p:sp>
+      <p:sp>
+        <p:nvSpPr>
+          <p:cNvPr id="25" name="Text 22"/>
+          <p:cNvSpPr/>
+          <p:nvPr/>
+        </p:nvSpPr>
+        <p:spPr>
+          <a:xfrm>
+            <a:off x="448056" y="1892808"/>
+            <a:ext cx="1344168" cy="256032"/>
+          </a:xfrm>
+          <a:prstGeom prst="rect">
+            <a:avLst/>
+          </a:prstGeom>
+          <a:noFill/>
+          <a:ln/>
+        </p:spPr>
+        <p:txBody>
+          <a:bodyPr wrap="square" lIns="127" tIns="127" rIns="127" bIns="127" rtlCol="0" anchor="ctr">
+            <a:normAutofit/>
+          </a:bodyPr>
+          <a:lstStyle/>
+          <a:p>
+            <a:pPr indent="0" marL="0">
+              <a:buNone/>
+            </a:pPr>
+            <a:r>
+              <a:rPr lang="en-US" sz="1020" dirty="0">
+                <a:solidFill>
+                  <a:srgbClr val="263B38"/>
+                </a:solidFill>
+              </a:rPr>
+              <a:t>Risque</a:t>
+            </a:r>
+            <a:endParaRPr lang="en-US" sz="1020" dirty="0"/>
+          </a:p>
+        </p:txBody>
+      </p:sp>
+      <p:sp>
+        <p:nvSpPr>
+          <p:cNvPr id="26" name="Shape 23"/>
+          <p:cNvSpPr/>
+          <p:nvPr/>
+        </p:nvSpPr>
+        <p:spPr>
+          <a:xfrm>
+            <a:off x="1828800" y="1865376"/>
+            <a:ext cx="2834640" cy="310896"/>
+          </a:xfrm>
+          <a:prstGeom prst="rect">
+            <a:avLst/>
+          </a:prstGeom>
+          <a:solidFill>
+            <a:srgbClr val="FFFFFF"/>
+          </a:solidFill>
+          <a:ln w="12700">
+            <a:solidFill>
+              <a:srgbClr val="D6E5E0"/>
+            </a:solidFill>
+            <a:prstDash val="solid"/>
+          </a:ln>
+        </p:spPr>
+      </p:sp>
+      <p:sp>
+        <p:nvSpPr>
+          <p:cNvPr id="27" name="Text 24"/>
+          <p:cNvSpPr/>
+          <p:nvPr/>
+        </p:nvSpPr>
+        <p:spPr>
+          <a:xfrm>
+            <a:off x="1865376" y="1892808"/>
+            <a:ext cx="2761488" cy="256032"/>
+          </a:xfrm>
+          <a:prstGeom prst="rect">
+            <a:avLst/>
+          </a:prstGeom>
+          <a:noFill/>
+          <a:ln/>
+        </p:spPr>
+        <p:txBody>
+          <a:bodyPr wrap="square" lIns="127" tIns="127" rIns="127" bIns="127" rtlCol="0" anchor="ctr">
+            <a:normAutofit/>
+          </a:bodyPr>
+          <a:lstStyle/>
+          <a:p>
+            <a:pPr indent="0" marL="0">
+              <a:buNone/>
+            </a:pPr>
+            <a:r>
+              <a:rPr lang="en-US" sz="1020" dirty="0">
+                <a:solidFill>
+                  <a:srgbClr val="263B38"/>
+                </a:solidFill>
+              </a:rPr>
+              <a:t>Aucun surcout apres execution</a:t>
+            </a:r>
+            <a:endParaRPr lang="en-US" sz="1020" dirty="0"/>
+          </a:p>
+        </p:txBody>
+      </p:sp>
+      <p:sp>
+        <p:nvSpPr>
+          <p:cNvPr id="28" name="Shape 25"/>
+          <p:cNvSpPr/>
+          <p:nvPr/>
+        </p:nvSpPr>
+        <p:spPr>
+          <a:xfrm>
+            <a:off x="4663440" y="1865376"/>
+            <a:ext cx="7116775" cy="310896"/>
+          </a:xfrm>
+          <a:prstGeom prst="rect">
+            <a:avLst/>
+          </a:prstGeom>
+          <a:solidFill>
+            <a:srgbClr val="FFFFFF"/>
+          </a:solidFill>
+          <a:ln w="12700">
+            <a:solidFill>
+              <a:srgbClr val="D6E5E0"/>
+            </a:solidFill>
+            <a:prstDash val="solid"/>
+          </a:ln>
+        </p:spPr>
+      </p:sp>
+      <p:sp>
+        <p:nvSpPr>
+          <p:cNvPr id="29" name="Text 26"/>
+          <p:cNvSpPr/>
+          <p:nvPr/>
+        </p:nvSpPr>
+        <p:spPr>
+          <a:xfrm>
+            <a:off x="4700016" y="1892808"/>
+            <a:ext cx="7043623" cy="256032"/>
+          </a:xfrm>
+          <a:prstGeom prst="rect">
+            <a:avLst/>
+          </a:prstGeom>
+          <a:noFill/>
+          <a:ln/>
+        </p:spPr>
+        <p:txBody>
+          <a:bodyPr wrap="square" lIns="127" tIns="127" rIns="127" bIns="127" rtlCol="0" anchor="ctr">
+            <a:normAutofit/>
+          </a:bodyPr>
+          <a:lstStyle/>
+          <a:p>
+            <a:pPr indent="0" marL="0">
+              <a:buNone/>
+            </a:pPr>
+            <a:r>
+              <a:rPr lang="en-US" sz="1020" dirty="0">
+                <a:solidFill>
+                  <a:srgbClr val="263B38"/>
+                </a:solidFill>
+              </a:rPr>
+              <a:t>Couteux si le rendu est frequent</a:t>
+            </a:r>
+            <a:endParaRPr lang="en-US" sz="1020" dirty="0"/>
+          </a:p>
+        </p:txBody>
+      </p:sp>
+      <p:sp>
+        <p:nvSpPr>
+          <p:cNvPr id="30" name="Text 27"/>
+          <p:cNvSpPr/>
+          <p:nvPr/>
+        </p:nvSpPr>
+        <p:spPr>
+          <a:xfrm>
+            <a:off x="411480" y="2340864"/>
+            <a:ext cx="11368735" cy="941832"/>
           </a:xfrm>
           <a:prstGeom prst="rect">
             <a:avLst/>
@@ -9429,7 +10077,7 @@
                 <a:ea typeface="Courier New" pitchFamily="34" charset="-122"/>
                 <a:cs typeface="Courier New" pitchFamily="34" charset="-120"/>
               </a:rPr>
-              <a:t>effect((onCleanup) =&gt; {</a:t>
+              <a:t>// one-shot : scroll apres un ajout</a:t>
             </a:r>
             <a:endParaRPr lang="en-US" sz="880" dirty="0"/>
           </a:p>
@@ -9446,8 +10094,14 @@
                 <a:ea typeface="Courier New" pitchFamily="34" charset="-122"/>
                 <a:cs typeface="Courier New" pitchFamily="34" charset="-120"/>
               </a:rPr>
-              <a:t>  const id = setInterval(() =&gt; console.log(this.search()), 1000);</a:t>
-            </a:r>
+              <a:t>afterNextRender(() =&gt; viewport.scrollToIndex(0), { injector });</a:t>
+            </a:r>
+            <a:endParaRPr lang="en-US" sz="880" dirty="0"/>
+          </a:p>
+          <a:p>
+            <a:pPr indent="0" marL="0">
+              <a:buNone/>
+            </a:pPr>
             <a:endParaRPr lang="en-US" sz="880" dirty="0"/>
           </a:p>
           <a:p>
@@ -9463,7 +10117,7 @@
                 <a:ea typeface="Courier New" pitchFamily="34" charset="-122"/>
                 <a:cs typeface="Courier New" pitchFamily="34" charset="-120"/>
               </a:rPr>
-              <a:t>  onCleanup(() =&gt; clearInterval(id));</a:t>
+              <a:t>// recurrent : mesure la hauteur a chaque rendu</a:t>
             </a:r>
             <a:endParaRPr lang="en-US" sz="880" dirty="0"/>
           </a:p>
@@ -9480,7 +10134,7 @@
                 <a:ea typeface="Courier New" pitchFamily="34" charset="-122"/>
                 <a:cs typeface="Courier New" pitchFamily="34" charset="-120"/>
               </a:rPr>
-              <a:t>});</a:t>
+              <a:t>afterEveryRender(() =&gt; { this.height.set(el.nativeElement.offsetHeight); });</a:t>
             </a:r>
             <a:endParaRPr lang="en-US" sz="880" dirty="0"/>
           </a:p>
@@ -9488,7 +10142,7 @@
       </p:sp>
       <p:sp>
         <p:nvSpPr>
-          <p:cNvPr id="14" name="Text 12"/>
+          <p:cNvPr id="31" name="Text 28"/>
           <p:cNvSpPr/>
           <p:nvPr/>
         </p:nvSpPr>
@@ -9516,7 +10170,7 @@
                   <a:srgbClr val="61716F"/>
                 </a:solidFill>
               </a:rPr>
-              <a:t>15/17</a:t>
+              <a:t>15/16</a:t>
             </a:r>
             <a:endParaRPr lang="en-US" sz="700" dirty="0"/>
           </a:p>
@@ -9569,1027 +10223,6 @@
             <a:avLst/>
           </a:prstGeom>
           <a:solidFill>
-            <a:srgbClr val="008A5B"/>
-          </a:solidFill>
-          <a:ln w="12700">
-            <a:solidFill>
-              <a:srgbClr val="008A5B"/>
-            </a:solidFill>
-            <a:prstDash val="solid"/>
-          </a:ln>
-        </p:spPr>
-      </p:sp>
-      <p:sp>
-        <p:nvSpPr>
-          <p:cNvPr id="3" name="Text 1"/>
-          <p:cNvSpPr/>
-          <p:nvPr/>
-        </p:nvSpPr>
-        <p:spPr>
-          <a:xfrm>
-            <a:off x="411480" y="219456"/>
-            <a:ext cx="9357055" cy="347472"/>
-          </a:xfrm>
-          <a:prstGeom prst="rect">
-            <a:avLst/>
-          </a:prstGeom>
-          <a:noFill/>
-          <a:ln/>
-        </p:spPr>
-        <p:txBody>
-          <a:bodyPr wrap="square" lIns="0" tIns="0" rIns="0" bIns="0" rtlCol="0" anchor="ctr">
-            <a:normAutofit/>
-          </a:bodyPr>
-          <a:lstStyle/>
-          <a:p>
-            <a:pPr indent="0" marL="0">
-              <a:buNone/>
-            </a:pPr>
-            <a:r>
-              <a:rPr lang="en-US" sz="2000" b="1" dirty="0">
-                <a:solidFill>
-                  <a:srgbClr val="1B2B2A"/>
-                </a:solidFill>
-              </a:rPr>
-              <a:t>afterNextRender() vs afterEveryRender()</a:t>
-            </a:r>
-            <a:endParaRPr lang="en-US" sz="2000" dirty="0"/>
-          </a:p>
-        </p:txBody>
-      </p:sp>
-      <p:sp>
-        <p:nvSpPr>
-          <p:cNvPr id="4" name="Text 2"/>
-          <p:cNvSpPr/>
-          <p:nvPr/>
-        </p:nvSpPr>
-        <p:spPr>
-          <a:xfrm>
-            <a:off x="10317175" y="246888"/>
-            <a:ext cx="1463040" cy="219456"/>
-          </a:xfrm>
-          <a:prstGeom prst="rect">
-            <a:avLst/>
-          </a:prstGeom>
-          <a:solidFill>
-            <a:srgbClr val="CFEDE2"/>
-          </a:solidFill>
-          <a:ln>
-            <a:solidFill>
-              <a:srgbClr val="CFEDE2"/>
-            </a:solidFill>
-          </a:ln>
-        </p:spPr>
-        <p:txBody>
-          <a:bodyPr wrap="square" lIns="254" tIns="254" rIns="254" bIns="254" rtlCol="0" anchor="ctr"/>
-          <a:lstStyle/>
-          <a:p>
-            <a:pPr algn="ctr" indent="0" marL="0">
-              <a:buNone/>
-            </a:pPr>
-            <a:r>
-              <a:rPr lang="en-US" sz="800" b="1" dirty="0">
-                <a:solidFill>
-                  <a:srgbClr val="008A5B"/>
-                </a:solidFill>
-              </a:rPr>
-              <a:t>BNP Paribas</a:t>
-            </a:r>
-            <a:endParaRPr lang="en-US" sz="800" dirty="0"/>
-          </a:p>
-        </p:txBody>
-      </p:sp>
-      <p:sp>
-        <p:nvSpPr>
-          <p:cNvPr id="6" name="Shape 3"/>
-          <p:cNvSpPr/>
-          <p:nvPr/>
-        </p:nvSpPr>
-        <p:spPr>
-          <a:xfrm>
-            <a:off x="411480" y="932688"/>
-            <a:ext cx="1417320" cy="310896"/>
-          </a:xfrm>
-          <a:prstGeom prst="rect">
-            <a:avLst/>
-          </a:prstGeom>
-          <a:solidFill>
-            <a:srgbClr val="008A5B"/>
-          </a:solidFill>
-          <a:ln w="12700">
-            <a:solidFill>
-              <a:srgbClr val="D6E5E0"/>
-            </a:solidFill>
-            <a:prstDash val="solid"/>
-          </a:ln>
-        </p:spPr>
-      </p:sp>
-      <p:sp>
-        <p:nvSpPr>
-          <p:cNvPr id="7" name="Text 4"/>
-          <p:cNvSpPr/>
-          <p:nvPr/>
-        </p:nvSpPr>
-        <p:spPr>
-          <a:xfrm>
-            <a:off x="448056" y="960120"/>
-            <a:ext cx="1344168" cy="256032"/>
-          </a:xfrm>
-          <a:prstGeom prst="rect">
-            <a:avLst/>
-          </a:prstGeom>
-          <a:noFill/>
-          <a:ln/>
-        </p:spPr>
-        <p:txBody>
-          <a:bodyPr wrap="square" lIns="127" tIns="127" rIns="127" bIns="127" rtlCol="0" anchor="ctr">
-            <a:normAutofit/>
-          </a:bodyPr>
-          <a:lstStyle/>
-          <a:p>
-            <a:pPr indent="0" marL="0">
-              <a:buNone/>
-            </a:pPr>
-            <a:endParaRPr lang="en-US" sz="1020" dirty="0"/>
-          </a:p>
-        </p:txBody>
-      </p:sp>
-      <p:sp>
-        <p:nvSpPr>
-          <p:cNvPr id="8" name="Shape 5"/>
-          <p:cNvSpPr/>
-          <p:nvPr/>
-        </p:nvSpPr>
-        <p:spPr>
-          <a:xfrm>
-            <a:off x="1828800" y="932688"/>
-            <a:ext cx="2834640" cy="310896"/>
-          </a:xfrm>
-          <a:prstGeom prst="rect">
-            <a:avLst/>
-          </a:prstGeom>
-          <a:solidFill>
-            <a:srgbClr val="008A5B"/>
-          </a:solidFill>
-          <a:ln w="12700">
-            <a:solidFill>
-              <a:srgbClr val="D6E5E0"/>
-            </a:solidFill>
-            <a:prstDash val="solid"/>
-          </a:ln>
-        </p:spPr>
-      </p:sp>
-      <p:sp>
-        <p:nvSpPr>
-          <p:cNvPr id="9" name="Text 6"/>
-          <p:cNvSpPr/>
-          <p:nvPr/>
-        </p:nvSpPr>
-        <p:spPr>
-          <a:xfrm>
-            <a:off x="1865376" y="960120"/>
-            <a:ext cx="2761488" cy="256032"/>
-          </a:xfrm>
-          <a:prstGeom prst="rect">
-            <a:avLst/>
-          </a:prstGeom>
-          <a:noFill/>
-          <a:ln/>
-        </p:spPr>
-        <p:txBody>
-          <a:bodyPr wrap="square" lIns="127" tIns="127" rIns="127" bIns="127" rtlCol="0" anchor="ctr">
-            <a:normAutofit/>
-          </a:bodyPr>
-          <a:lstStyle/>
-          <a:p>
-            <a:pPr indent="0" marL="0">
-              <a:buNone/>
-            </a:pPr>
-            <a:r>
-              <a:rPr lang="en-US" sz="1020" b="1" dirty="0">
-                <a:solidFill>
-                  <a:srgbClr val="FFFFFF"/>
-                </a:solidFill>
-              </a:rPr>
-              <a:t>afterNextRender()</a:t>
-            </a:r>
-            <a:endParaRPr lang="en-US" sz="1020" dirty="0"/>
-          </a:p>
-        </p:txBody>
-      </p:sp>
-      <p:sp>
-        <p:nvSpPr>
-          <p:cNvPr id="10" name="Shape 7"/>
-          <p:cNvSpPr/>
-          <p:nvPr/>
-        </p:nvSpPr>
-        <p:spPr>
-          <a:xfrm>
-            <a:off x="4663440" y="932688"/>
-            <a:ext cx="7116775" cy="310896"/>
-          </a:xfrm>
-          <a:prstGeom prst="rect">
-            <a:avLst/>
-          </a:prstGeom>
-          <a:solidFill>
-            <a:srgbClr val="008A5B"/>
-          </a:solidFill>
-          <a:ln w="12700">
-            <a:solidFill>
-              <a:srgbClr val="D6E5E0"/>
-            </a:solidFill>
-            <a:prstDash val="solid"/>
-          </a:ln>
-        </p:spPr>
-      </p:sp>
-      <p:sp>
-        <p:nvSpPr>
-          <p:cNvPr id="11" name="Text 8"/>
-          <p:cNvSpPr/>
-          <p:nvPr/>
-        </p:nvSpPr>
-        <p:spPr>
-          <a:xfrm>
-            <a:off x="4700016" y="960120"/>
-            <a:ext cx="7043623" cy="256032"/>
-          </a:xfrm>
-          <a:prstGeom prst="rect">
-            <a:avLst/>
-          </a:prstGeom>
-          <a:noFill/>
-          <a:ln/>
-        </p:spPr>
-        <p:txBody>
-          <a:bodyPr wrap="square" lIns="127" tIns="127" rIns="127" bIns="127" rtlCol="0" anchor="ctr">
-            <a:normAutofit/>
-          </a:bodyPr>
-          <a:lstStyle/>
-          <a:p>
-            <a:pPr indent="0" marL="0">
-              <a:buNone/>
-            </a:pPr>
-            <a:r>
-              <a:rPr lang="en-US" sz="1020" b="1" dirty="0">
-                <a:solidFill>
-                  <a:srgbClr val="FFFFFF"/>
-                </a:solidFill>
-              </a:rPr>
-              <a:t>afterEveryRender()</a:t>
-            </a:r>
-            <a:endParaRPr lang="en-US" sz="1020" dirty="0"/>
-          </a:p>
-        </p:txBody>
-      </p:sp>
-      <p:sp>
-        <p:nvSpPr>
-          <p:cNvPr id="12" name="Shape 9"/>
-          <p:cNvSpPr/>
-          <p:nvPr/>
-        </p:nvSpPr>
-        <p:spPr>
-          <a:xfrm>
-            <a:off x="411480" y="1243584"/>
-            <a:ext cx="1417320" cy="310896"/>
-          </a:xfrm>
-          <a:prstGeom prst="rect">
-            <a:avLst/>
-          </a:prstGeom>
-          <a:solidFill>
-            <a:srgbClr val="FFFFFF"/>
-          </a:solidFill>
-          <a:ln w="12700">
-            <a:solidFill>
-              <a:srgbClr val="D6E5E0"/>
-            </a:solidFill>
-            <a:prstDash val="solid"/>
-          </a:ln>
-        </p:spPr>
-      </p:sp>
-      <p:sp>
-        <p:nvSpPr>
-          <p:cNvPr id="13" name="Text 10"/>
-          <p:cNvSpPr/>
-          <p:nvPr/>
-        </p:nvSpPr>
-        <p:spPr>
-          <a:xfrm>
-            <a:off x="448056" y="1271016"/>
-            <a:ext cx="1344168" cy="256032"/>
-          </a:xfrm>
-          <a:prstGeom prst="rect">
-            <a:avLst/>
-          </a:prstGeom>
-          <a:noFill/>
-          <a:ln/>
-        </p:spPr>
-        <p:txBody>
-          <a:bodyPr wrap="square" lIns="127" tIns="127" rIns="127" bIns="127" rtlCol="0" anchor="ctr">
-            <a:normAutofit/>
-          </a:bodyPr>
-          <a:lstStyle/>
-          <a:p>
-            <a:pPr indent="0" marL="0">
-              <a:buNone/>
-            </a:pPr>
-            <a:r>
-              <a:rPr lang="en-US" sz="1020" dirty="0">
-                <a:solidFill>
-                  <a:srgbClr val="263B38"/>
-                </a:solidFill>
-              </a:rPr>
-              <a:t>Frequence</a:t>
-            </a:r>
-            <a:endParaRPr lang="en-US" sz="1020" dirty="0"/>
-          </a:p>
-        </p:txBody>
-      </p:sp>
-      <p:sp>
-        <p:nvSpPr>
-          <p:cNvPr id="14" name="Shape 11"/>
-          <p:cNvSpPr/>
-          <p:nvPr/>
-        </p:nvSpPr>
-        <p:spPr>
-          <a:xfrm>
-            <a:off x="1828800" y="1243584"/>
-            <a:ext cx="2834640" cy="310896"/>
-          </a:xfrm>
-          <a:prstGeom prst="rect">
-            <a:avLst/>
-          </a:prstGeom>
-          <a:solidFill>
-            <a:srgbClr val="FFFFFF"/>
-          </a:solidFill>
-          <a:ln w="12700">
-            <a:solidFill>
-              <a:srgbClr val="D6E5E0"/>
-            </a:solidFill>
-            <a:prstDash val="solid"/>
-          </a:ln>
-        </p:spPr>
-      </p:sp>
-      <p:sp>
-        <p:nvSpPr>
-          <p:cNvPr id="15" name="Text 12"/>
-          <p:cNvSpPr/>
-          <p:nvPr/>
-        </p:nvSpPr>
-        <p:spPr>
-          <a:xfrm>
-            <a:off x="1865376" y="1271016"/>
-            <a:ext cx="2761488" cy="256032"/>
-          </a:xfrm>
-          <a:prstGeom prst="rect">
-            <a:avLst/>
-          </a:prstGeom>
-          <a:noFill/>
-          <a:ln/>
-        </p:spPr>
-        <p:txBody>
-          <a:bodyPr wrap="square" lIns="127" tIns="127" rIns="127" bIns="127" rtlCol="0" anchor="ctr">
-            <a:normAutofit/>
-          </a:bodyPr>
-          <a:lstStyle/>
-          <a:p>
-            <a:pPr indent="0" marL="0">
-              <a:buNone/>
-            </a:pPr>
-            <a:r>
-              <a:rPr lang="en-US" sz="1020" dirty="0">
-                <a:solidFill>
-                  <a:srgbClr val="263B38"/>
-                </a:solidFill>
-              </a:rPr>
-              <a:t>Une seule fois apres le prochain rendu</a:t>
-            </a:r>
-            <a:endParaRPr lang="en-US" sz="1020" dirty="0"/>
-          </a:p>
-        </p:txBody>
-      </p:sp>
-      <p:sp>
-        <p:nvSpPr>
-          <p:cNvPr id="16" name="Shape 13"/>
-          <p:cNvSpPr/>
-          <p:nvPr/>
-        </p:nvSpPr>
-        <p:spPr>
-          <a:xfrm>
-            <a:off x="4663440" y="1243584"/>
-            <a:ext cx="7116775" cy="310896"/>
-          </a:xfrm>
-          <a:prstGeom prst="rect">
-            <a:avLst/>
-          </a:prstGeom>
-          <a:solidFill>
-            <a:srgbClr val="FFFFFF"/>
-          </a:solidFill>
-          <a:ln w="12700">
-            <a:solidFill>
-              <a:srgbClr val="D6E5E0"/>
-            </a:solidFill>
-            <a:prstDash val="solid"/>
-          </a:ln>
-        </p:spPr>
-      </p:sp>
-      <p:sp>
-        <p:nvSpPr>
-          <p:cNvPr id="17" name="Text 14"/>
-          <p:cNvSpPr/>
-          <p:nvPr/>
-        </p:nvSpPr>
-        <p:spPr>
-          <a:xfrm>
-            <a:off x="4700016" y="1271016"/>
-            <a:ext cx="7043623" cy="256032"/>
-          </a:xfrm>
-          <a:prstGeom prst="rect">
-            <a:avLst/>
-          </a:prstGeom>
-          <a:noFill/>
-          <a:ln/>
-        </p:spPr>
-        <p:txBody>
-          <a:bodyPr wrap="square" lIns="127" tIns="127" rIns="127" bIns="127" rtlCol="0" anchor="ctr">
-            <a:normAutofit/>
-          </a:bodyPr>
-          <a:lstStyle/>
-          <a:p>
-            <a:pPr indent="0" marL="0">
-              <a:buNone/>
-            </a:pPr>
-            <a:r>
-              <a:rPr lang="en-US" sz="1020" dirty="0">
-                <a:solidFill>
-                  <a:srgbClr val="263B38"/>
-                </a:solidFill>
-              </a:rPr>
-              <a:t>Apres chaque cycle de rendu</a:t>
-            </a:r>
-            <a:endParaRPr lang="en-US" sz="1020" dirty="0"/>
-          </a:p>
-        </p:txBody>
-      </p:sp>
-      <p:sp>
-        <p:nvSpPr>
-          <p:cNvPr id="18" name="Shape 15"/>
-          <p:cNvSpPr/>
-          <p:nvPr/>
-        </p:nvSpPr>
-        <p:spPr>
-          <a:xfrm>
-            <a:off x="411480" y="1554480"/>
-            <a:ext cx="1417320" cy="310896"/>
-          </a:xfrm>
-          <a:prstGeom prst="rect">
-            <a:avLst/>
-          </a:prstGeom>
-          <a:solidFill>
-            <a:srgbClr val="F3F8F6"/>
-          </a:solidFill>
-          <a:ln w="12700">
-            <a:solidFill>
-              <a:srgbClr val="D6E5E0"/>
-            </a:solidFill>
-            <a:prstDash val="solid"/>
-          </a:ln>
-        </p:spPr>
-      </p:sp>
-      <p:sp>
-        <p:nvSpPr>
-          <p:cNvPr id="19" name="Text 16"/>
-          <p:cNvSpPr/>
-          <p:nvPr/>
-        </p:nvSpPr>
-        <p:spPr>
-          <a:xfrm>
-            <a:off x="448056" y="1581912"/>
-            <a:ext cx="1344168" cy="256032"/>
-          </a:xfrm>
-          <a:prstGeom prst="rect">
-            <a:avLst/>
-          </a:prstGeom>
-          <a:noFill/>
-          <a:ln/>
-        </p:spPr>
-        <p:txBody>
-          <a:bodyPr wrap="square" lIns="127" tIns="127" rIns="127" bIns="127" rtlCol="0" anchor="ctr">
-            <a:normAutofit/>
-          </a:bodyPr>
-          <a:lstStyle/>
-          <a:p>
-            <a:pPr indent="0" marL="0">
-              <a:buNone/>
-            </a:pPr>
-            <a:r>
-              <a:rPr lang="en-US" sz="1020" dirty="0">
-                <a:solidFill>
-                  <a:srgbClr val="263B38"/>
-                </a:solidFill>
-              </a:rPr>
-              <a:t>Usage typique</a:t>
-            </a:r>
-            <a:endParaRPr lang="en-US" sz="1020" dirty="0"/>
-          </a:p>
-        </p:txBody>
-      </p:sp>
-      <p:sp>
-        <p:nvSpPr>
-          <p:cNvPr id="20" name="Shape 17"/>
-          <p:cNvSpPr/>
-          <p:nvPr/>
-        </p:nvSpPr>
-        <p:spPr>
-          <a:xfrm>
-            <a:off x="1828800" y="1554480"/>
-            <a:ext cx="2834640" cy="310896"/>
-          </a:xfrm>
-          <a:prstGeom prst="rect">
-            <a:avLst/>
-          </a:prstGeom>
-          <a:solidFill>
-            <a:srgbClr val="F3F8F6"/>
-          </a:solidFill>
-          <a:ln w="12700">
-            <a:solidFill>
-              <a:srgbClr val="D6E5E0"/>
-            </a:solidFill>
-            <a:prstDash val="solid"/>
-          </a:ln>
-        </p:spPr>
-      </p:sp>
-      <p:sp>
-        <p:nvSpPr>
-          <p:cNvPr id="21" name="Text 18"/>
-          <p:cNvSpPr/>
-          <p:nvPr/>
-        </p:nvSpPr>
-        <p:spPr>
-          <a:xfrm>
-            <a:off x="1865376" y="1581912"/>
-            <a:ext cx="2761488" cy="256032"/>
-          </a:xfrm>
-          <a:prstGeom prst="rect">
-            <a:avLst/>
-          </a:prstGeom>
-          <a:noFill/>
-          <a:ln/>
-        </p:spPr>
-        <p:txBody>
-          <a:bodyPr wrap="square" lIns="127" tIns="127" rIns="127" bIns="127" rtlCol="0" anchor="ctr">
-            <a:normAutofit/>
-          </a:bodyPr>
-          <a:lstStyle/>
-          <a:p>
-            <a:pPr indent="0" marL="0">
-              <a:buNone/>
-            </a:pPr>
-            <a:r>
-              <a:rPr lang="en-US" sz="1020" dirty="0">
-                <a:solidFill>
-                  <a:srgbClr val="263B38"/>
-                </a:solidFill>
-              </a:rPr>
-              <a:t>Scroll one-shot, init librairie tierce</a:t>
-            </a:r>
-            <a:endParaRPr lang="en-US" sz="1020" dirty="0"/>
-          </a:p>
-        </p:txBody>
-      </p:sp>
-      <p:sp>
-        <p:nvSpPr>
-          <p:cNvPr id="22" name="Shape 19"/>
-          <p:cNvSpPr/>
-          <p:nvPr/>
-        </p:nvSpPr>
-        <p:spPr>
-          <a:xfrm>
-            <a:off x="4663440" y="1554480"/>
-            <a:ext cx="7116775" cy="310896"/>
-          </a:xfrm>
-          <a:prstGeom prst="rect">
-            <a:avLst/>
-          </a:prstGeom>
-          <a:solidFill>
-            <a:srgbClr val="F3F8F6"/>
-          </a:solidFill>
-          <a:ln w="12700">
-            <a:solidFill>
-              <a:srgbClr val="D6E5E0"/>
-            </a:solidFill>
-            <a:prstDash val="solid"/>
-          </a:ln>
-        </p:spPr>
-      </p:sp>
-      <p:sp>
-        <p:nvSpPr>
-          <p:cNvPr id="23" name="Text 20"/>
-          <p:cNvSpPr/>
-          <p:nvPr/>
-        </p:nvSpPr>
-        <p:spPr>
-          <a:xfrm>
-            <a:off x="4700016" y="1581912"/>
-            <a:ext cx="7043623" cy="256032"/>
-          </a:xfrm>
-          <a:prstGeom prst="rect">
-            <a:avLst/>
-          </a:prstGeom>
-          <a:noFill/>
-          <a:ln/>
-        </p:spPr>
-        <p:txBody>
-          <a:bodyPr wrap="square" lIns="127" tIns="127" rIns="127" bIns="127" rtlCol="0" anchor="ctr">
-            <a:normAutofit/>
-          </a:bodyPr>
-          <a:lstStyle/>
-          <a:p>
-            <a:pPr indent="0" marL="0">
-              <a:buNone/>
-            </a:pPr>
-            <a:r>
-              <a:rPr lang="en-US" sz="1020" dirty="0">
-                <a:solidFill>
-                  <a:srgbClr val="263B38"/>
-                </a:solidFill>
-              </a:rPr>
-              <a:t>Mesures DOM continues, animations</a:t>
-            </a:r>
-            <a:endParaRPr lang="en-US" sz="1020" dirty="0"/>
-          </a:p>
-        </p:txBody>
-      </p:sp>
-      <p:sp>
-        <p:nvSpPr>
-          <p:cNvPr id="24" name="Shape 21"/>
-          <p:cNvSpPr/>
-          <p:nvPr/>
-        </p:nvSpPr>
-        <p:spPr>
-          <a:xfrm>
-            <a:off x="411480" y="1865376"/>
-            <a:ext cx="1417320" cy="310896"/>
-          </a:xfrm>
-          <a:prstGeom prst="rect">
-            <a:avLst/>
-          </a:prstGeom>
-          <a:solidFill>
-            <a:srgbClr val="FFFFFF"/>
-          </a:solidFill>
-          <a:ln w="12700">
-            <a:solidFill>
-              <a:srgbClr val="D6E5E0"/>
-            </a:solidFill>
-            <a:prstDash val="solid"/>
-          </a:ln>
-        </p:spPr>
-      </p:sp>
-      <p:sp>
-        <p:nvSpPr>
-          <p:cNvPr id="25" name="Text 22"/>
-          <p:cNvSpPr/>
-          <p:nvPr/>
-        </p:nvSpPr>
-        <p:spPr>
-          <a:xfrm>
-            <a:off x="448056" y="1892808"/>
-            <a:ext cx="1344168" cy="256032"/>
-          </a:xfrm>
-          <a:prstGeom prst="rect">
-            <a:avLst/>
-          </a:prstGeom>
-          <a:noFill/>
-          <a:ln/>
-        </p:spPr>
-        <p:txBody>
-          <a:bodyPr wrap="square" lIns="127" tIns="127" rIns="127" bIns="127" rtlCol="0" anchor="ctr">
-            <a:normAutofit/>
-          </a:bodyPr>
-          <a:lstStyle/>
-          <a:p>
-            <a:pPr indent="0" marL="0">
-              <a:buNone/>
-            </a:pPr>
-            <a:r>
-              <a:rPr lang="en-US" sz="1020" dirty="0">
-                <a:solidFill>
-                  <a:srgbClr val="263B38"/>
-                </a:solidFill>
-              </a:rPr>
-              <a:t>Risque</a:t>
-            </a:r>
-            <a:endParaRPr lang="en-US" sz="1020" dirty="0"/>
-          </a:p>
-        </p:txBody>
-      </p:sp>
-      <p:sp>
-        <p:nvSpPr>
-          <p:cNvPr id="26" name="Shape 23"/>
-          <p:cNvSpPr/>
-          <p:nvPr/>
-        </p:nvSpPr>
-        <p:spPr>
-          <a:xfrm>
-            <a:off x="1828800" y="1865376"/>
-            <a:ext cx="2834640" cy="310896"/>
-          </a:xfrm>
-          <a:prstGeom prst="rect">
-            <a:avLst/>
-          </a:prstGeom>
-          <a:solidFill>
-            <a:srgbClr val="FFFFFF"/>
-          </a:solidFill>
-          <a:ln w="12700">
-            <a:solidFill>
-              <a:srgbClr val="D6E5E0"/>
-            </a:solidFill>
-            <a:prstDash val="solid"/>
-          </a:ln>
-        </p:spPr>
-      </p:sp>
-      <p:sp>
-        <p:nvSpPr>
-          <p:cNvPr id="27" name="Text 24"/>
-          <p:cNvSpPr/>
-          <p:nvPr/>
-        </p:nvSpPr>
-        <p:spPr>
-          <a:xfrm>
-            <a:off x="1865376" y="1892808"/>
-            <a:ext cx="2761488" cy="256032"/>
-          </a:xfrm>
-          <a:prstGeom prst="rect">
-            <a:avLst/>
-          </a:prstGeom>
-          <a:noFill/>
-          <a:ln/>
-        </p:spPr>
-        <p:txBody>
-          <a:bodyPr wrap="square" lIns="127" tIns="127" rIns="127" bIns="127" rtlCol="0" anchor="ctr">
-            <a:normAutofit/>
-          </a:bodyPr>
-          <a:lstStyle/>
-          <a:p>
-            <a:pPr indent="0" marL="0">
-              <a:buNone/>
-            </a:pPr>
-            <a:r>
-              <a:rPr lang="en-US" sz="1020" dirty="0">
-                <a:solidFill>
-                  <a:srgbClr val="263B38"/>
-                </a:solidFill>
-              </a:rPr>
-              <a:t>Aucun surcout apres execution</a:t>
-            </a:r>
-            <a:endParaRPr lang="en-US" sz="1020" dirty="0"/>
-          </a:p>
-        </p:txBody>
-      </p:sp>
-      <p:sp>
-        <p:nvSpPr>
-          <p:cNvPr id="28" name="Shape 25"/>
-          <p:cNvSpPr/>
-          <p:nvPr/>
-        </p:nvSpPr>
-        <p:spPr>
-          <a:xfrm>
-            <a:off x="4663440" y="1865376"/>
-            <a:ext cx="7116775" cy="310896"/>
-          </a:xfrm>
-          <a:prstGeom prst="rect">
-            <a:avLst/>
-          </a:prstGeom>
-          <a:solidFill>
-            <a:srgbClr val="FFFFFF"/>
-          </a:solidFill>
-          <a:ln w="12700">
-            <a:solidFill>
-              <a:srgbClr val="D6E5E0"/>
-            </a:solidFill>
-            <a:prstDash val="solid"/>
-          </a:ln>
-        </p:spPr>
-      </p:sp>
-      <p:sp>
-        <p:nvSpPr>
-          <p:cNvPr id="29" name="Text 26"/>
-          <p:cNvSpPr/>
-          <p:nvPr/>
-        </p:nvSpPr>
-        <p:spPr>
-          <a:xfrm>
-            <a:off x="4700016" y="1892808"/>
-            <a:ext cx="7043623" cy="256032"/>
-          </a:xfrm>
-          <a:prstGeom prst="rect">
-            <a:avLst/>
-          </a:prstGeom>
-          <a:noFill/>
-          <a:ln/>
-        </p:spPr>
-        <p:txBody>
-          <a:bodyPr wrap="square" lIns="127" tIns="127" rIns="127" bIns="127" rtlCol="0" anchor="ctr">
-            <a:normAutofit/>
-          </a:bodyPr>
-          <a:lstStyle/>
-          <a:p>
-            <a:pPr indent="0" marL="0">
-              <a:buNone/>
-            </a:pPr>
-            <a:r>
-              <a:rPr lang="en-US" sz="1020" dirty="0">
-                <a:solidFill>
-                  <a:srgbClr val="263B38"/>
-                </a:solidFill>
-              </a:rPr>
-              <a:t>Couteux si le rendu est frequent</a:t>
-            </a:r>
-            <a:endParaRPr lang="en-US" sz="1020" dirty="0"/>
-          </a:p>
-        </p:txBody>
-      </p:sp>
-      <p:sp>
-        <p:nvSpPr>
-          <p:cNvPr id="30" name="Text 27"/>
-          <p:cNvSpPr/>
-          <p:nvPr/>
-        </p:nvSpPr>
-        <p:spPr>
-          <a:xfrm>
-            <a:off x="411480" y="2340864"/>
-            <a:ext cx="11368735" cy="941832"/>
-          </a:xfrm>
-          <a:prstGeom prst="rect">
-            <a:avLst/>
-          </a:prstGeom>
-          <a:solidFill>
-            <a:srgbClr val="15332F"/>
-          </a:solidFill>
-          <a:ln/>
-        </p:spPr>
-        <p:txBody>
-          <a:bodyPr wrap="square" lIns="1016" tIns="1016" rIns="1016" bIns="1016" rtlCol="0" anchor="t">
-            <a:normAutofit/>
-          </a:bodyPr>
-          <a:lstStyle/>
-          <a:p>
-            <a:pPr indent="0" marL="0">
-              <a:buNone/>
-            </a:pPr>
-            <a:r>
-              <a:rPr lang="en-US" sz="880" dirty="0">
-                <a:solidFill>
-                  <a:srgbClr val="F8FAFC"/>
-                </a:solidFill>
-                <a:latin typeface="Courier New" pitchFamily="34" charset="0"/>
-                <a:ea typeface="Courier New" pitchFamily="34" charset="-122"/>
-                <a:cs typeface="Courier New" pitchFamily="34" charset="-120"/>
-              </a:rPr>
-              <a:t>// one-shot : scroll apres un ajout</a:t>
-            </a:r>
-            <a:endParaRPr lang="en-US" sz="880" dirty="0"/>
-          </a:p>
-          <a:p>
-            <a:pPr indent="0" marL="0">
-              <a:buNone/>
-            </a:pPr>
-            <a:r>
-              <a:rPr lang="en-US" sz="880" dirty="0">
-                <a:solidFill>
-                  <a:srgbClr val="F8FAFC"/>
-                </a:solidFill>
-                <a:latin typeface="Courier New" pitchFamily="34" charset="0"/>
-                <a:ea typeface="Courier New" pitchFamily="34" charset="-122"/>
-                <a:cs typeface="Courier New" pitchFamily="34" charset="-120"/>
-              </a:rPr>
-              <a:t>afterNextRender(() =&gt; viewport.scrollToIndex(0), { injector });</a:t>
-            </a:r>
-            <a:endParaRPr lang="en-US" sz="880" dirty="0"/>
-          </a:p>
-          <a:p>
-            <a:pPr indent="0" marL="0">
-              <a:buNone/>
-            </a:pPr>
-            <a:endParaRPr lang="en-US" sz="880" dirty="0"/>
-          </a:p>
-          <a:p>
-            <a:pPr indent="0" marL="0">
-              <a:buNone/>
-            </a:pPr>
-            <a:r>
-              <a:rPr lang="en-US" sz="880" dirty="0">
-                <a:solidFill>
-                  <a:srgbClr val="F8FAFC"/>
-                </a:solidFill>
-                <a:latin typeface="Courier New" pitchFamily="34" charset="0"/>
-                <a:ea typeface="Courier New" pitchFamily="34" charset="-122"/>
-                <a:cs typeface="Courier New" pitchFamily="34" charset="-120"/>
-              </a:rPr>
-              <a:t>// recurrent : mesure la hauteur a chaque rendu</a:t>
-            </a:r>
-            <a:endParaRPr lang="en-US" sz="880" dirty="0"/>
-          </a:p>
-          <a:p>
-            <a:pPr indent="0" marL="0">
-              <a:buNone/>
-            </a:pPr>
-            <a:r>
-              <a:rPr lang="en-US" sz="880" dirty="0">
-                <a:solidFill>
-                  <a:srgbClr val="F8FAFC"/>
-                </a:solidFill>
-                <a:latin typeface="Courier New" pitchFamily="34" charset="0"/>
-                <a:ea typeface="Courier New" pitchFamily="34" charset="-122"/>
-                <a:cs typeface="Courier New" pitchFamily="34" charset="-120"/>
-              </a:rPr>
-              <a:t>afterEveryRender(() =&gt; { this.height.set(el.nativeElement.offsetHeight); });</a:t>
-            </a:r>
-            <a:endParaRPr lang="en-US" sz="880" dirty="0"/>
-          </a:p>
-        </p:txBody>
-      </p:sp>
-      <p:sp>
-        <p:nvSpPr>
-          <p:cNvPr id="31" name="Text 28"/>
-          <p:cNvSpPr/>
-          <p:nvPr/>
-        </p:nvSpPr>
-        <p:spPr>
-          <a:xfrm>
-            <a:off x="11277295" y="6537960"/>
-            <a:ext cx="502920" cy="182880"/>
-          </a:xfrm>
-          <a:prstGeom prst="rect">
-            <a:avLst/>
-          </a:prstGeom>
-          <a:noFill/>
-          <a:ln/>
-        </p:spPr>
-        <p:txBody>
-          <a:bodyPr wrap="square" rtlCol="0" anchor="ctr"/>
-          <a:lstStyle/>
-          <a:p>
-            <a:pPr algn="r" indent="0" marL="0">
-              <a:buNone/>
-            </a:pPr>
-            <a:r>
-              <a:rPr lang="en-US" sz="700" dirty="0">
-                <a:solidFill>
-                  <a:srgbClr val="61716F"/>
-                </a:solidFill>
-              </a:rPr>
-              <a:t>16/17</a:t>
-            </a:r>
-            <a:endParaRPr lang="en-US" sz="700" dirty="0"/>
-          </a:p>
-        </p:txBody>
-      </p:sp>
-    </p:spTree>
-  </p:cSld>
-  <p:clrMapOvr>
-    <a:masterClrMapping/>
-  </p:clrMapOvr>
-</p:sld>
-</file>
-
-<file path=ppt/slides/slide17.xml><?xml version="1.0" encoding="utf-8"?>
-<p:sld xmlns:a="http://schemas.openxmlformats.org/drawingml/2006/main" xmlns:r="http://schemas.openxmlformats.org/officeDocument/2006/relationships" xmlns:p="http://schemas.openxmlformats.org/presentationml/2006/main">
-  <p:cSld name="Slide 17">
-    <p:bg>
-      <p:bgPr>
-        <a:solidFill>
-          <a:srgbClr val="F3F8F6"/>
-        </a:solidFill>
-      </p:bgPr>
-    </p:bg>
-    <p:spTree>
-      <p:nvGrpSpPr>
-        <p:cNvPr id="1" name=""/>
-        <p:cNvGrpSpPr/>
-        <p:nvPr/>
-      </p:nvGrpSpPr>
-      <p:grpSpPr>
-        <a:xfrm>
-          <a:off x="0" y="0"/>
-          <a:ext cx="0" cy="0"/>
-          <a:chOff x="0" y="0"/>
-          <a:chExt cx="0" cy="0"/>
-        </a:xfrm>
-      </p:grpSpPr>
-      <p:sp>
-        <p:nvSpPr>
-          <p:cNvPr id="2" name="Shape 0"/>
-          <p:cNvSpPr/>
-          <p:nvPr/>
-        </p:nvSpPr>
-        <p:spPr>
-          <a:xfrm>
-            <a:off x="0" y="0"/>
-            <a:ext cx="12191695" cy="91440"/>
-          </a:xfrm>
-          <a:prstGeom prst="rect">
-            <a:avLst/>
-          </a:prstGeom>
-          <a:solidFill>
             <a:srgbClr val="00A86B"/>
           </a:solidFill>
           <a:ln w="12700">
@@ -11282,7 +10915,7 @@
                   <a:srgbClr val="61716F"/>
                 </a:solidFill>
               </a:rPr>
-              <a:t>17/17</a:t>
+              <a:t>16/16</a:t>
             </a:r>
             <a:endParaRPr lang="en-US" sz="700" dirty="0"/>
           </a:p>
@@ -11857,7 +11490,7 @@
                   <a:srgbClr val="61716F"/>
                 </a:solidFill>
               </a:rPr>
-              <a:t>2/17</a:t>
+              <a:t>2/16</a:t>
             </a:r>
             <a:endParaRPr lang="en-US" sz="700" dirty="0"/>
           </a:p>
@@ -12280,7 +11913,7 @@
                   <a:srgbClr val="61716F"/>
                 </a:solidFill>
               </a:rPr>
-              <a:t>3/17</a:t>
+              <a:t>3/16</a:t>
             </a:r>
             <a:endParaRPr lang="en-US" sz="700" dirty="0"/>
           </a:p>
@@ -12855,7 +12488,7 @@
                   <a:srgbClr val="61716F"/>
                 </a:solidFill>
               </a:rPr>
-              <a:t>4/17</a:t>
+              <a:t>4/16</a:t>
             </a:r>
             <a:endParaRPr lang="en-US" sz="700" dirty="0"/>
           </a:p>
@@ -13278,7 +12911,7 @@
                   <a:srgbClr val="61716F"/>
                 </a:solidFill>
               </a:rPr>
-              <a:t>5/17</a:t>
+              <a:t>5/16</a:t>
             </a:r>
             <a:endParaRPr lang="en-US" sz="700" dirty="0"/>
           </a:p>
@@ -13853,7 +13486,7 @@
                   <a:srgbClr val="61716F"/>
                 </a:solidFill>
               </a:rPr>
-              <a:t>6/17</a:t>
+              <a:t>6/16</a:t>
             </a:r>
             <a:endParaRPr lang="en-US" sz="700" dirty="0"/>
           </a:p>
@@ -14276,7 +13909,7 @@
                   <a:srgbClr val="61716F"/>
                 </a:solidFill>
               </a:rPr>
-              <a:t>7/17</a:t>
+              <a:t>7/16</a:t>
             </a:r>
             <a:endParaRPr lang="en-US" sz="700" dirty="0"/>
           </a:p>
@@ -15803,7 +15436,7 @@
                   <a:srgbClr val="61716F"/>
                 </a:solidFill>
               </a:rPr>
-              <a:t>8/17</a:t>
+              <a:t>8/16</a:t>
             </a:r>
             <a:endParaRPr lang="en-US" sz="700" dirty="0"/>
           </a:p>
@@ -16200,7 +15833,7 @@
                   <a:srgbClr val="61716F"/>
                 </a:solidFill>
               </a:rPr>
-              <a:t>9/17</a:t>
+              <a:t>9/16</a:t>
             </a:r>
             <a:endParaRPr lang="en-US" sz="700" dirty="0"/>
           </a:p>

</xml_diff>